<commit_message>
Add governed PMM hierarchical targeting
</commit_message>
<xml_diff>
--- a/deploy-site/exports/waters-nextgen-leadership-brief.pptx
+++ b/deploy-site/exports/waters-nextgen-leadership-brief.pptx
@@ -2,118 +2,23 @@
 <file path=ppt/presentation.xml><?xml version="1.0" encoding="utf-8"?>
 <p:presentation xmlns:p="http://schemas.openxmlformats.org/presentationml/2006/main">
   <p:sldMasterIdLst>
-    <p:sldMasterId xmlns:r="http://schemas.openxmlformats.org/officeDocument/2006/relationships" id="2147483648" r:id="R5cb6c97e2bcd419c"/>
+    <p:sldMasterId xmlns:r="http://schemas.openxmlformats.org/officeDocument/2006/relationships" id="2147483648" r:id="R0645685ff0904c3e"/>
   </p:sldMasterIdLst>
   <p:notesMasterIdLst>
-    <p:notesMasterId xmlns:r="http://schemas.openxmlformats.org/officeDocument/2006/relationships" r:id="R0efcaed8ecba4905"/>
+    <p:notesMasterId xmlns:r="http://schemas.openxmlformats.org/officeDocument/2006/relationships" r:id="R574e4d657cdf4717"/>
   </p:notesMasterIdLst>
   <p:sldIdLst>
-    <p:sldId xmlns:r="http://schemas.openxmlformats.org/officeDocument/2006/relationships" id="256" r:id="R556f780c76824fe4"/>
-    <p:sldId xmlns:r="http://schemas.openxmlformats.org/officeDocument/2006/relationships" id="257" r:id="Rb44282db72ae4917"/>
-    <p:sldId xmlns:r="http://schemas.openxmlformats.org/officeDocument/2006/relationships" id="258" r:id="Rca47cbee05144e34"/>
-    <p:sldId xmlns:r="http://schemas.openxmlformats.org/officeDocument/2006/relationships" id="259" r:id="R2525c5099d7346c2"/>
-    <p:sldId xmlns:r="http://schemas.openxmlformats.org/officeDocument/2006/relationships" id="260" r:id="R86a839fa955946ed"/>
-    <p:sldId xmlns:r="http://schemas.openxmlformats.org/officeDocument/2006/relationships" id="261" r:id="R6ff4f69e61dd4f68"/>
-    <p:sldId xmlns:r="http://schemas.openxmlformats.org/officeDocument/2006/relationships" id="262" r:id="R0b1498b47b7a460a"/>
-    <p:sldId xmlns:r="http://schemas.openxmlformats.org/officeDocument/2006/relationships" id="263" r:id="R839b2c6295394fca"/>
+    <p:sldId xmlns:r="http://schemas.openxmlformats.org/officeDocument/2006/relationships" id="256" r:id="R5809642b99b34b48"/>
+    <p:sldId xmlns:r="http://schemas.openxmlformats.org/officeDocument/2006/relationships" id="257" r:id="Rf6a17742eb734ffb"/>
+    <p:sldId xmlns:r="http://schemas.openxmlformats.org/officeDocument/2006/relationships" id="258" r:id="Ra004f8761c6c4eca"/>
+    <p:sldId xmlns:r="http://schemas.openxmlformats.org/officeDocument/2006/relationships" id="259" r:id="R74f12067878c4bbc"/>
+    <p:sldId xmlns:r="http://schemas.openxmlformats.org/officeDocument/2006/relationships" id="260" r:id="R4fc65cc5e586424f"/>
+    <p:sldId xmlns:r="http://schemas.openxmlformats.org/officeDocument/2006/relationships" id="261" r:id="R127276c4802a4447"/>
+    <p:sldId xmlns:r="http://schemas.openxmlformats.org/officeDocument/2006/relationships" id="262" r:id="Rd07db9301227450d"/>
+    <p:sldId xmlns:r="http://schemas.openxmlformats.org/officeDocument/2006/relationships" id="263" r:id="R84bc8e1c6cd34765"/>
   </p:sldIdLst>
   <p:sldSz cx="12192000" cy="6858000"/>
   <p:notesSz cx="6858000" cy="9144000"/>
-  <p:defaultTextStyle>
-    <a:defPPr xmlns:a="http://schemas.openxmlformats.org/drawingml/2006/main">
-      <a:defRPr lang="en-US"/>
-    </a:defPPr>
-    <a:lvl1pPr xmlns:a="http://schemas.openxmlformats.org/drawingml/2006/main" marL="0" indent="0" algn="l" defTabSz="914400">
-      <a:defRPr sz="1800" kern="1200">
-        <a:solidFill>
-          <a:schemeClr val="tx1"/>
-        </a:solidFill>
-        <a:latin typeface="+mn-lt"/>
-        <a:ea typeface="+mn-ea"/>
-        <a:cs typeface="+mn-cs"/>
-      </a:defRPr>
-    </a:lvl1pPr>
-    <a:lvl2pPr xmlns:a="http://schemas.openxmlformats.org/drawingml/2006/main" marL="457200" indent="0" algn="l" defTabSz="914400">
-      <a:defRPr sz="1800" kern="1200">
-        <a:solidFill>
-          <a:schemeClr val="tx1"/>
-        </a:solidFill>
-        <a:latin typeface="+mn-lt"/>
-        <a:ea typeface="+mn-ea"/>
-        <a:cs typeface="+mn-cs"/>
-      </a:defRPr>
-    </a:lvl2pPr>
-    <a:lvl3pPr xmlns:a="http://schemas.openxmlformats.org/drawingml/2006/main" marL="914400" indent="0" algn="l" defTabSz="914400">
-      <a:defRPr sz="1800" kern="1200">
-        <a:solidFill>
-          <a:schemeClr val="tx1"/>
-        </a:solidFill>
-        <a:latin typeface="+mn-lt"/>
-        <a:ea typeface="+mn-ea"/>
-        <a:cs typeface="+mn-cs"/>
-      </a:defRPr>
-    </a:lvl3pPr>
-    <a:lvl4pPr xmlns:a="http://schemas.openxmlformats.org/drawingml/2006/main" marL="1371600" indent="0" algn="l" defTabSz="914400">
-      <a:defRPr sz="1800" kern="1200">
-        <a:solidFill>
-          <a:schemeClr val="tx1"/>
-        </a:solidFill>
-        <a:latin typeface="+mn-lt"/>
-        <a:ea typeface="+mn-ea"/>
-        <a:cs typeface="+mn-cs"/>
-      </a:defRPr>
-    </a:lvl4pPr>
-    <a:lvl5pPr xmlns:a="http://schemas.openxmlformats.org/drawingml/2006/main" marL="1828800" indent="0" algn="l" defTabSz="914400">
-      <a:defRPr sz="1800" kern="1200">
-        <a:solidFill>
-          <a:schemeClr val="tx1"/>
-        </a:solidFill>
-        <a:latin typeface="+mn-lt"/>
-        <a:ea typeface="+mn-ea"/>
-        <a:cs typeface="+mn-cs"/>
-      </a:defRPr>
-    </a:lvl5pPr>
-    <a:lvl6pPr xmlns:a="http://schemas.openxmlformats.org/drawingml/2006/main" marL="2286000" indent="0" algn="l" defTabSz="914400">
-      <a:defRPr sz="1800" kern="1200">
-        <a:solidFill>
-          <a:schemeClr val="tx1"/>
-        </a:solidFill>
-        <a:latin typeface="+mn-lt"/>
-        <a:ea typeface="+mn-ea"/>
-        <a:cs typeface="+mn-cs"/>
-      </a:defRPr>
-    </a:lvl6pPr>
-    <a:lvl7pPr xmlns:a="http://schemas.openxmlformats.org/drawingml/2006/main" marL="2743200" indent="0" algn="l" defTabSz="914400">
-      <a:defRPr sz="1800" kern="1200">
-        <a:solidFill>
-          <a:schemeClr val="tx1"/>
-        </a:solidFill>
-        <a:latin typeface="+mn-lt"/>
-        <a:ea typeface="+mn-ea"/>
-        <a:cs typeface="+mn-cs"/>
-      </a:defRPr>
-    </a:lvl7pPr>
-    <a:lvl8pPr xmlns:a="http://schemas.openxmlformats.org/drawingml/2006/main" marL="3200400" indent="0" algn="l" defTabSz="914400">
-      <a:defRPr sz="1800" kern="1200">
-        <a:solidFill>
-          <a:schemeClr val="tx1"/>
-        </a:solidFill>
-        <a:latin typeface="+mn-lt"/>
-        <a:ea typeface="+mn-ea"/>
-        <a:cs typeface="+mn-cs"/>
-      </a:defRPr>
-    </a:lvl8pPr>
-    <a:lvl9pPr xmlns:a="http://schemas.openxmlformats.org/drawingml/2006/main" marL="3657600" indent="0" algn="l" defTabSz="914400">
-      <a:defRPr sz="1800" kern="1200">
-        <a:solidFill>
-          <a:schemeClr val="tx1"/>
-        </a:solidFill>
-        <a:latin typeface="+mn-lt"/>
-        <a:ea typeface="+mn-ea"/>
-        <a:cs typeface="+mn-cs"/>
-      </a:defRPr>
-    </a:lvl9pPr>
-  </p:defaultTextStyle>
 </p:presentation>
 </file>
 
@@ -1070,7 +975,7 @@
   </p:cSld>
   <p:clrMap bg1="lt1" tx1="dk1" bg2="lt2" tx2="dk2" accent1="accent1" accent2="accent2" accent3="accent3" accent4="accent4" accent5="accent5" accent6="accent6" hlink="hlink" folHlink="folHlink"/>
   <p:sldLayoutIdLst>
-    <p:sldLayoutId xmlns:r="http://schemas.openxmlformats.org/officeDocument/2006/relationships" id="2147483649" r:id="Ra8e8d68a59a448c5"/>
+    <p:sldLayoutId xmlns:r="http://schemas.openxmlformats.org/officeDocument/2006/relationships" id="2147483649" r:id="Rf9d51c5e50b64632"/>
   </p:sldLayoutIdLst>
   <p:txStyles>
     <p:titleStyle>
@@ -1621,7 +1526,7 @@
           <p:cNvPr id="14" name="">
             <a:extLst xmlns:a="http://schemas.openxmlformats.org/drawingml/2006/main">
               <a:ext uri="{FF2B5EF4-FFF2-40B4-BE49-F238E27FC236}">
-                <a16:creationId xmlns:a16="http://schemas.microsoft.com/office/drawing/2014/main" id="{2E1992FB-1065-4A4A-AFD3-177913356E63}"/>
+                <a16:creationId xmlns:a16="http://schemas.microsoft.com/office/drawing/2014/main" id="{6AEEA7B4-BA7D-4E3E-9537-4D90AF5170BD}"/>
               </a:ext>
             </a:extLst>
           </p:cNvPr>
@@ -1654,7 +1559,7 @@
           <p:cNvPr id="2" name="">
             <a:extLst xmlns:a="http://schemas.openxmlformats.org/drawingml/2006/main">
               <a:ext uri="{FF2B5EF4-FFF2-40B4-BE49-F238E27FC236}">
-                <a16:creationId xmlns:a16="http://schemas.microsoft.com/office/drawing/2014/main" id="{D8048C1B-FFFB-4D6D-8387-FF3163CCE705}"/>
+                <a16:creationId xmlns:a16="http://schemas.microsoft.com/office/drawing/2014/main" id="{0E296CBB-E93B-4E24-B02E-BAA55D59117E}"/>
               </a:ext>
             </a:extLst>
           </p:cNvPr>
@@ -1712,7 +1617,7 @@
           <p:cNvPr id="3" name="">
             <a:extLst xmlns:a="http://schemas.openxmlformats.org/drawingml/2006/main">
               <a:ext uri="{FF2B5EF4-FFF2-40B4-BE49-F238E27FC236}">
-                <a16:creationId xmlns:a16="http://schemas.microsoft.com/office/drawing/2014/main" id="{AB1091C1-2451-4EE6-8482-7E54A31EA6D6}"/>
+                <a16:creationId xmlns:a16="http://schemas.microsoft.com/office/drawing/2014/main" id="{03A24EFD-0B30-44B1-84A1-793129D366FE}"/>
               </a:ext>
             </a:extLst>
           </p:cNvPr>
@@ -1770,7 +1675,7 @@
           <p:cNvPr id="4" name="">
             <a:extLst xmlns:a="http://schemas.openxmlformats.org/drawingml/2006/main">
               <a:ext uri="{FF2B5EF4-FFF2-40B4-BE49-F238E27FC236}">
-                <a16:creationId xmlns:a16="http://schemas.microsoft.com/office/drawing/2014/main" id="{70324A5D-5C25-4D21-BC5D-1117F68F3F2F}"/>
+                <a16:creationId xmlns:a16="http://schemas.microsoft.com/office/drawing/2014/main" id="{D7265B06-7575-4239-815C-82C6A6E124B2}"/>
               </a:ext>
             </a:extLst>
           </p:cNvPr>
@@ -1818,7 +1723,7 @@
                 <a:ea typeface="Aptos"/>
                 <a:cs typeface="Aptos"/>
               </a:rPr>
-              <a:t>Five external signals. Three roadmap decisions.</a:t>
+              <a:t>Five external signals. Three evidence-gated decisions.</a:t>
             </a:r>
           </a:p>
         </p:txBody>
@@ -1828,7 +1733,7 @@
           <p:cNvPr id="5" name="">
             <a:extLst xmlns:a="http://schemas.openxmlformats.org/drawingml/2006/main">
               <a:ext uri="{FF2B5EF4-FFF2-40B4-BE49-F238E27FC236}">
-                <a16:creationId xmlns:a16="http://schemas.microsoft.com/office/drawing/2014/main" id="{B72A5F11-49DC-4A95-8F4D-7A0F87E17FF0}"/>
+                <a16:creationId xmlns:a16="http://schemas.microsoft.com/office/drawing/2014/main" id="{66857954-51F8-4273-AA53-59650C46E9E6}"/>
               </a:ext>
             </a:extLst>
           </p:cNvPr>
@@ -1886,7 +1791,7 @@
           <p:cNvPr id="6" name="">
             <a:extLst xmlns:a="http://schemas.openxmlformats.org/drawingml/2006/main">
               <a:ext uri="{FF2B5EF4-FFF2-40B4-BE49-F238E27FC236}">
-                <a16:creationId xmlns:a16="http://schemas.microsoft.com/office/drawing/2014/main" id="{FE925846-E492-44E0-AFFD-D65702E19760}"/>
+                <a16:creationId xmlns:a16="http://schemas.microsoft.com/office/drawing/2014/main" id="{69EB5DDB-33FD-4074-8C84-2E3D35E12559}"/>
               </a:ext>
             </a:extLst>
           </p:cNvPr>
@@ -1921,7 +1826,7 @@
           <p:cNvPr id="7" name="">
             <a:extLst xmlns:a="http://schemas.openxmlformats.org/drawingml/2006/main">
               <a:ext uri="{FF2B5EF4-FFF2-40B4-BE49-F238E27FC236}">
-                <a16:creationId xmlns:a16="http://schemas.microsoft.com/office/drawing/2014/main" id="{5C2C1A24-E61F-4139-8400-61606DAB4331}"/>
+                <a16:creationId xmlns:a16="http://schemas.microsoft.com/office/drawing/2014/main" id="{A35FD91B-A07E-4EB0-AE2A-E74EAEF3C212}"/>
               </a:ext>
             </a:extLst>
           </p:cNvPr>
@@ -1979,7 +1884,7 @@
           <p:cNvPr id="8" name="">
             <a:extLst xmlns:a="http://schemas.openxmlformats.org/drawingml/2006/main">
               <a:ext uri="{FF2B5EF4-FFF2-40B4-BE49-F238E27FC236}">
-                <a16:creationId xmlns:a16="http://schemas.microsoft.com/office/drawing/2014/main" id="{95A18E01-4DFE-4CFF-B8C5-A2619EC36D1F}"/>
+                <a16:creationId xmlns:a16="http://schemas.microsoft.com/office/drawing/2014/main" id="{24563CC0-8151-4244-91DD-1833F3DCC5BF}"/>
               </a:ext>
             </a:extLst>
           </p:cNvPr>
@@ -2027,7 +1932,7 @@
                 <a:ea typeface="Aptos"/>
                 <a:cs typeface="Aptos"/>
               </a:rPr>
-              <a:t>23</a:t>
+              <a:t>28</a:t>
             </a:r>
           </a:p>
         </p:txBody>
@@ -2037,7 +1942,7 @@
           <p:cNvPr id="9" name="">
             <a:extLst xmlns:a="http://schemas.openxmlformats.org/drawingml/2006/main">
               <a:ext uri="{FF2B5EF4-FFF2-40B4-BE49-F238E27FC236}">
-                <a16:creationId xmlns:a16="http://schemas.microsoft.com/office/drawing/2014/main" id="{C63CC360-701F-4606-B580-09A7CE9DED07}"/>
+                <a16:creationId xmlns:a16="http://schemas.microsoft.com/office/drawing/2014/main" id="{2CCC6241-8D8B-4F92-A78D-D873B7B01854}"/>
               </a:ext>
             </a:extLst>
           </p:cNvPr>
@@ -2095,7 +2000,7 @@
           <p:cNvPr id="10" name="">
             <a:extLst xmlns:a="http://schemas.openxmlformats.org/drawingml/2006/main">
               <a:ext uri="{FF2B5EF4-FFF2-40B4-BE49-F238E27FC236}">
-                <a16:creationId xmlns:a16="http://schemas.microsoft.com/office/drawing/2014/main" id="{067A32C0-F16B-46F7-8714-81509E928991}"/>
+                <a16:creationId xmlns:a16="http://schemas.microsoft.com/office/drawing/2014/main" id="{33EB04F1-8BAF-4B64-B1C2-A573B04E080B}"/>
               </a:ext>
             </a:extLst>
           </p:cNvPr>
@@ -2128,7 +2033,7 @@
           <p:cNvPr id="11" name="">
             <a:extLst xmlns:a="http://schemas.openxmlformats.org/drawingml/2006/main">
               <a:ext uri="{FF2B5EF4-FFF2-40B4-BE49-F238E27FC236}">
-                <a16:creationId xmlns:a16="http://schemas.microsoft.com/office/drawing/2014/main" id="{5CD7C706-2DEE-42B5-99E6-D8DDA7AA17DD}"/>
+                <a16:creationId xmlns:a16="http://schemas.microsoft.com/office/drawing/2014/main" id="{E21726AA-64EA-441A-AC29-152ECE445117}"/>
               </a:ext>
             </a:extLst>
           </p:cNvPr>
@@ -2186,7 +2091,7 @@
           <p:cNvPr id="12" name="">
             <a:extLst xmlns:a="http://schemas.openxmlformats.org/drawingml/2006/main">
               <a:ext uri="{FF2B5EF4-FFF2-40B4-BE49-F238E27FC236}">
-                <a16:creationId xmlns:a16="http://schemas.microsoft.com/office/drawing/2014/main" id="{0EA09BEA-E2C6-4C44-9510-57D7DA193719}"/>
+                <a16:creationId xmlns:a16="http://schemas.microsoft.com/office/drawing/2014/main" id="{F87B5A2C-6A15-41BE-89A7-52515E1B7BFF}"/>
               </a:ext>
             </a:extLst>
           </p:cNvPr>
@@ -2198,7 +2103,7 @@
         <p:spPr>
           <a:xfrm xmlns:a="http://schemas.openxmlformats.org/drawingml/2006/main">
             <a:off x="704850" y="6153150"/>
-            <a:ext cx="5334000" cy="266700"/>
+            <a:ext cx="6477000" cy="266700"/>
           </a:xfrm>
           <a:prstGeom xmlns:a="http://schemas.openxmlformats.org/drawingml/2006/main" prst="rect">
             <a:avLst/>
@@ -2234,7 +2139,7 @@
                 <a:ea typeface="Aptos"/>
                 <a:cs typeface="Aptos"/>
               </a:rPr>
-              <a:t>Prepared for roadmap review</a:t>
+              <a:t>Prepared for roadmap review · waters-ci-20260728-202611</a:t>
             </a:r>
           </a:p>
         </p:txBody>
@@ -2244,7 +2149,7 @@
           <p:cNvPr id="13" name="">
             <a:extLst xmlns:a="http://schemas.openxmlformats.org/drawingml/2006/main">
               <a:ext uri="{FF2B5EF4-FFF2-40B4-BE49-F238E27FC236}">
-                <a16:creationId xmlns:a16="http://schemas.microsoft.com/office/drawing/2014/main" id="{434E73B0-4DF6-41A3-A4A9-3A4519DA3B89}"/>
+                <a16:creationId xmlns:a16="http://schemas.microsoft.com/office/drawing/2014/main" id="{49B25830-D539-458D-8D6C-5710A1EE6E68}"/>
               </a:ext>
             </a:extLst>
           </p:cNvPr>
@@ -2300,7 +2205,7 @@
     </p:spTree>
     <p:extLst>
       <p:ext uri="{BB962C8B-B14F-4D97-AF65-F5344CB8AC3E}">
-        <p14:creationId xmlns:p14="http://schemas.microsoft.com/office/powerpoint/2010/main" val="1813484766"/>
+        <p14:creationId xmlns:p14="http://schemas.microsoft.com/office/powerpoint/2010/main" val="1545021187"/>
       </p:ext>
     </p:extLst>
   </p:cSld>
@@ -2331,7 +2236,7 @@
           <p:cNvPr id="26" name="">
             <a:extLst xmlns:a="http://schemas.openxmlformats.org/drawingml/2006/main">
               <a:ext uri="{FF2B5EF4-FFF2-40B4-BE49-F238E27FC236}">
-                <a16:creationId xmlns:a16="http://schemas.microsoft.com/office/drawing/2014/main" id="{6AC8F75C-E12A-4046-A5AC-4B1382F17EEE}"/>
+                <a16:creationId xmlns:a16="http://schemas.microsoft.com/office/drawing/2014/main" id="{BDF42869-993E-4EB7-A74F-DCD06AFB9CFB}"/>
               </a:ext>
             </a:extLst>
           </p:cNvPr>
@@ -2389,7 +2294,7 @@
           <p:cNvPr id="2" name="">
             <a:extLst xmlns:a="http://schemas.openxmlformats.org/drawingml/2006/main">
               <a:ext uri="{FF2B5EF4-FFF2-40B4-BE49-F238E27FC236}">
-                <a16:creationId xmlns:a16="http://schemas.microsoft.com/office/drawing/2014/main" id="{B9856A66-E6BE-40FF-AB54-F3F4D1972D2A}"/>
+                <a16:creationId xmlns:a16="http://schemas.microsoft.com/office/drawing/2014/main" id="{65095D3B-7729-4D21-B95B-5453773285EE}"/>
               </a:ext>
             </a:extLst>
           </p:cNvPr>
@@ -2447,7 +2352,7 @@
           <p:cNvPr id="3" name="">
             <a:extLst xmlns:a="http://schemas.openxmlformats.org/drawingml/2006/main">
               <a:ext uri="{FF2B5EF4-FFF2-40B4-BE49-F238E27FC236}">
-                <a16:creationId xmlns:a16="http://schemas.microsoft.com/office/drawing/2014/main" id="{4B4CEEE3-E6BE-459F-AB0D-51A09022B1EC}"/>
+                <a16:creationId xmlns:a16="http://schemas.microsoft.com/office/drawing/2014/main" id="{F816079B-0C91-4B2D-8212-8B7D7B903BE5}"/>
               </a:ext>
             </a:extLst>
           </p:cNvPr>
@@ -2505,7 +2410,7 @@
           <p:cNvPr id="4" name="">
             <a:extLst xmlns:a="http://schemas.openxmlformats.org/drawingml/2006/main">
               <a:ext uri="{FF2B5EF4-FFF2-40B4-BE49-F238E27FC236}">
-                <a16:creationId xmlns:a16="http://schemas.microsoft.com/office/drawing/2014/main" id="{4DFC0974-AB37-4EA2-87EC-FFC968DFACD3}"/>
+                <a16:creationId xmlns:a16="http://schemas.microsoft.com/office/drawing/2014/main" id="{640CFB8F-C664-496A-964D-AC729E29A614}"/>
               </a:ext>
             </a:extLst>
           </p:cNvPr>
@@ -2538,7 +2443,7 @@
           <p:cNvPr id="5" name="">
             <a:extLst xmlns:a="http://schemas.openxmlformats.org/drawingml/2006/main">
               <a:ext uri="{FF2B5EF4-FFF2-40B4-BE49-F238E27FC236}">
-                <a16:creationId xmlns:a16="http://schemas.microsoft.com/office/drawing/2014/main" id="{D28716F8-21CE-4184-9AAF-E5ED1FF7EA41}"/>
+                <a16:creationId xmlns:a16="http://schemas.microsoft.com/office/drawing/2014/main" id="{C461414F-870E-46DD-BE87-A77BD84EF511}"/>
               </a:ext>
             </a:extLst>
           </p:cNvPr>
@@ -2573,7 +2478,7 @@
           <p:cNvPr id="6" name="">
             <a:extLst xmlns:a="http://schemas.openxmlformats.org/drawingml/2006/main">
               <a:ext uri="{FF2B5EF4-FFF2-40B4-BE49-F238E27FC236}">
-                <a16:creationId xmlns:a16="http://schemas.microsoft.com/office/drawing/2014/main" id="{2B3855CF-A784-4B41-A505-214C3DFDC57B}"/>
+                <a16:creationId xmlns:a16="http://schemas.microsoft.com/office/drawing/2014/main" id="{9A8088B3-D427-474A-AAA7-ECFF3DC343E9}"/>
               </a:ext>
             </a:extLst>
           </p:cNvPr>
@@ -2631,7 +2536,7 @@
           <p:cNvPr id="7" name="">
             <a:extLst xmlns:a="http://schemas.openxmlformats.org/drawingml/2006/main">
               <a:ext uri="{FF2B5EF4-FFF2-40B4-BE49-F238E27FC236}">
-                <a16:creationId xmlns:a16="http://schemas.microsoft.com/office/drawing/2014/main" id="{BCACA8A7-E2EF-46FC-9BB7-452E4870EC31}"/>
+                <a16:creationId xmlns:a16="http://schemas.microsoft.com/office/drawing/2014/main" id="{58D1F342-B003-45DE-95D2-E56A98FB3FD9}"/>
               </a:ext>
             </a:extLst>
           </p:cNvPr>
@@ -2689,7 +2594,7 @@
           <p:cNvPr id="8" name="">
             <a:extLst xmlns:a="http://schemas.openxmlformats.org/drawingml/2006/main">
               <a:ext uri="{FF2B5EF4-FFF2-40B4-BE49-F238E27FC236}">
-                <a16:creationId xmlns:a16="http://schemas.microsoft.com/office/drawing/2014/main" id="{93B30FB4-25A4-4715-A43D-BB5FAC2F73FB}"/>
+                <a16:creationId xmlns:a16="http://schemas.microsoft.com/office/drawing/2014/main" id="{3B97F620-BEC3-4A57-8FF2-89F40327DEFE}"/>
               </a:ext>
             </a:extLst>
           </p:cNvPr>
@@ -2724,7 +2629,7 @@
           <p:cNvPr id="9" name="">
             <a:extLst xmlns:a="http://schemas.openxmlformats.org/drawingml/2006/main">
               <a:ext uri="{FF2B5EF4-FFF2-40B4-BE49-F238E27FC236}">
-                <a16:creationId xmlns:a16="http://schemas.microsoft.com/office/drawing/2014/main" id="{E544D265-3CDB-4458-B770-84A0F7277F10}"/>
+                <a16:creationId xmlns:a16="http://schemas.microsoft.com/office/drawing/2014/main" id="{BF6C398C-7747-4865-A40F-7E373ECBA182}"/>
               </a:ext>
             </a:extLst>
           </p:cNvPr>
@@ -2757,7 +2662,7 @@
           <p:cNvPr id="10" name="">
             <a:extLst xmlns:a="http://schemas.openxmlformats.org/drawingml/2006/main">
               <a:ext uri="{FF2B5EF4-FFF2-40B4-BE49-F238E27FC236}">
-                <a16:creationId xmlns:a16="http://schemas.microsoft.com/office/drawing/2014/main" id="{C7DFF51B-CBBE-44FA-8565-D8CCE7937CF6}"/>
+                <a16:creationId xmlns:a16="http://schemas.microsoft.com/office/drawing/2014/main" id="{E634C212-44E7-4EB6-A656-C512C4A8F7DD}"/>
               </a:ext>
             </a:extLst>
           </p:cNvPr>
@@ -2805,7 +2710,7 @@
                 <a:ea typeface="Aptos"/>
                 <a:cs typeface="Aptos"/>
               </a:rPr>
-              <a:t>1,098</a:t>
+              <a:t>1,137</a:t>
             </a:r>
           </a:p>
         </p:txBody>
@@ -2815,7 +2720,7 @@
           <p:cNvPr id="11" name="">
             <a:extLst xmlns:a="http://schemas.openxmlformats.org/drawingml/2006/main">
               <a:ext uri="{FF2B5EF4-FFF2-40B4-BE49-F238E27FC236}">
-                <a16:creationId xmlns:a16="http://schemas.microsoft.com/office/drawing/2014/main" id="{EC67F5F5-8472-4AF1-9872-0176756AF18F}"/>
+                <a16:creationId xmlns:a16="http://schemas.microsoft.com/office/drawing/2014/main" id="{66934FB2-04B0-48D9-A8BB-7C9BC0414A39}"/>
               </a:ext>
             </a:extLst>
           </p:cNvPr>
@@ -2873,7 +2778,7 @@
           <p:cNvPr id="12" name="">
             <a:extLst xmlns:a="http://schemas.openxmlformats.org/drawingml/2006/main">
               <a:ext uri="{FF2B5EF4-FFF2-40B4-BE49-F238E27FC236}">
-                <a16:creationId xmlns:a16="http://schemas.microsoft.com/office/drawing/2014/main" id="{0D41AB70-68A8-4B93-A84A-EE2C5A05BC8D}"/>
+                <a16:creationId xmlns:a16="http://schemas.microsoft.com/office/drawing/2014/main" id="{64895F12-A6F5-496E-B4D2-C5CC43CA3BDC}"/>
               </a:ext>
             </a:extLst>
           </p:cNvPr>
@@ -2931,7 +2836,7 @@
           <p:cNvPr id="13" name="">
             <a:extLst xmlns:a="http://schemas.openxmlformats.org/drawingml/2006/main">
               <a:ext uri="{FF2B5EF4-FFF2-40B4-BE49-F238E27FC236}">
-                <a16:creationId xmlns:a16="http://schemas.microsoft.com/office/drawing/2014/main" id="{70B0829C-EBAE-424A-B16C-C2135A9F0C3E}"/>
+                <a16:creationId xmlns:a16="http://schemas.microsoft.com/office/drawing/2014/main" id="{8E92CEA7-D3E8-4A19-AE8B-A04F213E48F9}"/>
               </a:ext>
             </a:extLst>
           </p:cNvPr>
@@ -2966,7 +2871,7 @@
           <p:cNvPr id="14" name="">
             <a:extLst xmlns:a="http://schemas.openxmlformats.org/drawingml/2006/main">
               <a:ext uri="{FF2B5EF4-FFF2-40B4-BE49-F238E27FC236}">
-                <a16:creationId xmlns:a16="http://schemas.microsoft.com/office/drawing/2014/main" id="{BF8B4E0F-911D-4A79-A318-1FD849A94694}"/>
+                <a16:creationId xmlns:a16="http://schemas.microsoft.com/office/drawing/2014/main" id="{AE85D0CA-BF0C-4B2C-BF27-24BC3AD62874}"/>
               </a:ext>
             </a:extLst>
           </p:cNvPr>
@@ -2999,7 +2904,7 @@
           <p:cNvPr id="15" name="">
             <a:extLst xmlns:a="http://schemas.openxmlformats.org/drawingml/2006/main">
               <a:ext uri="{FF2B5EF4-FFF2-40B4-BE49-F238E27FC236}">
-                <a16:creationId xmlns:a16="http://schemas.microsoft.com/office/drawing/2014/main" id="{840FB7C4-CD78-469B-8CFF-9AF1DACF5E64}"/>
+                <a16:creationId xmlns:a16="http://schemas.microsoft.com/office/drawing/2014/main" id="{82303C56-F153-468A-9C72-5008749CD626}"/>
               </a:ext>
             </a:extLst>
           </p:cNvPr>
@@ -3047,7 +2952,7 @@
                 <a:ea typeface="Aptos"/>
                 <a:cs typeface="Aptos"/>
               </a:rPr>
-              <a:t>328</a:t>
+              <a:t>335</a:t>
             </a:r>
           </a:p>
         </p:txBody>
@@ -3057,7 +2962,7 @@
           <p:cNvPr id="16" name="">
             <a:extLst xmlns:a="http://schemas.openxmlformats.org/drawingml/2006/main">
               <a:ext uri="{FF2B5EF4-FFF2-40B4-BE49-F238E27FC236}">
-                <a16:creationId xmlns:a16="http://schemas.microsoft.com/office/drawing/2014/main" id="{F87CA11F-EC85-4118-B4AE-5507415302A0}"/>
+                <a16:creationId xmlns:a16="http://schemas.microsoft.com/office/drawing/2014/main" id="{8F354954-5B02-416E-9804-66B63AB87B4A}"/>
               </a:ext>
             </a:extLst>
           </p:cNvPr>
@@ -3115,7 +3020,7 @@
           <p:cNvPr id="17" name="">
             <a:extLst xmlns:a="http://schemas.openxmlformats.org/drawingml/2006/main">
               <a:ext uri="{FF2B5EF4-FFF2-40B4-BE49-F238E27FC236}">
-                <a16:creationId xmlns:a16="http://schemas.microsoft.com/office/drawing/2014/main" id="{8103CC77-9D55-42CB-AB40-DA00D02E44FC}"/>
+                <a16:creationId xmlns:a16="http://schemas.microsoft.com/office/drawing/2014/main" id="{FD0D1BB8-94F7-402C-ACE9-0B4D33C6D138}"/>
               </a:ext>
             </a:extLst>
           </p:cNvPr>
@@ -3173,7 +3078,7 @@
           <p:cNvPr id="18" name="">
             <a:extLst xmlns:a="http://schemas.openxmlformats.org/drawingml/2006/main">
               <a:ext uri="{FF2B5EF4-FFF2-40B4-BE49-F238E27FC236}">
-                <a16:creationId xmlns:a16="http://schemas.microsoft.com/office/drawing/2014/main" id="{40B39D41-EA7B-4A4C-82C7-FCE4B8246ABD}"/>
+                <a16:creationId xmlns:a16="http://schemas.microsoft.com/office/drawing/2014/main" id="{E76CC1FC-C3AB-46C1-AEE9-6D09742E0F1E}"/>
               </a:ext>
             </a:extLst>
           </p:cNvPr>
@@ -3208,7 +3113,7 @@
           <p:cNvPr id="19" name="">
             <a:extLst xmlns:a="http://schemas.openxmlformats.org/drawingml/2006/main">
               <a:ext uri="{FF2B5EF4-FFF2-40B4-BE49-F238E27FC236}">
-                <a16:creationId xmlns:a16="http://schemas.microsoft.com/office/drawing/2014/main" id="{30839978-9FCA-4495-9446-DEBFF6845297}"/>
+                <a16:creationId xmlns:a16="http://schemas.microsoft.com/office/drawing/2014/main" id="{71FBD62A-6E96-46FB-8F0D-802E4BE72B60}"/>
               </a:ext>
             </a:extLst>
           </p:cNvPr>
@@ -3241,7 +3146,7 @@
           <p:cNvPr id="20" name="">
             <a:extLst xmlns:a="http://schemas.openxmlformats.org/drawingml/2006/main">
               <a:ext uri="{FF2B5EF4-FFF2-40B4-BE49-F238E27FC236}">
-                <a16:creationId xmlns:a16="http://schemas.microsoft.com/office/drawing/2014/main" id="{28AD0B46-3B40-45FB-8416-59240C15EAFD}"/>
+                <a16:creationId xmlns:a16="http://schemas.microsoft.com/office/drawing/2014/main" id="{63C5752A-D62A-4529-8AFC-3A77BD588A08}"/>
               </a:ext>
             </a:extLst>
           </p:cNvPr>
@@ -3289,7 +3194,7 @@
                 <a:ea typeface="Aptos"/>
                 <a:cs typeface="Aptos"/>
               </a:rPr>
-              <a:t>651</a:t>
+              <a:t>659</a:t>
             </a:r>
           </a:p>
         </p:txBody>
@@ -3299,7 +3204,7 @@
           <p:cNvPr id="21" name="">
             <a:extLst xmlns:a="http://schemas.openxmlformats.org/drawingml/2006/main">
               <a:ext uri="{FF2B5EF4-FFF2-40B4-BE49-F238E27FC236}">
-                <a16:creationId xmlns:a16="http://schemas.microsoft.com/office/drawing/2014/main" id="{8FD0E00E-F660-4141-867E-AE256D6C0837}"/>
+                <a16:creationId xmlns:a16="http://schemas.microsoft.com/office/drawing/2014/main" id="{ACA9692A-06C9-45D3-9ED1-EAE78C6CD5BC}"/>
               </a:ext>
             </a:extLst>
           </p:cNvPr>
@@ -3357,7 +3262,7 @@
           <p:cNvPr id="22" name="">
             <a:extLst xmlns:a="http://schemas.openxmlformats.org/drawingml/2006/main">
               <a:ext uri="{FF2B5EF4-FFF2-40B4-BE49-F238E27FC236}">
-                <a16:creationId xmlns:a16="http://schemas.microsoft.com/office/drawing/2014/main" id="{DF09C0FA-0953-4903-9BB4-EEA727B350BC}"/>
+                <a16:creationId xmlns:a16="http://schemas.microsoft.com/office/drawing/2014/main" id="{DAEC6C7D-04F8-4003-A47B-34774F2DA0B4}"/>
               </a:ext>
             </a:extLst>
           </p:cNvPr>
@@ -3415,7 +3320,7 @@
           <p:cNvPr id="23" name="">
             <a:extLst xmlns:a="http://schemas.openxmlformats.org/drawingml/2006/main">
               <a:ext uri="{FF2B5EF4-FFF2-40B4-BE49-F238E27FC236}">
-                <a16:creationId xmlns:a16="http://schemas.microsoft.com/office/drawing/2014/main" id="{6D8B7A28-7EE3-44C7-924B-04833928B663}"/>
+                <a16:creationId xmlns:a16="http://schemas.microsoft.com/office/drawing/2014/main" id="{E27B88DB-4118-4DD0-8DB0-F4D1CFFC00EB}"/>
               </a:ext>
             </a:extLst>
           </p:cNvPr>
@@ -3445,25 +3350,25 @@
           <a:lstStyle xmlns:a="http://schemas.openxmlformats.org/drawingml/2006/main"/>
           <a:p xmlns:a="http://schemas.openxmlformats.org/drawingml/2006/main">
             <a:pPr algn="ctr">
-              <a:defRPr sz="1125" b="0">
-                <a:solidFill>
-                  <a:srgbClr val="60767D"/>
-                </a:solidFill>
-                <a:latin typeface="Aptos"/>
-                <a:ea typeface="Aptos"/>
-                <a:cs typeface="Aptos"/>
-              </a:defRPr>
-            </a:pPr>
-            <a:r>
-              <a:rPr sz="1125" b="0">
-                <a:solidFill>
-                  <a:srgbClr val="60767D"/>
-                </a:solidFill>
-                <a:latin typeface="Aptos"/>
-                <a:ea typeface="Aptos"/>
-                <a:cs typeface="Aptos"/>
-              </a:rPr>
-              <a:t>Publication volume measures scientific activity—not market share, revenue, or customer adoption.</a:t>
+              <a:defRPr sz="1125" b="1">
+                <a:solidFill>
+                  <a:srgbClr val="BA3A42"/>
+                </a:solidFill>
+                <a:latin typeface="Aptos"/>
+                <a:ea typeface="Aptos"/>
+                <a:cs typeface="Aptos"/>
+              </a:defRPr>
+            </a:pPr>
+            <a:r>
+              <a:rPr sz="1125" b="1">
+                <a:solidFill>
+                  <a:srgbClr val="BA3A42"/>
+                </a:solidFill>
+                <a:latin typeface="Aptos"/>
+                <a:ea typeface="Aptos"/>
+                <a:cs typeface="Aptos"/>
+              </a:rPr>
+              <a:t>Waters business exposure remains UNQUANTIFIED pending installed-base, pipeline, win/loss, and engineering-effort evidence.</a:t>
             </a:r>
           </a:p>
         </p:txBody>
@@ -3473,7 +3378,7 @@
           <p:cNvPr id="24" name="">
             <a:extLst xmlns:a="http://schemas.openxmlformats.org/drawingml/2006/main">
               <a:ext uri="{FF2B5EF4-FFF2-40B4-BE49-F238E27FC236}">
-                <a16:creationId xmlns:a16="http://schemas.microsoft.com/office/drawing/2014/main" id="{80488405-F8AA-4FF7-99BB-A429BC3D97BC}"/>
+                <a16:creationId xmlns:a16="http://schemas.microsoft.com/office/drawing/2014/main" id="{A68C3D41-E176-4588-A4C6-829F946B00F6}"/>
               </a:ext>
             </a:extLst>
           </p:cNvPr>
@@ -3485,7 +3390,7 @@
         <p:spPr>
           <a:xfrm xmlns:a="http://schemas.openxmlformats.org/drawingml/2006/main">
             <a:off x="514350" y="6477000"/>
-            <a:ext cx="8191500" cy="190500"/>
+            <a:ext cx="9810750" cy="190500"/>
           </a:xfrm>
           <a:prstGeom xmlns:a="http://schemas.openxmlformats.org/drawingml/2006/main" prst="rect">
             <a:avLst/>
@@ -3521,7 +3426,7 @@
                 <a:ea typeface="Aptos"/>
                 <a:cs typeface="Aptos"/>
               </a:rPr>
-              <a:t>WATERS NEXT GEN COMPETITIVE INTELLIGENCE · 23 JUL 2026</a:t>
+              <a:t>WATERS NEXT GEN COMPETITIVE INTELLIGENCE · 28 JUL 2026 · waters-ci-20260728-202611</a:t>
             </a:r>
           </a:p>
         </p:txBody>
@@ -3531,7 +3436,7 @@
           <p:cNvPr id="25" name="">
             <a:extLst xmlns:a="http://schemas.openxmlformats.org/drawingml/2006/main">
               <a:ext uri="{FF2B5EF4-FFF2-40B4-BE49-F238E27FC236}">
-                <a16:creationId xmlns:a16="http://schemas.microsoft.com/office/drawing/2014/main" id="{9419EC03-1F30-4032-8AB5-D7D38A4378DC}"/>
+                <a16:creationId xmlns:a16="http://schemas.microsoft.com/office/drawing/2014/main" id="{6DE5521D-B3CD-4338-A4A4-F11571445361}"/>
               </a:ext>
             </a:extLst>
           </p:cNvPr>
@@ -3587,7 +3492,7 @@
     </p:spTree>
     <p:extLst>
       <p:ext uri="{BB962C8B-B14F-4D97-AF65-F5344CB8AC3E}">
-        <p14:creationId xmlns:p14="http://schemas.microsoft.com/office/powerpoint/2010/main" val="869325912"/>
+        <p14:creationId xmlns:p14="http://schemas.microsoft.com/office/powerpoint/2010/main" val="1353778790"/>
       </p:ext>
     </p:extLst>
   </p:cSld>
@@ -3618,7 +3523,7 @@
           <p:cNvPr id="37" name="">
             <a:extLst xmlns:a="http://schemas.openxmlformats.org/drawingml/2006/main">
               <a:ext uri="{FF2B5EF4-FFF2-40B4-BE49-F238E27FC236}">
-                <a16:creationId xmlns:a16="http://schemas.microsoft.com/office/drawing/2014/main" id="{C577F2F6-1C2E-491C-B87B-5C32A2B03A3F}"/>
+                <a16:creationId xmlns:a16="http://schemas.microsoft.com/office/drawing/2014/main" id="{F9C8F30D-17C4-4502-958E-1F51561EB566}"/>
               </a:ext>
             </a:extLst>
           </p:cNvPr>
@@ -3676,7 +3581,7 @@
           <p:cNvPr id="2" name="">
             <a:extLst xmlns:a="http://schemas.openxmlformats.org/drawingml/2006/main">
               <a:ext uri="{FF2B5EF4-FFF2-40B4-BE49-F238E27FC236}">
-                <a16:creationId xmlns:a16="http://schemas.microsoft.com/office/drawing/2014/main" id="{97C567B6-E639-46DE-A657-BF1D076B12A5}"/>
+                <a16:creationId xmlns:a16="http://schemas.microsoft.com/office/drawing/2014/main" id="{ABE7BB61-758E-43C6-AAD0-B3BF29219592}"/>
               </a:ext>
             </a:extLst>
           </p:cNvPr>
@@ -3734,7 +3639,7 @@
           <p:cNvPr id="3" name="">
             <a:extLst xmlns:a="http://schemas.openxmlformats.org/drawingml/2006/main">
               <a:ext uri="{FF2B5EF4-FFF2-40B4-BE49-F238E27FC236}">
-                <a16:creationId xmlns:a16="http://schemas.microsoft.com/office/drawing/2014/main" id="{815BEBBC-CF59-48DB-88BA-E8608CB8256F}"/>
+                <a16:creationId xmlns:a16="http://schemas.microsoft.com/office/drawing/2014/main" id="{1B25EAC5-EFCF-46D5-939D-F8A4012E11CB}"/>
               </a:ext>
             </a:extLst>
           </p:cNvPr>
@@ -3792,7 +3697,7 @@
           <p:cNvPr id="4" name="">
             <a:extLst xmlns:a="http://schemas.openxmlformats.org/drawingml/2006/main">
               <a:ext uri="{FF2B5EF4-FFF2-40B4-BE49-F238E27FC236}">
-                <a16:creationId xmlns:a16="http://schemas.microsoft.com/office/drawing/2014/main" id="{A8C0EF34-E68F-42EA-B28B-69BEEE7C75E3}"/>
+                <a16:creationId xmlns:a16="http://schemas.microsoft.com/office/drawing/2014/main" id="{CCF2C686-84F6-46AF-994A-1B14DE6D7E16}"/>
               </a:ext>
             </a:extLst>
           </p:cNvPr>
@@ -3825,7 +3730,7 @@
           <p:cNvPr id="5" name="">
             <a:extLst xmlns:a="http://schemas.openxmlformats.org/drawingml/2006/main">
               <a:ext uri="{FF2B5EF4-FFF2-40B4-BE49-F238E27FC236}">
-                <a16:creationId xmlns:a16="http://schemas.microsoft.com/office/drawing/2014/main" id="{B340D58F-0115-4CC7-BBC9-E7CD98B1A470}"/>
+                <a16:creationId xmlns:a16="http://schemas.microsoft.com/office/drawing/2014/main" id="{7D041459-B84F-4CBF-84BD-C83C97D96E24}"/>
               </a:ext>
             </a:extLst>
           </p:cNvPr>
@@ -3860,7 +3765,7 @@
           <p:cNvPr id="6" name="">
             <a:extLst xmlns:a="http://schemas.openxmlformats.org/drawingml/2006/main">
               <a:ext uri="{FF2B5EF4-FFF2-40B4-BE49-F238E27FC236}">
-                <a16:creationId xmlns:a16="http://schemas.microsoft.com/office/drawing/2014/main" id="{7C59A844-6E31-41B0-8187-1183DC72D75B}"/>
+                <a16:creationId xmlns:a16="http://schemas.microsoft.com/office/drawing/2014/main" id="{66B228E7-D3BB-4399-81A2-C1ECE4B711F6}"/>
               </a:ext>
             </a:extLst>
           </p:cNvPr>
@@ -3895,7 +3800,7 @@
           <p:cNvPr id="7" name="">
             <a:extLst xmlns:a="http://schemas.openxmlformats.org/drawingml/2006/main">
               <a:ext uri="{FF2B5EF4-FFF2-40B4-BE49-F238E27FC236}">
-                <a16:creationId xmlns:a16="http://schemas.microsoft.com/office/drawing/2014/main" id="{1AE959DE-BD73-478C-8BB9-DB5709CEF943}"/>
+                <a16:creationId xmlns:a16="http://schemas.microsoft.com/office/drawing/2014/main" id="{9795BCDA-8F79-4780-BE98-55F5A15DD3A0}"/>
               </a:ext>
             </a:extLst>
           </p:cNvPr>
@@ -3953,7 +3858,7 @@
           <p:cNvPr id="8" name="">
             <a:extLst xmlns:a="http://schemas.openxmlformats.org/drawingml/2006/main">
               <a:ext uri="{FF2B5EF4-FFF2-40B4-BE49-F238E27FC236}">
-                <a16:creationId xmlns:a16="http://schemas.microsoft.com/office/drawing/2014/main" id="{750883F4-6D91-4D5B-8592-43C0E66CD404}"/>
+                <a16:creationId xmlns:a16="http://schemas.microsoft.com/office/drawing/2014/main" id="{1EC76182-F763-4DB8-8530-F8E3CB1036A1}"/>
               </a:ext>
             </a:extLst>
           </p:cNvPr>
@@ -4011,7 +3916,7 @@
           <p:cNvPr id="9" name="">
             <a:extLst xmlns:a="http://schemas.openxmlformats.org/drawingml/2006/main">
               <a:ext uri="{FF2B5EF4-FFF2-40B4-BE49-F238E27FC236}">
-                <a16:creationId xmlns:a16="http://schemas.microsoft.com/office/drawing/2014/main" id="{0F116D51-42E0-4250-A0E2-C610E574B0C2}"/>
+                <a16:creationId xmlns:a16="http://schemas.microsoft.com/office/drawing/2014/main" id="{DD3BD1C1-464F-48C5-97BC-D961C418CEEF}"/>
               </a:ext>
             </a:extLst>
           </p:cNvPr>
@@ -4069,7 +3974,7 @@
           <p:cNvPr id="10" name="">
             <a:extLst xmlns:a="http://schemas.openxmlformats.org/drawingml/2006/main">
               <a:ext uri="{FF2B5EF4-FFF2-40B4-BE49-F238E27FC236}">
-                <a16:creationId xmlns:a16="http://schemas.microsoft.com/office/drawing/2014/main" id="{3286D95B-D992-4867-A489-2A58B5BCE92A}"/>
+                <a16:creationId xmlns:a16="http://schemas.microsoft.com/office/drawing/2014/main" id="{2DC9372D-BDC2-428A-BDE9-8F65D2F08587}"/>
               </a:ext>
             </a:extLst>
           </p:cNvPr>
@@ -4117,7 +4022,7 @@
                 <a:ea typeface="Aptos"/>
                 <a:cs typeface="Aptos"/>
               </a:rPr>
-              <a:t>328 records in the current one-year evidence window.</a:t>
+              <a:t>335 records; Waters exposure unquantified.</a:t>
             </a:r>
           </a:p>
         </p:txBody>
@@ -4127,7 +4032,7 @@
           <p:cNvPr id="11" name="">
             <a:extLst xmlns:a="http://schemas.openxmlformats.org/drawingml/2006/main">
               <a:ext uri="{FF2B5EF4-FFF2-40B4-BE49-F238E27FC236}">
-                <a16:creationId xmlns:a16="http://schemas.microsoft.com/office/drawing/2014/main" id="{24D44520-1007-4533-BCF0-D1F669972442}"/>
+                <a16:creationId xmlns:a16="http://schemas.microsoft.com/office/drawing/2014/main" id="{593835C1-555B-4B0B-ADD1-8553BC1D9E9C}"/>
               </a:ext>
             </a:extLst>
           </p:cNvPr>
@@ -4162,7 +4067,7 @@
           <p:cNvPr id="12" name="">
             <a:extLst xmlns:a="http://schemas.openxmlformats.org/drawingml/2006/main">
               <a:ext uri="{FF2B5EF4-FFF2-40B4-BE49-F238E27FC236}">
-                <a16:creationId xmlns:a16="http://schemas.microsoft.com/office/drawing/2014/main" id="{4BAC223C-F903-43A3-B005-136A6261F43D}"/>
+                <a16:creationId xmlns:a16="http://schemas.microsoft.com/office/drawing/2014/main" id="{75422605-8279-45E3-85D4-9CA160B0A68B}"/>
               </a:ext>
             </a:extLst>
           </p:cNvPr>
@@ -4197,7 +4102,7 @@
           <p:cNvPr id="13" name="">
             <a:extLst xmlns:a="http://schemas.openxmlformats.org/drawingml/2006/main">
               <a:ext uri="{FF2B5EF4-FFF2-40B4-BE49-F238E27FC236}">
-                <a16:creationId xmlns:a16="http://schemas.microsoft.com/office/drawing/2014/main" id="{8A36E8F5-CD25-4B10-BE98-3C1AD1FA2B63}"/>
+                <a16:creationId xmlns:a16="http://schemas.microsoft.com/office/drawing/2014/main" id="{5796876B-A85F-4187-98FE-FC034258CAAE}"/>
               </a:ext>
             </a:extLst>
           </p:cNvPr>
@@ -4255,7 +4160,7 @@
           <p:cNvPr id="14" name="">
             <a:extLst xmlns:a="http://schemas.openxmlformats.org/drawingml/2006/main">
               <a:ext uri="{FF2B5EF4-FFF2-40B4-BE49-F238E27FC236}">
-                <a16:creationId xmlns:a16="http://schemas.microsoft.com/office/drawing/2014/main" id="{E79BF881-DB03-4CFC-864E-B41C39D5610C}"/>
+                <a16:creationId xmlns:a16="http://schemas.microsoft.com/office/drawing/2014/main" id="{AD622EBC-8D0F-457A-A28A-FC9953F6907C}"/>
               </a:ext>
             </a:extLst>
           </p:cNvPr>
@@ -4313,7 +4218,7 @@
           <p:cNvPr id="15" name="">
             <a:extLst xmlns:a="http://schemas.openxmlformats.org/drawingml/2006/main">
               <a:ext uri="{FF2B5EF4-FFF2-40B4-BE49-F238E27FC236}">
-                <a16:creationId xmlns:a16="http://schemas.microsoft.com/office/drawing/2014/main" id="{1B413524-0D3C-4FEB-BC79-040B18C80EC0}"/>
+                <a16:creationId xmlns:a16="http://schemas.microsoft.com/office/drawing/2014/main" id="{9C1CFB07-8DA4-44B3-992B-D9F36DB19021}"/>
               </a:ext>
             </a:extLst>
           </p:cNvPr>
@@ -4371,7 +4276,7 @@
           <p:cNvPr id="16" name="">
             <a:extLst xmlns:a="http://schemas.openxmlformats.org/drawingml/2006/main">
               <a:ext uri="{FF2B5EF4-FFF2-40B4-BE49-F238E27FC236}">
-                <a16:creationId xmlns:a16="http://schemas.microsoft.com/office/drawing/2014/main" id="{6671449D-7360-4D4F-A744-0A6A5716D343}"/>
+                <a16:creationId xmlns:a16="http://schemas.microsoft.com/office/drawing/2014/main" id="{D1CD0487-E3F1-428C-B486-C9AE418892EC}"/>
               </a:ext>
             </a:extLst>
           </p:cNvPr>
@@ -4419,7 +4324,7 @@
                 <a:ea typeface="Aptos"/>
                 <a:cs typeface="Aptos"/>
               </a:rPr>
-              <a:t>6230C positioning competes on workflow value, not only hardware.</a:t>
+              <a:t>Observed issuer evidence; Waters exposure unquantified.</a:t>
             </a:r>
           </a:p>
         </p:txBody>
@@ -4429,7 +4334,7 @@
           <p:cNvPr id="17" name="">
             <a:extLst xmlns:a="http://schemas.openxmlformats.org/drawingml/2006/main">
               <a:ext uri="{FF2B5EF4-FFF2-40B4-BE49-F238E27FC236}">
-                <a16:creationId xmlns:a16="http://schemas.microsoft.com/office/drawing/2014/main" id="{E10083F1-58C8-4078-966F-2194379268CC}"/>
+                <a16:creationId xmlns:a16="http://schemas.microsoft.com/office/drawing/2014/main" id="{D733EF0C-1432-4E80-BC8C-766B0C0CCC8C}"/>
               </a:ext>
             </a:extLst>
           </p:cNvPr>
@@ -4464,7 +4369,7 @@
           <p:cNvPr id="18" name="">
             <a:extLst xmlns:a="http://schemas.openxmlformats.org/drawingml/2006/main">
               <a:ext uri="{FF2B5EF4-FFF2-40B4-BE49-F238E27FC236}">
-                <a16:creationId xmlns:a16="http://schemas.microsoft.com/office/drawing/2014/main" id="{DD0CD246-A949-4F66-A768-87D47598E64D}"/>
+                <a16:creationId xmlns:a16="http://schemas.microsoft.com/office/drawing/2014/main" id="{3A94D908-680F-4FE9-8719-935ECDCAE36C}"/>
               </a:ext>
             </a:extLst>
           </p:cNvPr>
@@ -4499,7 +4404,7 @@
           <p:cNvPr id="19" name="">
             <a:extLst xmlns:a="http://schemas.openxmlformats.org/drawingml/2006/main">
               <a:ext uri="{FF2B5EF4-FFF2-40B4-BE49-F238E27FC236}">
-                <a16:creationId xmlns:a16="http://schemas.microsoft.com/office/drawing/2014/main" id="{81534364-93FD-4ED6-8FDA-E4AF0915EE67}"/>
+                <a16:creationId xmlns:a16="http://schemas.microsoft.com/office/drawing/2014/main" id="{CE38DEAE-CF57-4422-8F55-581BE6B811C1}"/>
               </a:ext>
             </a:extLst>
           </p:cNvPr>
@@ -4557,7 +4462,7 @@
           <p:cNvPr id="20" name="">
             <a:extLst xmlns:a="http://schemas.openxmlformats.org/drawingml/2006/main">
               <a:ext uri="{FF2B5EF4-FFF2-40B4-BE49-F238E27FC236}">
-                <a16:creationId xmlns:a16="http://schemas.microsoft.com/office/drawing/2014/main" id="{8EA25623-4788-497A-862F-AFCEFBC80D6F}"/>
+                <a16:creationId xmlns:a16="http://schemas.microsoft.com/office/drawing/2014/main" id="{9FFD39F7-33C2-4165-B8C9-921FDB8B0B7B}"/>
               </a:ext>
             </a:extLst>
           </p:cNvPr>
@@ -4615,7 +4520,7 @@
           <p:cNvPr id="21" name="">
             <a:extLst xmlns:a="http://schemas.openxmlformats.org/drawingml/2006/main">
               <a:ext uri="{FF2B5EF4-FFF2-40B4-BE49-F238E27FC236}">
-                <a16:creationId xmlns:a16="http://schemas.microsoft.com/office/drawing/2014/main" id="{7DD9BCE5-EC48-4DEB-ACF2-C8177CF3E67B}"/>
+                <a16:creationId xmlns:a16="http://schemas.microsoft.com/office/drawing/2014/main" id="{887AF281-7808-44CC-B8A3-E21AEB689289}"/>
               </a:ext>
             </a:extLst>
           </p:cNvPr>
@@ -4663,7 +4568,7 @@
                 <a:ea typeface="Aptos"/>
                 <a:cs typeface="Aptos"/>
               </a:rPr>
-              <a:t>Troubleshooting time is a product opportunity</a:t>
+              <a:t>Troubleshooting requires internal validation</a:t>
             </a:r>
           </a:p>
         </p:txBody>
@@ -4673,7 +4578,7 @@
           <p:cNvPr id="22" name="">
             <a:extLst xmlns:a="http://schemas.openxmlformats.org/drawingml/2006/main">
               <a:ext uri="{FF2B5EF4-FFF2-40B4-BE49-F238E27FC236}">
-                <a16:creationId xmlns:a16="http://schemas.microsoft.com/office/drawing/2014/main" id="{0AD0099A-F5AD-4FF8-A47B-AEE1CBC7108A}"/>
+                <a16:creationId xmlns:a16="http://schemas.microsoft.com/office/drawing/2014/main" id="{FC107439-6F2B-42D3-BA8B-95CAC5B12105}"/>
               </a:ext>
             </a:extLst>
           </p:cNvPr>
@@ -4721,7 +4626,7 @@
                 <a:ea typeface="Aptos"/>
                 <a:cs typeface="Aptos"/>
               </a:rPr>
-              <a:t>The exact public source supports Waters UPLC high-pressure troubleshooting.</a:t>
+              <a:t>Public forum evidence is directional; recurrence and business impact are unquantified.</a:t>
             </a:r>
           </a:p>
         </p:txBody>
@@ -4731,7 +4636,7 @@
           <p:cNvPr id="23" name="">
             <a:extLst xmlns:a="http://schemas.openxmlformats.org/drawingml/2006/main">
               <a:ext uri="{FF2B5EF4-FFF2-40B4-BE49-F238E27FC236}">
-                <a16:creationId xmlns:a16="http://schemas.microsoft.com/office/drawing/2014/main" id="{C9925B2A-086C-4B96-832B-0CD64417783B}"/>
+                <a16:creationId xmlns:a16="http://schemas.microsoft.com/office/drawing/2014/main" id="{8D41B59C-7F7D-4866-A501-CD2DCE0B92A4}"/>
               </a:ext>
             </a:extLst>
           </p:cNvPr>
@@ -4766,7 +4671,7 @@
           <p:cNvPr id="24" name="">
             <a:extLst xmlns:a="http://schemas.openxmlformats.org/drawingml/2006/main">
               <a:ext uri="{FF2B5EF4-FFF2-40B4-BE49-F238E27FC236}">
-                <a16:creationId xmlns:a16="http://schemas.microsoft.com/office/drawing/2014/main" id="{9DFE562E-DBC8-47DC-B82D-BDBA92116DE1}"/>
+                <a16:creationId xmlns:a16="http://schemas.microsoft.com/office/drawing/2014/main" id="{905DD3FE-7D02-4BF0-AA74-92193E1A9776}"/>
               </a:ext>
             </a:extLst>
           </p:cNvPr>
@@ -4801,7 +4706,7 @@
           <p:cNvPr id="25" name="">
             <a:extLst xmlns:a="http://schemas.openxmlformats.org/drawingml/2006/main">
               <a:ext uri="{FF2B5EF4-FFF2-40B4-BE49-F238E27FC236}">
-                <a16:creationId xmlns:a16="http://schemas.microsoft.com/office/drawing/2014/main" id="{BFA0E51C-9618-4031-8E5F-C64004E5B24C}"/>
+                <a16:creationId xmlns:a16="http://schemas.microsoft.com/office/drawing/2014/main" id="{F93A9272-F4C3-4415-9C98-C54522D54DDD}"/>
               </a:ext>
             </a:extLst>
           </p:cNvPr>
@@ -4859,7 +4764,7 @@
           <p:cNvPr id="26" name="">
             <a:extLst xmlns:a="http://schemas.openxmlformats.org/drawingml/2006/main">
               <a:ext uri="{FF2B5EF4-FFF2-40B4-BE49-F238E27FC236}">
-                <a16:creationId xmlns:a16="http://schemas.microsoft.com/office/drawing/2014/main" id="{3FB957D1-D45D-4996-8266-D925F102A73C}"/>
+                <a16:creationId xmlns:a16="http://schemas.microsoft.com/office/drawing/2014/main" id="{A81B7F77-F85A-4D95-8511-7B07B30616E0}"/>
               </a:ext>
             </a:extLst>
           </p:cNvPr>
@@ -4917,7 +4822,7 @@
           <p:cNvPr id="27" name="">
             <a:extLst xmlns:a="http://schemas.openxmlformats.org/drawingml/2006/main">
               <a:ext uri="{FF2B5EF4-FFF2-40B4-BE49-F238E27FC236}">
-                <a16:creationId xmlns:a16="http://schemas.microsoft.com/office/drawing/2014/main" id="{F945BAA8-A9CC-44F9-8A59-96C226F89570}"/>
+                <a16:creationId xmlns:a16="http://schemas.microsoft.com/office/drawing/2014/main" id="{F2C15837-7F9D-402D-A8C4-12532D659F54}"/>
               </a:ext>
             </a:extLst>
           </p:cNvPr>
@@ -4975,7 +4880,7 @@
           <p:cNvPr id="28" name="">
             <a:extLst xmlns:a="http://schemas.openxmlformats.org/drawingml/2006/main">
               <a:ext uri="{FF2B5EF4-FFF2-40B4-BE49-F238E27FC236}">
-                <a16:creationId xmlns:a16="http://schemas.microsoft.com/office/drawing/2014/main" id="{93AC45DE-34B4-4DD4-A194-0FA3F578DCA6}"/>
+                <a16:creationId xmlns:a16="http://schemas.microsoft.com/office/drawing/2014/main" id="{8CC0E09B-4153-4D4C-9622-621A50375F5C}"/>
               </a:ext>
             </a:extLst>
           </p:cNvPr>
@@ -5023,7 +4928,7 @@
                 <a:ea typeface="Aptos"/>
                 <a:cs typeface="Aptos"/>
               </a:rPr>
-              <a:t>Direct SEC evidence links the portfolio to growth markets.</a:t>
+              <a:t>Direct issuer filing; no independent external corroboration.</a:t>
             </a:r>
           </a:p>
         </p:txBody>
@@ -5033,7 +4938,7 @@
           <p:cNvPr id="29" name="">
             <a:extLst xmlns:a="http://schemas.openxmlformats.org/drawingml/2006/main">
               <a:ext uri="{FF2B5EF4-FFF2-40B4-BE49-F238E27FC236}">
-                <a16:creationId xmlns:a16="http://schemas.microsoft.com/office/drawing/2014/main" id="{B14103AB-4E17-4FE8-B945-308779FD1B6C}"/>
+                <a16:creationId xmlns:a16="http://schemas.microsoft.com/office/drawing/2014/main" id="{55D45477-5B6D-4CCF-95D1-B87010E0E4B3}"/>
               </a:ext>
             </a:extLst>
           </p:cNvPr>
@@ -5068,7 +4973,7 @@
           <p:cNvPr id="30" name="">
             <a:extLst xmlns:a="http://schemas.openxmlformats.org/drawingml/2006/main">
               <a:ext uri="{FF2B5EF4-FFF2-40B4-BE49-F238E27FC236}">
-                <a16:creationId xmlns:a16="http://schemas.microsoft.com/office/drawing/2014/main" id="{9351F119-0A62-4759-AFA5-0EFD8B2D3440}"/>
+                <a16:creationId xmlns:a16="http://schemas.microsoft.com/office/drawing/2014/main" id="{09DF66C1-FECF-4DE4-9BBF-4435918F2D6B}"/>
               </a:ext>
             </a:extLst>
           </p:cNvPr>
@@ -5103,7 +5008,7 @@
           <p:cNvPr id="31" name="">
             <a:extLst xmlns:a="http://schemas.openxmlformats.org/drawingml/2006/main">
               <a:ext uri="{FF2B5EF4-FFF2-40B4-BE49-F238E27FC236}">
-                <a16:creationId xmlns:a16="http://schemas.microsoft.com/office/drawing/2014/main" id="{AD86DAAB-4F34-450F-A397-D6F02D63CEA8}"/>
+                <a16:creationId xmlns:a16="http://schemas.microsoft.com/office/drawing/2014/main" id="{86BFFD8F-6AD2-44C1-91B3-6EE3840C5E05}"/>
               </a:ext>
             </a:extLst>
           </p:cNvPr>
@@ -5161,7 +5066,7 @@
           <p:cNvPr id="32" name="">
             <a:extLst xmlns:a="http://schemas.openxmlformats.org/drawingml/2006/main">
               <a:ext uri="{FF2B5EF4-FFF2-40B4-BE49-F238E27FC236}">
-                <a16:creationId xmlns:a16="http://schemas.microsoft.com/office/drawing/2014/main" id="{A189D1A1-18E0-44FA-8956-B0B936042E87}"/>
+                <a16:creationId xmlns:a16="http://schemas.microsoft.com/office/drawing/2014/main" id="{32B2F4B0-C372-4878-A621-3268E51BEAAD}"/>
               </a:ext>
             </a:extLst>
           </p:cNvPr>
@@ -5219,7 +5124,7 @@
           <p:cNvPr id="33" name="">
             <a:extLst xmlns:a="http://schemas.openxmlformats.org/drawingml/2006/main">
               <a:ext uri="{FF2B5EF4-FFF2-40B4-BE49-F238E27FC236}">
-                <a16:creationId xmlns:a16="http://schemas.microsoft.com/office/drawing/2014/main" id="{553AFB40-E847-442D-A152-C85C4CE3A37F}"/>
+                <a16:creationId xmlns:a16="http://schemas.microsoft.com/office/drawing/2014/main" id="{882A0F19-1969-4C1A-8BBC-30E8844592E7}"/>
               </a:ext>
             </a:extLst>
           </p:cNvPr>
@@ -5277,7 +5182,7 @@
           <p:cNvPr id="34" name="">
             <a:extLst xmlns:a="http://schemas.openxmlformats.org/drawingml/2006/main">
               <a:ext uri="{FF2B5EF4-FFF2-40B4-BE49-F238E27FC236}">
-                <a16:creationId xmlns:a16="http://schemas.microsoft.com/office/drawing/2014/main" id="{3610B72C-EF80-4495-A7CE-25F62296C8A8}"/>
+                <a16:creationId xmlns:a16="http://schemas.microsoft.com/office/drawing/2014/main" id="{67EFA123-6A36-43AF-AA8B-5170E2EE3CF7}"/>
               </a:ext>
             </a:extLst>
           </p:cNvPr>
@@ -5325,7 +5230,7 @@
                 <a:ea typeface="Aptos"/>
                 <a:cs typeface="Aptos"/>
               </a:rPr>
-              <a:t>A near-term stage for MAM, complex modalities and transfer proof.</a:t>
+              <a:t>Observed agenda and sponsor facts; Waters exposure unquantified.</a:t>
             </a:r>
           </a:p>
         </p:txBody>
@@ -5335,7 +5240,7 @@
           <p:cNvPr id="35" name="">
             <a:extLst xmlns:a="http://schemas.openxmlformats.org/drawingml/2006/main">
               <a:ext uri="{FF2B5EF4-FFF2-40B4-BE49-F238E27FC236}">
-                <a16:creationId xmlns:a16="http://schemas.microsoft.com/office/drawing/2014/main" id="{D3C50A7C-A05D-47B2-A82A-730B7381F0FD}"/>
+                <a16:creationId xmlns:a16="http://schemas.microsoft.com/office/drawing/2014/main" id="{31930B68-A43B-4571-AEDE-576F504E5614}"/>
               </a:ext>
             </a:extLst>
           </p:cNvPr>
@@ -5347,7 +5252,7 @@
         <p:spPr>
           <a:xfrm xmlns:a="http://schemas.openxmlformats.org/drawingml/2006/main">
             <a:off x="514350" y="6477000"/>
-            <a:ext cx="8191500" cy="190500"/>
+            <a:ext cx="9810750" cy="190500"/>
           </a:xfrm>
           <a:prstGeom xmlns:a="http://schemas.openxmlformats.org/drawingml/2006/main" prst="rect">
             <a:avLst/>
@@ -5383,7 +5288,7 @@
                 <a:ea typeface="Aptos"/>
                 <a:cs typeface="Aptos"/>
               </a:rPr>
-              <a:t>WATERS NEXT GEN COMPETITIVE INTELLIGENCE · 23 JUL 2026</a:t>
+              <a:t>WATERS NEXT GEN COMPETITIVE INTELLIGENCE · 28 JUL 2026 · waters-ci-20260728-202611</a:t>
             </a:r>
           </a:p>
         </p:txBody>
@@ -5393,7 +5298,7 @@
           <p:cNvPr id="36" name="">
             <a:extLst xmlns:a="http://schemas.openxmlformats.org/drawingml/2006/main">
               <a:ext uri="{FF2B5EF4-FFF2-40B4-BE49-F238E27FC236}">
-                <a16:creationId xmlns:a16="http://schemas.microsoft.com/office/drawing/2014/main" id="{B5C3CDEF-9839-4187-ABF7-D2354CA8CC5A}"/>
+                <a16:creationId xmlns:a16="http://schemas.microsoft.com/office/drawing/2014/main" id="{B3D9FF6E-04AF-415A-BACE-E6E35F1E8955}"/>
               </a:ext>
             </a:extLst>
           </p:cNvPr>
@@ -5449,7 +5354,7 @@
     </p:spTree>
     <p:extLst>
       <p:ext uri="{BB962C8B-B14F-4D97-AF65-F5344CB8AC3E}">
-        <p14:creationId xmlns:p14="http://schemas.microsoft.com/office/powerpoint/2010/main" val="1056849089"/>
+        <p14:creationId xmlns:p14="http://schemas.microsoft.com/office/powerpoint/2010/main" val="1380687293"/>
       </p:ext>
     </p:extLst>
   </p:cSld>
@@ -5480,7 +5385,7 @@
           <p:cNvPr id="31" name="">
             <a:extLst xmlns:a="http://schemas.openxmlformats.org/drawingml/2006/main">
               <a:ext uri="{FF2B5EF4-FFF2-40B4-BE49-F238E27FC236}">
-                <a16:creationId xmlns:a16="http://schemas.microsoft.com/office/drawing/2014/main" id="{23414CD1-7FDB-4A18-BA1E-32E819D07DB4}"/>
+                <a16:creationId xmlns:a16="http://schemas.microsoft.com/office/drawing/2014/main" id="{5BD670C5-C635-48C5-B3F0-135C56DA401F}"/>
               </a:ext>
             </a:extLst>
           </p:cNvPr>
@@ -5538,7 +5443,7 @@
           <p:cNvPr id="2" name="">
             <a:extLst xmlns:a="http://schemas.openxmlformats.org/drawingml/2006/main">
               <a:ext uri="{FF2B5EF4-FFF2-40B4-BE49-F238E27FC236}">
-                <a16:creationId xmlns:a16="http://schemas.microsoft.com/office/drawing/2014/main" id="{D4E02DE3-7D04-4324-BDE9-72F4AE527C19}"/>
+                <a16:creationId xmlns:a16="http://schemas.microsoft.com/office/drawing/2014/main" id="{AE7B896A-8164-4B7F-A6C9-2E2CED5DAB4A}"/>
               </a:ext>
             </a:extLst>
           </p:cNvPr>
@@ -5586,7 +5491,7 @@
                 <a:ea typeface="Aptos"/>
                 <a:cs typeface="Aptos"/>
               </a:rPr>
-              <a:t>Competitors are packaging execution—not only instruments</a:t>
+              <a:t>Observed competitor actions suggest workflow packaging</a:t>
             </a:r>
           </a:p>
         </p:txBody>
@@ -5596,7 +5501,7 @@
           <p:cNvPr id="3" name="">
             <a:extLst xmlns:a="http://schemas.openxmlformats.org/drawingml/2006/main">
               <a:ext uri="{FF2B5EF4-FFF2-40B4-BE49-F238E27FC236}">
-                <a16:creationId xmlns:a16="http://schemas.microsoft.com/office/drawing/2014/main" id="{AF26B002-DD2C-4E00-ACE3-48818D8702D5}"/>
+                <a16:creationId xmlns:a16="http://schemas.microsoft.com/office/drawing/2014/main" id="{2F0D53C2-DD46-45BC-B0D6-A4B1DA525A1D}"/>
               </a:ext>
             </a:extLst>
           </p:cNvPr>
@@ -5644,7 +5549,7 @@
                 <a:ea typeface="Aptos"/>
                 <a:cs typeface="Aptos"/>
               </a:rPr>
-              <a:t>Four current moves make workflow speed, automation, software and method execution more visible to customers.</a:t>
+              <a:t>Inference confidence is Directional: each company view lacks two independently corroborating source families.</a:t>
             </a:r>
           </a:p>
         </p:txBody>
@@ -5654,7 +5559,7 @@
           <p:cNvPr id="4" name="">
             <a:extLst xmlns:a="http://schemas.openxmlformats.org/drawingml/2006/main">
               <a:ext uri="{FF2B5EF4-FFF2-40B4-BE49-F238E27FC236}">
-                <a16:creationId xmlns:a16="http://schemas.microsoft.com/office/drawing/2014/main" id="{9AA2D5A8-145C-495E-A97D-B7E97FAFE3CD}"/>
+                <a16:creationId xmlns:a16="http://schemas.microsoft.com/office/drawing/2014/main" id="{CFB9F4D0-3FA9-448E-9E9C-31B9D5956F72}"/>
               </a:ext>
             </a:extLst>
           </p:cNvPr>
@@ -5687,7 +5592,7 @@
           <p:cNvPr id="5" name="">
             <a:extLst xmlns:a="http://schemas.openxmlformats.org/drawingml/2006/main">
               <a:ext uri="{FF2B5EF4-FFF2-40B4-BE49-F238E27FC236}">
-                <a16:creationId xmlns:a16="http://schemas.microsoft.com/office/drawing/2014/main" id="{E6DCA543-1C85-458A-AAB5-D3856E2A3686}"/>
+                <a16:creationId xmlns:a16="http://schemas.microsoft.com/office/drawing/2014/main" id="{DFD7AE91-E322-4609-8429-C053189ACD1B}"/>
               </a:ext>
             </a:extLst>
           </p:cNvPr>
@@ -5722,7 +5627,7 @@
           <p:cNvPr id="6" name="">
             <a:extLst xmlns:a="http://schemas.openxmlformats.org/drawingml/2006/main">
               <a:ext uri="{FF2B5EF4-FFF2-40B4-BE49-F238E27FC236}">
-                <a16:creationId xmlns:a16="http://schemas.microsoft.com/office/drawing/2014/main" id="{F7043EE0-627F-484C-A975-014AD9F6D8B6}"/>
+                <a16:creationId xmlns:a16="http://schemas.microsoft.com/office/drawing/2014/main" id="{833F76B0-445B-4516-A1C8-2E34DC0D6160}"/>
               </a:ext>
             </a:extLst>
           </p:cNvPr>
@@ -5755,7 +5660,7 @@
           <p:cNvPr id="7" name="">
             <a:extLst xmlns:a="http://schemas.openxmlformats.org/drawingml/2006/main">
               <a:ext uri="{FF2B5EF4-FFF2-40B4-BE49-F238E27FC236}">
-                <a16:creationId xmlns:a16="http://schemas.microsoft.com/office/drawing/2014/main" id="{5E647E71-9BD6-4854-9DE3-51B5496393D1}"/>
+                <a16:creationId xmlns:a16="http://schemas.microsoft.com/office/drawing/2014/main" id="{EC2D59AA-685D-44C7-9194-CB44DE0054D4}"/>
               </a:ext>
             </a:extLst>
           </p:cNvPr>
@@ -5813,7 +5718,7 @@
           <p:cNvPr id="8" name="">
             <a:extLst xmlns:a="http://schemas.openxmlformats.org/drawingml/2006/main">
               <a:ext uri="{FF2B5EF4-FFF2-40B4-BE49-F238E27FC236}">
-                <a16:creationId xmlns:a16="http://schemas.microsoft.com/office/drawing/2014/main" id="{7454F798-9D05-4617-93B7-03A63FC1BDEA}"/>
+                <a16:creationId xmlns:a16="http://schemas.microsoft.com/office/drawing/2014/main" id="{A2B65BB4-9542-4E5E-AAA8-C76C8C330CD2}"/>
               </a:ext>
             </a:extLst>
           </p:cNvPr>
@@ -5871,7 +5776,7 @@
           <p:cNvPr id="9" name="">
             <a:extLst xmlns:a="http://schemas.openxmlformats.org/drawingml/2006/main">
               <a:ext uri="{FF2B5EF4-FFF2-40B4-BE49-F238E27FC236}">
-                <a16:creationId xmlns:a16="http://schemas.microsoft.com/office/drawing/2014/main" id="{5F2A5385-7B5E-44CB-805E-4DDC06ED79B4}"/>
+                <a16:creationId xmlns:a16="http://schemas.microsoft.com/office/drawing/2014/main" id="{EC30CCD6-B947-4030-9B94-3827D55E178E}"/>
               </a:ext>
             </a:extLst>
           </p:cNvPr>
@@ -5919,7 +5824,7 @@
                 <a:ea typeface="Aptos"/>
                 <a:cs typeface="Aptos"/>
               </a:rPr>
-              <a:t>Nexera X4</a:t>
+              <a:t>Observed: Nexera X4 launch</a:t>
             </a:r>
           </a:p>
         </p:txBody>
@@ -5929,7 +5834,7 @@
           <p:cNvPr id="10" name="">
             <a:extLst xmlns:a="http://schemas.openxmlformats.org/drawingml/2006/main">
               <a:ext uri="{FF2B5EF4-FFF2-40B4-BE49-F238E27FC236}">
-                <a16:creationId xmlns:a16="http://schemas.microsoft.com/office/drawing/2014/main" id="{F6B569C5-4818-40C2-8056-E79EE019EACD}"/>
+                <a16:creationId xmlns:a16="http://schemas.microsoft.com/office/drawing/2014/main" id="{D0AFBC29-CA12-4D63-8208-AEF85E9AD670}"/>
               </a:ext>
             </a:extLst>
           </p:cNvPr>
@@ -5977,7 +5882,7 @@
                 <a:ea typeface="Aptos"/>
                 <a:cs typeface="Aptos"/>
               </a:rPr>
-              <a:t>A new LC platform framed around workflow execution and usability.</a:t>
+              <a:t>Inference: productivity-led LC positioning. Alternative: normal platform refresh.</a:t>
             </a:r>
           </a:p>
         </p:txBody>
@@ -5987,7 +5892,7 @@
           <p:cNvPr id="11" name="">
             <a:extLst xmlns:a="http://schemas.openxmlformats.org/drawingml/2006/main">
               <a:ext uri="{FF2B5EF4-FFF2-40B4-BE49-F238E27FC236}">
-                <a16:creationId xmlns:a16="http://schemas.microsoft.com/office/drawing/2014/main" id="{1B3FDACD-7858-4A32-A8F4-95B35D1CE1D8}"/>
+                <a16:creationId xmlns:a16="http://schemas.microsoft.com/office/drawing/2014/main" id="{09A7C77B-D65B-4968-9DA6-7837178E4DAD}"/>
               </a:ext>
             </a:extLst>
           </p:cNvPr>
@@ -6022,7 +5927,7 @@
           <p:cNvPr id="12" name="">
             <a:extLst xmlns:a="http://schemas.openxmlformats.org/drawingml/2006/main">
               <a:ext uri="{FF2B5EF4-FFF2-40B4-BE49-F238E27FC236}">
-                <a16:creationId xmlns:a16="http://schemas.microsoft.com/office/drawing/2014/main" id="{69EFCFE4-1136-4D37-AA28-13CB6E9509A1}"/>
+                <a16:creationId xmlns:a16="http://schemas.microsoft.com/office/drawing/2014/main" id="{886C0451-F8F2-4B8A-B2A2-EBB6EE7D79D5}"/>
               </a:ext>
             </a:extLst>
           </p:cNvPr>
@@ -6055,7 +5960,7 @@
           <p:cNvPr id="13" name="">
             <a:extLst xmlns:a="http://schemas.openxmlformats.org/drawingml/2006/main">
               <a:ext uri="{FF2B5EF4-FFF2-40B4-BE49-F238E27FC236}">
-                <a16:creationId xmlns:a16="http://schemas.microsoft.com/office/drawing/2014/main" id="{BA76182E-85F9-4372-A8D3-872CBA38329D}"/>
+                <a16:creationId xmlns:a16="http://schemas.microsoft.com/office/drawing/2014/main" id="{B7880C45-39BE-4DA5-887E-3A8F588EB25F}"/>
               </a:ext>
             </a:extLst>
           </p:cNvPr>
@@ -6113,7 +6018,7 @@
           <p:cNvPr id="14" name="">
             <a:extLst xmlns:a="http://schemas.openxmlformats.org/drawingml/2006/main">
               <a:ext uri="{FF2B5EF4-FFF2-40B4-BE49-F238E27FC236}">
-                <a16:creationId xmlns:a16="http://schemas.microsoft.com/office/drawing/2014/main" id="{B154FE8D-E973-4885-B197-590619FA7EAA}"/>
+                <a16:creationId xmlns:a16="http://schemas.microsoft.com/office/drawing/2014/main" id="{6F2F8095-F00B-4F82-A001-E67BD52D91BC}"/>
               </a:ext>
             </a:extLst>
           </p:cNvPr>
@@ -6171,7 +6076,7 @@
           <p:cNvPr id="15" name="">
             <a:extLst xmlns:a="http://schemas.openxmlformats.org/drawingml/2006/main">
               <a:ext uri="{FF2B5EF4-FFF2-40B4-BE49-F238E27FC236}">
-                <a16:creationId xmlns:a16="http://schemas.microsoft.com/office/drawing/2014/main" id="{E1AA24E4-03AB-444E-B30A-6A6A523CB493}"/>
+                <a16:creationId xmlns:a16="http://schemas.microsoft.com/office/drawing/2014/main" id="{97255B62-F8FB-4987-85DB-F41AB3897253}"/>
               </a:ext>
             </a:extLst>
           </p:cNvPr>
@@ -6219,7 +6124,7 @@
                 <a:ea typeface="Aptos"/>
                 <a:cs typeface="Aptos"/>
               </a:rPr>
-              <a:t>6230C LC/TOF in MAM</a:t>
+              <a:t>Observed: 6230C LC/TOF in MAM</a:t>
             </a:r>
           </a:p>
         </p:txBody>
@@ -6229,7 +6134,7 @@
           <p:cNvPr id="16" name="">
             <a:extLst xmlns:a="http://schemas.openxmlformats.org/drawingml/2006/main">
               <a:ext uri="{FF2B5EF4-FFF2-40B4-BE49-F238E27FC236}">
-                <a16:creationId xmlns:a16="http://schemas.microsoft.com/office/drawing/2014/main" id="{9CDDCA3B-EBAE-43DD-AC23-40BB6B002B59}"/>
+                <a16:creationId xmlns:a16="http://schemas.microsoft.com/office/drawing/2014/main" id="{52990C60-E876-4A07-A27E-EDA7AE723CE2}"/>
               </a:ext>
             </a:extLst>
           </p:cNvPr>
@@ -6277,7 +6182,7 @@
                 <a:ea typeface="Aptos"/>
                 <a:cs typeface="Aptos"/>
               </a:rPr>
-              <a:t>Positions instrument value inside a defined biopharma workflow.</a:t>
+              <a:t>Inference: application-specific workflow packaging. Alternative: campaign positioning.</a:t>
             </a:r>
           </a:p>
         </p:txBody>
@@ -6287,7 +6192,7 @@
           <p:cNvPr id="17" name="">
             <a:extLst xmlns:a="http://schemas.openxmlformats.org/drawingml/2006/main">
               <a:ext uri="{FF2B5EF4-FFF2-40B4-BE49-F238E27FC236}">
-                <a16:creationId xmlns:a16="http://schemas.microsoft.com/office/drawing/2014/main" id="{E45A0034-1DB7-4A57-9A23-DA24352404A4}"/>
+                <a16:creationId xmlns:a16="http://schemas.microsoft.com/office/drawing/2014/main" id="{D5B7577D-4DBA-4719-87E7-46BA93598FEC}"/>
               </a:ext>
             </a:extLst>
           </p:cNvPr>
@@ -6322,7 +6227,7 @@
           <p:cNvPr id="18" name="">
             <a:extLst xmlns:a="http://schemas.openxmlformats.org/drawingml/2006/main">
               <a:ext uri="{FF2B5EF4-FFF2-40B4-BE49-F238E27FC236}">
-                <a16:creationId xmlns:a16="http://schemas.microsoft.com/office/drawing/2014/main" id="{AC92995C-73F0-4C76-AD07-D7AF49229A8C}"/>
+                <a16:creationId xmlns:a16="http://schemas.microsoft.com/office/drawing/2014/main" id="{913CDCF7-0934-4FF9-B538-D8DFB1AD89CE}"/>
               </a:ext>
             </a:extLst>
           </p:cNvPr>
@@ -6355,7 +6260,7 @@
           <p:cNvPr id="19" name="">
             <a:extLst xmlns:a="http://schemas.openxmlformats.org/drawingml/2006/main">
               <a:ext uri="{FF2B5EF4-FFF2-40B4-BE49-F238E27FC236}">
-                <a16:creationId xmlns:a16="http://schemas.microsoft.com/office/drawing/2014/main" id="{2236D06E-AE03-4216-8A9F-536C0CD0B19B}"/>
+                <a16:creationId xmlns:a16="http://schemas.microsoft.com/office/drawing/2014/main" id="{6F021920-1E7C-463F-9E4A-3661F6C046F7}"/>
               </a:ext>
             </a:extLst>
           </p:cNvPr>
@@ -6413,7 +6318,7 @@
           <p:cNvPr id="20" name="">
             <a:extLst xmlns:a="http://schemas.openxmlformats.org/drawingml/2006/main">
               <a:ext uri="{FF2B5EF4-FFF2-40B4-BE49-F238E27FC236}">
-                <a16:creationId xmlns:a16="http://schemas.microsoft.com/office/drawing/2014/main" id="{2A18AFBE-F7DC-4196-A28F-C52496E61F7F}"/>
+                <a16:creationId xmlns:a16="http://schemas.microsoft.com/office/drawing/2014/main" id="{863F3C2B-D942-46BB-B692-7F7A35457D33}"/>
               </a:ext>
             </a:extLst>
           </p:cNvPr>
@@ -6471,7 +6376,7 @@
           <p:cNvPr id="21" name="">
             <a:extLst xmlns:a="http://schemas.openxmlformats.org/drawingml/2006/main">
               <a:ext uri="{FF2B5EF4-FFF2-40B4-BE49-F238E27FC236}">
-                <a16:creationId xmlns:a16="http://schemas.microsoft.com/office/drawing/2014/main" id="{7C47938D-198D-47EF-84D5-5955FA78FFB8}"/>
+                <a16:creationId xmlns:a16="http://schemas.microsoft.com/office/drawing/2014/main" id="{A15B28F8-86D2-4701-B68E-04923B1159CC}"/>
               </a:ext>
             </a:extLst>
           </p:cNvPr>
@@ -6519,7 +6424,7 @@
                 <a:ea typeface="Aptos"/>
                 <a:cs typeface="Aptos"/>
               </a:rPr>
-              <a:t>novus V55 + SCIEX OS 5.0</a:t>
+              <a:t>Observed: novus V55 + SCIEX OS 5.0</a:t>
             </a:r>
           </a:p>
         </p:txBody>
@@ -6529,7 +6434,7 @@
           <p:cNvPr id="22" name="">
             <a:extLst xmlns:a="http://schemas.openxmlformats.org/drawingml/2006/main">
               <a:ext uri="{FF2B5EF4-FFF2-40B4-BE49-F238E27FC236}">
-                <a16:creationId xmlns:a16="http://schemas.microsoft.com/office/drawing/2014/main" id="{BFF4D81E-EFC9-4EFE-BCE4-C3FB9F36B9E6}"/>
+                <a16:creationId xmlns:a16="http://schemas.microsoft.com/office/drawing/2014/main" id="{8DF3299D-EF78-4B14-82C4-0A3B7220DB05}"/>
               </a:ext>
             </a:extLst>
           </p:cNvPr>
@@ -6577,7 +6482,7 @@
                 <a:ea typeface="Aptos"/>
                 <a:cs typeface="Aptos"/>
               </a:rPr>
-              <a:t>A software-led launch makes the operating experience part of the system promise.</a:t>
+              <a:t>Inference: software-led nominal-mass offer; this does not verify broader HRMS depth.</a:t>
             </a:r>
           </a:p>
         </p:txBody>
@@ -6587,7 +6492,7 @@
           <p:cNvPr id="23" name="">
             <a:extLst xmlns:a="http://schemas.openxmlformats.org/drawingml/2006/main">
               <a:ext uri="{FF2B5EF4-FFF2-40B4-BE49-F238E27FC236}">
-                <a16:creationId xmlns:a16="http://schemas.microsoft.com/office/drawing/2014/main" id="{5BBA8244-8B8A-49B4-8AA3-BFA4209191F2}"/>
+                <a16:creationId xmlns:a16="http://schemas.microsoft.com/office/drawing/2014/main" id="{869679A6-7DED-4BB0-9121-BBFCE9837D07}"/>
               </a:ext>
             </a:extLst>
           </p:cNvPr>
@@ -6622,7 +6527,7 @@
           <p:cNvPr id="24" name="">
             <a:extLst xmlns:a="http://schemas.openxmlformats.org/drawingml/2006/main">
               <a:ext uri="{FF2B5EF4-FFF2-40B4-BE49-F238E27FC236}">
-                <a16:creationId xmlns:a16="http://schemas.microsoft.com/office/drawing/2014/main" id="{D6A9070B-42CD-44C9-A4FD-265C87E6FCE4}"/>
+                <a16:creationId xmlns:a16="http://schemas.microsoft.com/office/drawing/2014/main" id="{1AC9BFAC-645A-4E96-8C9F-9A6DD463D469}"/>
               </a:ext>
             </a:extLst>
           </p:cNvPr>
@@ -6655,7 +6560,7 @@
           <p:cNvPr id="25" name="">
             <a:extLst xmlns:a="http://schemas.openxmlformats.org/drawingml/2006/main">
               <a:ext uri="{FF2B5EF4-FFF2-40B4-BE49-F238E27FC236}">
-                <a16:creationId xmlns:a16="http://schemas.microsoft.com/office/drawing/2014/main" id="{1DC134DE-A4A2-4D14-A80E-F15BCBD926DA}"/>
+                <a16:creationId xmlns:a16="http://schemas.microsoft.com/office/drawing/2014/main" id="{059437F7-D898-4DE3-92D9-1D25A03D80E5}"/>
               </a:ext>
             </a:extLst>
           </p:cNvPr>
@@ -6713,7 +6618,7 @@
           <p:cNvPr id="26" name="">
             <a:extLst xmlns:a="http://schemas.openxmlformats.org/drawingml/2006/main">
               <a:ext uri="{FF2B5EF4-FFF2-40B4-BE49-F238E27FC236}">
-                <a16:creationId xmlns:a16="http://schemas.microsoft.com/office/drawing/2014/main" id="{EFD092DB-1E6A-4AB4-8869-9313905E0B53}"/>
+                <a16:creationId xmlns:a16="http://schemas.microsoft.com/office/drawing/2014/main" id="{B12E77BC-D252-42D5-95C1-FF51E29144CA}"/>
               </a:ext>
             </a:extLst>
           </p:cNvPr>
@@ -6771,7 +6676,7 @@
           <p:cNvPr id="27" name="">
             <a:extLst xmlns:a="http://schemas.openxmlformats.org/drawingml/2006/main">
               <a:ext uri="{FF2B5EF4-FFF2-40B4-BE49-F238E27FC236}">
-                <a16:creationId xmlns:a16="http://schemas.microsoft.com/office/drawing/2014/main" id="{100EAF43-30B1-4BA3-8481-CB69A668F3FC}"/>
+                <a16:creationId xmlns:a16="http://schemas.microsoft.com/office/drawing/2014/main" id="{9EF609E2-45A9-47DA-BFE8-C10103017F01}"/>
               </a:ext>
             </a:extLst>
           </p:cNvPr>
@@ -6819,7 +6724,7 @@
                 <a:ea typeface="Aptos"/>
                 <a:cs typeface="Aptos"/>
               </a:rPr>
-              <a:t>Vanquish Amplify</a:t>
+              <a:t>Observed: Vanquish Amplify</a:t>
             </a:r>
           </a:p>
         </p:txBody>
@@ -6829,7 +6734,7 @@
           <p:cNvPr id="28" name="">
             <a:extLst xmlns:a="http://schemas.openxmlformats.org/drawingml/2006/main">
               <a:ext uri="{FF2B5EF4-FFF2-40B4-BE49-F238E27FC236}">
-                <a16:creationId xmlns:a16="http://schemas.microsoft.com/office/drawing/2014/main" id="{3AA23D06-2613-4DEF-BBE7-5F49CBC8AAEE}"/>
+                <a16:creationId xmlns:a16="http://schemas.microsoft.com/office/drawing/2014/main" id="{BF2D7C6B-F247-411A-9D9A-15A3573F9E33}"/>
               </a:ext>
             </a:extLst>
           </p:cNvPr>
@@ -6877,7 +6782,7 @@
                 <a:ea typeface="Aptos"/>
                 <a:cs typeface="Aptos"/>
               </a:rPr>
-              <a:t>Keeps UHPLC differentiation tied to operator and workflow performance.</a:t>
+              <a:t>Inference: inert biopharma workflow packaging. Alternative: portfolio refresh.</a:t>
             </a:r>
           </a:p>
         </p:txBody>
@@ -6887,7 +6792,7 @@
           <p:cNvPr id="29" name="">
             <a:extLst xmlns:a="http://schemas.openxmlformats.org/drawingml/2006/main">
               <a:ext uri="{FF2B5EF4-FFF2-40B4-BE49-F238E27FC236}">
-                <a16:creationId xmlns:a16="http://schemas.microsoft.com/office/drawing/2014/main" id="{B3A52A72-CF98-462E-A6EC-0D297B73E4F0}"/>
+                <a16:creationId xmlns:a16="http://schemas.microsoft.com/office/drawing/2014/main" id="{3606B878-1D5D-4B1B-83A3-1A74675D4A39}"/>
               </a:ext>
             </a:extLst>
           </p:cNvPr>
@@ -6899,7 +6804,7 @@
         <p:spPr>
           <a:xfrm xmlns:a="http://schemas.openxmlformats.org/drawingml/2006/main">
             <a:off x="514350" y="6477000"/>
-            <a:ext cx="8191500" cy="190500"/>
+            <a:ext cx="9810750" cy="190500"/>
           </a:xfrm>
           <a:prstGeom xmlns:a="http://schemas.openxmlformats.org/drawingml/2006/main" prst="rect">
             <a:avLst/>
@@ -6935,7 +6840,7 @@
                 <a:ea typeface="Aptos"/>
                 <a:cs typeface="Aptos"/>
               </a:rPr>
-              <a:t>WATERS NEXT GEN COMPETITIVE INTELLIGENCE · 23 JUL 2026</a:t>
+              <a:t>WATERS NEXT GEN COMPETITIVE INTELLIGENCE · 28 JUL 2026 · waters-ci-20260728-202611</a:t>
             </a:r>
           </a:p>
         </p:txBody>
@@ -6945,7 +6850,7 @@
           <p:cNvPr id="30" name="">
             <a:extLst xmlns:a="http://schemas.openxmlformats.org/drawingml/2006/main">
               <a:ext uri="{FF2B5EF4-FFF2-40B4-BE49-F238E27FC236}">
-                <a16:creationId xmlns:a16="http://schemas.microsoft.com/office/drawing/2014/main" id="{69E9D340-7485-42BB-BC1F-A21F5423E993}"/>
+                <a16:creationId xmlns:a16="http://schemas.microsoft.com/office/drawing/2014/main" id="{9C83407B-12F0-4AC9-B896-E9F950BA9F31}"/>
               </a:ext>
             </a:extLst>
           </p:cNvPr>
@@ -7001,7 +6906,7 @@
     </p:spTree>
     <p:extLst>
       <p:ext uri="{BB962C8B-B14F-4D97-AF65-F5344CB8AC3E}">
-        <p14:creationId xmlns:p14="http://schemas.microsoft.com/office/powerpoint/2010/main" val="661652308"/>
+        <p14:creationId xmlns:p14="http://schemas.microsoft.com/office/powerpoint/2010/main" val="1128882818"/>
       </p:ext>
     </p:extLst>
   </p:cSld>
@@ -7032,7 +6937,7 @@
           <p:cNvPr id="18" name="">
             <a:extLst xmlns:a="http://schemas.openxmlformats.org/drawingml/2006/main">
               <a:ext uri="{FF2B5EF4-FFF2-40B4-BE49-F238E27FC236}">
-                <a16:creationId xmlns:a16="http://schemas.microsoft.com/office/drawing/2014/main" id="{0851466E-9C43-4CC7-ACDA-188DD8F6B7C9}"/>
+                <a16:creationId xmlns:a16="http://schemas.microsoft.com/office/drawing/2014/main" id="{7A71DAB4-C304-4DB6-A4A4-7D0DFA2BDD73}"/>
               </a:ext>
             </a:extLst>
           </p:cNvPr>
@@ -7090,7 +6995,7 @@
           <p:cNvPr id="2" name="">
             <a:extLst xmlns:a="http://schemas.openxmlformats.org/drawingml/2006/main">
               <a:ext uri="{FF2B5EF4-FFF2-40B4-BE49-F238E27FC236}">
-                <a16:creationId xmlns:a16="http://schemas.microsoft.com/office/drawing/2014/main" id="{2181F21C-D860-4062-97E2-C93BF35BDF8C}"/>
+                <a16:creationId xmlns:a16="http://schemas.microsoft.com/office/drawing/2014/main" id="{B649E7DF-DBD3-408F-BEC2-5D97F8E07025}"/>
               </a:ext>
             </a:extLst>
           </p:cNvPr>
@@ -7102,7 +7007,7 @@
         <p:spPr>
           <a:xfrm xmlns:a="http://schemas.openxmlformats.org/drawingml/2006/main">
             <a:off x="514350" y="647700"/>
-            <a:ext cx="11096625" cy="590550"/>
+            <a:ext cx="11096625" cy="685800"/>
           </a:xfrm>
           <a:prstGeom xmlns:a="http://schemas.openxmlformats.org/drawingml/2006/main" prst="rect">
             <a:avLst/>
@@ -7120,7 +7025,7 @@
           <a:lstStyle xmlns:a="http://schemas.openxmlformats.org/drawingml/2006/main"/>
           <a:p xmlns:a="http://schemas.openxmlformats.org/drawingml/2006/main">
             <a:pPr algn="l">
-              <a:defRPr sz="2850" b="1">
+              <a:defRPr sz="2550" b="1">
                 <a:solidFill>
                   <a:srgbClr val="153640"/>
                 </a:solidFill>
@@ -7130,7 +7035,7 @@
               </a:defRPr>
             </a:pPr>
             <a:r>
-              <a:rPr sz="2850" b="1">
+              <a:rPr sz="2550" b="1">
                 <a:solidFill>
                   <a:srgbClr val="153640"/>
                 </a:solidFill>
@@ -7138,7 +7043,7 @@
                 <a:ea typeface="Aptos"/>
                 <a:cs typeface="Aptos"/>
               </a:rPr>
-              <a:t>Guided diagnosis is a measurable product opportunity</a:t>
+              <a:t>Customer evidence is a validation input—not a prevalence estimate</a:t>
             </a:r>
           </a:p>
         </p:txBody>
@@ -7148,18 +7053,18 @@
           <p:cNvPr id="3" name="">
             <a:extLst xmlns:a="http://schemas.openxmlformats.org/drawingml/2006/main">
               <a:ext uri="{FF2B5EF4-FFF2-40B4-BE49-F238E27FC236}">
-                <a16:creationId xmlns:a16="http://schemas.microsoft.com/office/drawing/2014/main" id="{6CBFF25A-600B-43D4-B426-149BA7A26BFE}"/>
-              </a:ext>
-            </a:extLst>
-          </p:cNvPr>
-          <p:cNvSpPr>
-            <a:spLocks xmlns:a="http://schemas.openxmlformats.org/drawingml/2006/main" noGrp="1"/>
-          </p:cNvSpPr>
-          <p:nvPr/>
-        </p:nvSpPr>
-        <p:spPr>
-          <a:xfrm xmlns:a="http://schemas.openxmlformats.org/drawingml/2006/main">
-            <a:off x="514350" y="1276350"/>
+                <a16:creationId xmlns:a16="http://schemas.microsoft.com/office/drawing/2014/main" id="{EC55C51D-3DBF-4769-A993-B76797C8B576}"/>
+              </a:ext>
+            </a:extLst>
+          </p:cNvPr>
+          <p:cNvSpPr>
+            <a:spLocks xmlns:a="http://schemas.openxmlformats.org/drawingml/2006/main" noGrp="1"/>
+          </p:cNvSpPr>
+          <p:nvPr/>
+        </p:nvSpPr>
+        <p:spPr>
+          <a:xfrm xmlns:a="http://schemas.openxmlformats.org/drawingml/2006/main">
+            <a:off x="514350" y="1371600"/>
             <a:ext cx="10620375" cy="361950"/>
           </a:xfrm>
           <a:prstGeom xmlns:a="http://schemas.openxmlformats.org/drawingml/2006/main" prst="rect">
@@ -7196,7 +7101,7 @@
                 <a:ea typeface="Aptos"/>
                 <a:cs typeface="Aptos"/>
               </a:rPr>
-              <a:t>The source supports a troubleshooting pattern; it does not, by itself, prove a carryover or autosampler defect.</a:t>
+              <a:t>Forum evidence is promoted to leadership only when at least three independent sources support the same theme.</a:t>
             </a:r>
           </a:p>
         </p:txBody>
@@ -7206,7 +7111,7 @@
           <p:cNvPr id="4" name="">
             <a:extLst xmlns:a="http://schemas.openxmlformats.org/drawingml/2006/main">
               <a:ext uri="{FF2B5EF4-FFF2-40B4-BE49-F238E27FC236}">
-                <a16:creationId xmlns:a16="http://schemas.microsoft.com/office/drawing/2014/main" id="{13557FB9-F7DF-4C42-A60C-5EFEA81EB9BF}"/>
+                <a16:creationId xmlns:a16="http://schemas.microsoft.com/office/drawing/2014/main" id="{83F71415-A245-4289-A17E-462A49D1580C}"/>
               </a:ext>
             </a:extLst>
           </p:cNvPr>
@@ -7239,7 +7144,7 @@
           <p:cNvPr id="5" name="">
             <a:extLst xmlns:a="http://schemas.openxmlformats.org/drawingml/2006/main">
               <a:ext uri="{FF2B5EF4-FFF2-40B4-BE49-F238E27FC236}">
-                <a16:creationId xmlns:a16="http://schemas.microsoft.com/office/drawing/2014/main" id="{1F87B635-A36A-47D2-A993-42A3CB1DE1BF}"/>
+                <a16:creationId xmlns:a16="http://schemas.microsoft.com/office/drawing/2014/main" id="{E33AA78A-5076-47E2-8A34-29480E126CEC}"/>
               </a:ext>
             </a:extLst>
           </p:cNvPr>
@@ -7274,7 +7179,7 @@
           <p:cNvPr id="6" name="">
             <a:extLst xmlns:a="http://schemas.openxmlformats.org/drawingml/2006/main">
               <a:ext uri="{FF2B5EF4-FFF2-40B4-BE49-F238E27FC236}">
-                <a16:creationId xmlns:a16="http://schemas.microsoft.com/office/drawing/2014/main" id="{A8C52C8A-6699-42F6-B529-98512ABDF150}"/>
+                <a16:creationId xmlns:a16="http://schemas.microsoft.com/office/drawing/2014/main" id="{159A6A36-990B-43F8-8283-0409E6F925B1}"/>
               </a:ext>
             </a:extLst>
           </p:cNvPr>
@@ -7304,7 +7209,7 @@
           <a:lstStyle xmlns:a="http://schemas.openxmlformats.org/drawingml/2006/main"/>
           <a:p xmlns:a="http://schemas.openxmlformats.org/drawingml/2006/main">
             <a:pPr algn="l">
-              <a:defRPr sz="3750" b="1">
+              <a:defRPr sz="3150" b="1">
                 <a:solidFill>
                   <a:srgbClr val="45D5C6"/>
                 </a:solidFill>
@@ -7314,7 +7219,7 @@
               </a:defRPr>
             </a:pPr>
             <a:r>
-              <a:rPr sz="3750" b="1">
+              <a:rPr sz="3150" b="1">
                 <a:solidFill>
                   <a:srgbClr val="45D5C6"/>
                 </a:solidFill>
@@ -7322,7 +7227,7 @@
                 <a:ea typeface="Aptos"/>
                 <a:cs typeface="Aptos"/>
               </a:rPr>
-              <a:t>68/100</a:t>
+              <a:t>DIRECTIONAL</a:t>
             </a:r>
           </a:p>
         </p:txBody>
@@ -7332,7 +7237,7 @@
           <p:cNvPr id="7" name="">
             <a:extLst xmlns:a="http://schemas.openxmlformats.org/drawingml/2006/main">
               <a:ext uri="{FF2B5EF4-FFF2-40B4-BE49-F238E27FC236}">
-                <a16:creationId xmlns:a16="http://schemas.microsoft.com/office/drawing/2014/main" id="{F07F266D-443C-4ED4-9F30-98D33AA18BA0}"/>
+                <a16:creationId xmlns:a16="http://schemas.microsoft.com/office/drawing/2014/main" id="{710BEA9A-CF16-4B3B-9E12-75BA56585D01}"/>
               </a:ext>
             </a:extLst>
           </p:cNvPr>
@@ -7380,7 +7285,7 @@
                 <a:ea typeface="Aptos"/>
                 <a:cs typeface="Aptos"/>
               </a:rPr>
-              <a:t>EVIDENCE CONFIDENCE</a:t>
+              <a:t>PUBLIC CUSTOMER EVIDENCE</a:t>
             </a:r>
           </a:p>
         </p:txBody>
@@ -7390,7 +7295,7 @@
           <p:cNvPr id="8" name="">
             <a:extLst xmlns:a="http://schemas.openxmlformats.org/drawingml/2006/main">
               <a:ext uri="{FF2B5EF4-FFF2-40B4-BE49-F238E27FC236}">
-                <a16:creationId xmlns:a16="http://schemas.microsoft.com/office/drawing/2014/main" id="{57EEAC40-A605-4484-AD57-2BD23029DE22}"/>
+                <a16:creationId xmlns:a16="http://schemas.microsoft.com/office/drawing/2014/main" id="{D55DCBCF-44A8-4D61-8A13-31218DC2B3CA}"/>
               </a:ext>
             </a:extLst>
           </p:cNvPr>
@@ -7438,7 +7343,7 @@
                 <a:ea typeface="Aptos"/>
                 <a:cs typeface="Aptos"/>
               </a:rPr>
-              <a:t>What is directly supported</a:t>
+              <a:t>Leadership threshold</a:t>
             </a:r>
           </a:p>
         </p:txBody>
@@ -7448,7 +7353,7 @@
           <p:cNvPr id="9" name="">
             <a:extLst xmlns:a="http://schemas.openxmlformats.org/drawingml/2006/main">
               <a:ext uri="{FF2B5EF4-FFF2-40B4-BE49-F238E27FC236}">
-                <a16:creationId xmlns:a16="http://schemas.microsoft.com/office/drawing/2014/main" id="{A1EDD9BC-EE12-4595-9F76-0BD48F65435B}"/>
+                <a16:creationId xmlns:a16="http://schemas.microsoft.com/office/drawing/2014/main" id="{6C13A66A-B598-499B-82C4-8FBAD3817401}"/>
               </a:ext>
             </a:extLst>
           </p:cNvPr>
@@ -7496,7 +7401,7 @@
                 <a:ea typeface="Aptos"/>
                 <a:cs typeface="Aptos"/>
               </a:rPr>
-              <a:t>Waters UPLC</a:t>
+              <a:t>3+ independent sources</a:t>
             </a:r>
           </a:p>
           <a:p xmlns:a="http://schemas.openxmlformats.org/drawingml/2006/main">
@@ -7519,30 +7424,7 @@
                 <a:ea typeface="Aptos"/>
                 <a:cs typeface="Aptos"/>
               </a:rPr>
-              <a:t>high pressure</a:t>
-            </a:r>
-          </a:p>
-          <a:p xmlns:a="http://schemas.openxmlformats.org/drawingml/2006/main">
-            <a:pPr algn="l">
-              <a:defRPr sz="1650" b="1">
-                <a:solidFill>
-                  <a:srgbClr val="FFFFFF"/>
-                </a:solidFill>
-                <a:latin typeface="Aptos"/>
-                <a:ea typeface="Aptos"/>
-                <a:cs typeface="Aptos"/>
-              </a:defRPr>
-            </a:pPr>
-            <a:r>
-              <a:rPr sz="1650" b="1">
-                <a:solidFill>
-                  <a:srgbClr val="FFFFFF"/>
-                </a:solidFill>
-                <a:latin typeface="Aptos"/>
-                <a:ea typeface="Aptos"/>
-                <a:cs typeface="Aptos"/>
-              </a:rPr>
-              <a:t>troubleshooting</a:t>
+              <a:t>plus internal field validation</a:t>
             </a:r>
           </a:p>
         </p:txBody>
@@ -7552,7 +7434,7 @@
           <p:cNvPr id="10" name="">
             <a:extLst xmlns:a="http://schemas.openxmlformats.org/drawingml/2006/main">
               <a:ext uri="{FF2B5EF4-FFF2-40B4-BE49-F238E27FC236}">
-                <a16:creationId xmlns:a16="http://schemas.microsoft.com/office/drawing/2014/main" id="{6A9FFB15-0A7E-40EF-A125-FBF02CAA5BAF}"/>
+                <a16:creationId xmlns:a16="http://schemas.microsoft.com/office/drawing/2014/main" id="{F8DD032D-037A-4059-87E1-6EA107C0C07B}"/>
               </a:ext>
             </a:extLst>
           </p:cNvPr>
@@ -7587,7 +7469,7 @@
           <p:cNvPr id="11" name="">
             <a:extLst xmlns:a="http://schemas.openxmlformats.org/drawingml/2006/main">
               <a:ext uri="{FF2B5EF4-FFF2-40B4-BE49-F238E27FC236}">
-                <a16:creationId xmlns:a16="http://schemas.microsoft.com/office/drawing/2014/main" id="{1E7C9BE7-C87A-4384-B48C-C3F4FE83EF57}"/>
+                <a16:creationId xmlns:a16="http://schemas.microsoft.com/office/drawing/2014/main" id="{288552B4-4E34-4A79-A007-E1C0D9AB1397}"/>
               </a:ext>
             </a:extLst>
           </p:cNvPr>
@@ -7645,7 +7527,7 @@
           <p:cNvPr id="12" name="">
             <a:extLst xmlns:a="http://schemas.openxmlformats.org/drawingml/2006/main">
               <a:ext uri="{FF2B5EF4-FFF2-40B4-BE49-F238E27FC236}">
-                <a16:creationId xmlns:a16="http://schemas.microsoft.com/office/drawing/2014/main" id="{1884A3EE-2520-44D0-98E4-9DDE53461B51}"/>
+                <a16:creationId xmlns:a16="http://schemas.microsoft.com/office/drawing/2014/main" id="{0B029B90-091E-4761-8E8B-763CCF842764}"/>
               </a:ext>
             </a:extLst>
           </p:cNvPr>
@@ -7693,7 +7575,7 @@
                 <a:ea typeface="Aptos"/>
                 <a:cs typeface="Aptos"/>
               </a:rPr>
-              <a:t>Treat diagnosis time as a measurable workflow outcome.</a:t>
+              <a:t>Do not infer product weakness from one complaint.</a:t>
             </a:r>
           </a:p>
         </p:txBody>
@@ -7703,7 +7585,7 @@
           <p:cNvPr id="13" name="">
             <a:extLst xmlns:a="http://schemas.openxmlformats.org/drawingml/2006/main">
               <a:ext uri="{FF2B5EF4-FFF2-40B4-BE49-F238E27FC236}">
-                <a16:creationId xmlns:a16="http://schemas.microsoft.com/office/drawing/2014/main" id="{2AB4618F-0410-49C8-9300-C9339C7017E8}"/>
+                <a16:creationId xmlns:a16="http://schemas.microsoft.com/office/drawing/2014/main" id="{D9020683-4320-4432-BE7B-C1DAFC25B551}"/>
               </a:ext>
             </a:extLst>
           </p:cNvPr>
@@ -7751,7 +7633,7 @@
                 <a:ea typeface="Aptos"/>
                 <a:cs typeface="Aptos"/>
               </a:rPr>
-              <a:t>Validate three things before adding requirements:</a:t>
+              <a:t>Before adding requirements, validate:</a:t>
             </a:r>
           </a:p>
         </p:txBody>
@@ -7761,7 +7643,7 @@
           <p:cNvPr id="14" name="">
             <a:extLst xmlns:a="http://schemas.openxmlformats.org/drawingml/2006/main">
               <a:ext uri="{FF2B5EF4-FFF2-40B4-BE49-F238E27FC236}">
-                <a16:creationId xmlns:a16="http://schemas.microsoft.com/office/drawing/2014/main" id="{9FFF98CB-A250-40F1-A8C3-BF4D2B9FBEEA}"/>
+                <a16:creationId xmlns:a16="http://schemas.microsoft.com/office/drawing/2014/main" id="{5FB9DE7D-D0D9-4DA9-9C3E-CFEE175D7EF1}"/>
               </a:ext>
             </a:extLst>
           </p:cNvPr>
@@ -7865,19 +7747,19 @@
           <p:cNvPr id="15" name="">
             <a:extLst xmlns:a="http://schemas.openxmlformats.org/drawingml/2006/main">
               <a:ext uri="{FF2B5EF4-FFF2-40B4-BE49-F238E27FC236}">
-                <a16:creationId xmlns:a16="http://schemas.microsoft.com/office/drawing/2014/main" id="{A48CD99A-2E77-4A07-A8A3-B325F5A8A4F6}"/>
-              </a:ext>
-            </a:extLst>
-          </p:cNvPr>
-          <p:cNvSpPr>
-            <a:spLocks xmlns:a="http://schemas.openxmlformats.org/drawingml/2006/main" noGrp="1"/>
-          </p:cNvSpPr>
-          <p:nvPr/>
-        </p:nvSpPr>
-        <p:spPr>
-          <a:xfrm xmlns:a="http://schemas.openxmlformats.org/drawingml/2006/main">
-            <a:off x="5429250" y="5314950"/>
-            <a:ext cx="5619750" cy="266700"/>
+                <a16:creationId xmlns:a16="http://schemas.microsoft.com/office/drawing/2014/main" id="{D03695F9-879F-4A84-87DE-7FB8CE8620B4}"/>
+              </a:ext>
+            </a:extLst>
+          </p:cNvPr>
+          <p:cNvSpPr>
+            <a:spLocks xmlns:a="http://schemas.openxmlformats.org/drawingml/2006/main" noGrp="1"/>
+          </p:cNvSpPr>
+          <p:nvPr/>
+        </p:nvSpPr>
+        <p:spPr>
+          <a:xfrm xmlns:a="http://schemas.openxmlformats.org/drawingml/2006/main">
+            <a:off x="5429250" y="5257800"/>
+            <a:ext cx="5619750" cy="428625"/>
           </a:xfrm>
           <a:prstGeom xmlns:a="http://schemas.openxmlformats.org/drawingml/2006/main" prst="rect">
             <a:avLst/>
@@ -7895,25 +7777,25 @@
           <a:lstStyle xmlns:a="http://schemas.openxmlformats.org/drawingml/2006/main"/>
           <a:p xmlns:a="http://schemas.openxmlformats.org/drawingml/2006/main">
             <a:pPr algn="l">
-              <a:defRPr sz="1125" b="0">
-                <a:solidFill>
-                  <a:srgbClr val="60767D"/>
-                </a:solidFill>
-                <a:latin typeface="Aptos"/>
-                <a:ea typeface="Aptos"/>
-                <a:cs typeface="Aptos"/>
-              </a:defRPr>
-            </a:pPr>
-            <a:r>
-              <a:rPr sz="1125" b="0">
-                <a:solidFill>
-                  <a:srgbClr val="60767D"/>
-                </a:solidFill>
-                <a:latin typeface="Aptos"/>
-                <a:ea typeface="Aptos"/>
-                <a:cs typeface="Aptos"/>
-              </a:rPr>
-              <a:t>Current evidence is directional—not a prevalence estimate.</a:t>
+              <a:defRPr sz="1050" b="1">
+                <a:solidFill>
+                  <a:srgbClr val="BA3A42"/>
+                </a:solidFill>
+                <a:latin typeface="Aptos"/>
+                <a:ea typeface="Aptos"/>
+                <a:cs typeface="Aptos"/>
+              </a:defRPr>
+            </a:pPr>
+            <a:r>
+              <a:rPr sz="1050" b="1">
+                <a:solidFill>
+                  <a:srgbClr val="BA3A42"/>
+                </a:solidFill>
+                <a:latin typeface="Aptos"/>
+                <a:ea typeface="Aptos"/>
+                <a:cs typeface="Aptos"/>
+              </a:rPr>
+              <a:t>Business impact: UNQUANTIFIED — installed-base, pipeline, field recurrence and effort are required.</a:t>
             </a:r>
           </a:p>
         </p:txBody>
@@ -7923,7 +7805,7 @@
           <p:cNvPr id="16" name="">
             <a:extLst xmlns:a="http://schemas.openxmlformats.org/drawingml/2006/main">
               <a:ext uri="{FF2B5EF4-FFF2-40B4-BE49-F238E27FC236}">
-                <a16:creationId xmlns:a16="http://schemas.microsoft.com/office/drawing/2014/main" id="{DEC9DDA5-DC65-42F6-B140-1F24DAD0E401}"/>
+                <a16:creationId xmlns:a16="http://schemas.microsoft.com/office/drawing/2014/main" id="{F4C1BCF4-FABE-4A1A-85C0-50118DB1BE78}"/>
               </a:ext>
             </a:extLst>
           </p:cNvPr>
@@ -7935,7 +7817,7 @@
         <p:spPr>
           <a:xfrm xmlns:a="http://schemas.openxmlformats.org/drawingml/2006/main">
             <a:off x="514350" y="6477000"/>
-            <a:ext cx="8191500" cy="190500"/>
+            <a:ext cx="9810750" cy="190500"/>
           </a:xfrm>
           <a:prstGeom xmlns:a="http://schemas.openxmlformats.org/drawingml/2006/main" prst="rect">
             <a:avLst/>
@@ -7971,7 +7853,7 @@
                 <a:ea typeface="Aptos"/>
                 <a:cs typeface="Aptos"/>
               </a:rPr>
-              <a:t>WATERS NEXT GEN COMPETITIVE INTELLIGENCE · 23 JUL 2026</a:t>
+              <a:t>WATERS NEXT GEN COMPETITIVE INTELLIGENCE · 28 JUL 2026 · waters-ci-20260728-202611</a:t>
             </a:r>
           </a:p>
         </p:txBody>
@@ -7981,7 +7863,7 @@
           <p:cNvPr id="17" name="">
             <a:extLst xmlns:a="http://schemas.openxmlformats.org/drawingml/2006/main">
               <a:ext uri="{FF2B5EF4-FFF2-40B4-BE49-F238E27FC236}">
-                <a16:creationId xmlns:a16="http://schemas.microsoft.com/office/drawing/2014/main" id="{D44DA705-2F91-4497-89AF-785D635C92FE}"/>
+                <a16:creationId xmlns:a16="http://schemas.microsoft.com/office/drawing/2014/main" id="{FE4DD0B3-861D-4F3A-A153-9B5235B89FD8}"/>
               </a:ext>
             </a:extLst>
           </p:cNvPr>
@@ -8037,7 +7919,7 @@
     </p:spTree>
     <p:extLst>
       <p:ext uri="{BB962C8B-B14F-4D97-AF65-F5344CB8AC3E}">
-        <p14:creationId xmlns:p14="http://schemas.microsoft.com/office/powerpoint/2010/main" val="2144623563"/>
+        <p14:creationId xmlns:p14="http://schemas.microsoft.com/office/powerpoint/2010/main" val="1492595347"/>
       </p:ext>
     </p:extLst>
   </p:cSld>
@@ -8065,10 +7947,10 @@
       </p:grpSpPr>
       <p:sp>
         <p:nvSpPr>
-          <p:cNvPr id="34" name="">
-            <a:extLst xmlns:a="http://schemas.openxmlformats.org/drawingml/2006/main">
-              <a:ext uri="{FF2B5EF4-FFF2-40B4-BE49-F238E27FC236}">
-                <a16:creationId xmlns:a16="http://schemas.microsoft.com/office/drawing/2014/main" id="{E1A9DAB3-BB91-4287-916A-12BC13A29630}"/>
+          <p:cNvPr id="40" name="">
+            <a:extLst xmlns:a="http://schemas.openxmlformats.org/drawingml/2006/main">
+              <a:ext uri="{FF2B5EF4-FFF2-40B4-BE49-F238E27FC236}">
+                <a16:creationId xmlns:a16="http://schemas.microsoft.com/office/drawing/2014/main" id="{528523A6-3F76-49AC-84D9-70D47CA941EE}"/>
               </a:ext>
             </a:extLst>
           </p:cNvPr>
@@ -8126,7 +8008,7 @@
           <p:cNvPr id="2" name="">
             <a:extLst xmlns:a="http://schemas.openxmlformats.org/drawingml/2006/main">
               <a:ext uri="{FF2B5EF4-FFF2-40B4-BE49-F238E27FC236}">
-                <a16:creationId xmlns:a16="http://schemas.microsoft.com/office/drawing/2014/main" id="{7089B9BD-4100-4C6B-95F1-86EE2F372D83}"/>
+                <a16:creationId xmlns:a16="http://schemas.microsoft.com/office/drawing/2014/main" id="{C21CAC34-C249-4C1F-8650-5F1387A5D225}"/>
               </a:ext>
             </a:extLst>
           </p:cNvPr>
@@ -8138,25 +8020,25 @@
         <p:spPr>
           <a:xfrm xmlns:a="http://schemas.openxmlformats.org/drawingml/2006/main">
             <a:off x="514350" y="647700"/>
-            <a:ext cx="11096625" cy="590550"/>
-          </a:xfrm>
-          <a:prstGeom xmlns:a="http://schemas.openxmlformats.org/drawingml/2006/main" prst="rect">
-            <a:avLst/>
-          </a:prstGeom>
-          <a:noFill xmlns:a="http://schemas.openxmlformats.org/drawingml/2006/main"/>
-          <a:ln xmlns:a="http://schemas.openxmlformats.org/drawingml/2006/main" w="0">
-            <a:noFill/>
-            <a:prstDash val="solid"/>
-          </a:ln>
-        </p:spPr>
-        <p:txBody>
-          <a:bodyPr xmlns:a="http://schemas.openxmlformats.org/drawingml/2006/main" wrap="square" lIns="0" tIns="0" rIns="0" bIns="0" anchor="t">
-            <a:normAutofit fontScale="100000"/>
+            <a:ext cx="11096625" cy="685800"/>
+          </a:xfrm>
+          <a:prstGeom xmlns:a="http://schemas.openxmlformats.org/drawingml/2006/main" prst="rect">
+            <a:avLst/>
+          </a:prstGeom>
+          <a:noFill xmlns:a="http://schemas.openxmlformats.org/drawingml/2006/main"/>
+          <a:ln xmlns:a="http://schemas.openxmlformats.org/drawingml/2006/main" w="0">
+            <a:noFill/>
+            <a:prstDash val="solid"/>
+          </a:ln>
+        </p:spPr>
+        <p:txBody>
+          <a:bodyPr xmlns:a="http://schemas.openxmlformats.org/drawingml/2006/main" wrap="square" lIns="0" tIns="0" rIns="0" bIns="0" anchor="t">
+            <a:normAutofit fontScale="98287"/>
           </a:bodyPr>
           <a:lstStyle xmlns:a="http://schemas.openxmlformats.org/drawingml/2006/main"/>
           <a:p xmlns:a="http://schemas.openxmlformats.org/drawingml/2006/main">
             <a:pPr algn="l">
-              <a:defRPr sz="2850" b="1">
+              <a:defRPr sz="2550" b="1">
                 <a:solidFill>
                   <a:srgbClr val="153640"/>
                 </a:solidFill>
@@ -8166,7 +8048,7 @@
               </a:defRPr>
             </a:pPr>
             <a:r>
-              <a:rPr sz="2850" b="1">
+              <a:rPr sz="2550" b="1">
                 <a:solidFill>
                   <a:srgbClr val="153640"/>
                 </a:solidFill>
@@ -8174,7 +8056,7 @@
                 <a:ea typeface="Aptos"/>
                 <a:cs typeface="Aptos"/>
               </a:rPr>
-              <a:t>Three decisions have different urgency and evidence profiles</a:t>
+              <a:t>Three decisions are evidence-prioritized; business impact is unquantified</a:t>
             </a:r>
           </a:p>
         </p:txBody>
@@ -8184,18 +8066,18 @@
           <p:cNvPr id="3" name="">
             <a:extLst xmlns:a="http://schemas.openxmlformats.org/drawingml/2006/main">
               <a:ext uri="{FF2B5EF4-FFF2-40B4-BE49-F238E27FC236}">
-                <a16:creationId xmlns:a16="http://schemas.microsoft.com/office/drawing/2014/main" id="{CA82A61C-1E28-4F2A-8FD7-869A60BB7F8C}"/>
-              </a:ext>
-            </a:extLst>
-          </p:cNvPr>
-          <p:cNvSpPr>
-            <a:spLocks xmlns:a="http://schemas.openxmlformats.org/drawingml/2006/main" noGrp="1"/>
-          </p:cNvSpPr>
-          <p:nvPr/>
-        </p:nvSpPr>
-        <p:spPr>
-          <a:xfrm xmlns:a="http://schemas.openxmlformats.org/drawingml/2006/main">
-            <a:off x="514350" y="1276350"/>
+                <a16:creationId xmlns:a16="http://schemas.microsoft.com/office/drawing/2014/main" id="{B20F0922-9E9F-470A-B9BC-ADED3B472197}"/>
+              </a:ext>
+            </a:extLst>
+          </p:cNvPr>
+          <p:cNvSpPr>
+            <a:spLocks xmlns:a="http://schemas.openxmlformats.org/drawingml/2006/main" noGrp="1"/>
+          </p:cNvSpPr>
+          <p:nvPr/>
+        </p:nvSpPr>
+        <p:spPr>
+          <a:xfrm xmlns:a="http://schemas.openxmlformats.org/drawingml/2006/main">
+            <a:off x="514350" y="1371600"/>
             <a:ext cx="10620375" cy="361950"/>
           </a:xfrm>
           <a:prstGeom xmlns:a="http://schemas.openxmlformats.org/drawingml/2006/main" prst="rect">
@@ -8232,7 +8114,7 @@
                 <a:ea typeface="Aptos"/>
                 <a:cs typeface="Aptos"/>
               </a:rPr>
-              <a:t>Priority scores rank roadmap attention. They are not confidence scores and do not replace customer validation.</a:t>
+              <a:t>No precise 0–100 score is shown while Waters exposure, customer value, or engineering effort is missing.</a:t>
             </a:r>
           </a:p>
         </p:txBody>
@@ -8242,7 +8124,7 @@
           <p:cNvPr id="4" name="">
             <a:extLst xmlns:a="http://schemas.openxmlformats.org/drawingml/2006/main">
               <a:ext uri="{FF2B5EF4-FFF2-40B4-BE49-F238E27FC236}">
-                <a16:creationId xmlns:a16="http://schemas.microsoft.com/office/drawing/2014/main" id="{BDB2BA6E-FDFF-4159-8B44-5A0BC29FBA55}"/>
+                <a16:creationId xmlns:a16="http://schemas.microsoft.com/office/drawing/2014/main" id="{43016B12-3083-4C38-9B14-FB11FA872B8D}"/>
               </a:ext>
             </a:extLst>
           </p:cNvPr>
@@ -8275,7 +8157,7 @@
           <p:cNvPr id="5" name="">
             <a:extLst xmlns:a="http://schemas.openxmlformats.org/drawingml/2006/main">
               <a:ext uri="{FF2B5EF4-FFF2-40B4-BE49-F238E27FC236}">
-                <a16:creationId xmlns:a16="http://schemas.microsoft.com/office/drawing/2014/main" id="{64A269B3-1C32-42B1-9592-5E11F2E4C9E0}"/>
+                <a16:creationId xmlns:a16="http://schemas.microsoft.com/office/drawing/2014/main" id="{43EBB8C1-CB2E-40DC-9849-3A8A869C2DDA}"/>
               </a:ext>
             </a:extLst>
           </p:cNvPr>
@@ -8310,7 +8192,7 @@
           <p:cNvPr id="6" name="">
             <a:extLst xmlns:a="http://schemas.openxmlformats.org/drawingml/2006/main">
               <a:ext uri="{FF2B5EF4-FFF2-40B4-BE49-F238E27FC236}">
-                <a16:creationId xmlns:a16="http://schemas.microsoft.com/office/drawing/2014/main" id="{0C0771CE-0AF0-4FE9-902D-03429CACCC15}"/>
+                <a16:creationId xmlns:a16="http://schemas.microsoft.com/office/drawing/2014/main" id="{8A9DA48E-53B3-4FF1-B895-1A5320186D99}"/>
               </a:ext>
             </a:extLst>
           </p:cNvPr>
@@ -8343,135 +8225,19 @@
           <p:cNvPr id="7" name="">
             <a:extLst xmlns:a="http://schemas.openxmlformats.org/drawingml/2006/main">
               <a:ext uri="{FF2B5EF4-FFF2-40B4-BE49-F238E27FC236}">
-                <a16:creationId xmlns:a16="http://schemas.microsoft.com/office/drawing/2014/main" id="{56BE2CA4-BECD-410B-9C09-EED7BA10DB4C}"/>
-              </a:ext>
-            </a:extLst>
-          </p:cNvPr>
-          <p:cNvSpPr>
-            <a:spLocks xmlns:a="http://schemas.openxmlformats.org/drawingml/2006/main" noGrp="1"/>
-          </p:cNvSpPr>
-          <p:nvPr/>
-        </p:nvSpPr>
-        <p:spPr>
-          <a:xfrm xmlns:a="http://schemas.openxmlformats.org/drawingml/2006/main">
-            <a:off x="723900" y="2400300"/>
+                <a16:creationId xmlns:a16="http://schemas.microsoft.com/office/drawing/2014/main" id="{4B1EE75B-684F-481E-9B13-EC3BB718ACDB}"/>
+              </a:ext>
+            </a:extLst>
+          </p:cNvPr>
+          <p:cNvSpPr>
+            <a:spLocks xmlns:a="http://schemas.openxmlformats.org/drawingml/2006/main" noGrp="1"/>
+          </p:cNvSpPr>
+          <p:nvPr/>
+        </p:nvSpPr>
+        <p:spPr>
+          <a:xfrm xmlns:a="http://schemas.openxmlformats.org/drawingml/2006/main">
+            <a:off x="723900" y="2381250"/>
             <a:ext cx="2990850" cy="228600"/>
-          </a:xfrm>
-          <a:prstGeom xmlns:a="http://schemas.openxmlformats.org/drawingml/2006/main" prst="rect">
-            <a:avLst/>
-          </a:prstGeom>
-          <a:noFill xmlns:a="http://schemas.openxmlformats.org/drawingml/2006/main"/>
-          <a:ln xmlns:a="http://schemas.openxmlformats.org/drawingml/2006/main" w="0">
-            <a:noFill/>
-            <a:prstDash val="solid"/>
-          </a:ln>
-        </p:spPr>
-        <p:txBody>
-          <a:bodyPr xmlns:a="http://schemas.openxmlformats.org/drawingml/2006/main" wrap="square" lIns="0" tIns="0" rIns="0" bIns="0" anchor="t">
-            <a:normAutofit fontScale="100000"/>
-          </a:bodyPr>
-          <a:lstStyle xmlns:a="http://schemas.openxmlformats.org/drawingml/2006/main"/>
-          <a:p xmlns:a="http://schemas.openxmlformats.org/drawingml/2006/main">
-            <a:pPr algn="l">
-              <a:defRPr sz="975" b="1">
-                <a:solidFill>
-                  <a:srgbClr val="D58C00"/>
-                </a:solidFill>
-                <a:latin typeface="Aptos"/>
-                <a:ea typeface="Aptos"/>
-                <a:cs typeface="Aptos"/>
-              </a:defRPr>
-            </a:pPr>
-            <a:r>
-              <a:rPr sz="975" b="1">
-                <a:solidFill>
-                  <a:srgbClr val="D58C00"/>
-                </a:solidFill>
-                <a:latin typeface="Aptos"/>
-                <a:ea typeface="Aptos"/>
-                <a:cs typeface="Aptos"/>
-              </a:rPr>
-              <a:t>DUE 07 AUG</a:t>
-            </a:r>
-          </a:p>
-        </p:txBody>
-      </p:sp>
-      <p:sp>
-        <p:nvSpPr>
-          <p:cNvPr id="8" name="">
-            <a:extLst xmlns:a="http://schemas.openxmlformats.org/drawingml/2006/main">
-              <a:ext uri="{FF2B5EF4-FFF2-40B4-BE49-F238E27FC236}">
-                <a16:creationId xmlns:a16="http://schemas.microsoft.com/office/drawing/2014/main" id="{7E3CC29A-3953-4C19-959E-42EC4852157E}"/>
-              </a:ext>
-            </a:extLst>
-          </p:cNvPr>
-          <p:cNvSpPr>
-            <a:spLocks xmlns:a="http://schemas.openxmlformats.org/drawingml/2006/main" noGrp="1"/>
-          </p:cNvSpPr>
-          <p:nvPr/>
-        </p:nvSpPr>
-        <p:spPr>
-          <a:xfrm xmlns:a="http://schemas.openxmlformats.org/drawingml/2006/main">
-            <a:off x="723900" y="2724150"/>
-            <a:ext cx="2990850" cy="476250"/>
-          </a:xfrm>
-          <a:prstGeom xmlns:a="http://schemas.openxmlformats.org/drawingml/2006/main" prst="rect">
-            <a:avLst/>
-          </a:prstGeom>
-          <a:noFill xmlns:a="http://schemas.openxmlformats.org/drawingml/2006/main"/>
-          <a:ln xmlns:a="http://schemas.openxmlformats.org/drawingml/2006/main" w="0">
-            <a:noFill/>
-            <a:prstDash val="solid"/>
-          </a:ln>
-        </p:spPr>
-        <p:txBody>
-          <a:bodyPr xmlns:a="http://schemas.openxmlformats.org/drawingml/2006/main" wrap="square" lIns="0" tIns="0" rIns="0" bIns="0" anchor="t">
-            <a:normAutofit fontScale="100000"/>
-          </a:bodyPr>
-          <a:lstStyle xmlns:a="http://schemas.openxmlformats.org/drawingml/2006/main"/>
-          <a:p xmlns:a="http://schemas.openxmlformats.org/drawingml/2006/main">
-            <a:pPr algn="l">
-              <a:defRPr sz="2550" b="1">
-                <a:solidFill>
-                  <a:srgbClr val="153640"/>
-                </a:solidFill>
-                <a:latin typeface="Aptos"/>
-                <a:ea typeface="Aptos"/>
-                <a:cs typeface="Aptos"/>
-              </a:defRPr>
-            </a:pPr>
-            <a:r>
-              <a:rPr sz="2550" b="1">
-                <a:solidFill>
-                  <a:srgbClr val="153640"/>
-                </a:solidFill>
-                <a:latin typeface="Aptos"/>
-                <a:ea typeface="Aptos"/>
-                <a:cs typeface="Aptos"/>
-              </a:rPr>
-              <a:t>55/100</a:t>
-            </a:r>
-          </a:p>
-        </p:txBody>
-      </p:sp>
-      <p:sp>
-        <p:nvSpPr>
-          <p:cNvPr id="9" name="">
-            <a:extLst xmlns:a="http://schemas.openxmlformats.org/drawingml/2006/main">
-              <a:ext uri="{FF2B5EF4-FFF2-40B4-BE49-F238E27FC236}">
-                <a16:creationId xmlns:a16="http://schemas.microsoft.com/office/drawing/2014/main" id="{E309E265-08CE-4459-9AA2-1946BB522BB6}"/>
-              </a:ext>
-            </a:extLst>
-          </p:cNvPr>
-          <p:cNvSpPr>
-            <a:spLocks xmlns:a="http://schemas.openxmlformats.org/drawingml/2006/main" noGrp="1"/>
-          </p:cNvSpPr>
-          <p:nvPr/>
-        </p:nvSpPr>
-        <p:spPr>
-          <a:xfrm xmlns:a="http://schemas.openxmlformats.org/drawingml/2006/main">
-            <a:off x="723900" y="3143250"/>
-            <a:ext cx="2990850" cy="209550"/>
           </a:xfrm>
           <a:prstGeom xmlns:a="http://schemas.openxmlformats.org/drawingml/2006/main" prst="rect">
             <a:avLst/>
@@ -8491,6 +8257,64 @@
             <a:pPr algn="l">
               <a:defRPr sz="900" b="1">
                 <a:solidFill>
+                  <a:srgbClr val="D58C00"/>
+                </a:solidFill>
+                <a:latin typeface="Aptos"/>
+                <a:ea typeface="Aptos"/>
+                <a:cs typeface="Aptos"/>
+              </a:defRPr>
+            </a:pPr>
+            <a:r>
+              <a:rPr sz="900" b="1">
+                <a:solidFill>
+                  <a:srgbClr val="D58C00"/>
+                </a:solidFill>
+                <a:latin typeface="Aptos"/>
+                <a:ea typeface="Aptos"/>
+                <a:cs typeface="Aptos"/>
+              </a:rPr>
+              <a:t>DUE AUGUST 7, 2026</a:t>
+            </a:r>
+          </a:p>
+        </p:txBody>
+      </p:sp>
+      <p:sp>
+        <p:nvSpPr>
+          <p:cNvPr id="8" name="">
+            <a:extLst xmlns:a="http://schemas.openxmlformats.org/drawingml/2006/main">
+              <a:ext uri="{FF2B5EF4-FFF2-40B4-BE49-F238E27FC236}">
+                <a16:creationId xmlns:a16="http://schemas.microsoft.com/office/drawing/2014/main" id="{93ACBB63-69BF-4247-97AD-AEC897AFD5D6}"/>
+              </a:ext>
+            </a:extLst>
+          </p:cNvPr>
+          <p:cNvSpPr>
+            <a:spLocks xmlns:a="http://schemas.openxmlformats.org/drawingml/2006/main" noGrp="1"/>
+          </p:cNvSpPr>
+          <p:nvPr/>
+        </p:nvSpPr>
+        <p:spPr>
+          <a:xfrm xmlns:a="http://schemas.openxmlformats.org/drawingml/2006/main">
+            <a:off x="723900" y="2695575"/>
+            <a:ext cx="2990850" cy="171450"/>
+          </a:xfrm>
+          <a:prstGeom xmlns:a="http://schemas.openxmlformats.org/drawingml/2006/main" prst="rect">
+            <a:avLst/>
+          </a:prstGeom>
+          <a:noFill xmlns:a="http://schemas.openxmlformats.org/drawingml/2006/main"/>
+          <a:ln xmlns:a="http://schemas.openxmlformats.org/drawingml/2006/main" w="0">
+            <a:noFill/>
+            <a:prstDash val="solid"/>
+          </a:ln>
+        </p:spPr>
+        <p:txBody>
+          <a:bodyPr xmlns:a="http://schemas.openxmlformats.org/drawingml/2006/main" wrap="square" lIns="0" tIns="0" rIns="0" bIns="0" anchor="t">
+            <a:normAutofit fontScale="100000"/>
+          </a:bodyPr>
+          <a:lstStyle xmlns:a="http://schemas.openxmlformats.org/drawingml/2006/main"/>
+          <a:p xmlns:a="http://schemas.openxmlformats.org/drawingml/2006/main">
+            <a:pPr algn="l">
+              <a:defRPr sz="825" b="1">
+                <a:solidFill>
                   <a:srgbClr val="60767D"/>
                 </a:solidFill>
                 <a:latin typeface="Aptos"/>
@@ -8499,7 +8323,7 @@
               </a:defRPr>
             </a:pPr>
             <a:r>
-              <a:rPr sz="900" b="1">
+              <a:rPr sz="825" b="1">
                 <a:solidFill>
                   <a:srgbClr val="60767D"/>
                 </a:solidFill>
@@ -8507,7 +8331,65 @@
                 <a:ea typeface="Aptos"/>
                 <a:cs typeface="Aptos"/>
               </a:rPr>
-              <a:t>PRIORITY SCORE</a:t>
+              <a:t>EVIDENCE PRIORITY</a:t>
+            </a:r>
+          </a:p>
+        </p:txBody>
+      </p:sp>
+      <p:sp>
+        <p:nvSpPr>
+          <p:cNvPr id="9" name="">
+            <a:extLst xmlns:a="http://schemas.openxmlformats.org/drawingml/2006/main">
+              <a:ext uri="{FF2B5EF4-FFF2-40B4-BE49-F238E27FC236}">
+                <a16:creationId xmlns:a16="http://schemas.microsoft.com/office/drawing/2014/main" id="{9485DEF7-D156-45F4-B007-E48381EE0F0A}"/>
+              </a:ext>
+            </a:extLst>
+          </p:cNvPr>
+          <p:cNvSpPr>
+            <a:spLocks xmlns:a="http://schemas.openxmlformats.org/drawingml/2006/main" noGrp="1"/>
+          </p:cNvSpPr>
+          <p:nvPr/>
+        </p:nvSpPr>
+        <p:spPr>
+          <a:xfrm xmlns:a="http://schemas.openxmlformats.org/drawingml/2006/main">
+            <a:off x="723900" y="2895600"/>
+            <a:ext cx="2990850" cy="342900"/>
+          </a:xfrm>
+          <a:prstGeom xmlns:a="http://schemas.openxmlformats.org/drawingml/2006/main" prst="rect">
+            <a:avLst/>
+          </a:prstGeom>
+          <a:noFill xmlns:a="http://schemas.openxmlformats.org/drawingml/2006/main"/>
+          <a:ln xmlns:a="http://schemas.openxmlformats.org/drawingml/2006/main" w="0">
+            <a:noFill/>
+            <a:prstDash val="solid"/>
+          </a:ln>
+        </p:spPr>
+        <p:txBody>
+          <a:bodyPr xmlns:a="http://schemas.openxmlformats.org/drawingml/2006/main" wrap="square" lIns="0" tIns="0" rIns="0" bIns="0" anchor="t">
+            <a:normAutofit fontScale="100000"/>
+          </a:bodyPr>
+          <a:lstStyle xmlns:a="http://schemas.openxmlformats.org/drawingml/2006/main"/>
+          <a:p xmlns:a="http://schemas.openxmlformats.org/drawingml/2006/main">
+            <a:pPr algn="l">
+              <a:defRPr sz="2025" b="1">
+                <a:solidFill>
+                  <a:srgbClr val="153640"/>
+                </a:solidFill>
+                <a:latin typeface="Aptos"/>
+                <a:ea typeface="Aptos"/>
+                <a:cs typeface="Aptos"/>
+              </a:defRPr>
+            </a:pPr>
+            <a:r>
+              <a:rPr sz="2025" b="1">
+                <a:solidFill>
+                  <a:srgbClr val="153640"/>
+                </a:solidFill>
+                <a:latin typeface="Aptos"/>
+                <a:ea typeface="Aptos"/>
+                <a:cs typeface="Aptos"/>
+              </a:rPr>
+              <a:t>Medium</a:t>
             </a:r>
           </a:p>
         </p:txBody>
@@ -8517,19 +8399,19 @@
           <p:cNvPr id="10" name="">
             <a:extLst xmlns:a="http://schemas.openxmlformats.org/drawingml/2006/main">
               <a:ext uri="{FF2B5EF4-FFF2-40B4-BE49-F238E27FC236}">
-                <a16:creationId xmlns:a16="http://schemas.microsoft.com/office/drawing/2014/main" id="{F682EAFD-8AA6-4C19-ADB2-032D6FFD1277}"/>
-              </a:ext>
-            </a:extLst>
-          </p:cNvPr>
-          <p:cNvSpPr>
-            <a:spLocks xmlns:a="http://schemas.openxmlformats.org/drawingml/2006/main" noGrp="1"/>
-          </p:cNvSpPr>
-          <p:nvPr/>
-        </p:nvSpPr>
-        <p:spPr>
-          <a:xfrm xmlns:a="http://schemas.openxmlformats.org/drawingml/2006/main">
-            <a:off x="723900" y="3524250"/>
-            <a:ext cx="2990850" cy="742950"/>
+                <a16:creationId xmlns:a16="http://schemas.microsoft.com/office/drawing/2014/main" id="{0E902AB9-0DED-4BA2-9B9D-031E4F52EB15}"/>
+              </a:ext>
+            </a:extLst>
+          </p:cNvPr>
+          <p:cNvSpPr>
+            <a:spLocks xmlns:a="http://schemas.openxmlformats.org/drawingml/2006/main" noGrp="1"/>
+          </p:cNvSpPr>
+          <p:nvPr/>
+        </p:nvSpPr>
+        <p:spPr>
+          <a:xfrm xmlns:a="http://schemas.openxmlformats.org/drawingml/2006/main">
+            <a:off x="723900" y="3276600"/>
+            <a:ext cx="2990850" cy="190500"/>
           </a:xfrm>
           <a:prstGeom xmlns:a="http://schemas.openxmlformats.org/drawingml/2006/main" prst="rect">
             <a:avLst/>
@@ -8547,7 +8429,65 @@
           <a:lstStyle xmlns:a="http://schemas.openxmlformats.org/drawingml/2006/main"/>
           <a:p xmlns:a="http://schemas.openxmlformats.org/drawingml/2006/main">
             <a:pPr algn="l">
-              <a:defRPr sz="1575" b="1">
+              <a:defRPr sz="825" b="1">
+                <a:solidFill>
+                  <a:srgbClr val="BA3A42"/>
+                </a:solidFill>
+                <a:latin typeface="Aptos"/>
+                <a:ea typeface="Aptos"/>
+                <a:cs typeface="Aptos"/>
+              </a:defRPr>
+            </a:pPr>
+            <a:r>
+              <a:rPr sz="825" b="1">
+                <a:solidFill>
+                  <a:srgbClr val="BA3A42"/>
+                </a:solidFill>
+                <a:latin typeface="Aptos"/>
+                <a:ea typeface="Aptos"/>
+                <a:cs typeface="Aptos"/>
+              </a:rPr>
+              <a:t>BUSINESS IMPACT · UNQUANTIFIED</a:t>
+            </a:r>
+          </a:p>
+        </p:txBody>
+      </p:sp>
+      <p:sp>
+        <p:nvSpPr>
+          <p:cNvPr id="11" name="">
+            <a:extLst xmlns:a="http://schemas.openxmlformats.org/drawingml/2006/main">
+              <a:ext uri="{FF2B5EF4-FFF2-40B4-BE49-F238E27FC236}">
+                <a16:creationId xmlns:a16="http://schemas.microsoft.com/office/drawing/2014/main" id="{CD6A3B50-E4B9-4E21-B7DE-A2725DBA4DF8}"/>
+              </a:ext>
+            </a:extLst>
+          </p:cNvPr>
+          <p:cNvSpPr>
+            <a:spLocks xmlns:a="http://schemas.openxmlformats.org/drawingml/2006/main" noGrp="1"/>
+          </p:cNvSpPr>
+          <p:nvPr/>
+        </p:nvSpPr>
+        <p:spPr>
+          <a:xfrm xmlns:a="http://schemas.openxmlformats.org/drawingml/2006/main">
+            <a:off x="723900" y="3571875"/>
+            <a:ext cx="2990850" cy="590550"/>
+          </a:xfrm>
+          <a:prstGeom xmlns:a="http://schemas.openxmlformats.org/drawingml/2006/main" prst="rect">
+            <a:avLst/>
+          </a:prstGeom>
+          <a:noFill xmlns:a="http://schemas.openxmlformats.org/drawingml/2006/main"/>
+          <a:ln xmlns:a="http://schemas.openxmlformats.org/drawingml/2006/main" w="0">
+            <a:noFill/>
+            <a:prstDash val="solid"/>
+          </a:ln>
+        </p:spPr>
+        <p:txBody>
+          <a:bodyPr xmlns:a="http://schemas.openxmlformats.org/drawingml/2006/main" wrap="square" lIns="0" tIns="0" rIns="0" bIns="0" anchor="t">
+            <a:normAutofit fontScale="90643"/>
+          </a:bodyPr>
+          <a:lstStyle xmlns:a="http://schemas.openxmlformats.org/drawingml/2006/main"/>
+          <a:p xmlns:a="http://schemas.openxmlformats.org/drawingml/2006/main">
+            <a:pPr algn="l">
+              <a:defRPr sz="1425" b="1">
                 <a:solidFill>
                   <a:srgbClr val="153640"/>
                 </a:solidFill>
@@ -8557,7 +8497,7 @@
               </a:defRPr>
             </a:pPr>
             <a:r>
-              <a:rPr sz="1575" b="1">
+              <a:rPr sz="1425" b="1">
                 <a:solidFill>
                   <a:srgbClr val="153640"/>
                 </a:solidFill>
@@ -8565,28 +8505,28 @@
                 <a:ea typeface="Aptos"/>
                 <a:cs typeface="Aptos"/>
               </a:rPr>
-              <a:t>Package a PFAS-ready regulated quantitation workflow?</a:t>
-            </a:r>
-          </a:p>
-        </p:txBody>
-      </p:sp>
-      <p:sp>
-        <p:nvSpPr>
-          <p:cNvPr id="11" name="">
-            <a:extLst xmlns:a="http://schemas.openxmlformats.org/drawingml/2006/main">
-              <a:ext uri="{FF2B5EF4-FFF2-40B4-BE49-F238E27FC236}">
-                <a16:creationId xmlns:a16="http://schemas.microsoft.com/office/drawing/2014/main" id="{B0685A25-5E7D-4EEE-982E-882107653A0D}"/>
-              </a:ext>
-            </a:extLst>
-          </p:cNvPr>
-          <p:cNvSpPr>
-            <a:spLocks xmlns:a="http://schemas.openxmlformats.org/drawingml/2006/main" noGrp="1"/>
-          </p:cNvSpPr>
-          <p:nvPr/>
-        </p:nvSpPr>
-        <p:spPr>
-          <a:xfrm xmlns:a="http://schemas.openxmlformats.org/drawingml/2006/main">
-            <a:off x="723900" y="4400550"/>
+              <a:t>Decide whether to package a PFAS-ready regulated quantitation workflow</a:t>
+            </a:r>
+          </a:p>
+        </p:txBody>
+      </p:sp>
+      <p:sp>
+        <p:nvSpPr>
+          <p:cNvPr id="12" name="">
+            <a:extLst xmlns:a="http://schemas.openxmlformats.org/drawingml/2006/main">
+              <a:ext uri="{FF2B5EF4-FFF2-40B4-BE49-F238E27FC236}">
+                <a16:creationId xmlns:a16="http://schemas.microsoft.com/office/drawing/2014/main" id="{10451755-1D28-4157-94BA-B65B5AA8CEC7}"/>
+              </a:ext>
+            </a:extLst>
+          </p:cNvPr>
+          <p:cNvSpPr>
+            <a:spLocks xmlns:a="http://schemas.openxmlformats.org/drawingml/2006/main" noGrp="1"/>
+          </p:cNvSpPr>
+          <p:nvPr/>
+        </p:nvSpPr>
+        <p:spPr>
+          <a:xfrm xmlns:a="http://schemas.openxmlformats.org/drawingml/2006/main">
+            <a:off x="723900" y="4267200"/>
             <a:ext cx="2990850" cy="9525"/>
           </a:xfrm>
           <a:prstGeom xmlns:a="http://schemas.openxmlformats.org/drawingml/2006/main" prst="rect">
@@ -8605,21 +8545,21 @@
       </p:sp>
       <p:sp>
         <p:nvSpPr>
-          <p:cNvPr id="12" name="">
-            <a:extLst xmlns:a="http://schemas.openxmlformats.org/drawingml/2006/main">
-              <a:ext uri="{FF2B5EF4-FFF2-40B4-BE49-F238E27FC236}">
-                <a16:creationId xmlns:a16="http://schemas.microsoft.com/office/drawing/2014/main" id="{926A13C8-AFA0-4AF9-8D68-F2F5DE2A26B9}"/>
-              </a:ext>
-            </a:extLst>
-          </p:cNvPr>
-          <p:cNvSpPr>
-            <a:spLocks xmlns:a="http://schemas.openxmlformats.org/drawingml/2006/main" noGrp="1"/>
-          </p:cNvSpPr>
-          <p:nvPr/>
-        </p:nvSpPr>
-        <p:spPr>
-          <a:xfrm xmlns:a="http://schemas.openxmlformats.org/drawingml/2006/main">
-            <a:off x="723900" y="4552950"/>
+          <p:cNvPr id="13" name="">
+            <a:extLst xmlns:a="http://schemas.openxmlformats.org/drawingml/2006/main">
+              <a:ext uri="{FF2B5EF4-FFF2-40B4-BE49-F238E27FC236}">
+                <a16:creationId xmlns:a16="http://schemas.microsoft.com/office/drawing/2014/main" id="{A8062C67-4172-4298-BC32-183D6C96C269}"/>
+              </a:ext>
+            </a:extLst>
+          </p:cNvPr>
+          <p:cNvSpPr>
+            <a:spLocks xmlns:a="http://schemas.openxmlformats.org/drawingml/2006/main" noGrp="1"/>
+          </p:cNvSpPr>
+          <p:nvPr/>
+        </p:nvSpPr>
+        <p:spPr>
+          <a:xfrm xmlns:a="http://schemas.openxmlformats.org/drawingml/2006/main">
+            <a:off x="723900" y="4410075"/>
             <a:ext cx="2990850" cy="190500"/>
           </a:xfrm>
           <a:prstGeom xmlns:a="http://schemas.openxmlformats.org/drawingml/2006/main" prst="rect">
@@ -8638,7 +8578,7 @@
           <a:lstStyle xmlns:a="http://schemas.openxmlformats.org/drawingml/2006/main"/>
           <a:p xmlns:a="http://schemas.openxmlformats.org/drawingml/2006/main">
             <a:pPr algn="l">
-              <a:defRPr sz="900" b="1">
+              <a:defRPr sz="825" b="1">
                 <a:solidFill>
                   <a:srgbClr val="60767D"/>
                 </a:solidFill>
@@ -8648,7 +8588,7 @@
               </a:defRPr>
             </a:pPr>
             <a:r>
-              <a:rPr sz="900" b="1">
+              <a:rPr sz="825" b="1">
                 <a:solidFill>
                   <a:srgbClr val="60767D"/>
                 </a:solidFill>
@@ -8656,29 +8596,29 @@
                 <a:ea typeface="Aptos"/>
                 <a:cs typeface="Aptos"/>
               </a:rPr>
-              <a:t>REQUIRED OUTPUT</a:t>
-            </a:r>
-          </a:p>
-        </p:txBody>
-      </p:sp>
-      <p:sp>
-        <p:nvSpPr>
-          <p:cNvPr id="13" name="">
-            <a:extLst xmlns:a="http://schemas.openxmlformats.org/drawingml/2006/main">
-              <a:ext uri="{FF2B5EF4-FFF2-40B4-BE49-F238E27FC236}">
-                <a16:creationId xmlns:a16="http://schemas.microsoft.com/office/drawing/2014/main" id="{A7039248-6941-41E3-A169-39411ADDB8B4}"/>
-              </a:ext>
-            </a:extLst>
-          </p:cNvPr>
-          <p:cNvSpPr>
-            <a:spLocks xmlns:a="http://schemas.openxmlformats.org/drawingml/2006/main" noGrp="1"/>
-          </p:cNvSpPr>
-          <p:nvPr/>
-        </p:nvSpPr>
-        <p:spPr>
-          <a:xfrm xmlns:a="http://schemas.openxmlformats.org/drawingml/2006/main">
-            <a:off x="723900" y="4819650"/>
-            <a:ext cx="2990850" cy="685800"/>
+              <a:t>OWNER · Product Management and Applications</a:t>
+            </a:r>
+          </a:p>
+        </p:txBody>
+      </p:sp>
+      <p:sp>
+        <p:nvSpPr>
+          <p:cNvPr id="14" name="">
+            <a:extLst xmlns:a="http://schemas.openxmlformats.org/drawingml/2006/main">
+              <a:ext uri="{FF2B5EF4-FFF2-40B4-BE49-F238E27FC236}">
+                <a16:creationId xmlns:a16="http://schemas.microsoft.com/office/drawing/2014/main" id="{93998130-7AFD-4412-AC9D-C13515E771C5}"/>
+              </a:ext>
+            </a:extLst>
+          </p:cNvPr>
+          <p:cNvSpPr>
+            <a:spLocks xmlns:a="http://schemas.openxmlformats.org/drawingml/2006/main" noGrp="1"/>
+          </p:cNvSpPr>
+          <p:nvPr/>
+        </p:nvSpPr>
+        <p:spPr>
+          <a:xfrm xmlns:a="http://schemas.openxmlformats.org/drawingml/2006/main">
+            <a:off x="723900" y="4705350"/>
+            <a:ext cx="2990850" cy="171450"/>
           </a:xfrm>
           <a:prstGeom xmlns:a="http://schemas.openxmlformats.org/drawingml/2006/main" prst="rect">
             <a:avLst/>
@@ -8696,7 +8636,65 @@
           <a:lstStyle xmlns:a="http://schemas.openxmlformats.org/drawingml/2006/main"/>
           <a:p xmlns:a="http://schemas.openxmlformats.org/drawingml/2006/main">
             <a:pPr algn="l">
-              <a:defRPr sz="1125" b="0">
+              <a:defRPr sz="825" b="1">
+                <a:solidFill>
+                  <a:srgbClr val="60767D"/>
+                </a:solidFill>
+                <a:latin typeface="Aptos"/>
+                <a:ea typeface="Aptos"/>
+                <a:cs typeface="Aptos"/>
+              </a:defRPr>
+            </a:pPr>
+            <a:r>
+              <a:rPr sz="825" b="1">
+                <a:solidFill>
+                  <a:srgbClr val="60767D"/>
+                </a:solidFill>
+                <a:latin typeface="Aptos"/>
+                <a:ea typeface="Aptos"/>
+                <a:cs typeface="Aptos"/>
+              </a:rPr>
+              <a:t>FINAL GO / NO-GO OUTPUT</a:t>
+            </a:r>
+          </a:p>
+        </p:txBody>
+      </p:sp>
+      <p:sp>
+        <p:nvSpPr>
+          <p:cNvPr id="15" name="">
+            <a:extLst xmlns:a="http://schemas.openxmlformats.org/drawingml/2006/main">
+              <a:ext uri="{FF2B5EF4-FFF2-40B4-BE49-F238E27FC236}">
+                <a16:creationId xmlns:a16="http://schemas.microsoft.com/office/drawing/2014/main" id="{47FD3872-E8E0-4957-897A-B014B190F7F1}"/>
+              </a:ext>
+            </a:extLst>
+          </p:cNvPr>
+          <p:cNvSpPr>
+            <a:spLocks xmlns:a="http://schemas.openxmlformats.org/drawingml/2006/main" noGrp="1"/>
+          </p:cNvSpPr>
+          <p:nvPr/>
+        </p:nvSpPr>
+        <p:spPr>
+          <a:xfrm xmlns:a="http://schemas.openxmlformats.org/drawingml/2006/main">
+            <a:off x="723900" y="4933950"/>
+            <a:ext cx="2990850" cy="571500"/>
+          </a:xfrm>
+          <a:prstGeom xmlns:a="http://schemas.openxmlformats.org/drawingml/2006/main" prst="rect">
+            <a:avLst/>
+          </a:prstGeom>
+          <a:noFill xmlns:a="http://schemas.openxmlformats.org/drawingml/2006/main"/>
+          <a:ln xmlns:a="http://schemas.openxmlformats.org/drawingml/2006/main" w="0">
+            <a:noFill/>
+            <a:prstDash val="solid"/>
+          </a:ln>
+        </p:spPr>
+        <p:txBody>
+          <a:bodyPr xmlns:a="http://schemas.openxmlformats.org/drawingml/2006/main" wrap="square" lIns="0" tIns="0" rIns="0" bIns="0" anchor="t">
+            <a:normAutofit fontScale="100000"/>
+          </a:bodyPr>
+          <a:lstStyle xmlns:a="http://schemas.openxmlformats.org/drawingml/2006/main"/>
+          <a:p xmlns:a="http://schemas.openxmlformats.org/drawingml/2006/main">
+            <a:pPr algn="l">
+              <a:defRPr sz="975" b="0">
                 <a:solidFill>
                   <a:srgbClr val="153640"/>
                 </a:solidFill>
@@ -8706,7 +8704,7 @@
               </a:defRPr>
             </a:pPr>
             <a:r>
-              <a:rPr sz="1125" b="0">
+              <a:rPr sz="975" b="0">
                 <a:solidFill>
                   <a:srgbClr val="153640"/>
                 </a:solidFill>
@@ -8714,17 +8712,17 @@
                 <a:ea typeface="Aptos"/>
                 <a:cs typeface="Aptos"/>
               </a:rPr>
-              <a:t>A claims matrix versus Thermo, SCIEX and Shimadzu, ending in a go/no-go.</a:t>
-            </a:r>
-          </a:p>
-        </p:txBody>
-      </p:sp>
-      <p:sp>
-        <p:nvSpPr>
-          <p:cNvPr id="14" name="">
-            <a:extLst xmlns:a="http://schemas.openxmlformats.org/drawingml/2006/main">
-              <a:ext uri="{FF2B5EF4-FFF2-40B4-BE49-F238E27FC236}">
-                <a16:creationId xmlns:a16="http://schemas.microsoft.com/office/drawing/2014/main" id="{37736019-100E-498B-8B02-EBF76E328865}"/>
+              <a:t>Choose build, package existing capability, reposition, partner, monitor, or stop for a PFAS-ready regulated quantitation workflow</a:t>
+            </a:r>
+          </a:p>
+        </p:txBody>
+      </p:sp>
+      <p:sp>
+        <p:nvSpPr>
+          <p:cNvPr id="16" name="">
+            <a:extLst xmlns:a="http://schemas.openxmlformats.org/drawingml/2006/main">
+              <a:ext uri="{FF2B5EF4-FFF2-40B4-BE49-F238E27FC236}">
+                <a16:creationId xmlns:a16="http://schemas.microsoft.com/office/drawing/2014/main" id="{962AB3FF-2672-4AD4-BC75-CCFECE45A9D9}"/>
               </a:ext>
             </a:extLst>
           </p:cNvPr>
@@ -8756,10 +8754,10 @@
       </p:sp>
       <p:sp>
         <p:nvSpPr>
-          <p:cNvPr id="15" name="">
-            <a:extLst xmlns:a="http://schemas.openxmlformats.org/drawingml/2006/main">
-              <a:ext uri="{FF2B5EF4-FFF2-40B4-BE49-F238E27FC236}">
-                <a16:creationId xmlns:a16="http://schemas.microsoft.com/office/drawing/2014/main" id="{52F7F758-8E4E-4815-8956-61B326C7F239}"/>
+          <p:cNvPr id="17" name="">
+            <a:extLst xmlns:a="http://schemas.openxmlformats.org/drawingml/2006/main">
+              <a:ext uri="{FF2B5EF4-FFF2-40B4-BE49-F238E27FC236}">
+                <a16:creationId xmlns:a16="http://schemas.microsoft.com/office/drawing/2014/main" id="{A7302319-C27B-4823-B46B-F7FCAD17188A}"/>
               </a:ext>
             </a:extLst>
           </p:cNvPr>
@@ -8789,138 +8787,22 @@
       </p:sp>
       <p:sp>
         <p:nvSpPr>
-          <p:cNvPr id="16" name="">
-            <a:extLst xmlns:a="http://schemas.openxmlformats.org/drawingml/2006/main">
-              <a:ext uri="{FF2B5EF4-FFF2-40B4-BE49-F238E27FC236}">
-                <a16:creationId xmlns:a16="http://schemas.microsoft.com/office/drawing/2014/main" id="{5BAF19B9-F773-4D57-B1F2-E4481DFA9638}"/>
-              </a:ext>
-            </a:extLst>
-          </p:cNvPr>
-          <p:cNvSpPr>
-            <a:spLocks xmlns:a="http://schemas.openxmlformats.org/drawingml/2006/main" noGrp="1"/>
-          </p:cNvSpPr>
-          <p:nvPr/>
-        </p:nvSpPr>
-        <p:spPr>
-          <a:xfrm xmlns:a="http://schemas.openxmlformats.org/drawingml/2006/main">
-            <a:off x="4600575" y="2400300"/>
+          <p:cNvPr id="18" name="">
+            <a:extLst xmlns:a="http://schemas.openxmlformats.org/drawingml/2006/main">
+              <a:ext uri="{FF2B5EF4-FFF2-40B4-BE49-F238E27FC236}">
+                <a16:creationId xmlns:a16="http://schemas.microsoft.com/office/drawing/2014/main" id="{1F722AE1-3C74-4414-A767-AA748DFC5985}"/>
+              </a:ext>
+            </a:extLst>
+          </p:cNvPr>
+          <p:cNvSpPr>
+            <a:spLocks xmlns:a="http://schemas.openxmlformats.org/drawingml/2006/main" noGrp="1"/>
+          </p:cNvSpPr>
+          <p:nvPr/>
+        </p:nvSpPr>
+        <p:spPr>
+          <a:xfrm xmlns:a="http://schemas.openxmlformats.org/drawingml/2006/main">
+            <a:off x="4600575" y="2381250"/>
             <a:ext cx="2990850" cy="228600"/>
-          </a:xfrm>
-          <a:prstGeom xmlns:a="http://schemas.openxmlformats.org/drawingml/2006/main" prst="rect">
-            <a:avLst/>
-          </a:prstGeom>
-          <a:noFill xmlns:a="http://schemas.openxmlformats.org/drawingml/2006/main"/>
-          <a:ln xmlns:a="http://schemas.openxmlformats.org/drawingml/2006/main" w="0">
-            <a:noFill/>
-            <a:prstDash val="solid"/>
-          </a:ln>
-        </p:spPr>
-        <p:txBody>
-          <a:bodyPr xmlns:a="http://schemas.openxmlformats.org/drawingml/2006/main" wrap="square" lIns="0" tIns="0" rIns="0" bIns="0" anchor="t">
-            <a:normAutofit fontScale="100000"/>
-          </a:bodyPr>
-          <a:lstStyle xmlns:a="http://schemas.openxmlformats.org/drawingml/2006/main"/>
-          <a:p xmlns:a="http://schemas.openxmlformats.org/drawingml/2006/main">
-            <a:pPr algn="l">
-              <a:defRPr sz="975" b="1">
-                <a:solidFill>
-                  <a:srgbClr val="087F8C"/>
-                </a:solidFill>
-                <a:latin typeface="Aptos"/>
-                <a:ea typeface="Aptos"/>
-                <a:cs typeface="Aptos"/>
-              </a:defRPr>
-            </a:pPr>
-            <a:r>
-              <a:rPr sz="975" b="1">
-                <a:solidFill>
-                  <a:srgbClr val="087F8C"/>
-                </a:solidFill>
-                <a:latin typeface="Aptos"/>
-                <a:ea typeface="Aptos"/>
-                <a:cs typeface="Aptos"/>
-              </a:rPr>
-              <a:t>DUE 14 AUG</a:t>
-            </a:r>
-          </a:p>
-        </p:txBody>
-      </p:sp>
-      <p:sp>
-        <p:nvSpPr>
-          <p:cNvPr id="17" name="">
-            <a:extLst xmlns:a="http://schemas.openxmlformats.org/drawingml/2006/main">
-              <a:ext uri="{FF2B5EF4-FFF2-40B4-BE49-F238E27FC236}">
-                <a16:creationId xmlns:a16="http://schemas.microsoft.com/office/drawing/2014/main" id="{E615E905-ACDE-4E15-9635-42928119433F}"/>
-              </a:ext>
-            </a:extLst>
-          </p:cNvPr>
-          <p:cNvSpPr>
-            <a:spLocks xmlns:a="http://schemas.openxmlformats.org/drawingml/2006/main" noGrp="1"/>
-          </p:cNvSpPr>
-          <p:nvPr/>
-        </p:nvSpPr>
-        <p:spPr>
-          <a:xfrm xmlns:a="http://schemas.openxmlformats.org/drawingml/2006/main">
-            <a:off x="4600575" y="2724150"/>
-            <a:ext cx="2990850" cy="476250"/>
-          </a:xfrm>
-          <a:prstGeom xmlns:a="http://schemas.openxmlformats.org/drawingml/2006/main" prst="rect">
-            <a:avLst/>
-          </a:prstGeom>
-          <a:noFill xmlns:a="http://schemas.openxmlformats.org/drawingml/2006/main"/>
-          <a:ln xmlns:a="http://schemas.openxmlformats.org/drawingml/2006/main" w="0">
-            <a:noFill/>
-            <a:prstDash val="solid"/>
-          </a:ln>
-        </p:spPr>
-        <p:txBody>
-          <a:bodyPr xmlns:a="http://schemas.openxmlformats.org/drawingml/2006/main" wrap="square" lIns="0" tIns="0" rIns="0" bIns="0" anchor="t">
-            <a:normAutofit fontScale="100000"/>
-          </a:bodyPr>
-          <a:lstStyle xmlns:a="http://schemas.openxmlformats.org/drawingml/2006/main"/>
-          <a:p xmlns:a="http://schemas.openxmlformats.org/drawingml/2006/main">
-            <a:pPr algn="l">
-              <a:defRPr sz="2550" b="1">
-                <a:solidFill>
-                  <a:srgbClr val="153640"/>
-                </a:solidFill>
-                <a:latin typeface="Aptos"/>
-                <a:ea typeface="Aptos"/>
-                <a:cs typeface="Aptos"/>
-              </a:defRPr>
-            </a:pPr>
-            <a:r>
-              <a:rPr sz="2550" b="1">
-                <a:solidFill>
-                  <a:srgbClr val="153640"/>
-                </a:solidFill>
-                <a:latin typeface="Aptos"/>
-                <a:ea typeface="Aptos"/>
-                <a:cs typeface="Aptos"/>
-              </a:rPr>
-              <a:t>72/100</a:t>
-            </a:r>
-          </a:p>
-        </p:txBody>
-      </p:sp>
-      <p:sp>
-        <p:nvSpPr>
-          <p:cNvPr id="18" name="">
-            <a:extLst xmlns:a="http://schemas.openxmlformats.org/drawingml/2006/main">
-              <a:ext uri="{FF2B5EF4-FFF2-40B4-BE49-F238E27FC236}">
-                <a16:creationId xmlns:a16="http://schemas.microsoft.com/office/drawing/2014/main" id="{089FA200-E791-44C7-BC6C-838E481C18AA}"/>
-              </a:ext>
-            </a:extLst>
-          </p:cNvPr>
-          <p:cNvSpPr>
-            <a:spLocks xmlns:a="http://schemas.openxmlformats.org/drawingml/2006/main" noGrp="1"/>
-          </p:cNvSpPr>
-          <p:nvPr/>
-        </p:nvSpPr>
-        <p:spPr>
-          <a:xfrm xmlns:a="http://schemas.openxmlformats.org/drawingml/2006/main">
-            <a:off x="4600575" y="3143250"/>
-            <a:ext cx="2990850" cy="209550"/>
           </a:xfrm>
           <a:prstGeom xmlns:a="http://schemas.openxmlformats.org/drawingml/2006/main" prst="rect">
             <a:avLst/>
@@ -8940,6 +8822,64 @@
             <a:pPr algn="l">
               <a:defRPr sz="900" b="1">
                 <a:solidFill>
+                  <a:srgbClr val="087F8C"/>
+                </a:solidFill>
+                <a:latin typeface="Aptos"/>
+                <a:ea typeface="Aptos"/>
+                <a:cs typeface="Aptos"/>
+              </a:defRPr>
+            </a:pPr>
+            <a:r>
+              <a:rPr sz="900" b="1">
+                <a:solidFill>
+                  <a:srgbClr val="087F8C"/>
+                </a:solidFill>
+                <a:latin typeface="Aptos"/>
+                <a:ea typeface="Aptos"/>
+                <a:cs typeface="Aptos"/>
+              </a:rPr>
+              <a:t>DUE AUGUST 14, 2026</a:t>
+            </a:r>
+          </a:p>
+        </p:txBody>
+      </p:sp>
+      <p:sp>
+        <p:nvSpPr>
+          <p:cNvPr id="19" name="">
+            <a:extLst xmlns:a="http://schemas.openxmlformats.org/drawingml/2006/main">
+              <a:ext uri="{FF2B5EF4-FFF2-40B4-BE49-F238E27FC236}">
+                <a16:creationId xmlns:a16="http://schemas.microsoft.com/office/drawing/2014/main" id="{8E4E00D5-87A0-45FC-9B08-115C76480D12}"/>
+              </a:ext>
+            </a:extLst>
+          </p:cNvPr>
+          <p:cNvSpPr>
+            <a:spLocks xmlns:a="http://schemas.openxmlformats.org/drawingml/2006/main" noGrp="1"/>
+          </p:cNvSpPr>
+          <p:nvPr/>
+        </p:nvSpPr>
+        <p:spPr>
+          <a:xfrm xmlns:a="http://schemas.openxmlformats.org/drawingml/2006/main">
+            <a:off x="4600575" y="2695575"/>
+            <a:ext cx="2990850" cy="171450"/>
+          </a:xfrm>
+          <a:prstGeom xmlns:a="http://schemas.openxmlformats.org/drawingml/2006/main" prst="rect">
+            <a:avLst/>
+          </a:prstGeom>
+          <a:noFill xmlns:a="http://schemas.openxmlformats.org/drawingml/2006/main"/>
+          <a:ln xmlns:a="http://schemas.openxmlformats.org/drawingml/2006/main" w="0">
+            <a:noFill/>
+            <a:prstDash val="solid"/>
+          </a:ln>
+        </p:spPr>
+        <p:txBody>
+          <a:bodyPr xmlns:a="http://schemas.openxmlformats.org/drawingml/2006/main" wrap="square" lIns="0" tIns="0" rIns="0" bIns="0" anchor="t">
+            <a:normAutofit fontScale="100000"/>
+          </a:bodyPr>
+          <a:lstStyle xmlns:a="http://schemas.openxmlformats.org/drawingml/2006/main"/>
+          <a:p xmlns:a="http://schemas.openxmlformats.org/drawingml/2006/main">
+            <a:pPr algn="l">
+              <a:defRPr sz="825" b="1">
+                <a:solidFill>
                   <a:srgbClr val="60767D"/>
                 </a:solidFill>
                 <a:latin typeface="Aptos"/>
@@ -8948,7 +8888,7 @@
               </a:defRPr>
             </a:pPr>
             <a:r>
-              <a:rPr sz="900" b="1">
+              <a:rPr sz="825" b="1">
                 <a:solidFill>
                   <a:srgbClr val="60767D"/>
                 </a:solidFill>
@@ -8956,29 +8896,29 @@
                 <a:ea typeface="Aptos"/>
                 <a:cs typeface="Aptos"/>
               </a:rPr>
-              <a:t>PRIORITY SCORE</a:t>
-            </a:r>
-          </a:p>
-        </p:txBody>
-      </p:sp>
-      <p:sp>
-        <p:nvSpPr>
-          <p:cNvPr id="19" name="">
-            <a:extLst xmlns:a="http://schemas.openxmlformats.org/drawingml/2006/main">
-              <a:ext uri="{FF2B5EF4-FFF2-40B4-BE49-F238E27FC236}">
-                <a16:creationId xmlns:a16="http://schemas.microsoft.com/office/drawing/2014/main" id="{E2D729E8-B5A2-4EA0-846E-7574C14BC7B6}"/>
-              </a:ext>
-            </a:extLst>
-          </p:cNvPr>
-          <p:cNvSpPr>
-            <a:spLocks xmlns:a="http://schemas.openxmlformats.org/drawingml/2006/main" noGrp="1"/>
-          </p:cNvSpPr>
-          <p:nvPr/>
-        </p:nvSpPr>
-        <p:spPr>
-          <a:xfrm xmlns:a="http://schemas.openxmlformats.org/drawingml/2006/main">
-            <a:off x="4600575" y="3524250"/>
-            <a:ext cx="2990850" cy="742950"/>
+              <a:t>EVIDENCE PRIORITY</a:t>
+            </a:r>
+          </a:p>
+        </p:txBody>
+      </p:sp>
+      <p:sp>
+        <p:nvSpPr>
+          <p:cNvPr id="20" name="">
+            <a:extLst xmlns:a="http://schemas.openxmlformats.org/drawingml/2006/main">
+              <a:ext uri="{FF2B5EF4-FFF2-40B4-BE49-F238E27FC236}">
+                <a16:creationId xmlns:a16="http://schemas.microsoft.com/office/drawing/2014/main" id="{C0BC9EF1-8D45-4389-A0D1-02B14F17F924}"/>
+              </a:ext>
+            </a:extLst>
+          </p:cNvPr>
+          <p:cNvSpPr>
+            <a:spLocks xmlns:a="http://schemas.openxmlformats.org/drawingml/2006/main" noGrp="1"/>
+          </p:cNvSpPr>
+          <p:nvPr/>
+        </p:nvSpPr>
+        <p:spPr>
+          <a:xfrm xmlns:a="http://schemas.openxmlformats.org/drawingml/2006/main">
+            <a:off x="4600575" y="2895600"/>
+            <a:ext cx="2990850" cy="342900"/>
           </a:xfrm>
           <a:prstGeom xmlns:a="http://schemas.openxmlformats.org/drawingml/2006/main" prst="rect">
             <a:avLst/>
@@ -8996,7 +8936,7 @@
           <a:lstStyle xmlns:a="http://schemas.openxmlformats.org/drawingml/2006/main"/>
           <a:p xmlns:a="http://schemas.openxmlformats.org/drawingml/2006/main">
             <a:pPr algn="l">
-              <a:defRPr sz="1575" b="1">
+              <a:defRPr sz="2025" b="1">
                 <a:solidFill>
                   <a:srgbClr val="153640"/>
                 </a:solidFill>
@@ -9006,7 +8946,7 @@
               </a:defRPr>
             </a:pPr>
             <a:r>
-              <a:rPr sz="1575" b="1">
+              <a:rPr sz="2025" b="1">
                 <a:solidFill>
                   <a:srgbClr val="153640"/>
                 </a:solidFill>
@@ -9014,28 +8954,144 @@
                 <a:ea typeface="Aptos"/>
                 <a:cs typeface="Aptos"/>
               </a:rPr>
-              <a:t>Do Next Gen LC and Alliance iS need new end-to-end workflow requirements?</a:t>
-            </a:r>
-          </a:p>
-        </p:txBody>
-      </p:sp>
-      <p:sp>
-        <p:nvSpPr>
-          <p:cNvPr id="20" name="">
-            <a:extLst xmlns:a="http://schemas.openxmlformats.org/drawingml/2006/main">
-              <a:ext uri="{FF2B5EF4-FFF2-40B4-BE49-F238E27FC236}">
-                <a16:creationId xmlns:a16="http://schemas.microsoft.com/office/drawing/2014/main" id="{CCA82114-9579-4D35-BE28-CF6A1B7CFEFD}"/>
-              </a:ext>
-            </a:extLst>
-          </p:cNvPr>
-          <p:cNvSpPr>
-            <a:spLocks xmlns:a="http://schemas.openxmlformats.org/drawingml/2006/main" noGrp="1"/>
-          </p:cNvSpPr>
-          <p:nvPr/>
-        </p:nvSpPr>
-        <p:spPr>
-          <a:xfrm xmlns:a="http://schemas.openxmlformats.org/drawingml/2006/main">
-            <a:off x="4600575" y="4400550"/>
+              <a:t>High</a:t>
+            </a:r>
+          </a:p>
+        </p:txBody>
+      </p:sp>
+      <p:sp>
+        <p:nvSpPr>
+          <p:cNvPr id="21" name="">
+            <a:extLst xmlns:a="http://schemas.openxmlformats.org/drawingml/2006/main">
+              <a:ext uri="{FF2B5EF4-FFF2-40B4-BE49-F238E27FC236}">
+                <a16:creationId xmlns:a16="http://schemas.microsoft.com/office/drawing/2014/main" id="{A9A5F0C3-5C7C-4B7C-8CAA-3133708FC830}"/>
+              </a:ext>
+            </a:extLst>
+          </p:cNvPr>
+          <p:cNvSpPr>
+            <a:spLocks xmlns:a="http://schemas.openxmlformats.org/drawingml/2006/main" noGrp="1"/>
+          </p:cNvSpPr>
+          <p:nvPr/>
+        </p:nvSpPr>
+        <p:spPr>
+          <a:xfrm xmlns:a="http://schemas.openxmlformats.org/drawingml/2006/main">
+            <a:off x="4600575" y="3276600"/>
+            <a:ext cx="2990850" cy="190500"/>
+          </a:xfrm>
+          <a:prstGeom xmlns:a="http://schemas.openxmlformats.org/drawingml/2006/main" prst="rect">
+            <a:avLst/>
+          </a:prstGeom>
+          <a:noFill xmlns:a="http://schemas.openxmlformats.org/drawingml/2006/main"/>
+          <a:ln xmlns:a="http://schemas.openxmlformats.org/drawingml/2006/main" w="0">
+            <a:noFill/>
+            <a:prstDash val="solid"/>
+          </a:ln>
+        </p:spPr>
+        <p:txBody>
+          <a:bodyPr xmlns:a="http://schemas.openxmlformats.org/drawingml/2006/main" wrap="square" lIns="0" tIns="0" rIns="0" bIns="0" anchor="t">
+            <a:normAutofit fontScale="100000"/>
+          </a:bodyPr>
+          <a:lstStyle xmlns:a="http://schemas.openxmlformats.org/drawingml/2006/main"/>
+          <a:p xmlns:a="http://schemas.openxmlformats.org/drawingml/2006/main">
+            <a:pPr algn="l">
+              <a:defRPr sz="825" b="1">
+                <a:solidFill>
+                  <a:srgbClr val="BA3A42"/>
+                </a:solidFill>
+                <a:latin typeface="Aptos"/>
+                <a:ea typeface="Aptos"/>
+                <a:cs typeface="Aptos"/>
+              </a:defRPr>
+            </a:pPr>
+            <a:r>
+              <a:rPr sz="825" b="1">
+                <a:solidFill>
+                  <a:srgbClr val="BA3A42"/>
+                </a:solidFill>
+                <a:latin typeface="Aptos"/>
+                <a:ea typeface="Aptos"/>
+                <a:cs typeface="Aptos"/>
+              </a:rPr>
+              <a:t>BUSINESS IMPACT · UNQUANTIFIED</a:t>
+            </a:r>
+          </a:p>
+        </p:txBody>
+      </p:sp>
+      <p:sp>
+        <p:nvSpPr>
+          <p:cNvPr id="22" name="">
+            <a:extLst xmlns:a="http://schemas.openxmlformats.org/drawingml/2006/main">
+              <a:ext uri="{FF2B5EF4-FFF2-40B4-BE49-F238E27FC236}">
+                <a16:creationId xmlns:a16="http://schemas.microsoft.com/office/drawing/2014/main" id="{3D7F39B9-19EE-4817-BA1E-7DCB3A6150FB}"/>
+              </a:ext>
+            </a:extLst>
+          </p:cNvPr>
+          <p:cNvSpPr>
+            <a:spLocks xmlns:a="http://schemas.openxmlformats.org/drawingml/2006/main" noGrp="1"/>
+          </p:cNvSpPr>
+          <p:nvPr/>
+        </p:nvSpPr>
+        <p:spPr>
+          <a:xfrm xmlns:a="http://schemas.openxmlformats.org/drawingml/2006/main">
+            <a:off x="4600575" y="3571875"/>
+            <a:ext cx="2990850" cy="590550"/>
+          </a:xfrm>
+          <a:prstGeom xmlns:a="http://schemas.openxmlformats.org/drawingml/2006/main" prst="rect">
+            <a:avLst/>
+          </a:prstGeom>
+          <a:noFill xmlns:a="http://schemas.openxmlformats.org/drawingml/2006/main"/>
+          <a:ln xmlns:a="http://schemas.openxmlformats.org/drawingml/2006/main" w="0">
+            <a:noFill/>
+            <a:prstDash val="solid"/>
+          </a:ln>
+        </p:spPr>
+        <p:txBody>
+          <a:bodyPr xmlns:a="http://schemas.openxmlformats.org/drawingml/2006/main" wrap="square" lIns="0" tIns="0" rIns="0" bIns="0" anchor="t">
+            <a:normAutofit fontScale="90643"/>
+          </a:bodyPr>
+          <a:lstStyle xmlns:a="http://schemas.openxmlformats.org/drawingml/2006/main"/>
+          <a:p xmlns:a="http://schemas.openxmlformats.org/drawingml/2006/main">
+            <a:pPr algn="l">
+              <a:defRPr sz="1425" b="1">
+                <a:solidFill>
+                  <a:srgbClr val="153640"/>
+                </a:solidFill>
+                <a:latin typeface="Aptos"/>
+                <a:ea typeface="Aptos"/>
+                <a:cs typeface="Aptos"/>
+              </a:defRPr>
+            </a:pPr>
+            <a:r>
+              <a:rPr sz="1425" b="1">
+                <a:solidFill>
+                  <a:srgbClr val="153640"/>
+                </a:solidFill>
+                <a:latin typeface="Aptos"/>
+                <a:ea typeface="Aptos"/>
+                <a:cs typeface="Aptos"/>
+              </a:rPr>
+              <a:t>Decide whether Next Gen LC and Alliance iS need new end-to-end workflow requirements</a:t>
+            </a:r>
+          </a:p>
+        </p:txBody>
+      </p:sp>
+      <p:sp>
+        <p:nvSpPr>
+          <p:cNvPr id="23" name="">
+            <a:extLst xmlns:a="http://schemas.openxmlformats.org/drawingml/2006/main">
+              <a:ext uri="{FF2B5EF4-FFF2-40B4-BE49-F238E27FC236}">
+                <a16:creationId xmlns:a16="http://schemas.microsoft.com/office/drawing/2014/main" id="{B56E9B73-E390-475E-B87D-0DDF153287F7}"/>
+              </a:ext>
+            </a:extLst>
+          </p:cNvPr>
+          <p:cNvSpPr>
+            <a:spLocks xmlns:a="http://schemas.openxmlformats.org/drawingml/2006/main" noGrp="1"/>
+          </p:cNvSpPr>
+          <p:nvPr/>
+        </p:nvSpPr>
+        <p:spPr>
+          <a:xfrm xmlns:a="http://schemas.openxmlformats.org/drawingml/2006/main">
+            <a:off x="4600575" y="4267200"/>
             <a:ext cx="2990850" cy="9525"/>
           </a:xfrm>
           <a:prstGeom xmlns:a="http://schemas.openxmlformats.org/drawingml/2006/main" prst="rect">
@@ -9054,21 +9110,21 @@
       </p:sp>
       <p:sp>
         <p:nvSpPr>
-          <p:cNvPr id="21" name="">
-            <a:extLst xmlns:a="http://schemas.openxmlformats.org/drawingml/2006/main">
-              <a:ext uri="{FF2B5EF4-FFF2-40B4-BE49-F238E27FC236}">
-                <a16:creationId xmlns:a16="http://schemas.microsoft.com/office/drawing/2014/main" id="{065A6B92-704A-4072-9994-F79CDB2FDBAB}"/>
-              </a:ext>
-            </a:extLst>
-          </p:cNvPr>
-          <p:cNvSpPr>
-            <a:spLocks xmlns:a="http://schemas.openxmlformats.org/drawingml/2006/main" noGrp="1"/>
-          </p:cNvSpPr>
-          <p:nvPr/>
-        </p:nvSpPr>
-        <p:spPr>
-          <a:xfrm xmlns:a="http://schemas.openxmlformats.org/drawingml/2006/main">
-            <a:off x="4600575" y="4552950"/>
+          <p:cNvPr id="24" name="">
+            <a:extLst xmlns:a="http://schemas.openxmlformats.org/drawingml/2006/main">
+              <a:ext uri="{FF2B5EF4-FFF2-40B4-BE49-F238E27FC236}">
+                <a16:creationId xmlns:a16="http://schemas.microsoft.com/office/drawing/2014/main" id="{13DE9D67-5F55-4759-A4BB-A7D088B0C554}"/>
+              </a:ext>
+            </a:extLst>
+          </p:cNvPr>
+          <p:cNvSpPr>
+            <a:spLocks xmlns:a="http://schemas.openxmlformats.org/drawingml/2006/main" noGrp="1"/>
+          </p:cNvSpPr>
+          <p:nvPr/>
+        </p:nvSpPr>
+        <p:spPr>
+          <a:xfrm xmlns:a="http://schemas.openxmlformats.org/drawingml/2006/main">
+            <a:off x="4600575" y="4410075"/>
             <a:ext cx="2990850" cy="190500"/>
           </a:xfrm>
           <a:prstGeom xmlns:a="http://schemas.openxmlformats.org/drawingml/2006/main" prst="rect">
@@ -9087,7 +9143,7 @@
           <a:lstStyle xmlns:a="http://schemas.openxmlformats.org/drawingml/2006/main"/>
           <a:p xmlns:a="http://schemas.openxmlformats.org/drawingml/2006/main">
             <a:pPr algn="l">
-              <a:defRPr sz="900" b="1">
+              <a:defRPr sz="825" b="1">
                 <a:solidFill>
                   <a:srgbClr val="60767D"/>
                 </a:solidFill>
@@ -9097,7 +9153,7 @@
               </a:defRPr>
             </a:pPr>
             <a:r>
-              <a:rPr sz="900" b="1">
+              <a:rPr sz="825" b="1">
                 <a:solidFill>
                   <a:srgbClr val="60767D"/>
                 </a:solidFill>
@@ -9105,29 +9161,29 @@
                 <a:ea typeface="Aptos"/>
                 <a:cs typeface="Aptos"/>
               </a:rPr>
-              <a:t>REQUIRED OUTPUT</a:t>
-            </a:r>
-          </a:p>
-        </p:txBody>
-      </p:sp>
-      <p:sp>
-        <p:nvSpPr>
-          <p:cNvPr id="22" name="">
-            <a:extLst xmlns:a="http://schemas.openxmlformats.org/drawingml/2006/main">
-              <a:ext uri="{FF2B5EF4-FFF2-40B4-BE49-F238E27FC236}">
-                <a16:creationId xmlns:a16="http://schemas.microsoft.com/office/drawing/2014/main" id="{E6C522B5-1624-4D20-AAD7-3468F5F7779B}"/>
-              </a:ext>
-            </a:extLst>
-          </p:cNvPr>
-          <p:cNvSpPr>
-            <a:spLocks xmlns:a="http://schemas.openxmlformats.org/drawingml/2006/main" noGrp="1"/>
-          </p:cNvSpPr>
-          <p:nvPr/>
-        </p:nvSpPr>
-        <p:spPr>
-          <a:xfrm xmlns:a="http://schemas.openxmlformats.org/drawingml/2006/main">
-            <a:off x="4600575" y="4819650"/>
-            <a:ext cx="2990850" cy="685800"/>
+              <a:t>OWNER · LC Platform PM and Software Lead</a:t>
+            </a:r>
+          </a:p>
+        </p:txBody>
+      </p:sp>
+      <p:sp>
+        <p:nvSpPr>
+          <p:cNvPr id="25" name="">
+            <a:extLst xmlns:a="http://schemas.openxmlformats.org/drawingml/2006/main">
+              <a:ext uri="{FF2B5EF4-FFF2-40B4-BE49-F238E27FC236}">
+                <a16:creationId xmlns:a16="http://schemas.microsoft.com/office/drawing/2014/main" id="{B7E78681-3A57-4BA3-A900-FB9EE714ACB3}"/>
+              </a:ext>
+            </a:extLst>
+          </p:cNvPr>
+          <p:cNvSpPr>
+            <a:spLocks xmlns:a="http://schemas.openxmlformats.org/drawingml/2006/main" noGrp="1"/>
+          </p:cNvSpPr>
+          <p:nvPr/>
+        </p:nvSpPr>
+        <p:spPr>
+          <a:xfrm xmlns:a="http://schemas.openxmlformats.org/drawingml/2006/main">
+            <a:off x="4600575" y="4705350"/>
+            <a:ext cx="2990850" cy="171450"/>
           </a:xfrm>
           <a:prstGeom xmlns:a="http://schemas.openxmlformats.org/drawingml/2006/main" prst="rect">
             <a:avLst/>
@@ -9145,7 +9201,65 @@
           <a:lstStyle xmlns:a="http://schemas.openxmlformats.org/drawingml/2006/main"/>
           <a:p xmlns:a="http://schemas.openxmlformats.org/drawingml/2006/main">
             <a:pPr algn="l">
-              <a:defRPr sz="1125" b="0">
+              <a:defRPr sz="825" b="1">
+                <a:solidFill>
+                  <a:srgbClr val="60767D"/>
+                </a:solidFill>
+                <a:latin typeface="Aptos"/>
+                <a:ea typeface="Aptos"/>
+                <a:cs typeface="Aptos"/>
+              </a:defRPr>
+            </a:pPr>
+            <a:r>
+              <a:rPr sz="825" b="1">
+                <a:solidFill>
+                  <a:srgbClr val="60767D"/>
+                </a:solidFill>
+                <a:latin typeface="Aptos"/>
+                <a:ea typeface="Aptos"/>
+                <a:cs typeface="Aptos"/>
+              </a:rPr>
+              <a:t>FINAL GO / NO-GO OUTPUT</a:t>
+            </a:r>
+          </a:p>
+        </p:txBody>
+      </p:sp>
+      <p:sp>
+        <p:nvSpPr>
+          <p:cNvPr id="26" name="">
+            <a:extLst xmlns:a="http://schemas.openxmlformats.org/drawingml/2006/main">
+              <a:ext uri="{FF2B5EF4-FFF2-40B4-BE49-F238E27FC236}">
+                <a16:creationId xmlns:a16="http://schemas.microsoft.com/office/drawing/2014/main" id="{6649E9B1-7A75-421F-ADDD-D4FEC2208427}"/>
+              </a:ext>
+            </a:extLst>
+          </p:cNvPr>
+          <p:cNvSpPr>
+            <a:spLocks xmlns:a="http://schemas.openxmlformats.org/drawingml/2006/main" noGrp="1"/>
+          </p:cNvSpPr>
+          <p:nvPr/>
+        </p:nvSpPr>
+        <p:spPr>
+          <a:xfrm xmlns:a="http://schemas.openxmlformats.org/drawingml/2006/main">
+            <a:off x="4600575" y="4933950"/>
+            <a:ext cx="2990850" cy="571500"/>
+          </a:xfrm>
+          <a:prstGeom xmlns:a="http://schemas.openxmlformats.org/drawingml/2006/main" prst="rect">
+            <a:avLst/>
+          </a:prstGeom>
+          <a:noFill xmlns:a="http://schemas.openxmlformats.org/drawingml/2006/main"/>
+          <a:ln xmlns:a="http://schemas.openxmlformats.org/drawingml/2006/main" w="0">
+            <a:noFill/>
+            <a:prstDash val="solid"/>
+          </a:ln>
+        </p:spPr>
+        <p:txBody>
+          <a:bodyPr xmlns:a="http://schemas.openxmlformats.org/drawingml/2006/main" wrap="square" lIns="0" tIns="0" rIns="0" bIns="0" anchor="t">
+            <a:normAutofit fontScale="100000"/>
+          </a:bodyPr>
+          <a:lstStyle xmlns:a="http://schemas.openxmlformats.org/drawingml/2006/main"/>
+          <a:p xmlns:a="http://schemas.openxmlformats.org/drawingml/2006/main">
+            <a:pPr algn="l">
+              <a:defRPr sz="975" b="0">
                 <a:solidFill>
                   <a:srgbClr val="153640"/>
                 </a:solidFill>
@@ -9155,7 +9269,7 @@
               </a:defRPr>
             </a:pPr>
             <a:r>
-              <a:rPr sz="1125" b="0">
+              <a:rPr sz="975" b="0">
                 <a:solidFill>
                   <a:srgbClr val="153640"/>
                 </a:solidFill>
@@ -9163,17 +9277,17 @@
                 <a:ea typeface="Aptos"/>
                 <a:cs typeface="Aptos"/>
               </a:rPr>
-              <a:t>One recommendation: build, package existing capability, reposition, or stop.</a:t>
-            </a:r>
-          </a:p>
-        </p:txBody>
-      </p:sp>
-      <p:sp>
-        <p:nvSpPr>
-          <p:cNvPr id="23" name="">
-            <a:extLst xmlns:a="http://schemas.openxmlformats.org/drawingml/2006/main">
-              <a:ext uri="{FF2B5EF4-FFF2-40B4-BE49-F238E27FC236}">
-                <a16:creationId xmlns:a16="http://schemas.microsoft.com/office/drawing/2014/main" id="{3F4D0460-2FCE-4A65-BEA3-5DA4192BF644}"/>
+              <a:t>One recommendation: build, package existing capabilities, reposition, or stop</a:t>
+            </a:r>
+          </a:p>
+        </p:txBody>
+      </p:sp>
+      <p:sp>
+        <p:nvSpPr>
+          <p:cNvPr id="27" name="">
+            <a:extLst xmlns:a="http://schemas.openxmlformats.org/drawingml/2006/main">
+              <a:ext uri="{FF2B5EF4-FFF2-40B4-BE49-F238E27FC236}">
+                <a16:creationId xmlns:a16="http://schemas.microsoft.com/office/drawing/2014/main" id="{3A6A0C63-C5C1-45BC-8AC8-CC0568B2D179}"/>
               </a:ext>
             </a:extLst>
           </p:cNvPr>
@@ -9205,10 +9319,10 @@
       </p:sp>
       <p:sp>
         <p:nvSpPr>
-          <p:cNvPr id="24" name="">
-            <a:extLst xmlns:a="http://schemas.openxmlformats.org/drawingml/2006/main">
-              <a:ext uri="{FF2B5EF4-FFF2-40B4-BE49-F238E27FC236}">
-                <a16:creationId xmlns:a16="http://schemas.microsoft.com/office/drawing/2014/main" id="{C8FEA1E9-F244-4A48-BAC8-20BABD0BB17E}"/>
+          <p:cNvPr id="28" name="">
+            <a:extLst xmlns:a="http://schemas.openxmlformats.org/drawingml/2006/main">
+              <a:ext uri="{FF2B5EF4-FFF2-40B4-BE49-F238E27FC236}">
+                <a16:creationId xmlns:a16="http://schemas.microsoft.com/office/drawing/2014/main" id="{6BF1B39C-1AB4-47BB-AB63-8FBE211807F4}"/>
               </a:ext>
             </a:extLst>
           </p:cNvPr>
@@ -9238,138 +9352,22 @@
       </p:sp>
       <p:sp>
         <p:nvSpPr>
-          <p:cNvPr id="25" name="">
-            <a:extLst xmlns:a="http://schemas.openxmlformats.org/drawingml/2006/main">
-              <a:ext uri="{FF2B5EF4-FFF2-40B4-BE49-F238E27FC236}">
-                <a16:creationId xmlns:a16="http://schemas.microsoft.com/office/drawing/2014/main" id="{FEC4DCCE-D8A6-4BDD-A956-09FBC7FE57DD}"/>
-              </a:ext>
-            </a:extLst>
-          </p:cNvPr>
-          <p:cNvSpPr>
-            <a:spLocks xmlns:a="http://schemas.openxmlformats.org/drawingml/2006/main" noGrp="1"/>
-          </p:cNvSpPr>
-          <p:nvPr/>
-        </p:nvSpPr>
-        <p:spPr>
-          <a:xfrm xmlns:a="http://schemas.openxmlformats.org/drawingml/2006/main">
-            <a:off x="8477250" y="2400300"/>
+          <p:cNvPr id="29" name="">
+            <a:extLst xmlns:a="http://schemas.openxmlformats.org/drawingml/2006/main">
+              <a:ext uri="{FF2B5EF4-FFF2-40B4-BE49-F238E27FC236}">
+                <a16:creationId xmlns:a16="http://schemas.microsoft.com/office/drawing/2014/main" id="{F680CACF-1C8B-4C20-BAE3-D2019D64CABC}"/>
+              </a:ext>
+            </a:extLst>
+          </p:cNvPr>
+          <p:cNvSpPr>
+            <a:spLocks xmlns:a="http://schemas.openxmlformats.org/drawingml/2006/main" noGrp="1"/>
+          </p:cNvSpPr>
+          <p:nvPr/>
+        </p:nvSpPr>
+        <p:spPr>
+          <a:xfrm xmlns:a="http://schemas.openxmlformats.org/drawingml/2006/main">
+            <a:off x="8477250" y="2381250"/>
             <a:ext cx="2990850" cy="228600"/>
-          </a:xfrm>
-          <a:prstGeom xmlns:a="http://schemas.openxmlformats.org/drawingml/2006/main" prst="rect">
-            <a:avLst/>
-          </a:prstGeom>
-          <a:noFill xmlns:a="http://schemas.openxmlformats.org/drawingml/2006/main"/>
-          <a:ln xmlns:a="http://schemas.openxmlformats.org/drawingml/2006/main" w="0">
-            <a:noFill/>
-            <a:prstDash val="solid"/>
-          </a:ln>
-        </p:spPr>
-        <p:txBody>
-          <a:bodyPr xmlns:a="http://schemas.openxmlformats.org/drawingml/2006/main" wrap="square" lIns="0" tIns="0" rIns="0" bIns="0" anchor="t">
-            <a:normAutofit fontScale="100000"/>
-          </a:bodyPr>
-          <a:lstStyle xmlns:a="http://schemas.openxmlformats.org/drawingml/2006/main"/>
-          <a:p xmlns:a="http://schemas.openxmlformats.org/drawingml/2006/main">
-            <a:pPr algn="l">
-              <a:defRPr sz="975" b="1">
-                <a:solidFill>
-                  <a:srgbClr val="087F8C"/>
-                </a:solidFill>
-                <a:latin typeface="Aptos"/>
-                <a:ea typeface="Aptos"/>
-                <a:cs typeface="Aptos"/>
-              </a:defRPr>
-            </a:pPr>
-            <a:r>
-              <a:rPr sz="975" b="1">
-                <a:solidFill>
-                  <a:srgbClr val="087F8C"/>
-                </a:solidFill>
-                <a:latin typeface="Aptos"/>
-                <a:ea typeface="Aptos"/>
-                <a:cs typeface="Aptos"/>
-              </a:rPr>
-              <a:t>DUE 21 AUG</a:t>
-            </a:r>
-          </a:p>
-        </p:txBody>
-      </p:sp>
-      <p:sp>
-        <p:nvSpPr>
-          <p:cNvPr id="26" name="">
-            <a:extLst xmlns:a="http://schemas.openxmlformats.org/drawingml/2006/main">
-              <a:ext uri="{FF2B5EF4-FFF2-40B4-BE49-F238E27FC236}">
-                <a16:creationId xmlns:a16="http://schemas.microsoft.com/office/drawing/2014/main" id="{B4A06445-467E-4BC2-B016-AC19BADABABF}"/>
-              </a:ext>
-            </a:extLst>
-          </p:cNvPr>
-          <p:cNvSpPr>
-            <a:spLocks xmlns:a="http://schemas.openxmlformats.org/drawingml/2006/main" noGrp="1"/>
-          </p:cNvSpPr>
-          <p:nvPr/>
-        </p:nvSpPr>
-        <p:spPr>
-          <a:xfrm xmlns:a="http://schemas.openxmlformats.org/drawingml/2006/main">
-            <a:off x="8477250" y="2724150"/>
-            <a:ext cx="2990850" cy="476250"/>
-          </a:xfrm>
-          <a:prstGeom xmlns:a="http://schemas.openxmlformats.org/drawingml/2006/main" prst="rect">
-            <a:avLst/>
-          </a:prstGeom>
-          <a:noFill xmlns:a="http://schemas.openxmlformats.org/drawingml/2006/main"/>
-          <a:ln xmlns:a="http://schemas.openxmlformats.org/drawingml/2006/main" w="0">
-            <a:noFill/>
-            <a:prstDash val="solid"/>
-          </a:ln>
-        </p:spPr>
-        <p:txBody>
-          <a:bodyPr xmlns:a="http://schemas.openxmlformats.org/drawingml/2006/main" wrap="square" lIns="0" tIns="0" rIns="0" bIns="0" anchor="t">
-            <a:normAutofit fontScale="100000"/>
-          </a:bodyPr>
-          <a:lstStyle xmlns:a="http://schemas.openxmlformats.org/drawingml/2006/main"/>
-          <a:p xmlns:a="http://schemas.openxmlformats.org/drawingml/2006/main">
-            <a:pPr algn="l">
-              <a:defRPr sz="2550" b="1">
-                <a:solidFill>
-                  <a:srgbClr val="153640"/>
-                </a:solidFill>
-                <a:latin typeface="Aptos"/>
-                <a:ea typeface="Aptos"/>
-                <a:cs typeface="Aptos"/>
-              </a:defRPr>
-            </a:pPr>
-            <a:r>
-              <a:rPr sz="2550" b="1">
-                <a:solidFill>
-                  <a:srgbClr val="153640"/>
-                </a:solidFill>
-                <a:latin typeface="Aptos"/>
-                <a:ea typeface="Aptos"/>
-                <a:cs typeface="Aptos"/>
-              </a:rPr>
-              <a:t>61/100</a:t>
-            </a:r>
-          </a:p>
-        </p:txBody>
-      </p:sp>
-      <p:sp>
-        <p:nvSpPr>
-          <p:cNvPr id="27" name="">
-            <a:extLst xmlns:a="http://schemas.openxmlformats.org/drawingml/2006/main">
-              <a:ext uri="{FF2B5EF4-FFF2-40B4-BE49-F238E27FC236}">
-                <a16:creationId xmlns:a16="http://schemas.microsoft.com/office/drawing/2014/main" id="{CEAE0FD9-8F26-41BE-B47B-0925A30F33F6}"/>
-              </a:ext>
-            </a:extLst>
-          </p:cNvPr>
-          <p:cNvSpPr>
-            <a:spLocks xmlns:a="http://schemas.openxmlformats.org/drawingml/2006/main" noGrp="1"/>
-          </p:cNvSpPr>
-          <p:nvPr/>
-        </p:nvSpPr>
-        <p:spPr>
-          <a:xfrm xmlns:a="http://schemas.openxmlformats.org/drawingml/2006/main">
-            <a:off x="8477250" y="3143250"/>
-            <a:ext cx="2990850" cy="209550"/>
           </a:xfrm>
           <a:prstGeom xmlns:a="http://schemas.openxmlformats.org/drawingml/2006/main" prst="rect">
             <a:avLst/>
@@ -9389,6 +9387,64 @@
             <a:pPr algn="l">
               <a:defRPr sz="900" b="1">
                 <a:solidFill>
+                  <a:srgbClr val="087F8C"/>
+                </a:solidFill>
+                <a:latin typeface="Aptos"/>
+                <a:ea typeface="Aptos"/>
+                <a:cs typeface="Aptos"/>
+              </a:defRPr>
+            </a:pPr>
+            <a:r>
+              <a:rPr sz="900" b="1">
+                <a:solidFill>
+                  <a:srgbClr val="087F8C"/>
+                </a:solidFill>
+                <a:latin typeface="Aptos"/>
+                <a:ea typeface="Aptos"/>
+                <a:cs typeface="Aptos"/>
+              </a:rPr>
+              <a:t>DUE AUGUST 21, 2026</a:t>
+            </a:r>
+          </a:p>
+        </p:txBody>
+      </p:sp>
+      <p:sp>
+        <p:nvSpPr>
+          <p:cNvPr id="30" name="">
+            <a:extLst xmlns:a="http://schemas.openxmlformats.org/drawingml/2006/main">
+              <a:ext uri="{FF2B5EF4-FFF2-40B4-BE49-F238E27FC236}">
+                <a16:creationId xmlns:a16="http://schemas.microsoft.com/office/drawing/2014/main" id="{31FA7480-3825-415B-A637-D1F8847A431F}"/>
+              </a:ext>
+            </a:extLst>
+          </p:cNvPr>
+          <p:cNvSpPr>
+            <a:spLocks xmlns:a="http://schemas.openxmlformats.org/drawingml/2006/main" noGrp="1"/>
+          </p:cNvSpPr>
+          <p:nvPr/>
+        </p:nvSpPr>
+        <p:spPr>
+          <a:xfrm xmlns:a="http://schemas.openxmlformats.org/drawingml/2006/main">
+            <a:off x="8477250" y="2695575"/>
+            <a:ext cx="2990850" cy="171450"/>
+          </a:xfrm>
+          <a:prstGeom xmlns:a="http://schemas.openxmlformats.org/drawingml/2006/main" prst="rect">
+            <a:avLst/>
+          </a:prstGeom>
+          <a:noFill xmlns:a="http://schemas.openxmlformats.org/drawingml/2006/main"/>
+          <a:ln xmlns:a="http://schemas.openxmlformats.org/drawingml/2006/main" w="0">
+            <a:noFill/>
+            <a:prstDash val="solid"/>
+          </a:ln>
+        </p:spPr>
+        <p:txBody>
+          <a:bodyPr xmlns:a="http://schemas.openxmlformats.org/drawingml/2006/main" wrap="square" lIns="0" tIns="0" rIns="0" bIns="0" anchor="t">
+            <a:normAutofit fontScale="100000"/>
+          </a:bodyPr>
+          <a:lstStyle xmlns:a="http://schemas.openxmlformats.org/drawingml/2006/main"/>
+          <a:p xmlns:a="http://schemas.openxmlformats.org/drawingml/2006/main">
+            <a:pPr algn="l">
+              <a:defRPr sz="825" b="1">
+                <a:solidFill>
                   <a:srgbClr val="60767D"/>
                 </a:solidFill>
                 <a:latin typeface="Aptos"/>
@@ -9397,7 +9453,7 @@
               </a:defRPr>
             </a:pPr>
             <a:r>
-              <a:rPr sz="900" b="1">
+              <a:rPr sz="825" b="1">
                 <a:solidFill>
                   <a:srgbClr val="60767D"/>
                 </a:solidFill>
@@ -9405,29 +9461,29 @@
                 <a:ea typeface="Aptos"/>
                 <a:cs typeface="Aptos"/>
               </a:rPr>
-              <a:t>PRIORITY SCORE</a:t>
-            </a:r>
-          </a:p>
-        </p:txBody>
-      </p:sp>
-      <p:sp>
-        <p:nvSpPr>
-          <p:cNvPr id="28" name="">
-            <a:extLst xmlns:a="http://schemas.openxmlformats.org/drawingml/2006/main">
-              <a:ext uri="{FF2B5EF4-FFF2-40B4-BE49-F238E27FC236}">
-                <a16:creationId xmlns:a16="http://schemas.microsoft.com/office/drawing/2014/main" id="{EA7D139C-1A22-4147-8588-6DECDFF875CD}"/>
-              </a:ext>
-            </a:extLst>
-          </p:cNvPr>
-          <p:cNvSpPr>
-            <a:spLocks xmlns:a="http://schemas.openxmlformats.org/drawingml/2006/main" noGrp="1"/>
-          </p:cNvSpPr>
-          <p:nvPr/>
-        </p:nvSpPr>
-        <p:spPr>
-          <a:xfrm xmlns:a="http://schemas.openxmlformats.org/drawingml/2006/main">
-            <a:off x="8477250" y="3524250"/>
-            <a:ext cx="2990850" cy="742950"/>
+              <a:t>EVIDENCE PRIORITY</a:t>
+            </a:r>
+          </a:p>
+        </p:txBody>
+      </p:sp>
+      <p:sp>
+        <p:nvSpPr>
+          <p:cNvPr id="31" name="">
+            <a:extLst xmlns:a="http://schemas.openxmlformats.org/drawingml/2006/main">
+              <a:ext uri="{FF2B5EF4-FFF2-40B4-BE49-F238E27FC236}">
+                <a16:creationId xmlns:a16="http://schemas.microsoft.com/office/drawing/2014/main" id="{7BB80737-D103-4F92-B318-97763E7C6E31}"/>
+              </a:ext>
+            </a:extLst>
+          </p:cNvPr>
+          <p:cNvSpPr>
+            <a:spLocks xmlns:a="http://schemas.openxmlformats.org/drawingml/2006/main" noGrp="1"/>
+          </p:cNvSpPr>
+          <p:nvPr/>
+        </p:nvSpPr>
+        <p:spPr>
+          <a:xfrm xmlns:a="http://schemas.openxmlformats.org/drawingml/2006/main">
+            <a:off x="8477250" y="2895600"/>
+            <a:ext cx="2990850" cy="342900"/>
           </a:xfrm>
           <a:prstGeom xmlns:a="http://schemas.openxmlformats.org/drawingml/2006/main" prst="rect">
             <a:avLst/>
@@ -9445,7 +9501,7 @@
           <a:lstStyle xmlns:a="http://schemas.openxmlformats.org/drawingml/2006/main"/>
           <a:p xmlns:a="http://schemas.openxmlformats.org/drawingml/2006/main">
             <a:pPr algn="l">
-              <a:defRPr sz="1575" b="1">
+              <a:defRPr sz="2025" b="1">
                 <a:solidFill>
                   <a:srgbClr val="153640"/>
                 </a:solidFill>
@@ -9455,7 +9511,7 @@
               </a:defRPr>
             </a:pPr>
             <a:r>
-              <a:rPr sz="1575" b="1">
+              <a:rPr sz="2025" b="1">
                 <a:solidFill>
                   <a:srgbClr val="153640"/>
                 </a:solidFill>
@@ -9463,28 +9519,144 @@
                 <a:ea typeface="Aptos"/>
                 <a:cs typeface="Aptos"/>
               </a:rPr>
-              <a:t>Does Next Gen LC need an oligonucleotide method-readiness package?</a:t>
-            </a:r>
-          </a:p>
-        </p:txBody>
-      </p:sp>
-      <p:sp>
-        <p:nvSpPr>
-          <p:cNvPr id="29" name="">
-            <a:extLst xmlns:a="http://schemas.openxmlformats.org/drawingml/2006/main">
-              <a:ext uri="{FF2B5EF4-FFF2-40B4-BE49-F238E27FC236}">
-                <a16:creationId xmlns:a16="http://schemas.microsoft.com/office/drawing/2014/main" id="{19B354F3-9AF4-4105-A23A-687A6808F5DC}"/>
-              </a:ext>
-            </a:extLst>
-          </p:cNvPr>
-          <p:cNvSpPr>
-            <a:spLocks xmlns:a="http://schemas.openxmlformats.org/drawingml/2006/main" noGrp="1"/>
-          </p:cNvSpPr>
-          <p:nvPr/>
-        </p:nvSpPr>
-        <p:spPr>
-          <a:xfrm xmlns:a="http://schemas.openxmlformats.org/drawingml/2006/main">
-            <a:off x="8477250" y="4400550"/>
+              <a:t>Medium</a:t>
+            </a:r>
+          </a:p>
+        </p:txBody>
+      </p:sp>
+      <p:sp>
+        <p:nvSpPr>
+          <p:cNvPr id="32" name="">
+            <a:extLst xmlns:a="http://schemas.openxmlformats.org/drawingml/2006/main">
+              <a:ext uri="{FF2B5EF4-FFF2-40B4-BE49-F238E27FC236}">
+                <a16:creationId xmlns:a16="http://schemas.microsoft.com/office/drawing/2014/main" id="{AD45227B-3BF5-4BC7-BD87-39D7DB1E4911}"/>
+              </a:ext>
+            </a:extLst>
+          </p:cNvPr>
+          <p:cNvSpPr>
+            <a:spLocks xmlns:a="http://schemas.openxmlformats.org/drawingml/2006/main" noGrp="1"/>
+          </p:cNvSpPr>
+          <p:nvPr/>
+        </p:nvSpPr>
+        <p:spPr>
+          <a:xfrm xmlns:a="http://schemas.openxmlformats.org/drawingml/2006/main">
+            <a:off x="8477250" y="3276600"/>
+            <a:ext cx="2990850" cy="190500"/>
+          </a:xfrm>
+          <a:prstGeom xmlns:a="http://schemas.openxmlformats.org/drawingml/2006/main" prst="rect">
+            <a:avLst/>
+          </a:prstGeom>
+          <a:noFill xmlns:a="http://schemas.openxmlformats.org/drawingml/2006/main"/>
+          <a:ln xmlns:a="http://schemas.openxmlformats.org/drawingml/2006/main" w="0">
+            <a:noFill/>
+            <a:prstDash val="solid"/>
+          </a:ln>
+        </p:spPr>
+        <p:txBody>
+          <a:bodyPr xmlns:a="http://schemas.openxmlformats.org/drawingml/2006/main" wrap="square" lIns="0" tIns="0" rIns="0" bIns="0" anchor="t">
+            <a:normAutofit fontScale="100000"/>
+          </a:bodyPr>
+          <a:lstStyle xmlns:a="http://schemas.openxmlformats.org/drawingml/2006/main"/>
+          <a:p xmlns:a="http://schemas.openxmlformats.org/drawingml/2006/main">
+            <a:pPr algn="l">
+              <a:defRPr sz="825" b="1">
+                <a:solidFill>
+                  <a:srgbClr val="BA3A42"/>
+                </a:solidFill>
+                <a:latin typeface="Aptos"/>
+                <a:ea typeface="Aptos"/>
+                <a:cs typeface="Aptos"/>
+              </a:defRPr>
+            </a:pPr>
+            <a:r>
+              <a:rPr sz="825" b="1">
+                <a:solidFill>
+                  <a:srgbClr val="BA3A42"/>
+                </a:solidFill>
+                <a:latin typeface="Aptos"/>
+                <a:ea typeface="Aptos"/>
+                <a:cs typeface="Aptos"/>
+              </a:rPr>
+              <a:t>BUSINESS IMPACT · UNQUANTIFIED</a:t>
+            </a:r>
+          </a:p>
+        </p:txBody>
+      </p:sp>
+      <p:sp>
+        <p:nvSpPr>
+          <p:cNvPr id="33" name="">
+            <a:extLst xmlns:a="http://schemas.openxmlformats.org/drawingml/2006/main">
+              <a:ext uri="{FF2B5EF4-FFF2-40B4-BE49-F238E27FC236}">
+                <a16:creationId xmlns:a16="http://schemas.microsoft.com/office/drawing/2014/main" id="{15C44D45-CBD1-441D-9443-61795A64EDBF}"/>
+              </a:ext>
+            </a:extLst>
+          </p:cNvPr>
+          <p:cNvSpPr>
+            <a:spLocks xmlns:a="http://schemas.openxmlformats.org/drawingml/2006/main" noGrp="1"/>
+          </p:cNvSpPr>
+          <p:nvPr/>
+        </p:nvSpPr>
+        <p:spPr>
+          <a:xfrm xmlns:a="http://schemas.openxmlformats.org/drawingml/2006/main">
+            <a:off x="8477250" y="3571875"/>
+            <a:ext cx="2990850" cy="590550"/>
+          </a:xfrm>
+          <a:prstGeom xmlns:a="http://schemas.openxmlformats.org/drawingml/2006/main" prst="rect">
+            <a:avLst/>
+          </a:prstGeom>
+          <a:noFill xmlns:a="http://schemas.openxmlformats.org/drawingml/2006/main"/>
+          <a:ln xmlns:a="http://schemas.openxmlformats.org/drawingml/2006/main" w="0">
+            <a:noFill/>
+            <a:prstDash val="solid"/>
+          </a:ln>
+        </p:spPr>
+        <p:txBody>
+          <a:bodyPr xmlns:a="http://schemas.openxmlformats.org/drawingml/2006/main" wrap="square" lIns="0" tIns="0" rIns="0" bIns="0" anchor="t">
+            <a:normAutofit fontScale="90643"/>
+          </a:bodyPr>
+          <a:lstStyle xmlns:a="http://schemas.openxmlformats.org/drawingml/2006/main"/>
+          <a:p xmlns:a="http://schemas.openxmlformats.org/drawingml/2006/main">
+            <a:pPr algn="l">
+              <a:defRPr sz="1425" b="1">
+                <a:solidFill>
+                  <a:srgbClr val="153640"/>
+                </a:solidFill>
+                <a:latin typeface="Aptos"/>
+                <a:ea typeface="Aptos"/>
+                <a:cs typeface="Aptos"/>
+              </a:defRPr>
+            </a:pPr>
+            <a:r>
+              <a:rPr sz="1425" b="1">
+                <a:solidFill>
+                  <a:srgbClr val="153640"/>
+                </a:solidFill>
+                <a:latin typeface="Aptos"/>
+                <a:ea typeface="Aptos"/>
+                <a:cs typeface="Aptos"/>
+              </a:rPr>
+              <a:t>Decide whether Next Gen LC needs an oligonucleotide method-readiness package</a:t>
+            </a:r>
+          </a:p>
+        </p:txBody>
+      </p:sp>
+      <p:sp>
+        <p:nvSpPr>
+          <p:cNvPr id="34" name="">
+            <a:extLst xmlns:a="http://schemas.openxmlformats.org/drawingml/2006/main">
+              <a:ext uri="{FF2B5EF4-FFF2-40B4-BE49-F238E27FC236}">
+                <a16:creationId xmlns:a16="http://schemas.microsoft.com/office/drawing/2014/main" id="{69E00A57-42FE-42A8-A8EB-FC89FEE9AEFF}"/>
+              </a:ext>
+            </a:extLst>
+          </p:cNvPr>
+          <p:cNvSpPr>
+            <a:spLocks xmlns:a="http://schemas.openxmlformats.org/drawingml/2006/main" noGrp="1"/>
+          </p:cNvSpPr>
+          <p:nvPr/>
+        </p:nvSpPr>
+        <p:spPr>
+          <a:xfrm xmlns:a="http://schemas.openxmlformats.org/drawingml/2006/main">
+            <a:off x="8477250" y="4267200"/>
             <a:ext cx="2990850" cy="9525"/>
           </a:xfrm>
           <a:prstGeom xmlns:a="http://schemas.openxmlformats.org/drawingml/2006/main" prst="rect">
@@ -9503,138 +9675,22 @@
       </p:sp>
       <p:sp>
         <p:nvSpPr>
-          <p:cNvPr id="30" name="">
-            <a:extLst xmlns:a="http://schemas.openxmlformats.org/drawingml/2006/main">
-              <a:ext uri="{FF2B5EF4-FFF2-40B4-BE49-F238E27FC236}">
-                <a16:creationId xmlns:a16="http://schemas.microsoft.com/office/drawing/2014/main" id="{61BB30D4-07AC-4ADD-9330-50F5D2E39EDB}"/>
-              </a:ext>
-            </a:extLst>
-          </p:cNvPr>
-          <p:cNvSpPr>
-            <a:spLocks xmlns:a="http://schemas.openxmlformats.org/drawingml/2006/main" noGrp="1"/>
-          </p:cNvSpPr>
-          <p:nvPr/>
-        </p:nvSpPr>
-        <p:spPr>
-          <a:xfrm xmlns:a="http://schemas.openxmlformats.org/drawingml/2006/main">
-            <a:off x="8477250" y="4552950"/>
+          <p:cNvPr id="35" name="">
+            <a:extLst xmlns:a="http://schemas.openxmlformats.org/drawingml/2006/main">
+              <a:ext uri="{FF2B5EF4-FFF2-40B4-BE49-F238E27FC236}">
+                <a16:creationId xmlns:a16="http://schemas.microsoft.com/office/drawing/2014/main" id="{D408F0F7-B00A-4563-A298-619FE26D8E9A}"/>
+              </a:ext>
+            </a:extLst>
+          </p:cNvPr>
+          <p:cNvSpPr>
+            <a:spLocks xmlns:a="http://schemas.openxmlformats.org/drawingml/2006/main" noGrp="1"/>
+          </p:cNvSpPr>
+          <p:nvPr/>
+        </p:nvSpPr>
+        <p:spPr>
+          <a:xfrm xmlns:a="http://schemas.openxmlformats.org/drawingml/2006/main">
+            <a:off x="8477250" y="4410075"/>
             <a:ext cx="2990850" cy="190500"/>
-          </a:xfrm>
-          <a:prstGeom xmlns:a="http://schemas.openxmlformats.org/drawingml/2006/main" prst="rect">
-            <a:avLst/>
-          </a:prstGeom>
-          <a:noFill xmlns:a="http://schemas.openxmlformats.org/drawingml/2006/main"/>
-          <a:ln xmlns:a="http://schemas.openxmlformats.org/drawingml/2006/main" w="0">
-            <a:noFill/>
-            <a:prstDash val="solid"/>
-          </a:ln>
-        </p:spPr>
-        <p:txBody>
-          <a:bodyPr xmlns:a="http://schemas.openxmlformats.org/drawingml/2006/main" wrap="square" lIns="0" tIns="0" rIns="0" bIns="0" anchor="t">
-            <a:normAutofit fontScale="100000"/>
-          </a:bodyPr>
-          <a:lstStyle xmlns:a="http://schemas.openxmlformats.org/drawingml/2006/main"/>
-          <a:p xmlns:a="http://schemas.openxmlformats.org/drawingml/2006/main">
-            <a:pPr algn="l">
-              <a:defRPr sz="900" b="1">
-                <a:solidFill>
-                  <a:srgbClr val="60767D"/>
-                </a:solidFill>
-                <a:latin typeface="Aptos"/>
-                <a:ea typeface="Aptos"/>
-                <a:cs typeface="Aptos"/>
-              </a:defRPr>
-            </a:pPr>
-            <a:r>
-              <a:rPr sz="900" b="1">
-                <a:solidFill>
-                  <a:srgbClr val="60767D"/>
-                </a:solidFill>
-                <a:latin typeface="Aptos"/>
-                <a:ea typeface="Aptos"/>
-                <a:cs typeface="Aptos"/>
-              </a:rPr>
-              <a:t>REQUIRED OUTPUT</a:t>
-            </a:r>
-          </a:p>
-        </p:txBody>
-      </p:sp>
-      <p:sp>
-        <p:nvSpPr>
-          <p:cNvPr id="31" name="">
-            <a:extLst xmlns:a="http://schemas.openxmlformats.org/drawingml/2006/main">
-              <a:ext uri="{FF2B5EF4-FFF2-40B4-BE49-F238E27FC236}">
-                <a16:creationId xmlns:a16="http://schemas.microsoft.com/office/drawing/2014/main" id="{CF40707D-BC91-4FEB-8782-D3CD433722D0}"/>
-              </a:ext>
-            </a:extLst>
-          </p:cNvPr>
-          <p:cNvSpPr>
-            <a:spLocks xmlns:a="http://schemas.openxmlformats.org/drawingml/2006/main" noGrp="1"/>
-          </p:cNvSpPr>
-          <p:nvPr/>
-        </p:nvSpPr>
-        <p:spPr>
-          <a:xfrm xmlns:a="http://schemas.openxmlformats.org/drawingml/2006/main">
-            <a:off x="8477250" y="4819650"/>
-            <a:ext cx="2990850" cy="685800"/>
-          </a:xfrm>
-          <a:prstGeom xmlns:a="http://schemas.openxmlformats.org/drawingml/2006/main" prst="rect">
-            <a:avLst/>
-          </a:prstGeom>
-          <a:noFill xmlns:a="http://schemas.openxmlformats.org/drawingml/2006/main"/>
-          <a:ln xmlns:a="http://schemas.openxmlformats.org/drawingml/2006/main" w="0">
-            <a:noFill/>
-            <a:prstDash val="solid"/>
-          </a:ln>
-        </p:spPr>
-        <p:txBody>
-          <a:bodyPr xmlns:a="http://schemas.openxmlformats.org/drawingml/2006/main" wrap="square" lIns="0" tIns="0" rIns="0" bIns="0" anchor="t">
-            <a:normAutofit fontScale="100000"/>
-          </a:bodyPr>
-          <a:lstStyle xmlns:a="http://schemas.openxmlformats.org/drawingml/2006/main"/>
-          <a:p xmlns:a="http://schemas.openxmlformats.org/drawingml/2006/main">
-            <a:pPr algn="l">
-              <a:defRPr sz="1125" b="0">
-                <a:solidFill>
-                  <a:srgbClr val="153640"/>
-                </a:solidFill>
-                <a:latin typeface="Aptos"/>
-                <a:ea typeface="Aptos"/>
-                <a:cs typeface="Aptos"/>
-              </a:defRPr>
-            </a:pPr>
-            <a:r>
-              <a:rPr sz="1125" b="0">
-                <a:solidFill>
-                  <a:srgbClr val="153640"/>
-                </a:solidFill>
-                <a:latin typeface="Aptos"/>
-                <a:ea typeface="Aptos"/>
-                <a:cs typeface="Aptos"/>
-              </a:rPr>
-              <a:t>A readiness dossier covering compatibility, carryover, throughput, transfer and software.</a:t>
-            </a:r>
-          </a:p>
-        </p:txBody>
-      </p:sp>
-      <p:sp>
-        <p:nvSpPr>
-          <p:cNvPr id="32" name="">
-            <a:extLst xmlns:a="http://schemas.openxmlformats.org/drawingml/2006/main">
-              <a:ext uri="{FF2B5EF4-FFF2-40B4-BE49-F238E27FC236}">
-                <a16:creationId xmlns:a16="http://schemas.microsoft.com/office/drawing/2014/main" id="{5E13F28E-5AEE-4D39-9A64-4AE04D42D02F}"/>
-              </a:ext>
-            </a:extLst>
-          </p:cNvPr>
-          <p:cNvSpPr>
-            <a:spLocks xmlns:a="http://schemas.openxmlformats.org/drawingml/2006/main" noGrp="1"/>
-          </p:cNvSpPr>
-          <p:nvPr/>
-        </p:nvSpPr>
-        <p:spPr>
-          <a:xfrm xmlns:a="http://schemas.openxmlformats.org/drawingml/2006/main">
-            <a:off x="514350" y="6477000"/>
-            <a:ext cx="8191500" cy="190500"/>
           </a:xfrm>
           <a:prstGeom xmlns:a="http://schemas.openxmlformats.org/drawingml/2006/main" prst="rect">
             <a:avLst/>
@@ -9670,17 +9726,191 @@
                 <a:ea typeface="Aptos"/>
                 <a:cs typeface="Aptos"/>
               </a:rPr>
-              <a:t>WATERS NEXT GEN COMPETITIVE INTELLIGENCE · 23 JUL 2026</a:t>
-            </a:r>
-          </a:p>
-        </p:txBody>
-      </p:sp>
-      <p:sp>
-        <p:nvSpPr>
-          <p:cNvPr id="33" name="">
-            <a:extLst xmlns:a="http://schemas.openxmlformats.org/drawingml/2006/main">
-              <a:ext uri="{FF2B5EF4-FFF2-40B4-BE49-F238E27FC236}">
-                <a16:creationId xmlns:a16="http://schemas.microsoft.com/office/drawing/2014/main" id="{C96EB7E2-8BE9-43B7-A60D-0BBB76ACBD9E}"/>
+              <a:t>OWNER · Biopharma Applications and Next Gen LC PM</a:t>
+            </a:r>
+          </a:p>
+        </p:txBody>
+      </p:sp>
+      <p:sp>
+        <p:nvSpPr>
+          <p:cNvPr id="36" name="">
+            <a:extLst xmlns:a="http://schemas.openxmlformats.org/drawingml/2006/main">
+              <a:ext uri="{FF2B5EF4-FFF2-40B4-BE49-F238E27FC236}">
+                <a16:creationId xmlns:a16="http://schemas.microsoft.com/office/drawing/2014/main" id="{40613F49-EECF-4E13-A00D-EC98B7CDF7E5}"/>
+              </a:ext>
+            </a:extLst>
+          </p:cNvPr>
+          <p:cNvSpPr>
+            <a:spLocks xmlns:a="http://schemas.openxmlformats.org/drawingml/2006/main" noGrp="1"/>
+          </p:cNvSpPr>
+          <p:nvPr/>
+        </p:nvSpPr>
+        <p:spPr>
+          <a:xfrm xmlns:a="http://schemas.openxmlformats.org/drawingml/2006/main">
+            <a:off x="8477250" y="4705350"/>
+            <a:ext cx="2990850" cy="171450"/>
+          </a:xfrm>
+          <a:prstGeom xmlns:a="http://schemas.openxmlformats.org/drawingml/2006/main" prst="rect">
+            <a:avLst/>
+          </a:prstGeom>
+          <a:noFill xmlns:a="http://schemas.openxmlformats.org/drawingml/2006/main"/>
+          <a:ln xmlns:a="http://schemas.openxmlformats.org/drawingml/2006/main" w="0">
+            <a:noFill/>
+            <a:prstDash val="solid"/>
+          </a:ln>
+        </p:spPr>
+        <p:txBody>
+          <a:bodyPr xmlns:a="http://schemas.openxmlformats.org/drawingml/2006/main" wrap="square" lIns="0" tIns="0" rIns="0" bIns="0" anchor="t">
+            <a:normAutofit fontScale="100000"/>
+          </a:bodyPr>
+          <a:lstStyle xmlns:a="http://schemas.openxmlformats.org/drawingml/2006/main"/>
+          <a:p xmlns:a="http://schemas.openxmlformats.org/drawingml/2006/main">
+            <a:pPr algn="l">
+              <a:defRPr sz="825" b="1">
+                <a:solidFill>
+                  <a:srgbClr val="60767D"/>
+                </a:solidFill>
+                <a:latin typeface="Aptos"/>
+                <a:ea typeface="Aptos"/>
+                <a:cs typeface="Aptos"/>
+              </a:defRPr>
+            </a:pPr>
+            <a:r>
+              <a:rPr sz="825" b="1">
+                <a:solidFill>
+                  <a:srgbClr val="60767D"/>
+                </a:solidFill>
+                <a:latin typeface="Aptos"/>
+                <a:ea typeface="Aptos"/>
+                <a:cs typeface="Aptos"/>
+              </a:rPr>
+              <a:t>FINAL GO / NO-GO OUTPUT</a:t>
+            </a:r>
+          </a:p>
+        </p:txBody>
+      </p:sp>
+      <p:sp>
+        <p:nvSpPr>
+          <p:cNvPr id="37" name="">
+            <a:extLst xmlns:a="http://schemas.openxmlformats.org/drawingml/2006/main">
+              <a:ext uri="{FF2B5EF4-FFF2-40B4-BE49-F238E27FC236}">
+                <a16:creationId xmlns:a16="http://schemas.microsoft.com/office/drawing/2014/main" id="{FA1855D1-502E-4B8E-86CA-EB2A853D13A1}"/>
+              </a:ext>
+            </a:extLst>
+          </p:cNvPr>
+          <p:cNvSpPr>
+            <a:spLocks xmlns:a="http://schemas.openxmlformats.org/drawingml/2006/main" noGrp="1"/>
+          </p:cNvSpPr>
+          <p:nvPr/>
+        </p:nvSpPr>
+        <p:spPr>
+          <a:xfrm xmlns:a="http://schemas.openxmlformats.org/drawingml/2006/main">
+            <a:off x="8477250" y="4933950"/>
+            <a:ext cx="2990850" cy="571500"/>
+          </a:xfrm>
+          <a:prstGeom xmlns:a="http://schemas.openxmlformats.org/drawingml/2006/main" prst="rect">
+            <a:avLst/>
+          </a:prstGeom>
+          <a:noFill xmlns:a="http://schemas.openxmlformats.org/drawingml/2006/main"/>
+          <a:ln xmlns:a="http://schemas.openxmlformats.org/drawingml/2006/main" w="0">
+            <a:noFill/>
+            <a:prstDash val="solid"/>
+          </a:ln>
+        </p:spPr>
+        <p:txBody>
+          <a:bodyPr xmlns:a="http://schemas.openxmlformats.org/drawingml/2006/main" wrap="square" lIns="0" tIns="0" rIns="0" bIns="0" anchor="t">
+            <a:normAutofit fontScale="100000"/>
+          </a:bodyPr>
+          <a:lstStyle xmlns:a="http://schemas.openxmlformats.org/drawingml/2006/main"/>
+          <a:p xmlns:a="http://schemas.openxmlformats.org/drawingml/2006/main">
+            <a:pPr algn="l">
+              <a:defRPr sz="975" b="0">
+                <a:solidFill>
+                  <a:srgbClr val="153640"/>
+                </a:solidFill>
+                <a:latin typeface="Aptos"/>
+                <a:ea typeface="Aptos"/>
+                <a:cs typeface="Aptos"/>
+              </a:defRPr>
+            </a:pPr>
+            <a:r>
+              <a:rPr sz="975" b="0">
+                <a:solidFill>
+                  <a:srgbClr val="153640"/>
+                </a:solidFill>
+                <a:latin typeface="Aptos"/>
+                <a:ea typeface="Aptos"/>
+                <a:cs typeface="Aptos"/>
+              </a:rPr>
+              <a:t>Choose package existing capability, build, partner, monitor, or stop for an oligonucleotide method-readiness offer</a:t>
+            </a:r>
+          </a:p>
+        </p:txBody>
+      </p:sp>
+      <p:sp>
+        <p:nvSpPr>
+          <p:cNvPr id="38" name="">
+            <a:extLst xmlns:a="http://schemas.openxmlformats.org/drawingml/2006/main">
+              <a:ext uri="{FF2B5EF4-FFF2-40B4-BE49-F238E27FC236}">
+                <a16:creationId xmlns:a16="http://schemas.microsoft.com/office/drawing/2014/main" id="{E7D0DEE3-839C-4F6E-8BF1-E09605CFB623}"/>
+              </a:ext>
+            </a:extLst>
+          </p:cNvPr>
+          <p:cNvSpPr>
+            <a:spLocks xmlns:a="http://schemas.openxmlformats.org/drawingml/2006/main" noGrp="1"/>
+          </p:cNvSpPr>
+          <p:nvPr/>
+        </p:nvSpPr>
+        <p:spPr>
+          <a:xfrm xmlns:a="http://schemas.openxmlformats.org/drawingml/2006/main">
+            <a:off x="514350" y="6477000"/>
+            <a:ext cx="9810750" cy="190500"/>
+          </a:xfrm>
+          <a:prstGeom xmlns:a="http://schemas.openxmlformats.org/drawingml/2006/main" prst="rect">
+            <a:avLst/>
+          </a:prstGeom>
+          <a:noFill xmlns:a="http://schemas.openxmlformats.org/drawingml/2006/main"/>
+          <a:ln xmlns:a="http://schemas.openxmlformats.org/drawingml/2006/main" w="0">
+            <a:noFill/>
+            <a:prstDash val="solid"/>
+          </a:ln>
+        </p:spPr>
+        <p:txBody>
+          <a:bodyPr xmlns:a="http://schemas.openxmlformats.org/drawingml/2006/main" wrap="square" lIns="0" tIns="0" rIns="0" bIns="0" anchor="t">
+            <a:normAutofit fontScale="100000"/>
+          </a:bodyPr>
+          <a:lstStyle xmlns:a="http://schemas.openxmlformats.org/drawingml/2006/main"/>
+          <a:p xmlns:a="http://schemas.openxmlformats.org/drawingml/2006/main">
+            <a:pPr algn="l">
+              <a:defRPr sz="825" b="1">
+                <a:solidFill>
+                  <a:srgbClr val="60767D"/>
+                </a:solidFill>
+                <a:latin typeface="Aptos"/>
+                <a:ea typeface="Aptos"/>
+                <a:cs typeface="Aptos"/>
+              </a:defRPr>
+            </a:pPr>
+            <a:r>
+              <a:rPr sz="825" b="1">
+                <a:solidFill>
+                  <a:srgbClr val="60767D"/>
+                </a:solidFill>
+                <a:latin typeface="Aptos"/>
+                <a:ea typeface="Aptos"/>
+                <a:cs typeface="Aptos"/>
+              </a:rPr>
+              <a:t>WATERS NEXT GEN COMPETITIVE INTELLIGENCE · 28 JUL 2026 · waters-ci-20260728-202611</a:t>
+            </a:r>
+          </a:p>
+        </p:txBody>
+      </p:sp>
+      <p:sp>
+        <p:nvSpPr>
+          <p:cNvPr id="39" name="">
+            <a:extLst xmlns:a="http://schemas.openxmlformats.org/drawingml/2006/main">
+              <a:ext uri="{FF2B5EF4-FFF2-40B4-BE49-F238E27FC236}">
+                <a16:creationId xmlns:a16="http://schemas.microsoft.com/office/drawing/2014/main" id="{ECEF07F5-E24B-41DC-907A-FFE872278BD6}"/>
               </a:ext>
             </a:extLst>
           </p:cNvPr>
@@ -9736,7 +9966,7 @@
     </p:spTree>
     <p:extLst>
       <p:ext uri="{BB962C8B-B14F-4D97-AF65-F5344CB8AC3E}">
-        <p14:creationId xmlns:p14="http://schemas.microsoft.com/office/powerpoint/2010/main" val="1468589853"/>
+        <p14:creationId xmlns:p14="http://schemas.microsoft.com/office/powerpoint/2010/main" val="1798459616"/>
       </p:ext>
     </p:extLst>
   </p:cSld>
@@ -9767,7 +9997,7 @@
           <p:cNvPr id="26" name="">
             <a:extLst xmlns:a="http://schemas.openxmlformats.org/drawingml/2006/main">
               <a:ext uri="{FF2B5EF4-FFF2-40B4-BE49-F238E27FC236}">
-                <a16:creationId xmlns:a16="http://schemas.microsoft.com/office/drawing/2014/main" id="{80ACD8A9-D120-4A70-BF6D-698BA48A8E7F}"/>
+                <a16:creationId xmlns:a16="http://schemas.microsoft.com/office/drawing/2014/main" id="{E03E0AB9-6DD5-47BA-8B1E-0E6D00233FBF}"/>
               </a:ext>
             </a:extLst>
           </p:cNvPr>
@@ -9825,7 +10055,7 @@
           <p:cNvPr id="2" name="">
             <a:extLst xmlns:a="http://schemas.openxmlformats.org/drawingml/2006/main">
               <a:ext uri="{FF2B5EF4-FFF2-40B4-BE49-F238E27FC236}">
-                <a16:creationId xmlns:a16="http://schemas.microsoft.com/office/drawing/2014/main" id="{256D1AB3-944D-4B28-83D7-FBE904F1D45E}"/>
+                <a16:creationId xmlns:a16="http://schemas.microsoft.com/office/drawing/2014/main" id="{76B8023E-1C98-4E9B-80CB-49AC45876309}"/>
               </a:ext>
             </a:extLst>
           </p:cNvPr>
@@ -9883,7 +10113,7 @@
           <p:cNvPr id="3" name="">
             <a:extLst xmlns:a="http://schemas.openxmlformats.org/drawingml/2006/main">
               <a:ext uri="{FF2B5EF4-FFF2-40B4-BE49-F238E27FC236}">
-                <a16:creationId xmlns:a16="http://schemas.microsoft.com/office/drawing/2014/main" id="{62B7EEBD-73FB-41F8-A97A-950C589F1DEE}"/>
+                <a16:creationId xmlns:a16="http://schemas.microsoft.com/office/drawing/2014/main" id="{46C0AD2C-6010-4E3B-B5DB-5C3723A80E07}"/>
               </a:ext>
             </a:extLst>
           </p:cNvPr>
@@ -9941,7 +10171,7 @@
           <p:cNvPr id="4" name="">
             <a:extLst xmlns:a="http://schemas.openxmlformats.org/drawingml/2006/main">
               <a:ext uri="{FF2B5EF4-FFF2-40B4-BE49-F238E27FC236}">
-                <a16:creationId xmlns:a16="http://schemas.microsoft.com/office/drawing/2014/main" id="{BA81CC5A-DE12-4F83-9CE6-701C7834491D}"/>
+                <a16:creationId xmlns:a16="http://schemas.microsoft.com/office/drawing/2014/main" id="{7363ED8E-78A0-4F5B-A588-1BE3EC919A25}"/>
               </a:ext>
             </a:extLst>
           </p:cNvPr>
@@ -9974,7 +10204,7 @@
           <p:cNvPr id="5" name="">
             <a:extLst xmlns:a="http://schemas.openxmlformats.org/drawingml/2006/main">
               <a:ext uri="{FF2B5EF4-FFF2-40B4-BE49-F238E27FC236}">
-                <a16:creationId xmlns:a16="http://schemas.microsoft.com/office/drawing/2014/main" id="{28D3D468-C2BE-45EC-8B3C-26846328B2AE}"/>
+                <a16:creationId xmlns:a16="http://schemas.microsoft.com/office/drawing/2014/main" id="{AAD05800-E248-4E79-9AF3-7E241CAD9DE5}"/>
               </a:ext>
             </a:extLst>
           </p:cNvPr>
@@ -10007,7 +10237,7 @@
           <p:cNvPr id="6" name="">
             <a:extLst xmlns:a="http://schemas.openxmlformats.org/drawingml/2006/main">
               <a:ext uri="{FF2B5EF4-FFF2-40B4-BE49-F238E27FC236}">
-                <a16:creationId xmlns:a16="http://schemas.microsoft.com/office/drawing/2014/main" id="{77FB8415-E660-4367-BC38-B31082186D7D}"/>
+                <a16:creationId xmlns:a16="http://schemas.microsoft.com/office/drawing/2014/main" id="{C9A520E5-C9D9-42F1-9887-C9B84FEEDB57}"/>
               </a:ext>
             </a:extLst>
           </p:cNvPr>
@@ -10042,7 +10272,7 @@
           <p:cNvPr id="7" name="">
             <a:extLst xmlns:a="http://schemas.openxmlformats.org/drawingml/2006/main">
               <a:ext uri="{FF2B5EF4-FFF2-40B4-BE49-F238E27FC236}">
-                <a16:creationId xmlns:a16="http://schemas.microsoft.com/office/drawing/2014/main" id="{9D742239-7973-403E-82D1-0F7E1642A9AF}"/>
+                <a16:creationId xmlns:a16="http://schemas.microsoft.com/office/drawing/2014/main" id="{CBDEE6C8-0DDC-4EB1-8205-CF588E750CC5}"/>
               </a:ext>
             </a:extLst>
           </p:cNvPr>
@@ -10100,7 +10330,7 @@
           <p:cNvPr id="8" name="">
             <a:extLst xmlns:a="http://schemas.openxmlformats.org/drawingml/2006/main">
               <a:ext uri="{FF2B5EF4-FFF2-40B4-BE49-F238E27FC236}">
-                <a16:creationId xmlns:a16="http://schemas.microsoft.com/office/drawing/2014/main" id="{F68E38A6-F56D-4D9C-8805-FDF26A5B253B}"/>
+                <a16:creationId xmlns:a16="http://schemas.microsoft.com/office/drawing/2014/main" id="{24D3088D-DFE9-4462-88C0-63D5F4D1716D}"/>
               </a:ext>
             </a:extLst>
           </p:cNvPr>
@@ -10158,7 +10388,7 @@
           <p:cNvPr id="9" name="">
             <a:extLst xmlns:a="http://schemas.openxmlformats.org/drawingml/2006/main">
               <a:ext uri="{FF2B5EF4-FFF2-40B4-BE49-F238E27FC236}">
-                <a16:creationId xmlns:a16="http://schemas.microsoft.com/office/drawing/2014/main" id="{FC4EABCA-CA25-4234-ABE9-FB0FDBC91727}"/>
+                <a16:creationId xmlns:a16="http://schemas.microsoft.com/office/drawing/2014/main" id="{21A31A66-E161-43A1-BCFF-7B9BE449D8B1}"/>
               </a:ext>
             </a:extLst>
           </p:cNvPr>
@@ -10216,7 +10446,7 @@
           <p:cNvPr id="10" name="">
             <a:extLst xmlns:a="http://schemas.openxmlformats.org/drawingml/2006/main">
               <a:ext uri="{FF2B5EF4-FFF2-40B4-BE49-F238E27FC236}">
-                <a16:creationId xmlns:a16="http://schemas.microsoft.com/office/drawing/2014/main" id="{0D1D1C77-E295-4B84-8A30-002E2E7A0148}"/>
+                <a16:creationId xmlns:a16="http://schemas.microsoft.com/office/drawing/2014/main" id="{550E1E0C-AA6B-4592-ADB3-2399027F2FEE}"/>
               </a:ext>
             </a:extLst>
           </p:cNvPr>
@@ -10251,7 +10481,7 @@
           <p:cNvPr id="11" name="">
             <a:extLst xmlns:a="http://schemas.openxmlformats.org/drawingml/2006/main">
               <a:ext uri="{FF2B5EF4-FFF2-40B4-BE49-F238E27FC236}">
-                <a16:creationId xmlns:a16="http://schemas.microsoft.com/office/drawing/2014/main" id="{11DA4073-910E-499C-8174-66D75C08A17C}"/>
+                <a16:creationId xmlns:a16="http://schemas.microsoft.com/office/drawing/2014/main" id="{104EF271-07B6-451A-B714-0EAFB9F21FB6}"/>
               </a:ext>
             </a:extLst>
           </p:cNvPr>
@@ -10309,7 +10539,7 @@
           <p:cNvPr id="12" name="">
             <a:extLst xmlns:a="http://schemas.openxmlformats.org/drawingml/2006/main">
               <a:ext uri="{FF2B5EF4-FFF2-40B4-BE49-F238E27FC236}">
-                <a16:creationId xmlns:a16="http://schemas.microsoft.com/office/drawing/2014/main" id="{1D9CD57D-1EB5-4FA6-979D-F60CA7E91069}"/>
+                <a16:creationId xmlns:a16="http://schemas.microsoft.com/office/drawing/2014/main" id="{2B6709DE-AAFE-474B-B00B-A66D888C8BFA}"/>
               </a:ext>
             </a:extLst>
           </p:cNvPr>
@@ -10367,7 +10597,7 @@
           <p:cNvPr id="13" name="">
             <a:extLst xmlns:a="http://schemas.openxmlformats.org/drawingml/2006/main">
               <a:ext uri="{FF2B5EF4-FFF2-40B4-BE49-F238E27FC236}">
-                <a16:creationId xmlns:a16="http://schemas.microsoft.com/office/drawing/2014/main" id="{DB80BC0E-2018-4746-B5F3-56BBFCD9F124}"/>
+                <a16:creationId xmlns:a16="http://schemas.microsoft.com/office/drawing/2014/main" id="{E2D05528-E5A4-471E-BFAF-458281BA1CAD}"/>
               </a:ext>
             </a:extLst>
           </p:cNvPr>
@@ -10425,7 +10655,7 @@
           <p:cNvPr id="14" name="">
             <a:extLst xmlns:a="http://schemas.openxmlformats.org/drawingml/2006/main">
               <a:ext uri="{FF2B5EF4-FFF2-40B4-BE49-F238E27FC236}">
-                <a16:creationId xmlns:a16="http://schemas.microsoft.com/office/drawing/2014/main" id="{4BAC69C1-0186-4D4F-90E6-57A2D486AB5B}"/>
+                <a16:creationId xmlns:a16="http://schemas.microsoft.com/office/drawing/2014/main" id="{2950859B-A676-4B87-9251-1B1C9206FA51}"/>
               </a:ext>
             </a:extLst>
           </p:cNvPr>
@@ -10460,7 +10690,7 @@
           <p:cNvPr id="15" name="">
             <a:extLst xmlns:a="http://schemas.openxmlformats.org/drawingml/2006/main">
               <a:ext uri="{FF2B5EF4-FFF2-40B4-BE49-F238E27FC236}">
-                <a16:creationId xmlns:a16="http://schemas.microsoft.com/office/drawing/2014/main" id="{54A3E874-91B7-4745-BD2C-59767916A3F5}"/>
+                <a16:creationId xmlns:a16="http://schemas.microsoft.com/office/drawing/2014/main" id="{F7173921-31B8-44D7-91E4-ADAF34BDB09C}"/>
               </a:ext>
             </a:extLst>
           </p:cNvPr>
@@ -10518,7 +10748,7 @@
           <p:cNvPr id="16" name="">
             <a:extLst xmlns:a="http://schemas.openxmlformats.org/drawingml/2006/main">
               <a:ext uri="{FF2B5EF4-FFF2-40B4-BE49-F238E27FC236}">
-                <a16:creationId xmlns:a16="http://schemas.microsoft.com/office/drawing/2014/main" id="{3754C839-7470-4E31-A9A4-ECEDEE2DCBF7}"/>
+                <a16:creationId xmlns:a16="http://schemas.microsoft.com/office/drawing/2014/main" id="{2DC1A27A-2F77-4131-97E3-F91A334BE1EA}"/>
               </a:ext>
             </a:extLst>
           </p:cNvPr>
@@ -10576,7 +10806,7 @@
           <p:cNvPr id="17" name="">
             <a:extLst xmlns:a="http://schemas.openxmlformats.org/drawingml/2006/main">
               <a:ext uri="{FF2B5EF4-FFF2-40B4-BE49-F238E27FC236}">
-                <a16:creationId xmlns:a16="http://schemas.microsoft.com/office/drawing/2014/main" id="{78580932-92EE-4E41-8B2C-D0697B10CEB2}"/>
+                <a16:creationId xmlns:a16="http://schemas.microsoft.com/office/drawing/2014/main" id="{3F0CAAE8-1568-4E22-8962-F2E927152B9A}"/>
               </a:ext>
             </a:extLst>
           </p:cNvPr>
@@ -10634,7 +10864,7 @@
           <p:cNvPr id="18" name="">
             <a:extLst xmlns:a="http://schemas.openxmlformats.org/drawingml/2006/main">
               <a:ext uri="{FF2B5EF4-FFF2-40B4-BE49-F238E27FC236}">
-                <a16:creationId xmlns:a16="http://schemas.microsoft.com/office/drawing/2014/main" id="{C9D32752-6B9F-4F53-9451-EF4E65932407}"/>
+                <a16:creationId xmlns:a16="http://schemas.microsoft.com/office/drawing/2014/main" id="{C2ECC07F-AFFF-4E05-A31C-5CAAD4BC33E8}"/>
               </a:ext>
             </a:extLst>
           </p:cNvPr>
@@ -10669,7 +10899,7 @@
           <p:cNvPr id="19" name="">
             <a:extLst xmlns:a="http://schemas.openxmlformats.org/drawingml/2006/main">
               <a:ext uri="{FF2B5EF4-FFF2-40B4-BE49-F238E27FC236}">
-                <a16:creationId xmlns:a16="http://schemas.microsoft.com/office/drawing/2014/main" id="{5D71AD3F-98E3-4071-88D5-DE169CDBF62C}"/>
+                <a16:creationId xmlns:a16="http://schemas.microsoft.com/office/drawing/2014/main" id="{8A0ABD81-0A75-4296-93BF-68E4E403C314}"/>
               </a:ext>
             </a:extLst>
           </p:cNvPr>
@@ -10727,7 +10957,7 @@
           <p:cNvPr id="20" name="">
             <a:extLst xmlns:a="http://schemas.openxmlformats.org/drawingml/2006/main">
               <a:ext uri="{FF2B5EF4-FFF2-40B4-BE49-F238E27FC236}">
-                <a16:creationId xmlns:a16="http://schemas.microsoft.com/office/drawing/2014/main" id="{FDCAC3F1-AA09-4F19-8D47-C478878C30F0}"/>
+                <a16:creationId xmlns:a16="http://schemas.microsoft.com/office/drawing/2014/main" id="{E2C0587D-65FE-4416-B738-6F15D6B0B8D1}"/>
               </a:ext>
             </a:extLst>
           </p:cNvPr>
@@ -10785,7 +11015,7 @@
           <p:cNvPr id="21" name="">
             <a:extLst xmlns:a="http://schemas.openxmlformats.org/drawingml/2006/main">
               <a:ext uri="{FF2B5EF4-FFF2-40B4-BE49-F238E27FC236}">
-                <a16:creationId xmlns:a16="http://schemas.microsoft.com/office/drawing/2014/main" id="{3CE602AA-69B7-4251-A68E-D4A8476F62F4}"/>
+                <a16:creationId xmlns:a16="http://schemas.microsoft.com/office/drawing/2014/main" id="{846C297F-2687-440E-AAAE-F65A0A2074C7}"/>
               </a:ext>
             </a:extLst>
           </p:cNvPr>
@@ -10833,7 +11063,7 @@
                 <a:ea typeface="Aptos"/>
                 <a:cs typeface="Aptos"/>
               </a:rPr>
-              <a:t>Complete method-readiness dossier and decide scope.</a:t>
+              <a:t>Choose package, build, partner, monitor, or stop.</a:t>
             </a:r>
           </a:p>
         </p:txBody>
@@ -10843,7 +11073,7 @@
           <p:cNvPr id="22" name="">
             <a:extLst xmlns:a="http://schemas.openxmlformats.org/drawingml/2006/main">
               <a:ext uri="{FF2B5EF4-FFF2-40B4-BE49-F238E27FC236}">
-                <a16:creationId xmlns:a16="http://schemas.microsoft.com/office/drawing/2014/main" id="{4C364B36-F9E9-43F7-BBE8-347FEAA34B26}"/>
+                <a16:creationId xmlns:a16="http://schemas.microsoft.com/office/drawing/2014/main" id="{46F2F345-0B54-4D2C-971A-2A8873C9906E}"/>
               </a:ext>
             </a:extLst>
           </p:cNvPr>
@@ -10878,7 +11108,7 @@
           <p:cNvPr id="23" name="">
             <a:extLst xmlns:a="http://schemas.openxmlformats.org/drawingml/2006/main">
               <a:ext uri="{FF2B5EF4-FFF2-40B4-BE49-F238E27FC236}">
-                <a16:creationId xmlns:a16="http://schemas.microsoft.com/office/drawing/2014/main" id="{6C08FCCE-E5E2-4A4A-B10A-53DC3A08C160}"/>
+                <a16:creationId xmlns:a16="http://schemas.microsoft.com/office/drawing/2014/main" id="{9B8B2609-149B-43EF-B92D-B02053F7A1AC}"/>
               </a:ext>
             </a:extLst>
           </p:cNvPr>
@@ -10936,7 +11166,7 @@
           <p:cNvPr id="24" name="">
             <a:extLst xmlns:a="http://schemas.openxmlformats.org/drawingml/2006/main">
               <a:ext uri="{FF2B5EF4-FFF2-40B4-BE49-F238E27FC236}">
-                <a16:creationId xmlns:a16="http://schemas.microsoft.com/office/drawing/2014/main" id="{154CDAB6-43DB-490C-A0F8-068484D05D4B}"/>
+                <a16:creationId xmlns:a16="http://schemas.microsoft.com/office/drawing/2014/main" id="{0BD5C294-6111-4022-906E-0F5D43E7FC7D}"/>
               </a:ext>
             </a:extLst>
           </p:cNvPr>
@@ -10948,7 +11178,7 @@
         <p:spPr>
           <a:xfrm xmlns:a="http://schemas.openxmlformats.org/drawingml/2006/main">
             <a:off x="514350" y="6477000"/>
-            <a:ext cx="8191500" cy="190500"/>
+            <a:ext cx="9810750" cy="190500"/>
           </a:xfrm>
           <a:prstGeom xmlns:a="http://schemas.openxmlformats.org/drawingml/2006/main" prst="rect">
             <a:avLst/>
@@ -10984,7 +11214,7 @@
                 <a:ea typeface="Aptos"/>
                 <a:cs typeface="Aptos"/>
               </a:rPr>
-              <a:t>WATERS NEXT GEN COMPETITIVE INTELLIGENCE · 23 JUL 2026</a:t>
+              <a:t>WATERS NEXT GEN COMPETITIVE INTELLIGENCE · 28 JUL 2026 · waters-ci-20260728-202611</a:t>
             </a:r>
           </a:p>
         </p:txBody>
@@ -10994,7 +11224,7 @@
           <p:cNvPr id="25" name="">
             <a:extLst xmlns:a="http://schemas.openxmlformats.org/drawingml/2006/main">
               <a:ext uri="{FF2B5EF4-FFF2-40B4-BE49-F238E27FC236}">
-                <a16:creationId xmlns:a16="http://schemas.microsoft.com/office/drawing/2014/main" id="{7F5017E1-7C6A-4F2B-B432-3F95E186C3E4}"/>
+                <a16:creationId xmlns:a16="http://schemas.microsoft.com/office/drawing/2014/main" id="{E495CC37-B4F5-476E-8F9F-1C549AF6A82E}"/>
               </a:ext>
             </a:extLst>
           </p:cNvPr>
@@ -11050,7 +11280,7 @@
     </p:spTree>
     <p:extLst>
       <p:ext uri="{BB962C8B-B14F-4D97-AF65-F5344CB8AC3E}">
-        <p14:creationId xmlns:p14="http://schemas.microsoft.com/office/powerpoint/2010/main" val="703804675"/>
+        <p14:creationId xmlns:p14="http://schemas.microsoft.com/office/powerpoint/2010/main" val="720460594"/>
       </p:ext>
     </p:extLst>
   </p:cSld>
@@ -11081,7 +11311,7 @@
           <p:cNvPr id="38" name="">
             <a:extLst xmlns:a="http://schemas.openxmlformats.org/drawingml/2006/main">
               <a:ext uri="{FF2B5EF4-FFF2-40B4-BE49-F238E27FC236}">
-                <a16:creationId xmlns:a16="http://schemas.microsoft.com/office/drawing/2014/main" id="{879172A8-9E7E-4011-AB4F-482CB0498D73}"/>
+                <a16:creationId xmlns:a16="http://schemas.microsoft.com/office/drawing/2014/main" id="{5664FBDC-54E4-4243-9828-118C59AEF38A}"/>
               </a:ext>
             </a:extLst>
           </p:cNvPr>
@@ -11139,7 +11369,7 @@
           <p:cNvPr id="2" name="">
             <a:extLst xmlns:a="http://schemas.openxmlformats.org/drawingml/2006/main">
               <a:ext uri="{FF2B5EF4-FFF2-40B4-BE49-F238E27FC236}">
-                <a16:creationId xmlns:a16="http://schemas.microsoft.com/office/drawing/2014/main" id="{CF4B3473-4D67-4FDA-9998-D303852CAE00}"/>
+                <a16:creationId xmlns:a16="http://schemas.microsoft.com/office/drawing/2014/main" id="{7753CE0B-813D-4694-94B6-8E2878752D73}"/>
               </a:ext>
             </a:extLst>
           </p:cNvPr>
@@ -11197,7 +11427,7 @@
           <p:cNvPr id="3" name="">
             <a:extLst xmlns:a="http://schemas.openxmlformats.org/drawingml/2006/main">
               <a:ext uri="{FF2B5EF4-FFF2-40B4-BE49-F238E27FC236}">
-                <a16:creationId xmlns:a16="http://schemas.microsoft.com/office/drawing/2014/main" id="{D16D7108-EA0C-4CD5-A1FB-45223A9FFE56}"/>
+                <a16:creationId xmlns:a16="http://schemas.microsoft.com/office/drawing/2014/main" id="{E5940C40-DE97-47B1-9849-936D3FB7C295}"/>
               </a:ext>
             </a:extLst>
           </p:cNvPr>
@@ -11255,7 +11485,7 @@
           <p:cNvPr id="4" name="">
             <a:extLst xmlns:a="http://schemas.openxmlformats.org/drawingml/2006/main">
               <a:ext uri="{FF2B5EF4-FFF2-40B4-BE49-F238E27FC236}">
-                <a16:creationId xmlns:a16="http://schemas.microsoft.com/office/drawing/2014/main" id="{E13D6F5F-9558-4772-9017-DAB800C89A6E}"/>
+                <a16:creationId xmlns:a16="http://schemas.microsoft.com/office/drawing/2014/main" id="{DFDB070C-DF8E-4C03-9556-8DA35AB8574C}"/>
               </a:ext>
             </a:extLst>
           </p:cNvPr>
@@ -11288,7 +11518,7 @@
           <p:cNvPr id="5" name="">
             <a:extLst xmlns:a="http://schemas.openxmlformats.org/drawingml/2006/main">
               <a:ext uri="{FF2B5EF4-FFF2-40B4-BE49-F238E27FC236}">
-                <a16:creationId xmlns:a16="http://schemas.microsoft.com/office/drawing/2014/main" id="{3DA37F06-2B9E-4648-AF02-DC887027643F}"/>
+                <a16:creationId xmlns:a16="http://schemas.microsoft.com/office/drawing/2014/main" id="{16F81CE1-59C3-4EED-A155-689EAF9A78CF}"/>
               </a:ext>
             </a:extLst>
           </p:cNvPr>
@@ -11346,7 +11576,7 @@
           <p:cNvPr id="6" name="">
             <a:extLst xmlns:a="http://schemas.openxmlformats.org/drawingml/2006/main">
               <a:ext uri="{FF2B5EF4-FFF2-40B4-BE49-F238E27FC236}">
-                <a16:creationId xmlns:a16="http://schemas.microsoft.com/office/drawing/2014/main" id="{ABA57F60-A0C5-463F-83BD-ECB0C3E90310}"/>
+                <a16:creationId xmlns:a16="http://schemas.microsoft.com/office/drawing/2014/main" id="{4C1CFCBE-DC83-4C8A-95F8-E0A60EEDBE21}"/>
               </a:ext>
             </a:extLst>
           </p:cNvPr>
@@ -11404,7 +11634,7 @@
           <p:cNvPr id="7" name="">
             <a:extLst xmlns:a="http://schemas.openxmlformats.org/drawingml/2006/main">
               <a:ext uri="{FF2B5EF4-FFF2-40B4-BE49-F238E27FC236}">
-                <a16:creationId xmlns:a16="http://schemas.microsoft.com/office/drawing/2014/main" id="{156FE57B-E533-424B-89AD-D4CF7CAF67C1}"/>
+                <a16:creationId xmlns:a16="http://schemas.microsoft.com/office/drawing/2014/main" id="{A5100DD8-E790-4006-814D-057266FD32EC}"/>
               </a:ext>
             </a:extLst>
           </p:cNvPr>
@@ -11462,7 +11692,7 @@
           <p:cNvPr id="8" name="">
             <a:extLst xmlns:a="http://schemas.openxmlformats.org/drawingml/2006/main">
               <a:ext uri="{FF2B5EF4-FFF2-40B4-BE49-F238E27FC236}">
-                <a16:creationId xmlns:a16="http://schemas.microsoft.com/office/drawing/2014/main" id="{A582CEC0-0C91-4546-949F-592287867A72}"/>
+                <a16:creationId xmlns:a16="http://schemas.microsoft.com/office/drawing/2014/main" id="{AFAD26EA-30B7-41AA-A316-56C68B88C5FE}"/>
               </a:ext>
             </a:extLst>
           </p:cNvPr>
@@ -11510,7 +11740,7 @@
                 <a:ea typeface="Aptos"/>
                 <a:cs typeface="Aptos"/>
               </a:rPr>
-              <a:t>pubmed.ncbi.nlm.nih.gov</a:t>
+              <a:t>https://pubmed.ncbi.nlm.nih.gov/</a:t>
             </a:r>
           </a:p>
         </p:txBody>
@@ -11520,7 +11750,7 @@
           <p:cNvPr id="9" name="">
             <a:extLst xmlns:a="http://schemas.openxmlformats.org/drawingml/2006/main">
               <a:ext uri="{FF2B5EF4-FFF2-40B4-BE49-F238E27FC236}">
-                <a16:creationId xmlns:a16="http://schemas.microsoft.com/office/drawing/2014/main" id="{F4D42134-47D9-46AF-B9BF-D1CF8793D01E}"/>
+                <a16:creationId xmlns:a16="http://schemas.microsoft.com/office/drawing/2014/main" id="{0BC109E4-9CE0-41EE-A64F-F97AC3DF7FEB}"/>
               </a:ext>
             </a:extLst>
           </p:cNvPr>
@@ -11553,7 +11783,7 @@
           <p:cNvPr id="10" name="">
             <a:extLst xmlns:a="http://schemas.openxmlformats.org/drawingml/2006/main">
               <a:ext uri="{FF2B5EF4-FFF2-40B4-BE49-F238E27FC236}">
-                <a16:creationId xmlns:a16="http://schemas.microsoft.com/office/drawing/2014/main" id="{6094ED03-84D9-4E0C-B09C-602669470A85}"/>
+                <a16:creationId xmlns:a16="http://schemas.microsoft.com/office/drawing/2014/main" id="{A3B98699-4565-48ED-8779-26315FFBC20C}"/>
               </a:ext>
             </a:extLst>
           </p:cNvPr>
@@ -11611,7 +11841,7 @@
           <p:cNvPr id="11" name="">
             <a:extLst xmlns:a="http://schemas.openxmlformats.org/drawingml/2006/main">
               <a:ext uri="{FF2B5EF4-FFF2-40B4-BE49-F238E27FC236}">
-                <a16:creationId xmlns:a16="http://schemas.microsoft.com/office/drawing/2014/main" id="{67ABD49B-67E1-4F35-8337-8F3497BAFF3E}"/>
+                <a16:creationId xmlns:a16="http://schemas.microsoft.com/office/drawing/2014/main" id="{81B9FF74-390D-4F52-9E5E-96162AC54BDA}"/>
               </a:ext>
             </a:extLst>
           </p:cNvPr>
@@ -11669,7 +11899,7 @@
           <p:cNvPr id="12" name="">
             <a:extLst xmlns:a="http://schemas.openxmlformats.org/drawingml/2006/main">
               <a:ext uri="{FF2B5EF4-FFF2-40B4-BE49-F238E27FC236}">
-                <a16:creationId xmlns:a16="http://schemas.microsoft.com/office/drawing/2014/main" id="{903D8CB5-4AD1-4B13-9484-29F98DF4992A}"/>
+                <a16:creationId xmlns:a16="http://schemas.microsoft.com/office/drawing/2014/main" id="{53C2B773-5714-4FA7-8B79-2E7EF749BDC4}"/>
               </a:ext>
             </a:extLst>
           </p:cNvPr>
@@ -11727,7 +11957,7 @@
           <p:cNvPr id="13" name="">
             <a:extLst xmlns:a="http://schemas.openxmlformats.org/drawingml/2006/main">
               <a:ext uri="{FF2B5EF4-FFF2-40B4-BE49-F238E27FC236}">
-                <a16:creationId xmlns:a16="http://schemas.microsoft.com/office/drawing/2014/main" id="{0C79A982-F4E3-475C-B1DB-DAD25CC8E794}"/>
+                <a16:creationId xmlns:a16="http://schemas.microsoft.com/office/drawing/2014/main" id="{77454531-3721-469B-B2AB-7B57A299C758}"/>
               </a:ext>
             </a:extLst>
           </p:cNvPr>
@@ -11752,7 +11982,7 @@
         </p:spPr>
         <p:txBody>
           <a:bodyPr xmlns:a="http://schemas.openxmlformats.org/drawingml/2006/main" wrap="square" lIns="0" tIns="0" rIns="0" bIns="0" anchor="t">
-            <a:normAutofit fontScale="100000"/>
+            <a:normAutofit fontScale="93289"/>
           </a:bodyPr>
           <a:lstStyle xmlns:a="http://schemas.openxmlformats.org/drawingml/2006/main"/>
           <a:p xmlns:a="http://schemas.openxmlformats.org/drawingml/2006/main">
@@ -11775,7 +12005,7 @@
                 <a:ea typeface="Aptos"/>
                 <a:cs typeface="Aptos"/>
               </a:rPr>
-              <a:t>agilent.com/about/newsroom/presrel/2026/29may-ca26021.html</a:t>
+              <a:t>https://www.agilent.com/about/newsroom/presrel/2026/29may-ca26021.html</a:t>
             </a:r>
           </a:p>
         </p:txBody>
@@ -11785,7 +12015,7 @@
           <p:cNvPr id="14" name="">
             <a:extLst xmlns:a="http://schemas.openxmlformats.org/drawingml/2006/main">
               <a:ext uri="{FF2B5EF4-FFF2-40B4-BE49-F238E27FC236}">
-                <a16:creationId xmlns:a16="http://schemas.microsoft.com/office/drawing/2014/main" id="{3B66C5EC-8D08-4D1B-A413-868CD544EB9E}"/>
+                <a16:creationId xmlns:a16="http://schemas.microsoft.com/office/drawing/2014/main" id="{885FA1AC-551B-4323-BC23-AAB9E5F494E4}"/>
               </a:ext>
             </a:extLst>
           </p:cNvPr>
@@ -11818,7 +12048,7 @@
           <p:cNvPr id="15" name="">
             <a:extLst xmlns:a="http://schemas.openxmlformats.org/drawingml/2006/main">
               <a:ext uri="{FF2B5EF4-FFF2-40B4-BE49-F238E27FC236}">
-                <a16:creationId xmlns:a16="http://schemas.microsoft.com/office/drawing/2014/main" id="{4182C43E-C956-4DDF-9EB8-16A9E46109DA}"/>
+                <a16:creationId xmlns:a16="http://schemas.microsoft.com/office/drawing/2014/main" id="{9EDF1B6A-8624-4AE5-B76C-4AB472AED53E}"/>
               </a:ext>
             </a:extLst>
           </p:cNvPr>
@@ -11876,7 +12106,7 @@
           <p:cNvPr id="16" name="">
             <a:extLst xmlns:a="http://schemas.openxmlformats.org/drawingml/2006/main">
               <a:ext uri="{FF2B5EF4-FFF2-40B4-BE49-F238E27FC236}">
-                <a16:creationId xmlns:a16="http://schemas.microsoft.com/office/drawing/2014/main" id="{1E4C54BB-874E-4C97-BE6F-294DE82E04E5}"/>
+                <a16:creationId xmlns:a16="http://schemas.microsoft.com/office/drawing/2014/main" id="{5A04CAB5-E004-45DF-B57E-CBBAC313D8ED}"/>
               </a:ext>
             </a:extLst>
           </p:cNvPr>
@@ -11924,7 +12154,7 @@
                 <a:ea typeface="Aptos"/>
                 <a:cs typeface="Aptos"/>
               </a:rPr>
-              <a:t>CUSTOMER EVIDENCE</a:t>
+              <a:t>AGILENT FILING</a:t>
             </a:r>
           </a:p>
         </p:txBody>
@@ -11934,7 +12164,7 @@
           <p:cNvPr id="17" name="">
             <a:extLst xmlns:a="http://schemas.openxmlformats.org/drawingml/2006/main">
               <a:ext uri="{FF2B5EF4-FFF2-40B4-BE49-F238E27FC236}">
-                <a16:creationId xmlns:a16="http://schemas.microsoft.com/office/drawing/2014/main" id="{37F03936-8000-4F15-AA06-B24A86B8515C}"/>
+                <a16:creationId xmlns:a16="http://schemas.microsoft.com/office/drawing/2014/main" id="{83B48D49-D305-4D23-824D-8E9637354488}"/>
               </a:ext>
             </a:extLst>
           </p:cNvPr>
@@ -11982,7 +12212,7 @@
                 <a:ea typeface="Aptos"/>
                 <a:cs typeface="Aptos"/>
               </a:rPr>
-              <a:t>Waters UPLC high-pressure troubleshooting</a:t>
+              <a:t>Issuer-reported LC / LC-MS growth</a:t>
             </a:r>
           </a:p>
         </p:txBody>
@@ -11992,7 +12222,7 @@
           <p:cNvPr id="18" name="">
             <a:extLst xmlns:a="http://schemas.openxmlformats.org/drawingml/2006/main">
               <a:ext uri="{FF2B5EF4-FFF2-40B4-BE49-F238E27FC236}">
-                <a16:creationId xmlns:a16="http://schemas.microsoft.com/office/drawing/2014/main" id="{69F08582-BB72-4CFA-B57A-FFEB0C8E288B}"/>
+                <a16:creationId xmlns:a16="http://schemas.microsoft.com/office/drawing/2014/main" id="{C5FD4953-E7CE-4DD6-9409-68BDA5731386}"/>
               </a:ext>
             </a:extLst>
           </p:cNvPr>
@@ -12040,7 +12270,7 @@
                 <a:ea typeface="Aptos"/>
                 <a:cs typeface="Aptos"/>
               </a:rPr>
-              <a:t>reddit.com/r/CHROMATOGRAPHY</a:t>
+              <a:t>https://www.sec.gov/edgar/browse/?CIK=1090872</a:t>
             </a:r>
           </a:p>
         </p:txBody>
@@ -12050,7 +12280,7 @@
           <p:cNvPr id="19" name="">
             <a:extLst xmlns:a="http://schemas.openxmlformats.org/drawingml/2006/main">
               <a:ext uri="{FF2B5EF4-FFF2-40B4-BE49-F238E27FC236}">
-                <a16:creationId xmlns:a16="http://schemas.microsoft.com/office/drawing/2014/main" id="{7EC62691-D4A3-48E6-8322-C1AD2DBE330D}"/>
+                <a16:creationId xmlns:a16="http://schemas.microsoft.com/office/drawing/2014/main" id="{1684BDC5-7D52-4F41-910F-94BD1EEF1868}"/>
               </a:ext>
             </a:extLst>
           </p:cNvPr>
@@ -12083,7 +12313,7 @@
           <p:cNvPr id="20" name="">
             <a:extLst xmlns:a="http://schemas.openxmlformats.org/drawingml/2006/main">
               <a:ext uri="{FF2B5EF4-FFF2-40B4-BE49-F238E27FC236}">
-                <a16:creationId xmlns:a16="http://schemas.microsoft.com/office/drawing/2014/main" id="{6AC9736C-7229-461D-847B-9C6C7F81F1FE}"/>
+                <a16:creationId xmlns:a16="http://schemas.microsoft.com/office/drawing/2014/main" id="{F51D1CD6-9356-475D-8684-2E5FD39B296F}"/>
               </a:ext>
             </a:extLst>
           </p:cNvPr>
@@ -12141,7 +12371,7 @@
           <p:cNvPr id="21" name="">
             <a:extLst xmlns:a="http://schemas.openxmlformats.org/drawingml/2006/main">
               <a:ext uri="{FF2B5EF4-FFF2-40B4-BE49-F238E27FC236}">
-                <a16:creationId xmlns:a16="http://schemas.microsoft.com/office/drawing/2014/main" id="{0FB077F7-F95F-47D2-B242-3820E31CE5D5}"/>
+                <a16:creationId xmlns:a16="http://schemas.microsoft.com/office/drawing/2014/main" id="{AAC1B102-6E80-4CDE-9598-B3A9CE0C2343}"/>
               </a:ext>
             </a:extLst>
           </p:cNvPr>
@@ -12189,7 +12419,7 @@
                 <a:ea typeface="Aptos"/>
                 <a:cs typeface="Aptos"/>
               </a:rPr>
-              <a:t>CORPORATE INTENT</a:t>
+              <a:t>SHIMADZU LAUNCH</a:t>
             </a:r>
           </a:p>
         </p:txBody>
@@ -12199,7 +12429,7 @@
           <p:cNvPr id="22" name="">
             <a:extLst xmlns:a="http://schemas.openxmlformats.org/drawingml/2006/main">
               <a:ext uri="{FF2B5EF4-FFF2-40B4-BE49-F238E27FC236}">
-                <a16:creationId xmlns:a16="http://schemas.microsoft.com/office/drawing/2014/main" id="{047EB324-D669-40FD-93F5-E729D20B36F2}"/>
+                <a16:creationId xmlns:a16="http://schemas.microsoft.com/office/drawing/2014/main" id="{4E554BDD-DEBE-48E6-8714-B0A99C04B906}"/>
               </a:ext>
             </a:extLst>
           </p:cNvPr>
@@ -12247,7 +12477,7 @@
                 <a:ea typeface="Aptos"/>
                 <a:cs typeface="Aptos"/>
               </a:rPr>
-              <a:t>Agilent quarterly filing</a:t>
+              <a:t>Nexera X4 UHPLC</a:t>
             </a:r>
           </a:p>
         </p:txBody>
@@ -12257,7 +12487,7 @@
           <p:cNvPr id="23" name="">
             <a:extLst xmlns:a="http://schemas.openxmlformats.org/drawingml/2006/main">
               <a:ext uri="{FF2B5EF4-FFF2-40B4-BE49-F238E27FC236}">
-                <a16:creationId xmlns:a16="http://schemas.microsoft.com/office/drawing/2014/main" id="{8AEC80B6-952F-4E1B-8459-4F6F11DCA2AC}"/>
+                <a16:creationId xmlns:a16="http://schemas.microsoft.com/office/drawing/2014/main" id="{BF488978-CA2F-4EFA-986A-01DC4A19D407}"/>
               </a:ext>
             </a:extLst>
           </p:cNvPr>
@@ -12305,7 +12535,7 @@
                 <a:ea typeface="Aptos"/>
                 <a:cs typeface="Aptos"/>
               </a:rPr>
-              <a:t>sec.gov · Agilent quarterly filing</a:t>
+              <a:t>https://www.shimadzu.com/news/2026/k8iri3_20_z4uvwt.html</a:t>
             </a:r>
           </a:p>
         </p:txBody>
@@ -12315,7 +12545,7 @@
           <p:cNvPr id="24" name="">
             <a:extLst xmlns:a="http://schemas.openxmlformats.org/drawingml/2006/main">
               <a:ext uri="{FF2B5EF4-FFF2-40B4-BE49-F238E27FC236}">
-                <a16:creationId xmlns:a16="http://schemas.microsoft.com/office/drawing/2014/main" id="{0382AD0A-AB53-46FB-86E5-5E26A5B302F1}"/>
+                <a16:creationId xmlns:a16="http://schemas.microsoft.com/office/drawing/2014/main" id="{95DE20F5-ABC4-411B-BA71-CAEDCFC6FC4D}"/>
               </a:ext>
             </a:extLst>
           </p:cNvPr>
@@ -12348,7 +12578,7 @@
           <p:cNvPr id="25" name="">
             <a:extLst xmlns:a="http://schemas.openxmlformats.org/drawingml/2006/main">
               <a:ext uri="{FF2B5EF4-FFF2-40B4-BE49-F238E27FC236}">
-                <a16:creationId xmlns:a16="http://schemas.microsoft.com/office/drawing/2014/main" id="{D3D86274-DFD1-49C2-A41F-89DDC407C911}"/>
+                <a16:creationId xmlns:a16="http://schemas.microsoft.com/office/drawing/2014/main" id="{E3F84A06-C24E-4D67-940C-49A4B8854902}"/>
               </a:ext>
             </a:extLst>
           </p:cNvPr>
@@ -12406,7 +12636,7 @@
           <p:cNvPr id="26" name="">
             <a:extLst xmlns:a="http://schemas.openxmlformats.org/drawingml/2006/main">
               <a:ext uri="{FF2B5EF4-FFF2-40B4-BE49-F238E27FC236}">
-                <a16:creationId xmlns:a16="http://schemas.microsoft.com/office/drawing/2014/main" id="{60EB7AF1-F43D-4AAE-A9D1-A0C165794F40}"/>
+                <a16:creationId xmlns:a16="http://schemas.microsoft.com/office/drawing/2014/main" id="{F8C18B91-3410-4249-AFD1-A693BD9EC0D9}"/>
               </a:ext>
             </a:extLst>
           </p:cNvPr>
@@ -12454,7 +12684,7 @@
                 <a:ea typeface="Aptos"/>
                 <a:cs typeface="Aptos"/>
               </a:rPr>
-              <a:t>COMPETITOR LAUNCHES</a:t>
+              <a:t>SCIEX LAUNCH</a:t>
             </a:r>
           </a:p>
         </p:txBody>
@@ -12464,7 +12694,7 @@
           <p:cNvPr id="27" name="">
             <a:extLst xmlns:a="http://schemas.openxmlformats.org/drawingml/2006/main">
               <a:ext uri="{FF2B5EF4-FFF2-40B4-BE49-F238E27FC236}">
-                <a16:creationId xmlns:a16="http://schemas.microsoft.com/office/drawing/2014/main" id="{E7AB92A0-0606-432F-BB3A-68DE2B41A046}"/>
+                <a16:creationId xmlns:a16="http://schemas.microsoft.com/office/drawing/2014/main" id="{B1C55083-881C-4D21-8A61-561184332433}"/>
               </a:ext>
             </a:extLst>
           </p:cNvPr>
@@ -12512,7 +12742,7 @@
                 <a:ea typeface="Aptos"/>
                 <a:cs typeface="Aptos"/>
               </a:rPr>
-              <a:t>Nexera X4 · novus V55 / OS 5.0 · Vanquish Amplify</a:t>
+              <a:t>novus V55 with SCIEX OS 5.0</a:t>
             </a:r>
           </a:p>
         </p:txBody>
@@ -12522,7 +12752,7 @@
           <p:cNvPr id="28" name="">
             <a:extLst xmlns:a="http://schemas.openxmlformats.org/drawingml/2006/main">
               <a:ext uri="{FF2B5EF4-FFF2-40B4-BE49-F238E27FC236}">
-                <a16:creationId xmlns:a16="http://schemas.microsoft.com/office/drawing/2014/main" id="{BE48423B-7799-4ACC-BFC5-EA5A8C7020C5}"/>
+                <a16:creationId xmlns:a16="http://schemas.microsoft.com/office/drawing/2014/main" id="{EE32202C-77D0-40EB-BF94-C2D31F03EAD0}"/>
               </a:ext>
             </a:extLst>
           </p:cNvPr>
@@ -12547,7 +12777,7 @@
         </p:spPr>
         <p:txBody>
           <a:bodyPr xmlns:a="http://schemas.openxmlformats.org/drawingml/2006/main" wrap="square" lIns="0" tIns="0" rIns="0" bIns="0" anchor="t">
-            <a:normAutofit fontScale="100000"/>
+            <a:normAutofit fontScale="77381"/>
           </a:bodyPr>
           <a:lstStyle xmlns:a="http://schemas.openxmlformats.org/drawingml/2006/main"/>
           <a:p xmlns:a="http://schemas.openxmlformats.org/drawingml/2006/main">
@@ -12570,7 +12800,7 @@
                 <a:ea typeface="Aptos"/>
                 <a:cs typeface="Aptos"/>
               </a:rPr>
-              <a:t>shimadzu.com · sciex.com · thermofisher.com</a:t>
+              <a:t>https://sciex.com/about-us/press-releases/2026/sciex-launches-its-5th-generation-of-nominal-mass-novus-v55-system-with-sciexos-5-0-software</a:t>
             </a:r>
           </a:p>
         </p:txBody>
@@ -12580,7 +12810,7 @@
           <p:cNvPr id="29" name="">
             <a:extLst xmlns:a="http://schemas.openxmlformats.org/drawingml/2006/main">
               <a:ext uri="{FF2B5EF4-FFF2-40B4-BE49-F238E27FC236}">
-                <a16:creationId xmlns:a16="http://schemas.microsoft.com/office/drawing/2014/main" id="{DB1B5237-3B4D-4937-AB5E-FE79A334F067}"/>
+                <a16:creationId xmlns:a16="http://schemas.microsoft.com/office/drawing/2014/main" id="{008489AF-50B8-4DEA-AA9C-83D3A9C97043}"/>
               </a:ext>
             </a:extLst>
           </p:cNvPr>
@@ -12613,7 +12843,7 @@
           <p:cNvPr id="30" name="">
             <a:extLst xmlns:a="http://schemas.openxmlformats.org/drawingml/2006/main">
               <a:ext uri="{FF2B5EF4-FFF2-40B4-BE49-F238E27FC236}">
-                <a16:creationId xmlns:a16="http://schemas.microsoft.com/office/drawing/2014/main" id="{D76057CF-A2D9-475B-951E-0CBAACC3BD35}"/>
+                <a16:creationId xmlns:a16="http://schemas.microsoft.com/office/drawing/2014/main" id="{B2AE866D-70FB-4EB0-9F77-9D0394B3DFD6}"/>
               </a:ext>
             </a:extLst>
           </p:cNvPr>
@@ -12671,7 +12901,7 @@
           <p:cNvPr id="31" name="">
             <a:extLst xmlns:a="http://schemas.openxmlformats.org/drawingml/2006/main">
               <a:ext uri="{FF2B5EF4-FFF2-40B4-BE49-F238E27FC236}">
-                <a16:creationId xmlns:a16="http://schemas.microsoft.com/office/drawing/2014/main" id="{931EAEA5-FD9A-436E-8C50-FBCA50C5445F}"/>
+                <a16:creationId xmlns:a16="http://schemas.microsoft.com/office/drawing/2014/main" id="{17C48AD4-CBE2-456D-923C-EDBE58C990A6}"/>
               </a:ext>
             </a:extLst>
           </p:cNvPr>
@@ -12729,7 +12959,7 @@
           <p:cNvPr id="32" name="">
             <a:extLst xmlns:a="http://schemas.openxmlformats.org/drawingml/2006/main">
               <a:ext uri="{FF2B5EF4-FFF2-40B4-BE49-F238E27FC236}">
-                <a16:creationId xmlns:a16="http://schemas.microsoft.com/office/drawing/2014/main" id="{D8F402C0-C47B-470C-AEE0-79D2D19D9C9E}"/>
+                <a16:creationId xmlns:a16="http://schemas.microsoft.com/office/drawing/2014/main" id="{32E0B757-DCB2-4DEF-9C29-1B73D3F863F2}"/>
               </a:ext>
             </a:extLst>
           </p:cNvPr>
@@ -12787,7 +13017,7 @@
           <p:cNvPr id="33" name="">
             <a:extLst xmlns:a="http://schemas.openxmlformats.org/drawingml/2006/main">
               <a:ext uri="{FF2B5EF4-FFF2-40B4-BE49-F238E27FC236}">
-                <a16:creationId xmlns:a16="http://schemas.microsoft.com/office/drawing/2014/main" id="{DC508859-008C-45AF-86D8-CBEF305EFDE7}"/>
+                <a16:creationId xmlns:a16="http://schemas.microsoft.com/office/drawing/2014/main" id="{E913001B-E0A0-497B-8C50-DDDE94075386}"/>
               </a:ext>
             </a:extLst>
           </p:cNvPr>
@@ -12835,7 +13065,7 @@
                 <a:ea typeface="Aptos"/>
                 <a:cs typeface="Aptos"/>
               </a:rPr>
-              <a:t>bioprocessingsummit.com</a:t>
+              <a:t>https://www.bioprocessingsummit.com/</a:t>
             </a:r>
           </a:p>
         </p:txBody>
@@ -12845,7 +13075,7 @@
           <p:cNvPr id="34" name="">
             <a:extLst xmlns:a="http://schemas.openxmlformats.org/drawingml/2006/main">
               <a:ext uri="{FF2B5EF4-FFF2-40B4-BE49-F238E27FC236}">
-                <a16:creationId xmlns:a16="http://schemas.microsoft.com/office/drawing/2014/main" id="{77F6F297-FD4C-45E7-9816-9906F0B04D1B}"/>
+                <a16:creationId xmlns:a16="http://schemas.microsoft.com/office/drawing/2014/main" id="{4AFDFD67-8C6A-489A-87D0-D62F2E421F62}"/>
               </a:ext>
             </a:extLst>
           </p:cNvPr>
@@ -12880,7 +13110,7 @@
           <p:cNvPr id="35" name="">
             <a:extLst xmlns:a="http://schemas.openxmlformats.org/drawingml/2006/main">
               <a:ext uri="{FF2B5EF4-FFF2-40B4-BE49-F238E27FC236}">
-                <a16:creationId xmlns:a16="http://schemas.microsoft.com/office/drawing/2014/main" id="{75BAAAED-7BB8-4ACF-B51F-5C80EA4EDA28}"/>
+                <a16:creationId xmlns:a16="http://schemas.microsoft.com/office/drawing/2014/main" id="{3219C101-56E7-4F6E-B283-7CAB441D119C}"/>
               </a:ext>
             </a:extLst>
           </p:cNvPr>
@@ -12928,7 +13158,7 @@
                 <a:ea typeface="Aptos"/>
                 <a:cs typeface="Aptos"/>
               </a:rPr>
-              <a:t>Method note: priority scores combine market, competitor, customer, roadmap, source-quality and time-sensitivity factors.</a:t>
+              <a:t>Snapshot: waters-ci-20260728-202611 · As of 2026-07-28T20:26:11 · Business magnitude requires Waters internal data.</a:t>
             </a:r>
           </a:p>
         </p:txBody>
@@ -12938,7 +13168,7 @@
           <p:cNvPr id="36" name="">
             <a:extLst xmlns:a="http://schemas.openxmlformats.org/drawingml/2006/main">
               <a:ext uri="{FF2B5EF4-FFF2-40B4-BE49-F238E27FC236}">
-                <a16:creationId xmlns:a16="http://schemas.microsoft.com/office/drawing/2014/main" id="{255B3EB3-93E2-4D40-9AFF-7FCBA05820F7}"/>
+                <a16:creationId xmlns:a16="http://schemas.microsoft.com/office/drawing/2014/main" id="{F93FDE16-91B8-4C06-BE58-D55A2232C455}"/>
               </a:ext>
             </a:extLst>
           </p:cNvPr>
@@ -12950,7 +13180,7 @@
         <p:spPr>
           <a:xfrm xmlns:a="http://schemas.openxmlformats.org/drawingml/2006/main">
             <a:off x="514350" y="6477000"/>
-            <a:ext cx="8191500" cy="190500"/>
+            <a:ext cx="9810750" cy="190500"/>
           </a:xfrm>
           <a:prstGeom xmlns:a="http://schemas.openxmlformats.org/drawingml/2006/main" prst="rect">
             <a:avLst/>
@@ -12986,7 +13216,7 @@
                 <a:ea typeface="Aptos"/>
                 <a:cs typeface="Aptos"/>
               </a:rPr>
-              <a:t>WATERS NEXT GEN COMPETITIVE INTELLIGENCE · 23 JUL 2026</a:t>
+              <a:t>WATERS NEXT GEN COMPETITIVE INTELLIGENCE · 28 JUL 2026 · waters-ci-20260728-202611</a:t>
             </a:r>
           </a:p>
         </p:txBody>
@@ -12996,7 +13226,7 @@
           <p:cNvPr id="37" name="">
             <a:extLst xmlns:a="http://schemas.openxmlformats.org/drawingml/2006/main">
               <a:ext uri="{FF2B5EF4-FFF2-40B4-BE49-F238E27FC236}">
-                <a16:creationId xmlns:a16="http://schemas.microsoft.com/office/drawing/2014/main" id="{7D562509-A741-40A9-ADA7-CF3B936AE807}"/>
+                <a16:creationId xmlns:a16="http://schemas.microsoft.com/office/drawing/2014/main" id="{048F5C99-0D88-4F6C-B809-D554AC3A828E}"/>
               </a:ext>
             </a:extLst>
           </p:cNvPr>
@@ -13052,7 +13282,7 @@
     </p:spTree>
     <p:extLst>
       <p:ext uri="{BB962C8B-B14F-4D97-AF65-F5344CB8AC3E}">
-        <p14:creationId xmlns:p14="http://schemas.microsoft.com/office/powerpoint/2010/main" val="2051886855"/>
+        <p14:creationId xmlns:p14="http://schemas.microsoft.com/office/powerpoint/2010/main" val="634233799"/>
       </p:ext>
     </p:extLst>
   </p:cSld>

</xml_diff>

<commit_message>
chore: refresh intelligence and cloud schedule
</commit_message>
<xml_diff>
--- a/deploy-site/exports/waters-nextgen-leadership-brief.pptx
+++ b/deploy-site/exports/waters-nextgen-leadership-brief.pptx
@@ -2,20 +2,20 @@
 <file path=ppt/presentation.xml><?xml version="1.0" encoding="utf-8"?>
 <p:presentation xmlns:p="http://schemas.openxmlformats.org/presentationml/2006/main">
   <p:sldMasterIdLst>
-    <p:sldMasterId xmlns:r="http://schemas.openxmlformats.org/officeDocument/2006/relationships" id="2147483648" r:id="Rf7105d1000f24301"/>
+    <p:sldMasterId xmlns:r="http://schemas.openxmlformats.org/officeDocument/2006/relationships" id="2147483648" r:id="Rd7f68449db4440f2"/>
   </p:sldMasterIdLst>
   <p:notesMasterIdLst>
-    <p:notesMasterId xmlns:r="http://schemas.openxmlformats.org/officeDocument/2006/relationships" r:id="Rec788046dc4b4679"/>
+    <p:notesMasterId xmlns:r="http://schemas.openxmlformats.org/officeDocument/2006/relationships" r:id="Ree9d64bb38154449"/>
   </p:notesMasterIdLst>
   <p:sldIdLst>
-    <p:sldId xmlns:r="http://schemas.openxmlformats.org/officeDocument/2006/relationships" id="256" r:id="R082eb740ad9d4333"/>
-    <p:sldId xmlns:r="http://schemas.openxmlformats.org/officeDocument/2006/relationships" id="257" r:id="R210f01b1d4874913"/>
-    <p:sldId xmlns:r="http://schemas.openxmlformats.org/officeDocument/2006/relationships" id="258" r:id="R1f9208dd8b644ec9"/>
-    <p:sldId xmlns:r="http://schemas.openxmlformats.org/officeDocument/2006/relationships" id="259" r:id="R4f0ec28199fb4aec"/>
-    <p:sldId xmlns:r="http://schemas.openxmlformats.org/officeDocument/2006/relationships" id="260" r:id="R0c6a496550534181"/>
-    <p:sldId xmlns:r="http://schemas.openxmlformats.org/officeDocument/2006/relationships" id="261" r:id="R1191622e333c45a3"/>
-    <p:sldId xmlns:r="http://schemas.openxmlformats.org/officeDocument/2006/relationships" id="262" r:id="R9b9cb531c25a4aae"/>
-    <p:sldId xmlns:r="http://schemas.openxmlformats.org/officeDocument/2006/relationships" id="263" r:id="R43ff276ea4ed46c1"/>
+    <p:sldId xmlns:r="http://schemas.openxmlformats.org/officeDocument/2006/relationships" id="256" r:id="Rd64d390c99994fb0"/>
+    <p:sldId xmlns:r="http://schemas.openxmlformats.org/officeDocument/2006/relationships" id="257" r:id="R5d172cdb27ea4e33"/>
+    <p:sldId xmlns:r="http://schemas.openxmlformats.org/officeDocument/2006/relationships" id="258" r:id="R0a179b4323e7451b"/>
+    <p:sldId xmlns:r="http://schemas.openxmlformats.org/officeDocument/2006/relationships" id="259" r:id="R1163a224a5a0479d"/>
+    <p:sldId xmlns:r="http://schemas.openxmlformats.org/officeDocument/2006/relationships" id="260" r:id="Rdfc24e2d6cfe4375"/>
+    <p:sldId xmlns:r="http://schemas.openxmlformats.org/officeDocument/2006/relationships" id="261" r:id="R45fc0b0f97704f53"/>
+    <p:sldId xmlns:r="http://schemas.openxmlformats.org/officeDocument/2006/relationships" id="262" r:id="Rd201ab4733dd401a"/>
+    <p:sldId xmlns:r="http://schemas.openxmlformats.org/officeDocument/2006/relationships" id="263" r:id="R27f516412f774fe8"/>
   </p:sldIdLst>
   <p:sldSz cx="12192000" cy="6858000"/>
   <p:notesSz cx="6858000" cy="9144000"/>
@@ -529,17 +529,17 @@
           </a:p>
           <a:p xmlns:a="http://schemas.openxmlformats.org/drawingml/2006/main">
             <a:r>
-              <a:t>- https://pubmed.ncbi.nlm.nih.gov/?term=%28%28%22laboratory+automation%22+OR+%22workflow+software%22+OR+%22AI%22%29+AND+%28%22LC-MS%22+OR+chromatography+OR+%22mass+spectrometry%22%29%29+AND+%28%222025%2F08%2F02%22%5BDate+-+Publication%5D+%3A+%222026%2F08%2F02%22%5BDate+-+Publication%5D%29</a:t>
-            </a:r>
-          </a:p>
-          <a:p xmlns:a="http://schemas.openxmlformats.org/drawingml/2006/main">
-            <a:r>
-              <a:t>- https://pubmed.ncbi.nlm.nih.gov/?term=%28%28PFAS+OR+%22per-+and+polyfluoroalkyl%22%29+AND+%28%22LC-MS%22+OR+%22LC-MS%2FMS%22+OR+chromatography%29%29+AND+%28%222025%2F08%2F02%22%5BDate+-+Publication%5D+%3A+%222026%2F08%2F02%22%5BDate+-+Publication%5D%29</a:t>
-            </a:r>
-          </a:p>
-          <a:p xmlns:a="http://schemas.openxmlformats.org/drawingml/2006/main">
-            <a:r>
-              <a:t>- https://pubmed.ncbi.nlm.nih.gov/?term=%28%28oligonucleotide+OR+%22nucleic+acid%22+OR+siRNA%29+AND+%28%22LC-MS%22+OR+chromatography+OR+%22mass+spectrometry%22%29%29+AND+%28%222025%2F08%2F02%22%5BDate+-+Publication%5D+%3A+%222026%2F08%2F02%22%5BDate+-+Publication%5D%29</a:t>
+              <a:t>- https://pubmed.ncbi.nlm.nih.gov/?term=%28%28%22laboratory+automation%22+OR+%22workflow+software%22+OR+%22AI%22%29+AND+%28%22LC-MS%22+OR+chromatography+OR+%22mass+spectrometry%22%29%29+AND+%28%222025%2F08%2F13%22%5BDate+-+Publication%5D+%3A+%222026%2F08%2F13%22%5BDate+-+Publication%5D%29</a:t>
+            </a:r>
+          </a:p>
+          <a:p xmlns:a="http://schemas.openxmlformats.org/drawingml/2006/main">
+            <a:r>
+              <a:t>- https://pubmed.ncbi.nlm.nih.gov/?term=%28%28PFAS+OR+%22per-+and+polyfluoroalkyl%22%29+AND+%28%22LC-MS%22+OR+%22LC-MS%2FMS%22+OR+chromatography%29%29+AND+%28%222025%2F08%2F13%22%5BDate+-+Publication%5D+%3A+%222026%2F08%2F13%22%5BDate+-+Publication%5D%29</a:t>
+            </a:r>
+          </a:p>
+          <a:p xmlns:a="http://schemas.openxmlformats.org/drawingml/2006/main">
+            <a:r>
+              <a:t>- https://pubmed.ncbi.nlm.nih.gov/?term=%28%28oligonucleotide+OR+%22nucleic+acid%22+OR+siRNA%29+AND+%28%22LC-MS%22+OR+chromatography+OR+%22mass+spectrometry%22%29%29+AND+%28%222025%2F08%2F13%22%5BDate+-+Publication%5D+%3A+%222026%2F08%2F13%22%5BDate+-+Publication%5D%29</a:t>
             </a:r>
           </a:p>
           <a:p xmlns:a="http://schemas.openxmlformats.org/drawingml/2006/main">
@@ -619,7 +619,7 @@
           </a:p>
           <a:p xmlns:a="http://schemas.openxmlformats.org/drawingml/2006/main">
             <a:r>
-              <a:t>- https://pubmed.ncbi.nlm.nih.gov/?term=%28%28PFAS+OR+%22per-+and+polyfluoroalkyl%22%29+AND+%28%22LC-MS%22+OR+%22LC-MS%2FMS%22+OR+chromatography%29%29+AND+%28%222025%2F08%2F02%22%5BDate+-+Publication%5D+%3A+%222026%2F08%2F02%22%5BDate+-+Publication%5D%29</a:t>
+              <a:t>- https://pubmed.ncbi.nlm.nih.gov/?term=%28%28PFAS+OR+%22per-+and+polyfluoroalkyl%22%29+AND+%28%22LC-MS%22+OR+%22LC-MS%2FMS%22+OR+chromatography%29%29+AND+%28%222025%2F08%2F13%22%5BDate+-+Publication%5D+%3A+%222026%2F08%2F13%22%5BDate+-+Publication%5D%29</a:t>
             </a:r>
           </a:p>
           <a:p xmlns:a="http://schemas.openxmlformats.org/drawingml/2006/main">
@@ -949,7 +949,7 @@
           </a:p>
           <a:p xmlns:a="http://schemas.openxmlformats.org/drawingml/2006/main">
             <a:r>
-              <a:t>- https://pubmed.ncbi.nlm.nih.gov/?term=%28%28PFAS+OR+%22per-+and+polyfluoroalkyl%22%29+AND+%28%22LC-MS%22+OR+%22LC-MS%2FMS%22+OR+chromatography%29%29+AND+%28%222025%2F08%2F02%22%5BDate+-+Publication%5D+%3A+%222026%2F08%2F02%22%5BDate+-+Publication%5D%29</a:t>
+              <a:t>- https://pubmed.ncbi.nlm.nih.gov/?term=%28%28PFAS+OR+%22per-+and+polyfluoroalkyl%22%29+AND+%28%22LC-MS%22+OR+%22LC-MS%2FMS%22+OR+chromatography%29%29+AND+%28%222025%2F08%2F13%22%5BDate+-+Publication%5D+%3A+%222026%2F08%2F13%22%5BDate+-+Publication%5D%29</a:t>
             </a:r>
           </a:p>
           <a:p xmlns:a="http://schemas.openxmlformats.org/drawingml/2006/main">
@@ -969,7 +969,7 @@
           </a:p>
           <a:p xmlns:a="http://schemas.openxmlformats.org/drawingml/2006/main">
             <a:r>
-              <a:t>- https://pubmed.ncbi.nlm.nih.gov/?term=%28%28%22laboratory+automation%22+OR+%22workflow+software%22+OR+%22AI%22%29+AND+%28%22LC-MS%22+OR+chromatography+OR+%22mass+spectrometry%22%29%29+AND+%28%222025%2F08%2F02%22%5BDate+-+Publication%5D+%3A+%222026%2F08%2F02%22%5BDate+-+Publication%5D%29</a:t>
+              <a:t>- https://pubmed.ncbi.nlm.nih.gov/?term=%28%28%22laboratory+automation%22+OR+%22workflow+software%22+OR+%22AI%22%29+AND+%28%22LC-MS%22+OR+chromatography+OR+%22mass+spectrometry%22%29%29+AND+%28%222025%2F08%2F13%22%5BDate+-+Publication%5D+%3A+%222026%2F08%2F13%22%5BDate+-+Publication%5D%29</a:t>
             </a:r>
           </a:p>
           <a:p xmlns:a="http://schemas.openxmlformats.org/drawingml/2006/main">
@@ -984,7 +984,7 @@
           </a:p>
           <a:p xmlns:a="http://schemas.openxmlformats.org/drawingml/2006/main">
             <a:r>
-              <a:t>- https://pubmed.ncbi.nlm.nih.gov/?term=%28%28oligonucleotide+OR+%22nucleic+acid%22+OR+siRNA%29+AND+%28%22LC-MS%22+OR+chromatography+OR+%22mass+spectrometry%22%29%29+AND+%28%222025%2F08%2F02%22%5BDate+-+Publication%5D+%3A+%222026%2F08%2F02%22%5BDate+-+Publication%5D%29</a:t>
+              <a:t>- https://pubmed.ncbi.nlm.nih.gov/?term=%28%28oligonucleotide+OR+%22nucleic+acid%22+OR+siRNA%29+AND+%28%22LC-MS%22+OR+chromatography+OR+%22mass+spectrometry%22%29%29+AND+%28%222025%2F08%2F13%22%5BDate+-+Publication%5D+%3A+%222026%2F08%2F13%22%5BDate+-+Publication%5D%29</a:t>
             </a:r>
           </a:p>
           <a:p xmlns:a="http://schemas.openxmlformats.org/drawingml/2006/main">
@@ -1079,7 +1079,7 @@
           </a:p>
           <a:p xmlns:a="http://schemas.openxmlformats.org/drawingml/2006/main">
             <a:r>
-              <a:t>- https://pubmed.ncbi.nlm.nih.gov/?term=%28%28PFAS+OR+%22per-+and+polyfluoroalkyl%22%29+AND+%28%22LC-MS%22+OR+%22LC-MS%2FMS%22+OR+chromatography%29%29+AND+%28%222025%2F08%2F02%22%5BDate+-+Publication%5D+%3A+%222026%2F08%2F02%22%5BDate+-+Publication%5D%29</a:t>
+              <a:t>- https://pubmed.ncbi.nlm.nih.gov/?term=%28%28PFAS+OR+%22per-+and+polyfluoroalkyl%22%29+AND+%28%22LC-MS%22+OR+%22LC-MS%2FMS%22+OR+chromatography%29%29+AND+%28%222025%2F08%2F13%22%5BDate+-+Publication%5D+%3A+%222026%2F08%2F13%22%5BDate+-+Publication%5D%29</a:t>
             </a:r>
           </a:p>
           <a:p xmlns:a="http://schemas.openxmlformats.org/drawingml/2006/main">
@@ -1099,7 +1099,7 @@
           </a:p>
           <a:p xmlns:a="http://schemas.openxmlformats.org/drawingml/2006/main">
             <a:r>
-              <a:t>- https://pubmed.ncbi.nlm.nih.gov/?term=%28%28%22laboratory+automation%22+OR+%22workflow+software%22+OR+%22AI%22%29+AND+%28%22LC-MS%22+OR+chromatography+OR+%22mass+spectrometry%22%29%29+AND+%28%222025%2F08%2F02%22%5BDate+-+Publication%5D+%3A+%222026%2F08%2F02%22%5BDate+-+Publication%5D%29</a:t>
+              <a:t>- https://pubmed.ncbi.nlm.nih.gov/?term=%28%28%22laboratory+automation%22+OR+%22workflow+software%22+OR+%22AI%22%29+AND+%28%22LC-MS%22+OR+chromatography+OR+%22mass+spectrometry%22%29%29+AND+%28%222025%2F08%2F13%22%5BDate+-+Publication%5D+%3A+%222026%2F08%2F13%22%5BDate+-+Publication%5D%29</a:t>
             </a:r>
           </a:p>
           <a:p xmlns:a="http://schemas.openxmlformats.org/drawingml/2006/main">
@@ -1114,7 +1114,7 @@
           </a:p>
           <a:p xmlns:a="http://schemas.openxmlformats.org/drawingml/2006/main">
             <a:r>
-              <a:t>- https://pubmed.ncbi.nlm.nih.gov/?term=%28%28oligonucleotide+OR+%22nucleic+acid%22+OR+siRNA%29+AND+%28%22LC-MS%22+OR+chromatography+OR+%22mass+spectrometry%22%29%29+AND+%28%222025%2F08%2F02%22%5BDate+-+Publication%5D+%3A+%222026%2F08%2F02%22%5BDate+-+Publication%5D%29</a:t>
+              <a:t>- https://pubmed.ncbi.nlm.nih.gov/?term=%28%28oligonucleotide+OR+%22nucleic+acid%22+OR+siRNA%29+AND+%28%22LC-MS%22+OR+chromatography+OR+%22mass+spectrometry%22%29%29+AND+%28%222025%2F08%2F13%22%5BDate+-+Publication%5D+%3A+%222026%2F08%2F13%22%5BDate+-+Publication%5D%29</a:t>
             </a:r>
           </a:p>
           <a:p xmlns:a="http://schemas.openxmlformats.org/drawingml/2006/main">
@@ -1194,7 +1194,7 @@
           </a:p>
           <a:p xmlns:a="http://schemas.openxmlformats.org/drawingml/2006/main">
             <a:r>
-              <a:t>- https://pubmed.ncbi.nlm.nih.gov/?term=%28%28PFAS+OR+%22per-+and+polyfluoroalkyl%22%29+AND+%28%22LC-MS%22+OR+%22LC-MS%2FMS%22+OR+chromatography%29%29+AND+%28%222025%2F08%2F02%22%5BDate+-+Publication%5D+%3A+%222026%2F08%2F02%22%5BDate+-+Publication%5D%29</a:t>
+              <a:t>- https://pubmed.ncbi.nlm.nih.gov/?term=%28%28PFAS+OR+%22per-+and+polyfluoroalkyl%22%29+AND+%28%22LC-MS%22+OR+%22LC-MS%2FMS%22+OR+chromatography%29%29+AND+%28%222025%2F08%2F13%22%5BDate+-+Publication%5D+%3A+%222026%2F08%2F13%22%5BDate+-+Publication%5D%29</a:t>
             </a:r>
           </a:p>
           <a:p xmlns:a="http://schemas.openxmlformats.org/drawingml/2006/main">
@@ -1292,7 +1292,7 @@
   </p:cSld>
   <p:clrMap bg1="lt1" tx1="dk1" bg2="lt2" tx2="dk2" accent1="accent1" accent2="accent2" accent3="accent3" accent4="accent4" accent5="accent5" accent6="accent6" hlink="hlink" folHlink="folHlink"/>
   <p:sldLayoutIdLst>
-    <p:sldLayoutId xmlns:r="http://schemas.openxmlformats.org/officeDocument/2006/relationships" id="2147483649" r:id="R21f03e67d6e24747"/>
+    <p:sldLayoutId xmlns:r="http://schemas.openxmlformats.org/officeDocument/2006/relationships" id="2147483649" r:id="R0f40835474de45f6"/>
   </p:sldLayoutIdLst>
   <p:txStyles>
     <p:titleStyle>
@@ -1843,7 +1843,7 @@
           <p:cNvPr id="14" name="">
             <a:extLst xmlns:a="http://schemas.openxmlformats.org/drawingml/2006/main">
               <a:ext uri="{FF2B5EF4-FFF2-40B4-BE49-F238E27FC236}">
-                <a16:creationId xmlns:a16="http://schemas.microsoft.com/office/drawing/2014/main" id="{B5A87100-EAD3-404A-9841-C5A235C5B405}"/>
+                <a16:creationId xmlns:a16="http://schemas.microsoft.com/office/drawing/2014/main" id="{7A0B6A4D-7F9D-45F4-AF77-E8FE91A9B23C}"/>
               </a:ext>
             </a:extLst>
           </p:cNvPr>
@@ -1876,7 +1876,7 @@
           <p:cNvPr id="2" name="">
             <a:extLst xmlns:a="http://schemas.openxmlformats.org/drawingml/2006/main">
               <a:ext uri="{FF2B5EF4-FFF2-40B4-BE49-F238E27FC236}">
-                <a16:creationId xmlns:a16="http://schemas.microsoft.com/office/drawing/2014/main" id="{C9DA041D-8E7B-417C-B702-A9D7B319F4A6}"/>
+                <a16:creationId xmlns:a16="http://schemas.microsoft.com/office/drawing/2014/main" id="{DF822AB8-4672-4E57-ADE9-B5297CB5B7E2}"/>
               </a:ext>
             </a:extLst>
           </p:cNvPr>
@@ -1934,7 +1934,7 @@
           <p:cNvPr id="3" name="">
             <a:extLst xmlns:a="http://schemas.openxmlformats.org/drawingml/2006/main">
               <a:ext uri="{FF2B5EF4-FFF2-40B4-BE49-F238E27FC236}">
-                <a16:creationId xmlns:a16="http://schemas.microsoft.com/office/drawing/2014/main" id="{D6067D50-17B1-4141-9B7C-6DCF130EF82E}"/>
+                <a16:creationId xmlns:a16="http://schemas.microsoft.com/office/drawing/2014/main" id="{99F7FB0F-F399-4BC9-9F2A-399FF7D67428}"/>
               </a:ext>
             </a:extLst>
           </p:cNvPr>
@@ -1992,7 +1992,7 @@
           <p:cNvPr id="4" name="">
             <a:extLst xmlns:a="http://schemas.openxmlformats.org/drawingml/2006/main">
               <a:ext uri="{FF2B5EF4-FFF2-40B4-BE49-F238E27FC236}">
-                <a16:creationId xmlns:a16="http://schemas.microsoft.com/office/drawing/2014/main" id="{8687B0E1-C2B8-456A-B7FC-83E445F7FF75}"/>
+                <a16:creationId xmlns:a16="http://schemas.microsoft.com/office/drawing/2014/main" id="{CE45D295-9C23-4A0F-974D-0137CB618D48}"/>
               </a:ext>
             </a:extLst>
           </p:cNvPr>
@@ -2050,7 +2050,7 @@
           <p:cNvPr id="5" name="">
             <a:extLst xmlns:a="http://schemas.openxmlformats.org/drawingml/2006/main">
               <a:ext uri="{FF2B5EF4-FFF2-40B4-BE49-F238E27FC236}">
-                <a16:creationId xmlns:a16="http://schemas.microsoft.com/office/drawing/2014/main" id="{B638A316-9303-4CC9-9EE8-8DEDE3D0E80F}"/>
+                <a16:creationId xmlns:a16="http://schemas.microsoft.com/office/drawing/2014/main" id="{DB3A916B-AF16-45DC-BBC8-7CFC2FBD3203}"/>
               </a:ext>
             </a:extLst>
           </p:cNvPr>
@@ -2108,7 +2108,7 @@
           <p:cNvPr id="6" name="">
             <a:extLst xmlns:a="http://schemas.openxmlformats.org/drawingml/2006/main">
               <a:ext uri="{FF2B5EF4-FFF2-40B4-BE49-F238E27FC236}">
-                <a16:creationId xmlns:a16="http://schemas.microsoft.com/office/drawing/2014/main" id="{FA3B15B9-A3CE-4259-A24C-D4EE2B4D6CB0}"/>
+                <a16:creationId xmlns:a16="http://schemas.microsoft.com/office/drawing/2014/main" id="{13A9F168-A677-4E56-9BE9-AB1A053006CE}"/>
               </a:ext>
             </a:extLst>
           </p:cNvPr>
@@ -2143,7 +2143,7 @@
           <p:cNvPr id="7" name="">
             <a:extLst xmlns:a="http://schemas.openxmlformats.org/drawingml/2006/main">
               <a:ext uri="{FF2B5EF4-FFF2-40B4-BE49-F238E27FC236}">
-                <a16:creationId xmlns:a16="http://schemas.microsoft.com/office/drawing/2014/main" id="{FA34EF81-060A-402A-8994-CAC90A3E81DA}"/>
+                <a16:creationId xmlns:a16="http://schemas.microsoft.com/office/drawing/2014/main" id="{6EAA1210-C3C6-400E-A153-45C8187D154F}"/>
               </a:ext>
             </a:extLst>
           </p:cNvPr>
@@ -2201,7 +2201,7 @@
           <p:cNvPr id="8" name="">
             <a:extLst xmlns:a="http://schemas.openxmlformats.org/drawingml/2006/main">
               <a:ext uri="{FF2B5EF4-FFF2-40B4-BE49-F238E27FC236}">
-                <a16:creationId xmlns:a16="http://schemas.microsoft.com/office/drawing/2014/main" id="{BBA894A7-C1A4-4C79-9879-559AB0C34EE8}"/>
+                <a16:creationId xmlns:a16="http://schemas.microsoft.com/office/drawing/2014/main" id="{7C022E4F-7503-4546-B738-54B42CFF0D93}"/>
               </a:ext>
             </a:extLst>
           </p:cNvPr>
@@ -2249,7 +2249,7 @@
                 <a:ea typeface="Aptos"/>
                 <a:cs typeface="Aptos"/>
               </a:rPr>
-              <a:t>02</a:t>
+              <a:t>13</a:t>
             </a:r>
           </a:p>
         </p:txBody>
@@ -2259,7 +2259,7 @@
           <p:cNvPr id="9" name="">
             <a:extLst xmlns:a="http://schemas.openxmlformats.org/drawingml/2006/main">
               <a:ext uri="{FF2B5EF4-FFF2-40B4-BE49-F238E27FC236}">
-                <a16:creationId xmlns:a16="http://schemas.microsoft.com/office/drawing/2014/main" id="{885A235E-D7F9-4739-AA1B-E233C548A570}"/>
+                <a16:creationId xmlns:a16="http://schemas.microsoft.com/office/drawing/2014/main" id="{ED3BB944-8270-4531-B93C-2F557E8BC9A0}"/>
               </a:ext>
             </a:extLst>
           </p:cNvPr>
@@ -2317,7 +2317,7 @@
           <p:cNvPr id="10" name="">
             <a:extLst xmlns:a="http://schemas.openxmlformats.org/drawingml/2006/main">
               <a:ext uri="{FF2B5EF4-FFF2-40B4-BE49-F238E27FC236}">
-                <a16:creationId xmlns:a16="http://schemas.microsoft.com/office/drawing/2014/main" id="{90606D2F-1915-4003-B82C-E3F96C7CE918}"/>
+                <a16:creationId xmlns:a16="http://schemas.microsoft.com/office/drawing/2014/main" id="{C9CF5CC4-6504-4A01-A77C-AAE6069A4A25}"/>
               </a:ext>
             </a:extLst>
           </p:cNvPr>
@@ -2350,7 +2350,7 @@
           <p:cNvPr id="11" name="">
             <a:extLst xmlns:a="http://schemas.openxmlformats.org/drawingml/2006/main">
               <a:ext uri="{FF2B5EF4-FFF2-40B4-BE49-F238E27FC236}">
-                <a16:creationId xmlns:a16="http://schemas.microsoft.com/office/drawing/2014/main" id="{C671767F-A635-467F-8EDF-8B8CBAA91D4B}"/>
+                <a16:creationId xmlns:a16="http://schemas.microsoft.com/office/drawing/2014/main" id="{A8BC12D9-B1AB-4599-AA39-656C180396AF}"/>
               </a:ext>
             </a:extLst>
           </p:cNvPr>
@@ -2408,7 +2408,7 @@
           <p:cNvPr id="12" name="">
             <a:extLst xmlns:a="http://schemas.openxmlformats.org/drawingml/2006/main">
               <a:ext uri="{FF2B5EF4-FFF2-40B4-BE49-F238E27FC236}">
-                <a16:creationId xmlns:a16="http://schemas.microsoft.com/office/drawing/2014/main" id="{E345146E-25E2-476C-8B8A-4512665D95B4}"/>
+                <a16:creationId xmlns:a16="http://schemas.microsoft.com/office/drawing/2014/main" id="{F409315A-CA92-4D7D-B3E6-010F76D6DD50}"/>
               </a:ext>
             </a:extLst>
           </p:cNvPr>
@@ -2456,7 +2456,7 @@
                 <a:ea typeface="Aptos"/>
                 <a:cs typeface="Aptos"/>
               </a:rPr>
-              <a:t>Prepared for roadmap review · waters-ci-20260802160152</a:t>
+              <a:t>Prepared for roadmap review · waters-ci-20260813070817</a:t>
             </a:r>
           </a:p>
         </p:txBody>
@@ -2466,7 +2466,7 @@
           <p:cNvPr id="13" name="">
             <a:extLst xmlns:a="http://schemas.openxmlformats.org/drawingml/2006/main">
               <a:ext uri="{FF2B5EF4-FFF2-40B4-BE49-F238E27FC236}">
-                <a16:creationId xmlns:a16="http://schemas.microsoft.com/office/drawing/2014/main" id="{E05B7467-DF16-40CE-B910-9DA851BBB25C}"/>
+                <a16:creationId xmlns:a16="http://schemas.microsoft.com/office/drawing/2014/main" id="{27AA9721-D91D-4037-B81A-614EC86EA35E}"/>
               </a:ext>
             </a:extLst>
           </p:cNvPr>
@@ -2522,7 +2522,7 @@
     </p:spTree>
     <p:extLst>
       <p:ext uri="{BB962C8B-B14F-4D97-AF65-F5344CB8AC3E}">
-        <p14:creationId xmlns:p14="http://schemas.microsoft.com/office/powerpoint/2010/main" val="988591461"/>
+        <p14:creationId xmlns:p14="http://schemas.microsoft.com/office/powerpoint/2010/main" val="228314583"/>
       </p:ext>
     </p:extLst>
   </p:cSld>
@@ -2553,7 +2553,7 @@
           <p:cNvPr id="25" name="">
             <a:extLst xmlns:a="http://schemas.openxmlformats.org/drawingml/2006/main">
               <a:ext uri="{FF2B5EF4-FFF2-40B4-BE49-F238E27FC236}">
-                <a16:creationId xmlns:a16="http://schemas.microsoft.com/office/drawing/2014/main" id="{F2F0D821-C588-4C5E-9A7D-D792081C858F}"/>
+                <a16:creationId xmlns:a16="http://schemas.microsoft.com/office/drawing/2014/main" id="{9EF3EE79-08F8-4179-B3F6-D600C3EA04F0}"/>
               </a:ext>
             </a:extLst>
           </p:cNvPr>
@@ -2611,7 +2611,7 @@
           <p:cNvPr id="2" name="">
             <a:extLst xmlns:a="http://schemas.openxmlformats.org/drawingml/2006/main">
               <a:ext uri="{FF2B5EF4-FFF2-40B4-BE49-F238E27FC236}">
-                <a16:creationId xmlns:a16="http://schemas.microsoft.com/office/drawing/2014/main" id="{00A154E1-FDDC-40B3-AEF7-E17D3F34272B}"/>
+                <a16:creationId xmlns:a16="http://schemas.microsoft.com/office/drawing/2014/main" id="{DA4D2EDD-4DDB-4997-B9A9-D1DD3D1197A5}"/>
               </a:ext>
             </a:extLst>
           </p:cNvPr>
@@ -2669,7 +2669,7 @@
           <p:cNvPr id="3" name="">
             <a:extLst xmlns:a="http://schemas.openxmlformats.org/drawingml/2006/main">
               <a:ext uri="{FF2B5EF4-FFF2-40B4-BE49-F238E27FC236}">
-                <a16:creationId xmlns:a16="http://schemas.microsoft.com/office/drawing/2014/main" id="{9F0B4BA0-A826-4B17-AC9F-69CFD88F9C6F}"/>
+                <a16:creationId xmlns:a16="http://schemas.microsoft.com/office/drawing/2014/main" id="{2793D056-D89F-4EAF-90FA-1EDB99712529}"/>
               </a:ext>
             </a:extLst>
           </p:cNvPr>
@@ -2727,7 +2727,7 @@
           <p:cNvPr id="4" name="">
             <a:extLst xmlns:a="http://schemas.openxmlformats.org/drawingml/2006/main">
               <a:ext uri="{FF2B5EF4-FFF2-40B4-BE49-F238E27FC236}">
-                <a16:creationId xmlns:a16="http://schemas.microsoft.com/office/drawing/2014/main" id="{81C45C44-C531-4865-AA6B-094D0B0CBCCB}"/>
+                <a16:creationId xmlns:a16="http://schemas.microsoft.com/office/drawing/2014/main" id="{21A14686-DD51-4FB1-8F2E-89DB23827406}"/>
               </a:ext>
             </a:extLst>
           </p:cNvPr>
@@ -2760,7 +2760,7 @@
           <p:cNvPr id="5" name="">
             <a:extLst xmlns:a="http://schemas.openxmlformats.org/drawingml/2006/main">
               <a:ext uri="{FF2B5EF4-FFF2-40B4-BE49-F238E27FC236}">
-                <a16:creationId xmlns:a16="http://schemas.microsoft.com/office/drawing/2014/main" id="{3B465407-7037-4558-896B-32B917A2EF28}"/>
+                <a16:creationId xmlns:a16="http://schemas.microsoft.com/office/drawing/2014/main" id="{819777BE-61BB-44E6-BCEE-4D9365808432}"/>
               </a:ext>
             </a:extLst>
           </p:cNvPr>
@@ -2795,7 +2795,7 @@
           <p:cNvPr id="6" name="">
             <a:extLst xmlns:a="http://schemas.openxmlformats.org/drawingml/2006/main">
               <a:ext uri="{FF2B5EF4-FFF2-40B4-BE49-F238E27FC236}">
-                <a16:creationId xmlns:a16="http://schemas.microsoft.com/office/drawing/2014/main" id="{FA6B8D71-1E73-4F64-BBC9-18D13054BFFA}"/>
+                <a16:creationId xmlns:a16="http://schemas.microsoft.com/office/drawing/2014/main" id="{6B161206-5228-4C8F-A87D-8869498E69CD}"/>
               </a:ext>
             </a:extLst>
           </p:cNvPr>
@@ -2853,7 +2853,7 @@
           <p:cNvPr id="7" name="">
             <a:extLst xmlns:a="http://schemas.openxmlformats.org/drawingml/2006/main">
               <a:ext uri="{FF2B5EF4-FFF2-40B4-BE49-F238E27FC236}">
-                <a16:creationId xmlns:a16="http://schemas.microsoft.com/office/drawing/2014/main" id="{1D8A9F43-3E71-4025-8147-10EF68D8803F}"/>
+                <a16:creationId xmlns:a16="http://schemas.microsoft.com/office/drawing/2014/main" id="{E5BE9CDB-B03B-4806-84E8-5B7812FDCF3A}"/>
               </a:ext>
             </a:extLst>
           </p:cNvPr>
@@ -2911,7 +2911,7 @@
           <p:cNvPr id="8" name="">
             <a:extLst xmlns:a="http://schemas.openxmlformats.org/drawingml/2006/main">
               <a:ext uri="{FF2B5EF4-FFF2-40B4-BE49-F238E27FC236}">
-                <a16:creationId xmlns:a16="http://schemas.microsoft.com/office/drawing/2014/main" id="{963F4D18-05C0-40B3-9BDA-9D0B2B4EB4F8}"/>
+                <a16:creationId xmlns:a16="http://schemas.microsoft.com/office/drawing/2014/main" id="{CAE4C9EA-241C-4198-88F4-5ECAA72295F8}"/>
               </a:ext>
             </a:extLst>
           </p:cNvPr>
@@ -2946,7 +2946,7 @@
           <p:cNvPr id="9" name="">
             <a:extLst xmlns:a="http://schemas.openxmlformats.org/drawingml/2006/main">
               <a:ext uri="{FF2B5EF4-FFF2-40B4-BE49-F238E27FC236}">
-                <a16:creationId xmlns:a16="http://schemas.microsoft.com/office/drawing/2014/main" id="{C74F20DB-12AA-4751-A3B5-4061F65369C7}"/>
+                <a16:creationId xmlns:a16="http://schemas.microsoft.com/office/drawing/2014/main" id="{5F544C0F-CD6C-4C45-AE79-192B57F1B327}"/>
               </a:ext>
             </a:extLst>
           </p:cNvPr>
@@ -2979,7 +2979,7 @@
           <p:cNvPr id="10" name="">
             <a:extLst xmlns:a="http://schemas.openxmlformats.org/drawingml/2006/main">
               <a:ext uri="{FF2B5EF4-FFF2-40B4-BE49-F238E27FC236}">
-                <a16:creationId xmlns:a16="http://schemas.microsoft.com/office/drawing/2014/main" id="{D3651619-62B3-475F-9227-16B5AE3D52D6}"/>
+                <a16:creationId xmlns:a16="http://schemas.microsoft.com/office/drawing/2014/main" id="{A5CB1788-77C2-4284-AEDA-018A209DA893}"/>
               </a:ext>
             </a:extLst>
           </p:cNvPr>
@@ -3027,7 +3027,7 @@
                 <a:ea typeface="Aptos"/>
                 <a:cs typeface="Aptos"/>
               </a:rPr>
-              <a:t>1,125</a:t>
+              <a:t>1,135</a:t>
             </a:r>
           </a:p>
         </p:txBody>
@@ -3037,7 +3037,7 @@
           <p:cNvPr id="11" name="">
             <a:extLst xmlns:a="http://schemas.openxmlformats.org/drawingml/2006/main">
               <a:ext uri="{FF2B5EF4-FFF2-40B4-BE49-F238E27FC236}">
-                <a16:creationId xmlns:a16="http://schemas.microsoft.com/office/drawing/2014/main" id="{F8DD452D-9A57-4CF1-8C67-8BAA776769EF}"/>
+                <a16:creationId xmlns:a16="http://schemas.microsoft.com/office/drawing/2014/main" id="{AEF82C2F-E1EB-4E29-9F2C-596BC6AD4D03}"/>
               </a:ext>
             </a:extLst>
           </p:cNvPr>
@@ -3095,7 +3095,7 @@
           <p:cNvPr id="12" name="">
             <a:extLst xmlns:a="http://schemas.openxmlformats.org/drawingml/2006/main">
               <a:ext uri="{FF2B5EF4-FFF2-40B4-BE49-F238E27FC236}">
-                <a16:creationId xmlns:a16="http://schemas.microsoft.com/office/drawing/2014/main" id="{D7675103-926D-4495-9C25-D8666A58FFC7}"/>
+                <a16:creationId xmlns:a16="http://schemas.microsoft.com/office/drawing/2014/main" id="{B61055B1-C5CF-4909-AED8-9C0CDA0FA744}"/>
               </a:ext>
             </a:extLst>
           </p:cNvPr>
@@ -3153,7 +3153,7 @@
           <p:cNvPr id="13" name="">
             <a:extLst xmlns:a="http://schemas.openxmlformats.org/drawingml/2006/main">
               <a:ext uri="{FF2B5EF4-FFF2-40B4-BE49-F238E27FC236}">
-                <a16:creationId xmlns:a16="http://schemas.microsoft.com/office/drawing/2014/main" id="{04F6E325-5265-4A5A-BEFD-F821A854B0AB}"/>
+                <a16:creationId xmlns:a16="http://schemas.microsoft.com/office/drawing/2014/main" id="{12D57292-7898-43E2-B5C3-702FC2778425}"/>
               </a:ext>
             </a:extLst>
           </p:cNvPr>
@@ -3188,7 +3188,7 @@
           <p:cNvPr id="14" name="">
             <a:extLst xmlns:a="http://schemas.openxmlformats.org/drawingml/2006/main">
               <a:ext uri="{FF2B5EF4-FFF2-40B4-BE49-F238E27FC236}">
-                <a16:creationId xmlns:a16="http://schemas.microsoft.com/office/drawing/2014/main" id="{4CCE382D-2424-456A-B77D-89C55236DBA5}"/>
+                <a16:creationId xmlns:a16="http://schemas.microsoft.com/office/drawing/2014/main" id="{507BD44F-1579-4F1B-A0E2-5AC7CFFE58C3}"/>
               </a:ext>
             </a:extLst>
           </p:cNvPr>
@@ -3221,7 +3221,7 @@
           <p:cNvPr id="15" name="">
             <a:extLst xmlns:a="http://schemas.openxmlformats.org/drawingml/2006/main">
               <a:ext uri="{FF2B5EF4-FFF2-40B4-BE49-F238E27FC236}">
-                <a16:creationId xmlns:a16="http://schemas.microsoft.com/office/drawing/2014/main" id="{BA590C74-13F7-4C7E-BED0-E7F4BF4BDC1B}"/>
+                <a16:creationId xmlns:a16="http://schemas.microsoft.com/office/drawing/2014/main" id="{0ED4F895-0BA8-4F9B-AF92-E3FCD2DDCA3E}"/>
               </a:ext>
             </a:extLst>
           </p:cNvPr>
@@ -3269,7 +3269,7 @@
                 <a:ea typeface="Aptos"/>
                 <a:cs typeface="Aptos"/>
               </a:rPr>
-              <a:t>325</a:t>
+              <a:t>335</a:t>
             </a:r>
           </a:p>
         </p:txBody>
@@ -3279,7 +3279,7 @@
           <p:cNvPr id="16" name="">
             <a:extLst xmlns:a="http://schemas.openxmlformats.org/drawingml/2006/main">
               <a:ext uri="{FF2B5EF4-FFF2-40B4-BE49-F238E27FC236}">
-                <a16:creationId xmlns:a16="http://schemas.microsoft.com/office/drawing/2014/main" id="{65C72A1C-07E6-4AF0-8CD9-FF7EB394FEBC}"/>
+                <a16:creationId xmlns:a16="http://schemas.microsoft.com/office/drawing/2014/main" id="{CE1E28F2-DA4E-4C4D-8152-D1E5DA208F03}"/>
               </a:ext>
             </a:extLst>
           </p:cNvPr>
@@ -3337,7 +3337,7 @@
           <p:cNvPr id="17" name="">
             <a:extLst xmlns:a="http://schemas.openxmlformats.org/drawingml/2006/main">
               <a:ext uri="{FF2B5EF4-FFF2-40B4-BE49-F238E27FC236}">
-                <a16:creationId xmlns:a16="http://schemas.microsoft.com/office/drawing/2014/main" id="{DA697C9B-3B86-4E29-B176-3F5F2FB5E1F1}"/>
+                <a16:creationId xmlns:a16="http://schemas.microsoft.com/office/drawing/2014/main" id="{DCC7D58D-0CC9-4758-82DD-0DD7BFFC2B13}"/>
               </a:ext>
             </a:extLst>
           </p:cNvPr>
@@ -3395,7 +3395,7 @@
           <p:cNvPr id="18" name="">
             <a:extLst xmlns:a="http://schemas.openxmlformats.org/drawingml/2006/main">
               <a:ext uri="{FF2B5EF4-FFF2-40B4-BE49-F238E27FC236}">
-                <a16:creationId xmlns:a16="http://schemas.microsoft.com/office/drawing/2014/main" id="{33F86412-A100-4211-93CC-E147C016994F}"/>
+                <a16:creationId xmlns:a16="http://schemas.microsoft.com/office/drawing/2014/main" id="{C060CD88-4C14-4E78-8682-3AE122656A40}"/>
               </a:ext>
             </a:extLst>
           </p:cNvPr>
@@ -3430,7 +3430,7 @@
           <p:cNvPr id="19" name="">
             <a:extLst xmlns:a="http://schemas.openxmlformats.org/drawingml/2006/main">
               <a:ext uri="{FF2B5EF4-FFF2-40B4-BE49-F238E27FC236}">
-                <a16:creationId xmlns:a16="http://schemas.microsoft.com/office/drawing/2014/main" id="{9DCEC7A0-DB14-460C-A3C6-0A0226361B99}"/>
+                <a16:creationId xmlns:a16="http://schemas.microsoft.com/office/drawing/2014/main" id="{82298462-35AA-44F5-9B02-75C4E3900ACD}"/>
               </a:ext>
             </a:extLst>
           </p:cNvPr>
@@ -3463,7 +3463,7 @@
           <p:cNvPr id="20" name="">
             <a:extLst xmlns:a="http://schemas.openxmlformats.org/drawingml/2006/main">
               <a:ext uri="{FF2B5EF4-FFF2-40B4-BE49-F238E27FC236}">
-                <a16:creationId xmlns:a16="http://schemas.microsoft.com/office/drawing/2014/main" id="{DAA0C7E2-C1D3-462B-8161-9118ED4DF77D}"/>
+                <a16:creationId xmlns:a16="http://schemas.microsoft.com/office/drawing/2014/main" id="{1C823F0C-1334-4A14-B951-94EAF75FCA85}"/>
               </a:ext>
             </a:extLst>
           </p:cNvPr>
@@ -3511,7 +3511,7 @@
                 <a:ea typeface="Aptos"/>
                 <a:cs typeface="Aptos"/>
               </a:rPr>
-              <a:t>647</a:t>
+              <a:t>656</a:t>
             </a:r>
           </a:p>
         </p:txBody>
@@ -3521,7 +3521,7 @@
           <p:cNvPr id="21" name="">
             <a:extLst xmlns:a="http://schemas.openxmlformats.org/drawingml/2006/main">
               <a:ext uri="{FF2B5EF4-FFF2-40B4-BE49-F238E27FC236}">
-                <a16:creationId xmlns:a16="http://schemas.microsoft.com/office/drawing/2014/main" id="{5C4D2ECE-F9BD-42B0-B22B-764070EBC5CF}"/>
+                <a16:creationId xmlns:a16="http://schemas.microsoft.com/office/drawing/2014/main" id="{87EFF479-0635-4B10-8BC6-58F3DD9E40D1}"/>
               </a:ext>
             </a:extLst>
           </p:cNvPr>
@@ -3579,7 +3579,7 @@
           <p:cNvPr id="22" name="">
             <a:extLst xmlns:a="http://schemas.openxmlformats.org/drawingml/2006/main">
               <a:ext uri="{FF2B5EF4-FFF2-40B4-BE49-F238E27FC236}">
-                <a16:creationId xmlns:a16="http://schemas.microsoft.com/office/drawing/2014/main" id="{DDBAE532-8D03-4CFE-8992-3E2CCD538303}"/>
+                <a16:creationId xmlns:a16="http://schemas.microsoft.com/office/drawing/2014/main" id="{C8EADB0C-6EA1-41A7-B9BE-4C8C7E5606AF}"/>
               </a:ext>
             </a:extLst>
           </p:cNvPr>
@@ -3637,7 +3637,7 @@
           <p:cNvPr id="23" name="">
             <a:extLst xmlns:a="http://schemas.openxmlformats.org/drawingml/2006/main">
               <a:ext uri="{FF2B5EF4-FFF2-40B4-BE49-F238E27FC236}">
-                <a16:creationId xmlns:a16="http://schemas.microsoft.com/office/drawing/2014/main" id="{271A37CF-41C4-4A05-ABE5-2F64EF08BD45}"/>
+                <a16:creationId xmlns:a16="http://schemas.microsoft.com/office/drawing/2014/main" id="{21BAFEA9-7B8B-4CC0-AA0D-D2EEF3F2F194}"/>
               </a:ext>
             </a:extLst>
           </p:cNvPr>
@@ -3685,7 +3685,7 @@
                 <a:ea typeface="Aptos"/>
                 <a:cs typeface="Aptos"/>
               </a:rPr>
-              <a:t>WATERS NEXT GEN COMPETITIVE INTELLIGENCE · 02 AUG 2026 · waters-ci-20260802160152</a:t>
+              <a:t>WATERS NEXT GEN COMPETITIVE INTELLIGENCE · 13 AUG 2026 · waters-ci-20260813070817</a:t>
             </a:r>
           </a:p>
         </p:txBody>
@@ -3695,7 +3695,7 @@
           <p:cNvPr id="24" name="">
             <a:extLst xmlns:a="http://schemas.openxmlformats.org/drawingml/2006/main">
               <a:ext uri="{FF2B5EF4-FFF2-40B4-BE49-F238E27FC236}">
-                <a16:creationId xmlns:a16="http://schemas.microsoft.com/office/drawing/2014/main" id="{2B42248A-B772-4A1A-ADC0-A6CFA2D2B5FE}"/>
+                <a16:creationId xmlns:a16="http://schemas.microsoft.com/office/drawing/2014/main" id="{35FABF07-4DF8-4EAA-A6F9-7EA86D79D42F}"/>
               </a:ext>
             </a:extLst>
           </p:cNvPr>
@@ -3751,7 +3751,7 @@
     </p:spTree>
     <p:extLst>
       <p:ext uri="{BB962C8B-B14F-4D97-AF65-F5344CB8AC3E}">
-        <p14:creationId xmlns:p14="http://schemas.microsoft.com/office/powerpoint/2010/main" val="1484359568"/>
+        <p14:creationId xmlns:p14="http://schemas.microsoft.com/office/powerpoint/2010/main" val="775500096"/>
       </p:ext>
     </p:extLst>
   </p:cSld>
@@ -3782,7 +3782,7 @@
           <p:cNvPr id="37" name="">
             <a:extLst xmlns:a="http://schemas.openxmlformats.org/drawingml/2006/main">
               <a:ext uri="{FF2B5EF4-FFF2-40B4-BE49-F238E27FC236}">
-                <a16:creationId xmlns:a16="http://schemas.microsoft.com/office/drawing/2014/main" id="{B2FC065B-3114-41A9-8FED-C8716A714658}"/>
+                <a16:creationId xmlns:a16="http://schemas.microsoft.com/office/drawing/2014/main" id="{86A10C2A-70AA-4841-8B67-390821515EB0}"/>
               </a:ext>
             </a:extLst>
           </p:cNvPr>
@@ -3840,7 +3840,7 @@
           <p:cNvPr id="2" name="">
             <a:extLst xmlns:a="http://schemas.openxmlformats.org/drawingml/2006/main">
               <a:ext uri="{FF2B5EF4-FFF2-40B4-BE49-F238E27FC236}">
-                <a16:creationId xmlns:a16="http://schemas.microsoft.com/office/drawing/2014/main" id="{846DF707-5F93-4D69-9669-7E20F687755C}"/>
+                <a16:creationId xmlns:a16="http://schemas.microsoft.com/office/drawing/2014/main" id="{9D3EF534-067C-4AF2-B51C-70A9FA840C0E}"/>
               </a:ext>
             </a:extLst>
           </p:cNvPr>
@@ -3898,7 +3898,7 @@
           <p:cNvPr id="3" name="">
             <a:extLst xmlns:a="http://schemas.openxmlformats.org/drawingml/2006/main">
               <a:ext uri="{FF2B5EF4-FFF2-40B4-BE49-F238E27FC236}">
-                <a16:creationId xmlns:a16="http://schemas.microsoft.com/office/drawing/2014/main" id="{320972A3-1737-47AD-8005-E654DB0B6E52}"/>
+                <a16:creationId xmlns:a16="http://schemas.microsoft.com/office/drawing/2014/main" id="{32394362-2D32-47DA-B745-DAE618D41A1D}"/>
               </a:ext>
             </a:extLst>
           </p:cNvPr>
@@ -3956,7 +3956,7 @@
           <p:cNvPr id="4" name="">
             <a:extLst xmlns:a="http://schemas.openxmlformats.org/drawingml/2006/main">
               <a:ext uri="{FF2B5EF4-FFF2-40B4-BE49-F238E27FC236}">
-                <a16:creationId xmlns:a16="http://schemas.microsoft.com/office/drawing/2014/main" id="{A8BF8CF7-2875-4DD8-B493-1B5F41519DF3}"/>
+                <a16:creationId xmlns:a16="http://schemas.microsoft.com/office/drawing/2014/main" id="{577F04DB-73A6-4057-A4D5-AD4DE6B229C6}"/>
               </a:ext>
             </a:extLst>
           </p:cNvPr>
@@ -3989,7 +3989,7 @@
           <p:cNvPr id="5" name="">
             <a:extLst xmlns:a="http://schemas.openxmlformats.org/drawingml/2006/main">
               <a:ext uri="{FF2B5EF4-FFF2-40B4-BE49-F238E27FC236}">
-                <a16:creationId xmlns:a16="http://schemas.microsoft.com/office/drawing/2014/main" id="{DA2DC171-F87D-47F2-BBB8-2E082FE68915}"/>
+                <a16:creationId xmlns:a16="http://schemas.microsoft.com/office/drawing/2014/main" id="{3FB6A66A-51F5-419A-8FC1-4C99A1546B1D}"/>
               </a:ext>
             </a:extLst>
           </p:cNvPr>
@@ -4024,7 +4024,7 @@
           <p:cNvPr id="6" name="">
             <a:extLst xmlns:a="http://schemas.openxmlformats.org/drawingml/2006/main">
               <a:ext uri="{FF2B5EF4-FFF2-40B4-BE49-F238E27FC236}">
-                <a16:creationId xmlns:a16="http://schemas.microsoft.com/office/drawing/2014/main" id="{DC2060C3-BC2F-4A48-BB49-6D7C093AFCAA}"/>
+                <a16:creationId xmlns:a16="http://schemas.microsoft.com/office/drawing/2014/main" id="{E9F67CCD-B4A7-4D09-AF99-17F381DF3B73}"/>
               </a:ext>
             </a:extLst>
           </p:cNvPr>
@@ -4059,7 +4059,7 @@
           <p:cNvPr id="7" name="">
             <a:extLst xmlns:a="http://schemas.openxmlformats.org/drawingml/2006/main">
               <a:ext uri="{FF2B5EF4-FFF2-40B4-BE49-F238E27FC236}">
-                <a16:creationId xmlns:a16="http://schemas.microsoft.com/office/drawing/2014/main" id="{CDD761F1-450D-4359-ACA5-41EF2FC0D0DA}"/>
+                <a16:creationId xmlns:a16="http://schemas.microsoft.com/office/drawing/2014/main" id="{AAE413AF-56CB-4067-84EA-B8D921F225FC}"/>
               </a:ext>
             </a:extLst>
           </p:cNvPr>
@@ -4117,7 +4117,7 @@
           <p:cNvPr id="8" name="">
             <a:extLst xmlns:a="http://schemas.openxmlformats.org/drawingml/2006/main">
               <a:ext uri="{FF2B5EF4-FFF2-40B4-BE49-F238E27FC236}">
-                <a16:creationId xmlns:a16="http://schemas.microsoft.com/office/drawing/2014/main" id="{4805984A-5F53-4491-8689-C1A2AD2B9881}"/>
+                <a16:creationId xmlns:a16="http://schemas.microsoft.com/office/drawing/2014/main" id="{F81FEFC9-19A6-46D1-A692-AAF6165E55C3}"/>
               </a:ext>
             </a:extLst>
           </p:cNvPr>
@@ -4175,7 +4175,7 @@
           <p:cNvPr id="9" name="">
             <a:extLst xmlns:a="http://schemas.openxmlformats.org/drawingml/2006/main">
               <a:ext uri="{FF2B5EF4-FFF2-40B4-BE49-F238E27FC236}">
-                <a16:creationId xmlns:a16="http://schemas.microsoft.com/office/drawing/2014/main" id="{3680DF25-D31F-40A7-89E0-13E1D067F290}"/>
+                <a16:creationId xmlns:a16="http://schemas.microsoft.com/office/drawing/2014/main" id="{B74E3F14-0A7B-4C58-B919-DF6F8C4AF080}"/>
               </a:ext>
             </a:extLst>
           </p:cNvPr>
@@ -4233,7 +4233,7 @@
           <p:cNvPr id="10" name="">
             <a:extLst xmlns:a="http://schemas.openxmlformats.org/drawingml/2006/main">
               <a:ext uri="{FF2B5EF4-FFF2-40B4-BE49-F238E27FC236}">
-                <a16:creationId xmlns:a16="http://schemas.microsoft.com/office/drawing/2014/main" id="{DEA76605-8A41-47FA-8575-BE85D8C0A7E8}"/>
+                <a16:creationId xmlns:a16="http://schemas.microsoft.com/office/drawing/2014/main" id="{F7BE98CC-CD20-418B-865C-69212431C3F0}"/>
               </a:ext>
             </a:extLst>
           </p:cNvPr>
@@ -4281,7 +4281,7 @@
                 <a:ea typeface="Aptos"/>
                 <a:cs typeface="Aptos"/>
               </a:rPr>
-              <a:t>325 records from the canonical PubMed query.</a:t>
+              <a:t>335 records from the canonical PubMed query.</a:t>
             </a:r>
           </a:p>
         </p:txBody>
@@ -4291,7 +4291,7 @@
           <p:cNvPr id="11" name="">
             <a:extLst xmlns:a="http://schemas.openxmlformats.org/drawingml/2006/main">
               <a:ext uri="{FF2B5EF4-FFF2-40B4-BE49-F238E27FC236}">
-                <a16:creationId xmlns:a16="http://schemas.microsoft.com/office/drawing/2014/main" id="{947BA36D-F642-4ACD-997F-D0442D2B5C9C}"/>
+                <a16:creationId xmlns:a16="http://schemas.microsoft.com/office/drawing/2014/main" id="{CD600435-2BF9-4C82-A42C-D73C54E4B1DC}"/>
               </a:ext>
             </a:extLst>
           </p:cNvPr>
@@ -4326,7 +4326,7 @@
           <p:cNvPr id="12" name="">
             <a:extLst xmlns:a="http://schemas.openxmlformats.org/drawingml/2006/main">
               <a:ext uri="{FF2B5EF4-FFF2-40B4-BE49-F238E27FC236}">
-                <a16:creationId xmlns:a16="http://schemas.microsoft.com/office/drawing/2014/main" id="{7558E1DF-98CC-4B61-BC34-5EB3FC87C205}"/>
+                <a16:creationId xmlns:a16="http://schemas.microsoft.com/office/drawing/2014/main" id="{7EAAB9CA-7E88-48AE-B2FF-8769912C4FDA}"/>
               </a:ext>
             </a:extLst>
           </p:cNvPr>
@@ -4361,7 +4361,7 @@
           <p:cNvPr id="13" name="">
             <a:extLst xmlns:a="http://schemas.openxmlformats.org/drawingml/2006/main">
               <a:ext uri="{FF2B5EF4-FFF2-40B4-BE49-F238E27FC236}">
-                <a16:creationId xmlns:a16="http://schemas.microsoft.com/office/drawing/2014/main" id="{5E899533-BC86-4279-BF5D-8ACC0471C5CC}"/>
+                <a16:creationId xmlns:a16="http://schemas.microsoft.com/office/drawing/2014/main" id="{DA4E4021-94A5-4B6D-A165-4CB0517451CF}"/>
               </a:ext>
             </a:extLst>
           </p:cNvPr>
@@ -4419,7 +4419,7 @@
           <p:cNvPr id="14" name="">
             <a:extLst xmlns:a="http://schemas.openxmlformats.org/drawingml/2006/main">
               <a:ext uri="{FF2B5EF4-FFF2-40B4-BE49-F238E27FC236}">
-                <a16:creationId xmlns:a16="http://schemas.microsoft.com/office/drawing/2014/main" id="{F0441135-07A0-40FC-A420-0DF77B5A9B63}"/>
+                <a16:creationId xmlns:a16="http://schemas.microsoft.com/office/drawing/2014/main" id="{678A89FE-FF23-43CD-8180-9BD9830AF546}"/>
               </a:ext>
             </a:extLst>
           </p:cNvPr>
@@ -4477,7 +4477,7 @@
           <p:cNvPr id="15" name="">
             <a:extLst xmlns:a="http://schemas.openxmlformats.org/drawingml/2006/main">
               <a:ext uri="{FF2B5EF4-FFF2-40B4-BE49-F238E27FC236}">
-                <a16:creationId xmlns:a16="http://schemas.microsoft.com/office/drawing/2014/main" id="{59F3FA00-BFD7-4AF0-97F4-2BCA6A982C55}"/>
+                <a16:creationId xmlns:a16="http://schemas.microsoft.com/office/drawing/2014/main" id="{3404B907-9B5A-4804-B5D4-2E9333DBF81D}"/>
               </a:ext>
             </a:extLst>
           </p:cNvPr>
@@ -4535,7 +4535,7 @@
           <p:cNvPr id="16" name="">
             <a:extLst xmlns:a="http://schemas.openxmlformats.org/drawingml/2006/main">
               <a:ext uri="{FF2B5EF4-FFF2-40B4-BE49-F238E27FC236}">
-                <a16:creationId xmlns:a16="http://schemas.microsoft.com/office/drawing/2014/main" id="{0E58DE68-153B-4794-81EF-E8EA1E2CAE56}"/>
+                <a16:creationId xmlns:a16="http://schemas.microsoft.com/office/drawing/2014/main" id="{FEFA52B2-8805-4582-93E1-6409A68B633A}"/>
               </a:ext>
             </a:extLst>
           </p:cNvPr>
@@ -4593,7 +4593,7 @@
           <p:cNvPr id="17" name="">
             <a:extLst xmlns:a="http://schemas.openxmlformats.org/drawingml/2006/main">
               <a:ext uri="{FF2B5EF4-FFF2-40B4-BE49-F238E27FC236}">
-                <a16:creationId xmlns:a16="http://schemas.microsoft.com/office/drawing/2014/main" id="{0EA8DA6A-17AA-4557-BB20-316B5BA7AD6E}"/>
+                <a16:creationId xmlns:a16="http://schemas.microsoft.com/office/drawing/2014/main" id="{FB3A4457-B8BF-4A07-AE45-6B87596EFA06}"/>
               </a:ext>
             </a:extLst>
           </p:cNvPr>
@@ -4628,7 +4628,7 @@
           <p:cNvPr id="18" name="">
             <a:extLst xmlns:a="http://schemas.openxmlformats.org/drawingml/2006/main">
               <a:ext uri="{FF2B5EF4-FFF2-40B4-BE49-F238E27FC236}">
-                <a16:creationId xmlns:a16="http://schemas.microsoft.com/office/drawing/2014/main" id="{06455489-11F1-465B-9B0B-2E57E2F45EF8}"/>
+                <a16:creationId xmlns:a16="http://schemas.microsoft.com/office/drawing/2014/main" id="{6B317260-6072-4D6E-A235-8B1F31EEF452}"/>
               </a:ext>
             </a:extLst>
           </p:cNvPr>
@@ -4663,7 +4663,7 @@
           <p:cNvPr id="19" name="">
             <a:extLst xmlns:a="http://schemas.openxmlformats.org/drawingml/2006/main">
               <a:ext uri="{FF2B5EF4-FFF2-40B4-BE49-F238E27FC236}">
-                <a16:creationId xmlns:a16="http://schemas.microsoft.com/office/drawing/2014/main" id="{78809F6F-10A4-45DC-87A3-1157C288B005}"/>
+                <a16:creationId xmlns:a16="http://schemas.microsoft.com/office/drawing/2014/main" id="{981ED18C-C447-4F39-B9DF-261270CC8552}"/>
               </a:ext>
             </a:extLst>
           </p:cNvPr>
@@ -4721,7 +4721,7 @@
           <p:cNvPr id="20" name="">
             <a:extLst xmlns:a="http://schemas.openxmlformats.org/drawingml/2006/main">
               <a:ext uri="{FF2B5EF4-FFF2-40B4-BE49-F238E27FC236}">
-                <a16:creationId xmlns:a16="http://schemas.microsoft.com/office/drawing/2014/main" id="{AA36BD54-9DC0-49B9-9C7C-A113F86189B7}"/>
+                <a16:creationId xmlns:a16="http://schemas.microsoft.com/office/drawing/2014/main" id="{8074F3A0-A4ED-4DCE-A3FC-053911276C34}"/>
               </a:ext>
             </a:extLst>
           </p:cNvPr>
@@ -4779,7 +4779,7 @@
           <p:cNvPr id="21" name="">
             <a:extLst xmlns:a="http://schemas.openxmlformats.org/drawingml/2006/main">
               <a:ext uri="{FF2B5EF4-FFF2-40B4-BE49-F238E27FC236}">
-                <a16:creationId xmlns:a16="http://schemas.microsoft.com/office/drawing/2014/main" id="{F7406C45-C574-40D9-8E0E-33CBE6FA7D79}"/>
+                <a16:creationId xmlns:a16="http://schemas.microsoft.com/office/drawing/2014/main" id="{D82AA76A-46D3-46F2-B5A3-940C72596A53}"/>
               </a:ext>
             </a:extLst>
           </p:cNvPr>
@@ -4837,7 +4837,7 @@
           <p:cNvPr id="22" name="">
             <a:extLst xmlns:a="http://schemas.openxmlformats.org/drawingml/2006/main">
               <a:ext uri="{FF2B5EF4-FFF2-40B4-BE49-F238E27FC236}">
-                <a16:creationId xmlns:a16="http://schemas.microsoft.com/office/drawing/2014/main" id="{D29DDDA2-C2C9-4F54-B4D6-0521F4D51A45}"/>
+                <a16:creationId xmlns:a16="http://schemas.microsoft.com/office/drawing/2014/main" id="{2F90D2AE-4808-4F96-BDC2-FD039ACE828A}"/>
               </a:ext>
             </a:extLst>
           </p:cNvPr>
@@ -4895,7 +4895,7 @@
           <p:cNvPr id="23" name="">
             <a:extLst xmlns:a="http://schemas.openxmlformats.org/drawingml/2006/main">
               <a:ext uri="{FF2B5EF4-FFF2-40B4-BE49-F238E27FC236}">
-                <a16:creationId xmlns:a16="http://schemas.microsoft.com/office/drawing/2014/main" id="{46DAB1C5-D909-40E3-B01F-3DB8D8289634}"/>
+                <a16:creationId xmlns:a16="http://schemas.microsoft.com/office/drawing/2014/main" id="{FFB68D3A-8ED3-4953-BE33-9DDF9706CDD6}"/>
               </a:ext>
             </a:extLst>
           </p:cNvPr>
@@ -4930,7 +4930,7 @@
           <p:cNvPr id="24" name="">
             <a:extLst xmlns:a="http://schemas.openxmlformats.org/drawingml/2006/main">
               <a:ext uri="{FF2B5EF4-FFF2-40B4-BE49-F238E27FC236}">
-                <a16:creationId xmlns:a16="http://schemas.microsoft.com/office/drawing/2014/main" id="{57212F9B-9D40-43FC-8C7B-3CC693721598}"/>
+                <a16:creationId xmlns:a16="http://schemas.microsoft.com/office/drawing/2014/main" id="{87A579D7-30CE-443A-B3FA-EDBF0B8297EE}"/>
               </a:ext>
             </a:extLst>
           </p:cNvPr>
@@ -4965,7 +4965,7 @@
           <p:cNvPr id="25" name="">
             <a:extLst xmlns:a="http://schemas.openxmlformats.org/drawingml/2006/main">
               <a:ext uri="{FF2B5EF4-FFF2-40B4-BE49-F238E27FC236}">
-                <a16:creationId xmlns:a16="http://schemas.microsoft.com/office/drawing/2014/main" id="{F6E2F532-925A-4A69-ACF4-4FA552D2B909}"/>
+                <a16:creationId xmlns:a16="http://schemas.microsoft.com/office/drawing/2014/main" id="{E273B36B-DB5B-4ED2-AF18-B55814E2F230}"/>
               </a:ext>
             </a:extLst>
           </p:cNvPr>
@@ -5023,7 +5023,7 @@
           <p:cNvPr id="26" name="">
             <a:extLst xmlns:a="http://schemas.openxmlformats.org/drawingml/2006/main">
               <a:ext uri="{FF2B5EF4-FFF2-40B4-BE49-F238E27FC236}">
-                <a16:creationId xmlns:a16="http://schemas.microsoft.com/office/drawing/2014/main" id="{04DB440A-58CD-47D8-A097-DB02FE07D00C}"/>
+                <a16:creationId xmlns:a16="http://schemas.microsoft.com/office/drawing/2014/main" id="{82BDE4C3-E0DC-47C3-A516-9F8C2AE6F826}"/>
               </a:ext>
             </a:extLst>
           </p:cNvPr>
@@ -5081,7 +5081,7 @@
           <p:cNvPr id="27" name="">
             <a:extLst xmlns:a="http://schemas.openxmlformats.org/drawingml/2006/main">
               <a:ext uri="{FF2B5EF4-FFF2-40B4-BE49-F238E27FC236}">
-                <a16:creationId xmlns:a16="http://schemas.microsoft.com/office/drawing/2014/main" id="{A6DD3AB9-E8A3-40CD-A047-491BC318AD5D}"/>
+                <a16:creationId xmlns:a16="http://schemas.microsoft.com/office/drawing/2014/main" id="{7E3B62DC-E657-4C9A-82D8-1422D2D8213D}"/>
               </a:ext>
             </a:extLst>
           </p:cNvPr>
@@ -5139,7 +5139,7 @@
           <p:cNvPr id="28" name="">
             <a:extLst xmlns:a="http://schemas.openxmlformats.org/drawingml/2006/main">
               <a:ext uri="{FF2B5EF4-FFF2-40B4-BE49-F238E27FC236}">
-                <a16:creationId xmlns:a16="http://schemas.microsoft.com/office/drawing/2014/main" id="{B49B7C7F-8540-4D68-968E-0165C60246BA}"/>
+                <a16:creationId xmlns:a16="http://schemas.microsoft.com/office/drawing/2014/main" id="{5101D934-49F8-4ECE-A9FD-CA66E4613C53}"/>
               </a:ext>
             </a:extLst>
           </p:cNvPr>
@@ -5197,7 +5197,7 @@
           <p:cNvPr id="29" name="">
             <a:extLst xmlns:a="http://schemas.openxmlformats.org/drawingml/2006/main">
               <a:ext uri="{FF2B5EF4-FFF2-40B4-BE49-F238E27FC236}">
-                <a16:creationId xmlns:a16="http://schemas.microsoft.com/office/drawing/2014/main" id="{37AE1128-6E0D-4499-8B9C-A10058952160}"/>
+                <a16:creationId xmlns:a16="http://schemas.microsoft.com/office/drawing/2014/main" id="{C7B3F5BF-E7A0-4894-A99E-6F6320AEFA37}"/>
               </a:ext>
             </a:extLst>
           </p:cNvPr>
@@ -5232,7 +5232,7 @@
           <p:cNvPr id="30" name="">
             <a:extLst xmlns:a="http://schemas.openxmlformats.org/drawingml/2006/main">
               <a:ext uri="{FF2B5EF4-FFF2-40B4-BE49-F238E27FC236}">
-                <a16:creationId xmlns:a16="http://schemas.microsoft.com/office/drawing/2014/main" id="{9027E342-7B3F-41CC-ABE2-5929B010E9A9}"/>
+                <a16:creationId xmlns:a16="http://schemas.microsoft.com/office/drawing/2014/main" id="{726ECCAC-B251-415D-A6AD-29856AD53381}"/>
               </a:ext>
             </a:extLst>
           </p:cNvPr>
@@ -5267,7 +5267,7 @@
           <p:cNvPr id="31" name="">
             <a:extLst xmlns:a="http://schemas.openxmlformats.org/drawingml/2006/main">
               <a:ext uri="{FF2B5EF4-FFF2-40B4-BE49-F238E27FC236}">
-                <a16:creationId xmlns:a16="http://schemas.microsoft.com/office/drawing/2014/main" id="{51772EDD-D6D0-4737-91BB-B8ABC39ECCAF}"/>
+                <a16:creationId xmlns:a16="http://schemas.microsoft.com/office/drawing/2014/main" id="{934BAED4-6956-4CA7-B93F-E120922A220C}"/>
               </a:ext>
             </a:extLst>
           </p:cNvPr>
@@ -5325,7 +5325,7 @@
           <p:cNvPr id="32" name="">
             <a:extLst xmlns:a="http://schemas.openxmlformats.org/drawingml/2006/main">
               <a:ext uri="{FF2B5EF4-FFF2-40B4-BE49-F238E27FC236}">
-                <a16:creationId xmlns:a16="http://schemas.microsoft.com/office/drawing/2014/main" id="{03048CE7-E6EC-45FF-9206-B32535408DE0}"/>
+                <a16:creationId xmlns:a16="http://schemas.microsoft.com/office/drawing/2014/main" id="{DECA2A91-892E-4B6C-B6E3-ECAD62B7A933}"/>
               </a:ext>
             </a:extLst>
           </p:cNvPr>
@@ -5383,7 +5383,7 @@
           <p:cNvPr id="33" name="">
             <a:extLst xmlns:a="http://schemas.openxmlformats.org/drawingml/2006/main">
               <a:ext uri="{FF2B5EF4-FFF2-40B4-BE49-F238E27FC236}">
-                <a16:creationId xmlns:a16="http://schemas.microsoft.com/office/drawing/2014/main" id="{BCAFA654-A56C-4E5C-9555-B27F91C39373}"/>
+                <a16:creationId xmlns:a16="http://schemas.microsoft.com/office/drawing/2014/main" id="{5C2BC6CB-9D9D-427D-9D16-588D0B1991F3}"/>
               </a:ext>
             </a:extLst>
           </p:cNvPr>
@@ -5441,7 +5441,7 @@
           <p:cNvPr id="34" name="">
             <a:extLst xmlns:a="http://schemas.openxmlformats.org/drawingml/2006/main">
               <a:ext uri="{FF2B5EF4-FFF2-40B4-BE49-F238E27FC236}">
-                <a16:creationId xmlns:a16="http://schemas.microsoft.com/office/drawing/2014/main" id="{D6E48ED1-5C7B-4ECA-BAA9-4CB656402241}"/>
+                <a16:creationId xmlns:a16="http://schemas.microsoft.com/office/drawing/2014/main" id="{2F7BC65C-A5CD-47D1-91F9-E0EFF9D55162}"/>
               </a:ext>
             </a:extLst>
           </p:cNvPr>
@@ -5499,7 +5499,7 @@
           <p:cNvPr id="35" name="">
             <a:extLst xmlns:a="http://schemas.openxmlformats.org/drawingml/2006/main">
               <a:ext uri="{FF2B5EF4-FFF2-40B4-BE49-F238E27FC236}">
-                <a16:creationId xmlns:a16="http://schemas.microsoft.com/office/drawing/2014/main" id="{BB7B8D9A-1A75-4248-A113-99586737DB36}"/>
+                <a16:creationId xmlns:a16="http://schemas.microsoft.com/office/drawing/2014/main" id="{BF99EE76-7CFA-469F-890D-8AA94A5AFE94}"/>
               </a:ext>
             </a:extLst>
           </p:cNvPr>
@@ -5547,7 +5547,7 @@
                 <a:ea typeface="Aptos"/>
                 <a:cs typeface="Aptos"/>
               </a:rPr>
-              <a:t>WATERS NEXT GEN COMPETITIVE INTELLIGENCE · 02 AUG 2026 · waters-ci-20260802160152</a:t>
+              <a:t>WATERS NEXT GEN COMPETITIVE INTELLIGENCE · 13 AUG 2026 · waters-ci-20260813070817</a:t>
             </a:r>
           </a:p>
         </p:txBody>
@@ -5557,7 +5557,7 @@
           <p:cNvPr id="36" name="">
             <a:extLst xmlns:a="http://schemas.openxmlformats.org/drawingml/2006/main">
               <a:ext uri="{FF2B5EF4-FFF2-40B4-BE49-F238E27FC236}">
-                <a16:creationId xmlns:a16="http://schemas.microsoft.com/office/drawing/2014/main" id="{79D94002-F376-4DFF-9ED3-EDF60E1EAE63}"/>
+                <a16:creationId xmlns:a16="http://schemas.microsoft.com/office/drawing/2014/main" id="{B20DB7BD-7860-4027-B571-63E618CEA09F}"/>
               </a:ext>
             </a:extLst>
           </p:cNvPr>
@@ -5613,7 +5613,7 @@
     </p:spTree>
     <p:extLst>
       <p:ext uri="{BB962C8B-B14F-4D97-AF65-F5344CB8AC3E}">
-        <p14:creationId xmlns:p14="http://schemas.microsoft.com/office/powerpoint/2010/main" val="733205393"/>
+        <p14:creationId xmlns:p14="http://schemas.microsoft.com/office/powerpoint/2010/main" val="138632279"/>
       </p:ext>
     </p:extLst>
   </p:cSld>
@@ -5644,7 +5644,7 @@
           <p:cNvPr id="31" name="">
             <a:extLst xmlns:a="http://schemas.openxmlformats.org/drawingml/2006/main">
               <a:ext uri="{FF2B5EF4-FFF2-40B4-BE49-F238E27FC236}">
-                <a16:creationId xmlns:a16="http://schemas.microsoft.com/office/drawing/2014/main" id="{0B413A6A-12A6-428D-92A9-7F6EC28B0B94}"/>
+                <a16:creationId xmlns:a16="http://schemas.microsoft.com/office/drawing/2014/main" id="{7E29194F-892A-47BC-9688-C72CD7018C90}"/>
               </a:ext>
             </a:extLst>
           </p:cNvPr>
@@ -5702,7 +5702,7 @@
           <p:cNvPr id="2" name="">
             <a:extLst xmlns:a="http://schemas.openxmlformats.org/drawingml/2006/main">
               <a:ext uri="{FF2B5EF4-FFF2-40B4-BE49-F238E27FC236}">
-                <a16:creationId xmlns:a16="http://schemas.microsoft.com/office/drawing/2014/main" id="{37149860-D663-46A2-AF00-37DF4276643A}"/>
+                <a16:creationId xmlns:a16="http://schemas.microsoft.com/office/drawing/2014/main" id="{4C4C52FF-E4AF-4183-BABE-CA1E8C0A85BE}"/>
               </a:ext>
             </a:extLst>
           </p:cNvPr>
@@ -5760,7 +5760,7 @@
           <p:cNvPr id="3" name="">
             <a:extLst xmlns:a="http://schemas.openxmlformats.org/drawingml/2006/main">
               <a:ext uri="{FF2B5EF4-FFF2-40B4-BE49-F238E27FC236}">
-                <a16:creationId xmlns:a16="http://schemas.microsoft.com/office/drawing/2014/main" id="{8BBFA23B-9BC6-45AC-BC45-BFF9AB5C1F6E}"/>
+                <a16:creationId xmlns:a16="http://schemas.microsoft.com/office/drawing/2014/main" id="{B8069645-CABD-4F9D-AAA0-6BAE9F3056C1}"/>
               </a:ext>
             </a:extLst>
           </p:cNvPr>
@@ -5818,7 +5818,7 @@
           <p:cNvPr id="4" name="">
             <a:extLst xmlns:a="http://schemas.openxmlformats.org/drawingml/2006/main">
               <a:ext uri="{FF2B5EF4-FFF2-40B4-BE49-F238E27FC236}">
-                <a16:creationId xmlns:a16="http://schemas.microsoft.com/office/drawing/2014/main" id="{B6DDCC34-DE4D-4CAE-B07C-9C7BA4E09E29}"/>
+                <a16:creationId xmlns:a16="http://schemas.microsoft.com/office/drawing/2014/main" id="{C8A89B46-F9FD-436D-BC07-824262DB8213}"/>
               </a:ext>
             </a:extLst>
           </p:cNvPr>
@@ -5851,7 +5851,7 @@
           <p:cNvPr id="5" name="">
             <a:extLst xmlns:a="http://schemas.openxmlformats.org/drawingml/2006/main">
               <a:ext uri="{FF2B5EF4-FFF2-40B4-BE49-F238E27FC236}">
-                <a16:creationId xmlns:a16="http://schemas.microsoft.com/office/drawing/2014/main" id="{1227A98D-279D-4DD9-A0CF-5CA8448D9394}"/>
+                <a16:creationId xmlns:a16="http://schemas.microsoft.com/office/drawing/2014/main" id="{C0412B42-329F-4418-B8BF-04ACE423042B}"/>
               </a:ext>
             </a:extLst>
           </p:cNvPr>
@@ -5886,7 +5886,7 @@
           <p:cNvPr id="6" name="">
             <a:extLst xmlns:a="http://schemas.openxmlformats.org/drawingml/2006/main">
               <a:ext uri="{FF2B5EF4-FFF2-40B4-BE49-F238E27FC236}">
-                <a16:creationId xmlns:a16="http://schemas.microsoft.com/office/drawing/2014/main" id="{8B9E9826-A4D7-4DC3-AF55-8FF4EC7A8650}"/>
+                <a16:creationId xmlns:a16="http://schemas.microsoft.com/office/drawing/2014/main" id="{DC21B0DE-DEB0-4ED4-B3E9-B496A9F40D50}"/>
               </a:ext>
             </a:extLst>
           </p:cNvPr>
@@ -5919,7 +5919,7 @@
           <p:cNvPr id="7" name="">
             <a:extLst xmlns:a="http://schemas.openxmlformats.org/drawingml/2006/main">
               <a:ext uri="{FF2B5EF4-FFF2-40B4-BE49-F238E27FC236}">
-                <a16:creationId xmlns:a16="http://schemas.microsoft.com/office/drawing/2014/main" id="{F39B9C1A-64F3-4F8B-BC4E-604BF8B5926A}"/>
+                <a16:creationId xmlns:a16="http://schemas.microsoft.com/office/drawing/2014/main" id="{3F2ACA6B-2FEC-41A6-A620-C9FC5065699F}"/>
               </a:ext>
             </a:extLst>
           </p:cNvPr>
@@ -5977,7 +5977,7 @@
           <p:cNvPr id="8" name="">
             <a:extLst xmlns:a="http://schemas.openxmlformats.org/drawingml/2006/main">
               <a:ext uri="{FF2B5EF4-FFF2-40B4-BE49-F238E27FC236}">
-                <a16:creationId xmlns:a16="http://schemas.microsoft.com/office/drawing/2014/main" id="{3455887C-7CCE-4A68-BD3F-183F0A00DE64}"/>
+                <a16:creationId xmlns:a16="http://schemas.microsoft.com/office/drawing/2014/main" id="{280793D5-3B90-4CC1-91CA-059B5C695797}"/>
               </a:ext>
             </a:extLst>
           </p:cNvPr>
@@ -6035,7 +6035,7 @@
           <p:cNvPr id="9" name="">
             <a:extLst xmlns:a="http://schemas.openxmlformats.org/drawingml/2006/main">
               <a:ext uri="{FF2B5EF4-FFF2-40B4-BE49-F238E27FC236}">
-                <a16:creationId xmlns:a16="http://schemas.microsoft.com/office/drawing/2014/main" id="{F23A2E50-3BCD-41D6-8852-700162EB63D8}"/>
+                <a16:creationId xmlns:a16="http://schemas.microsoft.com/office/drawing/2014/main" id="{DDB31615-627C-4199-AA5E-D4F3B416A7D2}"/>
               </a:ext>
             </a:extLst>
           </p:cNvPr>
@@ -6093,7 +6093,7 @@
           <p:cNvPr id="10" name="">
             <a:extLst xmlns:a="http://schemas.openxmlformats.org/drawingml/2006/main">
               <a:ext uri="{FF2B5EF4-FFF2-40B4-BE49-F238E27FC236}">
-                <a16:creationId xmlns:a16="http://schemas.microsoft.com/office/drawing/2014/main" id="{4C7452E0-557F-4910-B50B-42AB0E9AACA4}"/>
+                <a16:creationId xmlns:a16="http://schemas.microsoft.com/office/drawing/2014/main" id="{E819C7F8-C1D8-41EE-AB5D-649CCFE3B55F}"/>
               </a:ext>
             </a:extLst>
           </p:cNvPr>
@@ -6151,7 +6151,7 @@
           <p:cNvPr id="11" name="">
             <a:extLst xmlns:a="http://schemas.openxmlformats.org/drawingml/2006/main">
               <a:ext uri="{FF2B5EF4-FFF2-40B4-BE49-F238E27FC236}">
-                <a16:creationId xmlns:a16="http://schemas.microsoft.com/office/drawing/2014/main" id="{19E6143A-3302-458B-A433-3E16E279D7CF}"/>
+                <a16:creationId xmlns:a16="http://schemas.microsoft.com/office/drawing/2014/main" id="{15085620-8AAA-45CB-8E7B-D8C6684E0E4E}"/>
               </a:ext>
             </a:extLst>
           </p:cNvPr>
@@ -6186,7 +6186,7 @@
           <p:cNvPr id="12" name="">
             <a:extLst xmlns:a="http://schemas.openxmlformats.org/drawingml/2006/main">
               <a:ext uri="{FF2B5EF4-FFF2-40B4-BE49-F238E27FC236}">
-                <a16:creationId xmlns:a16="http://schemas.microsoft.com/office/drawing/2014/main" id="{ED0F4DBE-6B83-4A69-AD46-A95A25CD86E5}"/>
+                <a16:creationId xmlns:a16="http://schemas.microsoft.com/office/drawing/2014/main" id="{C48AF58E-63EB-418D-9530-F226A8BB6BE7}"/>
               </a:ext>
             </a:extLst>
           </p:cNvPr>
@@ -6219,7 +6219,7 @@
           <p:cNvPr id="13" name="">
             <a:extLst xmlns:a="http://schemas.openxmlformats.org/drawingml/2006/main">
               <a:ext uri="{FF2B5EF4-FFF2-40B4-BE49-F238E27FC236}">
-                <a16:creationId xmlns:a16="http://schemas.microsoft.com/office/drawing/2014/main" id="{44930113-910F-4FC9-BFEE-5A5BDC6CD692}"/>
+                <a16:creationId xmlns:a16="http://schemas.microsoft.com/office/drawing/2014/main" id="{D8B0D123-918B-4665-9BA5-40FCE3DF43D8}"/>
               </a:ext>
             </a:extLst>
           </p:cNvPr>
@@ -6277,7 +6277,7 @@
           <p:cNvPr id="14" name="">
             <a:extLst xmlns:a="http://schemas.openxmlformats.org/drawingml/2006/main">
               <a:ext uri="{FF2B5EF4-FFF2-40B4-BE49-F238E27FC236}">
-                <a16:creationId xmlns:a16="http://schemas.microsoft.com/office/drawing/2014/main" id="{22C06229-8998-4BC5-9F67-E070C7981671}"/>
+                <a16:creationId xmlns:a16="http://schemas.microsoft.com/office/drawing/2014/main" id="{F0CE004D-DAE5-4C4C-9664-14ED2D79428B}"/>
               </a:ext>
             </a:extLst>
           </p:cNvPr>
@@ -6335,7 +6335,7 @@
           <p:cNvPr id="15" name="">
             <a:extLst xmlns:a="http://schemas.openxmlformats.org/drawingml/2006/main">
               <a:ext uri="{FF2B5EF4-FFF2-40B4-BE49-F238E27FC236}">
-                <a16:creationId xmlns:a16="http://schemas.microsoft.com/office/drawing/2014/main" id="{950DED21-B267-4FE8-B8A7-D78B2CC91CE0}"/>
+                <a16:creationId xmlns:a16="http://schemas.microsoft.com/office/drawing/2014/main" id="{964F3BB1-B7CA-412B-B4A2-599D5969BB86}"/>
               </a:ext>
             </a:extLst>
           </p:cNvPr>
@@ -6393,7 +6393,7 @@
           <p:cNvPr id="16" name="">
             <a:extLst xmlns:a="http://schemas.openxmlformats.org/drawingml/2006/main">
               <a:ext uri="{FF2B5EF4-FFF2-40B4-BE49-F238E27FC236}">
-                <a16:creationId xmlns:a16="http://schemas.microsoft.com/office/drawing/2014/main" id="{C9923471-5968-4E29-9C33-00F348F6EF58}"/>
+                <a16:creationId xmlns:a16="http://schemas.microsoft.com/office/drawing/2014/main" id="{EFC9BD31-09C4-4442-9E6D-E3E6507946B4}"/>
               </a:ext>
             </a:extLst>
           </p:cNvPr>
@@ -6451,7 +6451,7 @@
           <p:cNvPr id="17" name="">
             <a:extLst xmlns:a="http://schemas.openxmlformats.org/drawingml/2006/main">
               <a:ext uri="{FF2B5EF4-FFF2-40B4-BE49-F238E27FC236}">
-                <a16:creationId xmlns:a16="http://schemas.microsoft.com/office/drawing/2014/main" id="{F92D48EF-02F3-4D3C-8710-77296DBAF3B1}"/>
+                <a16:creationId xmlns:a16="http://schemas.microsoft.com/office/drawing/2014/main" id="{61BA03A1-BFD9-4AFD-AF66-80318C218D32}"/>
               </a:ext>
             </a:extLst>
           </p:cNvPr>
@@ -6486,7 +6486,7 @@
           <p:cNvPr id="18" name="">
             <a:extLst xmlns:a="http://schemas.openxmlformats.org/drawingml/2006/main">
               <a:ext uri="{FF2B5EF4-FFF2-40B4-BE49-F238E27FC236}">
-                <a16:creationId xmlns:a16="http://schemas.microsoft.com/office/drawing/2014/main" id="{6A21762D-A5E2-40DD-816A-29EF44771EE7}"/>
+                <a16:creationId xmlns:a16="http://schemas.microsoft.com/office/drawing/2014/main" id="{FD59D8D7-96A5-435B-A9FB-C851742EFC32}"/>
               </a:ext>
             </a:extLst>
           </p:cNvPr>
@@ -6519,7 +6519,7 @@
           <p:cNvPr id="19" name="">
             <a:extLst xmlns:a="http://schemas.openxmlformats.org/drawingml/2006/main">
               <a:ext uri="{FF2B5EF4-FFF2-40B4-BE49-F238E27FC236}">
-                <a16:creationId xmlns:a16="http://schemas.microsoft.com/office/drawing/2014/main" id="{C08E039B-190A-4947-9820-6D28C046FF25}"/>
+                <a16:creationId xmlns:a16="http://schemas.microsoft.com/office/drawing/2014/main" id="{0381B156-3FEE-4313-8DA0-1F273962E780}"/>
               </a:ext>
             </a:extLst>
           </p:cNvPr>
@@ -6577,7 +6577,7 @@
           <p:cNvPr id="20" name="">
             <a:extLst xmlns:a="http://schemas.openxmlformats.org/drawingml/2006/main">
               <a:ext uri="{FF2B5EF4-FFF2-40B4-BE49-F238E27FC236}">
-                <a16:creationId xmlns:a16="http://schemas.microsoft.com/office/drawing/2014/main" id="{A8BDCB4F-667A-4E08-9F28-C0E653822387}"/>
+                <a16:creationId xmlns:a16="http://schemas.microsoft.com/office/drawing/2014/main" id="{2865E709-40B5-4F66-B7FA-56BCBD98A84A}"/>
               </a:ext>
             </a:extLst>
           </p:cNvPr>
@@ -6635,7 +6635,7 @@
           <p:cNvPr id="21" name="">
             <a:extLst xmlns:a="http://schemas.openxmlformats.org/drawingml/2006/main">
               <a:ext uri="{FF2B5EF4-FFF2-40B4-BE49-F238E27FC236}">
-                <a16:creationId xmlns:a16="http://schemas.microsoft.com/office/drawing/2014/main" id="{E17502DB-1C61-48CD-92C8-98A201172494}"/>
+                <a16:creationId xmlns:a16="http://schemas.microsoft.com/office/drawing/2014/main" id="{314B46F2-0F15-417D-AE94-5F3A91EDB7C2}"/>
               </a:ext>
             </a:extLst>
           </p:cNvPr>
@@ -6693,7 +6693,7 @@
           <p:cNvPr id="22" name="">
             <a:extLst xmlns:a="http://schemas.openxmlformats.org/drawingml/2006/main">
               <a:ext uri="{FF2B5EF4-FFF2-40B4-BE49-F238E27FC236}">
-                <a16:creationId xmlns:a16="http://schemas.microsoft.com/office/drawing/2014/main" id="{A6D48781-36E9-44F8-9937-3C32EBD936EA}"/>
+                <a16:creationId xmlns:a16="http://schemas.microsoft.com/office/drawing/2014/main" id="{204B4EC3-0DDD-4CBD-A701-9E58A95AA772}"/>
               </a:ext>
             </a:extLst>
           </p:cNvPr>
@@ -6751,7 +6751,7 @@
           <p:cNvPr id="23" name="">
             <a:extLst xmlns:a="http://schemas.openxmlformats.org/drawingml/2006/main">
               <a:ext uri="{FF2B5EF4-FFF2-40B4-BE49-F238E27FC236}">
-                <a16:creationId xmlns:a16="http://schemas.microsoft.com/office/drawing/2014/main" id="{637EEF82-54FF-4D77-A94E-73A2C1212510}"/>
+                <a16:creationId xmlns:a16="http://schemas.microsoft.com/office/drawing/2014/main" id="{B898E5D0-2483-43C5-A8B0-A3F30E6669F3}"/>
               </a:ext>
             </a:extLst>
           </p:cNvPr>
@@ -6786,7 +6786,7 @@
           <p:cNvPr id="24" name="">
             <a:extLst xmlns:a="http://schemas.openxmlformats.org/drawingml/2006/main">
               <a:ext uri="{FF2B5EF4-FFF2-40B4-BE49-F238E27FC236}">
-                <a16:creationId xmlns:a16="http://schemas.microsoft.com/office/drawing/2014/main" id="{CDBCBFDC-EC86-4A51-B3F0-0F2329E249D1}"/>
+                <a16:creationId xmlns:a16="http://schemas.microsoft.com/office/drawing/2014/main" id="{F443B792-569F-4469-B7E8-36F917EA31CF}"/>
               </a:ext>
             </a:extLst>
           </p:cNvPr>
@@ -6819,7 +6819,7 @@
           <p:cNvPr id="25" name="">
             <a:extLst xmlns:a="http://schemas.openxmlformats.org/drawingml/2006/main">
               <a:ext uri="{FF2B5EF4-FFF2-40B4-BE49-F238E27FC236}">
-                <a16:creationId xmlns:a16="http://schemas.microsoft.com/office/drawing/2014/main" id="{D01CE5E4-F412-496F-A178-44AEFCE279D5}"/>
+                <a16:creationId xmlns:a16="http://schemas.microsoft.com/office/drawing/2014/main" id="{6EEA5ED1-7AEF-48F3-A44F-3277D726D521}"/>
               </a:ext>
             </a:extLst>
           </p:cNvPr>
@@ -6877,7 +6877,7 @@
           <p:cNvPr id="26" name="">
             <a:extLst xmlns:a="http://schemas.openxmlformats.org/drawingml/2006/main">
               <a:ext uri="{FF2B5EF4-FFF2-40B4-BE49-F238E27FC236}">
-                <a16:creationId xmlns:a16="http://schemas.microsoft.com/office/drawing/2014/main" id="{816B03C8-2733-4E5C-8F91-B284B50D3B3D}"/>
+                <a16:creationId xmlns:a16="http://schemas.microsoft.com/office/drawing/2014/main" id="{89127A70-1FFF-4928-AF1C-1B8A72B34A32}"/>
               </a:ext>
             </a:extLst>
           </p:cNvPr>
@@ -6935,7 +6935,7 @@
           <p:cNvPr id="27" name="">
             <a:extLst xmlns:a="http://schemas.openxmlformats.org/drawingml/2006/main">
               <a:ext uri="{FF2B5EF4-FFF2-40B4-BE49-F238E27FC236}">
-                <a16:creationId xmlns:a16="http://schemas.microsoft.com/office/drawing/2014/main" id="{86E1598D-6FA3-4E93-83A5-57D4549753F6}"/>
+                <a16:creationId xmlns:a16="http://schemas.microsoft.com/office/drawing/2014/main" id="{95EE3889-5C34-4C00-8607-89CCE0057F97}"/>
               </a:ext>
             </a:extLst>
           </p:cNvPr>
@@ -6993,7 +6993,7 @@
           <p:cNvPr id="28" name="">
             <a:extLst xmlns:a="http://schemas.openxmlformats.org/drawingml/2006/main">
               <a:ext uri="{FF2B5EF4-FFF2-40B4-BE49-F238E27FC236}">
-                <a16:creationId xmlns:a16="http://schemas.microsoft.com/office/drawing/2014/main" id="{9EA942D0-CC61-4CC0-AEF1-55BE96E1282F}"/>
+                <a16:creationId xmlns:a16="http://schemas.microsoft.com/office/drawing/2014/main" id="{65DB9162-D405-455C-9309-B1EC5AE5F969}"/>
               </a:ext>
             </a:extLst>
           </p:cNvPr>
@@ -7051,7 +7051,7 @@
           <p:cNvPr id="29" name="">
             <a:extLst xmlns:a="http://schemas.openxmlformats.org/drawingml/2006/main">
               <a:ext uri="{FF2B5EF4-FFF2-40B4-BE49-F238E27FC236}">
-                <a16:creationId xmlns:a16="http://schemas.microsoft.com/office/drawing/2014/main" id="{8CC95967-9BA5-4317-AA17-BE6B4A4BAF1E}"/>
+                <a16:creationId xmlns:a16="http://schemas.microsoft.com/office/drawing/2014/main" id="{A6BE6F0F-EB81-437F-93F4-EF91859E20A5}"/>
               </a:ext>
             </a:extLst>
           </p:cNvPr>
@@ -7099,7 +7099,7 @@
                 <a:ea typeface="Aptos"/>
                 <a:cs typeface="Aptos"/>
               </a:rPr>
-              <a:t>WATERS NEXT GEN COMPETITIVE INTELLIGENCE · 02 AUG 2026 · waters-ci-20260802160152</a:t>
+              <a:t>WATERS NEXT GEN COMPETITIVE INTELLIGENCE · 13 AUG 2026 · waters-ci-20260813070817</a:t>
             </a:r>
           </a:p>
         </p:txBody>
@@ -7109,7 +7109,7 @@
           <p:cNvPr id="30" name="">
             <a:extLst xmlns:a="http://schemas.openxmlformats.org/drawingml/2006/main">
               <a:ext uri="{FF2B5EF4-FFF2-40B4-BE49-F238E27FC236}">
-                <a16:creationId xmlns:a16="http://schemas.microsoft.com/office/drawing/2014/main" id="{9953434E-8324-4AC1-95F8-0AB3194A4EEA}"/>
+                <a16:creationId xmlns:a16="http://schemas.microsoft.com/office/drawing/2014/main" id="{B3B1A2C9-6A4B-46D4-8C97-FB54D8E2EA98}"/>
               </a:ext>
             </a:extLst>
           </p:cNvPr>
@@ -7165,7 +7165,7 @@
     </p:spTree>
     <p:extLst>
       <p:ext uri="{BB962C8B-B14F-4D97-AF65-F5344CB8AC3E}">
-        <p14:creationId xmlns:p14="http://schemas.microsoft.com/office/powerpoint/2010/main" val="347837390"/>
+        <p14:creationId xmlns:p14="http://schemas.microsoft.com/office/powerpoint/2010/main" val="112031297"/>
       </p:ext>
     </p:extLst>
   </p:cSld>
@@ -7196,7 +7196,7 @@
           <p:cNvPr id="17" name="">
             <a:extLst xmlns:a="http://schemas.openxmlformats.org/drawingml/2006/main">
               <a:ext uri="{FF2B5EF4-FFF2-40B4-BE49-F238E27FC236}">
-                <a16:creationId xmlns:a16="http://schemas.microsoft.com/office/drawing/2014/main" id="{009EB8A9-B122-408F-881C-92AB0AD87E8F}"/>
+                <a16:creationId xmlns:a16="http://schemas.microsoft.com/office/drawing/2014/main" id="{870A1921-E1FC-406A-BD5F-1EDF78B880D2}"/>
               </a:ext>
             </a:extLst>
           </p:cNvPr>
@@ -7254,7 +7254,7 @@
           <p:cNvPr id="2" name="">
             <a:extLst xmlns:a="http://schemas.openxmlformats.org/drawingml/2006/main">
               <a:ext uri="{FF2B5EF4-FFF2-40B4-BE49-F238E27FC236}">
-                <a16:creationId xmlns:a16="http://schemas.microsoft.com/office/drawing/2014/main" id="{272518BC-F0A2-45CF-8825-B380EDC40EA3}"/>
+                <a16:creationId xmlns:a16="http://schemas.microsoft.com/office/drawing/2014/main" id="{3BB06143-209C-4C0F-97A0-587F9DA75824}"/>
               </a:ext>
             </a:extLst>
           </p:cNvPr>
@@ -7312,7 +7312,7 @@
           <p:cNvPr id="3" name="">
             <a:extLst xmlns:a="http://schemas.openxmlformats.org/drawingml/2006/main">
               <a:ext uri="{FF2B5EF4-FFF2-40B4-BE49-F238E27FC236}">
-                <a16:creationId xmlns:a16="http://schemas.microsoft.com/office/drawing/2014/main" id="{FB9A848C-CF92-4B55-8728-6F5E38D3BB62}"/>
+                <a16:creationId xmlns:a16="http://schemas.microsoft.com/office/drawing/2014/main" id="{E8FAE24F-4158-4FFC-A34A-B2F4C37A79EB}"/>
               </a:ext>
             </a:extLst>
           </p:cNvPr>
@@ -7370,7 +7370,7 @@
           <p:cNvPr id="4" name="">
             <a:extLst xmlns:a="http://schemas.openxmlformats.org/drawingml/2006/main">
               <a:ext uri="{FF2B5EF4-FFF2-40B4-BE49-F238E27FC236}">
-                <a16:creationId xmlns:a16="http://schemas.microsoft.com/office/drawing/2014/main" id="{463792F1-E7A3-4DAD-84FA-63E98AF087D3}"/>
+                <a16:creationId xmlns:a16="http://schemas.microsoft.com/office/drawing/2014/main" id="{41951C5D-AC69-4293-A388-A6968147876B}"/>
               </a:ext>
             </a:extLst>
           </p:cNvPr>
@@ -7403,7 +7403,7 @@
           <p:cNvPr id="5" name="">
             <a:extLst xmlns:a="http://schemas.openxmlformats.org/drawingml/2006/main">
               <a:ext uri="{FF2B5EF4-FFF2-40B4-BE49-F238E27FC236}">
-                <a16:creationId xmlns:a16="http://schemas.microsoft.com/office/drawing/2014/main" id="{D88DE43E-6F54-4FEB-B2A7-5B97963F85E5}"/>
+                <a16:creationId xmlns:a16="http://schemas.microsoft.com/office/drawing/2014/main" id="{010F5805-148F-4569-82E9-780831B2D143}"/>
               </a:ext>
             </a:extLst>
           </p:cNvPr>
@@ -7438,7 +7438,7 @@
           <p:cNvPr id="6" name="">
             <a:extLst xmlns:a="http://schemas.openxmlformats.org/drawingml/2006/main">
               <a:ext uri="{FF2B5EF4-FFF2-40B4-BE49-F238E27FC236}">
-                <a16:creationId xmlns:a16="http://schemas.microsoft.com/office/drawing/2014/main" id="{A4AC3129-F2AF-47C1-9F88-5F85C8194417}"/>
+                <a16:creationId xmlns:a16="http://schemas.microsoft.com/office/drawing/2014/main" id="{C5372DAC-42F1-4AC6-BBE0-0284210D9F4D}"/>
               </a:ext>
             </a:extLst>
           </p:cNvPr>
@@ -7496,7 +7496,7 @@
           <p:cNvPr id="7" name="">
             <a:extLst xmlns:a="http://schemas.openxmlformats.org/drawingml/2006/main">
               <a:ext uri="{FF2B5EF4-FFF2-40B4-BE49-F238E27FC236}">
-                <a16:creationId xmlns:a16="http://schemas.microsoft.com/office/drawing/2014/main" id="{9A8E43BE-801F-40B5-89C7-7D794ADFC0F8}"/>
+                <a16:creationId xmlns:a16="http://schemas.microsoft.com/office/drawing/2014/main" id="{51B8EC7C-9AB2-4F08-A967-9E8C2C7868D4}"/>
               </a:ext>
             </a:extLst>
           </p:cNvPr>
@@ -7554,7 +7554,7 @@
           <p:cNvPr id="8" name="">
             <a:extLst xmlns:a="http://schemas.openxmlformats.org/drawingml/2006/main">
               <a:ext uri="{FF2B5EF4-FFF2-40B4-BE49-F238E27FC236}">
-                <a16:creationId xmlns:a16="http://schemas.microsoft.com/office/drawing/2014/main" id="{456E5606-C290-4670-BF8B-15CD1835BAD5}"/>
+                <a16:creationId xmlns:a16="http://schemas.microsoft.com/office/drawing/2014/main" id="{1CAAF87E-50CA-4FD3-B71A-8C302D3986C3}"/>
               </a:ext>
             </a:extLst>
           </p:cNvPr>
@@ -7612,7 +7612,7 @@
           <p:cNvPr id="9" name="">
             <a:extLst xmlns:a="http://schemas.openxmlformats.org/drawingml/2006/main">
               <a:ext uri="{FF2B5EF4-FFF2-40B4-BE49-F238E27FC236}">
-                <a16:creationId xmlns:a16="http://schemas.microsoft.com/office/drawing/2014/main" id="{0686F4A4-4647-42AA-BCB5-593EE7A8B876}"/>
+                <a16:creationId xmlns:a16="http://schemas.microsoft.com/office/drawing/2014/main" id="{7F7A6F4F-DAA9-4E64-9EBE-1E57678CE598}"/>
               </a:ext>
             </a:extLst>
           </p:cNvPr>
@@ -7693,7 +7693,7 @@
           <p:cNvPr id="10" name="">
             <a:extLst xmlns:a="http://schemas.openxmlformats.org/drawingml/2006/main">
               <a:ext uri="{FF2B5EF4-FFF2-40B4-BE49-F238E27FC236}">
-                <a16:creationId xmlns:a16="http://schemas.microsoft.com/office/drawing/2014/main" id="{00F3C971-CB00-4B77-9D1F-3388964432A5}"/>
+                <a16:creationId xmlns:a16="http://schemas.microsoft.com/office/drawing/2014/main" id="{D8C5B32C-7CDB-4559-B97E-B52144DCD3CB}"/>
               </a:ext>
             </a:extLst>
           </p:cNvPr>
@@ -7728,7 +7728,7 @@
           <p:cNvPr id="11" name="">
             <a:extLst xmlns:a="http://schemas.openxmlformats.org/drawingml/2006/main">
               <a:ext uri="{FF2B5EF4-FFF2-40B4-BE49-F238E27FC236}">
-                <a16:creationId xmlns:a16="http://schemas.microsoft.com/office/drawing/2014/main" id="{693CD539-537A-4FDB-B2A0-69A8D4DF12A6}"/>
+                <a16:creationId xmlns:a16="http://schemas.microsoft.com/office/drawing/2014/main" id="{D23E058C-72D4-44E3-93C6-894A031FC212}"/>
               </a:ext>
             </a:extLst>
           </p:cNvPr>
@@ -7786,7 +7786,7 @@
           <p:cNvPr id="12" name="">
             <a:extLst xmlns:a="http://schemas.openxmlformats.org/drawingml/2006/main">
               <a:ext uri="{FF2B5EF4-FFF2-40B4-BE49-F238E27FC236}">
-                <a16:creationId xmlns:a16="http://schemas.microsoft.com/office/drawing/2014/main" id="{DF92E835-EDB2-491F-B7C4-2BDC1728D360}"/>
+                <a16:creationId xmlns:a16="http://schemas.microsoft.com/office/drawing/2014/main" id="{0BA32BC5-9F84-498F-AD20-9C1AA3EF92F6}"/>
               </a:ext>
             </a:extLst>
           </p:cNvPr>
@@ -7844,7 +7844,7 @@
           <p:cNvPr id="13" name="">
             <a:extLst xmlns:a="http://schemas.openxmlformats.org/drawingml/2006/main">
               <a:ext uri="{FF2B5EF4-FFF2-40B4-BE49-F238E27FC236}">
-                <a16:creationId xmlns:a16="http://schemas.microsoft.com/office/drawing/2014/main" id="{2595DFDD-70C2-4DA7-90E1-0766F2C71C74}"/>
+                <a16:creationId xmlns:a16="http://schemas.microsoft.com/office/drawing/2014/main" id="{10E06D17-7718-4FBB-9E49-927C4671BA5D}"/>
               </a:ext>
             </a:extLst>
           </p:cNvPr>
@@ -7902,7 +7902,7 @@
           <p:cNvPr id="14" name="">
             <a:extLst xmlns:a="http://schemas.openxmlformats.org/drawingml/2006/main">
               <a:ext uri="{FF2B5EF4-FFF2-40B4-BE49-F238E27FC236}">
-                <a16:creationId xmlns:a16="http://schemas.microsoft.com/office/drawing/2014/main" id="{2D580E14-21ED-481C-8DE0-7D58D4D5E97F}"/>
+                <a16:creationId xmlns:a16="http://schemas.microsoft.com/office/drawing/2014/main" id="{2886A792-C50C-4688-A70F-3C491EFA8B55}"/>
               </a:ext>
             </a:extLst>
           </p:cNvPr>
@@ -8006,7 +8006,7 @@
           <p:cNvPr id="15" name="">
             <a:extLst xmlns:a="http://schemas.openxmlformats.org/drawingml/2006/main">
               <a:ext uri="{FF2B5EF4-FFF2-40B4-BE49-F238E27FC236}">
-                <a16:creationId xmlns:a16="http://schemas.microsoft.com/office/drawing/2014/main" id="{2A330747-0A5A-4073-BBD6-FAF8ECF0848C}"/>
+                <a16:creationId xmlns:a16="http://schemas.microsoft.com/office/drawing/2014/main" id="{4615E46F-0066-4A95-BD3C-F7371A10FEE5}"/>
               </a:ext>
             </a:extLst>
           </p:cNvPr>
@@ -8054,7 +8054,7 @@
                 <a:ea typeface="Aptos"/>
                 <a:cs typeface="Aptos"/>
               </a:rPr>
-              <a:t>WATERS NEXT GEN COMPETITIVE INTELLIGENCE · 02 AUG 2026 · waters-ci-20260802160152</a:t>
+              <a:t>WATERS NEXT GEN COMPETITIVE INTELLIGENCE · 13 AUG 2026 · waters-ci-20260813070817</a:t>
             </a:r>
           </a:p>
         </p:txBody>
@@ -8064,7 +8064,7 @@
           <p:cNvPr id="16" name="">
             <a:extLst xmlns:a="http://schemas.openxmlformats.org/drawingml/2006/main">
               <a:ext uri="{FF2B5EF4-FFF2-40B4-BE49-F238E27FC236}">
-                <a16:creationId xmlns:a16="http://schemas.microsoft.com/office/drawing/2014/main" id="{8733EC7E-5846-4628-803F-44FDCFC27517}"/>
+                <a16:creationId xmlns:a16="http://schemas.microsoft.com/office/drawing/2014/main" id="{529D3770-8337-43E3-BC05-F62786B723F3}"/>
               </a:ext>
             </a:extLst>
           </p:cNvPr>
@@ -8120,7 +8120,7 @@
     </p:spTree>
     <p:extLst>
       <p:ext uri="{BB962C8B-B14F-4D97-AF65-F5344CB8AC3E}">
-        <p14:creationId xmlns:p14="http://schemas.microsoft.com/office/powerpoint/2010/main" val="1426724051"/>
+        <p14:creationId xmlns:p14="http://schemas.microsoft.com/office/powerpoint/2010/main" val="2038293230"/>
       </p:ext>
     </p:extLst>
   </p:cSld>
@@ -8151,7 +8151,7 @@
           <p:cNvPr id="37" name="">
             <a:extLst xmlns:a="http://schemas.openxmlformats.org/drawingml/2006/main">
               <a:ext uri="{FF2B5EF4-FFF2-40B4-BE49-F238E27FC236}">
-                <a16:creationId xmlns:a16="http://schemas.microsoft.com/office/drawing/2014/main" id="{50E173AA-CD9F-4776-91CC-91FFF9C69587}"/>
+                <a16:creationId xmlns:a16="http://schemas.microsoft.com/office/drawing/2014/main" id="{DB4D74BE-CAAF-4F46-BB20-A425D763CC31}"/>
               </a:ext>
             </a:extLst>
           </p:cNvPr>
@@ -8209,7 +8209,7 @@
           <p:cNvPr id="2" name="">
             <a:extLst xmlns:a="http://schemas.openxmlformats.org/drawingml/2006/main">
               <a:ext uri="{FF2B5EF4-FFF2-40B4-BE49-F238E27FC236}">
-                <a16:creationId xmlns:a16="http://schemas.microsoft.com/office/drawing/2014/main" id="{C1AF48DD-E241-426D-AB87-40229D688E05}"/>
+                <a16:creationId xmlns:a16="http://schemas.microsoft.com/office/drawing/2014/main" id="{DFC5A1D3-EF3E-400C-BAB3-430405446AD4}"/>
               </a:ext>
             </a:extLst>
           </p:cNvPr>
@@ -8267,7 +8267,7 @@
           <p:cNvPr id="3" name="">
             <a:extLst xmlns:a="http://schemas.openxmlformats.org/drawingml/2006/main">
               <a:ext uri="{FF2B5EF4-FFF2-40B4-BE49-F238E27FC236}">
-                <a16:creationId xmlns:a16="http://schemas.microsoft.com/office/drawing/2014/main" id="{B2E559CA-F4C1-4BEE-A7E8-EF66FA73DA25}"/>
+                <a16:creationId xmlns:a16="http://schemas.microsoft.com/office/drawing/2014/main" id="{E9483337-EA28-4FE7-9702-A415E4098171}"/>
               </a:ext>
             </a:extLst>
           </p:cNvPr>
@@ -8325,7 +8325,7 @@
           <p:cNvPr id="4" name="">
             <a:extLst xmlns:a="http://schemas.openxmlformats.org/drawingml/2006/main">
               <a:ext uri="{FF2B5EF4-FFF2-40B4-BE49-F238E27FC236}">
-                <a16:creationId xmlns:a16="http://schemas.microsoft.com/office/drawing/2014/main" id="{00FB782B-69CB-4EFC-9D67-D126C7D0B1B5}"/>
+                <a16:creationId xmlns:a16="http://schemas.microsoft.com/office/drawing/2014/main" id="{AA92781D-428F-4BC2-AA6F-A0F65DABF461}"/>
               </a:ext>
             </a:extLst>
           </p:cNvPr>
@@ -8358,7 +8358,7 @@
           <p:cNvPr id="5" name="">
             <a:extLst xmlns:a="http://schemas.openxmlformats.org/drawingml/2006/main">
               <a:ext uri="{FF2B5EF4-FFF2-40B4-BE49-F238E27FC236}">
-                <a16:creationId xmlns:a16="http://schemas.microsoft.com/office/drawing/2014/main" id="{5B11C13B-5285-445A-A734-D8C1709D72FD}"/>
+                <a16:creationId xmlns:a16="http://schemas.microsoft.com/office/drawing/2014/main" id="{C17BFB09-7E82-42AB-B9F1-EC9209E096CB}"/>
               </a:ext>
             </a:extLst>
           </p:cNvPr>
@@ -8393,7 +8393,7 @@
           <p:cNvPr id="6" name="">
             <a:extLst xmlns:a="http://schemas.openxmlformats.org/drawingml/2006/main">
               <a:ext uri="{FF2B5EF4-FFF2-40B4-BE49-F238E27FC236}">
-                <a16:creationId xmlns:a16="http://schemas.microsoft.com/office/drawing/2014/main" id="{30481557-4FF7-414F-88F2-143BC16F7268}"/>
+                <a16:creationId xmlns:a16="http://schemas.microsoft.com/office/drawing/2014/main" id="{4BC7126B-D90A-42B7-9CD7-7948C32BD4CD}"/>
               </a:ext>
             </a:extLst>
           </p:cNvPr>
@@ -8426,7 +8426,7 @@
           <p:cNvPr id="7" name="">
             <a:extLst xmlns:a="http://schemas.openxmlformats.org/drawingml/2006/main">
               <a:ext uri="{FF2B5EF4-FFF2-40B4-BE49-F238E27FC236}">
-                <a16:creationId xmlns:a16="http://schemas.microsoft.com/office/drawing/2014/main" id="{6EE8A531-08CB-460D-AA2E-191FC822B3F0}"/>
+                <a16:creationId xmlns:a16="http://schemas.microsoft.com/office/drawing/2014/main" id="{EA1B960F-585B-44BA-9EB8-AE68EA642592}"/>
               </a:ext>
             </a:extLst>
           </p:cNvPr>
@@ -8484,7 +8484,7 @@
           <p:cNvPr id="8" name="">
             <a:extLst xmlns:a="http://schemas.openxmlformats.org/drawingml/2006/main">
               <a:ext uri="{FF2B5EF4-FFF2-40B4-BE49-F238E27FC236}">
-                <a16:creationId xmlns:a16="http://schemas.microsoft.com/office/drawing/2014/main" id="{0BFC13CD-6377-4377-96CE-3DA6DE1AF891}"/>
+                <a16:creationId xmlns:a16="http://schemas.microsoft.com/office/drawing/2014/main" id="{41C119CA-8665-4E9D-841B-A7DF2DF8D519}"/>
               </a:ext>
             </a:extLst>
           </p:cNvPr>
@@ -8542,7 +8542,7 @@
           <p:cNvPr id="9" name="">
             <a:extLst xmlns:a="http://schemas.openxmlformats.org/drawingml/2006/main">
               <a:ext uri="{FF2B5EF4-FFF2-40B4-BE49-F238E27FC236}">
-                <a16:creationId xmlns:a16="http://schemas.microsoft.com/office/drawing/2014/main" id="{26FF4F3F-FD73-4737-8AFF-7A0E321295F1}"/>
+                <a16:creationId xmlns:a16="http://schemas.microsoft.com/office/drawing/2014/main" id="{44BA1151-BBDF-4F01-83CF-D79E2B5AFC93}"/>
               </a:ext>
             </a:extLst>
           </p:cNvPr>
@@ -8600,7 +8600,7 @@
           <p:cNvPr id="10" name="">
             <a:extLst xmlns:a="http://schemas.openxmlformats.org/drawingml/2006/main">
               <a:ext uri="{FF2B5EF4-FFF2-40B4-BE49-F238E27FC236}">
-                <a16:creationId xmlns:a16="http://schemas.microsoft.com/office/drawing/2014/main" id="{EA010215-55AE-4923-953E-F4D363B1A1FD}"/>
+                <a16:creationId xmlns:a16="http://schemas.microsoft.com/office/drawing/2014/main" id="{E00E0109-3BD5-47CE-8474-045E58CE14F9}"/>
               </a:ext>
             </a:extLst>
           </p:cNvPr>
@@ -8658,7 +8658,7 @@
           <p:cNvPr id="11" name="">
             <a:extLst xmlns:a="http://schemas.openxmlformats.org/drawingml/2006/main">
               <a:ext uri="{FF2B5EF4-FFF2-40B4-BE49-F238E27FC236}">
-                <a16:creationId xmlns:a16="http://schemas.microsoft.com/office/drawing/2014/main" id="{29F6A4ED-99D3-4EAC-B42A-3C95E843CD4B}"/>
+                <a16:creationId xmlns:a16="http://schemas.microsoft.com/office/drawing/2014/main" id="{4061F1CF-2ADE-4794-8B97-E46E27AAA989}"/>
               </a:ext>
             </a:extLst>
           </p:cNvPr>
@@ -8691,7 +8691,7 @@
           <p:cNvPr id="12" name="">
             <a:extLst xmlns:a="http://schemas.openxmlformats.org/drawingml/2006/main">
               <a:ext uri="{FF2B5EF4-FFF2-40B4-BE49-F238E27FC236}">
-                <a16:creationId xmlns:a16="http://schemas.microsoft.com/office/drawing/2014/main" id="{C054AE6A-730C-43DD-B963-C414EC2D32EF}"/>
+                <a16:creationId xmlns:a16="http://schemas.microsoft.com/office/drawing/2014/main" id="{96F83541-4D97-42CD-B92D-71531F71FB2D}"/>
               </a:ext>
             </a:extLst>
           </p:cNvPr>
@@ -8749,7 +8749,7 @@
           <p:cNvPr id="13" name="">
             <a:extLst xmlns:a="http://schemas.openxmlformats.org/drawingml/2006/main">
               <a:ext uri="{FF2B5EF4-FFF2-40B4-BE49-F238E27FC236}">
-                <a16:creationId xmlns:a16="http://schemas.microsoft.com/office/drawing/2014/main" id="{CD920361-7F16-4F25-AEB9-E198E7D686FF}"/>
+                <a16:creationId xmlns:a16="http://schemas.microsoft.com/office/drawing/2014/main" id="{66C0DEBB-6E3F-46EF-83A3-48F12F6AB654}"/>
               </a:ext>
             </a:extLst>
           </p:cNvPr>
@@ -8807,7 +8807,7 @@
           <p:cNvPr id="14" name="">
             <a:extLst xmlns:a="http://schemas.openxmlformats.org/drawingml/2006/main">
               <a:ext uri="{FF2B5EF4-FFF2-40B4-BE49-F238E27FC236}">
-                <a16:creationId xmlns:a16="http://schemas.microsoft.com/office/drawing/2014/main" id="{C0E69610-D47F-4822-BF2F-1DA3031E4666}"/>
+                <a16:creationId xmlns:a16="http://schemas.microsoft.com/office/drawing/2014/main" id="{37FDCAFD-DAB3-4A6A-9A82-808513074AA5}"/>
               </a:ext>
             </a:extLst>
           </p:cNvPr>
@@ -8865,7 +8865,7 @@
           <p:cNvPr id="15" name="">
             <a:extLst xmlns:a="http://schemas.openxmlformats.org/drawingml/2006/main">
               <a:ext uri="{FF2B5EF4-FFF2-40B4-BE49-F238E27FC236}">
-                <a16:creationId xmlns:a16="http://schemas.microsoft.com/office/drawing/2014/main" id="{660FDE1F-DA00-42F0-8912-A08E07A7B3FC}"/>
+                <a16:creationId xmlns:a16="http://schemas.microsoft.com/office/drawing/2014/main" id="{08BBF848-97AD-4879-9CC6-26EC7B181500}"/>
               </a:ext>
             </a:extLst>
           </p:cNvPr>
@@ -8900,7 +8900,7 @@
           <p:cNvPr id="16" name="">
             <a:extLst xmlns:a="http://schemas.openxmlformats.org/drawingml/2006/main">
               <a:ext uri="{FF2B5EF4-FFF2-40B4-BE49-F238E27FC236}">
-                <a16:creationId xmlns:a16="http://schemas.microsoft.com/office/drawing/2014/main" id="{8DF2A62C-51BA-40A8-A706-C66AB7B2A876}"/>
+                <a16:creationId xmlns:a16="http://schemas.microsoft.com/office/drawing/2014/main" id="{D31BAE44-9836-4255-80A7-BD395939166D}"/>
               </a:ext>
             </a:extLst>
           </p:cNvPr>
@@ -8933,7 +8933,7 @@
           <p:cNvPr id="17" name="">
             <a:extLst xmlns:a="http://schemas.openxmlformats.org/drawingml/2006/main">
               <a:ext uri="{FF2B5EF4-FFF2-40B4-BE49-F238E27FC236}">
-                <a16:creationId xmlns:a16="http://schemas.microsoft.com/office/drawing/2014/main" id="{393FA470-FF18-4747-A045-CC70084370FB}"/>
+                <a16:creationId xmlns:a16="http://schemas.microsoft.com/office/drawing/2014/main" id="{1F9D5368-3A27-41DB-9F0E-CCD68A0C8C77}"/>
               </a:ext>
             </a:extLst>
           </p:cNvPr>
@@ -8991,7 +8991,7 @@
           <p:cNvPr id="18" name="">
             <a:extLst xmlns:a="http://schemas.openxmlformats.org/drawingml/2006/main">
               <a:ext uri="{FF2B5EF4-FFF2-40B4-BE49-F238E27FC236}">
-                <a16:creationId xmlns:a16="http://schemas.microsoft.com/office/drawing/2014/main" id="{8A00AD65-11A2-46DE-8E06-222A7EDBB9DD}"/>
+                <a16:creationId xmlns:a16="http://schemas.microsoft.com/office/drawing/2014/main" id="{27F6D267-4094-4A57-8CA5-2C84C996CEC1}"/>
               </a:ext>
             </a:extLst>
           </p:cNvPr>
@@ -9049,7 +9049,7 @@
           <p:cNvPr id="19" name="">
             <a:extLst xmlns:a="http://schemas.openxmlformats.org/drawingml/2006/main">
               <a:ext uri="{FF2B5EF4-FFF2-40B4-BE49-F238E27FC236}">
-                <a16:creationId xmlns:a16="http://schemas.microsoft.com/office/drawing/2014/main" id="{9D20D198-1FA3-4295-A323-8464E8503E1F}"/>
+                <a16:creationId xmlns:a16="http://schemas.microsoft.com/office/drawing/2014/main" id="{F2430C66-A574-404A-94DF-C540A4AEAD8B}"/>
               </a:ext>
             </a:extLst>
           </p:cNvPr>
@@ -9107,7 +9107,7 @@
           <p:cNvPr id="20" name="">
             <a:extLst xmlns:a="http://schemas.openxmlformats.org/drawingml/2006/main">
               <a:ext uri="{FF2B5EF4-FFF2-40B4-BE49-F238E27FC236}">
-                <a16:creationId xmlns:a16="http://schemas.microsoft.com/office/drawing/2014/main" id="{DCA976C5-F260-404B-96D7-CFF225CB78EB}"/>
+                <a16:creationId xmlns:a16="http://schemas.microsoft.com/office/drawing/2014/main" id="{9CA0B07D-E881-467F-A2E3-F127D41B1FC4}"/>
               </a:ext>
             </a:extLst>
           </p:cNvPr>
@@ -9165,7 +9165,7 @@
           <p:cNvPr id="21" name="">
             <a:extLst xmlns:a="http://schemas.openxmlformats.org/drawingml/2006/main">
               <a:ext uri="{FF2B5EF4-FFF2-40B4-BE49-F238E27FC236}">
-                <a16:creationId xmlns:a16="http://schemas.microsoft.com/office/drawing/2014/main" id="{A1F34A21-A1E9-4B54-98F5-0C6ED79673E2}"/>
+                <a16:creationId xmlns:a16="http://schemas.microsoft.com/office/drawing/2014/main" id="{34F453A8-ED87-4F6D-96F1-BB2949ECD721}"/>
               </a:ext>
             </a:extLst>
           </p:cNvPr>
@@ -9198,7 +9198,7 @@
           <p:cNvPr id="22" name="">
             <a:extLst xmlns:a="http://schemas.openxmlformats.org/drawingml/2006/main">
               <a:ext uri="{FF2B5EF4-FFF2-40B4-BE49-F238E27FC236}">
-                <a16:creationId xmlns:a16="http://schemas.microsoft.com/office/drawing/2014/main" id="{CF64FE06-F881-4395-8856-A750CE7F0713}"/>
+                <a16:creationId xmlns:a16="http://schemas.microsoft.com/office/drawing/2014/main" id="{41CE6237-C020-41E7-9E07-CD38A5D24E4C}"/>
               </a:ext>
             </a:extLst>
           </p:cNvPr>
@@ -9256,7 +9256,7 @@
           <p:cNvPr id="23" name="">
             <a:extLst xmlns:a="http://schemas.openxmlformats.org/drawingml/2006/main">
               <a:ext uri="{FF2B5EF4-FFF2-40B4-BE49-F238E27FC236}">
-                <a16:creationId xmlns:a16="http://schemas.microsoft.com/office/drawing/2014/main" id="{F27C6754-F841-4147-8546-FFA8206EFBDE}"/>
+                <a16:creationId xmlns:a16="http://schemas.microsoft.com/office/drawing/2014/main" id="{A4513662-D4DB-4FCF-A83D-05FD4A203D66}"/>
               </a:ext>
             </a:extLst>
           </p:cNvPr>
@@ -9314,7 +9314,7 @@
           <p:cNvPr id="24" name="">
             <a:extLst xmlns:a="http://schemas.openxmlformats.org/drawingml/2006/main">
               <a:ext uri="{FF2B5EF4-FFF2-40B4-BE49-F238E27FC236}">
-                <a16:creationId xmlns:a16="http://schemas.microsoft.com/office/drawing/2014/main" id="{9195D7D0-3996-4C51-B560-75C0D5B15F15}"/>
+                <a16:creationId xmlns:a16="http://schemas.microsoft.com/office/drawing/2014/main" id="{CC122E95-B499-4CFF-B6CA-3628BC2C0C27}"/>
               </a:ext>
             </a:extLst>
           </p:cNvPr>
@@ -9372,7 +9372,7 @@
           <p:cNvPr id="25" name="">
             <a:extLst xmlns:a="http://schemas.openxmlformats.org/drawingml/2006/main">
               <a:ext uri="{FF2B5EF4-FFF2-40B4-BE49-F238E27FC236}">
-                <a16:creationId xmlns:a16="http://schemas.microsoft.com/office/drawing/2014/main" id="{92B7365F-4ADB-4EA3-BE91-0A85173203DE}"/>
+                <a16:creationId xmlns:a16="http://schemas.microsoft.com/office/drawing/2014/main" id="{3431B2F6-EA5A-41DD-9C01-24BD67C83EFE}"/>
               </a:ext>
             </a:extLst>
           </p:cNvPr>
@@ -9407,7 +9407,7 @@
           <p:cNvPr id="26" name="">
             <a:extLst xmlns:a="http://schemas.openxmlformats.org/drawingml/2006/main">
               <a:ext uri="{FF2B5EF4-FFF2-40B4-BE49-F238E27FC236}">
-                <a16:creationId xmlns:a16="http://schemas.microsoft.com/office/drawing/2014/main" id="{6FC2DB6E-DBD2-4187-B7E8-C244D984FE8F}"/>
+                <a16:creationId xmlns:a16="http://schemas.microsoft.com/office/drawing/2014/main" id="{4914450E-4ABE-4153-8344-B4C46D4126B2}"/>
               </a:ext>
             </a:extLst>
           </p:cNvPr>
@@ -9440,7 +9440,7 @@
           <p:cNvPr id="27" name="">
             <a:extLst xmlns:a="http://schemas.openxmlformats.org/drawingml/2006/main">
               <a:ext uri="{FF2B5EF4-FFF2-40B4-BE49-F238E27FC236}">
-                <a16:creationId xmlns:a16="http://schemas.microsoft.com/office/drawing/2014/main" id="{18B4D34C-DD06-4F75-B53B-4E8B52DB292F}"/>
+                <a16:creationId xmlns:a16="http://schemas.microsoft.com/office/drawing/2014/main" id="{98849BE5-FF8A-45DA-BA0D-FA232D2D3B8F}"/>
               </a:ext>
             </a:extLst>
           </p:cNvPr>
@@ -9498,7 +9498,7 @@
           <p:cNvPr id="28" name="">
             <a:extLst xmlns:a="http://schemas.openxmlformats.org/drawingml/2006/main">
               <a:ext uri="{FF2B5EF4-FFF2-40B4-BE49-F238E27FC236}">
-                <a16:creationId xmlns:a16="http://schemas.microsoft.com/office/drawing/2014/main" id="{B85676CF-4FE3-4AF7-B981-5582581512F6}"/>
+                <a16:creationId xmlns:a16="http://schemas.microsoft.com/office/drawing/2014/main" id="{ED7220FC-D977-40B5-9034-90493082C5FB}"/>
               </a:ext>
             </a:extLst>
           </p:cNvPr>
@@ -9556,7 +9556,7 @@
           <p:cNvPr id="29" name="">
             <a:extLst xmlns:a="http://schemas.openxmlformats.org/drawingml/2006/main">
               <a:ext uri="{FF2B5EF4-FFF2-40B4-BE49-F238E27FC236}">
-                <a16:creationId xmlns:a16="http://schemas.microsoft.com/office/drawing/2014/main" id="{2D1B5F02-587E-477F-8920-5A2658D84D1E}"/>
+                <a16:creationId xmlns:a16="http://schemas.microsoft.com/office/drawing/2014/main" id="{7F48C78F-5347-49C1-B1A1-341DE42B1719}"/>
               </a:ext>
             </a:extLst>
           </p:cNvPr>
@@ -9614,7 +9614,7 @@
           <p:cNvPr id="30" name="">
             <a:extLst xmlns:a="http://schemas.openxmlformats.org/drawingml/2006/main">
               <a:ext uri="{FF2B5EF4-FFF2-40B4-BE49-F238E27FC236}">
-                <a16:creationId xmlns:a16="http://schemas.microsoft.com/office/drawing/2014/main" id="{F9B5A6D6-AA39-4A1E-9B4F-6515F4DB21EC}"/>
+                <a16:creationId xmlns:a16="http://schemas.microsoft.com/office/drawing/2014/main" id="{EC266EDF-426F-482A-98D4-A9BCBA7AE5FF}"/>
               </a:ext>
             </a:extLst>
           </p:cNvPr>
@@ -9672,7 +9672,7 @@
           <p:cNvPr id="31" name="">
             <a:extLst xmlns:a="http://schemas.openxmlformats.org/drawingml/2006/main">
               <a:ext uri="{FF2B5EF4-FFF2-40B4-BE49-F238E27FC236}">
-                <a16:creationId xmlns:a16="http://schemas.microsoft.com/office/drawing/2014/main" id="{02D93686-78EE-494F-B17C-B5C77E682446}"/>
+                <a16:creationId xmlns:a16="http://schemas.microsoft.com/office/drawing/2014/main" id="{ECE3EB5C-EAAF-4347-83AC-07ED32074D65}"/>
               </a:ext>
             </a:extLst>
           </p:cNvPr>
@@ -9705,7 +9705,7 @@
           <p:cNvPr id="32" name="">
             <a:extLst xmlns:a="http://schemas.openxmlformats.org/drawingml/2006/main">
               <a:ext uri="{FF2B5EF4-FFF2-40B4-BE49-F238E27FC236}">
-                <a16:creationId xmlns:a16="http://schemas.microsoft.com/office/drawing/2014/main" id="{866D5BC8-444C-43A2-A39C-87C994BEB250}"/>
+                <a16:creationId xmlns:a16="http://schemas.microsoft.com/office/drawing/2014/main" id="{26358251-AC96-4B56-ACEB-531C6C471559}"/>
               </a:ext>
             </a:extLst>
           </p:cNvPr>
@@ -9763,7 +9763,7 @@
           <p:cNvPr id="33" name="">
             <a:extLst xmlns:a="http://schemas.openxmlformats.org/drawingml/2006/main">
               <a:ext uri="{FF2B5EF4-FFF2-40B4-BE49-F238E27FC236}">
-                <a16:creationId xmlns:a16="http://schemas.microsoft.com/office/drawing/2014/main" id="{C7CC97A6-7E6C-4E51-8EA9-8C62C13F42E1}"/>
+                <a16:creationId xmlns:a16="http://schemas.microsoft.com/office/drawing/2014/main" id="{9A3103D8-97F7-45DF-8D06-1CE00DE3F5E9}"/>
               </a:ext>
             </a:extLst>
           </p:cNvPr>
@@ -9821,7 +9821,7 @@
           <p:cNvPr id="34" name="">
             <a:extLst xmlns:a="http://schemas.openxmlformats.org/drawingml/2006/main">
               <a:ext uri="{FF2B5EF4-FFF2-40B4-BE49-F238E27FC236}">
-                <a16:creationId xmlns:a16="http://schemas.microsoft.com/office/drawing/2014/main" id="{16100DFD-7478-45D6-A76E-52FC7515E2E0}"/>
+                <a16:creationId xmlns:a16="http://schemas.microsoft.com/office/drawing/2014/main" id="{1993B558-9185-4DF3-A3B4-1DFF91C29B07}"/>
               </a:ext>
             </a:extLst>
           </p:cNvPr>
@@ -9879,7 +9879,7 @@
           <p:cNvPr id="35" name="">
             <a:extLst xmlns:a="http://schemas.openxmlformats.org/drawingml/2006/main">
               <a:ext uri="{FF2B5EF4-FFF2-40B4-BE49-F238E27FC236}">
-                <a16:creationId xmlns:a16="http://schemas.microsoft.com/office/drawing/2014/main" id="{687ADBEF-60DC-4060-A368-F98B78B08089}"/>
+                <a16:creationId xmlns:a16="http://schemas.microsoft.com/office/drawing/2014/main" id="{2D0DD19A-D871-422A-A26C-E7E4C0CC8EE5}"/>
               </a:ext>
             </a:extLst>
           </p:cNvPr>
@@ -9927,7 +9927,7 @@
                 <a:ea typeface="Aptos"/>
                 <a:cs typeface="Aptos"/>
               </a:rPr>
-              <a:t>WATERS NEXT GEN COMPETITIVE INTELLIGENCE · 02 AUG 2026 · waters-ci-20260802160152</a:t>
+              <a:t>WATERS NEXT GEN COMPETITIVE INTELLIGENCE · 13 AUG 2026 · waters-ci-20260813070817</a:t>
             </a:r>
           </a:p>
         </p:txBody>
@@ -9937,7 +9937,7 @@
           <p:cNvPr id="36" name="">
             <a:extLst xmlns:a="http://schemas.openxmlformats.org/drawingml/2006/main">
               <a:ext uri="{FF2B5EF4-FFF2-40B4-BE49-F238E27FC236}">
-                <a16:creationId xmlns:a16="http://schemas.microsoft.com/office/drawing/2014/main" id="{3AE2AE9C-7BB1-4AC3-BCD0-FA666F017EDC}"/>
+                <a16:creationId xmlns:a16="http://schemas.microsoft.com/office/drawing/2014/main" id="{9B0C0BA8-1176-4862-AB23-BF2F50FBD2E5}"/>
               </a:ext>
             </a:extLst>
           </p:cNvPr>
@@ -9993,7 +9993,7 @@
     </p:spTree>
     <p:extLst>
       <p:ext uri="{BB962C8B-B14F-4D97-AF65-F5344CB8AC3E}">
-        <p14:creationId xmlns:p14="http://schemas.microsoft.com/office/powerpoint/2010/main" val="479299002"/>
+        <p14:creationId xmlns:p14="http://schemas.microsoft.com/office/powerpoint/2010/main" val="510387907"/>
       </p:ext>
     </p:extLst>
   </p:cSld>
@@ -10024,7 +10024,7 @@
           <p:cNvPr id="26" name="">
             <a:extLst xmlns:a="http://schemas.openxmlformats.org/drawingml/2006/main">
               <a:ext uri="{FF2B5EF4-FFF2-40B4-BE49-F238E27FC236}">
-                <a16:creationId xmlns:a16="http://schemas.microsoft.com/office/drawing/2014/main" id="{04A09307-11B2-4050-9734-27CC4386ECF2}"/>
+                <a16:creationId xmlns:a16="http://schemas.microsoft.com/office/drawing/2014/main" id="{E4656AC4-522E-4D04-A1C0-A1E3E05DBE18}"/>
               </a:ext>
             </a:extLst>
           </p:cNvPr>
@@ -10082,7 +10082,7 @@
           <p:cNvPr id="2" name="">
             <a:extLst xmlns:a="http://schemas.openxmlformats.org/drawingml/2006/main">
               <a:ext uri="{FF2B5EF4-FFF2-40B4-BE49-F238E27FC236}">
-                <a16:creationId xmlns:a16="http://schemas.microsoft.com/office/drawing/2014/main" id="{1962E5EF-1B8C-497A-870B-BC3DA74EE160}"/>
+                <a16:creationId xmlns:a16="http://schemas.microsoft.com/office/drawing/2014/main" id="{A92D069E-745B-4D61-B65C-1C4ECD1A39D8}"/>
               </a:ext>
             </a:extLst>
           </p:cNvPr>
@@ -10140,7 +10140,7 @@
           <p:cNvPr id="3" name="">
             <a:extLst xmlns:a="http://schemas.openxmlformats.org/drawingml/2006/main">
               <a:ext uri="{FF2B5EF4-FFF2-40B4-BE49-F238E27FC236}">
-                <a16:creationId xmlns:a16="http://schemas.microsoft.com/office/drawing/2014/main" id="{BFA858E0-B7EE-448C-B2CB-A7E9B360105E}"/>
+                <a16:creationId xmlns:a16="http://schemas.microsoft.com/office/drawing/2014/main" id="{54BD13D2-A4F9-4D9A-884F-982BAE3A8BC3}"/>
               </a:ext>
             </a:extLst>
           </p:cNvPr>
@@ -10198,7 +10198,7 @@
           <p:cNvPr id="4" name="">
             <a:extLst xmlns:a="http://schemas.openxmlformats.org/drawingml/2006/main">
               <a:ext uri="{FF2B5EF4-FFF2-40B4-BE49-F238E27FC236}">
-                <a16:creationId xmlns:a16="http://schemas.microsoft.com/office/drawing/2014/main" id="{B764AEBB-0F64-4CD1-B8E2-FC7152EB00F9}"/>
+                <a16:creationId xmlns:a16="http://schemas.microsoft.com/office/drawing/2014/main" id="{A3A372F0-D575-4616-9133-08D7052D5F75}"/>
               </a:ext>
             </a:extLst>
           </p:cNvPr>
@@ -10231,7 +10231,7 @@
           <p:cNvPr id="5" name="">
             <a:extLst xmlns:a="http://schemas.openxmlformats.org/drawingml/2006/main">
               <a:ext uri="{FF2B5EF4-FFF2-40B4-BE49-F238E27FC236}">
-                <a16:creationId xmlns:a16="http://schemas.microsoft.com/office/drawing/2014/main" id="{77EAC6BE-B3CB-40FD-840A-E6A5A0BB54B3}"/>
+                <a16:creationId xmlns:a16="http://schemas.microsoft.com/office/drawing/2014/main" id="{B4B8005F-B2E7-468A-A28F-449CA4EC8EAD}"/>
               </a:ext>
             </a:extLst>
           </p:cNvPr>
@@ -10264,7 +10264,7 @@
           <p:cNvPr id="6" name="">
             <a:extLst xmlns:a="http://schemas.openxmlformats.org/drawingml/2006/main">
               <a:ext uri="{FF2B5EF4-FFF2-40B4-BE49-F238E27FC236}">
-                <a16:creationId xmlns:a16="http://schemas.microsoft.com/office/drawing/2014/main" id="{10CD15D9-9CE1-4BBE-A6BA-63E312227E30}"/>
+                <a16:creationId xmlns:a16="http://schemas.microsoft.com/office/drawing/2014/main" id="{EE47D12B-30A9-4EEE-BE8B-BA0F8E3D8BCE}"/>
               </a:ext>
             </a:extLst>
           </p:cNvPr>
@@ -10299,7 +10299,7 @@
           <p:cNvPr id="7" name="">
             <a:extLst xmlns:a="http://schemas.openxmlformats.org/drawingml/2006/main">
               <a:ext uri="{FF2B5EF4-FFF2-40B4-BE49-F238E27FC236}">
-                <a16:creationId xmlns:a16="http://schemas.microsoft.com/office/drawing/2014/main" id="{00D985B8-9CB3-4B4D-AB8D-D52CF951ADB9}"/>
+                <a16:creationId xmlns:a16="http://schemas.microsoft.com/office/drawing/2014/main" id="{2D3CC394-85E2-4A33-99E6-B33850AE79A2}"/>
               </a:ext>
             </a:extLst>
           </p:cNvPr>
@@ -10357,7 +10357,7 @@
           <p:cNvPr id="8" name="">
             <a:extLst xmlns:a="http://schemas.openxmlformats.org/drawingml/2006/main">
               <a:ext uri="{FF2B5EF4-FFF2-40B4-BE49-F238E27FC236}">
-                <a16:creationId xmlns:a16="http://schemas.microsoft.com/office/drawing/2014/main" id="{26A53674-FA39-43E1-B0B7-35BA27580A34}"/>
+                <a16:creationId xmlns:a16="http://schemas.microsoft.com/office/drawing/2014/main" id="{A262DEC3-B5E4-4117-B0B1-D8ADF87763F8}"/>
               </a:ext>
             </a:extLst>
           </p:cNvPr>
@@ -10415,7 +10415,7 @@
           <p:cNvPr id="9" name="">
             <a:extLst xmlns:a="http://schemas.openxmlformats.org/drawingml/2006/main">
               <a:ext uri="{FF2B5EF4-FFF2-40B4-BE49-F238E27FC236}">
-                <a16:creationId xmlns:a16="http://schemas.microsoft.com/office/drawing/2014/main" id="{2017BAC3-9EEE-4C8B-A2FD-AC168EEC22FF}"/>
+                <a16:creationId xmlns:a16="http://schemas.microsoft.com/office/drawing/2014/main" id="{4FE45C7D-1D02-477D-8B27-3F656DF1E93F}"/>
               </a:ext>
             </a:extLst>
           </p:cNvPr>
@@ -10473,7 +10473,7 @@
           <p:cNvPr id="10" name="">
             <a:extLst xmlns:a="http://schemas.openxmlformats.org/drawingml/2006/main">
               <a:ext uri="{FF2B5EF4-FFF2-40B4-BE49-F238E27FC236}">
-                <a16:creationId xmlns:a16="http://schemas.microsoft.com/office/drawing/2014/main" id="{354D96B4-2E0A-4E97-B1FA-810A13833D22}"/>
+                <a16:creationId xmlns:a16="http://schemas.microsoft.com/office/drawing/2014/main" id="{8A713BBB-03D0-49FA-8CC9-5F7E7FE2973A}"/>
               </a:ext>
             </a:extLst>
           </p:cNvPr>
@@ -10508,7 +10508,7 @@
           <p:cNvPr id="11" name="">
             <a:extLst xmlns:a="http://schemas.openxmlformats.org/drawingml/2006/main">
               <a:ext uri="{FF2B5EF4-FFF2-40B4-BE49-F238E27FC236}">
-                <a16:creationId xmlns:a16="http://schemas.microsoft.com/office/drawing/2014/main" id="{FD02F3EA-81FB-48E3-8E63-8BD22A5A1858}"/>
+                <a16:creationId xmlns:a16="http://schemas.microsoft.com/office/drawing/2014/main" id="{9BF3F0BE-52DF-43B6-8F28-7DC13D76D0F4}"/>
               </a:ext>
             </a:extLst>
           </p:cNvPr>
@@ -10566,7 +10566,7 @@
           <p:cNvPr id="12" name="">
             <a:extLst xmlns:a="http://schemas.openxmlformats.org/drawingml/2006/main">
               <a:ext uri="{FF2B5EF4-FFF2-40B4-BE49-F238E27FC236}">
-                <a16:creationId xmlns:a16="http://schemas.microsoft.com/office/drawing/2014/main" id="{047D072E-6DF4-42E7-A7B2-1A65C5555AC2}"/>
+                <a16:creationId xmlns:a16="http://schemas.microsoft.com/office/drawing/2014/main" id="{A4607318-2CC4-4ABF-A3B4-4D1565B37437}"/>
               </a:ext>
             </a:extLst>
           </p:cNvPr>
@@ -10624,7 +10624,7 @@
           <p:cNvPr id="13" name="">
             <a:extLst xmlns:a="http://schemas.openxmlformats.org/drawingml/2006/main">
               <a:ext uri="{FF2B5EF4-FFF2-40B4-BE49-F238E27FC236}">
-                <a16:creationId xmlns:a16="http://schemas.microsoft.com/office/drawing/2014/main" id="{91C3CED7-9307-488D-ADBA-6E29D532F0EE}"/>
+                <a16:creationId xmlns:a16="http://schemas.microsoft.com/office/drawing/2014/main" id="{4E35A15A-F6D7-4897-92DD-8F21A5F77D20}"/>
               </a:ext>
             </a:extLst>
           </p:cNvPr>
@@ -10682,7 +10682,7 @@
           <p:cNvPr id="14" name="">
             <a:extLst xmlns:a="http://schemas.openxmlformats.org/drawingml/2006/main">
               <a:ext uri="{FF2B5EF4-FFF2-40B4-BE49-F238E27FC236}">
-                <a16:creationId xmlns:a16="http://schemas.microsoft.com/office/drawing/2014/main" id="{6178FCE1-B847-4487-A332-C56E312BE5E0}"/>
+                <a16:creationId xmlns:a16="http://schemas.microsoft.com/office/drawing/2014/main" id="{B500904C-B371-496B-9006-C40F101233E4}"/>
               </a:ext>
             </a:extLst>
           </p:cNvPr>
@@ -10717,7 +10717,7 @@
           <p:cNvPr id="15" name="">
             <a:extLst xmlns:a="http://schemas.openxmlformats.org/drawingml/2006/main">
               <a:ext uri="{FF2B5EF4-FFF2-40B4-BE49-F238E27FC236}">
-                <a16:creationId xmlns:a16="http://schemas.microsoft.com/office/drawing/2014/main" id="{773AB0D0-12A8-4917-B161-1313CB8AF81E}"/>
+                <a16:creationId xmlns:a16="http://schemas.microsoft.com/office/drawing/2014/main" id="{6BBC5CB6-ACFF-462A-B9DE-D4C6ADD5BB40}"/>
               </a:ext>
             </a:extLst>
           </p:cNvPr>
@@ -10775,7 +10775,7 @@
           <p:cNvPr id="16" name="">
             <a:extLst xmlns:a="http://schemas.openxmlformats.org/drawingml/2006/main">
               <a:ext uri="{FF2B5EF4-FFF2-40B4-BE49-F238E27FC236}">
-                <a16:creationId xmlns:a16="http://schemas.microsoft.com/office/drawing/2014/main" id="{03958C5F-2D6F-416C-97A5-AE9280C3607E}"/>
+                <a16:creationId xmlns:a16="http://schemas.microsoft.com/office/drawing/2014/main" id="{3B0AB455-970E-47C0-BA6D-44BAED59F1FB}"/>
               </a:ext>
             </a:extLst>
           </p:cNvPr>
@@ -10833,7 +10833,7 @@
           <p:cNvPr id="17" name="">
             <a:extLst xmlns:a="http://schemas.openxmlformats.org/drawingml/2006/main">
               <a:ext uri="{FF2B5EF4-FFF2-40B4-BE49-F238E27FC236}">
-                <a16:creationId xmlns:a16="http://schemas.microsoft.com/office/drawing/2014/main" id="{9805E13E-5FC1-41B6-B820-CFDF12E3B88F}"/>
+                <a16:creationId xmlns:a16="http://schemas.microsoft.com/office/drawing/2014/main" id="{09BEE206-FCE9-48D4-BB03-3152F77B7289}"/>
               </a:ext>
             </a:extLst>
           </p:cNvPr>
@@ -10891,7 +10891,7 @@
           <p:cNvPr id="18" name="">
             <a:extLst xmlns:a="http://schemas.openxmlformats.org/drawingml/2006/main">
               <a:ext uri="{FF2B5EF4-FFF2-40B4-BE49-F238E27FC236}">
-                <a16:creationId xmlns:a16="http://schemas.microsoft.com/office/drawing/2014/main" id="{6A1B4470-42FB-4CC4-A73F-44DB907E77DC}"/>
+                <a16:creationId xmlns:a16="http://schemas.microsoft.com/office/drawing/2014/main" id="{EA719CC5-035F-44E5-9A87-0C4D8E6E6CF3}"/>
               </a:ext>
             </a:extLst>
           </p:cNvPr>
@@ -10926,7 +10926,7 @@
           <p:cNvPr id="19" name="">
             <a:extLst xmlns:a="http://schemas.openxmlformats.org/drawingml/2006/main">
               <a:ext uri="{FF2B5EF4-FFF2-40B4-BE49-F238E27FC236}">
-                <a16:creationId xmlns:a16="http://schemas.microsoft.com/office/drawing/2014/main" id="{E44005F8-0F8A-4E66-BB3F-2485C58BB207}"/>
+                <a16:creationId xmlns:a16="http://schemas.microsoft.com/office/drawing/2014/main" id="{BBD1A865-A661-46F3-8F37-041B3AD38D99}"/>
               </a:ext>
             </a:extLst>
           </p:cNvPr>
@@ -10984,7 +10984,7 @@
           <p:cNvPr id="20" name="">
             <a:extLst xmlns:a="http://schemas.openxmlformats.org/drawingml/2006/main">
               <a:ext uri="{FF2B5EF4-FFF2-40B4-BE49-F238E27FC236}">
-                <a16:creationId xmlns:a16="http://schemas.microsoft.com/office/drawing/2014/main" id="{8E701D4B-BEE6-4483-AACE-6FCAC6D697B3}"/>
+                <a16:creationId xmlns:a16="http://schemas.microsoft.com/office/drawing/2014/main" id="{39FB21F0-E3B3-4B07-A9DF-E2F5FE13ED68}"/>
               </a:ext>
             </a:extLst>
           </p:cNvPr>
@@ -11042,7 +11042,7 @@
           <p:cNvPr id="21" name="">
             <a:extLst xmlns:a="http://schemas.openxmlformats.org/drawingml/2006/main">
               <a:ext uri="{FF2B5EF4-FFF2-40B4-BE49-F238E27FC236}">
-                <a16:creationId xmlns:a16="http://schemas.microsoft.com/office/drawing/2014/main" id="{F1F814EA-E8C1-44CB-84E7-DB07CD68C39A}"/>
+                <a16:creationId xmlns:a16="http://schemas.microsoft.com/office/drawing/2014/main" id="{A1C3474E-7CF0-4172-9C7A-20269E33F4E6}"/>
               </a:ext>
             </a:extLst>
           </p:cNvPr>
@@ -11100,7 +11100,7 @@
           <p:cNvPr id="22" name="">
             <a:extLst xmlns:a="http://schemas.openxmlformats.org/drawingml/2006/main">
               <a:ext uri="{FF2B5EF4-FFF2-40B4-BE49-F238E27FC236}">
-                <a16:creationId xmlns:a16="http://schemas.microsoft.com/office/drawing/2014/main" id="{0FC4559D-FA58-4AAA-BCA0-F635C62E7941}"/>
+                <a16:creationId xmlns:a16="http://schemas.microsoft.com/office/drawing/2014/main" id="{B58D6CD1-F393-4A8D-B3EC-32A61D1E565E}"/>
               </a:ext>
             </a:extLst>
           </p:cNvPr>
@@ -11135,7 +11135,7 @@
           <p:cNvPr id="23" name="">
             <a:extLst xmlns:a="http://schemas.openxmlformats.org/drawingml/2006/main">
               <a:ext uri="{FF2B5EF4-FFF2-40B4-BE49-F238E27FC236}">
-                <a16:creationId xmlns:a16="http://schemas.microsoft.com/office/drawing/2014/main" id="{70B8634F-673D-4573-BC8D-A5F435E98975}"/>
+                <a16:creationId xmlns:a16="http://schemas.microsoft.com/office/drawing/2014/main" id="{A116F8C1-8C52-4C95-AD7C-627B0EE6A855}"/>
               </a:ext>
             </a:extLst>
           </p:cNvPr>
@@ -11193,7 +11193,7 @@
           <p:cNvPr id="24" name="">
             <a:extLst xmlns:a="http://schemas.openxmlformats.org/drawingml/2006/main">
               <a:ext uri="{FF2B5EF4-FFF2-40B4-BE49-F238E27FC236}">
-                <a16:creationId xmlns:a16="http://schemas.microsoft.com/office/drawing/2014/main" id="{49327E1A-2ED2-418A-9611-EA047A086598}"/>
+                <a16:creationId xmlns:a16="http://schemas.microsoft.com/office/drawing/2014/main" id="{2CBCF7D6-38DF-4C95-86ED-9284507D89A6}"/>
               </a:ext>
             </a:extLst>
           </p:cNvPr>
@@ -11241,7 +11241,7 @@
                 <a:ea typeface="Aptos"/>
                 <a:cs typeface="Aptos"/>
               </a:rPr>
-              <a:t>WATERS NEXT GEN COMPETITIVE INTELLIGENCE · 02 AUG 2026 · waters-ci-20260802160152</a:t>
+              <a:t>WATERS NEXT GEN COMPETITIVE INTELLIGENCE · 13 AUG 2026 · waters-ci-20260813070817</a:t>
             </a:r>
           </a:p>
         </p:txBody>
@@ -11251,7 +11251,7 @@
           <p:cNvPr id="25" name="">
             <a:extLst xmlns:a="http://schemas.openxmlformats.org/drawingml/2006/main">
               <a:ext uri="{FF2B5EF4-FFF2-40B4-BE49-F238E27FC236}">
-                <a16:creationId xmlns:a16="http://schemas.microsoft.com/office/drawing/2014/main" id="{856F5094-9442-47B5-84D4-C1ECDFBD8DD6}"/>
+                <a16:creationId xmlns:a16="http://schemas.microsoft.com/office/drawing/2014/main" id="{377678F5-E563-4E40-BB88-AFFEC3B9FDC6}"/>
               </a:ext>
             </a:extLst>
           </p:cNvPr>
@@ -11307,7 +11307,7 @@
     </p:spTree>
     <p:extLst>
       <p:ext uri="{BB962C8B-B14F-4D97-AF65-F5344CB8AC3E}">
-        <p14:creationId xmlns:p14="http://schemas.microsoft.com/office/powerpoint/2010/main" val="1700816217"/>
+        <p14:creationId xmlns:p14="http://schemas.microsoft.com/office/powerpoint/2010/main" val="1263370584"/>
       </p:ext>
     </p:extLst>
   </p:cSld>
@@ -11338,7 +11338,7 @@
           <p:cNvPr id="38" name="">
             <a:extLst xmlns:a="http://schemas.openxmlformats.org/drawingml/2006/main">
               <a:ext uri="{FF2B5EF4-FFF2-40B4-BE49-F238E27FC236}">
-                <a16:creationId xmlns:a16="http://schemas.microsoft.com/office/drawing/2014/main" id="{FF8E209E-837C-42DA-814C-7026FA19AFCC}"/>
+                <a16:creationId xmlns:a16="http://schemas.microsoft.com/office/drawing/2014/main" id="{A7D0040D-16E2-414B-B809-D74C29796C3E}"/>
               </a:ext>
             </a:extLst>
           </p:cNvPr>
@@ -11396,7 +11396,7 @@
           <p:cNvPr id="2" name="">
             <a:extLst xmlns:a="http://schemas.openxmlformats.org/drawingml/2006/main">
               <a:ext uri="{FF2B5EF4-FFF2-40B4-BE49-F238E27FC236}">
-                <a16:creationId xmlns:a16="http://schemas.microsoft.com/office/drawing/2014/main" id="{062AABDD-8C12-4FF9-9B03-36AB775F3467}"/>
+                <a16:creationId xmlns:a16="http://schemas.microsoft.com/office/drawing/2014/main" id="{A083B339-E8F7-44EA-A758-5A0913E31C61}"/>
               </a:ext>
             </a:extLst>
           </p:cNvPr>
@@ -11454,7 +11454,7 @@
           <p:cNvPr id="3" name="">
             <a:extLst xmlns:a="http://schemas.openxmlformats.org/drawingml/2006/main">
               <a:ext uri="{FF2B5EF4-FFF2-40B4-BE49-F238E27FC236}">
-                <a16:creationId xmlns:a16="http://schemas.microsoft.com/office/drawing/2014/main" id="{054301A6-ED84-411E-89BA-DEF390C6725E}"/>
+                <a16:creationId xmlns:a16="http://schemas.microsoft.com/office/drawing/2014/main" id="{08CF3CDE-CB5C-4DA1-BBCB-B8A1BC6476C5}"/>
               </a:ext>
             </a:extLst>
           </p:cNvPr>
@@ -11512,7 +11512,7 @@
           <p:cNvPr id="4" name="">
             <a:extLst xmlns:a="http://schemas.openxmlformats.org/drawingml/2006/main">
               <a:ext uri="{FF2B5EF4-FFF2-40B4-BE49-F238E27FC236}">
-                <a16:creationId xmlns:a16="http://schemas.microsoft.com/office/drawing/2014/main" id="{3B04824F-283F-43C9-B7C8-74550AC99DEE}"/>
+                <a16:creationId xmlns:a16="http://schemas.microsoft.com/office/drawing/2014/main" id="{341775EA-5363-442B-95D8-448EB54D682C}"/>
               </a:ext>
             </a:extLst>
           </p:cNvPr>
@@ -11545,7 +11545,7 @@
           <p:cNvPr id="5" name="">
             <a:extLst xmlns:a="http://schemas.openxmlformats.org/drawingml/2006/main">
               <a:ext uri="{FF2B5EF4-FFF2-40B4-BE49-F238E27FC236}">
-                <a16:creationId xmlns:a16="http://schemas.microsoft.com/office/drawing/2014/main" id="{06D3927F-0E25-4D61-A7FE-F2FDCBA4200C}"/>
+                <a16:creationId xmlns:a16="http://schemas.microsoft.com/office/drawing/2014/main" id="{3BB5569E-886F-42D2-B734-9D8D979F3856}"/>
               </a:ext>
             </a:extLst>
           </p:cNvPr>
@@ -11603,7 +11603,7 @@
           <p:cNvPr id="6" name="">
             <a:extLst xmlns:a="http://schemas.openxmlformats.org/drawingml/2006/main">
               <a:ext uri="{FF2B5EF4-FFF2-40B4-BE49-F238E27FC236}">
-                <a16:creationId xmlns:a16="http://schemas.microsoft.com/office/drawing/2014/main" id="{BA6BA819-5408-41E9-8029-ED9955807242}"/>
+                <a16:creationId xmlns:a16="http://schemas.microsoft.com/office/drawing/2014/main" id="{54FC7C4C-46D9-4299-ABF6-4AEA24B32767}"/>
               </a:ext>
             </a:extLst>
           </p:cNvPr>
@@ -11661,7 +11661,7 @@
           <p:cNvPr id="7" name="">
             <a:extLst xmlns:a="http://schemas.openxmlformats.org/drawingml/2006/main">
               <a:ext uri="{FF2B5EF4-FFF2-40B4-BE49-F238E27FC236}">
-                <a16:creationId xmlns:a16="http://schemas.microsoft.com/office/drawing/2014/main" id="{58056BF4-DFB9-418F-BB31-A1E8559CFBA4}"/>
+                <a16:creationId xmlns:a16="http://schemas.microsoft.com/office/drawing/2014/main" id="{BACD637D-EB59-467D-BAC2-85A041A49EAF}"/>
               </a:ext>
             </a:extLst>
           </p:cNvPr>
@@ -11717,10 +11717,10 @@
       <p:sp>
         <p:nvSpPr>
           <p:cNvPr id="8" name="">
-            <a:hlinkClick xmlns:r="http://schemas.openxmlformats.org/officeDocument/2006/relationships" xmlns:a="http://schemas.openxmlformats.org/drawingml/2006/main" r:id="R7d26182d7fb24b82"/>
-            <a:extLst xmlns:a="http://schemas.openxmlformats.org/drawingml/2006/main">
-              <a:ext uri="{FF2B5EF4-FFF2-40B4-BE49-F238E27FC236}">
-                <a16:creationId xmlns:a16="http://schemas.microsoft.com/office/drawing/2014/main" id="{9164EF1D-0AAE-415F-ACA6-DBFE90C89E95}"/>
+            <a:hlinkClick xmlns:r="http://schemas.openxmlformats.org/officeDocument/2006/relationships" xmlns:a="http://schemas.openxmlformats.org/drawingml/2006/main" r:id="Red9b1478fb1b485e"/>
+            <a:extLst xmlns:a="http://schemas.openxmlformats.org/drawingml/2006/main">
+              <a:ext uri="{FF2B5EF4-FFF2-40B4-BE49-F238E27FC236}">
+                <a16:creationId xmlns:a16="http://schemas.microsoft.com/office/drawing/2014/main" id="{FC685DDE-6FFE-4C19-BB2E-E2D318C966C3}"/>
               </a:ext>
             </a:extLst>
           </p:cNvPr>
@@ -11768,7 +11768,7 @@
                 <a:ea typeface="Aptos"/>
                 <a:cs typeface="Aptos"/>
               </a:rPr>
-              <a:t>https://pubmed.ncbi.nlm.nih.gov/?term=%28%28PFAS+OR+%22per-+and+polyfluoroalkyl%22%29+AND+%28%22LC-MS%22+OR+%22LC-MS%2FMS%22+OR+chromatography%29%29+AND+%28%222025%2F08%2F02%22%5BDate+-+Publication%5D+%3A+%222026%2F08%2F02%22%5BDate+-+Publication%5D%29</a:t>
+              <a:t>https://pubmed.ncbi.nlm.nih.gov/?term=%28%28PFAS+OR+%22per-+and+polyfluoroalkyl%22%29+AND+%28%22LC-MS%22+OR+%22LC-MS%2FMS%22+OR+chromatography%29%29+AND+%28%222025%2F08%2F13%22%5BDate+-+Publication%5D+%3A+%222026%2F08%2F13%22%5BDate+-+Publication%5D%29</a:t>
             </a:r>
           </a:p>
         </p:txBody>
@@ -11778,7 +11778,7 @@
           <p:cNvPr id="9" name="">
             <a:extLst xmlns:a="http://schemas.openxmlformats.org/drawingml/2006/main">
               <a:ext uri="{FF2B5EF4-FFF2-40B4-BE49-F238E27FC236}">
-                <a16:creationId xmlns:a16="http://schemas.microsoft.com/office/drawing/2014/main" id="{A0C37E5A-AFA8-47CF-BF2D-4AA50CFDF6B1}"/>
+                <a16:creationId xmlns:a16="http://schemas.microsoft.com/office/drawing/2014/main" id="{35FF3872-34F8-4D44-82B9-546A4F9F06C7}"/>
               </a:ext>
             </a:extLst>
           </p:cNvPr>
@@ -11811,7 +11811,7 @@
           <p:cNvPr id="10" name="">
             <a:extLst xmlns:a="http://schemas.openxmlformats.org/drawingml/2006/main">
               <a:ext uri="{FF2B5EF4-FFF2-40B4-BE49-F238E27FC236}">
-                <a16:creationId xmlns:a16="http://schemas.microsoft.com/office/drawing/2014/main" id="{5EFD4470-DE87-47D7-A6BE-81F58C070D78}"/>
+                <a16:creationId xmlns:a16="http://schemas.microsoft.com/office/drawing/2014/main" id="{83BCD9EA-18D7-4729-B3CD-9A8BEAC8A099}"/>
               </a:ext>
             </a:extLst>
           </p:cNvPr>
@@ -11869,7 +11869,7 @@
           <p:cNvPr id="11" name="">
             <a:extLst xmlns:a="http://schemas.openxmlformats.org/drawingml/2006/main">
               <a:ext uri="{FF2B5EF4-FFF2-40B4-BE49-F238E27FC236}">
-                <a16:creationId xmlns:a16="http://schemas.microsoft.com/office/drawing/2014/main" id="{2E0B7C49-D24C-4051-8E59-001725B627D5}"/>
+                <a16:creationId xmlns:a16="http://schemas.microsoft.com/office/drawing/2014/main" id="{4C034143-C366-4D60-A884-DDB5E7249662}"/>
               </a:ext>
             </a:extLst>
           </p:cNvPr>
@@ -11927,7 +11927,7 @@
           <p:cNvPr id="12" name="">
             <a:extLst xmlns:a="http://schemas.openxmlformats.org/drawingml/2006/main">
               <a:ext uri="{FF2B5EF4-FFF2-40B4-BE49-F238E27FC236}">
-                <a16:creationId xmlns:a16="http://schemas.microsoft.com/office/drawing/2014/main" id="{300CD4DF-5C12-447F-9F9B-266B045D6905}"/>
+                <a16:creationId xmlns:a16="http://schemas.microsoft.com/office/drawing/2014/main" id="{78966395-28F2-4E63-A675-6865D038C830}"/>
               </a:ext>
             </a:extLst>
           </p:cNvPr>
@@ -11983,10 +11983,10 @@
       <p:sp>
         <p:nvSpPr>
           <p:cNvPr id="13" name="">
-            <a:hlinkClick xmlns:r="http://schemas.openxmlformats.org/officeDocument/2006/relationships" xmlns:a="http://schemas.openxmlformats.org/drawingml/2006/main" r:id="R2aa1c9e9d6c743c6"/>
-            <a:extLst xmlns:a="http://schemas.openxmlformats.org/drawingml/2006/main">
-              <a:ext uri="{FF2B5EF4-FFF2-40B4-BE49-F238E27FC236}">
-                <a16:creationId xmlns:a16="http://schemas.microsoft.com/office/drawing/2014/main" id="{AA77A6F3-8A6F-4CD8-B82F-D4E5681B1482}"/>
+            <a:hlinkClick xmlns:r="http://schemas.openxmlformats.org/officeDocument/2006/relationships" xmlns:a="http://schemas.openxmlformats.org/drawingml/2006/main" r:id="R0a9e04737bfb4d9c"/>
+            <a:extLst xmlns:a="http://schemas.openxmlformats.org/drawingml/2006/main">
+              <a:ext uri="{FF2B5EF4-FFF2-40B4-BE49-F238E27FC236}">
+                <a16:creationId xmlns:a16="http://schemas.microsoft.com/office/drawing/2014/main" id="{08DDEFA5-DB41-4FB0-B46F-BB5D2F424A8D}"/>
               </a:ext>
             </a:extLst>
           </p:cNvPr>
@@ -12044,7 +12044,7 @@
           <p:cNvPr id="14" name="">
             <a:extLst xmlns:a="http://schemas.openxmlformats.org/drawingml/2006/main">
               <a:ext uri="{FF2B5EF4-FFF2-40B4-BE49-F238E27FC236}">
-                <a16:creationId xmlns:a16="http://schemas.microsoft.com/office/drawing/2014/main" id="{04548C81-7F09-454C-9F35-B90BF1B1BA9B}"/>
+                <a16:creationId xmlns:a16="http://schemas.microsoft.com/office/drawing/2014/main" id="{2A922C17-DCA1-4B3B-BFBB-9665AC140D1D}"/>
               </a:ext>
             </a:extLst>
           </p:cNvPr>
@@ -12077,7 +12077,7 @@
           <p:cNvPr id="15" name="">
             <a:extLst xmlns:a="http://schemas.openxmlformats.org/drawingml/2006/main">
               <a:ext uri="{FF2B5EF4-FFF2-40B4-BE49-F238E27FC236}">
-                <a16:creationId xmlns:a16="http://schemas.microsoft.com/office/drawing/2014/main" id="{24E08145-C43A-45CB-842B-464535D4462E}"/>
+                <a16:creationId xmlns:a16="http://schemas.microsoft.com/office/drawing/2014/main" id="{5D250DB1-1F4A-4C31-996E-145BFEF43AE8}"/>
               </a:ext>
             </a:extLst>
           </p:cNvPr>
@@ -12135,7 +12135,7 @@
           <p:cNvPr id="16" name="">
             <a:extLst xmlns:a="http://schemas.openxmlformats.org/drawingml/2006/main">
               <a:ext uri="{FF2B5EF4-FFF2-40B4-BE49-F238E27FC236}">
-                <a16:creationId xmlns:a16="http://schemas.microsoft.com/office/drawing/2014/main" id="{F7DBB9C5-A595-4204-A55B-2D39C32BF9A3}"/>
+                <a16:creationId xmlns:a16="http://schemas.microsoft.com/office/drawing/2014/main" id="{72D4F003-9B66-48C6-AD69-7ACCD3FBFF89}"/>
               </a:ext>
             </a:extLst>
           </p:cNvPr>
@@ -12193,7 +12193,7 @@
           <p:cNvPr id="17" name="">
             <a:extLst xmlns:a="http://schemas.openxmlformats.org/drawingml/2006/main">
               <a:ext uri="{FF2B5EF4-FFF2-40B4-BE49-F238E27FC236}">
-                <a16:creationId xmlns:a16="http://schemas.microsoft.com/office/drawing/2014/main" id="{A2F4F595-1799-4FC4-84A7-935D2D10D9F1}"/>
+                <a16:creationId xmlns:a16="http://schemas.microsoft.com/office/drawing/2014/main" id="{2BC520CE-872E-432F-BCA6-C04F095844AA}"/>
               </a:ext>
             </a:extLst>
           </p:cNvPr>
@@ -12249,10 +12249,10 @@
       <p:sp>
         <p:nvSpPr>
           <p:cNvPr id="18" name="">
-            <a:hlinkClick xmlns:r="http://schemas.openxmlformats.org/officeDocument/2006/relationships" xmlns:a="http://schemas.openxmlformats.org/drawingml/2006/main" r:id="R63f0abd5968b4174"/>
-            <a:extLst xmlns:a="http://schemas.openxmlformats.org/drawingml/2006/main">
-              <a:ext uri="{FF2B5EF4-FFF2-40B4-BE49-F238E27FC236}">
-                <a16:creationId xmlns:a16="http://schemas.microsoft.com/office/drawing/2014/main" id="{79D217F7-975B-4AA7-ACD3-404CD02C9E3C}"/>
+            <a:hlinkClick xmlns:r="http://schemas.openxmlformats.org/officeDocument/2006/relationships" xmlns:a="http://schemas.openxmlformats.org/drawingml/2006/main" r:id="R096cb83171b34616"/>
+            <a:extLst xmlns:a="http://schemas.openxmlformats.org/drawingml/2006/main">
+              <a:ext uri="{FF2B5EF4-FFF2-40B4-BE49-F238E27FC236}">
+                <a16:creationId xmlns:a16="http://schemas.microsoft.com/office/drawing/2014/main" id="{C6F19FE4-285E-42B1-87E4-BBFCA9EC9B7F}"/>
               </a:ext>
             </a:extLst>
           </p:cNvPr>
@@ -12310,7 +12310,7 @@
           <p:cNvPr id="19" name="">
             <a:extLst xmlns:a="http://schemas.openxmlformats.org/drawingml/2006/main">
               <a:ext uri="{FF2B5EF4-FFF2-40B4-BE49-F238E27FC236}">
-                <a16:creationId xmlns:a16="http://schemas.microsoft.com/office/drawing/2014/main" id="{4FFE03DC-84C4-4881-A1A3-91A764C8D67D}"/>
+                <a16:creationId xmlns:a16="http://schemas.microsoft.com/office/drawing/2014/main" id="{A4E29824-4C83-4314-AD1F-B12F985C81E5}"/>
               </a:ext>
             </a:extLst>
           </p:cNvPr>
@@ -12343,7 +12343,7 @@
           <p:cNvPr id="20" name="">
             <a:extLst xmlns:a="http://schemas.openxmlformats.org/drawingml/2006/main">
               <a:ext uri="{FF2B5EF4-FFF2-40B4-BE49-F238E27FC236}">
-                <a16:creationId xmlns:a16="http://schemas.microsoft.com/office/drawing/2014/main" id="{FA628E1F-79F0-473A-9435-2EB9D5E7F57B}"/>
+                <a16:creationId xmlns:a16="http://schemas.microsoft.com/office/drawing/2014/main" id="{76D6CA4A-B9FB-4A8B-8BF5-46F02E2481B0}"/>
               </a:ext>
             </a:extLst>
           </p:cNvPr>
@@ -12401,7 +12401,7 @@
           <p:cNvPr id="21" name="">
             <a:extLst xmlns:a="http://schemas.openxmlformats.org/drawingml/2006/main">
               <a:ext uri="{FF2B5EF4-FFF2-40B4-BE49-F238E27FC236}">
-                <a16:creationId xmlns:a16="http://schemas.microsoft.com/office/drawing/2014/main" id="{6C9557B7-4E6E-4692-AC6F-A6DFC507E0CB}"/>
+                <a16:creationId xmlns:a16="http://schemas.microsoft.com/office/drawing/2014/main" id="{9F7C72ED-ABBB-4CBB-8E53-4535966897FD}"/>
               </a:ext>
             </a:extLst>
           </p:cNvPr>
@@ -12459,7 +12459,7 @@
           <p:cNvPr id="22" name="">
             <a:extLst xmlns:a="http://schemas.openxmlformats.org/drawingml/2006/main">
               <a:ext uri="{FF2B5EF4-FFF2-40B4-BE49-F238E27FC236}">
-                <a16:creationId xmlns:a16="http://schemas.microsoft.com/office/drawing/2014/main" id="{F746CE04-B735-4561-B6C4-C7F1A3549BF1}"/>
+                <a16:creationId xmlns:a16="http://schemas.microsoft.com/office/drawing/2014/main" id="{88C37170-FFEB-499F-910D-B7A6FF151E76}"/>
               </a:ext>
             </a:extLst>
           </p:cNvPr>
@@ -12515,10 +12515,10 @@
       <p:sp>
         <p:nvSpPr>
           <p:cNvPr id="23" name="">
-            <a:hlinkClick xmlns:r="http://schemas.openxmlformats.org/officeDocument/2006/relationships" xmlns:a="http://schemas.openxmlformats.org/drawingml/2006/main" r:id="R6a2e00cef6ad4a02"/>
-            <a:extLst xmlns:a="http://schemas.openxmlformats.org/drawingml/2006/main">
-              <a:ext uri="{FF2B5EF4-FFF2-40B4-BE49-F238E27FC236}">
-                <a16:creationId xmlns:a16="http://schemas.microsoft.com/office/drawing/2014/main" id="{6E2AD361-65D8-4D50-9661-1A53BD0F6A86}"/>
+            <a:hlinkClick xmlns:r="http://schemas.openxmlformats.org/officeDocument/2006/relationships" xmlns:a="http://schemas.openxmlformats.org/drawingml/2006/main" r:id="Rf7328ad13df04350"/>
+            <a:extLst xmlns:a="http://schemas.openxmlformats.org/drawingml/2006/main">
+              <a:ext uri="{FF2B5EF4-FFF2-40B4-BE49-F238E27FC236}">
+                <a16:creationId xmlns:a16="http://schemas.microsoft.com/office/drawing/2014/main" id="{C7839549-6FE1-4D09-8350-5DBDAFC231A1}"/>
               </a:ext>
             </a:extLst>
           </p:cNvPr>
@@ -12576,7 +12576,7 @@
           <p:cNvPr id="24" name="">
             <a:extLst xmlns:a="http://schemas.openxmlformats.org/drawingml/2006/main">
               <a:ext uri="{FF2B5EF4-FFF2-40B4-BE49-F238E27FC236}">
-                <a16:creationId xmlns:a16="http://schemas.microsoft.com/office/drawing/2014/main" id="{03BAC93C-9346-49BE-A4DA-87A187CC40D0}"/>
+                <a16:creationId xmlns:a16="http://schemas.microsoft.com/office/drawing/2014/main" id="{FC1E90A3-50A2-4898-9424-DA602DBDDE1F}"/>
               </a:ext>
             </a:extLst>
           </p:cNvPr>
@@ -12609,7 +12609,7 @@
           <p:cNvPr id="25" name="">
             <a:extLst xmlns:a="http://schemas.openxmlformats.org/drawingml/2006/main">
               <a:ext uri="{FF2B5EF4-FFF2-40B4-BE49-F238E27FC236}">
-                <a16:creationId xmlns:a16="http://schemas.microsoft.com/office/drawing/2014/main" id="{629E3BCE-B785-4362-85ED-08C215B5BE5A}"/>
+                <a16:creationId xmlns:a16="http://schemas.microsoft.com/office/drawing/2014/main" id="{18F5A1C4-568D-4A45-AAB8-EEE1FE78553E}"/>
               </a:ext>
             </a:extLst>
           </p:cNvPr>
@@ -12667,7 +12667,7 @@
           <p:cNvPr id="26" name="">
             <a:extLst xmlns:a="http://schemas.openxmlformats.org/drawingml/2006/main">
               <a:ext uri="{FF2B5EF4-FFF2-40B4-BE49-F238E27FC236}">
-                <a16:creationId xmlns:a16="http://schemas.microsoft.com/office/drawing/2014/main" id="{9AAD56D1-B787-427F-9AE8-1FAF8F1F89C3}"/>
+                <a16:creationId xmlns:a16="http://schemas.microsoft.com/office/drawing/2014/main" id="{0CA1D05E-B648-498C-8E73-968DDC02D43A}"/>
               </a:ext>
             </a:extLst>
           </p:cNvPr>
@@ -12725,7 +12725,7 @@
           <p:cNvPr id="27" name="">
             <a:extLst xmlns:a="http://schemas.openxmlformats.org/drawingml/2006/main">
               <a:ext uri="{FF2B5EF4-FFF2-40B4-BE49-F238E27FC236}">
-                <a16:creationId xmlns:a16="http://schemas.microsoft.com/office/drawing/2014/main" id="{E74D43E9-8304-47A8-9C66-42B37B0CAFF8}"/>
+                <a16:creationId xmlns:a16="http://schemas.microsoft.com/office/drawing/2014/main" id="{CD9F0641-50E6-4D8E-97AF-6A2B5C6CFE1C}"/>
               </a:ext>
             </a:extLst>
           </p:cNvPr>
@@ -12781,10 +12781,10 @@
       <p:sp>
         <p:nvSpPr>
           <p:cNvPr id="28" name="">
-            <a:hlinkClick xmlns:r="http://schemas.openxmlformats.org/officeDocument/2006/relationships" xmlns:a="http://schemas.openxmlformats.org/drawingml/2006/main" r:id="R0dc18a94407e4373"/>
-            <a:extLst xmlns:a="http://schemas.openxmlformats.org/drawingml/2006/main">
-              <a:ext uri="{FF2B5EF4-FFF2-40B4-BE49-F238E27FC236}">
-                <a16:creationId xmlns:a16="http://schemas.microsoft.com/office/drawing/2014/main" id="{CCFA0FDE-7229-4921-8039-F0E60F3F9137}"/>
+            <a:hlinkClick xmlns:r="http://schemas.openxmlformats.org/officeDocument/2006/relationships" xmlns:a="http://schemas.openxmlformats.org/drawingml/2006/main" r:id="Rec13bdbc53604572"/>
+            <a:extLst xmlns:a="http://schemas.openxmlformats.org/drawingml/2006/main">
+              <a:ext uri="{FF2B5EF4-FFF2-40B4-BE49-F238E27FC236}">
+                <a16:creationId xmlns:a16="http://schemas.microsoft.com/office/drawing/2014/main" id="{1FDD1E8D-055D-4576-9F69-AA3124185580}"/>
               </a:ext>
             </a:extLst>
           </p:cNvPr>
@@ -12842,7 +12842,7 @@
           <p:cNvPr id="29" name="">
             <a:extLst xmlns:a="http://schemas.openxmlformats.org/drawingml/2006/main">
               <a:ext uri="{FF2B5EF4-FFF2-40B4-BE49-F238E27FC236}">
-                <a16:creationId xmlns:a16="http://schemas.microsoft.com/office/drawing/2014/main" id="{E3CB0FEC-5614-47A4-9B2E-4B35EB7C4B83}"/>
+                <a16:creationId xmlns:a16="http://schemas.microsoft.com/office/drawing/2014/main" id="{8CD05A75-CB74-4407-9C76-56768C5BAED4}"/>
               </a:ext>
             </a:extLst>
           </p:cNvPr>
@@ -12875,7 +12875,7 @@
           <p:cNvPr id="30" name="">
             <a:extLst xmlns:a="http://schemas.openxmlformats.org/drawingml/2006/main">
               <a:ext uri="{FF2B5EF4-FFF2-40B4-BE49-F238E27FC236}">
-                <a16:creationId xmlns:a16="http://schemas.microsoft.com/office/drawing/2014/main" id="{A71D5C67-7893-4896-B3D1-BECDD486AF9D}"/>
+                <a16:creationId xmlns:a16="http://schemas.microsoft.com/office/drawing/2014/main" id="{306A5E26-A0F7-4D49-B488-8D640AB59151}"/>
               </a:ext>
             </a:extLst>
           </p:cNvPr>
@@ -12933,7 +12933,7 @@
           <p:cNvPr id="31" name="">
             <a:extLst xmlns:a="http://schemas.openxmlformats.org/drawingml/2006/main">
               <a:ext uri="{FF2B5EF4-FFF2-40B4-BE49-F238E27FC236}">
-                <a16:creationId xmlns:a16="http://schemas.microsoft.com/office/drawing/2014/main" id="{75747AF1-23DA-4B2D-9CE5-045A2B1DE9FC}"/>
+                <a16:creationId xmlns:a16="http://schemas.microsoft.com/office/drawing/2014/main" id="{96B7439A-E86C-4FF1-99C9-C7EAB833A897}"/>
               </a:ext>
             </a:extLst>
           </p:cNvPr>
@@ -12991,7 +12991,7 @@
           <p:cNvPr id="32" name="">
             <a:extLst xmlns:a="http://schemas.openxmlformats.org/drawingml/2006/main">
               <a:ext uri="{FF2B5EF4-FFF2-40B4-BE49-F238E27FC236}">
-                <a16:creationId xmlns:a16="http://schemas.microsoft.com/office/drawing/2014/main" id="{7530C0B5-4EE8-420B-B068-1AAF6F857F78}"/>
+                <a16:creationId xmlns:a16="http://schemas.microsoft.com/office/drawing/2014/main" id="{62D44E11-D7E9-4CF0-B41F-103288582632}"/>
               </a:ext>
             </a:extLst>
           </p:cNvPr>
@@ -13047,10 +13047,10 @@
       <p:sp>
         <p:nvSpPr>
           <p:cNvPr id="33" name="">
-            <a:hlinkClick xmlns:r="http://schemas.openxmlformats.org/officeDocument/2006/relationships" xmlns:a="http://schemas.openxmlformats.org/drawingml/2006/main" r:id="Rfd5cf979efdf4df0"/>
-            <a:extLst xmlns:a="http://schemas.openxmlformats.org/drawingml/2006/main">
-              <a:ext uri="{FF2B5EF4-FFF2-40B4-BE49-F238E27FC236}">
-                <a16:creationId xmlns:a16="http://schemas.microsoft.com/office/drawing/2014/main" id="{49EC9775-7B76-47D4-9E18-9EB62E952A45}"/>
+            <a:hlinkClick xmlns:r="http://schemas.openxmlformats.org/officeDocument/2006/relationships" xmlns:a="http://schemas.openxmlformats.org/drawingml/2006/main" r:id="R6159171908fe4e0d"/>
+            <a:extLst xmlns:a="http://schemas.openxmlformats.org/drawingml/2006/main">
+              <a:ext uri="{FF2B5EF4-FFF2-40B4-BE49-F238E27FC236}">
+                <a16:creationId xmlns:a16="http://schemas.microsoft.com/office/drawing/2014/main" id="{4838532F-4BF1-4016-92C2-65EA17BE32CD}"/>
               </a:ext>
             </a:extLst>
           </p:cNvPr>
@@ -13108,7 +13108,7 @@
           <p:cNvPr id="34" name="">
             <a:extLst xmlns:a="http://schemas.openxmlformats.org/drawingml/2006/main">
               <a:ext uri="{FF2B5EF4-FFF2-40B4-BE49-F238E27FC236}">
-                <a16:creationId xmlns:a16="http://schemas.microsoft.com/office/drawing/2014/main" id="{AD40B252-A533-4806-A779-C33ACD9FC7B4}"/>
+                <a16:creationId xmlns:a16="http://schemas.microsoft.com/office/drawing/2014/main" id="{C43542C2-24CF-4BFE-9A35-ED57D7C7CDF0}"/>
               </a:ext>
             </a:extLst>
           </p:cNvPr>
@@ -13143,7 +13143,7 @@
           <p:cNvPr id="35" name="">
             <a:extLst xmlns:a="http://schemas.openxmlformats.org/drawingml/2006/main">
               <a:ext uri="{FF2B5EF4-FFF2-40B4-BE49-F238E27FC236}">
-                <a16:creationId xmlns:a16="http://schemas.microsoft.com/office/drawing/2014/main" id="{2C9CB388-CCB6-47E8-922B-0241F1E32FD7}"/>
+                <a16:creationId xmlns:a16="http://schemas.microsoft.com/office/drawing/2014/main" id="{B101A231-C197-4740-8DD3-5C918E2B2940}"/>
               </a:ext>
             </a:extLst>
           </p:cNvPr>
@@ -13191,7 +13191,7 @@
                 <a:ea typeface="Aptos"/>
                 <a:cs typeface="Aptos"/>
               </a:rPr>
-              <a:t>Snapshot: waters-ci-20260802160152 · As of 2026-08-02T16:01:52 · Business magnitude requires Waters internal data.</a:t>
+              <a:t>Snapshot: waters-ci-20260813070817 · As of 2026-08-13T07:08:17 · Business magnitude requires Waters internal data.</a:t>
             </a:r>
           </a:p>
         </p:txBody>
@@ -13201,7 +13201,7 @@
           <p:cNvPr id="36" name="">
             <a:extLst xmlns:a="http://schemas.openxmlformats.org/drawingml/2006/main">
               <a:ext uri="{FF2B5EF4-FFF2-40B4-BE49-F238E27FC236}">
-                <a16:creationId xmlns:a16="http://schemas.microsoft.com/office/drawing/2014/main" id="{7687D5AC-31F6-42F4-AEE8-4F830F6347DD}"/>
+                <a16:creationId xmlns:a16="http://schemas.microsoft.com/office/drawing/2014/main" id="{911CBF6B-60C5-4E99-938C-56F72DB24693}"/>
               </a:ext>
             </a:extLst>
           </p:cNvPr>
@@ -13249,7 +13249,7 @@
                 <a:ea typeface="Aptos"/>
                 <a:cs typeface="Aptos"/>
               </a:rPr>
-              <a:t>WATERS NEXT GEN COMPETITIVE INTELLIGENCE · 02 AUG 2026 · waters-ci-20260802160152</a:t>
+              <a:t>WATERS NEXT GEN COMPETITIVE INTELLIGENCE · 13 AUG 2026 · waters-ci-20260813070817</a:t>
             </a:r>
           </a:p>
         </p:txBody>
@@ -13259,7 +13259,7 @@
           <p:cNvPr id="37" name="">
             <a:extLst xmlns:a="http://schemas.openxmlformats.org/drawingml/2006/main">
               <a:ext uri="{FF2B5EF4-FFF2-40B4-BE49-F238E27FC236}">
-                <a16:creationId xmlns:a16="http://schemas.microsoft.com/office/drawing/2014/main" id="{B871ABED-4E1F-4A9A-A593-3F47B7E44B47}"/>
+                <a16:creationId xmlns:a16="http://schemas.microsoft.com/office/drawing/2014/main" id="{3AF99F69-B35D-4A36-8958-EB41B9DCDB0D}"/>
               </a:ext>
             </a:extLst>
           </p:cNvPr>
@@ -13315,7 +13315,7 @@
     </p:spTree>
     <p:extLst>
       <p:ext uri="{BB962C8B-B14F-4D97-AF65-F5344CB8AC3E}">
-        <p14:creationId xmlns:p14="http://schemas.microsoft.com/office/powerpoint/2010/main" val="627843768"/>
+        <p14:creationId xmlns:p14="http://schemas.microsoft.com/office/powerpoint/2010/main" val="989659359"/>
       </p:ext>
     </p:extLst>
   </p:cSld>

</xml_diff>

<commit_message>
Deploy competitive intelligence engineering updates
</commit_message>
<xml_diff>
--- a/deploy-site/exports/waters-nextgen-leadership-brief.pptx
+++ b/deploy-site/exports/waters-nextgen-leadership-brief.pptx
@@ -2,20 +2,20 @@
 <file path=ppt/presentation.xml><?xml version="1.0" encoding="utf-8"?>
 <p:presentation xmlns:p="http://schemas.openxmlformats.org/presentationml/2006/main">
   <p:sldMasterIdLst>
-    <p:sldMasterId xmlns:r="http://schemas.openxmlformats.org/officeDocument/2006/relationships" id="2147483648" r:id="Rd7f68449db4440f2"/>
+    <p:sldMasterId xmlns:r="http://schemas.openxmlformats.org/officeDocument/2006/relationships" id="2147483648" r:id="R6b1221ea26fc4cff"/>
   </p:sldMasterIdLst>
   <p:notesMasterIdLst>
-    <p:notesMasterId xmlns:r="http://schemas.openxmlformats.org/officeDocument/2006/relationships" r:id="Ree9d64bb38154449"/>
+    <p:notesMasterId xmlns:r="http://schemas.openxmlformats.org/officeDocument/2006/relationships" r:id="Re878d1ae7d544329"/>
   </p:notesMasterIdLst>
   <p:sldIdLst>
-    <p:sldId xmlns:r="http://schemas.openxmlformats.org/officeDocument/2006/relationships" id="256" r:id="Rd64d390c99994fb0"/>
-    <p:sldId xmlns:r="http://schemas.openxmlformats.org/officeDocument/2006/relationships" id="257" r:id="R5d172cdb27ea4e33"/>
-    <p:sldId xmlns:r="http://schemas.openxmlformats.org/officeDocument/2006/relationships" id="258" r:id="R0a179b4323e7451b"/>
-    <p:sldId xmlns:r="http://schemas.openxmlformats.org/officeDocument/2006/relationships" id="259" r:id="R1163a224a5a0479d"/>
-    <p:sldId xmlns:r="http://schemas.openxmlformats.org/officeDocument/2006/relationships" id="260" r:id="Rdfc24e2d6cfe4375"/>
-    <p:sldId xmlns:r="http://schemas.openxmlformats.org/officeDocument/2006/relationships" id="261" r:id="R45fc0b0f97704f53"/>
-    <p:sldId xmlns:r="http://schemas.openxmlformats.org/officeDocument/2006/relationships" id="262" r:id="Rd201ab4733dd401a"/>
-    <p:sldId xmlns:r="http://schemas.openxmlformats.org/officeDocument/2006/relationships" id="263" r:id="R27f516412f774fe8"/>
+    <p:sldId xmlns:r="http://schemas.openxmlformats.org/officeDocument/2006/relationships" id="256" r:id="R55ef541e454c4414"/>
+    <p:sldId xmlns:r="http://schemas.openxmlformats.org/officeDocument/2006/relationships" id="257" r:id="Rb8396b1e44934989"/>
+    <p:sldId xmlns:r="http://schemas.openxmlformats.org/officeDocument/2006/relationships" id="258" r:id="Rb880a0080a454b1c"/>
+    <p:sldId xmlns:r="http://schemas.openxmlformats.org/officeDocument/2006/relationships" id="259" r:id="Rf684c207b04c4789"/>
+    <p:sldId xmlns:r="http://schemas.openxmlformats.org/officeDocument/2006/relationships" id="260" r:id="R4dc6540b7c3b434e"/>
+    <p:sldId xmlns:r="http://schemas.openxmlformats.org/officeDocument/2006/relationships" id="261" r:id="Re462dde2ef0a4656"/>
+    <p:sldId xmlns:r="http://schemas.openxmlformats.org/officeDocument/2006/relationships" id="262" r:id="R5172897c1ad94410"/>
+    <p:sldId xmlns:r="http://schemas.openxmlformats.org/officeDocument/2006/relationships" id="263" r:id="Re3700c5afc444ef5"/>
   </p:sldIdLst>
   <p:sldSz cx="12192000" cy="6858000"/>
   <p:notesSz cx="6858000" cy="9144000"/>
@@ -529,17 +529,17 @@
           </a:p>
           <a:p xmlns:a="http://schemas.openxmlformats.org/drawingml/2006/main">
             <a:r>
-              <a:t>- https://pubmed.ncbi.nlm.nih.gov/?term=%28%28%22laboratory+automation%22+OR+%22workflow+software%22+OR+%22AI%22%29+AND+%28%22LC-MS%22+OR+chromatography+OR+%22mass+spectrometry%22%29%29+AND+%28%222025%2F08%2F13%22%5BDate+-+Publication%5D+%3A+%222026%2F08%2F13%22%5BDate+-+Publication%5D%29</a:t>
-            </a:r>
-          </a:p>
-          <a:p xmlns:a="http://schemas.openxmlformats.org/drawingml/2006/main">
-            <a:r>
-              <a:t>- https://pubmed.ncbi.nlm.nih.gov/?term=%28%28PFAS+OR+%22per-+and+polyfluoroalkyl%22%29+AND+%28%22LC-MS%22+OR+%22LC-MS%2FMS%22+OR+chromatography%29%29+AND+%28%222025%2F08%2F13%22%5BDate+-+Publication%5D+%3A+%222026%2F08%2F13%22%5BDate+-+Publication%5D%29</a:t>
-            </a:r>
-          </a:p>
-          <a:p xmlns:a="http://schemas.openxmlformats.org/drawingml/2006/main">
-            <a:r>
-              <a:t>- https://pubmed.ncbi.nlm.nih.gov/?term=%28%28oligonucleotide+OR+%22nucleic+acid%22+OR+siRNA%29+AND+%28%22LC-MS%22+OR+chromatography+OR+%22mass+spectrometry%22%29%29+AND+%28%222025%2F08%2F13%22%5BDate+-+Publication%5D+%3A+%222026%2F08%2F13%22%5BDate+-+Publication%5D%29</a:t>
+              <a:t>- https://pubmed.ncbi.nlm.nih.gov/?term=%28%28%22laboratory+automation%22+OR+%22workflow+software%22+OR+%22AI%22%29+AND+%28%22LC-MS%22+OR+chromatography+OR+%22mass+spectrometry%22%29%29+AND+%28%222025%2F08%2F17%22%5BDate+-+Publication%5D+%3A+%222026%2F08%2F17%22%5BDate+-+Publication%5D%29</a:t>
+            </a:r>
+          </a:p>
+          <a:p xmlns:a="http://schemas.openxmlformats.org/drawingml/2006/main">
+            <a:r>
+              <a:t>- https://pubmed.ncbi.nlm.nih.gov/?term=%28%28PFAS+OR+%22per-+and+polyfluoroalkyl%22%29+AND+%28%22LC-MS%22+OR+%22LC-MS%2FMS%22+OR+chromatography%29%29+AND+%28%222025%2F08%2F17%22%5BDate+-+Publication%5D+%3A+%222026%2F08%2F17%22%5BDate+-+Publication%5D%29</a:t>
+            </a:r>
+          </a:p>
+          <a:p xmlns:a="http://schemas.openxmlformats.org/drawingml/2006/main">
+            <a:r>
+              <a:t>- https://pubmed.ncbi.nlm.nih.gov/?term=%28%28oligonucleotide+OR+%22nucleic+acid%22+OR+siRNA%29+AND+%28%22LC-MS%22+OR+chromatography+OR+%22mass+spectrometry%22%29%29+AND+%28%222025%2F08%2F17%22%5BDate+-+Publication%5D+%3A+%222026%2F08%2F17%22%5BDate+-+Publication%5D%29</a:t>
             </a:r>
           </a:p>
           <a:p xmlns:a="http://schemas.openxmlformats.org/drawingml/2006/main">
@@ -619,7 +619,7 @@
           </a:p>
           <a:p xmlns:a="http://schemas.openxmlformats.org/drawingml/2006/main">
             <a:r>
-              <a:t>- https://pubmed.ncbi.nlm.nih.gov/?term=%28%28PFAS+OR+%22per-+and+polyfluoroalkyl%22%29+AND+%28%22LC-MS%22+OR+%22LC-MS%2FMS%22+OR+chromatography%29%29+AND+%28%222025%2F08%2F13%22%5BDate+-+Publication%5D+%3A+%222026%2F08%2F13%22%5BDate+-+Publication%5D%29</a:t>
+              <a:t>- https://pubmed.ncbi.nlm.nih.gov/?term=%28%28PFAS+OR+%22per-+and+polyfluoroalkyl%22%29+AND+%28%22LC-MS%22+OR+%22LC-MS%2FMS%22+OR+chromatography%29%29+AND+%28%222025%2F08%2F17%22%5BDate+-+Publication%5D+%3A+%222026%2F08%2F17%22%5BDate+-+Publication%5D%29</a:t>
             </a:r>
           </a:p>
           <a:p xmlns:a="http://schemas.openxmlformats.org/drawingml/2006/main">
@@ -644,12 +644,12 @@
           </a:p>
           <a:p xmlns:a="http://schemas.openxmlformats.org/drawingml/2006/main">
             <a:r>
-              <a:t>- https://www.reddit.com/r/CHROMATOGRAPHY/comments/1h1i93y/waters_acquity_uplc_beh_17_um_21_x_100_mm_column/</a:t>
-            </a:r>
-          </a:p>
-          <a:p xmlns:a="http://schemas.openxmlformats.org/drawingml/2006/main">
-            <a:r>
-              <a:t>- https://www.reddit.com/r/CHROMATOGRAPHY/comments/1e3y2sy/getting_started_with_empower_3/</a:t>
+              <a:t>- https://www.labwrench.com/thread/135698/hplc-pump-and-autosampler-preventative-performance-maintenance</a:t>
+            </a:r>
+          </a:p>
+          <a:p xmlns:a="http://schemas.openxmlformats.org/drawingml/2006/main">
+            <a:r>
+              <a:t>- https://www.reddit.com/r/CHROMATOGRAPHY/comments/xlr4pf/best_uhplc_on_the_market/</a:t>
             </a:r>
           </a:p>
           <a:p xmlns:a="http://schemas.openxmlformats.org/drawingml/2006/main">
@@ -829,37 +829,37 @@
           </a:p>
           <a:p xmlns:a="http://schemas.openxmlformats.org/drawingml/2006/main">
             <a:r>
-              <a:t>- https://www.reddit.com/r/CHROMATOGRAPHY/comments/1h1i93y/waters_acquity_uplc_beh_17_um_21_x_100_mm_column/</a:t>
-            </a:r>
-          </a:p>
-          <a:p xmlns:a="http://schemas.openxmlformats.org/drawingml/2006/main">
-            <a:r>
-              <a:t>- https://www.reddit.com/r/CHROMATOGRAPHY/comments/1e3y2sy/getting_started_with_empower_3/</a:t>
-            </a:r>
-          </a:p>
-          <a:p xmlns:a="http://schemas.openxmlformats.org/drawingml/2006/main">
-            <a:r>
               <a:t>- https://www.labwrench.com/thread/135698/hplc-pump-and-autosampler-preventative-performance-maintenance</a:t>
             </a:r>
           </a:p>
           <a:p xmlns:a="http://schemas.openxmlformats.org/drawingml/2006/main">
             <a:r>
-              <a:t>- https://www.reddit.com/r/CHROMATOGRAPHY/comments/1somxpf/waters_acquity_arc_lcms_214_nm_uv_baseline/</a:t>
-            </a:r>
-          </a:p>
-          <a:p xmlns:a="http://schemas.openxmlformats.org/drawingml/2006/main">
-            <a:r>
               <a:t>- https://www.reddit.com/r/CHROMATOGRAPHY/comments/xlr4pf/best_uhplc_on_the_market/</a:t>
             </a:r>
           </a:p>
           <a:p xmlns:a="http://schemas.openxmlformats.org/drawingml/2006/main">
             <a:r>
-              <a:t>- https://www.reddit.com/r/CHROMATOGRAPHY/comments/1q24noh/reccomendations_for_new_hplc_system_for_routine/</a:t>
-            </a:r>
-          </a:p>
-          <a:p xmlns:a="http://schemas.openxmlformats.org/drawingml/2006/main">
-            <a:r>
-              <a:t>- https://www.reddit.com/r/CHROMATOGRAPHY/comments/1h6lnr0/agilent_1260_hplc_vs_thermo_vanquish_flex/</a:t>
+              <a:t>- https://www.reddit.com/r/massspectrometry/comments/1uxyipd/efficient_quant_workflow_for_targetlynx/</a:t>
+            </a:r>
+          </a:p>
+          <a:p xmlns:a="http://schemas.openxmlformats.org/drawingml/2006/main">
+            <a:r>
+              <a:t>- https://www.reddit.com/r/massspectrometry/comments/1ux1imr/most_frustrating_thing_about_mass_spectrometry/</a:t>
+            </a:r>
+          </a:p>
+          <a:p xmlns:a="http://schemas.openxmlformats.org/drawingml/2006/main">
+            <a:r>
+              <a:t>- https://www.reddit.com/r/massspectrometry/comments/1u1dpq6/synapt_nonresponsive_fluidics_purge_issue/</a:t>
+            </a:r>
+          </a:p>
+          <a:p xmlns:a="http://schemas.openxmlformats.org/drawingml/2006/main">
+            <a:r>
+              <a:t>- https://www.reddit.com/r/massspectrometry/comments/1up1dlw/best_software_to_use_agilent_g3540a_gc_with/</a:t>
+            </a:r>
+          </a:p>
+          <a:p xmlns:a="http://schemas.openxmlformats.org/drawingml/2006/main">
+            <a:r>
+              <a:t>- https://www.reddit.com/r/CHROMATOGRAPHY/comments/1sbtsdx/comparing_vendors_and_systems_thoughts/</a:t>
             </a:r>
           </a:p>
           <a:p xmlns:a="http://schemas.openxmlformats.org/drawingml/2006/main">
@@ -949,7 +949,7 @@
           </a:p>
           <a:p xmlns:a="http://schemas.openxmlformats.org/drawingml/2006/main">
             <a:r>
-              <a:t>- https://pubmed.ncbi.nlm.nih.gov/?term=%28%28PFAS+OR+%22per-+and+polyfluoroalkyl%22%29+AND+%28%22LC-MS%22+OR+%22LC-MS%2FMS%22+OR+chromatography%29%29+AND+%28%222025%2F08%2F13%22%5BDate+-+Publication%5D+%3A+%222026%2F08%2F13%22%5BDate+-+Publication%5D%29</a:t>
+              <a:t>- https://pubmed.ncbi.nlm.nih.gov/?term=%28%28PFAS+OR+%22per-+and+polyfluoroalkyl%22%29+AND+%28%22LC-MS%22+OR+%22LC-MS%2FMS%22+OR+chromatography%29%29+AND+%28%222025%2F08%2F17%22%5BDate+-+Publication%5D+%3A+%222026%2F08%2F17%22%5BDate+-+Publication%5D%29</a:t>
             </a:r>
           </a:p>
           <a:p xmlns:a="http://schemas.openxmlformats.org/drawingml/2006/main">
@@ -969,7 +969,7 @@
           </a:p>
           <a:p xmlns:a="http://schemas.openxmlformats.org/drawingml/2006/main">
             <a:r>
-              <a:t>- https://pubmed.ncbi.nlm.nih.gov/?term=%28%28%22laboratory+automation%22+OR+%22workflow+software%22+OR+%22AI%22%29+AND+%28%22LC-MS%22+OR+chromatography+OR+%22mass+spectrometry%22%29%29+AND+%28%222025%2F08%2F13%22%5BDate+-+Publication%5D+%3A+%222026%2F08%2F13%22%5BDate+-+Publication%5D%29</a:t>
+              <a:t>- https://pubmed.ncbi.nlm.nih.gov/?term=%28%28%22laboratory+automation%22+OR+%22workflow+software%22+OR+%22AI%22%29+AND+%28%22LC-MS%22+OR+chromatography+OR+%22mass+spectrometry%22%29%29+AND+%28%222025%2F08%2F17%22%5BDate+-+Publication%5D+%3A+%222026%2F08%2F17%22%5BDate+-+Publication%5D%29</a:t>
             </a:r>
           </a:p>
           <a:p xmlns:a="http://schemas.openxmlformats.org/drawingml/2006/main">
@@ -984,7 +984,7 @@
           </a:p>
           <a:p xmlns:a="http://schemas.openxmlformats.org/drawingml/2006/main">
             <a:r>
-              <a:t>- https://pubmed.ncbi.nlm.nih.gov/?term=%28%28oligonucleotide+OR+%22nucleic+acid%22+OR+siRNA%29+AND+%28%22LC-MS%22+OR+chromatography+OR+%22mass+spectrometry%22%29%29+AND+%28%222025%2F08%2F13%22%5BDate+-+Publication%5D+%3A+%222026%2F08%2F13%22%5BDate+-+Publication%5D%29</a:t>
+              <a:t>- https://pubmed.ncbi.nlm.nih.gov/?term=%28%28oligonucleotide+OR+%22nucleic+acid%22+OR+siRNA%29+AND+%28%22LC-MS%22+OR+chromatography+OR+%22mass+spectrometry%22%29%29+AND+%28%222025%2F08%2F17%22%5BDate+-+Publication%5D+%3A+%222026%2F08%2F17%22%5BDate+-+Publication%5D%29</a:t>
             </a:r>
           </a:p>
           <a:p xmlns:a="http://schemas.openxmlformats.org/drawingml/2006/main">
@@ -1079,7 +1079,7 @@
           </a:p>
           <a:p xmlns:a="http://schemas.openxmlformats.org/drawingml/2006/main">
             <a:r>
-              <a:t>- https://pubmed.ncbi.nlm.nih.gov/?term=%28%28PFAS+OR+%22per-+and+polyfluoroalkyl%22%29+AND+%28%22LC-MS%22+OR+%22LC-MS%2FMS%22+OR+chromatography%29%29+AND+%28%222025%2F08%2F13%22%5BDate+-+Publication%5D+%3A+%222026%2F08%2F13%22%5BDate+-+Publication%5D%29</a:t>
+              <a:t>- https://pubmed.ncbi.nlm.nih.gov/?term=%28%28PFAS+OR+%22per-+and+polyfluoroalkyl%22%29+AND+%28%22LC-MS%22+OR+%22LC-MS%2FMS%22+OR+chromatography%29%29+AND+%28%222025%2F08%2F17%22%5BDate+-+Publication%5D+%3A+%222026%2F08%2F17%22%5BDate+-+Publication%5D%29</a:t>
             </a:r>
           </a:p>
           <a:p xmlns:a="http://schemas.openxmlformats.org/drawingml/2006/main">
@@ -1099,7 +1099,7 @@
           </a:p>
           <a:p xmlns:a="http://schemas.openxmlformats.org/drawingml/2006/main">
             <a:r>
-              <a:t>- https://pubmed.ncbi.nlm.nih.gov/?term=%28%28%22laboratory+automation%22+OR+%22workflow+software%22+OR+%22AI%22%29+AND+%28%22LC-MS%22+OR+chromatography+OR+%22mass+spectrometry%22%29%29+AND+%28%222025%2F08%2F13%22%5BDate+-+Publication%5D+%3A+%222026%2F08%2F13%22%5BDate+-+Publication%5D%29</a:t>
+              <a:t>- https://pubmed.ncbi.nlm.nih.gov/?term=%28%28%22laboratory+automation%22+OR+%22workflow+software%22+OR+%22AI%22%29+AND+%28%22LC-MS%22+OR+chromatography+OR+%22mass+spectrometry%22%29%29+AND+%28%222025%2F08%2F17%22%5BDate+-+Publication%5D+%3A+%222026%2F08%2F17%22%5BDate+-+Publication%5D%29</a:t>
             </a:r>
           </a:p>
           <a:p xmlns:a="http://schemas.openxmlformats.org/drawingml/2006/main">
@@ -1114,7 +1114,7 @@
           </a:p>
           <a:p xmlns:a="http://schemas.openxmlformats.org/drawingml/2006/main">
             <a:r>
-              <a:t>- https://pubmed.ncbi.nlm.nih.gov/?term=%28%28oligonucleotide+OR+%22nucleic+acid%22+OR+siRNA%29+AND+%28%22LC-MS%22+OR+chromatography+OR+%22mass+spectrometry%22%29%29+AND+%28%222025%2F08%2F13%22%5BDate+-+Publication%5D+%3A+%222026%2F08%2F13%22%5BDate+-+Publication%5D%29</a:t>
+              <a:t>- https://pubmed.ncbi.nlm.nih.gov/?term=%28%28oligonucleotide+OR+%22nucleic+acid%22+OR+siRNA%29+AND+%28%22LC-MS%22+OR+chromatography+OR+%22mass+spectrometry%22%29%29+AND+%28%222025%2F08%2F17%22%5BDate+-+Publication%5D+%3A+%222026%2F08%2F17%22%5BDate+-+Publication%5D%29</a:t>
             </a:r>
           </a:p>
           <a:p xmlns:a="http://schemas.openxmlformats.org/drawingml/2006/main">
@@ -1194,7 +1194,7 @@
           </a:p>
           <a:p xmlns:a="http://schemas.openxmlformats.org/drawingml/2006/main">
             <a:r>
-              <a:t>- https://pubmed.ncbi.nlm.nih.gov/?term=%28%28PFAS+OR+%22per-+and+polyfluoroalkyl%22%29+AND+%28%22LC-MS%22+OR+%22LC-MS%2FMS%22+OR+chromatography%29%29+AND+%28%222025%2F08%2F13%22%5BDate+-+Publication%5D+%3A+%222026%2F08%2F13%22%5BDate+-+Publication%5D%29</a:t>
+              <a:t>- https://pubmed.ncbi.nlm.nih.gov/?term=%28%28PFAS+OR+%22per-+and+polyfluoroalkyl%22%29+AND+%28%22LC-MS%22+OR+%22LC-MS%2FMS%22+OR+chromatography%29%29+AND+%28%222025%2F08%2F17%22%5BDate+-+Publication%5D+%3A+%222026%2F08%2F17%22%5BDate+-+Publication%5D%29</a:t>
             </a:r>
           </a:p>
           <a:p xmlns:a="http://schemas.openxmlformats.org/drawingml/2006/main">
@@ -1292,7 +1292,7 @@
   </p:cSld>
   <p:clrMap bg1="lt1" tx1="dk1" bg2="lt2" tx2="dk2" accent1="accent1" accent2="accent2" accent3="accent3" accent4="accent4" accent5="accent5" accent6="accent6" hlink="hlink" folHlink="folHlink"/>
   <p:sldLayoutIdLst>
-    <p:sldLayoutId xmlns:r="http://schemas.openxmlformats.org/officeDocument/2006/relationships" id="2147483649" r:id="R0f40835474de45f6"/>
+    <p:sldLayoutId xmlns:r="http://schemas.openxmlformats.org/officeDocument/2006/relationships" id="2147483649" r:id="Rc01745b939eb4d61"/>
   </p:sldLayoutIdLst>
   <p:txStyles>
     <p:titleStyle>
@@ -1843,7 +1843,7 @@
           <p:cNvPr id="14" name="">
             <a:extLst xmlns:a="http://schemas.openxmlformats.org/drawingml/2006/main">
               <a:ext uri="{FF2B5EF4-FFF2-40B4-BE49-F238E27FC236}">
-                <a16:creationId xmlns:a16="http://schemas.microsoft.com/office/drawing/2014/main" id="{7A0B6A4D-7F9D-45F4-AF77-E8FE91A9B23C}"/>
+                <a16:creationId xmlns:a16="http://schemas.microsoft.com/office/drawing/2014/main" id="{6CB153D5-222D-4B4B-B88E-6F5C4C37F2F2}"/>
               </a:ext>
             </a:extLst>
           </p:cNvPr>
@@ -1876,7 +1876,7 @@
           <p:cNvPr id="2" name="">
             <a:extLst xmlns:a="http://schemas.openxmlformats.org/drawingml/2006/main">
               <a:ext uri="{FF2B5EF4-FFF2-40B4-BE49-F238E27FC236}">
-                <a16:creationId xmlns:a16="http://schemas.microsoft.com/office/drawing/2014/main" id="{DF822AB8-4672-4E57-ADE9-B5297CB5B7E2}"/>
+                <a16:creationId xmlns:a16="http://schemas.microsoft.com/office/drawing/2014/main" id="{E240E70D-082C-4646-9E64-C17DE4DBFD51}"/>
               </a:ext>
             </a:extLst>
           </p:cNvPr>
@@ -1934,7 +1934,7 @@
           <p:cNvPr id="3" name="">
             <a:extLst xmlns:a="http://schemas.openxmlformats.org/drawingml/2006/main">
               <a:ext uri="{FF2B5EF4-FFF2-40B4-BE49-F238E27FC236}">
-                <a16:creationId xmlns:a16="http://schemas.microsoft.com/office/drawing/2014/main" id="{99F7FB0F-F399-4BC9-9F2A-399FF7D67428}"/>
+                <a16:creationId xmlns:a16="http://schemas.microsoft.com/office/drawing/2014/main" id="{743268F0-0507-41CE-8CCA-33985940C07F}"/>
               </a:ext>
             </a:extLst>
           </p:cNvPr>
@@ -1992,7 +1992,7 @@
           <p:cNvPr id="4" name="">
             <a:extLst xmlns:a="http://schemas.openxmlformats.org/drawingml/2006/main">
               <a:ext uri="{FF2B5EF4-FFF2-40B4-BE49-F238E27FC236}">
-                <a16:creationId xmlns:a16="http://schemas.microsoft.com/office/drawing/2014/main" id="{CE45D295-9C23-4A0F-974D-0137CB618D48}"/>
+                <a16:creationId xmlns:a16="http://schemas.microsoft.com/office/drawing/2014/main" id="{04FCE4B2-6EA6-454B-84A4-A8234A89E1FD}"/>
               </a:ext>
             </a:extLst>
           </p:cNvPr>
@@ -2050,7 +2050,7 @@
           <p:cNvPr id="5" name="">
             <a:extLst xmlns:a="http://schemas.openxmlformats.org/drawingml/2006/main">
               <a:ext uri="{FF2B5EF4-FFF2-40B4-BE49-F238E27FC236}">
-                <a16:creationId xmlns:a16="http://schemas.microsoft.com/office/drawing/2014/main" id="{DB3A916B-AF16-45DC-BBC8-7CFC2FBD3203}"/>
+                <a16:creationId xmlns:a16="http://schemas.microsoft.com/office/drawing/2014/main" id="{F65C5D59-D096-4B3E-896C-7031F27A7A6D}"/>
               </a:ext>
             </a:extLst>
           </p:cNvPr>
@@ -2108,7 +2108,7 @@
           <p:cNvPr id="6" name="">
             <a:extLst xmlns:a="http://schemas.openxmlformats.org/drawingml/2006/main">
               <a:ext uri="{FF2B5EF4-FFF2-40B4-BE49-F238E27FC236}">
-                <a16:creationId xmlns:a16="http://schemas.microsoft.com/office/drawing/2014/main" id="{13A9F168-A677-4E56-9BE9-AB1A053006CE}"/>
+                <a16:creationId xmlns:a16="http://schemas.microsoft.com/office/drawing/2014/main" id="{966E6677-8CF8-410D-A770-3CD234BB9F82}"/>
               </a:ext>
             </a:extLst>
           </p:cNvPr>
@@ -2143,7 +2143,7 @@
           <p:cNvPr id="7" name="">
             <a:extLst xmlns:a="http://schemas.openxmlformats.org/drawingml/2006/main">
               <a:ext uri="{FF2B5EF4-FFF2-40B4-BE49-F238E27FC236}">
-                <a16:creationId xmlns:a16="http://schemas.microsoft.com/office/drawing/2014/main" id="{6EAA1210-C3C6-400E-A153-45C8187D154F}"/>
+                <a16:creationId xmlns:a16="http://schemas.microsoft.com/office/drawing/2014/main" id="{DB34C0AF-E2BC-4D89-A982-4D88ABA9B47E}"/>
               </a:ext>
             </a:extLst>
           </p:cNvPr>
@@ -2201,7 +2201,7 @@
           <p:cNvPr id="8" name="">
             <a:extLst xmlns:a="http://schemas.openxmlformats.org/drawingml/2006/main">
               <a:ext uri="{FF2B5EF4-FFF2-40B4-BE49-F238E27FC236}">
-                <a16:creationId xmlns:a16="http://schemas.microsoft.com/office/drawing/2014/main" id="{7C022E4F-7503-4546-B738-54B42CFF0D93}"/>
+                <a16:creationId xmlns:a16="http://schemas.microsoft.com/office/drawing/2014/main" id="{A4FB664C-0B7D-45CB-ADBC-765D245BF008}"/>
               </a:ext>
             </a:extLst>
           </p:cNvPr>
@@ -2249,7 +2249,7 @@
                 <a:ea typeface="Aptos"/>
                 <a:cs typeface="Aptos"/>
               </a:rPr>
-              <a:t>13</a:t>
+              <a:t>17</a:t>
             </a:r>
           </a:p>
         </p:txBody>
@@ -2259,7 +2259,7 @@
           <p:cNvPr id="9" name="">
             <a:extLst xmlns:a="http://schemas.openxmlformats.org/drawingml/2006/main">
               <a:ext uri="{FF2B5EF4-FFF2-40B4-BE49-F238E27FC236}">
-                <a16:creationId xmlns:a16="http://schemas.microsoft.com/office/drawing/2014/main" id="{ED3BB944-8270-4531-B93C-2F557E8BC9A0}"/>
+                <a16:creationId xmlns:a16="http://schemas.microsoft.com/office/drawing/2014/main" id="{F47C07CC-2641-4F8C-A738-A7E3700BFB60}"/>
               </a:ext>
             </a:extLst>
           </p:cNvPr>
@@ -2317,7 +2317,7 @@
           <p:cNvPr id="10" name="">
             <a:extLst xmlns:a="http://schemas.openxmlformats.org/drawingml/2006/main">
               <a:ext uri="{FF2B5EF4-FFF2-40B4-BE49-F238E27FC236}">
-                <a16:creationId xmlns:a16="http://schemas.microsoft.com/office/drawing/2014/main" id="{C9CF5CC4-6504-4A01-A77C-AAE6069A4A25}"/>
+                <a16:creationId xmlns:a16="http://schemas.microsoft.com/office/drawing/2014/main" id="{96C690AD-950E-4A86-998A-DE81281FDD70}"/>
               </a:ext>
             </a:extLst>
           </p:cNvPr>
@@ -2350,7 +2350,7 @@
           <p:cNvPr id="11" name="">
             <a:extLst xmlns:a="http://schemas.openxmlformats.org/drawingml/2006/main">
               <a:ext uri="{FF2B5EF4-FFF2-40B4-BE49-F238E27FC236}">
-                <a16:creationId xmlns:a16="http://schemas.microsoft.com/office/drawing/2014/main" id="{A8BC12D9-B1AB-4599-AA39-656C180396AF}"/>
+                <a16:creationId xmlns:a16="http://schemas.microsoft.com/office/drawing/2014/main" id="{0545C645-3591-49AF-BDAC-EFEF9F38449A}"/>
               </a:ext>
             </a:extLst>
           </p:cNvPr>
@@ -2408,7 +2408,7 @@
           <p:cNvPr id="12" name="">
             <a:extLst xmlns:a="http://schemas.openxmlformats.org/drawingml/2006/main">
               <a:ext uri="{FF2B5EF4-FFF2-40B4-BE49-F238E27FC236}">
-                <a16:creationId xmlns:a16="http://schemas.microsoft.com/office/drawing/2014/main" id="{F409315A-CA92-4D7D-B3E6-010F76D6DD50}"/>
+                <a16:creationId xmlns:a16="http://schemas.microsoft.com/office/drawing/2014/main" id="{270C2474-3FCC-4B47-81CF-0C42D43A642D}"/>
               </a:ext>
             </a:extLst>
           </p:cNvPr>
@@ -2456,7 +2456,7 @@
                 <a:ea typeface="Aptos"/>
                 <a:cs typeface="Aptos"/>
               </a:rPr>
-              <a:t>Prepared for roadmap review · waters-ci-20260813070817</a:t>
+              <a:t>Prepared for roadmap review · waters-ci-20260817124300</a:t>
             </a:r>
           </a:p>
         </p:txBody>
@@ -2466,7 +2466,7 @@
           <p:cNvPr id="13" name="">
             <a:extLst xmlns:a="http://schemas.openxmlformats.org/drawingml/2006/main">
               <a:ext uri="{FF2B5EF4-FFF2-40B4-BE49-F238E27FC236}">
-                <a16:creationId xmlns:a16="http://schemas.microsoft.com/office/drawing/2014/main" id="{27AA9721-D91D-4037-B81A-614EC86EA35E}"/>
+                <a16:creationId xmlns:a16="http://schemas.microsoft.com/office/drawing/2014/main" id="{74E95FEE-98CF-4497-AC9F-7F11FC58DBA1}"/>
               </a:ext>
             </a:extLst>
           </p:cNvPr>
@@ -2522,7 +2522,7 @@
     </p:spTree>
     <p:extLst>
       <p:ext uri="{BB962C8B-B14F-4D97-AF65-F5344CB8AC3E}">
-        <p14:creationId xmlns:p14="http://schemas.microsoft.com/office/powerpoint/2010/main" val="228314583"/>
+        <p14:creationId xmlns:p14="http://schemas.microsoft.com/office/powerpoint/2010/main" val="1751265326"/>
       </p:ext>
     </p:extLst>
   </p:cSld>
@@ -2553,7 +2553,7 @@
           <p:cNvPr id="25" name="">
             <a:extLst xmlns:a="http://schemas.openxmlformats.org/drawingml/2006/main">
               <a:ext uri="{FF2B5EF4-FFF2-40B4-BE49-F238E27FC236}">
-                <a16:creationId xmlns:a16="http://schemas.microsoft.com/office/drawing/2014/main" id="{9EF3EE79-08F8-4179-B3F6-D600C3EA04F0}"/>
+                <a16:creationId xmlns:a16="http://schemas.microsoft.com/office/drawing/2014/main" id="{BB1C8234-E1B2-4F7D-AA7F-407731237D42}"/>
               </a:ext>
             </a:extLst>
           </p:cNvPr>
@@ -2611,7 +2611,7 @@
           <p:cNvPr id="2" name="">
             <a:extLst xmlns:a="http://schemas.openxmlformats.org/drawingml/2006/main">
               <a:ext uri="{FF2B5EF4-FFF2-40B4-BE49-F238E27FC236}">
-                <a16:creationId xmlns:a16="http://schemas.microsoft.com/office/drawing/2014/main" id="{DA4D2EDD-4DDB-4997-B9A9-D1DD3D1197A5}"/>
+                <a16:creationId xmlns:a16="http://schemas.microsoft.com/office/drawing/2014/main" id="{4B1DD58A-223E-4B79-B0CE-6D1FC4E1CCDE}"/>
               </a:ext>
             </a:extLst>
           </p:cNvPr>
@@ -2669,7 +2669,7 @@
           <p:cNvPr id="3" name="">
             <a:extLst xmlns:a="http://schemas.openxmlformats.org/drawingml/2006/main">
               <a:ext uri="{FF2B5EF4-FFF2-40B4-BE49-F238E27FC236}">
-                <a16:creationId xmlns:a16="http://schemas.microsoft.com/office/drawing/2014/main" id="{2793D056-D89F-4EAF-90FA-1EDB99712529}"/>
+                <a16:creationId xmlns:a16="http://schemas.microsoft.com/office/drawing/2014/main" id="{1BE34BA5-27CF-4DFA-8A85-74BFFFB275EE}"/>
               </a:ext>
             </a:extLst>
           </p:cNvPr>
@@ -2727,7 +2727,7 @@
           <p:cNvPr id="4" name="">
             <a:extLst xmlns:a="http://schemas.openxmlformats.org/drawingml/2006/main">
               <a:ext uri="{FF2B5EF4-FFF2-40B4-BE49-F238E27FC236}">
-                <a16:creationId xmlns:a16="http://schemas.microsoft.com/office/drawing/2014/main" id="{21A14686-DD51-4FB1-8F2E-89DB23827406}"/>
+                <a16:creationId xmlns:a16="http://schemas.microsoft.com/office/drawing/2014/main" id="{8567AAEA-913A-488F-B1EE-C3EBBDE65701}"/>
               </a:ext>
             </a:extLst>
           </p:cNvPr>
@@ -2760,7 +2760,7 @@
           <p:cNvPr id="5" name="">
             <a:extLst xmlns:a="http://schemas.openxmlformats.org/drawingml/2006/main">
               <a:ext uri="{FF2B5EF4-FFF2-40B4-BE49-F238E27FC236}">
-                <a16:creationId xmlns:a16="http://schemas.microsoft.com/office/drawing/2014/main" id="{819777BE-61BB-44E6-BCEE-4D9365808432}"/>
+                <a16:creationId xmlns:a16="http://schemas.microsoft.com/office/drawing/2014/main" id="{7C21B487-8379-4E54-A9DA-92D79100E742}"/>
               </a:ext>
             </a:extLst>
           </p:cNvPr>
@@ -2795,7 +2795,7 @@
           <p:cNvPr id="6" name="">
             <a:extLst xmlns:a="http://schemas.openxmlformats.org/drawingml/2006/main">
               <a:ext uri="{FF2B5EF4-FFF2-40B4-BE49-F238E27FC236}">
-                <a16:creationId xmlns:a16="http://schemas.microsoft.com/office/drawing/2014/main" id="{6B161206-5228-4C8F-A87D-8869498E69CD}"/>
+                <a16:creationId xmlns:a16="http://schemas.microsoft.com/office/drawing/2014/main" id="{6D4C186E-1637-4211-9208-7BB6779E570C}"/>
               </a:ext>
             </a:extLst>
           </p:cNvPr>
@@ -2853,7 +2853,7 @@
           <p:cNvPr id="7" name="">
             <a:extLst xmlns:a="http://schemas.openxmlformats.org/drawingml/2006/main">
               <a:ext uri="{FF2B5EF4-FFF2-40B4-BE49-F238E27FC236}">
-                <a16:creationId xmlns:a16="http://schemas.microsoft.com/office/drawing/2014/main" id="{E5BE9CDB-B03B-4806-84E8-5B7812FDCF3A}"/>
+                <a16:creationId xmlns:a16="http://schemas.microsoft.com/office/drawing/2014/main" id="{139D57AA-C656-4734-9621-9B19BE2BE5CB}"/>
               </a:ext>
             </a:extLst>
           </p:cNvPr>
@@ -2911,7 +2911,7 @@
           <p:cNvPr id="8" name="">
             <a:extLst xmlns:a="http://schemas.openxmlformats.org/drawingml/2006/main">
               <a:ext uri="{FF2B5EF4-FFF2-40B4-BE49-F238E27FC236}">
-                <a16:creationId xmlns:a16="http://schemas.microsoft.com/office/drawing/2014/main" id="{CAE4C9EA-241C-4198-88F4-5ECAA72295F8}"/>
+                <a16:creationId xmlns:a16="http://schemas.microsoft.com/office/drawing/2014/main" id="{4BE8A139-403C-45D2-9CEB-A1FE2C459D2F}"/>
               </a:ext>
             </a:extLst>
           </p:cNvPr>
@@ -2946,7 +2946,7 @@
           <p:cNvPr id="9" name="">
             <a:extLst xmlns:a="http://schemas.openxmlformats.org/drawingml/2006/main">
               <a:ext uri="{FF2B5EF4-FFF2-40B4-BE49-F238E27FC236}">
-                <a16:creationId xmlns:a16="http://schemas.microsoft.com/office/drawing/2014/main" id="{5F544C0F-CD6C-4C45-AE79-192B57F1B327}"/>
+                <a16:creationId xmlns:a16="http://schemas.microsoft.com/office/drawing/2014/main" id="{C84DFE6C-27C7-44F8-87C7-C0AD7F8466D7}"/>
               </a:ext>
             </a:extLst>
           </p:cNvPr>
@@ -2979,7 +2979,7 @@
           <p:cNvPr id="10" name="">
             <a:extLst xmlns:a="http://schemas.openxmlformats.org/drawingml/2006/main">
               <a:ext uri="{FF2B5EF4-FFF2-40B4-BE49-F238E27FC236}">
-                <a16:creationId xmlns:a16="http://schemas.microsoft.com/office/drawing/2014/main" id="{A5CB1788-77C2-4284-AEDA-018A209DA893}"/>
+                <a16:creationId xmlns:a16="http://schemas.microsoft.com/office/drawing/2014/main" id="{0506E4FB-6D89-44B4-9E69-4AFB76D16385}"/>
               </a:ext>
             </a:extLst>
           </p:cNvPr>
@@ -3037,7 +3037,7 @@
           <p:cNvPr id="11" name="">
             <a:extLst xmlns:a="http://schemas.openxmlformats.org/drawingml/2006/main">
               <a:ext uri="{FF2B5EF4-FFF2-40B4-BE49-F238E27FC236}">
-                <a16:creationId xmlns:a16="http://schemas.microsoft.com/office/drawing/2014/main" id="{AEF82C2F-E1EB-4E29-9F2C-596BC6AD4D03}"/>
+                <a16:creationId xmlns:a16="http://schemas.microsoft.com/office/drawing/2014/main" id="{C69A26B4-22EE-45EA-949B-8E5161EC5EB5}"/>
               </a:ext>
             </a:extLst>
           </p:cNvPr>
@@ -3095,7 +3095,7 @@
           <p:cNvPr id="12" name="">
             <a:extLst xmlns:a="http://schemas.openxmlformats.org/drawingml/2006/main">
               <a:ext uri="{FF2B5EF4-FFF2-40B4-BE49-F238E27FC236}">
-                <a16:creationId xmlns:a16="http://schemas.microsoft.com/office/drawing/2014/main" id="{B61055B1-C5CF-4909-AED8-9C0CDA0FA744}"/>
+                <a16:creationId xmlns:a16="http://schemas.microsoft.com/office/drawing/2014/main" id="{37AC7EDD-2672-42EA-9D86-CAFF2644B925}"/>
               </a:ext>
             </a:extLst>
           </p:cNvPr>
@@ -3153,7 +3153,7 @@
           <p:cNvPr id="13" name="">
             <a:extLst xmlns:a="http://schemas.openxmlformats.org/drawingml/2006/main">
               <a:ext uri="{FF2B5EF4-FFF2-40B4-BE49-F238E27FC236}">
-                <a16:creationId xmlns:a16="http://schemas.microsoft.com/office/drawing/2014/main" id="{12D57292-7898-43E2-B5C3-702FC2778425}"/>
+                <a16:creationId xmlns:a16="http://schemas.microsoft.com/office/drawing/2014/main" id="{418B7189-1E14-4C84-A8FB-DE8077F4C1A0}"/>
               </a:ext>
             </a:extLst>
           </p:cNvPr>
@@ -3188,7 +3188,7 @@
           <p:cNvPr id="14" name="">
             <a:extLst xmlns:a="http://schemas.openxmlformats.org/drawingml/2006/main">
               <a:ext uri="{FF2B5EF4-FFF2-40B4-BE49-F238E27FC236}">
-                <a16:creationId xmlns:a16="http://schemas.microsoft.com/office/drawing/2014/main" id="{507BD44F-1579-4F1B-A0E2-5AC7CFFE58C3}"/>
+                <a16:creationId xmlns:a16="http://schemas.microsoft.com/office/drawing/2014/main" id="{C72146F3-36C6-4F6E-99DC-72DFB072D708}"/>
               </a:ext>
             </a:extLst>
           </p:cNvPr>
@@ -3221,7 +3221,7 @@
           <p:cNvPr id="15" name="">
             <a:extLst xmlns:a="http://schemas.openxmlformats.org/drawingml/2006/main">
               <a:ext uri="{FF2B5EF4-FFF2-40B4-BE49-F238E27FC236}">
-                <a16:creationId xmlns:a16="http://schemas.microsoft.com/office/drawing/2014/main" id="{0ED4F895-0BA8-4F9B-AF92-E3FCD2DDCA3E}"/>
+                <a16:creationId xmlns:a16="http://schemas.microsoft.com/office/drawing/2014/main" id="{3FAEBD40-074C-40C8-9634-4DF7C5566752}"/>
               </a:ext>
             </a:extLst>
           </p:cNvPr>
@@ -3269,7 +3269,7 @@
                 <a:ea typeface="Aptos"/>
                 <a:cs typeface="Aptos"/>
               </a:rPr>
-              <a:t>335</a:t>
+              <a:t>336</a:t>
             </a:r>
           </a:p>
         </p:txBody>
@@ -3279,7 +3279,7 @@
           <p:cNvPr id="16" name="">
             <a:extLst xmlns:a="http://schemas.openxmlformats.org/drawingml/2006/main">
               <a:ext uri="{FF2B5EF4-FFF2-40B4-BE49-F238E27FC236}">
-                <a16:creationId xmlns:a16="http://schemas.microsoft.com/office/drawing/2014/main" id="{CE1E28F2-DA4E-4C4D-8152-D1E5DA208F03}"/>
+                <a16:creationId xmlns:a16="http://schemas.microsoft.com/office/drawing/2014/main" id="{9BE320E3-9502-46DB-B5E8-7439CDAC3082}"/>
               </a:ext>
             </a:extLst>
           </p:cNvPr>
@@ -3337,7 +3337,7 @@
           <p:cNvPr id="17" name="">
             <a:extLst xmlns:a="http://schemas.openxmlformats.org/drawingml/2006/main">
               <a:ext uri="{FF2B5EF4-FFF2-40B4-BE49-F238E27FC236}">
-                <a16:creationId xmlns:a16="http://schemas.microsoft.com/office/drawing/2014/main" id="{DCC7D58D-0CC9-4758-82DD-0DD7BFFC2B13}"/>
+                <a16:creationId xmlns:a16="http://schemas.microsoft.com/office/drawing/2014/main" id="{A8768100-7D16-4358-9E8B-FA28763C8EBC}"/>
               </a:ext>
             </a:extLst>
           </p:cNvPr>
@@ -3395,7 +3395,7 @@
           <p:cNvPr id="18" name="">
             <a:extLst xmlns:a="http://schemas.openxmlformats.org/drawingml/2006/main">
               <a:ext uri="{FF2B5EF4-FFF2-40B4-BE49-F238E27FC236}">
-                <a16:creationId xmlns:a16="http://schemas.microsoft.com/office/drawing/2014/main" id="{C060CD88-4C14-4E78-8682-3AE122656A40}"/>
+                <a16:creationId xmlns:a16="http://schemas.microsoft.com/office/drawing/2014/main" id="{511B179B-FF89-445D-A5C3-EEDBB055BC3E}"/>
               </a:ext>
             </a:extLst>
           </p:cNvPr>
@@ -3430,7 +3430,7 @@
           <p:cNvPr id="19" name="">
             <a:extLst xmlns:a="http://schemas.openxmlformats.org/drawingml/2006/main">
               <a:ext uri="{FF2B5EF4-FFF2-40B4-BE49-F238E27FC236}">
-                <a16:creationId xmlns:a16="http://schemas.microsoft.com/office/drawing/2014/main" id="{82298462-35AA-44F5-9B02-75C4E3900ACD}"/>
+                <a16:creationId xmlns:a16="http://schemas.microsoft.com/office/drawing/2014/main" id="{1CC6118F-F89F-448D-BAB4-C045BD806AC1}"/>
               </a:ext>
             </a:extLst>
           </p:cNvPr>
@@ -3463,7 +3463,7 @@
           <p:cNvPr id="20" name="">
             <a:extLst xmlns:a="http://schemas.openxmlformats.org/drawingml/2006/main">
               <a:ext uri="{FF2B5EF4-FFF2-40B4-BE49-F238E27FC236}">
-                <a16:creationId xmlns:a16="http://schemas.microsoft.com/office/drawing/2014/main" id="{1C823F0C-1334-4A14-B951-94EAF75FCA85}"/>
+                <a16:creationId xmlns:a16="http://schemas.microsoft.com/office/drawing/2014/main" id="{2C680D3B-C247-44CE-8576-4E53E678F647}"/>
               </a:ext>
             </a:extLst>
           </p:cNvPr>
@@ -3511,7 +3511,7 @@
                 <a:ea typeface="Aptos"/>
                 <a:cs typeface="Aptos"/>
               </a:rPr>
-              <a:t>656</a:t>
+              <a:t>655</a:t>
             </a:r>
           </a:p>
         </p:txBody>
@@ -3521,7 +3521,7 @@
           <p:cNvPr id="21" name="">
             <a:extLst xmlns:a="http://schemas.openxmlformats.org/drawingml/2006/main">
               <a:ext uri="{FF2B5EF4-FFF2-40B4-BE49-F238E27FC236}">
-                <a16:creationId xmlns:a16="http://schemas.microsoft.com/office/drawing/2014/main" id="{87EFF479-0635-4B10-8BC6-58F3DD9E40D1}"/>
+                <a16:creationId xmlns:a16="http://schemas.microsoft.com/office/drawing/2014/main" id="{BF7C93BA-5D84-4D37-865D-1E66A7B9BF07}"/>
               </a:ext>
             </a:extLst>
           </p:cNvPr>
@@ -3579,7 +3579,7 @@
           <p:cNvPr id="22" name="">
             <a:extLst xmlns:a="http://schemas.openxmlformats.org/drawingml/2006/main">
               <a:ext uri="{FF2B5EF4-FFF2-40B4-BE49-F238E27FC236}">
-                <a16:creationId xmlns:a16="http://schemas.microsoft.com/office/drawing/2014/main" id="{C8EADB0C-6EA1-41A7-B9BE-4C8C7E5606AF}"/>
+                <a16:creationId xmlns:a16="http://schemas.microsoft.com/office/drawing/2014/main" id="{4AD10826-BAE8-455E-B655-26EDEFB0C243}"/>
               </a:ext>
             </a:extLst>
           </p:cNvPr>
@@ -3637,7 +3637,7 @@
           <p:cNvPr id="23" name="">
             <a:extLst xmlns:a="http://schemas.openxmlformats.org/drawingml/2006/main">
               <a:ext uri="{FF2B5EF4-FFF2-40B4-BE49-F238E27FC236}">
-                <a16:creationId xmlns:a16="http://schemas.microsoft.com/office/drawing/2014/main" id="{21BAFEA9-7B8B-4CC0-AA0D-D2EEF3F2F194}"/>
+                <a16:creationId xmlns:a16="http://schemas.microsoft.com/office/drawing/2014/main" id="{3EFCA5C0-C575-4687-A46E-EAAA54291428}"/>
               </a:ext>
             </a:extLst>
           </p:cNvPr>
@@ -3685,7 +3685,7 @@
                 <a:ea typeface="Aptos"/>
                 <a:cs typeface="Aptos"/>
               </a:rPr>
-              <a:t>WATERS NEXT GEN COMPETITIVE INTELLIGENCE · 13 AUG 2026 · waters-ci-20260813070817</a:t>
+              <a:t>WATERS NEXT GEN COMPETITIVE INTELLIGENCE · 17 AUG 2026 · waters-ci-20260817124300</a:t>
             </a:r>
           </a:p>
         </p:txBody>
@@ -3695,7 +3695,7 @@
           <p:cNvPr id="24" name="">
             <a:extLst xmlns:a="http://schemas.openxmlformats.org/drawingml/2006/main">
               <a:ext uri="{FF2B5EF4-FFF2-40B4-BE49-F238E27FC236}">
-                <a16:creationId xmlns:a16="http://schemas.microsoft.com/office/drawing/2014/main" id="{35FABF07-4DF8-4EAA-A6F9-7EA86D79D42F}"/>
+                <a16:creationId xmlns:a16="http://schemas.microsoft.com/office/drawing/2014/main" id="{6C6A9131-B357-4F1B-ADE1-8ECCB01137DE}"/>
               </a:ext>
             </a:extLst>
           </p:cNvPr>
@@ -3751,7 +3751,7 @@
     </p:spTree>
     <p:extLst>
       <p:ext uri="{BB962C8B-B14F-4D97-AF65-F5344CB8AC3E}">
-        <p14:creationId xmlns:p14="http://schemas.microsoft.com/office/powerpoint/2010/main" val="775500096"/>
+        <p14:creationId xmlns:p14="http://schemas.microsoft.com/office/powerpoint/2010/main" val="327133428"/>
       </p:ext>
     </p:extLst>
   </p:cSld>
@@ -3782,7 +3782,7 @@
           <p:cNvPr id="37" name="">
             <a:extLst xmlns:a="http://schemas.openxmlformats.org/drawingml/2006/main">
               <a:ext uri="{FF2B5EF4-FFF2-40B4-BE49-F238E27FC236}">
-                <a16:creationId xmlns:a16="http://schemas.microsoft.com/office/drawing/2014/main" id="{86A10C2A-70AA-4841-8B67-390821515EB0}"/>
+                <a16:creationId xmlns:a16="http://schemas.microsoft.com/office/drawing/2014/main" id="{2E56F7E4-8B86-444D-89D9-B3850D5A4CAE}"/>
               </a:ext>
             </a:extLst>
           </p:cNvPr>
@@ -3840,7 +3840,7 @@
           <p:cNvPr id="2" name="">
             <a:extLst xmlns:a="http://schemas.openxmlformats.org/drawingml/2006/main">
               <a:ext uri="{FF2B5EF4-FFF2-40B4-BE49-F238E27FC236}">
-                <a16:creationId xmlns:a16="http://schemas.microsoft.com/office/drawing/2014/main" id="{9D3EF534-067C-4AF2-B51C-70A9FA840C0E}"/>
+                <a16:creationId xmlns:a16="http://schemas.microsoft.com/office/drawing/2014/main" id="{99EFA815-931F-4FE6-8B2E-1BAE6E224BF7}"/>
               </a:ext>
             </a:extLst>
           </p:cNvPr>
@@ -3898,7 +3898,7 @@
           <p:cNvPr id="3" name="">
             <a:extLst xmlns:a="http://schemas.openxmlformats.org/drawingml/2006/main">
               <a:ext uri="{FF2B5EF4-FFF2-40B4-BE49-F238E27FC236}">
-                <a16:creationId xmlns:a16="http://schemas.microsoft.com/office/drawing/2014/main" id="{32394362-2D32-47DA-B745-DAE618D41A1D}"/>
+                <a16:creationId xmlns:a16="http://schemas.microsoft.com/office/drawing/2014/main" id="{99A934B4-040A-4D32-9B3A-41862F214A78}"/>
               </a:ext>
             </a:extLst>
           </p:cNvPr>
@@ -3956,7 +3956,7 @@
           <p:cNvPr id="4" name="">
             <a:extLst xmlns:a="http://schemas.openxmlformats.org/drawingml/2006/main">
               <a:ext uri="{FF2B5EF4-FFF2-40B4-BE49-F238E27FC236}">
-                <a16:creationId xmlns:a16="http://schemas.microsoft.com/office/drawing/2014/main" id="{577F04DB-73A6-4057-A4D5-AD4DE6B229C6}"/>
+                <a16:creationId xmlns:a16="http://schemas.microsoft.com/office/drawing/2014/main" id="{95FFD659-7DCA-4AB9-8508-46DE2624E1FA}"/>
               </a:ext>
             </a:extLst>
           </p:cNvPr>
@@ -3989,7 +3989,7 @@
           <p:cNvPr id="5" name="">
             <a:extLst xmlns:a="http://schemas.openxmlformats.org/drawingml/2006/main">
               <a:ext uri="{FF2B5EF4-FFF2-40B4-BE49-F238E27FC236}">
-                <a16:creationId xmlns:a16="http://schemas.microsoft.com/office/drawing/2014/main" id="{3FB6A66A-51F5-419A-8FC1-4C99A1546B1D}"/>
+                <a16:creationId xmlns:a16="http://schemas.microsoft.com/office/drawing/2014/main" id="{A2FB579A-E33B-48A5-93B1-9B92B8A2C172}"/>
               </a:ext>
             </a:extLst>
           </p:cNvPr>
@@ -4024,7 +4024,7 @@
           <p:cNvPr id="6" name="">
             <a:extLst xmlns:a="http://schemas.openxmlformats.org/drawingml/2006/main">
               <a:ext uri="{FF2B5EF4-FFF2-40B4-BE49-F238E27FC236}">
-                <a16:creationId xmlns:a16="http://schemas.microsoft.com/office/drawing/2014/main" id="{E9F67CCD-B4A7-4D09-AF99-17F381DF3B73}"/>
+                <a16:creationId xmlns:a16="http://schemas.microsoft.com/office/drawing/2014/main" id="{768C4A1A-F048-4A94-939D-5A0F0EB60394}"/>
               </a:ext>
             </a:extLst>
           </p:cNvPr>
@@ -4059,7 +4059,7 @@
           <p:cNvPr id="7" name="">
             <a:extLst xmlns:a="http://schemas.openxmlformats.org/drawingml/2006/main">
               <a:ext uri="{FF2B5EF4-FFF2-40B4-BE49-F238E27FC236}">
-                <a16:creationId xmlns:a16="http://schemas.microsoft.com/office/drawing/2014/main" id="{AAE413AF-56CB-4067-84EA-B8D921F225FC}"/>
+                <a16:creationId xmlns:a16="http://schemas.microsoft.com/office/drawing/2014/main" id="{4C703075-75FC-47A7-A356-39723158B66B}"/>
               </a:ext>
             </a:extLst>
           </p:cNvPr>
@@ -4117,7 +4117,7 @@
           <p:cNvPr id="8" name="">
             <a:extLst xmlns:a="http://schemas.openxmlformats.org/drawingml/2006/main">
               <a:ext uri="{FF2B5EF4-FFF2-40B4-BE49-F238E27FC236}">
-                <a16:creationId xmlns:a16="http://schemas.microsoft.com/office/drawing/2014/main" id="{F81FEFC9-19A6-46D1-A692-AAF6165E55C3}"/>
+                <a16:creationId xmlns:a16="http://schemas.microsoft.com/office/drawing/2014/main" id="{D875D76C-6037-439A-8C2E-3F7388D51510}"/>
               </a:ext>
             </a:extLst>
           </p:cNvPr>
@@ -4175,7 +4175,7 @@
           <p:cNvPr id="9" name="">
             <a:extLst xmlns:a="http://schemas.openxmlformats.org/drawingml/2006/main">
               <a:ext uri="{FF2B5EF4-FFF2-40B4-BE49-F238E27FC236}">
-                <a16:creationId xmlns:a16="http://schemas.microsoft.com/office/drawing/2014/main" id="{B74E3F14-0A7B-4C58-B919-DF6F8C4AF080}"/>
+                <a16:creationId xmlns:a16="http://schemas.microsoft.com/office/drawing/2014/main" id="{61039203-2420-4CBE-BC01-73BB13977A91}"/>
               </a:ext>
             </a:extLst>
           </p:cNvPr>
@@ -4233,7 +4233,7 @@
           <p:cNvPr id="10" name="">
             <a:extLst xmlns:a="http://schemas.openxmlformats.org/drawingml/2006/main">
               <a:ext uri="{FF2B5EF4-FFF2-40B4-BE49-F238E27FC236}">
-                <a16:creationId xmlns:a16="http://schemas.microsoft.com/office/drawing/2014/main" id="{F7BE98CC-CD20-418B-865C-69212431C3F0}"/>
+                <a16:creationId xmlns:a16="http://schemas.microsoft.com/office/drawing/2014/main" id="{E464C584-D687-4E9A-A0B1-F6B8071CB290}"/>
               </a:ext>
             </a:extLst>
           </p:cNvPr>
@@ -4281,7 +4281,7 @@
                 <a:ea typeface="Aptos"/>
                 <a:cs typeface="Aptos"/>
               </a:rPr>
-              <a:t>335 records from the canonical PubMed query.</a:t>
+              <a:t>336 records from the canonical PubMed query.</a:t>
             </a:r>
           </a:p>
         </p:txBody>
@@ -4291,7 +4291,7 @@
           <p:cNvPr id="11" name="">
             <a:extLst xmlns:a="http://schemas.openxmlformats.org/drawingml/2006/main">
               <a:ext uri="{FF2B5EF4-FFF2-40B4-BE49-F238E27FC236}">
-                <a16:creationId xmlns:a16="http://schemas.microsoft.com/office/drawing/2014/main" id="{CD600435-2BF9-4C82-A42C-D73C54E4B1DC}"/>
+                <a16:creationId xmlns:a16="http://schemas.microsoft.com/office/drawing/2014/main" id="{AD041166-717D-4D34-8C21-23AD4C2E0F4D}"/>
               </a:ext>
             </a:extLst>
           </p:cNvPr>
@@ -4326,7 +4326,7 @@
           <p:cNvPr id="12" name="">
             <a:extLst xmlns:a="http://schemas.openxmlformats.org/drawingml/2006/main">
               <a:ext uri="{FF2B5EF4-FFF2-40B4-BE49-F238E27FC236}">
-                <a16:creationId xmlns:a16="http://schemas.microsoft.com/office/drawing/2014/main" id="{7EAAB9CA-7E88-48AE-B2FF-8769912C4FDA}"/>
+                <a16:creationId xmlns:a16="http://schemas.microsoft.com/office/drawing/2014/main" id="{2E908071-D6DD-4B79-92C2-D8172937D9D3}"/>
               </a:ext>
             </a:extLst>
           </p:cNvPr>
@@ -4361,7 +4361,7 @@
           <p:cNvPr id="13" name="">
             <a:extLst xmlns:a="http://schemas.openxmlformats.org/drawingml/2006/main">
               <a:ext uri="{FF2B5EF4-FFF2-40B4-BE49-F238E27FC236}">
-                <a16:creationId xmlns:a16="http://schemas.microsoft.com/office/drawing/2014/main" id="{DA4E4021-94A5-4B6D-A165-4CB0517451CF}"/>
+                <a16:creationId xmlns:a16="http://schemas.microsoft.com/office/drawing/2014/main" id="{CF555971-2212-4EFD-BE9E-5EBC2B9E17EC}"/>
               </a:ext>
             </a:extLst>
           </p:cNvPr>
@@ -4419,7 +4419,7 @@
           <p:cNvPr id="14" name="">
             <a:extLst xmlns:a="http://schemas.openxmlformats.org/drawingml/2006/main">
               <a:ext uri="{FF2B5EF4-FFF2-40B4-BE49-F238E27FC236}">
-                <a16:creationId xmlns:a16="http://schemas.microsoft.com/office/drawing/2014/main" id="{678A89FE-FF23-43CD-8180-9BD9830AF546}"/>
+                <a16:creationId xmlns:a16="http://schemas.microsoft.com/office/drawing/2014/main" id="{37F36D55-BC4D-43BA-AC25-17110EBBCF67}"/>
               </a:ext>
             </a:extLst>
           </p:cNvPr>
@@ -4477,7 +4477,7 @@
           <p:cNvPr id="15" name="">
             <a:extLst xmlns:a="http://schemas.openxmlformats.org/drawingml/2006/main">
               <a:ext uri="{FF2B5EF4-FFF2-40B4-BE49-F238E27FC236}">
-                <a16:creationId xmlns:a16="http://schemas.microsoft.com/office/drawing/2014/main" id="{3404B907-9B5A-4804-B5D4-2E9333DBF81D}"/>
+                <a16:creationId xmlns:a16="http://schemas.microsoft.com/office/drawing/2014/main" id="{9B2E4770-D0EA-42F5-A9E1-8D762311CBD5}"/>
               </a:ext>
             </a:extLst>
           </p:cNvPr>
@@ -4535,7 +4535,7 @@
           <p:cNvPr id="16" name="">
             <a:extLst xmlns:a="http://schemas.openxmlformats.org/drawingml/2006/main">
               <a:ext uri="{FF2B5EF4-FFF2-40B4-BE49-F238E27FC236}">
-                <a16:creationId xmlns:a16="http://schemas.microsoft.com/office/drawing/2014/main" id="{FEFA52B2-8805-4582-93E1-6409A68B633A}"/>
+                <a16:creationId xmlns:a16="http://schemas.microsoft.com/office/drawing/2014/main" id="{9213B2F3-EF41-4BBB-8202-75AFA698E82C}"/>
               </a:ext>
             </a:extLst>
           </p:cNvPr>
@@ -4593,7 +4593,7 @@
           <p:cNvPr id="17" name="">
             <a:extLst xmlns:a="http://schemas.openxmlformats.org/drawingml/2006/main">
               <a:ext uri="{FF2B5EF4-FFF2-40B4-BE49-F238E27FC236}">
-                <a16:creationId xmlns:a16="http://schemas.microsoft.com/office/drawing/2014/main" id="{FB3A4457-B8BF-4A07-AE45-6B87596EFA06}"/>
+                <a16:creationId xmlns:a16="http://schemas.microsoft.com/office/drawing/2014/main" id="{25A7EDFF-1B88-4774-BB11-8D95A73FC481}"/>
               </a:ext>
             </a:extLst>
           </p:cNvPr>
@@ -4628,7 +4628,7 @@
           <p:cNvPr id="18" name="">
             <a:extLst xmlns:a="http://schemas.openxmlformats.org/drawingml/2006/main">
               <a:ext uri="{FF2B5EF4-FFF2-40B4-BE49-F238E27FC236}">
-                <a16:creationId xmlns:a16="http://schemas.microsoft.com/office/drawing/2014/main" id="{6B317260-6072-4D6E-A235-8B1F31EEF452}"/>
+                <a16:creationId xmlns:a16="http://schemas.microsoft.com/office/drawing/2014/main" id="{3D528EC4-D6FF-4C3C-A1FE-CB12B8FA1718}"/>
               </a:ext>
             </a:extLst>
           </p:cNvPr>
@@ -4663,7 +4663,7 @@
           <p:cNvPr id="19" name="">
             <a:extLst xmlns:a="http://schemas.openxmlformats.org/drawingml/2006/main">
               <a:ext uri="{FF2B5EF4-FFF2-40B4-BE49-F238E27FC236}">
-                <a16:creationId xmlns:a16="http://schemas.microsoft.com/office/drawing/2014/main" id="{981ED18C-C447-4F39-B9DF-261270CC8552}"/>
+                <a16:creationId xmlns:a16="http://schemas.microsoft.com/office/drawing/2014/main" id="{D8E6FF9E-E5BE-40CC-8B11-19953F05EAF8}"/>
               </a:ext>
             </a:extLst>
           </p:cNvPr>
@@ -4721,7 +4721,7 @@
           <p:cNvPr id="20" name="">
             <a:extLst xmlns:a="http://schemas.openxmlformats.org/drawingml/2006/main">
               <a:ext uri="{FF2B5EF4-FFF2-40B4-BE49-F238E27FC236}">
-                <a16:creationId xmlns:a16="http://schemas.microsoft.com/office/drawing/2014/main" id="{8074F3A0-A4ED-4DCE-A3FC-053911276C34}"/>
+                <a16:creationId xmlns:a16="http://schemas.microsoft.com/office/drawing/2014/main" id="{133F2FAF-3CCF-435B-8E3D-86B155146FA9}"/>
               </a:ext>
             </a:extLst>
           </p:cNvPr>
@@ -4779,7 +4779,7 @@
           <p:cNvPr id="21" name="">
             <a:extLst xmlns:a="http://schemas.openxmlformats.org/drawingml/2006/main">
               <a:ext uri="{FF2B5EF4-FFF2-40B4-BE49-F238E27FC236}">
-                <a16:creationId xmlns:a16="http://schemas.microsoft.com/office/drawing/2014/main" id="{D82AA76A-46D3-46F2-B5A3-940C72596A53}"/>
+                <a16:creationId xmlns:a16="http://schemas.microsoft.com/office/drawing/2014/main" id="{45CD94B3-E2BA-4B5A-B73F-FBC1C2B6AA81}"/>
               </a:ext>
             </a:extLst>
           </p:cNvPr>
@@ -4837,7 +4837,7 @@
           <p:cNvPr id="22" name="">
             <a:extLst xmlns:a="http://schemas.openxmlformats.org/drawingml/2006/main">
               <a:ext uri="{FF2B5EF4-FFF2-40B4-BE49-F238E27FC236}">
-                <a16:creationId xmlns:a16="http://schemas.microsoft.com/office/drawing/2014/main" id="{2F90D2AE-4808-4F96-BDC2-FD039ACE828A}"/>
+                <a16:creationId xmlns:a16="http://schemas.microsoft.com/office/drawing/2014/main" id="{60279F59-BCFE-4BF4-868C-5ECAF80E7212}"/>
               </a:ext>
             </a:extLst>
           </p:cNvPr>
@@ -4895,7 +4895,7 @@
           <p:cNvPr id="23" name="">
             <a:extLst xmlns:a="http://schemas.openxmlformats.org/drawingml/2006/main">
               <a:ext uri="{FF2B5EF4-FFF2-40B4-BE49-F238E27FC236}">
-                <a16:creationId xmlns:a16="http://schemas.microsoft.com/office/drawing/2014/main" id="{FFB68D3A-8ED3-4953-BE33-9DDF9706CDD6}"/>
+                <a16:creationId xmlns:a16="http://schemas.microsoft.com/office/drawing/2014/main" id="{FA888E17-3B3C-4109-B7DF-CEF9214294FD}"/>
               </a:ext>
             </a:extLst>
           </p:cNvPr>
@@ -4930,7 +4930,7 @@
           <p:cNvPr id="24" name="">
             <a:extLst xmlns:a="http://schemas.openxmlformats.org/drawingml/2006/main">
               <a:ext uri="{FF2B5EF4-FFF2-40B4-BE49-F238E27FC236}">
-                <a16:creationId xmlns:a16="http://schemas.microsoft.com/office/drawing/2014/main" id="{87A579D7-30CE-443A-B3FA-EDBF0B8297EE}"/>
+                <a16:creationId xmlns:a16="http://schemas.microsoft.com/office/drawing/2014/main" id="{A1D5314F-2BC6-43E2-9642-59813168330D}"/>
               </a:ext>
             </a:extLst>
           </p:cNvPr>
@@ -4965,7 +4965,7 @@
           <p:cNvPr id="25" name="">
             <a:extLst xmlns:a="http://schemas.openxmlformats.org/drawingml/2006/main">
               <a:ext uri="{FF2B5EF4-FFF2-40B4-BE49-F238E27FC236}">
-                <a16:creationId xmlns:a16="http://schemas.microsoft.com/office/drawing/2014/main" id="{E273B36B-DB5B-4ED2-AF18-B55814E2F230}"/>
+                <a16:creationId xmlns:a16="http://schemas.microsoft.com/office/drawing/2014/main" id="{B229A7F3-58D4-41C2-9166-C0612DF15D0D}"/>
               </a:ext>
             </a:extLst>
           </p:cNvPr>
@@ -5023,7 +5023,7 @@
           <p:cNvPr id="26" name="">
             <a:extLst xmlns:a="http://schemas.openxmlformats.org/drawingml/2006/main">
               <a:ext uri="{FF2B5EF4-FFF2-40B4-BE49-F238E27FC236}">
-                <a16:creationId xmlns:a16="http://schemas.microsoft.com/office/drawing/2014/main" id="{82BDE4C3-E0DC-47C3-A516-9F8C2AE6F826}"/>
+                <a16:creationId xmlns:a16="http://schemas.microsoft.com/office/drawing/2014/main" id="{3D31D0CF-E355-4D20-A432-4BE707BFC98C}"/>
               </a:ext>
             </a:extLst>
           </p:cNvPr>
@@ -5081,7 +5081,7 @@
           <p:cNvPr id="27" name="">
             <a:extLst xmlns:a="http://schemas.openxmlformats.org/drawingml/2006/main">
               <a:ext uri="{FF2B5EF4-FFF2-40B4-BE49-F238E27FC236}">
-                <a16:creationId xmlns:a16="http://schemas.microsoft.com/office/drawing/2014/main" id="{7E3B62DC-E657-4C9A-82D8-1422D2D8213D}"/>
+                <a16:creationId xmlns:a16="http://schemas.microsoft.com/office/drawing/2014/main" id="{E5300784-2781-48C1-83F6-5C6107E32FE9}"/>
               </a:ext>
             </a:extLst>
           </p:cNvPr>
@@ -5139,7 +5139,7 @@
           <p:cNvPr id="28" name="">
             <a:extLst xmlns:a="http://schemas.openxmlformats.org/drawingml/2006/main">
               <a:ext uri="{FF2B5EF4-FFF2-40B4-BE49-F238E27FC236}">
-                <a16:creationId xmlns:a16="http://schemas.microsoft.com/office/drawing/2014/main" id="{5101D934-49F8-4ECE-A9FD-CA66E4613C53}"/>
+                <a16:creationId xmlns:a16="http://schemas.microsoft.com/office/drawing/2014/main" id="{20F1019A-6648-4396-B544-5A1E7E697018}"/>
               </a:ext>
             </a:extLst>
           </p:cNvPr>
@@ -5197,7 +5197,7 @@
           <p:cNvPr id="29" name="">
             <a:extLst xmlns:a="http://schemas.openxmlformats.org/drawingml/2006/main">
               <a:ext uri="{FF2B5EF4-FFF2-40B4-BE49-F238E27FC236}">
-                <a16:creationId xmlns:a16="http://schemas.microsoft.com/office/drawing/2014/main" id="{C7B3F5BF-E7A0-4894-A99E-6F6320AEFA37}"/>
+                <a16:creationId xmlns:a16="http://schemas.microsoft.com/office/drawing/2014/main" id="{6A58DD3F-2C15-4D8B-95A5-0F01BAA74099}"/>
               </a:ext>
             </a:extLst>
           </p:cNvPr>
@@ -5232,7 +5232,7 @@
           <p:cNvPr id="30" name="">
             <a:extLst xmlns:a="http://schemas.openxmlformats.org/drawingml/2006/main">
               <a:ext uri="{FF2B5EF4-FFF2-40B4-BE49-F238E27FC236}">
-                <a16:creationId xmlns:a16="http://schemas.microsoft.com/office/drawing/2014/main" id="{726ECCAC-B251-415D-A6AD-29856AD53381}"/>
+                <a16:creationId xmlns:a16="http://schemas.microsoft.com/office/drawing/2014/main" id="{EC157395-DB6D-4E9B-BED4-2578B192919D}"/>
               </a:ext>
             </a:extLst>
           </p:cNvPr>
@@ -5267,7 +5267,7 @@
           <p:cNvPr id="31" name="">
             <a:extLst xmlns:a="http://schemas.openxmlformats.org/drawingml/2006/main">
               <a:ext uri="{FF2B5EF4-FFF2-40B4-BE49-F238E27FC236}">
-                <a16:creationId xmlns:a16="http://schemas.microsoft.com/office/drawing/2014/main" id="{934BAED4-6956-4CA7-B93F-E120922A220C}"/>
+                <a16:creationId xmlns:a16="http://schemas.microsoft.com/office/drawing/2014/main" id="{BD02D834-C296-4383-9E84-99E329AAC9A8}"/>
               </a:ext>
             </a:extLst>
           </p:cNvPr>
@@ -5325,7 +5325,7 @@
           <p:cNvPr id="32" name="">
             <a:extLst xmlns:a="http://schemas.openxmlformats.org/drawingml/2006/main">
               <a:ext uri="{FF2B5EF4-FFF2-40B4-BE49-F238E27FC236}">
-                <a16:creationId xmlns:a16="http://schemas.microsoft.com/office/drawing/2014/main" id="{DECA2A91-892E-4B6C-B6E3-ECAD62B7A933}"/>
+                <a16:creationId xmlns:a16="http://schemas.microsoft.com/office/drawing/2014/main" id="{EC0FFB8C-EDCE-4469-A431-B50B30322D34}"/>
               </a:ext>
             </a:extLst>
           </p:cNvPr>
@@ -5383,7 +5383,7 @@
           <p:cNvPr id="33" name="">
             <a:extLst xmlns:a="http://schemas.openxmlformats.org/drawingml/2006/main">
               <a:ext uri="{FF2B5EF4-FFF2-40B4-BE49-F238E27FC236}">
-                <a16:creationId xmlns:a16="http://schemas.microsoft.com/office/drawing/2014/main" id="{5C2BC6CB-9D9D-427D-9D16-588D0B1991F3}"/>
+                <a16:creationId xmlns:a16="http://schemas.microsoft.com/office/drawing/2014/main" id="{F63A9DC7-F565-427F-9B6B-2075F5D9BFA3}"/>
               </a:ext>
             </a:extLst>
           </p:cNvPr>
@@ -5441,7 +5441,7 @@
           <p:cNvPr id="34" name="">
             <a:extLst xmlns:a="http://schemas.openxmlformats.org/drawingml/2006/main">
               <a:ext uri="{FF2B5EF4-FFF2-40B4-BE49-F238E27FC236}">
-                <a16:creationId xmlns:a16="http://schemas.microsoft.com/office/drawing/2014/main" id="{2F7BC65C-A5CD-47D1-91F9-E0EFF9D55162}"/>
+                <a16:creationId xmlns:a16="http://schemas.microsoft.com/office/drawing/2014/main" id="{C70F1241-2781-42F9-BD7D-F9103BE414B7}"/>
               </a:ext>
             </a:extLst>
           </p:cNvPr>
@@ -5499,7 +5499,7 @@
           <p:cNvPr id="35" name="">
             <a:extLst xmlns:a="http://schemas.openxmlformats.org/drawingml/2006/main">
               <a:ext uri="{FF2B5EF4-FFF2-40B4-BE49-F238E27FC236}">
-                <a16:creationId xmlns:a16="http://schemas.microsoft.com/office/drawing/2014/main" id="{BF99EE76-7CFA-469F-890D-8AA94A5AFE94}"/>
+                <a16:creationId xmlns:a16="http://schemas.microsoft.com/office/drawing/2014/main" id="{E0964E61-1AC0-4FC5-9F89-45757FB19E81}"/>
               </a:ext>
             </a:extLst>
           </p:cNvPr>
@@ -5547,7 +5547,7 @@
                 <a:ea typeface="Aptos"/>
                 <a:cs typeface="Aptos"/>
               </a:rPr>
-              <a:t>WATERS NEXT GEN COMPETITIVE INTELLIGENCE · 13 AUG 2026 · waters-ci-20260813070817</a:t>
+              <a:t>WATERS NEXT GEN COMPETITIVE INTELLIGENCE · 17 AUG 2026 · waters-ci-20260817124300</a:t>
             </a:r>
           </a:p>
         </p:txBody>
@@ -5557,7 +5557,7 @@
           <p:cNvPr id="36" name="">
             <a:extLst xmlns:a="http://schemas.openxmlformats.org/drawingml/2006/main">
               <a:ext uri="{FF2B5EF4-FFF2-40B4-BE49-F238E27FC236}">
-                <a16:creationId xmlns:a16="http://schemas.microsoft.com/office/drawing/2014/main" id="{B20DB7BD-7860-4027-B571-63E618CEA09F}"/>
+                <a16:creationId xmlns:a16="http://schemas.microsoft.com/office/drawing/2014/main" id="{77B705F1-0095-4FED-8631-421BC4623950}"/>
               </a:ext>
             </a:extLst>
           </p:cNvPr>
@@ -5613,7 +5613,7 @@
     </p:spTree>
     <p:extLst>
       <p:ext uri="{BB962C8B-B14F-4D97-AF65-F5344CB8AC3E}">
-        <p14:creationId xmlns:p14="http://schemas.microsoft.com/office/powerpoint/2010/main" val="138632279"/>
+        <p14:creationId xmlns:p14="http://schemas.microsoft.com/office/powerpoint/2010/main" val="906120089"/>
       </p:ext>
     </p:extLst>
   </p:cSld>
@@ -5644,7 +5644,7 @@
           <p:cNvPr id="31" name="">
             <a:extLst xmlns:a="http://schemas.openxmlformats.org/drawingml/2006/main">
               <a:ext uri="{FF2B5EF4-FFF2-40B4-BE49-F238E27FC236}">
-                <a16:creationId xmlns:a16="http://schemas.microsoft.com/office/drawing/2014/main" id="{7E29194F-892A-47BC-9688-C72CD7018C90}"/>
+                <a16:creationId xmlns:a16="http://schemas.microsoft.com/office/drawing/2014/main" id="{F8C58079-E60A-42BB-963C-A7299855345A}"/>
               </a:ext>
             </a:extLst>
           </p:cNvPr>
@@ -5702,7 +5702,7 @@
           <p:cNvPr id="2" name="">
             <a:extLst xmlns:a="http://schemas.openxmlformats.org/drawingml/2006/main">
               <a:ext uri="{FF2B5EF4-FFF2-40B4-BE49-F238E27FC236}">
-                <a16:creationId xmlns:a16="http://schemas.microsoft.com/office/drawing/2014/main" id="{4C4C52FF-E4AF-4183-BABE-CA1E8C0A85BE}"/>
+                <a16:creationId xmlns:a16="http://schemas.microsoft.com/office/drawing/2014/main" id="{15CF73F5-20FE-4A79-9D02-ACFFB8A565B2}"/>
               </a:ext>
             </a:extLst>
           </p:cNvPr>
@@ -5760,7 +5760,7 @@
           <p:cNvPr id="3" name="">
             <a:extLst xmlns:a="http://schemas.openxmlformats.org/drawingml/2006/main">
               <a:ext uri="{FF2B5EF4-FFF2-40B4-BE49-F238E27FC236}">
-                <a16:creationId xmlns:a16="http://schemas.microsoft.com/office/drawing/2014/main" id="{B8069645-CABD-4F9D-AAA0-6BAE9F3056C1}"/>
+                <a16:creationId xmlns:a16="http://schemas.microsoft.com/office/drawing/2014/main" id="{3E7CB3EB-C6FB-43B7-BDE9-5C115EC66AA1}"/>
               </a:ext>
             </a:extLst>
           </p:cNvPr>
@@ -5818,7 +5818,7 @@
           <p:cNvPr id="4" name="">
             <a:extLst xmlns:a="http://schemas.openxmlformats.org/drawingml/2006/main">
               <a:ext uri="{FF2B5EF4-FFF2-40B4-BE49-F238E27FC236}">
-                <a16:creationId xmlns:a16="http://schemas.microsoft.com/office/drawing/2014/main" id="{C8A89B46-F9FD-436D-BC07-824262DB8213}"/>
+                <a16:creationId xmlns:a16="http://schemas.microsoft.com/office/drawing/2014/main" id="{F4C16FE5-BAC0-4A06-8B7E-CB5F69D00FCF}"/>
               </a:ext>
             </a:extLst>
           </p:cNvPr>
@@ -5851,7 +5851,7 @@
           <p:cNvPr id="5" name="">
             <a:extLst xmlns:a="http://schemas.openxmlformats.org/drawingml/2006/main">
               <a:ext uri="{FF2B5EF4-FFF2-40B4-BE49-F238E27FC236}">
-                <a16:creationId xmlns:a16="http://schemas.microsoft.com/office/drawing/2014/main" id="{C0412B42-329F-4418-B8BF-04ACE423042B}"/>
+                <a16:creationId xmlns:a16="http://schemas.microsoft.com/office/drawing/2014/main" id="{33943C41-756A-48CF-9A36-83F04871C137}"/>
               </a:ext>
             </a:extLst>
           </p:cNvPr>
@@ -5886,7 +5886,7 @@
           <p:cNvPr id="6" name="">
             <a:extLst xmlns:a="http://schemas.openxmlformats.org/drawingml/2006/main">
               <a:ext uri="{FF2B5EF4-FFF2-40B4-BE49-F238E27FC236}">
-                <a16:creationId xmlns:a16="http://schemas.microsoft.com/office/drawing/2014/main" id="{DC21B0DE-DEB0-4ED4-B3E9-B496A9F40D50}"/>
+                <a16:creationId xmlns:a16="http://schemas.microsoft.com/office/drawing/2014/main" id="{D87DE794-8B4A-4637-8757-ECBDE29ACE03}"/>
               </a:ext>
             </a:extLst>
           </p:cNvPr>
@@ -5919,7 +5919,7 @@
           <p:cNvPr id="7" name="">
             <a:extLst xmlns:a="http://schemas.openxmlformats.org/drawingml/2006/main">
               <a:ext uri="{FF2B5EF4-FFF2-40B4-BE49-F238E27FC236}">
-                <a16:creationId xmlns:a16="http://schemas.microsoft.com/office/drawing/2014/main" id="{3F2ACA6B-2FEC-41A6-A620-C9FC5065699F}"/>
+                <a16:creationId xmlns:a16="http://schemas.microsoft.com/office/drawing/2014/main" id="{3DB79A4C-A07B-4364-A1F8-49ED2DE7970F}"/>
               </a:ext>
             </a:extLst>
           </p:cNvPr>
@@ -5977,7 +5977,7 @@
           <p:cNvPr id="8" name="">
             <a:extLst xmlns:a="http://schemas.openxmlformats.org/drawingml/2006/main">
               <a:ext uri="{FF2B5EF4-FFF2-40B4-BE49-F238E27FC236}">
-                <a16:creationId xmlns:a16="http://schemas.microsoft.com/office/drawing/2014/main" id="{280793D5-3B90-4CC1-91CA-059B5C695797}"/>
+                <a16:creationId xmlns:a16="http://schemas.microsoft.com/office/drawing/2014/main" id="{3FC25C05-E85B-44AC-B129-07B16BE8D391}"/>
               </a:ext>
             </a:extLst>
           </p:cNvPr>
@@ -6035,7 +6035,7 @@
           <p:cNvPr id="9" name="">
             <a:extLst xmlns:a="http://schemas.openxmlformats.org/drawingml/2006/main">
               <a:ext uri="{FF2B5EF4-FFF2-40B4-BE49-F238E27FC236}">
-                <a16:creationId xmlns:a16="http://schemas.microsoft.com/office/drawing/2014/main" id="{DDB31615-627C-4199-AA5E-D4F3B416A7D2}"/>
+                <a16:creationId xmlns:a16="http://schemas.microsoft.com/office/drawing/2014/main" id="{16647CDA-1239-47B4-89BA-FC38B04A1C85}"/>
               </a:ext>
             </a:extLst>
           </p:cNvPr>
@@ -6093,7 +6093,7 @@
           <p:cNvPr id="10" name="">
             <a:extLst xmlns:a="http://schemas.openxmlformats.org/drawingml/2006/main">
               <a:ext uri="{FF2B5EF4-FFF2-40B4-BE49-F238E27FC236}">
-                <a16:creationId xmlns:a16="http://schemas.microsoft.com/office/drawing/2014/main" id="{E819C7F8-C1D8-41EE-AB5D-649CCFE3B55F}"/>
+                <a16:creationId xmlns:a16="http://schemas.microsoft.com/office/drawing/2014/main" id="{3486CFD1-A653-45BF-9DD3-5959B856C90A}"/>
               </a:ext>
             </a:extLst>
           </p:cNvPr>
@@ -6151,7 +6151,7 @@
           <p:cNvPr id="11" name="">
             <a:extLst xmlns:a="http://schemas.openxmlformats.org/drawingml/2006/main">
               <a:ext uri="{FF2B5EF4-FFF2-40B4-BE49-F238E27FC236}">
-                <a16:creationId xmlns:a16="http://schemas.microsoft.com/office/drawing/2014/main" id="{15085620-8AAA-45CB-8E7B-D8C6684E0E4E}"/>
+                <a16:creationId xmlns:a16="http://schemas.microsoft.com/office/drawing/2014/main" id="{46754B50-91E6-48B2-BB17-DCCCC5FB1E92}"/>
               </a:ext>
             </a:extLst>
           </p:cNvPr>
@@ -6186,7 +6186,7 @@
           <p:cNvPr id="12" name="">
             <a:extLst xmlns:a="http://schemas.openxmlformats.org/drawingml/2006/main">
               <a:ext uri="{FF2B5EF4-FFF2-40B4-BE49-F238E27FC236}">
-                <a16:creationId xmlns:a16="http://schemas.microsoft.com/office/drawing/2014/main" id="{C48AF58E-63EB-418D-9530-F226A8BB6BE7}"/>
+                <a16:creationId xmlns:a16="http://schemas.microsoft.com/office/drawing/2014/main" id="{DC364B4A-5DF0-41FC-913C-E1A740B3A58E}"/>
               </a:ext>
             </a:extLst>
           </p:cNvPr>
@@ -6219,7 +6219,7 @@
           <p:cNvPr id="13" name="">
             <a:extLst xmlns:a="http://schemas.openxmlformats.org/drawingml/2006/main">
               <a:ext uri="{FF2B5EF4-FFF2-40B4-BE49-F238E27FC236}">
-                <a16:creationId xmlns:a16="http://schemas.microsoft.com/office/drawing/2014/main" id="{D8B0D123-918B-4665-9BA5-40FCE3DF43D8}"/>
+                <a16:creationId xmlns:a16="http://schemas.microsoft.com/office/drawing/2014/main" id="{8B3FF07D-ADF4-467D-BBA7-88367878986B}"/>
               </a:ext>
             </a:extLst>
           </p:cNvPr>
@@ -6277,7 +6277,7 @@
           <p:cNvPr id="14" name="">
             <a:extLst xmlns:a="http://schemas.openxmlformats.org/drawingml/2006/main">
               <a:ext uri="{FF2B5EF4-FFF2-40B4-BE49-F238E27FC236}">
-                <a16:creationId xmlns:a16="http://schemas.microsoft.com/office/drawing/2014/main" id="{F0CE004D-DAE5-4C4C-9664-14ED2D79428B}"/>
+                <a16:creationId xmlns:a16="http://schemas.microsoft.com/office/drawing/2014/main" id="{164012EB-678C-4F30-9270-745F9449A5F8}"/>
               </a:ext>
             </a:extLst>
           </p:cNvPr>
@@ -6335,7 +6335,7 @@
           <p:cNvPr id="15" name="">
             <a:extLst xmlns:a="http://schemas.openxmlformats.org/drawingml/2006/main">
               <a:ext uri="{FF2B5EF4-FFF2-40B4-BE49-F238E27FC236}">
-                <a16:creationId xmlns:a16="http://schemas.microsoft.com/office/drawing/2014/main" id="{964F3BB1-B7CA-412B-B4A2-599D5969BB86}"/>
+                <a16:creationId xmlns:a16="http://schemas.microsoft.com/office/drawing/2014/main" id="{BC34A706-A6B4-4B65-BE77-B4396C1A49E0}"/>
               </a:ext>
             </a:extLst>
           </p:cNvPr>
@@ -6393,7 +6393,7 @@
           <p:cNvPr id="16" name="">
             <a:extLst xmlns:a="http://schemas.openxmlformats.org/drawingml/2006/main">
               <a:ext uri="{FF2B5EF4-FFF2-40B4-BE49-F238E27FC236}">
-                <a16:creationId xmlns:a16="http://schemas.microsoft.com/office/drawing/2014/main" id="{EFC9BD31-09C4-4442-9E6D-E3E6507946B4}"/>
+                <a16:creationId xmlns:a16="http://schemas.microsoft.com/office/drawing/2014/main" id="{9744671E-DAF4-499F-A269-23C3638CC0EC}"/>
               </a:ext>
             </a:extLst>
           </p:cNvPr>
@@ -6451,7 +6451,7 @@
           <p:cNvPr id="17" name="">
             <a:extLst xmlns:a="http://schemas.openxmlformats.org/drawingml/2006/main">
               <a:ext uri="{FF2B5EF4-FFF2-40B4-BE49-F238E27FC236}">
-                <a16:creationId xmlns:a16="http://schemas.microsoft.com/office/drawing/2014/main" id="{61BA03A1-BFD9-4AFD-AF66-80318C218D32}"/>
+                <a16:creationId xmlns:a16="http://schemas.microsoft.com/office/drawing/2014/main" id="{0F15A82A-25E7-4DC5-8574-ACF40C66206E}"/>
               </a:ext>
             </a:extLst>
           </p:cNvPr>
@@ -6486,7 +6486,7 @@
           <p:cNvPr id="18" name="">
             <a:extLst xmlns:a="http://schemas.openxmlformats.org/drawingml/2006/main">
               <a:ext uri="{FF2B5EF4-FFF2-40B4-BE49-F238E27FC236}">
-                <a16:creationId xmlns:a16="http://schemas.microsoft.com/office/drawing/2014/main" id="{FD59D8D7-96A5-435B-A9FB-C851742EFC32}"/>
+                <a16:creationId xmlns:a16="http://schemas.microsoft.com/office/drawing/2014/main" id="{91CC4ACE-F0F1-4235-819B-FACF0A67E784}"/>
               </a:ext>
             </a:extLst>
           </p:cNvPr>
@@ -6519,7 +6519,7 @@
           <p:cNvPr id="19" name="">
             <a:extLst xmlns:a="http://schemas.openxmlformats.org/drawingml/2006/main">
               <a:ext uri="{FF2B5EF4-FFF2-40B4-BE49-F238E27FC236}">
-                <a16:creationId xmlns:a16="http://schemas.microsoft.com/office/drawing/2014/main" id="{0381B156-3FEE-4313-8DA0-1F273962E780}"/>
+                <a16:creationId xmlns:a16="http://schemas.microsoft.com/office/drawing/2014/main" id="{8843F08B-FF4C-44CC-A429-3664DB7040D3}"/>
               </a:ext>
             </a:extLst>
           </p:cNvPr>
@@ -6577,7 +6577,7 @@
           <p:cNvPr id="20" name="">
             <a:extLst xmlns:a="http://schemas.openxmlformats.org/drawingml/2006/main">
               <a:ext uri="{FF2B5EF4-FFF2-40B4-BE49-F238E27FC236}">
-                <a16:creationId xmlns:a16="http://schemas.microsoft.com/office/drawing/2014/main" id="{2865E709-40B5-4F66-B7FA-56BCBD98A84A}"/>
+                <a16:creationId xmlns:a16="http://schemas.microsoft.com/office/drawing/2014/main" id="{6BDF565E-674B-43BE-9503-7968C28EB1F8}"/>
               </a:ext>
             </a:extLst>
           </p:cNvPr>
@@ -6635,7 +6635,7 @@
           <p:cNvPr id="21" name="">
             <a:extLst xmlns:a="http://schemas.openxmlformats.org/drawingml/2006/main">
               <a:ext uri="{FF2B5EF4-FFF2-40B4-BE49-F238E27FC236}">
-                <a16:creationId xmlns:a16="http://schemas.microsoft.com/office/drawing/2014/main" id="{314B46F2-0F15-417D-AE94-5F3A91EDB7C2}"/>
+                <a16:creationId xmlns:a16="http://schemas.microsoft.com/office/drawing/2014/main" id="{04EAC7E5-1AEF-4B53-B10B-1E92AFF7B90A}"/>
               </a:ext>
             </a:extLst>
           </p:cNvPr>
@@ -6693,7 +6693,7 @@
           <p:cNvPr id="22" name="">
             <a:extLst xmlns:a="http://schemas.openxmlformats.org/drawingml/2006/main">
               <a:ext uri="{FF2B5EF4-FFF2-40B4-BE49-F238E27FC236}">
-                <a16:creationId xmlns:a16="http://schemas.microsoft.com/office/drawing/2014/main" id="{204B4EC3-0DDD-4CBD-A701-9E58A95AA772}"/>
+                <a16:creationId xmlns:a16="http://schemas.microsoft.com/office/drawing/2014/main" id="{C66D1C91-8F83-4648-8D96-D93E2D1CED44}"/>
               </a:ext>
             </a:extLst>
           </p:cNvPr>
@@ -6751,7 +6751,7 @@
           <p:cNvPr id="23" name="">
             <a:extLst xmlns:a="http://schemas.openxmlformats.org/drawingml/2006/main">
               <a:ext uri="{FF2B5EF4-FFF2-40B4-BE49-F238E27FC236}">
-                <a16:creationId xmlns:a16="http://schemas.microsoft.com/office/drawing/2014/main" id="{B898E5D0-2483-43C5-A8B0-A3F30E6669F3}"/>
+                <a16:creationId xmlns:a16="http://schemas.microsoft.com/office/drawing/2014/main" id="{C1EB3929-CEB0-491B-A6C1-8B6173BB0550}"/>
               </a:ext>
             </a:extLst>
           </p:cNvPr>
@@ -6786,7 +6786,7 @@
           <p:cNvPr id="24" name="">
             <a:extLst xmlns:a="http://schemas.openxmlformats.org/drawingml/2006/main">
               <a:ext uri="{FF2B5EF4-FFF2-40B4-BE49-F238E27FC236}">
-                <a16:creationId xmlns:a16="http://schemas.microsoft.com/office/drawing/2014/main" id="{F443B792-569F-4469-B7E8-36F917EA31CF}"/>
+                <a16:creationId xmlns:a16="http://schemas.microsoft.com/office/drawing/2014/main" id="{33A88D4E-99F8-4403-8924-509C30D97BC3}"/>
               </a:ext>
             </a:extLst>
           </p:cNvPr>
@@ -6819,7 +6819,7 @@
           <p:cNvPr id="25" name="">
             <a:extLst xmlns:a="http://schemas.openxmlformats.org/drawingml/2006/main">
               <a:ext uri="{FF2B5EF4-FFF2-40B4-BE49-F238E27FC236}">
-                <a16:creationId xmlns:a16="http://schemas.microsoft.com/office/drawing/2014/main" id="{6EEA5ED1-7AEF-48F3-A44F-3277D726D521}"/>
+                <a16:creationId xmlns:a16="http://schemas.microsoft.com/office/drawing/2014/main" id="{BE014D38-AAE4-4BE7-B177-68F514295D42}"/>
               </a:ext>
             </a:extLst>
           </p:cNvPr>
@@ -6877,7 +6877,7 @@
           <p:cNvPr id="26" name="">
             <a:extLst xmlns:a="http://schemas.openxmlformats.org/drawingml/2006/main">
               <a:ext uri="{FF2B5EF4-FFF2-40B4-BE49-F238E27FC236}">
-                <a16:creationId xmlns:a16="http://schemas.microsoft.com/office/drawing/2014/main" id="{89127A70-1FFF-4928-AF1C-1B8A72B34A32}"/>
+                <a16:creationId xmlns:a16="http://schemas.microsoft.com/office/drawing/2014/main" id="{E87CAC8D-72FA-4B5F-9154-36AF21749A39}"/>
               </a:ext>
             </a:extLst>
           </p:cNvPr>
@@ -6935,7 +6935,7 @@
           <p:cNvPr id="27" name="">
             <a:extLst xmlns:a="http://schemas.openxmlformats.org/drawingml/2006/main">
               <a:ext uri="{FF2B5EF4-FFF2-40B4-BE49-F238E27FC236}">
-                <a16:creationId xmlns:a16="http://schemas.microsoft.com/office/drawing/2014/main" id="{95EE3889-5C34-4C00-8607-89CCE0057F97}"/>
+                <a16:creationId xmlns:a16="http://schemas.microsoft.com/office/drawing/2014/main" id="{1E6F11E1-99E9-49E2-B0C0-3A8216D30D29}"/>
               </a:ext>
             </a:extLst>
           </p:cNvPr>
@@ -6993,7 +6993,7 @@
           <p:cNvPr id="28" name="">
             <a:extLst xmlns:a="http://schemas.openxmlformats.org/drawingml/2006/main">
               <a:ext uri="{FF2B5EF4-FFF2-40B4-BE49-F238E27FC236}">
-                <a16:creationId xmlns:a16="http://schemas.microsoft.com/office/drawing/2014/main" id="{65DB9162-D405-455C-9309-B1EC5AE5F969}"/>
+                <a16:creationId xmlns:a16="http://schemas.microsoft.com/office/drawing/2014/main" id="{16C260FF-4233-44F8-B3E3-E25B6AE0A2E3}"/>
               </a:ext>
             </a:extLst>
           </p:cNvPr>
@@ -7051,7 +7051,7 @@
           <p:cNvPr id="29" name="">
             <a:extLst xmlns:a="http://schemas.openxmlformats.org/drawingml/2006/main">
               <a:ext uri="{FF2B5EF4-FFF2-40B4-BE49-F238E27FC236}">
-                <a16:creationId xmlns:a16="http://schemas.microsoft.com/office/drawing/2014/main" id="{A6BE6F0F-EB81-437F-93F4-EF91859E20A5}"/>
+                <a16:creationId xmlns:a16="http://schemas.microsoft.com/office/drawing/2014/main" id="{E4DA6921-EB77-4230-95E9-29D50B405386}"/>
               </a:ext>
             </a:extLst>
           </p:cNvPr>
@@ -7099,7 +7099,7 @@
                 <a:ea typeface="Aptos"/>
                 <a:cs typeface="Aptos"/>
               </a:rPr>
-              <a:t>WATERS NEXT GEN COMPETITIVE INTELLIGENCE · 13 AUG 2026 · waters-ci-20260813070817</a:t>
+              <a:t>WATERS NEXT GEN COMPETITIVE INTELLIGENCE · 17 AUG 2026 · waters-ci-20260817124300</a:t>
             </a:r>
           </a:p>
         </p:txBody>
@@ -7109,7 +7109,7 @@
           <p:cNvPr id="30" name="">
             <a:extLst xmlns:a="http://schemas.openxmlformats.org/drawingml/2006/main">
               <a:ext uri="{FF2B5EF4-FFF2-40B4-BE49-F238E27FC236}">
-                <a16:creationId xmlns:a16="http://schemas.microsoft.com/office/drawing/2014/main" id="{B3B1A2C9-6A4B-46D4-8C97-FB54D8E2EA98}"/>
+                <a16:creationId xmlns:a16="http://schemas.microsoft.com/office/drawing/2014/main" id="{C7F6AB50-8C44-461F-AA7E-23A67E4A2B8A}"/>
               </a:ext>
             </a:extLst>
           </p:cNvPr>
@@ -7165,7 +7165,7 @@
     </p:spTree>
     <p:extLst>
       <p:ext uri="{BB962C8B-B14F-4D97-AF65-F5344CB8AC3E}">
-        <p14:creationId xmlns:p14="http://schemas.microsoft.com/office/powerpoint/2010/main" val="112031297"/>
+        <p14:creationId xmlns:p14="http://schemas.microsoft.com/office/powerpoint/2010/main" val="2026591930"/>
       </p:ext>
     </p:extLst>
   </p:cSld>
@@ -7196,7 +7196,7 @@
           <p:cNvPr id="17" name="">
             <a:extLst xmlns:a="http://schemas.openxmlformats.org/drawingml/2006/main">
               <a:ext uri="{FF2B5EF4-FFF2-40B4-BE49-F238E27FC236}">
-                <a16:creationId xmlns:a16="http://schemas.microsoft.com/office/drawing/2014/main" id="{870A1921-E1FC-406A-BD5F-1EDF78B880D2}"/>
+                <a16:creationId xmlns:a16="http://schemas.microsoft.com/office/drawing/2014/main" id="{2E9C8950-9865-42A3-96F1-5F848F855909}"/>
               </a:ext>
             </a:extLst>
           </p:cNvPr>
@@ -7254,7 +7254,7 @@
           <p:cNvPr id="2" name="">
             <a:extLst xmlns:a="http://schemas.openxmlformats.org/drawingml/2006/main">
               <a:ext uri="{FF2B5EF4-FFF2-40B4-BE49-F238E27FC236}">
-                <a16:creationId xmlns:a16="http://schemas.microsoft.com/office/drawing/2014/main" id="{3BB06143-209C-4C0F-97A0-587F9DA75824}"/>
+                <a16:creationId xmlns:a16="http://schemas.microsoft.com/office/drawing/2014/main" id="{59CD1398-25E5-47D6-BA6B-C45DF13866F0}"/>
               </a:ext>
             </a:extLst>
           </p:cNvPr>
@@ -7312,7 +7312,7 @@
           <p:cNvPr id="3" name="">
             <a:extLst xmlns:a="http://schemas.openxmlformats.org/drawingml/2006/main">
               <a:ext uri="{FF2B5EF4-FFF2-40B4-BE49-F238E27FC236}">
-                <a16:creationId xmlns:a16="http://schemas.microsoft.com/office/drawing/2014/main" id="{E8FAE24F-4158-4FFC-A34A-B2F4C37A79EB}"/>
+                <a16:creationId xmlns:a16="http://schemas.microsoft.com/office/drawing/2014/main" id="{819D4FAB-6480-4678-B7C6-8FF54D56C2F5}"/>
               </a:ext>
             </a:extLst>
           </p:cNvPr>
@@ -7370,7 +7370,7 @@
           <p:cNvPr id="4" name="">
             <a:extLst xmlns:a="http://schemas.openxmlformats.org/drawingml/2006/main">
               <a:ext uri="{FF2B5EF4-FFF2-40B4-BE49-F238E27FC236}">
-                <a16:creationId xmlns:a16="http://schemas.microsoft.com/office/drawing/2014/main" id="{41951C5D-AC69-4293-A388-A6968147876B}"/>
+                <a16:creationId xmlns:a16="http://schemas.microsoft.com/office/drawing/2014/main" id="{6FCD1BEC-5A63-498D-8179-FE69F46DFA29}"/>
               </a:ext>
             </a:extLst>
           </p:cNvPr>
@@ -7403,7 +7403,7 @@
           <p:cNvPr id="5" name="">
             <a:extLst xmlns:a="http://schemas.openxmlformats.org/drawingml/2006/main">
               <a:ext uri="{FF2B5EF4-FFF2-40B4-BE49-F238E27FC236}">
-                <a16:creationId xmlns:a16="http://schemas.microsoft.com/office/drawing/2014/main" id="{010F5805-148F-4569-82E9-780831B2D143}"/>
+                <a16:creationId xmlns:a16="http://schemas.microsoft.com/office/drawing/2014/main" id="{BAA2FB7E-A34E-4C22-A9CC-74AEFD119DFF}"/>
               </a:ext>
             </a:extLst>
           </p:cNvPr>
@@ -7438,7 +7438,7 @@
           <p:cNvPr id="6" name="">
             <a:extLst xmlns:a="http://schemas.openxmlformats.org/drawingml/2006/main">
               <a:ext uri="{FF2B5EF4-FFF2-40B4-BE49-F238E27FC236}">
-                <a16:creationId xmlns:a16="http://schemas.microsoft.com/office/drawing/2014/main" id="{C5372DAC-42F1-4AC6-BBE0-0284210D9F4D}"/>
+                <a16:creationId xmlns:a16="http://schemas.microsoft.com/office/drawing/2014/main" id="{07197101-95F6-4D6E-BA7D-AFE51AE027AE}"/>
               </a:ext>
             </a:extLst>
           </p:cNvPr>
@@ -7496,7 +7496,7 @@
           <p:cNvPr id="7" name="">
             <a:extLst xmlns:a="http://schemas.openxmlformats.org/drawingml/2006/main">
               <a:ext uri="{FF2B5EF4-FFF2-40B4-BE49-F238E27FC236}">
-                <a16:creationId xmlns:a16="http://schemas.microsoft.com/office/drawing/2014/main" id="{51B8EC7C-9AB2-4F08-A967-9E8C2C7868D4}"/>
+                <a16:creationId xmlns:a16="http://schemas.microsoft.com/office/drawing/2014/main" id="{5315EEDC-A43E-414D-A7DF-21F16E1D931E}"/>
               </a:ext>
             </a:extLst>
           </p:cNvPr>
@@ -7554,7 +7554,7 @@
           <p:cNvPr id="8" name="">
             <a:extLst xmlns:a="http://schemas.openxmlformats.org/drawingml/2006/main">
               <a:ext uri="{FF2B5EF4-FFF2-40B4-BE49-F238E27FC236}">
-                <a16:creationId xmlns:a16="http://schemas.microsoft.com/office/drawing/2014/main" id="{1CAAF87E-50CA-4FD3-B71A-8C302D3986C3}"/>
+                <a16:creationId xmlns:a16="http://schemas.microsoft.com/office/drawing/2014/main" id="{55B2B777-80D4-41F1-93EB-31669CEA1E7E}"/>
               </a:ext>
             </a:extLst>
           </p:cNvPr>
@@ -7612,7 +7612,7 @@
           <p:cNvPr id="9" name="">
             <a:extLst xmlns:a="http://schemas.openxmlformats.org/drawingml/2006/main">
               <a:ext uri="{FF2B5EF4-FFF2-40B4-BE49-F238E27FC236}">
-                <a16:creationId xmlns:a16="http://schemas.microsoft.com/office/drawing/2014/main" id="{7F7A6F4F-DAA9-4E64-9EBE-1E57678CE598}"/>
+                <a16:creationId xmlns:a16="http://schemas.microsoft.com/office/drawing/2014/main" id="{EF06EF6E-9652-488E-A181-31D9D43F1A09}"/>
               </a:ext>
             </a:extLst>
           </p:cNvPr>
@@ -7693,7 +7693,7 @@
           <p:cNvPr id="10" name="">
             <a:extLst xmlns:a="http://schemas.openxmlformats.org/drawingml/2006/main">
               <a:ext uri="{FF2B5EF4-FFF2-40B4-BE49-F238E27FC236}">
-                <a16:creationId xmlns:a16="http://schemas.microsoft.com/office/drawing/2014/main" id="{D8C5B32C-7CDB-4559-B97E-B52144DCD3CB}"/>
+                <a16:creationId xmlns:a16="http://schemas.microsoft.com/office/drawing/2014/main" id="{603EBC39-EC57-4BA6-924B-63EB46ED2342}"/>
               </a:ext>
             </a:extLst>
           </p:cNvPr>
@@ -7728,7 +7728,7 @@
           <p:cNvPr id="11" name="">
             <a:extLst xmlns:a="http://schemas.openxmlformats.org/drawingml/2006/main">
               <a:ext uri="{FF2B5EF4-FFF2-40B4-BE49-F238E27FC236}">
-                <a16:creationId xmlns:a16="http://schemas.microsoft.com/office/drawing/2014/main" id="{D23E058C-72D4-44E3-93C6-894A031FC212}"/>
+                <a16:creationId xmlns:a16="http://schemas.microsoft.com/office/drawing/2014/main" id="{DB051100-A267-4EFC-AA17-311F679A2F28}"/>
               </a:ext>
             </a:extLst>
           </p:cNvPr>
@@ -7786,7 +7786,7 @@
           <p:cNvPr id="12" name="">
             <a:extLst xmlns:a="http://schemas.openxmlformats.org/drawingml/2006/main">
               <a:ext uri="{FF2B5EF4-FFF2-40B4-BE49-F238E27FC236}">
-                <a16:creationId xmlns:a16="http://schemas.microsoft.com/office/drawing/2014/main" id="{0BA32BC5-9F84-498F-AD20-9C1AA3EF92F6}"/>
+                <a16:creationId xmlns:a16="http://schemas.microsoft.com/office/drawing/2014/main" id="{4F81332D-CFA3-44BE-AAAE-03EDDD9B2293}"/>
               </a:ext>
             </a:extLst>
           </p:cNvPr>
@@ -7844,7 +7844,7 @@
           <p:cNvPr id="13" name="">
             <a:extLst xmlns:a="http://schemas.openxmlformats.org/drawingml/2006/main">
               <a:ext uri="{FF2B5EF4-FFF2-40B4-BE49-F238E27FC236}">
-                <a16:creationId xmlns:a16="http://schemas.microsoft.com/office/drawing/2014/main" id="{10E06D17-7718-4FBB-9E49-927C4671BA5D}"/>
+                <a16:creationId xmlns:a16="http://schemas.microsoft.com/office/drawing/2014/main" id="{A31C9F33-8C36-4446-BCA6-CE16F80EC9F7}"/>
               </a:ext>
             </a:extLst>
           </p:cNvPr>
@@ -7902,7 +7902,7 @@
           <p:cNvPr id="14" name="">
             <a:extLst xmlns:a="http://schemas.openxmlformats.org/drawingml/2006/main">
               <a:ext uri="{FF2B5EF4-FFF2-40B4-BE49-F238E27FC236}">
-                <a16:creationId xmlns:a16="http://schemas.microsoft.com/office/drawing/2014/main" id="{2886A792-C50C-4688-A70F-3C491EFA8B55}"/>
+                <a16:creationId xmlns:a16="http://schemas.microsoft.com/office/drawing/2014/main" id="{47707275-1297-4657-A620-F30BCD678BF5}"/>
               </a:ext>
             </a:extLst>
           </p:cNvPr>
@@ -8006,7 +8006,7 @@
           <p:cNvPr id="15" name="">
             <a:extLst xmlns:a="http://schemas.openxmlformats.org/drawingml/2006/main">
               <a:ext uri="{FF2B5EF4-FFF2-40B4-BE49-F238E27FC236}">
-                <a16:creationId xmlns:a16="http://schemas.microsoft.com/office/drawing/2014/main" id="{4615E46F-0066-4A95-BD3C-F7371A10FEE5}"/>
+                <a16:creationId xmlns:a16="http://schemas.microsoft.com/office/drawing/2014/main" id="{087D4055-AE73-406B-B2E8-F7E10BF040CF}"/>
               </a:ext>
             </a:extLst>
           </p:cNvPr>
@@ -8054,7 +8054,7 @@
                 <a:ea typeface="Aptos"/>
                 <a:cs typeface="Aptos"/>
               </a:rPr>
-              <a:t>WATERS NEXT GEN COMPETITIVE INTELLIGENCE · 13 AUG 2026 · waters-ci-20260813070817</a:t>
+              <a:t>WATERS NEXT GEN COMPETITIVE INTELLIGENCE · 17 AUG 2026 · waters-ci-20260817124300</a:t>
             </a:r>
           </a:p>
         </p:txBody>
@@ -8064,7 +8064,7 @@
           <p:cNvPr id="16" name="">
             <a:extLst xmlns:a="http://schemas.openxmlformats.org/drawingml/2006/main">
               <a:ext uri="{FF2B5EF4-FFF2-40B4-BE49-F238E27FC236}">
-                <a16:creationId xmlns:a16="http://schemas.microsoft.com/office/drawing/2014/main" id="{529D3770-8337-43E3-BC05-F62786B723F3}"/>
+                <a16:creationId xmlns:a16="http://schemas.microsoft.com/office/drawing/2014/main" id="{6D46575A-8AD3-4279-8EEB-A95E64FFA550}"/>
               </a:ext>
             </a:extLst>
           </p:cNvPr>
@@ -8120,7 +8120,7 @@
     </p:spTree>
     <p:extLst>
       <p:ext uri="{BB962C8B-B14F-4D97-AF65-F5344CB8AC3E}">
-        <p14:creationId xmlns:p14="http://schemas.microsoft.com/office/powerpoint/2010/main" val="2038293230"/>
+        <p14:creationId xmlns:p14="http://schemas.microsoft.com/office/powerpoint/2010/main" val="570183646"/>
       </p:ext>
     </p:extLst>
   </p:cSld>
@@ -8151,7 +8151,7 @@
           <p:cNvPr id="37" name="">
             <a:extLst xmlns:a="http://schemas.openxmlformats.org/drawingml/2006/main">
               <a:ext uri="{FF2B5EF4-FFF2-40B4-BE49-F238E27FC236}">
-                <a16:creationId xmlns:a16="http://schemas.microsoft.com/office/drawing/2014/main" id="{DB4D74BE-CAAF-4F46-BB20-A425D763CC31}"/>
+                <a16:creationId xmlns:a16="http://schemas.microsoft.com/office/drawing/2014/main" id="{CA905E1F-3F0D-4B1F-9E7A-F69479FC7FF9}"/>
               </a:ext>
             </a:extLst>
           </p:cNvPr>
@@ -8209,7 +8209,7 @@
           <p:cNvPr id="2" name="">
             <a:extLst xmlns:a="http://schemas.openxmlformats.org/drawingml/2006/main">
               <a:ext uri="{FF2B5EF4-FFF2-40B4-BE49-F238E27FC236}">
-                <a16:creationId xmlns:a16="http://schemas.microsoft.com/office/drawing/2014/main" id="{DFC5A1D3-EF3E-400C-BAB3-430405446AD4}"/>
+                <a16:creationId xmlns:a16="http://schemas.microsoft.com/office/drawing/2014/main" id="{91D1DDE9-7867-4E6A-9443-0BA13BF03D05}"/>
               </a:ext>
             </a:extLst>
           </p:cNvPr>
@@ -8267,7 +8267,7 @@
           <p:cNvPr id="3" name="">
             <a:extLst xmlns:a="http://schemas.openxmlformats.org/drawingml/2006/main">
               <a:ext uri="{FF2B5EF4-FFF2-40B4-BE49-F238E27FC236}">
-                <a16:creationId xmlns:a16="http://schemas.microsoft.com/office/drawing/2014/main" id="{E9483337-EA28-4FE7-9702-A415E4098171}"/>
+                <a16:creationId xmlns:a16="http://schemas.microsoft.com/office/drawing/2014/main" id="{D068F465-44C4-4E15-86FC-4355986140CB}"/>
               </a:ext>
             </a:extLst>
           </p:cNvPr>
@@ -8325,7 +8325,7 @@
           <p:cNvPr id="4" name="">
             <a:extLst xmlns:a="http://schemas.openxmlformats.org/drawingml/2006/main">
               <a:ext uri="{FF2B5EF4-FFF2-40B4-BE49-F238E27FC236}">
-                <a16:creationId xmlns:a16="http://schemas.microsoft.com/office/drawing/2014/main" id="{AA92781D-428F-4BC2-AA6F-A0F65DABF461}"/>
+                <a16:creationId xmlns:a16="http://schemas.microsoft.com/office/drawing/2014/main" id="{43DED25A-DC59-4AE9-B610-035B750D148F}"/>
               </a:ext>
             </a:extLst>
           </p:cNvPr>
@@ -8358,7 +8358,7 @@
           <p:cNvPr id="5" name="">
             <a:extLst xmlns:a="http://schemas.openxmlformats.org/drawingml/2006/main">
               <a:ext uri="{FF2B5EF4-FFF2-40B4-BE49-F238E27FC236}">
-                <a16:creationId xmlns:a16="http://schemas.microsoft.com/office/drawing/2014/main" id="{C17BFB09-7E82-42AB-B9F1-EC9209E096CB}"/>
+                <a16:creationId xmlns:a16="http://schemas.microsoft.com/office/drawing/2014/main" id="{AF92DC1C-A849-4879-9850-AB2E8B886D4C}"/>
               </a:ext>
             </a:extLst>
           </p:cNvPr>
@@ -8393,7 +8393,7 @@
           <p:cNvPr id="6" name="">
             <a:extLst xmlns:a="http://schemas.openxmlformats.org/drawingml/2006/main">
               <a:ext uri="{FF2B5EF4-FFF2-40B4-BE49-F238E27FC236}">
-                <a16:creationId xmlns:a16="http://schemas.microsoft.com/office/drawing/2014/main" id="{4BC7126B-D90A-42B7-9CD7-7948C32BD4CD}"/>
+                <a16:creationId xmlns:a16="http://schemas.microsoft.com/office/drawing/2014/main" id="{3E708680-86CB-4B76-B71A-6497DF3EE25E}"/>
               </a:ext>
             </a:extLst>
           </p:cNvPr>
@@ -8426,7 +8426,7 @@
           <p:cNvPr id="7" name="">
             <a:extLst xmlns:a="http://schemas.openxmlformats.org/drawingml/2006/main">
               <a:ext uri="{FF2B5EF4-FFF2-40B4-BE49-F238E27FC236}">
-                <a16:creationId xmlns:a16="http://schemas.microsoft.com/office/drawing/2014/main" id="{EA1B960F-585B-44BA-9EB8-AE68EA642592}"/>
+                <a16:creationId xmlns:a16="http://schemas.microsoft.com/office/drawing/2014/main" id="{CABB2633-6171-429A-B671-94A379B53A2B}"/>
               </a:ext>
             </a:extLst>
           </p:cNvPr>
@@ -8484,7 +8484,7 @@
           <p:cNvPr id="8" name="">
             <a:extLst xmlns:a="http://schemas.openxmlformats.org/drawingml/2006/main">
               <a:ext uri="{FF2B5EF4-FFF2-40B4-BE49-F238E27FC236}">
-                <a16:creationId xmlns:a16="http://schemas.microsoft.com/office/drawing/2014/main" id="{41C119CA-8665-4E9D-841B-A7DF2DF8D519}"/>
+                <a16:creationId xmlns:a16="http://schemas.microsoft.com/office/drawing/2014/main" id="{9A912350-AE98-4360-A45E-07C26D03BA92}"/>
               </a:ext>
             </a:extLst>
           </p:cNvPr>
@@ -8542,7 +8542,7 @@
           <p:cNvPr id="9" name="">
             <a:extLst xmlns:a="http://schemas.openxmlformats.org/drawingml/2006/main">
               <a:ext uri="{FF2B5EF4-FFF2-40B4-BE49-F238E27FC236}">
-                <a16:creationId xmlns:a16="http://schemas.microsoft.com/office/drawing/2014/main" id="{44BA1151-BBDF-4F01-83CF-D79E2B5AFC93}"/>
+                <a16:creationId xmlns:a16="http://schemas.microsoft.com/office/drawing/2014/main" id="{E5E43E8C-8685-4C61-9F3E-DEEA7C7C98E0}"/>
               </a:ext>
             </a:extLst>
           </p:cNvPr>
@@ -8600,7 +8600,7 @@
           <p:cNvPr id="10" name="">
             <a:extLst xmlns:a="http://schemas.openxmlformats.org/drawingml/2006/main">
               <a:ext uri="{FF2B5EF4-FFF2-40B4-BE49-F238E27FC236}">
-                <a16:creationId xmlns:a16="http://schemas.microsoft.com/office/drawing/2014/main" id="{E00E0109-3BD5-47CE-8474-045E58CE14F9}"/>
+                <a16:creationId xmlns:a16="http://schemas.microsoft.com/office/drawing/2014/main" id="{6016E242-CBA9-4ADA-82F6-4A60D55F8ADA}"/>
               </a:ext>
             </a:extLst>
           </p:cNvPr>
@@ -8658,7 +8658,7 @@
           <p:cNvPr id="11" name="">
             <a:extLst xmlns:a="http://schemas.openxmlformats.org/drawingml/2006/main">
               <a:ext uri="{FF2B5EF4-FFF2-40B4-BE49-F238E27FC236}">
-                <a16:creationId xmlns:a16="http://schemas.microsoft.com/office/drawing/2014/main" id="{4061F1CF-2ADE-4794-8B97-E46E27AAA989}"/>
+                <a16:creationId xmlns:a16="http://schemas.microsoft.com/office/drawing/2014/main" id="{318A5148-010A-42CE-B073-E854CA2BA262}"/>
               </a:ext>
             </a:extLst>
           </p:cNvPr>
@@ -8691,7 +8691,7 @@
           <p:cNvPr id="12" name="">
             <a:extLst xmlns:a="http://schemas.openxmlformats.org/drawingml/2006/main">
               <a:ext uri="{FF2B5EF4-FFF2-40B4-BE49-F238E27FC236}">
-                <a16:creationId xmlns:a16="http://schemas.microsoft.com/office/drawing/2014/main" id="{96F83541-4D97-42CD-B92D-71531F71FB2D}"/>
+                <a16:creationId xmlns:a16="http://schemas.microsoft.com/office/drawing/2014/main" id="{5DC5C520-B1FA-4FDB-BB39-CAF82FE6CDA0}"/>
               </a:ext>
             </a:extLst>
           </p:cNvPr>
@@ -8749,7 +8749,7 @@
           <p:cNvPr id="13" name="">
             <a:extLst xmlns:a="http://schemas.openxmlformats.org/drawingml/2006/main">
               <a:ext uri="{FF2B5EF4-FFF2-40B4-BE49-F238E27FC236}">
-                <a16:creationId xmlns:a16="http://schemas.microsoft.com/office/drawing/2014/main" id="{66C0DEBB-6E3F-46EF-83A3-48F12F6AB654}"/>
+                <a16:creationId xmlns:a16="http://schemas.microsoft.com/office/drawing/2014/main" id="{6A9918DF-385F-4631-A6EC-F96997DCBC50}"/>
               </a:ext>
             </a:extLst>
           </p:cNvPr>
@@ -8807,7 +8807,7 @@
           <p:cNvPr id="14" name="">
             <a:extLst xmlns:a="http://schemas.openxmlformats.org/drawingml/2006/main">
               <a:ext uri="{FF2B5EF4-FFF2-40B4-BE49-F238E27FC236}">
-                <a16:creationId xmlns:a16="http://schemas.microsoft.com/office/drawing/2014/main" id="{37FDCAFD-DAB3-4A6A-9A82-808513074AA5}"/>
+                <a16:creationId xmlns:a16="http://schemas.microsoft.com/office/drawing/2014/main" id="{F1D3F4F7-C97A-43DA-B357-09C707466CDF}"/>
               </a:ext>
             </a:extLst>
           </p:cNvPr>
@@ -8865,7 +8865,7 @@
           <p:cNvPr id="15" name="">
             <a:extLst xmlns:a="http://schemas.openxmlformats.org/drawingml/2006/main">
               <a:ext uri="{FF2B5EF4-FFF2-40B4-BE49-F238E27FC236}">
-                <a16:creationId xmlns:a16="http://schemas.microsoft.com/office/drawing/2014/main" id="{08BBF848-97AD-4879-9CC6-26EC7B181500}"/>
+                <a16:creationId xmlns:a16="http://schemas.microsoft.com/office/drawing/2014/main" id="{DB055579-DCB3-4925-9073-6BA76C9390FD}"/>
               </a:ext>
             </a:extLst>
           </p:cNvPr>
@@ -8900,7 +8900,7 @@
           <p:cNvPr id="16" name="">
             <a:extLst xmlns:a="http://schemas.openxmlformats.org/drawingml/2006/main">
               <a:ext uri="{FF2B5EF4-FFF2-40B4-BE49-F238E27FC236}">
-                <a16:creationId xmlns:a16="http://schemas.microsoft.com/office/drawing/2014/main" id="{D31BAE44-9836-4255-80A7-BD395939166D}"/>
+                <a16:creationId xmlns:a16="http://schemas.microsoft.com/office/drawing/2014/main" id="{04DE3699-F50A-4BBE-8507-38F9241F620A}"/>
               </a:ext>
             </a:extLst>
           </p:cNvPr>
@@ -8933,7 +8933,7 @@
           <p:cNvPr id="17" name="">
             <a:extLst xmlns:a="http://schemas.openxmlformats.org/drawingml/2006/main">
               <a:ext uri="{FF2B5EF4-FFF2-40B4-BE49-F238E27FC236}">
-                <a16:creationId xmlns:a16="http://schemas.microsoft.com/office/drawing/2014/main" id="{1F9D5368-3A27-41DB-9F0E-CCD68A0C8C77}"/>
+                <a16:creationId xmlns:a16="http://schemas.microsoft.com/office/drawing/2014/main" id="{1FE1A941-A345-4FCB-9450-90370D34E6A7}"/>
               </a:ext>
             </a:extLst>
           </p:cNvPr>
@@ -8991,7 +8991,7 @@
           <p:cNvPr id="18" name="">
             <a:extLst xmlns:a="http://schemas.openxmlformats.org/drawingml/2006/main">
               <a:ext uri="{FF2B5EF4-FFF2-40B4-BE49-F238E27FC236}">
-                <a16:creationId xmlns:a16="http://schemas.microsoft.com/office/drawing/2014/main" id="{27F6D267-4094-4A57-8CA5-2C84C996CEC1}"/>
+                <a16:creationId xmlns:a16="http://schemas.microsoft.com/office/drawing/2014/main" id="{9128AEDB-5D65-48AC-895F-090507907F50}"/>
               </a:ext>
             </a:extLst>
           </p:cNvPr>
@@ -9049,7 +9049,7 @@
           <p:cNvPr id="19" name="">
             <a:extLst xmlns:a="http://schemas.openxmlformats.org/drawingml/2006/main">
               <a:ext uri="{FF2B5EF4-FFF2-40B4-BE49-F238E27FC236}">
-                <a16:creationId xmlns:a16="http://schemas.microsoft.com/office/drawing/2014/main" id="{F2430C66-A574-404A-94DF-C540A4AEAD8B}"/>
+                <a16:creationId xmlns:a16="http://schemas.microsoft.com/office/drawing/2014/main" id="{85FBFA17-036F-4C0C-868F-53C970F2DD83}"/>
               </a:ext>
             </a:extLst>
           </p:cNvPr>
@@ -9107,7 +9107,7 @@
           <p:cNvPr id="20" name="">
             <a:extLst xmlns:a="http://schemas.openxmlformats.org/drawingml/2006/main">
               <a:ext uri="{FF2B5EF4-FFF2-40B4-BE49-F238E27FC236}">
-                <a16:creationId xmlns:a16="http://schemas.microsoft.com/office/drawing/2014/main" id="{9CA0B07D-E881-467F-A2E3-F127D41B1FC4}"/>
+                <a16:creationId xmlns:a16="http://schemas.microsoft.com/office/drawing/2014/main" id="{D976FB24-76AC-488E-820A-5443825E084C}"/>
               </a:ext>
             </a:extLst>
           </p:cNvPr>
@@ -9165,7 +9165,7 @@
           <p:cNvPr id="21" name="">
             <a:extLst xmlns:a="http://schemas.openxmlformats.org/drawingml/2006/main">
               <a:ext uri="{FF2B5EF4-FFF2-40B4-BE49-F238E27FC236}">
-                <a16:creationId xmlns:a16="http://schemas.microsoft.com/office/drawing/2014/main" id="{34F453A8-ED87-4F6D-96F1-BB2949ECD721}"/>
+                <a16:creationId xmlns:a16="http://schemas.microsoft.com/office/drawing/2014/main" id="{CE007361-CD55-42F1-8947-151C8A1FC48A}"/>
               </a:ext>
             </a:extLst>
           </p:cNvPr>
@@ -9198,7 +9198,7 @@
           <p:cNvPr id="22" name="">
             <a:extLst xmlns:a="http://schemas.openxmlformats.org/drawingml/2006/main">
               <a:ext uri="{FF2B5EF4-FFF2-40B4-BE49-F238E27FC236}">
-                <a16:creationId xmlns:a16="http://schemas.microsoft.com/office/drawing/2014/main" id="{41CE6237-C020-41E7-9E07-CD38A5D24E4C}"/>
+                <a16:creationId xmlns:a16="http://schemas.microsoft.com/office/drawing/2014/main" id="{C6EA0409-2A30-46F8-9DEA-714284DE12C1}"/>
               </a:ext>
             </a:extLst>
           </p:cNvPr>
@@ -9256,7 +9256,7 @@
           <p:cNvPr id="23" name="">
             <a:extLst xmlns:a="http://schemas.openxmlformats.org/drawingml/2006/main">
               <a:ext uri="{FF2B5EF4-FFF2-40B4-BE49-F238E27FC236}">
-                <a16:creationId xmlns:a16="http://schemas.microsoft.com/office/drawing/2014/main" id="{A4513662-D4DB-4FCF-A83D-05FD4A203D66}"/>
+                <a16:creationId xmlns:a16="http://schemas.microsoft.com/office/drawing/2014/main" id="{351B0F15-440B-405B-854F-8A4076F7CEFA}"/>
               </a:ext>
             </a:extLst>
           </p:cNvPr>
@@ -9314,7 +9314,7 @@
           <p:cNvPr id="24" name="">
             <a:extLst xmlns:a="http://schemas.openxmlformats.org/drawingml/2006/main">
               <a:ext uri="{FF2B5EF4-FFF2-40B4-BE49-F238E27FC236}">
-                <a16:creationId xmlns:a16="http://schemas.microsoft.com/office/drawing/2014/main" id="{CC122E95-B499-4CFF-B6CA-3628BC2C0C27}"/>
+                <a16:creationId xmlns:a16="http://schemas.microsoft.com/office/drawing/2014/main" id="{A848220B-D21A-4F1C-AFE3-D18183FA7BFA}"/>
               </a:ext>
             </a:extLst>
           </p:cNvPr>
@@ -9372,7 +9372,7 @@
           <p:cNvPr id="25" name="">
             <a:extLst xmlns:a="http://schemas.openxmlformats.org/drawingml/2006/main">
               <a:ext uri="{FF2B5EF4-FFF2-40B4-BE49-F238E27FC236}">
-                <a16:creationId xmlns:a16="http://schemas.microsoft.com/office/drawing/2014/main" id="{3431B2F6-EA5A-41DD-9C01-24BD67C83EFE}"/>
+                <a16:creationId xmlns:a16="http://schemas.microsoft.com/office/drawing/2014/main" id="{69871C23-9CF4-4E55-A595-2B035A2CD6EB}"/>
               </a:ext>
             </a:extLst>
           </p:cNvPr>
@@ -9407,7 +9407,7 @@
           <p:cNvPr id="26" name="">
             <a:extLst xmlns:a="http://schemas.openxmlformats.org/drawingml/2006/main">
               <a:ext uri="{FF2B5EF4-FFF2-40B4-BE49-F238E27FC236}">
-                <a16:creationId xmlns:a16="http://schemas.microsoft.com/office/drawing/2014/main" id="{4914450E-4ABE-4153-8344-B4C46D4126B2}"/>
+                <a16:creationId xmlns:a16="http://schemas.microsoft.com/office/drawing/2014/main" id="{6C7DA4B2-BBFD-49FC-94FE-E9E314C6A875}"/>
               </a:ext>
             </a:extLst>
           </p:cNvPr>
@@ -9440,7 +9440,7 @@
           <p:cNvPr id="27" name="">
             <a:extLst xmlns:a="http://schemas.openxmlformats.org/drawingml/2006/main">
               <a:ext uri="{FF2B5EF4-FFF2-40B4-BE49-F238E27FC236}">
-                <a16:creationId xmlns:a16="http://schemas.microsoft.com/office/drawing/2014/main" id="{98849BE5-FF8A-45DA-BA0D-FA232D2D3B8F}"/>
+                <a16:creationId xmlns:a16="http://schemas.microsoft.com/office/drawing/2014/main" id="{33D6D66A-72AC-4290-9F29-9AA00C36E2D1}"/>
               </a:ext>
             </a:extLst>
           </p:cNvPr>
@@ -9498,7 +9498,7 @@
           <p:cNvPr id="28" name="">
             <a:extLst xmlns:a="http://schemas.openxmlformats.org/drawingml/2006/main">
               <a:ext uri="{FF2B5EF4-FFF2-40B4-BE49-F238E27FC236}">
-                <a16:creationId xmlns:a16="http://schemas.microsoft.com/office/drawing/2014/main" id="{ED7220FC-D977-40B5-9034-90493082C5FB}"/>
+                <a16:creationId xmlns:a16="http://schemas.microsoft.com/office/drawing/2014/main" id="{85A1D521-038F-439F-8B17-41F48638242F}"/>
               </a:ext>
             </a:extLst>
           </p:cNvPr>
@@ -9556,7 +9556,7 @@
           <p:cNvPr id="29" name="">
             <a:extLst xmlns:a="http://schemas.openxmlformats.org/drawingml/2006/main">
               <a:ext uri="{FF2B5EF4-FFF2-40B4-BE49-F238E27FC236}">
-                <a16:creationId xmlns:a16="http://schemas.microsoft.com/office/drawing/2014/main" id="{7F48C78F-5347-49C1-B1A1-341DE42B1719}"/>
+                <a16:creationId xmlns:a16="http://schemas.microsoft.com/office/drawing/2014/main" id="{006C7554-7F58-4BD5-A851-1A2F28EF0BBB}"/>
               </a:ext>
             </a:extLst>
           </p:cNvPr>
@@ -9614,7 +9614,7 @@
           <p:cNvPr id="30" name="">
             <a:extLst xmlns:a="http://schemas.openxmlformats.org/drawingml/2006/main">
               <a:ext uri="{FF2B5EF4-FFF2-40B4-BE49-F238E27FC236}">
-                <a16:creationId xmlns:a16="http://schemas.microsoft.com/office/drawing/2014/main" id="{EC266EDF-426F-482A-98D4-A9BCBA7AE5FF}"/>
+                <a16:creationId xmlns:a16="http://schemas.microsoft.com/office/drawing/2014/main" id="{CE3C456A-91D8-48AE-A1B5-0D5248B525A7}"/>
               </a:ext>
             </a:extLst>
           </p:cNvPr>
@@ -9672,7 +9672,7 @@
           <p:cNvPr id="31" name="">
             <a:extLst xmlns:a="http://schemas.openxmlformats.org/drawingml/2006/main">
               <a:ext uri="{FF2B5EF4-FFF2-40B4-BE49-F238E27FC236}">
-                <a16:creationId xmlns:a16="http://schemas.microsoft.com/office/drawing/2014/main" id="{ECE3EB5C-EAAF-4347-83AC-07ED32074D65}"/>
+                <a16:creationId xmlns:a16="http://schemas.microsoft.com/office/drawing/2014/main" id="{A309FC5F-B64B-4092-9FC2-DEA474B7C15B}"/>
               </a:ext>
             </a:extLst>
           </p:cNvPr>
@@ -9705,7 +9705,7 @@
           <p:cNvPr id="32" name="">
             <a:extLst xmlns:a="http://schemas.openxmlformats.org/drawingml/2006/main">
               <a:ext uri="{FF2B5EF4-FFF2-40B4-BE49-F238E27FC236}">
-                <a16:creationId xmlns:a16="http://schemas.microsoft.com/office/drawing/2014/main" id="{26358251-AC96-4B56-ACEB-531C6C471559}"/>
+                <a16:creationId xmlns:a16="http://schemas.microsoft.com/office/drawing/2014/main" id="{9D835A3D-2FAB-4BED-AD2B-9F93861B1BD0}"/>
               </a:ext>
             </a:extLst>
           </p:cNvPr>
@@ -9763,7 +9763,7 @@
           <p:cNvPr id="33" name="">
             <a:extLst xmlns:a="http://schemas.openxmlformats.org/drawingml/2006/main">
               <a:ext uri="{FF2B5EF4-FFF2-40B4-BE49-F238E27FC236}">
-                <a16:creationId xmlns:a16="http://schemas.microsoft.com/office/drawing/2014/main" id="{9A3103D8-97F7-45DF-8D06-1CE00DE3F5E9}"/>
+                <a16:creationId xmlns:a16="http://schemas.microsoft.com/office/drawing/2014/main" id="{374B9436-1CD5-48BE-B656-9832E71001F1}"/>
               </a:ext>
             </a:extLst>
           </p:cNvPr>
@@ -9821,7 +9821,7 @@
           <p:cNvPr id="34" name="">
             <a:extLst xmlns:a="http://schemas.openxmlformats.org/drawingml/2006/main">
               <a:ext uri="{FF2B5EF4-FFF2-40B4-BE49-F238E27FC236}">
-                <a16:creationId xmlns:a16="http://schemas.microsoft.com/office/drawing/2014/main" id="{1993B558-9185-4DF3-A3B4-1DFF91C29B07}"/>
+                <a16:creationId xmlns:a16="http://schemas.microsoft.com/office/drawing/2014/main" id="{E175FAA4-0945-45B0-AA0A-36FD58A119FE}"/>
               </a:ext>
             </a:extLst>
           </p:cNvPr>
@@ -9879,7 +9879,7 @@
           <p:cNvPr id="35" name="">
             <a:extLst xmlns:a="http://schemas.openxmlformats.org/drawingml/2006/main">
               <a:ext uri="{FF2B5EF4-FFF2-40B4-BE49-F238E27FC236}">
-                <a16:creationId xmlns:a16="http://schemas.microsoft.com/office/drawing/2014/main" id="{2D0DD19A-D871-422A-A26C-E7E4C0CC8EE5}"/>
+                <a16:creationId xmlns:a16="http://schemas.microsoft.com/office/drawing/2014/main" id="{F224EB8A-5291-4D3C-84E3-DAF06505BC26}"/>
               </a:ext>
             </a:extLst>
           </p:cNvPr>
@@ -9927,7 +9927,7 @@
                 <a:ea typeface="Aptos"/>
                 <a:cs typeface="Aptos"/>
               </a:rPr>
-              <a:t>WATERS NEXT GEN COMPETITIVE INTELLIGENCE · 13 AUG 2026 · waters-ci-20260813070817</a:t>
+              <a:t>WATERS NEXT GEN COMPETITIVE INTELLIGENCE · 17 AUG 2026 · waters-ci-20260817124300</a:t>
             </a:r>
           </a:p>
         </p:txBody>
@@ -9937,7 +9937,7 @@
           <p:cNvPr id="36" name="">
             <a:extLst xmlns:a="http://schemas.openxmlformats.org/drawingml/2006/main">
               <a:ext uri="{FF2B5EF4-FFF2-40B4-BE49-F238E27FC236}">
-                <a16:creationId xmlns:a16="http://schemas.microsoft.com/office/drawing/2014/main" id="{9B0C0BA8-1176-4862-AB23-BF2F50FBD2E5}"/>
+                <a16:creationId xmlns:a16="http://schemas.microsoft.com/office/drawing/2014/main" id="{9789469E-7B67-45D3-BF21-E6FB08C6F494}"/>
               </a:ext>
             </a:extLst>
           </p:cNvPr>
@@ -9993,7 +9993,7 @@
     </p:spTree>
     <p:extLst>
       <p:ext uri="{BB962C8B-B14F-4D97-AF65-F5344CB8AC3E}">
-        <p14:creationId xmlns:p14="http://schemas.microsoft.com/office/powerpoint/2010/main" val="510387907"/>
+        <p14:creationId xmlns:p14="http://schemas.microsoft.com/office/powerpoint/2010/main" val="1913361237"/>
       </p:ext>
     </p:extLst>
   </p:cSld>
@@ -10024,7 +10024,7 @@
           <p:cNvPr id="26" name="">
             <a:extLst xmlns:a="http://schemas.openxmlformats.org/drawingml/2006/main">
               <a:ext uri="{FF2B5EF4-FFF2-40B4-BE49-F238E27FC236}">
-                <a16:creationId xmlns:a16="http://schemas.microsoft.com/office/drawing/2014/main" id="{E4656AC4-522E-4D04-A1C0-A1E3E05DBE18}"/>
+                <a16:creationId xmlns:a16="http://schemas.microsoft.com/office/drawing/2014/main" id="{815D1DBC-CC69-49A5-ACBE-837653733B5A}"/>
               </a:ext>
             </a:extLst>
           </p:cNvPr>
@@ -10082,7 +10082,7 @@
           <p:cNvPr id="2" name="">
             <a:extLst xmlns:a="http://schemas.openxmlformats.org/drawingml/2006/main">
               <a:ext uri="{FF2B5EF4-FFF2-40B4-BE49-F238E27FC236}">
-                <a16:creationId xmlns:a16="http://schemas.microsoft.com/office/drawing/2014/main" id="{A92D069E-745B-4D61-B65C-1C4ECD1A39D8}"/>
+                <a16:creationId xmlns:a16="http://schemas.microsoft.com/office/drawing/2014/main" id="{D9632293-978B-4ACF-9522-23D8CF96B568}"/>
               </a:ext>
             </a:extLst>
           </p:cNvPr>
@@ -10140,7 +10140,7 @@
           <p:cNvPr id="3" name="">
             <a:extLst xmlns:a="http://schemas.openxmlformats.org/drawingml/2006/main">
               <a:ext uri="{FF2B5EF4-FFF2-40B4-BE49-F238E27FC236}">
-                <a16:creationId xmlns:a16="http://schemas.microsoft.com/office/drawing/2014/main" id="{54BD13D2-A4F9-4D9A-884F-982BAE3A8BC3}"/>
+                <a16:creationId xmlns:a16="http://schemas.microsoft.com/office/drawing/2014/main" id="{0ABFAB36-286C-43E8-BED4-A87028753C47}"/>
               </a:ext>
             </a:extLst>
           </p:cNvPr>
@@ -10198,7 +10198,7 @@
           <p:cNvPr id="4" name="">
             <a:extLst xmlns:a="http://schemas.openxmlformats.org/drawingml/2006/main">
               <a:ext uri="{FF2B5EF4-FFF2-40B4-BE49-F238E27FC236}">
-                <a16:creationId xmlns:a16="http://schemas.microsoft.com/office/drawing/2014/main" id="{A3A372F0-D575-4616-9133-08D7052D5F75}"/>
+                <a16:creationId xmlns:a16="http://schemas.microsoft.com/office/drawing/2014/main" id="{0703FEB9-603D-4559-99A4-A45FA1144B96}"/>
               </a:ext>
             </a:extLst>
           </p:cNvPr>
@@ -10231,7 +10231,7 @@
           <p:cNvPr id="5" name="">
             <a:extLst xmlns:a="http://schemas.openxmlformats.org/drawingml/2006/main">
               <a:ext uri="{FF2B5EF4-FFF2-40B4-BE49-F238E27FC236}">
-                <a16:creationId xmlns:a16="http://schemas.microsoft.com/office/drawing/2014/main" id="{B4B8005F-B2E7-468A-A28F-449CA4EC8EAD}"/>
+                <a16:creationId xmlns:a16="http://schemas.microsoft.com/office/drawing/2014/main" id="{E7B0DD43-66F2-459C-A383-0B41E5C5E62D}"/>
               </a:ext>
             </a:extLst>
           </p:cNvPr>
@@ -10264,7 +10264,7 @@
           <p:cNvPr id="6" name="">
             <a:extLst xmlns:a="http://schemas.openxmlformats.org/drawingml/2006/main">
               <a:ext uri="{FF2B5EF4-FFF2-40B4-BE49-F238E27FC236}">
-                <a16:creationId xmlns:a16="http://schemas.microsoft.com/office/drawing/2014/main" id="{EE47D12B-30A9-4EEE-BE8B-BA0F8E3D8BCE}"/>
+                <a16:creationId xmlns:a16="http://schemas.microsoft.com/office/drawing/2014/main" id="{D1637327-1BB6-41F8-BAC2-6B4E2B8995A0}"/>
               </a:ext>
             </a:extLst>
           </p:cNvPr>
@@ -10299,7 +10299,7 @@
           <p:cNvPr id="7" name="">
             <a:extLst xmlns:a="http://schemas.openxmlformats.org/drawingml/2006/main">
               <a:ext uri="{FF2B5EF4-FFF2-40B4-BE49-F238E27FC236}">
-                <a16:creationId xmlns:a16="http://schemas.microsoft.com/office/drawing/2014/main" id="{2D3CC394-85E2-4A33-99E6-B33850AE79A2}"/>
+                <a16:creationId xmlns:a16="http://schemas.microsoft.com/office/drawing/2014/main" id="{D175C65E-B624-4E6F-9FC3-E38490848BC8}"/>
               </a:ext>
             </a:extLst>
           </p:cNvPr>
@@ -10357,7 +10357,7 @@
           <p:cNvPr id="8" name="">
             <a:extLst xmlns:a="http://schemas.openxmlformats.org/drawingml/2006/main">
               <a:ext uri="{FF2B5EF4-FFF2-40B4-BE49-F238E27FC236}">
-                <a16:creationId xmlns:a16="http://schemas.microsoft.com/office/drawing/2014/main" id="{A262DEC3-B5E4-4117-B0B1-D8ADF87763F8}"/>
+                <a16:creationId xmlns:a16="http://schemas.microsoft.com/office/drawing/2014/main" id="{5DF335A7-89C8-4DAE-ABF4-712C79044AE0}"/>
               </a:ext>
             </a:extLst>
           </p:cNvPr>
@@ -10415,7 +10415,7 @@
           <p:cNvPr id="9" name="">
             <a:extLst xmlns:a="http://schemas.openxmlformats.org/drawingml/2006/main">
               <a:ext uri="{FF2B5EF4-FFF2-40B4-BE49-F238E27FC236}">
-                <a16:creationId xmlns:a16="http://schemas.microsoft.com/office/drawing/2014/main" id="{4FE45C7D-1D02-477D-8B27-3F656DF1E93F}"/>
+                <a16:creationId xmlns:a16="http://schemas.microsoft.com/office/drawing/2014/main" id="{4D535FFF-B8B4-49BF-B722-68480869F33A}"/>
               </a:ext>
             </a:extLst>
           </p:cNvPr>
@@ -10473,7 +10473,7 @@
           <p:cNvPr id="10" name="">
             <a:extLst xmlns:a="http://schemas.openxmlformats.org/drawingml/2006/main">
               <a:ext uri="{FF2B5EF4-FFF2-40B4-BE49-F238E27FC236}">
-                <a16:creationId xmlns:a16="http://schemas.microsoft.com/office/drawing/2014/main" id="{8A713BBB-03D0-49FA-8CC9-5F7E7FE2973A}"/>
+                <a16:creationId xmlns:a16="http://schemas.microsoft.com/office/drawing/2014/main" id="{1E614146-C5B8-4DB3-B9E1-08104438743E}"/>
               </a:ext>
             </a:extLst>
           </p:cNvPr>
@@ -10508,7 +10508,7 @@
           <p:cNvPr id="11" name="">
             <a:extLst xmlns:a="http://schemas.openxmlformats.org/drawingml/2006/main">
               <a:ext uri="{FF2B5EF4-FFF2-40B4-BE49-F238E27FC236}">
-                <a16:creationId xmlns:a16="http://schemas.microsoft.com/office/drawing/2014/main" id="{9BF3F0BE-52DF-43B6-8F28-7DC13D76D0F4}"/>
+                <a16:creationId xmlns:a16="http://schemas.microsoft.com/office/drawing/2014/main" id="{9B908A2F-1D95-448A-980B-F9E4024B8C9C}"/>
               </a:ext>
             </a:extLst>
           </p:cNvPr>
@@ -10566,7 +10566,7 @@
           <p:cNvPr id="12" name="">
             <a:extLst xmlns:a="http://schemas.openxmlformats.org/drawingml/2006/main">
               <a:ext uri="{FF2B5EF4-FFF2-40B4-BE49-F238E27FC236}">
-                <a16:creationId xmlns:a16="http://schemas.microsoft.com/office/drawing/2014/main" id="{A4607318-2CC4-4ABF-A3B4-4D1565B37437}"/>
+                <a16:creationId xmlns:a16="http://schemas.microsoft.com/office/drawing/2014/main" id="{9324ED1F-505F-4E6C-B9AB-97684E72C5EE}"/>
               </a:ext>
             </a:extLst>
           </p:cNvPr>
@@ -10624,7 +10624,7 @@
           <p:cNvPr id="13" name="">
             <a:extLst xmlns:a="http://schemas.openxmlformats.org/drawingml/2006/main">
               <a:ext uri="{FF2B5EF4-FFF2-40B4-BE49-F238E27FC236}">
-                <a16:creationId xmlns:a16="http://schemas.microsoft.com/office/drawing/2014/main" id="{4E35A15A-F6D7-4897-92DD-8F21A5F77D20}"/>
+                <a16:creationId xmlns:a16="http://schemas.microsoft.com/office/drawing/2014/main" id="{6B693ABC-1835-49A8-B6D1-15F7CEC4C09E}"/>
               </a:ext>
             </a:extLst>
           </p:cNvPr>
@@ -10682,7 +10682,7 @@
           <p:cNvPr id="14" name="">
             <a:extLst xmlns:a="http://schemas.openxmlformats.org/drawingml/2006/main">
               <a:ext uri="{FF2B5EF4-FFF2-40B4-BE49-F238E27FC236}">
-                <a16:creationId xmlns:a16="http://schemas.microsoft.com/office/drawing/2014/main" id="{B500904C-B371-496B-9006-C40F101233E4}"/>
+                <a16:creationId xmlns:a16="http://schemas.microsoft.com/office/drawing/2014/main" id="{247CADEB-BB32-41DA-91E8-6E9E3958FB3F}"/>
               </a:ext>
             </a:extLst>
           </p:cNvPr>
@@ -10717,7 +10717,7 @@
           <p:cNvPr id="15" name="">
             <a:extLst xmlns:a="http://schemas.openxmlformats.org/drawingml/2006/main">
               <a:ext uri="{FF2B5EF4-FFF2-40B4-BE49-F238E27FC236}">
-                <a16:creationId xmlns:a16="http://schemas.microsoft.com/office/drawing/2014/main" id="{6BBC5CB6-ACFF-462A-B9DE-D4C6ADD5BB40}"/>
+                <a16:creationId xmlns:a16="http://schemas.microsoft.com/office/drawing/2014/main" id="{64DDBC4F-D190-41F0-BABC-D489D878B96A}"/>
               </a:ext>
             </a:extLst>
           </p:cNvPr>
@@ -10775,7 +10775,7 @@
           <p:cNvPr id="16" name="">
             <a:extLst xmlns:a="http://schemas.openxmlformats.org/drawingml/2006/main">
               <a:ext uri="{FF2B5EF4-FFF2-40B4-BE49-F238E27FC236}">
-                <a16:creationId xmlns:a16="http://schemas.microsoft.com/office/drawing/2014/main" id="{3B0AB455-970E-47C0-BA6D-44BAED59F1FB}"/>
+                <a16:creationId xmlns:a16="http://schemas.microsoft.com/office/drawing/2014/main" id="{57F05424-FA27-4751-9AAB-7FB86C9866C7}"/>
               </a:ext>
             </a:extLst>
           </p:cNvPr>
@@ -10833,7 +10833,7 @@
           <p:cNvPr id="17" name="">
             <a:extLst xmlns:a="http://schemas.openxmlformats.org/drawingml/2006/main">
               <a:ext uri="{FF2B5EF4-FFF2-40B4-BE49-F238E27FC236}">
-                <a16:creationId xmlns:a16="http://schemas.microsoft.com/office/drawing/2014/main" id="{09BEE206-FCE9-48D4-BB03-3152F77B7289}"/>
+                <a16:creationId xmlns:a16="http://schemas.microsoft.com/office/drawing/2014/main" id="{AE8977B3-EAF8-4648-B276-4D71A5A2E6BE}"/>
               </a:ext>
             </a:extLst>
           </p:cNvPr>
@@ -10891,7 +10891,7 @@
           <p:cNvPr id="18" name="">
             <a:extLst xmlns:a="http://schemas.openxmlformats.org/drawingml/2006/main">
               <a:ext uri="{FF2B5EF4-FFF2-40B4-BE49-F238E27FC236}">
-                <a16:creationId xmlns:a16="http://schemas.microsoft.com/office/drawing/2014/main" id="{EA719CC5-035F-44E5-9A87-0C4D8E6E6CF3}"/>
+                <a16:creationId xmlns:a16="http://schemas.microsoft.com/office/drawing/2014/main" id="{E014C177-40D9-478D-A636-9F88C64EE44A}"/>
               </a:ext>
             </a:extLst>
           </p:cNvPr>
@@ -10926,7 +10926,7 @@
           <p:cNvPr id="19" name="">
             <a:extLst xmlns:a="http://schemas.openxmlformats.org/drawingml/2006/main">
               <a:ext uri="{FF2B5EF4-FFF2-40B4-BE49-F238E27FC236}">
-                <a16:creationId xmlns:a16="http://schemas.microsoft.com/office/drawing/2014/main" id="{BBD1A865-A661-46F3-8F37-041B3AD38D99}"/>
+                <a16:creationId xmlns:a16="http://schemas.microsoft.com/office/drawing/2014/main" id="{54AD52BD-8C5F-4110-9D55-312B7929BFFF}"/>
               </a:ext>
             </a:extLst>
           </p:cNvPr>
@@ -10984,7 +10984,7 @@
           <p:cNvPr id="20" name="">
             <a:extLst xmlns:a="http://schemas.openxmlformats.org/drawingml/2006/main">
               <a:ext uri="{FF2B5EF4-FFF2-40B4-BE49-F238E27FC236}">
-                <a16:creationId xmlns:a16="http://schemas.microsoft.com/office/drawing/2014/main" id="{39FB21F0-E3B3-4B07-A9DF-E2F5FE13ED68}"/>
+                <a16:creationId xmlns:a16="http://schemas.microsoft.com/office/drawing/2014/main" id="{EE12A31A-A36E-4EA5-ABCD-FF7967C71FD7}"/>
               </a:ext>
             </a:extLst>
           </p:cNvPr>
@@ -11042,7 +11042,7 @@
           <p:cNvPr id="21" name="">
             <a:extLst xmlns:a="http://schemas.openxmlformats.org/drawingml/2006/main">
               <a:ext uri="{FF2B5EF4-FFF2-40B4-BE49-F238E27FC236}">
-                <a16:creationId xmlns:a16="http://schemas.microsoft.com/office/drawing/2014/main" id="{A1C3474E-7CF0-4172-9C7A-20269E33F4E6}"/>
+                <a16:creationId xmlns:a16="http://schemas.microsoft.com/office/drawing/2014/main" id="{C6A761BC-5F5D-4F8A-89BC-F9FC5D264EAB}"/>
               </a:ext>
             </a:extLst>
           </p:cNvPr>
@@ -11100,7 +11100,7 @@
           <p:cNvPr id="22" name="">
             <a:extLst xmlns:a="http://schemas.openxmlformats.org/drawingml/2006/main">
               <a:ext uri="{FF2B5EF4-FFF2-40B4-BE49-F238E27FC236}">
-                <a16:creationId xmlns:a16="http://schemas.microsoft.com/office/drawing/2014/main" id="{B58D6CD1-F393-4A8D-B3EC-32A61D1E565E}"/>
+                <a16:creationId xmlns:a16="http://schemas.microsoft.com/office/drawing/2014/main" id="{983E9BA3-0993-4DDB-A182-04065E512122}"/>
               </a:ext>
             </a:extLst>
           </p:cNvPr>
@@ -11135,7 +11135,7 @@
           <p:cNvPr id="23" name="">
             <a:extLst xmlns:a="http://schemas.openxmlformats.org/drawingml/2006/main">
               <a:ext uri="{FF2B5EF4-FFF2-40B4-BE49-F238E27FC236}">
-                <a16:creationId xmlns:a16="http://schemas.microsoft.com/office/drawing/2014/main" id="{A116F8C1-8C52-4C95-AD7C-627B0EE6A855}"/>
+                <a16:creationId xmlns:a16="http://schemas.microsoft.com/office/drawing/2014/main" id="{401FFB8C-5645-46DB-900B-58F08F5866FC}"/>
               </a:ext>
             </a:extLst>
           </p:cNvPr>
@@ -11193,7 +11193,7 @@
           <p:cNvPr id="24" name="">
             <a:extLst xmlns:a="http://schemas.openxmlformats.org/drawingml/2006/main">
               <a:ext uri="{FF2B5EF4-FFF2-40B4-BE49-F238E27FC236}">
-                <a16:creationId xmlns:a16="http://schemas.microsoft.com/office/drawing/2014/main" id="{2CBCF7D6-38DF-4C95-86ED-9284507D89A6}"/>
+                <a16:creationId xmlns:a16="http://schemas.microsoft.com/office/drawing/2014/main" id="{00A4AE52-BCD0-40CB-94DC-5FF0B9E92699}"/>
               </a:ext>
             </a:extLst>
           </p:cNvPr>
@@ -11241,7 +11241,7 @@
                 <a:ea typeface="Aptos"/>
                 <a:cs typeface="Aptos"/>
               </a:rPr>
-              <a:t>WATERS NEXT GEN COMPETITIVE INTELLIGENCE · 13 AUG 2026 · waters-ci-20260813070817</a:t>
+              <a:t>WATERS NEXT GEN COMPETITIVE INTELLIGENCE · 17 AUG 2026 · waters-ci-20260817124300</a:t>
             </a:r>
           </a:p>
         </p:txBody>
@@ -11251,7 +11251,7 @@
           <p:cNvPr id="25" name="">
             <a:extLst xmlns:a="http://schemas.openxmlformats.org/drawingml/2006/main">
               <a:ext uri="{FF2B5EF4-FFF2-40B4-BE49-F238E27FC236}">
-                <a16:creationId xmlns:a16="http://schemas.microsoft.com/office/drawing/2014/main" id="{377678F5-E563-4E40-BB88-AFFEC3B9FDC6}"/>
+                <a16:creationId xmlns:a16="http://schemas.microsoft.com/office/drawing/2014/main" id="{51B27A01-F313-41E0-B36E-5D5FE3A8D506}"/>
               </a:ext>
             </a:extLst>
           </p:cNvPr>
@@ -11307,7 +11307,7 @@
     </p:spTree>
     <p:extLst>
       <p:ext uri="{BB962C8B-B14F-4D97-AF65-F5344CB8AC3E}">
-        <p14:creationId xmlns:p14="http://schemas.microsoft.com/office/powerpoint/2010/main" val="1263370584"/>
+        <p14:creationId xmlns:p14="http://schemas.microsoft.com/office/powerpoint/2010/main" val="786264057"/>
       </p:ext>
     </p:extLst>
   </p:cSld>
@@ -11338,7 +11338,7 @@
           <p:cNvPr id="38" name="">
             <a:extLst xmlns:a="http://schemas.openxmlformats.org/drawingml/2006/main">
               <a:ext uri="{FF2B5EF4-FFF2-40B4-BE49-F238E27FC236}">
-                <a16:creationId xmlns:a16="http://schemas.microsoft.com/office/drawing/2014/main" id="{A7D0040D-16E2-414B-B809-D74C29796C3E}"/>
+                <a16:creationId xmlns:a16="http://schemas.microsoft.com/office/drawing/2014/main" id="{42C858C8-8156-46AF-B1D9-F10053F18C22}"/>
               </a:ext>
             </a:extLst>
           </p:cNvPr>
@@ -11396,7 +11396,7 @@
           <p:cNvPr id="2" name="">
             <a:extLst xmlns:a="http://schemas.openxmlformats.org/drawingml/2006/main">
               <a:ext uri="{FF2B5EF4-FFF2-40B4-BE49-F238E27FC236}">
-                <a16:creationId xmlns:a16="http://schemas.microsoft.com/office/drawing/2014/main" id="{A083B339-E8F7-44EA-A758-5A0913E31C61}"/>
+                <a16:creationId xmlns:a16="http://schemas.microsoft.com/office/drawing/2014/main" id="{F5F146B2-0137-4D13-A458-94AFF1992E95}"/>
               </a:ext>
             </a:extLst>
           </p:cNvPr>
@@ -11454,7 +11454,7 @@
           <p:cNvPr id="3" name="">
             <a:extLst xmlns:a="http://schemas.openxmlformats.org/drawingml/2006/main">
               <a:ext uri="{FF2B5EF4-FFF2-40B4-BE49-F238E27FC236}">
-                <a16:creationId xmlns:a16="http://schemas.microsoft.com/office/drawing/2014/main" id="{08CF3CDE-CB5C-4DA1-BBCB-B8A1BC6476C5}"/>
+                <a16:creationId xmlns:a16="http://schemas.microsoft.com/office/drawing/2014/main" id="{5CC53B60-EDF8-44D8-8D6E-0845D1D5F9B2}"/>
               </a:ext>
             </a:extLst>
           </p:cNvPr>
@@ -11512,7 +11512,7 @@
           <p:cNvPr id="4" name="">
             <a:extLst xmlns:a="http://schemas.openxmlformats.org/drawingml/2006/main">
               <a:ext uri="{FF2B5EF4-FFF2-40B4-BE49-F238E27FC236}">
-                <a16:creationId xmlns:a16="http://schemas.microsoft.com/office/drawing/2014/main" id="{341775EA-5363-442B-95D8-448EB54D682C}"/>
+                <a16:creationId xmlns:a16="http://schemas.microsoft.com/office/drawing/2014/main" id="{7D227110-A4D4-4D8B-A7FC-A62918B0DE8E}"/>
               </a:ext>
             </a:extLst>
           </p:cNvPr>
@@ -11545,7 +11545,7 @@
           <p:cNvPr id="5" name="">
             <a:extLst xmlns:a="http://schemas.openxmlformats.org/drawingml/2006/main">
               <a:ext uri="{FF2B5EF4-FFF2-40B4-BE49-F238E27FC236}">
-                <a16:creationId xmlns:a16="http://schemas.microsoft.com/office/drawing/2014/main" id="{3BB5569E-886F-42D2-B734-9D8D979F3856}"/>
+                <a16:creationId xmlns:a16="http://schemas.microsoft.com/office/drawing/2014/main" id="{F0BC3547-C419-4EBF-AF65-512D926CC2D0}"/>
               </a:ext>
             </a:extLst>
           </p:cNvPr>
@@ -11603,7 +11603,7 @@
           <p:cNvPr id="6" name="">
             <a:extLst xmlns:a="http://schemas.openxmlformats.org/drawingml/2006/main">
               <a:ext uri="{FF2B5EF4-FFF2-40B4-BE49-F238E27FC236}">
-                <a16:creationId xmlns:a16="http://schemas.microsoft.com/office/drawing/2014/main" id="{54FC7C4C-46D9-4299-ABF6-4AEA24B32767}"/>
+                <a16:creationId xmlns:a16="http://schemas.microsoft.com/office/drawing/2014/main" id="{30C3E8DB-B3A9-401E-A3E2-B9CEAF7E8544}"/>
               </a:ext>
             </a:extLst>
           </p:cNvPr>
@@ -11661,7 +11661,7 @@
           <p:cNvPr id="7" name="">
             <a:extLst xmlns:a="http://schemas.openxmlformats.org/drawingml/2006/main">
               <a:ext uri="{FF2B5EF4-FFF2-40B4-BE49-F238E27FC236}">
-                <a16:creationId xmlns:a16="http://schemas.microsoft.com/office/drawing/2014/main" id="{BACD637D-EB59-467D-BAC2-85A041A49EAF}"/>
+                <a16:creationId xmlns:a16="http://schemas.microsoft.com/office/drawing/2014/main" id="{4112535E-FD8A-48D2-A4C1-E72241BC7DC3}"/>
               </a:ext>
             </a:extLst>
           </p:cNvPr>
@@ -11717,10 +11717,10 @@
       <p:sp>
         <p:nvSpPr>
           <p:cNvPr id="8" name="">
-            <a:hlinkClick xmlns:r="http://schemas.openxmlformats.org/officeDocument/2006/relationships" xmlns:a="http://schemas.openxmlformats.org/drawingml/2006/main" r:id="Red9b1478fb1b485e"/>
-            <a:extLst xmlns:a="http://schemas.openxmlformats.org/drawingml/2006/main">
-              <a:ext uri="{FF2B5EF4-FFF2-40B4-BE49-F238E27FC236}">
-                <a16:creationId xmlns:a16="http://schemas.microsoft.com/office/drawing/2014/main" id="{FC685DDE-6FFE-4C19-BB2E-E2D318C966C3}"/>
+            <a:hlinkClick xmlns:r="http://schemas.openxmlformats.org/officeDocument/2006/relationships" xmlns:a="http://schemas.openxmlformats.org/drawingml/2006/main" r:id="R4dc2a76046144483"/>
+            <a:extLst xmlns:a="http://schemas.openxmlformats.org/drawingml/2006/main">
+              <a:ext uri="{FF2B5EF4-FFF2-40B4-BE49-F238E27FC236}">
+                <a16:creationId xmlns:a16="http://schemas.microsoft.com/office/drawing/2014/main" id="{F126D89D-DC51-409C-A32E-0C4388377FDD}"/>
               </a:ext>
             </a:extLst>
           </p:cNvPr>
@@ -11768,7 +11768,7 @@
                 <a:ea typeface="Aptos"/>
                 <a:cs typeface="Aptos"/>
               </a:rPr>
-              <a:t>https://pubmed.ncbi.nlm.nih.gov/?term=%28%28PFAS+OR+%22per-+and+polyfluoroalkyl%22%29+AND+%28%22LC-MS%22+OR+%22LC-MS%2FMS%22+OR+chromatography%29%29+AND+%28%222025%2F08%2F13%22%5BDate+-+Publication%5D+%3A+%222026%2F08%2F13%22%5BDate+-+Publication%5D%29</a:t>
+              <a:t>https://pubmed.ncbi.nlm.nih.gov/?term=%28%28PFAS+OR+%22per-+and+polyfluoroalkyl%22%29+AND+%28%22LC-MS%22+OR+%22LC-MS%2FMS%22+OR+chromatography%29%29+AND+%28%222025%2F08%2F17%22%5BDate+-+Publication%5D+%3A+%222026%2F08%2F17%22%5BDate+-+Publication%5D%29</a:t>
             </a:r>
           </a:p>
         </p:txBody>
@@ -11778,7 +11778,7 @@
           <p:cNvPr id="9" name="">
             <a:extLst xmlns:a="http://schemas.openxmlformats.org/drawingml/2006/main">
               <a:ext uri="{FF2B5EF4-FFF2-40B4-BE49-F238E27FC236}">
-                <a16:creationId xmlns:a16="http://schemas.microsoft.com/office/drawing/2014/main" id="{35FF3872-34F8-4D44-82B9-546A4F9F06C7}"/>
+                <a16:creationId xmlns:a16="http://schemas.microsoft.com/office/drawing/2014/main" id="{013820AF-56B6-472D-94FF-F730819FE7AC}"/>
               </a:ext>
             </a:extLst>
           </p:cNvPr>
@@ -11811,7 +11811,7 @@
           <p:cNvPr id="10" name="">
             <a:extLst xmlns:a="http://schemas.openxmlformats.org/drawingml/2006/main">
               <a:ext uri="{FF2B5EF4-FFF2-40B4-BE49-F238E27FC236}">
-                <a16:creationId xmlns:a16="http://schemas.microsoft.com/office/drawing/2014/main" id="{83BCD9EA-18D7-4729-B3CD-9A8BEAC8A099}"/>
+                <a16:creationId xmlns:a16="http://schemas.microsoft.com/office/drawing/2014/main" id="{0E53F82C-3D81-46A2-90F1-6D209C2AFB7F}"/>
               </a:ext>
             </a:extLst>
           </p:cNvPr>
@@ -11869,7 +11869,7 @@
           <p:cNvPr id="11" name="">
             <a:extLst xmlns:a="http://schemas.openxmlformats.org/drawingml/2006/main">
               <a:ext uri="{FF2B5EF4-FFF2-40B4-BE49-F238E27FC236}">
-                <a16:creationId xmlns:a16="http://schemas.microsoft.com/office/drawing/2014/main" id="{4C034143-C366-4D60-A884-DDB5E7249662}"/>
+                <a16:creationId xmlns:a16="http://schemas.microsoft.com/office/drawing/2014/main" id="{BB719665-FE66-4499-A93B-6C48E700464C}"/>
               </a:ext>
             </a:extLst>
           </p:cNvPr>
@@ -11927,7 +11927,7 @@
           <p:cNvPr id="12" name="">
             <a:extLst xmlns:a="http://schemas.openxmlformats.org/drawingml/2006/main">
               <a:ext uri="{FF2B5EF4-FFF2-40B4-BE49-F238E27FC236}">
-                <a16:creationId xmlns:a16="http://schemas.microsoft.com/office/drawing/2014/main" id="{78966395-28F2-4E63-A675-6865D038C830}"/>
+                <a16:creationId xmlns:a16="http://schemas.microsoft.com/office/drawing/2014/main" id="{9C42DB96-4965-42B8-9CF0-967C5DEDDB6C}"/>
               </a:ext>
             </a:extLst>
           </p:cNvPr>
@@ -11983,10 +11983,10 @@
       <p:sp>
         <p:nvSpPr>
           <p:cNvPr id="13" name="">
-            <a:hlinkClick xmlns:r="http://schemas.openxmlformats.org/officeDocument/2006/relationships" xmlns:a="http://schemas.openxmlformats.org/drawingml/2006/main" r:id="R0a9e04737bfb4d9c"/>
-            <a:extLst xmlns:a="http://schemas.openxmlformats.org/drawingml/2006/main">
-              <a:ext uri="{FF2B5EF4-FFF2-40B4-BE49-F238E27FC236}">
-                <a16:creationId xmlns:a16="http://schemas.microsoft.com/office/drawing/2014/main" id="{08DDEFA5-DB41-4FB0-B46F-BB5D2F424A8D}"/>
+            <a:hlinkClick xmlns:r="http://schemas.openxmlformats.org/officeDocument/2006/relationships" xmlns:a="http://schemas.openxmlformats.org/drawingml/2006/main" r:id="R86858532b1b84cd8"/>
+            <a:extLst xmlns:a="http://schemas.openxmlformats.org/drawingml/2006/main">
+              <a:ext uri="{FF2B5EF4-FFF2-40B4-BE49-F238E27FC236}">
+                <a16:creationId xmlns:a16="http://schemas.microsoft.com/office/drawing/2014/main" id="{7CF24DAA-98ED-486A-BBBB-750E1E56F77C}"/>
               </a:ext>
             </a:extLst>
           </p:cNvPr>
@@ -12044,7 +12044,7 @@
           <p:cNvPr id="14" name="">
             <a:extLst xmlns:a="http://schemas.openxmlformats.org/drawingml/2006/main">
               <a:ext uri="{FF2B5EF4-FFF2-40B4-BE49-F238E27FC236}">
-                <a16:creationId xmlns:a16="http://schemas.microsoft.com/office/drawing/2014/main" id="{2A922C17-DCA1-4B3B-BFBB-9665AC140D1D}"/>
+                <a16:creationId xmlns:a16="http://schemas.microsoft.com/office/drawing/2014/main" id="{745E7327-7C61-488A-8D71-17BA8A9781B5}"/>
               </a:ext>
             </a:extLst>
           </p:cNvPr>
@@ -12077,7 +12077,7 @@
           <p:cNvPr id="15" name="">
             <a:extLst xmlns:a="http://schemas.openxmlformats.org/drawingml/2006/main">
               <a:ext uri="{FF2B5EF4-FFF2-40B4-BE49-F238E27FC236}">
-                <a16:creationId xmlns:a16="http://schemas.microsoft.com/office/drawing/2014/main" id="{5D250DB1-1F4A-4C31-996E-145BFEF43AE8}"/>
+                <a16:creationId xmlns:a16="http://schemas.microsoft.com/office/drawing/2014/main" id="{7907DC36-A542-4392-B0EF-A4CF7189F23A}"/>
               </a:ext>
             </a:extLst>
           </p:cNvPr>
@@ -12135,7 +12135,7 @@
           <p:cNvPr id="16" name="">
             <a:extLst xmlns:a="http://schemas.openxmlformats.org/drawingml/2006/main">
               <a:ext uri="{FF2B5EF4-FFF2-40B4-BE49-F238E27FC236}">
-                <a16:creationId xmlns:a16="http://schemas.microsoft.com/office/drawing/2014/main" id="{72D4F003-9B66-48C6-AD69-7ACCD3FBFF89}"/>
+                <a16:creationId xmlns:a16="http://schemas.microsoft.com/office/drawing/2014/main" id="{D45E9C14-63AB-418E-BACB-755287AF4E73}"/>
               </a:ext>
             </a:extLst>
           </p:cNvPr>
@@ -12193,7 +12193,7 @@
           <p:cNvPr id="17" name="">
             <a:extLst xmlns:a="http://schemas.openxmlformats.org/drawingml/2006/main">
               <a:ext uri="{FF2B5EF4-FFF2-40B4-BE49-F238E27FC236}">
-                <a16:creationId xmlns:a16="http://schemas.microsoft.com/office/drawing/2014/main" id="{2BC520CE-872E-432F-BCA6-C04F095844AA}"/>
+                <a16:creationId xmlns:a16="http://schemas.microsoft.com/office/drawing/2014/main" id="{82EB48B5-8CDB-42F0-8A2E-281D387B437C}"/>
               </a:ext>
             </a:extLst>
           </p:cNvPr>
@@ -12249,10 +12249,10 @@
       <p:sp>
         <p:nvSpPr>
           <p:cNvPr id="18" name="">
-            <a:hlinkClick xmlns:r="http://schemas.openxmlformats.org/officeDocument/2006/relationships" xmlns:a="http://schemas.openxmlformats.org/drawingml/2006/main" r:id="R096cb83171b34616"/>
-            <a:extLst xmlns:a="http://schemas.openxmlformats.org/drawingml/2006/main">
-              <a:ext uri="{FF2B5EF4-FFF2-40B4-BE49-F238E27FC236}">
-                <a16:creationId xmlns:a16="http://schemas.microsoft.com/office/drawing/2014/main" id="{C6F19FE4-285E-42B1-87E4-BBFCA9EC9B7F}"/>
+            <a:hlinkClick xmlns:r="http://schemas.openxmlformats.org/officeDocument/2006/relationships" xmlns:a="http://schemas.openxmlformats.org/drawingml/2006/main" r:id="R2d2e81e6d61741ef"/>
+            <a:extLst xmlns:a="http://schemas.openxmlformats.org/drawingml/2006/main">
+              <a:ext uri="{FF2B5EF4-FFF2-40B4-BE49-F238E27FC236}">
+                <a16:creationId xmlns:a16="http://schemas.microsoft.com/office/drawing/2014/main" id="{683698E7-1075-466E-902D-013150684011}"/>
               </a:ext>
             </a:extLst>
           </p:cNvPr>
@@ -12310,7 +12310,7 @@
           <p:cNvPr id="19" name="">
             <a:extLst xmlns:a="http://schemas.openxmlformats.org/drawingml/2006/main">
               <a:ext uri="{FF2B5EF4-FFF2-40B4-BE49-F238E27FC236}">
-                <a16:creationId xmlns:a16="http://schemas.microsoft.com/office/drawing/2014/main" id="{A4E29824-4C83-4314-AD1F-B12F985C81E5}"/>
+                <a16:creationId xmlns:a16="http://schemas.microsoft.com/office/drawing/2014/main" id="{B01F5203-CB11-45A1-9FCB-3B2E4CBFB5FE}"/>
               </a:ext>
             </a:extLst>
           </p:cNvPr>
@@ -12343,7 +12343,7 @@
           <p:cNvPr id="20" name="">
             <a:extLst xmlns:a="http://schemas.openxmlformats.org/drawingml/2006/main">
               <a:ext uri="{FF2B5EF4-FFF2-40B4-BE49-F238E27FC236}">
-                <a16:creationId xmlns:a16="http://schemas.microsoft.com/office/drawing/2014/main" id="{76D6CA4A-B9FB-4A8B-8BF5-46F02E2481B0}"/>
+                <a16:creationId xmlns:a16="http://schemas.microsoft.com/office/drawing/2014/main" id="{9329C9D9-81C9-4BBA-9DFB-843BBC34B53A}"/>
               </a:ext>
             </a:extLst>
           </p:cNvPr>
@@ -12401,7 +12401,7 @@
           <p:cNvPr id="21" name="">
             <a:extLst xmlns:a="http://schemas.openxmlformats.org/drawingml/2006/main">
               <a:ext uri="{FF2B5EF4-FFF2-40B4-BE49-F238E27FC236}">
-                <a16:creationId xmlns:a16="http://schemas.microsoft.com/office/drawing/2014/main" id="{9F7C72ED-ABBB-4CBB-8E53-4535966897FD}"/>
+                <a16:creationId xmlns:a16="http://schemas.microsoft.com/office/drawing/2014/main" id="{9CA26E1E-D621-44D0-B118-CF52A9777A75}"/>
               </a:ext>
             </a:extLst>
           </p:cNvPr>
@@ -12459,7 +12459,7 @@
           <p:cNvPr id="22" name="">
             <a:extLst xmlns:a="http://schemas.openxmlformats.org/drawingml/2006/main">
               <a:ext uri="{FF2B5EF4-FFF2-40B4-BE49-F238E27FC236}">
-                <a16:creationId xmlns:a16="http://schemas.microsoft.com/office/drawing/2014/main" id="{88C37170-FFEB-499F-910D-B7A6FF151E76}"/>
+                <a16:creationId xmlns:a16="http://schemas.microsoft.com/office/drawing/2014/main" id="{D0F932E9-665A-456E-B3D5-2DFD6B07A97A}"/>
               </a:ext>
             </a:extLst>
           </p:cNvPr>
@@ -12515,10 +12515,10 @@
       <p:sp>
         <p:nvSpPr>
           <p:cNvPr id="23" name="">
-            <a:hlinkClick xmlns:r="http://schemas.openxmlformats.org/officeDocument/2006/relationships" xmlns:a="http://schemas.openxmlformats.org/drawingml/2006/main" r:id="Rf7328ad13df04350"/>
-            <a:extLst xmlns:a="http://schemas.openxmlformats.org/drawingml/2006/main">
-              <a:ext uri="{FF2B5EF4-FFF2-40B4-BE49-F238E27FC236}">
-                <a16:creationId xmlns:a16="http://schemas.microsoft.com/office/drawing/2014/main" id="{C7839549-6FE1-4D09-8350-5DBDAFC231A1}"/>
+            <a:hlinkClick xmlns:r="http://schemas.openxmlformats.org/officeDocument/2006/relationships" xmlns:a="http://schemas.openxmlformats.org/drawingml/2006/main" r:id="R30d64dfb53c84636"/>
+            <a:extLst xmlns:a="http://schemas.openxmlformats.org/drawingml/2006/main">
+              <a:ext uri="{FF2B5EF4-FFF2-40B4-BE49-F238E27FC236}">
+                <a16:creationId xmlns:a16="http://schemas.microsoft.com/office/drawing/2014/main" id="{76CDAD7B-5EC0-424B-8925-65685A71DECC}"/>
               </a:ext>
             </a:extLst>
           </p:cNvPr>
@@ -12576,7 +12576,7 @@
           <p:cNvPr id="24" name="">
             <a:extLst xmlns:a="http://schemas.openxmlformats.org/drawingml/2006/main">
               <a:ext uri="{FF2B5EF4-FFF2-40B4-BE49-F238E27FC236}">
-                <a16:creationId xmlns:a16="http://schemas.microsoft.com/office/drawing/2014/main" id="{FC1E90A3-50A2-4898-9424-DA602DBDDE1F}"/>
+                <a16:creationId xmlns:a16="http://schemas.microsoft.com/office/drawing/2014/main" id="{FF726ABD-C512-45DC-BB4A-80303E5D4A6F}"/>
               </a:ext>
             </a:extLst>
           </p:cNvPr>
@@ -12609,7 +12609,7 @@
           <p:cNvPr id="25" name="">
             <a:extLst xmlns:a="http://schemas.openxmlformats.org/drawingml/2006/main">
               <a:ext uri="{FF2B5EF4-FFF2-40B4-BE49-F238E27FC236}">
-                <a16:creationId xmlns:a16="http://schemas.microsoft.com/office/drawing/2014/main" id="{18F5A1C4-568D-4A45-AAB8-EEE1FE78553E}"/>
+                <a16:creationId xmlns:a16="http://schemas.microsoft.com/office/drawing/2014/main" id="{29DC2B00-8641-4E28-A8FE-8400E21F4A7C}"/>
               </a:ext>
             </a:extLst>
           </p:cNvPr>
@@ -12667,7 +12667,7 @@
           <p:cNvPr id="26" name="">
             <a:extLst xmlns:a="http://schemas.openxmlformats.org/drawingml/2006/main">
               <a:ext uri="{FF2B5EF4-FFF2-40B4-BE49-F238E27FC236}">
-                <a16:creationId xmlns:a16="http://schemas.microsoft.com/office/drawing/2014/main" id="{0CA1D05E-B648-498C-8E73-968DDC02D43A}"/>
+                <a16:creationId xmlns:a16="http://schemas.microsoft.com/office/drawing/2014/main" id="{7542D708-3CA9-411D-80C8-C5DF57292CD3}"/>
               </a:ext>
             </a:extLst>
           </p:cNvPr>
@@ -12725,7 +12725,7 @@
           <p:cNvPr id="27" name="">
             <a:extLst xmlns:a="http://schemas.openxmlformats.org/drawingml/2006/main">
               <a:ext uri="{FF2B5EF4-FFF2-40B4-BE49-F238E27FC236}">
-                <a16:creationId xmlns:a16="http://schemas.microsoft.com/office/drawing/2014/main" id="{CD9F0641-50E6-4D8E-97AF-6A2B5C6CFE1C}"/>
+                <a16:creationId xmlns:a16="http://schemas.microsoft.com/office/drawing/2014/main" id="{973F832C-3784-4E33-BC21-F71416DA99D1}"/>
               </a:ext>
             </a:extLst>
           </p:cNvPr>
@@ -12781,10 +12781,10 @@
       <p:sp>
         <p:nvSpPr>
           <p:cNvPr id="28" name="">
-            <a:hlinkClick xmlns:r="http://schemas.openxmlformats.org/officeDocument/2006/relationships" xmlns:a="http://schemas.openxmlformats.org/drawingml/2006/main" r:id="Rec13bdbc53604572"/>
-            <a:extLst xmlns:a="http://schemas.openxmlformats.org/drawingml/2006/main">
-              <a:ext uri="{FF2B5EF4-FFF2-40B4-BE49-F238E27FC236}">
-                <a16:creationId xmlns:a16="http://schemas.microsoft.com/office/drawing/2014/main" id="{1FDD1E8D-055D-4576-9F69-AA3124185580}"/>
+            <a:hlinkClick xmlns:r="http://schemas.openxmlformats.org/officeDocument/2006/relationships" xmlns:a="http://schemas.openxmlformats.org/drawingml/2006/main" r:id="Rf3cfe9ea83a2499d"/>
+            <a:extLst xmlns:a="http://schemas.openxmlformats.org/drawingml/2006/main">
+              <a:ext uri="{FF2B5EF4-FFF2-40B4-BE49-F238E27FC236}">
+                <a16:creationId xmlns:a16="http://schemas.microsoft.com/office/drawing/2014/main" id="{5848CDEA-B095-4F10-ABAF-1A5C85DFB4B5}"/>
               </a:ext>
             </a:extLst>
           </p:cNvPr>
@@ -12842,7 +12842,7 @@
           <p:cNvPr id="29" name="">
             <a:extLst xmlns:a="http://schemas.openxmlformats.org/drawingml/2006/main">
               <a:ext uri="{FF2B5EF4-FFF2-40B4-BE49-F238E27FC236}">
-                <a16:creationId xmlns:a16="http://schemas.microsoft.com/office/drawing/2014/main" id="{8CD05A75-CB74-4407-9C76-56768C5BAED4}"/>
+                <a16:creationId xmlns:a16="http://schemas.microsoft.com/office/drawing/2014/main" id="{78930B46-6D0F-4D7C-9042-93CE74FF4A73}"/>
               </a:ext>
             </a:extLst>
           </p:cNvPr>
@@ -12875,7 +12875,7 @@
           <p:cNvPr id="30" name="">
             <a:extLst xmlns:a="http://schemas.openxmlformats.org/drawingml/2006/main">
               <a:ext uri="{FF2B5EF4-FFF2-40B4-BE49-F238E27FC236}">
-                <a16:creationId xmlns:a16="http://schemas.microsoft.com/office/drawing/2014/main" id="{306A5E26-A0F7-4D49-B488-8D640AB59151}"/>
+                <a16:creationId xmlns:a16="http://schemas.microsoft.com/office/drawing/2014/main" id="{A3C2CB32-5A0F-45BF-8FD9-F82150DB5E6A}"/>
               </a:ext>
             </a:extLst>
           </p:cNvPr>
@@ -12933,7 +12933,7 @@
           <p:cNvPr id="31" name="">
             <a:extLst xmlns:a="http://schemas.openxmlformats.org/drawingml/2006/main">
               <a:ext uri="{FF2B5EF4-FFF2-40B4-BE49-F238E27FC236}">
-                <a16:creationId xmlns:a16="http://schemas.microsoft.com/office/drawing/2014/main" id="{96B7439A-E86C-4FF1-99C9-C7EAB833A897}"/>
+                <a16:creationId xmlns:a16="http://schemas.microsoft.com/office/drawing/2014/main" id="{D42B78DE-7684-40B0-8BF4-5F04316BBB17}"/>
               </a:ext>
             </a:extLst>
           </p:cNvPr>
@@ -12991,7 +12991,7 @@
           <p:cNvPr id="32" name="">
             <a:extLst xmlns:a="http://schemas.openxmlformats.org/drawingml/2006/main">
               <a:ext uri="{FF2B5EF4-FFF2-40B4-BE49-F238E27FC236}">
-                <a16:creationId xmlns:a16="http://schemas.microsoft.com/office/drawing/2014/main" id="{62D44E11-D7E9-4CF0-B41F-103288582632}"/>
+                <a16:creationId xmlns:a16="http://schemas.microsoft.com/office/drawing/2014/main" id="{0CC45C86-BC00-4E7C-9A44-D398FEF91580}"/>
               </a:ext>
             </a:extLst>
           </p:cNvPr>
@@ -13047,10 +13047,10 @@
       <p:sp>
         <p:nvSpPr>
           <p:cNvPr id="33" name="">
-            <a:hlinkClick xmlns:r="http://schemas.openxmlformats.org/officeDocument/2006/relationships" xmlns:a="http://schemas.openxmlformats.org/drawingml/2006/main" r:id="R6159171908fe4e0d"/>
-            <a:extLst xmlns:a="http://schemas.openxmlformats.org/drawingml/2006/main">
-              <a:ext uri="{FF2B5EF4-FFF2-40B4-BE49-F238E27FC236}">
-                <a16:creationId xmlns:a16="http://schemas.microsoft.com/office/drawing/2014/main" id="{4838532F-4BF1-4016-92C2-65EA17BE32CD}"/>
+            <a:hlinkClick xmlns:r="http://schemas.openxmlformats.org/officeDocument/2006/relationships" xmlns:a="http://schemas.openxmlformats.org/drawingml/2006/main" r:id="R4015d6f821aa4e23"/>
+            <a:extLst xmlns:a="http://schemas.openxmlformats.org/drawingml/2006/main">
+              <a:ext uri="{FF2B5EF4-FFF2-40B4-BE49-F238E27FC236}">
+                <a16:creationId xmlns:a16="http://schemas.microsoft.com/office/drawing/2014/main" id="{8E348F2B-8E70-443B-BDF4-6FDED28337BA}"/>
               </a:ext>
             </a:extLst>
           </p:cNvPr>
@@ -13108,7 +13108,7 @@
           <p:cNvPr id="34" name="">
             <a:extLst xmlns:a="http://schemas.openxmlformats.org/drawingml/2006/main">
               <a:ext uri="{FF2B5EF4-FFF2-40B4-BE49-F238E27FC236}">
-                <a16:creationId xmlns:a16="http://schemas.microsoft.com/office/drawing/2014/main" id="{C43542C2-24CF-4BFE-9A35-ED57D7C7CDF0}"/>
+                <a16:creationId xmlns:a16="http://schemas.microsoft.com/office/drawing/2014/main" id="{39F1C259-A794-4AAF-810C-865E4997E232}"/>
               </a:ext>
             </a:extLst>
           </p:cNvPr>
@@ -13143,7 +13143,7 @@
           <p:cNvPr id="35" name="">
             <a:extLst xmlns:a="http://schemas.openxmlformats.org/drawingml/2006/main">
               <a:ext uri="{FF2B5EF4-FFF2-40B4-BE49-F238E27FC236}">
-                <a16:creationId xmlns:a16="http://schemas.microsoft.com/office/drawing/2014/main" id="{B101A231-C197-4740-8DD3-5C918E2B2940}"/>
+                <a16:creationId xmlns:a16="http://schemas.microsoft.com/office/drawing/2014/main" id="{2C466B1F-5A32-4DF7-943F-9C230C82C8A3}"/>
               </a:ext>
             </a:extLst>
           </p:cNvPr>
@@ -13191,7 +13191,7 @@
                 <a:ea typeface="Aptos"/>
                 <a:cs typeface="Aptos"/>
               </a:rPr>
-              <a:t>Snapshot: waters-ci-20260813070817 · As of 2026-08-13T07:08:17 · Business magnitude requires Waters internal data.</a:t>
+              <a:t>Snapshot: waters-ci-20260817124300 · As of 2026-08-17T12:43:00 · Business magnitude requires Waters internal data.</a:t>
             </a:r>
           </a:p>
         </p:txBody>
@@ -13201,7 +13201,7 @@
           <p:cNvPr id="36" name="">
             <a:extLst xmlns:a="http://schemas.openxmlformats.org/drawingml/2006/main">
               <a:ext uri="{FF2B5EF4-FFF2-40B4-BE49-F238E27FC236}">
-                <a16:creationId xmlns:a16="http://schemas.microsoft.com/office/drawing/2014/main" id="{911CBF6B-60C5-4E99-938C-56F72DB24693}"/>
+                <a16:creationId xmlns:a16="http://schemas.microsoft.com/office/drawing/2014/main" id="{5F1FDF5F-F33D-4937-9CE5-C9EA28128AAC}"/>
               </a:ext>
             </a:extLst>
           </p:cNvPr>
@@ -13249,7 +13249,7 @@
                 <a:ea typeface="Aptos"/>
                 <a:cs typeface="Aptos"/>
               </a:rPr>
-              <a:t>WATERS NEXT GEN COMPETITIVE INTELLIGENCE · 13 AUG 2026 · waters-ci-20260813070817</a:t>
+              <a:t>WATERS NEXT GEN COMPETITIVE INTELLIGENCE · 17 AUG 2026 · waters-ci-20260817124300</a:t>
             </a:r>
           </a:p>
         </p:txBody>
@@ -13259,7 +13259,7 @@
           <p:cNvPr id="37" name="">
             <a:extLst xmlns:a="http://schemas.openxmlformats.org/drawingml/2006/main">
               <a:ext uri="{FF2B5EF4-FFF2-40B4-BE49-F238E27FC236}">
-                <a16:creationId xmlns:a16="http://schemas.microsoft.com/office/drawing/2014/main" id="{3AF99F69-B35D-4A36-8958-EB41B9DCDB0D}"/>
+                <a16:creationId xmlns:a16="http://schemas.microsoft.com/office/drawing/2014/main" id="{B5E83AA7-E29A-4BB1-A959-2C86AF2CA9D4}"/>
               </a:ext>
             </a:extLst>
           </p:cNvPr>
@@ -13315,7 +13315,7 @@
     </p:spTree>
     <p:extLst>
       <p:ext uri="{BB962C8B-B14F-4D97-AF65-F5344CB8AC3E}">
-        <p14:creationId xmlns:p14="http://schemas.microsoft.com/office/powerpoint/2010/main" val="989659359"/>
+        <p14:creationId xmlns:p14="http://schemas.microsoft.com/office/powerpoint/2010/main" val="1100017722"/>
       </p:ext>
     </p:extLst>
   </p:cSld>

</xml_diff>

<commit_message>
Deploy patent insights to engineering view
</commit_message>
<xml_diff>
--- a/deploy-site/exports/waters-nextgen-leadership-brief.pptx
+++ b/deploy-site/exports/waters-nextgen-leadership-brief.pptx
@@ -2,20 +2,20 @@
 <file path=ppt/presentation.xml><?xml version="1.0" encoding="utf-8"?>
 <p:presentation xmlns:p="http://schemas.openxmlformats.org/presentationml/2006/main">
   <p:sldMasterIdLst>
-    <p:sldMasterId xmlns:r="http://schemas.openxmlformats.org/officeDocument/2006/relationships" id="2147483648" r:id="R6b1221ea26fc4cff"/>
+    <p:sldMasterId xmlns:r="http://schemas.openxmlformats.org/officeDocument/2006/relationships" id="2147483648" r:id="R47025f820bd44dc9"/>
   </p:sldMasterIdLst>
   <p:notesMasterIdLst>
-    <p:notesMasterId xmlns:r="http://schemas.openxmlformats.org/officeDocument/2006/relationships" r:id="Re878d1ae7d544329"/>
+    <p:notesMasterId xmlns:r="http://schemas.openxmlformats.org/officeDocument/2006/relationships" r:id="Ra26fa839c44d4450"/>
   </p:notesMasterIdLst>
   <p:sldIdLst>
-    <p:sldId xmlns:r="http://schemas.openxmlformats.org/officeDocument/2006/relationships" id="256" r:id="R55ef541e454c4414"/>
-    <p:sldId xmlns:r="http://schemas.openxmlformats.org/officeDocument/2006/relationships" id="257" r:id="Rb8396b1e44934989"/>
-    <p:sldId xmlns:r="http://schemas.openxmlformats.org/officeDocument/2006/relationships" id="258" r:id="Rb880a0080a454b1c"/>
-    <p:sldId xmlns:r="http://schemas.openxmlformats.org/officeDocument/2006/relationships" id="259" r:id="Rf684c207b04c4789"/>
-    <p:sldId xmlns:r="http://schemas.openxmlformats.org/officeDocument/2006/relationships" id="260" r:id="R4dc6540b7c3b434e"/>
-    <p:sldId xmlns:r="http://schemas.openxmlformats.org/officeDocument/2006/relationships" id="261" r:id="Re462dde2ef0a4656"/>
-    <p:sldId xmlns:r="http://schemas.openxmlformats.org/officeDocument/2006/relationships" id="262" r:id="R5172897c1ad94410"/>
-    <p:sldId xmlns:r="http://schemas.openxmlformats.org/officeDocument/2006/relationships" id="263" r:id="Re3700c5afc444ef5"/>
+    <p:sldId xmlns:r="http://schemas.openxmlformats.org/officeDocument/2006/relationships" id="256" r:id="Rbbd4b53579344fb9"/>
+    <p:sldId xmlns:r="http://schemas.openxmlformats.org/officeDocument/2006/relationships" id="257" r:id="Rfdc95bf5ca9343a0"/>
+    <p:sldId xmlns:r="http://schemas.openxmlformats.org/officeDocument/2006/relationships" id="258" r:id="Re9ccaa700412492d"/>
+    <p:sldId xmlns:r="http://schemas.openxmlformats.org/officeDocument/2006/relationships" id="259" r:id="Rae6ac13d472a464b"/>
+    <p:sldId xmlns:r="http://schemas.openxmlformats.org/officeDocument/2006/relationships" id="260" r:id="R39662f3792504b4e"/>
+    <p:sldId xmlns:r="http://schemas.openxmlformats.org/officeDocument/2006/relationships" id="261" r:id="Rb48859e6fa594dee"/>
+    <p:sldId xmlns:r="http://schemas.openxmlformats.org/officeDocument/2006/relationships" id="262" r:id="R12c666dbf7664d59"/>
+    <p:sldId xmlns:r="http://schemas.openxmlformats.org/officeDocument/2006/relationships" id="263" r:id="R480b47ed46344084"/>
   </p:sldIdLst>
   <p:sldSz cx="12192000" cy="6858000"/>
   <p:notesSz cx="6858000" cy="9144000"/>
@@ -529,17 +529,17 @@
           </a:p>
           <a:p xmlns:a="http://schemas.openxmlformats.org/drawingml/2006/main">
             <a:r>
-              <a:t>- https://pubmed.ncbi.nlm.nih.gov/?term=%28%28%22laboratory+automation%22+OR+%22workflow+software%22+OR+%22AI%22%29+AND+%28%22LC-MS%22+OR+chromatography+OR+%22mass+spectrometry%22%29%29+AND+%28%222025%2F08%2F17%22%5BDate+-+Publication%5D+%3A+%222026%2F08%2F17%22%5BDate+-+Publication%5D%29</a:t>
-            </a:r>
-          </a:p>
-          <a:p xmlns:a="http://schemas.openxmlformats.org/drawingml/2006/main">
-            <a:r>
-              <a:t>- https://pubmed.ncbi.nlm.nih.gov/?term=%28%28PFAS+OR+%22per-+and+polyfluoroalkyl%22%29+AND+%28%22LC-MS%22+OR+%22LC-MS%2FMS%22+OR+chromatography%29%29+AND+%28%222025%2F08%2F17%22%5BDate+-+Publication%5D+%3A+%222026%2F08%2F17%22%5BDate+-+Publication%5D%29</a:t>
-            </a:r>
-          </a:p>
-          <a:p xmlns:a="http://schemas.openxmlformats.org/drawingml/2006/main">
-            <a:r>
-              <a:t>- https://pubmed.ncbi.nlm.nih.gov/?term=%28%28oligonucleotide+OR+%22nucleic+acid%22+OR+siRNA%29+AND+%28%22LC-MS%22+OR+chromatography+OR+%22mass+spectrometry%22%29%29+AND+%28%222025%2F08%2F17%22%5BDate+-+Publication%5D+%3A+%222026%2F08%2F17%22%5BDate+-+Publication%5D%29</a:t>
+              <a:t>- https://pubmed.ncbi.nlm.nih.gov/?term=%28%28%22laboratory+automation%22+OR+%22workflow+software%22+OR+%22AI%22%29+AND+%28%22LC-MS%22+OR+chromatography+OR+%22mass+spectrometry%22%29%29+AND+%28%222025%2F08%2F20%22%5BDate+-+Publication%5D+%3A+%222026%2F08%2F20%22%5BDate+-+Publication%5D%29</a:t>
+            </a:r>
+          </a:p>
+          <a:p xmlns:a="http://schemas.openxmlformats.org/drawingml/2006/main">
+            <a:r>
+              <a:t>- https://pubmed.ncbi.nlm.nih.gov/?term=%28%28PFAS+OR+%22per-+and+polyfluoroalkyl%22%29+AND+%28%22LC-MS%22+OR+%22LC-MS%2FMS%22+OR+chromatography%29%29+AND+%28%222025%2F08%2F20%22%5BDate+-+Publication%5D+%3A+%222026%2F08%2F20%22%5BDate+-+Publication%5D%29</a:t>
+            </a:r>
+          </a:p>
+          <a:p xmlns:a="http://schemas.openxmlformats.org/drawingml/2006/main">
+            <a:r>
+              <a:t>- https://pubmed.ncbi.nlm.nih.gov/?term=%28%28oligonucleotide+OR+%22nucleic+acid%22+OR+siRNA%29+AND+%28%22LC-MS%22+OR+chromatography+OR+%22mass+spectrometry%22%29%29+AND+%28%222025%2F08%2F20%22%5BDate+-+Publication%5D+%3A+%222026%2F08%2F20%22%5BDate+-+Publication%5D%29</a:t>
             </a:r>
           </a:p>
           <a:p xmlns:a="http://schemas.openxmlformats.org/drawingml/2006/main">
@@ -619,7 +619,7 @@
           </a:p>
           <a:p xmlns:a="http://schemas.openxmlformats.org/drawingml/2006/main">
             <a:r>
-              <a:t>- https://pubmed.ncbi.nlm.nih.gov/?term=%28%28PFAS+OR+%22per-+and+polyfluoroalkyl%22%29+AND+%28%22LC-MS%22+OR+%22LC-MS%2FMS%22+OR+chromatography%29%29+AND+%28%222025%2F08%2F17%22%5BDate+-+Publication%5D+%3A+%222026%2F08%2F17%22%5BDate+-+Publication%5D%29</a:t>
+              <a:t>- https://pubmed.ncbi.nlm.nih.gov/?term=%28%28PFAS+OR+%22per-+and+polyfluoroalkyl%22%29+AND+%28%22LC-MS%22+OR+%22LC-MS%2FMS%22+OR+chromatography%29%29+AND+%28%222025%2F08%2F20%22%5BDate+-+Publication%5D+%3A+%222026%2F08%2F20%22%5BDate+-+Publication%5D%29</a:t>
             </a:r>
           </a:p>
           <a:p xmlns:a="http://schemas.openxmlformats.org/drawingml/2006/main">
@@ -639,17 +639,17 @@
           </a:p>
           <a:p xmlns:a="http://schemas.openxmlformats.org/drawingml/2006/main">
             <a:r>
-              <a:t>- https://www.reddit.com/r/CHROMATOGRAPHY/comments/1uk333s/update_uplc_waters_high_pressure_problem/</a:t>
-            </a:r>
-          </a:p>
-          <a:p xmlns:a="http://schemas.openxmlformats.org/drawingml/2006/main">
-            <a:r>
               <a:t>- https://www.labwrench.com/thread/135698/hplc-pump-and-autosampler-preventative-performance-maintenance</a:t>
             </a:r>
           </a:p>
           <a:p xmlns:a="http://schemas.openxmlformats.org/drawingml/2006/main">
             <a:r>
               <a:t>- https://www.reddit.com/r/CHROMATOGRAPHY/comments/xlr4pf/best_uhplc_on_the_market/</a:t>
+            </a:r>
+          </a:p>
+          <a:p xmlns:a="http://schemas.openxmlformats.org/drawingml/2006/main">
+            <a:r>
+              <a:t>- https://www.reddit.com/r/massspectrometry/comments/1uxyipd/efficient_quant_workflow_for_targetlynx/</a:t>
             </a:r>
           </a:p>
           <a:p xmlns:a="http://schemas.openxmlformats.org/drawingml/2006/main">
@@ -824,11 +824,6 @@
           </a:p>
           <a:p xmlns:a="http://schemas.openxmlformats.org/drawingml/2006/main">
             <a:r>
-              <a:t>- https://www.reddit.com/r/CHROMATOGRAPHY/comments/1uk333s/update_uplc_waters_high_pressure_problem/</a:t>
-            </a:r>
-          </a:p>
-          <a:p xmlns:a="http://schemas.openxmlformats.org/drawingml/2006/main">
-            <a:r>
               <a:t>- https://www.labwrench.com/thread/135698/hplc-pump-and-autosampler-preventative-performance-maintenance</a:t>
             </a:r>
           </a:p>
@@ -860,6 +855,11 @@
           <a:p xmlns:a="http://schemas.openxmlformats.org/drawingml/2006/main">
             <a:r>
               <a:t>- https://www.reddit.com/r/CHROMATOGRAPHY/comments/1sbtsdx/comparing_vendors_and_systems_thoughts/</a:t>
+            </a:r>
+          </a:p>
+          <a:p xmlns:a="http://schemas.openxmlformats.org/drawingml/2006/main">
+            <a:r>
+              <a:t>- https://www.reddit.com/r/massspectrometry/comments/1sognqt/what_is_the_fastest_way_to_convert_raw_files_to/</a:t>
             </a:r>
           </a:p>
           <a:p xmlns:a="http://schemas.openxmlformats.org/drawingml/2006/main">
@@ -949,7 +949,7 @@
           </a:p>
           <a:p xmlns:a="http://schemas.openxmlformats.org/drawingml/2006/main">
             <a:r>
-              <a:t>- https://pubmed.ncbi.nlm.nih.gov/?term=%28%28PFAS+OR+%22per-+and+polyfluoroalkyl%22%29+AND+%28%22LC-MS%22+OR+%22LC-MS%2FMS%22+OR+chromatography%29%29+AND+%28%222025%2F08%2F17%22%5BDate+-+Publication%5D+%3A+%222026%2F08%2F17%22%5BDate+-+Publication%5D%29</a:t>
+              <a:t>- https://pubmed.ncbi.nlm.nih.gov/?term=%28%28PFAS+OR+%22per-+and+polyfluoroalkyl%22%29+AND+%28%22LC-MS%22+OR+%22LC-MS%2FMS%22+OR+chromatography%29%29+AND+%28%222025%2F08%2F20%22%5BDate+-+Publication%5D+%3A+%222026%2F08%2F20%22%5BDate+-+Publication%5D%29</a:t>
             </a:r>
           </a:p>
           <a:p xmlns:a="http://schemas.openxmlformats.org/drawingml/2006/main">
@@ -969,7 +969,7 @@
           </a:p>
           <a:p xmlns:a="http://schemas.openxmlformats.org/drawingml/2006/main">
             <a:r>
-              <a:t>- https://pubmed.ncbi.nlm.nih.gov/?term=%28%28%22laboratory+automation%22+OR+%22workflow+software%22+OR+%22AI%22%29+AND+%28%22LC-MS%22+OR+chromatography+OR+%22mass+spectrometry%22%29%29+AND+%28%222025%2F08%2F17%22%5BDate+-+Publication%5D+%3A+%222026%2F08%2F17%22%5BDate+-+Publication%5D%29</a:t>
+              <a:t>- https://pubmed.ncbi.nlm.nih.gov/?term=%28%28%22laboratory+automation%22+OR+%22workflow+software%22+OR+%22AI%22%29+AND+%28%22LC-MS%22+OR+chromatography+OR+%22mass+spectrometry%22%29%29+AND+%28%222025%2F08%2F20%22%5BDate+-+Publication%5D+%3A+%222026%2F08%2F20%22%5BDate+-+Publication%5D%29</a:t>
             </a:r>
           </a:p>
           <a:p xmlns:a="http://schemas.openxmlformats.org/drawingml/2006/main">
@@ -984,7 +984,7 @@
           </a:p>
           <a:p xmlns:a="http://schemas.openxmlformats.org/drawingml/2006/main">
             <a:r>
-              <a:t>- https://pubmed.ncbi.nlm.nih.gov/?term=%28%28oligonucleotide+OR+%22nucleic+acid%22+OR+siRNA%29+AND+%28%22LC-MS%22+OR+chromatography+OR+%22mass+spectrometry%22%29%29+AND+%28%222025%2F08%2F17%22%5BDate+-+Publication%5D+%3A+%222026%2F08%2F17%22%5BDate+-+Publication%5D%29</a:t>
+              <a:t>- https://pubmed.ncbi.nlm.nih.gov/?term=%28%28oligonucleotide+OR+%22nucleic+acid%22+OR+siRNA%29+AND+%28%22LC-MS%22+OR+chromatography+OR+%22mass+spectrometry%22%29%29+AND+%28%222025%2F08%2F20%22%5BDate+-+Publication%5D+%3A+%222026%2F08%2F20%22%5BDate+-+Publication%5D%29</a:t>
             </a:r>
           </a:p>
           <a:p xmlns:a="http://schemas.openxmlformats.org/drawingml/2006/main">
@@ -1079,7 +1079,7 @@
           </a:p>
           <a:p xmlns:a="http://schemas.openxmlformats.org/drawingml/2006/main">
             <a:r>
-              <a:t>- https://pubmed.ncbi.nlm.nih.gov/?term=%28%28PFAS+OR+%22per-+and+polyfluoroalkyl%22%29+AND+%28%22LC-MS%22+OR+%22LC-MS%2FMS%22+OR+chromatography%29%29+AND+%28%222025%2F08%2F17%22%5BDate+-+Publication%5D+%3A+%222026%2F08%2F17%22%5BDate+-+Publication%5D%29</a:t>
+              <a:t>- https://pubmed.ncbi.nlm.nih.gov/?term=%28%28PFAS+OR+%22per-+and+polyfluoroalkyl%22%29+AND+%28%22LC-MS%22+OR+%22LC-MS%2FMS%22+OR+chromatography%29%29+AND+%28%222025%2F08%2F20%22%5BDate+-+Publication%5D+%3A+%222026%2F08%2F20%22%5BDate+-+Publication%5D%29</a:t>
             </a:r>
           </a:p>
           <a:p xmlns:a="http://schemas.openxmlformats.org/drawingml/2006/main">
@@ -1099,7 +1099,7 @@
           </a:p>
           <a:p xmlns:a="http://schemas.openxmlformats.org/drawingml/2006/main">
             <a:r>
-              <a:t>- https://pubmed.ncbi.nlm.nih.gov/?term=%28%28%22laboratory+automation%22+OR+%22workflow+software%22+OR+%22AI%22%29+AND+%28%22LC-MS%22+OR+chromatography+OR+%22mass+spectrometry%22%29%29+AND+%28%222025%2F08%2F17%22%5BDate+-+Publication%5D+%3A+%222026%2F08%2F17%22%5BDate+-+Publication%5D%29</a:t>
+              <a:t>- https://pubmed.ncbi.nlm.nih.gov/?term=%28%28%22laboratory+automation%22+OR+%22workflow+software%22+OR+%22AI%22%29+AND+%28%22LC-MS%22+OR+chromatography+OR+%22mass+spectrometry%22%29%29+AND+%28%222025%2F08%2F20%22%5BDate+-+Publication%5D+%3A+%222026%2F08%2F20%22%5BDate+-+Publication%5D%29</a:t>
             </a:r>
           </a:p>
           <a:p xmlns:a="http://schemas.openxmlformats.org/drawingml/2006/main">
@@ -1114,7 +1114,7 @@
           </a:p>
           <a:p xmlns:a="http://schemas.openxmlformats.org/drawingml/2006/main">
             <a:r>
-              <a:t>- https://pubmed.ncbi.nlm.nih.gov/?term=%28%28oligonucleotide+OR+%22nucleic+acid%22+OR+siRNA%29+AND+%28%22LC-MS%22+OR+chromatography+OR+%22mass+spectrometry%22%29%29+AND+%28%222025%2F08%2F17%22%5BDate+-+Publication%5D+%3A+%222026%2F08%2F17%22%5BDate+-+Publication%5D%29</a:t>
+              <a:t>- https://pubmed.ncbi.nlm.nih.gov/?term=%28%28oligonucleotide+OR+%22nucleic+acid%22+OR+siRNA%29+AND+%28%22LC-MS%22+OR+chromatography+OR+%22mass+spectrometry%22%29%29+AND+%28%222025%2F08%2F20%22%5BDate+-+Publication%5D+%3A+%222026%2F08%2F20%22%5BDate+-+Publication%5D%29</a:t>
             </a:r>
           </a:p>
           <a:p xmlns:a="http://schemas.openxmlformats.org/drawingml/2006/main">
@@ -1194,7 +1194,7 @@
           </a:p>
           <a:p xmlns:a="http://schemas.openxmlformats.org/drawingml/2006/main">
             <a:r>
-              <a:t>- https://pubmed.ncbi.nlm.nih.gov/?term=%28%28PFAS+OR+%22per-+and+polyfluoroalkyl%22%29+AND+%28%22LC-MS%22+OR+%22LC-MS%2FMS%22+OR+chromatography%29%29+AND+%28%222025%2F08%2F17%22%5BDate+-+Publication%5D+%3A+%222026%2F08%2F17%22%5BDate+-+Publication%5D%29</a:t>
+              <a:t>- https://pubmed.ncbi.nlm.nih.gov/?term=%28%28PFAS+OR+%22per-+and+polyfluoroalkyl%22%29+AND+%28%22LC-MS%22+OR+%22LC-MS%2FMS%22+OR+chromatography%29%29+AND+%28%222025%2F08%2F20%22%5BDate+-+Publication%5D+%3A+%222026%2F08%2F20%22%5BDate+-+Publication%5D%29</a:t>
             </a:r>
           </a:p>
           <a:p xmlns:a="http://schemas.openxmlformats.org/drawingml/2006/main">
@@ -1292,7 +1292,7 @@
   </p:cSld>
   <p:clrMap bg1="lt1" tx1="dk1" bg2="lt2" tx2="dk2" accent1="accent1" accent2="accent2" accent3="accent3" accent4="accent4" accent5="accent5" accent6="accent6" hlink="hlink" folHlink="folHlink"/>
   <p:sldLayoutIdLst>
-    <p:sldLayoutId xmlns:r="http://schemas.openxmlformats.org/officeDocument/2006/relationships" id="2147483649" r:id="Rc01745b939eb4d61"/>
+    <p:sldLayoutId xmlns:r="http://schemas.openxmlformats.org/officeDocument/2006/relationships" id="2147483649" r:id="R470b4c11bcea4911"/>
   </p:sldLayoutIdLst>
   <p:txStyles>
     <p:titleStyle>
@@ -1843,7 +1843,7 @@
           <p:cNvPr id="14" name="">
             <a:extLst xmlns:a="http://schemas.openxmlformats.org/drawingml/2006/main">
               <a:ext uri="{FF2B5EF4-FFF2-40B4-BE49-F238E27FC236}">
-                <a16:creationId xmlns:a16="http://schemas.microsoft.com/office/drawing/2014/main" id="{6CB153D5-222D-4B4B-B88E-6F5C4C37F2F2}"/>
+                <a16:creationId xmlns:a16="http://schemas.microsoft.com/office/drawing/2014/main" id="{446D0D9F-2982-47F8-BF9D-8FCBD8EB5E5B}"/>
               </a:ext>
             </a:extLst>
           </p:cNvPr>
@@ -1876,7 +1876,7 @@
           <p:cNvPr id="2" name="">
             <a:extLst xmlns:a="http://schemas.openxmlformats.org/drawingml/2006/main">
               <a:ext uri="{FF2B5EF4-FFF2-40B4-BE49-F238E27FC236}">
-                <a16:creationId xmlns:a16="http://schemas.microsoft.com/office/drawing/2014/main" id="{E240E70D-082C-4646-9E64-C17DE4DBFD51}"/>
+                <a16:creationId xmlns:a16="http://schemas.microsoft.com/office/drawing/2014/main" id="{0CDC7B97-CEA7-4F0A-B453-BDB68C9C8C0A}"/>
               </a:ext>
             </a:extLst>
           </p:cNvPr>
@@ -1934,7 +1934,7 @@
           <p:cNvPr id="3" name="">
             <a:extLst xmlns:a="http://schemas.openxmlformats.org/drawingml/2006/main">
               <a:ext uri="{FF2B5EF4-FFF2-40B4-BE49-F238E27FC236}">
-                <a16:creationId xmlns:a16="http://schemas.microsoft.com/office/drawing/2014/main" id="{743268F0-0507-41CE-8CCA-33985940C07F}"/>
+                <a16:creationId xmlns:a16="http://schemas.microsoft.com/office/drawing/2014/main" id="{9472343C-A13D-42FD-8710-D3570575E07F}"/>
               </a:ext>
             </a:extLst>
           </p:cNvPr>
@@ -1992,7 +1992,7 @@
           <p:cNvPr id="4" name="">
             <a:extLst xmlns:a="http://schemas.openxmlformats.org/drawingml/2006/main">
               <a:ext uri="{FF2B5EF4-FFF2-40B4-BE49-F238E27FC236}">
-                <a16:creationId xmlns:a16="http://schemas.microsoft.com/office/drawing/2014/main" id="{04FCE4B2-6EA6-454B-84A4-A8234A89E1FD}"/>
+                <a16:creationId xmlns:a16="http://schemas.microsoft.com/office/drawing/2014/main" id="{46DB0F60-F44E-4154-95AE-85EB21B5AE59}"/>
               </a:ext>
             </a:extLst>
           </p:cNvPr>
@@ -2050,7 +2050,7 @@
           <p:cNvPr id="5" name="">
             <a:extLst xmlns:a="http://schemas.openxmlformats.org/drawingml/2006/main">
               <a:ext uri="{FF2B5EF4-FFF2-40B4-BE49-F238E27FC236}">
-                <a16:creationId xmlns:a16="http://schemas.microsoft.com/office/drawing/2014/main" id="{F65C5D59-D096-4B3E-896C-7031F27A7A6D}"/>
+                <a16:creationId xmlns:a16="http://schemas.microsoft.com/office/drawing/2014/main" id="{F60B3F64-161E-4F1F-884D-5217A1B5D030}"/>
               </a:ext>
             </a:extLst>
           </p:cNvPr>
@@ -2108,7 +2108,7 @@
           <p:cNvPr id="6" name="">
             <a:extLst xmlns:a="http://schemas.openxmlformats.org/drawingml/2006/main">
               <a:ext uri="{FF2B5EF4-FFF2-40B4-BE49-F238E27FC236}">
-                <a16:creationId xmlns:a16="http://schemas.microsoft.com/office/drawing/2014/main" id="{966E6677-8CF8-410D-A770-3CD234BB9F82}"/>
+                <a16:creationId xmlns:a16="http://schemas.microsoft.com/office/drawing/2014/main" id="{59CE457D-E199-48CA-AFD9-EAA9272E3C3E}"/>
               </a:ext>
             </a:extLst>
           </p:cNvPr>
@@ -2143,7 +2143,7 @@
           <p:cNvPr id="7" name="">
             <a:extLst xmlns:a="http://schemas.openxmlformats.org/drawingml/2006/main">
               <a:ext uri="{FF2B5EF4-FFF2-40B4-BE49-F238E27FC236}">
-                <a16:creationId xmlns:a16="http://schemas.microsoft.com/office/drawing/2014/main" id="{DB34C0AF-E2BC-4D89-A982-4D88ABA9B47E}"/>
+                <a16:creationId xmlns:a16="http://schemas.microsoft.com/office/drawing/2014/main" id="{5FA23563-9A35-4EC2-85A6-B9131B3936FF}"/>
               </a:ext>
             </a:extLst>
           </p:cNvPr>
@@ -2201,7 +2201,7 @@
           <p:cNvPr id="8" name="">
             <a:extLst xmlns:a="http://schemas.openxmlformats.org/drawingml/2006/main">
               <a:ext uri="{FF2B5EF4-FFF2-40B4-BE49-F238E27FC236}">
-                <a16:creationId xmlns:a16="http://schemas.microsoft.com/office/drawing/2014/main" id="{A4FB664C-0B7D-45CB-ADBC-765D245BF008}"/>
+                <a16:creationId xmlns:a16="http://schemas.microsoft.com/office/drawing/2014/main" id="{65EDC6AD-BFFF-4681-8B38-9EE827B6945E}"/>
               </a:ext>
             </a:extLst>
           </p:cNvPr>
@@ -2249,7 +2249,7 @@
                 <a:ea typeface="Aptos"/>
                 <a:cs typeface="Aptos"/>
               </a:rPr>
-              <a:t>17</a:t>
+              <a:t>23</a:t>
             </a:r>
           </a:p>
         </p:txBody>
@@ -2259,7 +2259,7 @@
           <p:cNvPr id="9" name="">
             <a:extLst xmlns:a="http://schemas.openxmlformats.org/drawingml/2006/main">
               <a:ext uri="{FF2B5EF4-FFF2-40B4-BE49-F238E27FC236}">
-                <a16:creationId xmlns:a16="http://schemas.microsoft.com/office/drawing/2014/main" id="{F47C07CC-2641-4F8C-A738-A7E3700BFB60}"/>
+                <a16:creationId xmlns:a16="http://schemas.microsoft.com/office/drawing/2014/main" id="{63327954-BAE3-4591-9DA1-5D515ADEE2AB}"/>
               </a:ext>
             </a:extLst>
           </p:cNvPr>
@@ -2317,7 +2317,7 @@
           <p:cNvPr id="10" name="">
             <a:extLst xmlns:a="http://schemas.openxmlformats.org/drawingml/2006/main">
               <a:ext uri="{FF2B5EF4-FFF2-40B4-BE49-F238E27FC236}">
-                <a16:creationId xmlns:a16="http://schemas.microsoft.com/office/drawing/2014/main" id="{96C690AD-950E-4A86-998A-DE81281FDD70}"/>
+                <a16:creationId xmlns:a16="http://schemas.microsoft.com/office/drawing/2014/main" id="{CD8FABA7-3752-4E3B-89E9-9FDCFE91DC4F}"/>
               </a:ext>
             </a:extLst>
           </p:cNvPr>
@@ -2350,7 +2350,7 @@
           <p:cNvPr id="11" name="">
             <a:extLst xmlns:a="http://schemas.openxmlformats.org/drawingml/2006/main">
               <a:ext uri="{FF2B5EF4-FFF2-40B4-BE49-F238E27FC236}">
-                <a16:creationId xmlns:a16="http://schemas.microsoft.com/office/drawing/2014/main" id="{0545C645-3591-49AF-BDAC-EFEF9F38449A}"/>
+                <a16:creationId xmlns:a16="http://schemas.microsoft.com/office/drawing/2014/main" id="{B080C26D-01D2-4842-B663-81AC30CCDFD0}"/>
               </a:ext>
             </a:extLst>
           </p:cNvPr>
@@ -2408,7 +2408,7 @@
           <p:cNvPr id="12" name="">
             <a:extLst xmlns:a="http://schemas.openxmlformats.org/drawingml/2006/main">
               <a:ext uri="{FF2B5EF4-FFF2-40B4-BE49-F238E27FC236}">
-                <a16:creationId xmlns:a16="http://schemas.microsoft.com/office/drawing/2014/main" id="{270C2474-3FCC-4B47-81CF-0C42D43A642D}"/>
+                <a16:creationId xmlns:a16="http://schemas.microsoft.com/office/drawing/2014/main" id="{47B2A43E-994A-4B51-BCA2-105331B3A3E5}"/>
               </a:ext>
             </a:extLst>
           </p:cNvPr>
@@ -2456,7 +2456,7 @@
                 <a:ea typeface="Aptos"/>
                 <a:cs typeface="Aptos"/>
               </a:rPr>
-              <a:t>Prepared for roadmap review · waters-ci-20260817124300</a:t>
+              <a:t>Prepared for roadmap review · waters-ci-20260820104036</a:t>
             </a:r>
           </a:p>
         </p:txBody>
@@ -2466,7 +2466,7 @@
           <p:cNvPr id="13" name="">
             <a:extLst xmlns:a="http://schemas.openxmlformats.org/drawingml/2006/main">
               <a:ext uri="{FF2B5EF4-FFF2-40B4-BE49-F238E27FC236}">
-                <a16:creationId xmlns:a16="http://schemas.microsoft.com/office/drawing/2014/main" id="{74E95FEE-98CF-4497-AC9F-7F11FC58DBA1}"/>
+                <a16:creationId xmlns:a16="http://schemas.microsoft.com/office/drawing/2014/main" id="{0EA2BD30-D561-4F23-948F-E363AAA75566}"/>
               </a:ext>
             </a:extLst>
           </p:cNvPr>
@@ -2522,7 +2522,7 @@
     </p:spTree>
     <p:extLst>
       <p:ext uri="{BB962C8B-B14F-4D97-AF65-F5344CB8AC3E}">
-        <p14:creationId xmlns:p14="http://schemas.microsoft.com/office/powerpoint/2010/main" val="1751265326"/>
+        <p14:creationId xmlns:p14="http://schemas.microsoft.com/office/powerpoint/2010/main" val="1784191674"/>
       </p:ext>
     </p:extLst>
   </p:cSld>
@@ -2553,7 +2553,7 @@
           <p:cNvPr id="25" name="">
             <a:extLst xmlns:a="http://schemas.openxmlformats.org/drawingml/2006/main">
               <a:ext uri="{FF2B5EF4-FFF2-40B4-BE49-F238E27FC236}">
-                <a16:creationId xmlns:a16="http://schemas.microsoft.com/office/drawing/2014/main" id="{BB1C8234-E1B2-4F7D-AA7F-407731237D42}"/>
+                <a16:creationId xmlns:a16="http://schemas.microsoft.com/office/drawing/2014/main" id="{07765648-078A-436B-807F-8A75E2764254}"/>
               </a:ext>
             </a:extLst>
           </p:cNvPr>
@@ -2611,7 +2611,7 @@
           <p:cNvPr id="2" name="">
             <a:extLst xmlns:a="http://schemas.openxmlformats.org/drawingml/2006/main">
               <a:ext uri="{FF2B5EF4-FFF2-40B4-BE49-F238E27FC236}">
-                <a16:creationId xmlns:a16="http://schemas.microsoft.com/office/drawing/2014/main" id="{4B1DD58A-223E-4B79-B0CE-6D1FC4E1CCDE}"/>
+                <a16:creationId xmlns:a16="http://schemas.microsoft.com/office/drawing/2014/main" id="{A4E45576-440A-4C72-84BF-283607CBD931}"/>
               </a:ext>
             </a:extLst>
           </p:cNvPr>
@@ -2669,7 +2669,7 @@
           <p:cNvPr id="3" name="">
             <a:extLst xmlns:a="http://schemas.openxmlformats.org/drawingml/2006/main">
               <a:ext uri="{FF2B5EF4-FFF2-40B4-BE49-F238E27FC236}">
-                <a16:creationId xmlns:a16="http://schemas.microsoft.com/office/drawing/2014/main" id="{1BE34BA5-27CF-4DFA-8A85-74BFFFB275EE}"/>
+                <a16:creationId xmlns:a16="http://schemas.microsoft.com/office/drawing/2014/main" id="{266241CD-1DFC-4DA0-852B-D83F4DA3C3C8}"/>
               </a:ext>
             </a:extLst>
           </p:cNvPr>
@@ -2727,7 +2727,7 @@
           <p:cNvPr id="4" name="">
             <a:extLst xmlns:a="http://schemas.openxmlformats.org/drawingml/2006/main">
               <a:ext uri="{FF2B5EF4-FFF2-40B4-BE49-F238E27FC236}">
-                <a16:creationId xmlns:a16="http://schemas.microsoft.com/office/drawing/2014/main" id="{8567AAEA-913A-488F-B1EE-C3EBBDE65701}"/>
+                <a16:creationId xmlns:a16="http://schemas.microsoft.com/office/drawing/2014/main" id="{448C179F-80C2-4070-96DE-D9D4C0042071}"/>
               </a:ext>
             </a:extLst>
           </p:cNvPr>
@@ -2760,7 +2760,7 @@
           <p:cNvPr id="5" name="">
             <a:extLst xmlns:a="http://schemas.openxmlformats.org/drawingml/2006/main">
               <a:ext uri="{FF2B5EF4-FFF2-40B4-BE49-F238E27FC236}">
-                <a16:creationId xmlns:a16="http://schemas.microsoft.com/office/drawing/2014/main" id="{7C21B487-8379-4E54-A9DA-92D79100E742}"/>
+                <a16:creationId xmlns:a16="http://schemas.microsoft.com/office/drawing/2014/main" id="{1D700C2A-75EF-4BB3-A50B-6FD24774261C}"/>
               </a:ext>
             </a:extLst>
           </p:cNvPr>
@@ -2795,7 +2795,7 @@
           <p:cNvPr id="6" name="">
             <a:extLst xmlns:a="http://schemas.openxmlformats.org/drawingml/2006/main">
               <a:ext uri="{FF2B5EF4-FFF2-40B4-BE49-F238E27FC236}">
-                <a16:creationId xmlns:a16="http://schemas.microsoft.com/office/drawing/2014/main" id="{6D4C186E-1637-4211-9208-7BB6779E570C}"/>
+                <a16:creationId xmlns:a16="http://schemas.microsoft.com/office/drawing/2014/main" id="{19FB8E75-8814-446E-A9B9-5BAFC6716254}"/>
               </a:ext>
             </a:extLst>
           </p:cNvPr>
@@ -2853,7 +2853,7 @@
           <p:cNvPr id="7" name="">
             <a:extLst xmlns:a="http://schemas.openxmlformats.org/drawingml/2006/main">
               <a:ext uri="{FF2B5EF4-FFF2-40B4-BE49-F238E27FC236}">
-                <a16:creationId xmlns:a16="http://schemas.microsoft.com/office/drawing/2014/main" id="{139D57AA-C656-4734-9621-9B19BE2BE5CB}"/>
+                <a16:creationId xmlns:a16="http://schemas.microsoft.com/office/drawing/2014/main" id="{F46ABA17-EEC4-445E-BED3-01E63980CAE3}"/>
               </a:ext>
             </a:extLst>
           </p:cNvPr>
@@ -2911,7 +2911,7 @@
           <p:cNvPr id="8" name="">
             <a:extLst xmlns:a="http://schemas.openxmlformats.org/drawingml/2006/main">
               <a:ext uri="{FF2B5EF4-FFF2-40B4-BE49-F238E27FC236}">
-                <a16:creationId xmlns:a16="http://schemas.microsoft.com/office/drawing/2014/main" id="{4BE8A139-403C-45D2-9CEB-A1FE2C459D2F}"/>
+                <a16:creationId xmlns:a16="http://schemas.microsoft.com/office/drawing/2014/main" id="{45B16D81-AEE3-4300-A69A-68F3874A2870}"/>
               </a:ext>
             </a:extLst>
           </p:cNvPr>
@@ -2946,7 +2946,7 @@
           <p:cNvPr id="9" name="">
             <a:extLst xmlns:a="http://schemas.openxmlformats.org/drawingml/2006/main">
               <a:ext uri="{FF2B5EF4-FFF2-40B4-BE49-F238E27FC236}">
-                <a16:creationId xmlns:a16="http://schemas.microsoft.com/office/drawing/2014/main" id="{C84DFE6C-27C7-44F8-87C7-C0AD7F8466D7}"/>
+                <a16:creationId xmlns:a16="http://schemas.microsoft.com/office/drawing/2014/main" id="{0C722A6D-112E-40DF-AFBC-F1CE6A25F856}"/>
               </a:ext>
             </a:extLst>
           </p:cNvPr>
@@ -2979,7 +2979,7 @@
           <p:cNvPr id="10" name="">
             <a:extLst xmlns:a="http://schemas.openxmlformats.org/drawingml/2006/main">
               <a:ext uri="{FF2B5EF4-FFF2-40B4-BE49-F238E27FC236}">
-                <a16:creationId xmlns:a16="http://schemas.microsoft.com/office/drawing/2014/main" id="{0506E4FB-6D89-44B4-9E69-4AFB76D16385}"/>
+                <a16:creationId xmlns:a16="http://schemas.microsoft.com/office/drawing/2014/main" id="{CE232432-D719-49C9-90FA-E0B2422BC11F}"/>
               </a:ext>
             </a:extLst>
           </p:cNvPr>
@@ -3027,7 +3027,7 @@
                 <a:ea typeface="Aptos"/>
                 <a:cs typeface="Aptos"/>
               </a:rPr>
-              <a:t>1,135</a:t>
+              <a:t>1,142</a:t>
             </a:r>
           </a:p>
         </p:txBody>
@@ -3037,7 +3037,7 @@
           <p:cNvPr id="11" name="">
             <a:extLst xmlns:a="http://schemas.openxmlformats.org/drawingml/2006/main">
               <a:ext uri="{FF2B5EF4-FFF2-40B4-BE49-F238E27FC236}">
-                <a16:creationId xmlns:a16="http://schemas.microsoft.com/office/drawing/2014/main" id="{C69A26B4-22EE-45EA-949B-8E5161EC5EB5}"/>
+                <a16:creationId xmlns:a16="http://schemas.microsoft.com/office/drawing/2014/main" id="{EE7F7E69-3ABC-4A46-9214-2AAB24E2751F}"/>
               </a:ext>
             </a:extLst>
           </p:cNvPr>
@@ -3095,7 +3095,7 @@
           <p:cNvPr id="12" name="">
             <a:extLst xmlns:a="http://schemas.openxmlformats.org/drawingml/2006/main">
               <a:ext uri="{FF2B5EF4-FFF2-40B4-BE49-F238E27FC236}">
-                <a16:creationId xmlns:a16="http://schemas.microsoft.com/office/drawing/2014/main" id="{37AC7EDD-2672-42EA-9D86-CAFF2644B925}"/>
+                <a16:creationId xmlns:a16="http://schemas.microsoft.com/office/drawing/2014/main" id="{C04A01DE-C1E2-4BBB-91E0-49AD099B39A9}"/>
               </a:ext>
             </a:extLst>
           </p:cNvPr>
@@ -3153,7 +3153,7 @@
           <p:cNvPr id="13" name="">
             <a:extLst xmlns:a="http://schemas.openxmlformats.org/drawingml/2006/main">
               <a:ext uri="{FF2B5EF4-FFF2-40B4-BE49-F238E27FC236}">
-                <a16:creationId xmlns:a16="http://schemas.microsoft.com/office/drawing/2014/main" id="{418B7189-1E14-4C84-A8FB-DE8077F4C1A0}"/>
+                <a16:creationId xmlns:a16="http://schemas.microsoft.com/office/drawing/2014/main" id="{F8752766-7A0A-4FF3-9D2B-E202AD2E367F}"/>
               </a:ext>
             </a:extLst>
           </p:cNvPr>
@@ -3188,7 +3188,7 @@
           <p:cNvPr id="14" name="">
             <a:extLst xmlns:a="http://schemas.openxmlformats.org/drawingml/2006/main">
               <a:ext uri="{FF2B5EF4-FFF2-40B4-BE49-F238E27FC236}">
-                <a16:creationId xmlns:a16="http://schemas.microsoft.com/office/drawing/2014/main" id="{C72146F3-36C6-4F6E-99DC-72DFB072D708}"/>
+                <a16:creationId xmlns:a16="http://schemas.microsoft.com/office/drawing/2014/main" id="{029CBF8B-F0F1-46CE-B0AC-A42BD9FF63FA}"/>
               </a:ext>
             </a:extLst>
           </p:cNvPr>
@@ -3221,7 +3221,7 @@
           <p:cNvPr id="15" name="">
             <a:extLst xmlns:a="http://schemas.openxmlformats.org/drawingml/2006/main">
               <a:ext uri="{FF2B5EF4-FFF2-40B4-BE49-F238E27FC236}">
-                <a16:creationId xmlns:a16="http://schemas.microsoft.com/office/drawing/2014/main" id="{3FAEBD40-074C-40C8-9634-4DF7C5566752}"/>
+                <a16:creationId xmlns:a16="http://schemas.microsoft.com/office/drawing/2014/main" id="{3F16295B-0479-460C-92C7-F15677DF8CA9}"/>
               </a:ext>
             </a:extLst>
           </p:cNvPr>
@@ -3279,7 +3279,7 @@
           <p:cNvPr id="16" name="">
             <a:extLst xmlns:a="http://schemas.openxmlformats.org/drawingml/2006/main">
               <a:ext uri="{FF2B5EF4-FFF2-40B4-BE49-F238E27FC236}">
-                <a16:creationId xmlns:a16="http://schemas.microsoft.com/office/drawing/2014/main" id="{9BE320E3-9502-46DB-B5E8-7439CDAC3082}"/>
+                <a16:creationId xmlns:a16="http://schemas.microsoft.com/office/drawing/2014/main" id="{7E50B898-3139-4CCB-B073-A6B3D568B33D}"/>
               </a:ext>
             </a:extLst>
           </p:cNvPr>
@@ -3337,7 +3337,7 @@
           <p:cNvPr id="17" name="">
             <a:extLst xmlns:a="http://schemas.openxmlformats.org/drawingml/2006/main">
               <a:ext uri="{FF2B5EF4-FFF2-40B4-BE49-F238E27FC236}">
-                <a16:creationId xmlns:a16="http://schemas.microsoft.com/office/drawing/2014/main" id="{A8768100-7D16-4358-9E8B-FA28763C8EBC}"/>
+                <a16:creationId xmlns:a16="http://schemas.microsoft.com/office/drawing/2014/main" id="{4ADFCD2A-F3B2-4136-82A7-4E631AD4ABB4}"/>
               </a:ext>
             </a:extLst>
           </p:cNvPr>
@@ -3395,7 +3395,7 @@
           <p:cNvPr id="18" name="">
             <a:extLst xmlns:a="http://schemas.openxmlformats.org/drawingml/2006/main">
               <a:ext uri="{FF2B5EF4-FFF2-40B4-BE49-F238E27FC236}">
-                <a16:creationId xmlns:a16="http://schemas.microsoft.com/office/drawing/2014/main" id="{511B179B-FF89-445D-A5C3-EEDBB055BC3E}"/>
+                <a16:creationId xmlns:a16="http://schemas.microsoft.com/office/drawing/2014/main" id="{43CA8A53-A542-4CD0-930E-7A6777AEBEC1}"/>
               </a:ext>
             </a:extLst>
           </p:cNvPr>
@@ -3430,7 +3430,7 @@
           <p:cNvPr id="19" name="">
             <a:extLst xmlns:a="http://schemas.openxmlformats.org/drawingml/2006/main">
               <a:ext uri="{FF2B5EF4-FFF2-40B4-BE49-F238E27FC236}">
-                <a16:creationId xmlns:a16="http://schemas.microsoft.com/office/drawing/2014/main" id="{1CC6118F-F89F-448D-BAB4-C045BD806AC1}"/>
+                <a16:creationId xmlns:a16="http://schemas.microsoft.com/office/drawing/2014/main" id="{C71B33EF-43CC-41B3-863E-05578F32D84D}"/>
               </a:ext>
             </a:extLst>
           </p:cNvPr>
@@ -3463,7 +3463,7 @@
           <p:cNvPr id="20" name="">
             <a:extLst xmlns:a="http://schemas.openxmlformats.org/drawingml/2006/main">
               <a:ext uri="{FF2B5EF4-FFF2-40B4-BE49-F238E27FC236}">
-                <a16:creationId xmlns:a16="http://schemas.microsoft.com/office/drawing/2014/main" id="{2C680D3B-C247-44CE-8576-4E53E678F647}"/>
+                <a16:creationId xmlns:a16="http://schemas.microsoft.com/office/drawing/2014/main" id="{E0DEFCF0-C20A-415E-B3D8-8AECBDA3C138}"/>
               </a:ext>
             </a:extLst>
           </p:cNvPr>
@@ -3511,7 +3511,7 @@
                 <a:ea typeface="Aptos"/>
                 <a:cs typeface="Aptos"/>
               </a:rPr>
-              <a:t>655</a:t>
+              <a:t>656</a:t>
             </a:r>
           </a:p>
         </p:txBody>
@@ -3521,7 +3521,7 @@
           <p:cNvPr id="21" name="">
             <a:extLst xmlns:a="http://schemas.openxmlformats.org/drawingml/2006/main">
               <a:ext uri="{FF2B5EF4-FFF2-40B4-BE49-F238E27FC236}">
-                <a16:creationId xmlns:a16="http://schemas.microsoft.com/office/drawing/2014/main" id="{BF7C93BA-5D84-4D37-865D-1E66A7B9BF07}"/>
+                <a16:creationId xmlns:a16="http://schemas.microsoft.com/office/drawing/2014/main" id="{05E12317-426E-48B4-BB07-8996C12F32B0}"/>
               </a:ext>
             </a:extLst>
           </p:cNvPr>
@@ -3579,7 +3579,7 @@
           <p:cNvPr id="22" name="">
             <a:extLst xmlns:a="http://schemas.openxmlformats.org/drawingml/2006/main">
               <a:ext uri="{FF2B5EF4-FFF2-40B4-BE49-F238E27FC236}">
-                <a16:creationId xmlns:a16="http://schemas.microsoft.com/office/drawing/2014/main" id="{4AD10826-BAE8-455E-B655-26EDEFB0C243}"/>
+                <a16:creationId xmlns:a16="http://schemas.microsoft.com/office/drawing/2014/main" id="{3B063F08-CBBA-4965-80BA-26B1428609DC}"/>
               </a:ext>
             </a:extLst>
           </p:cNvPr>
@@ -3637,7 +3637,7 @@
           <p:cNvPr id="23" name="">
             <a:extLst xmlns:a="http://schemas.openxmlformats.org/drawingml/2006/main">
               <a:ext uri="{FF2B5EF4-FFF2-40B4-BE49-F238E27FC236}">
-                <a16:creationId xmlns:a16="http://schemas.microsoft.com/office/drawing/2014/main" id="{3EFCA5C0-C575-4687-A46E-EAAA54291428}"/>
+                <a16:creationId xmlns:a16="http://schemas.microsoft.com/office/drawing/2014/main" id="{F812C9C7-9A02-4FD7-B625-8FF3C159F8DB}"/>
               </a:ext>
             </a:extLst>
           </p:cNvPr>
@@ -3685,7 +3685,7 @@
                 <a:ea typeface="Aptos"/>
                 <a:cs typeface="Aptos"/>
               </a:rPr>
-              <a:t>WATERS NEXT GEN COMPETITIVE INTELLIGENCE · 17 AUG 2026 · waters-ci-20260817124300</a:t>
+              <a:t>WATERS NEXT GEN COMPETITIVE INTELLIGENCE · 23 AUG 2026 · waters-ci-20260820104036</a:t>
             </a:r>
           </a:p>
         </p:txBody>
@@ -3695,7 +3695,7 @@
           <p:cNvPr id="24" name="">
             <a:extLst xmlns:a="http://schemas.openxmlformats.org/drawingml/2006/main">
               <a:ext uri="{FF2B5EF4-FFF2-40B4-BE49-F238E27FC236}">
-                <a16:creationId xmlns:a16="http://schemas.microsoft.com/office/drawing/2014/main" id="{6C6A9131-B357-4F1B-ADE1-8ECCB01137DE}"/>
+                <a16:creationId xmlns:a16="http://schemas.microsoft.com/office/drawing/2014/main" id="{B2FA46A9-E74B-4D1A-8301-4CB6A45F115D}"/>
               </a:ext>
             </a:extLst>
           </p:cNvPr>
@@ -3751,7 +3751,7 @@
     </p:spTree>
     <p:extLst>
       <p:ext uri="{BB962C8B-B14F-4D97-AF65-F5344CB8AC3E}">
-        <p14:creationId xmlns:p14="http://schemas.microsoft.com/office/powerpoint/2010/main" val="327133428"/>
+        <p14:creationId xmlns:p14="http://schemas.microsoft.com/office/powerpoint/2010/main" val="48565560"/>
       </p:ext>
     </p:extLst>
   </p:cSld>
@@ -3782,7 +3782,7 @@
           <p:cNvPr id="37" name="">
             <a:extLst xmlns:a="http://schemas.openxmlformats.org/drawingml/2006/main">
               <a:ext uri="{FF2B5EF4-FFF2-40B4-BE49-F238E27FC236}">
-                <a16:creationId xmlns:a16="http://schemas.microsoft.com/office/drawing/2014/main" id="{2E56F7E4-8B86-444D-89D9-B3850D5A4CAE}"/>
+                <a16:creationId xmlns:a16="http://schemas.microsoft.com/office/drawing/2014/main" id="{CFE8EAF1-A21A-4024-96AE-42493369608B}"/>
               </a:ext>
             </a:extLst>
           </p:cNvPr>
@@ -3840,7 +3840,7 @@
           <p:cNvPr id="2" name="">
             <a:extLst xmlns:a="http://schemas.openxmlformats.org/drawingml/2006/main">
               <a:ext uri="{FF2B5EF4-FFF2-40B4-BE49-F238E27FC236}">
-                <a16:creationId xmlns:a16="http://schemas.microsoft.com/office/drawing/2014/main" id="{99EFA815-931F-4FE6-8B2E-1BAE6E224BF7}"/>
+                <a16:creationId xmlns:a16="http://schemas.microsoft.com/office/drawing/2014/main" id="{23E5462F-A644-4E75-93D4-8B08150F3B47}"/>
               </a:ext>
             </a:extLst>
           </p:cNvPr>
@@ -3898,7 +3898,7 @@
           <p:cNvPr id="3" name="">
             <a:extLst xmlns:a="http://schemas.openxmlformats.org/drawingml/2006/main">
               <a:ext uri="{FF2B5EF4-FFF2-40B4-BE49-F238E27FC236}">
-                <a16:creationId xmlns:a16="http://schemas.microsoft.com/office/drawing/2014/main" id="{99A934B4-040A-4D32-9B3A-41862F214A78}"/>
+                <a16:creationId xmlns:a16="http://schemas.microsoft.com/office/drawing/2014/main" id="{A1FA54E5-3011-4270-97D5-F0D64073D73B}"/>
               </a:ext>
             </a:extLst>
           </p:cNvPr>
@@ -3956,7 +3956,7 @@
           <p:cNvPr id="4" name="">
             <a:extLst xmlns:a="http://schemas.openxmlformats.org/drawingml/2006/main">
               <a:ext uri="{FF2B5EF4-FFF2-40B4-BE49-F238E27FC236}">
-                <a16:creationId xmlns:a16="http://schemas.microsoft.com/office/drawing/2014/main" id="{95FFD659-7DCA-4AB9-8508-46DE2624E1FA}"/>
+                <a16:creationId xmlns:a16="http://schemas.microsoft.com/office/drawing/2014/main" id="{CC565C6B-6517-4BEC-9F61-D20747111561}"/>
               </a:ext>
             </a:extLst>
           </p:cNvPr>
@@ -3989,7 +3989,7 @@
           <p:cNvPr id="5" name="">
             <a:extLst xmlns:a="http://schemas.openxmlformats.org/drawingml/2006/main">
               <a:ext uri="{FF2B5EF4-FFF2-40B4-BE49-F238E27FC236}">
-                <a16:creationId xmlns:a16="http://schemas.microsoft.com/office/drawing/2014/main" id="{A2FB579A-E33B-48A5-93B1-9B92B8A2C172}"/>
+                <a16:creationId xmlns:a16="http://schemas.microsoft.com/office/drawing/2014/main" id="{2A7AD552-5983-4B7A-B4E6-24EA0810BB69}"/>
               </a:ext>
             </a:extLst>
           </p:cNvPr>
@@ -4024,7 +4024,7 @@
           <p:cNvPr id="6" name="">
             <a:extLst xmlns:a="http://schemas.openxmlformats.org/drawingml/2006/main">
               <a:ext uri="{FF2B5EF4-FFF2-40B4-BE49-F238E27FC236}">
-                <a16:creationId xmlns:a16="http://schemas.microsoft.com/office/drawing/2014/main" id="{768C4A1A-F048-4A94-939D-5A0F0EB60394}"/>
+                <a16:creationId xmlns:a16="http://schemas.microsoft.com/office/drawing/2014/main" id="{4EE33C26-EF61-4213-8B5D-F7C68106C112}"/>
               </a:ext>
             </a:extLst>
           </p:cNvPr>
@@ -4059,7 +4059,7 @@
           <p:cNvPr id="7" name="">
             <a:extLst xmlns:a="http://schemas.openxmlformats.org/drawingml/2006/main">
               <a:ext uri="{FF2B5EF4-FFF2-40B4-BE49-F238E27FC236}">
-                <a16:creationId xmlns:a16="http://schemas.microsoft.com/office/drawing/2014/main" id="{4C703075-75FC-47A7-A356-39723158B66B}"/>
+                <a16:creationId xmlns:a16="http://schemas.microsoft.com/office/drawing/2014/main" id="{0893FFCB-3625-47F3-8769-3C5FCC50C1B4}"/>
               </a:ext>
             </a:extLst>
           </p:cNvPr>
@@ -4117,7 +4117,7 @@
           <p:cNvPr id="8" name="">
             <a:extLst xmlns:a="http://schemas.openxmlformats.org/drawingml/2006/main">
               <a:ext uri="{FF2B5EF4-FFF2-40B4-BE49-F238E27FC236}">
-                <a16:creationId xmlns:a16="http://schemas.microsoft.com/office/drawing/2014/main" id="{D875D76C-6037-439A-8C2E-3F7388D51510}"/>
+                <a16:creationId xmlns:a16="http://schemas.microsoft.com/office/drawing/2014/main" id="{583D8C26-ECB2-4DA0-9EC0-2A0D9FF3E6F3}"/>
               </a:ext>
             </a:extLst>
           </p:cNvPr>
@@ -4175,7 +4175,7 @@
           <p:cNvPr id="9" name="">
             <a:extLst xmlns:a="http://schemas.openxmlformats.org/drawingml/2006/main">
               <a:ext uri="{FF2B5EF4-FFF2-40B4-BE49-F238E27FC236}">
-                <a16:creationId xmlns:a16="http://schemas.microsoft.com/office/drawing/2014/main" id="{61039203-2420-4CBE-BC01-73BB13977A91}"/>
+                <a16:creationId xmlns:a16="http://schemas.microsoft.com/office/drawing/2014/main" id="{2013F8A4-2366-4E62-B044-A86063B61FC6}"/>
               </a:ext>
             </a:extLst>
           </p:cNvPr>
@@ -4233,7 +4233,7 @@
           <p:cNvPr id="10" name="">
             <a:extLst xmlns:a="http://schemas.openxmlformats.org/drawingml/2006/main">
               <a:ext uri="{FF2B5EF4-FFF2-40B4-BE49-F238E27FC236}">
-                <a16:creationId xmlns:a16="http://schemas.microsoft.com/office/drawing/2014/main" id="{E464C584-D687-4E9A-A0B1-F6B8071CB290}"/>
+                <a16:creationId xmlns:a16="http://schemas.microsoft.com/office/drawing/2014/main" id="{26E89E93-206E-4140-AFD2-C4337D38A313}"/>
               </a:ext>
             </a:extLst>
           </p:cNvPr>
@@ -4291,7 +4291,7 @@
           <p:cNvPr id="11" name="">
             <a:extLst xmlns:a="http://schemas.openxmlformats.org/drawingml/2006/main">
               <a:ext uri="{FF2B5EF4-FFF2-40B4-BE49-F238E27FC236}">
-                <a16:creationId xmlns:a16="http://schemas.microsoft.com/office/drawing/2014/main" id="{AD041166-717D-4D34-8C21-23AD4C2E0F4D}"/>
+                <a16:creationId xmlns:a16="http://schemas.microsoft.com/office/drawing/2014/main" id="{24EC296D-7245-427C-BC1B-023C3B82AC21}"/>
               </a:ext>
             </a:extLst>
           </p:cNvPr>
@@ -4326,7 +4326,7 @@
           <p:cNvPr id="12" name="">
             <a:extLst xmlns:a="http://schemas.openxmlformats.org/drawingml/2006/main">
               <a:ext uri="{FF2B5EF4-FFF2-40B4-BE49-F238E27FC236}">
-                <a16:creationId xmlns:a16="http://schemas.microsoft.com/office/drawing/2014/main" id="{2E908071-D6DD-4B79-92C2-D8172937D9D3}"/>
+                <a16:creationId xmlns:a16="http://schemas.microsoft.com/office/drawing/2014/main" id="{FB15A235-AA52-4FE2-80CA-D1CCFB8F9EEF}"/>
               </a:ext>
             </a:extLst>
           </p:cNvPr>
@@ -4361,7 +4361,7 @@
           <p:cNvPr id="13" name="">
             <a:extLst xmlns:a="http://schemas.openxmlformats.org/drawingml/2006/main">
               <a:ext uri="{FF2B5EF4-FFF2-40B4-BE49-F238E27FC236}">
-                <a16:creationId xmlns:a16="http://schemas.microsoft.com/office/drawing/2014/main" id="{CF555971-2212-4EFD-BE9E-5EBC2B9E17EC}"/>
+                <a16:creationId xmlns:a16="http://schemas.microsoft.com/office/drawing/2014/main" id="{8729F9B8-1E1A-4F47-8FD4-831760808D1C}"/>
               </a:ext>
             </a:extLst>
           </p:cNvPr>
@@ -4419,7 +4419,7 @@
           <p:cNvPr id="14" name="">
             <a:extLst xmlns:a="http://schemas.openxmlformats.org/drawingml/2006/main">
               <a:ext uri="{FF2B5EF4-FFF2-40B4-BE49-F238E27FC236}">
-                <a16:creationId xmlns:a16="http://schemas.microsoft.com/office/drawing/2014/main" id="{37F36D55-BC4D-43BA-AC25-17110EBBCF67}"/>
+                <a16:creationId xmlns:a16="http://schemas.microsoft.com/office/drawing/2014/main" id="{6A556FE4-232B-4F6A-9F21-B92D870FA519}"/>
               </a:ext>
             </a:extLst>
           </p:cNvPr>
@@ -4477,7 +4477,7 @@
           <p:cNvPr id="15" name="">
             <a:extLst xmlns:a="http://schemas.openxmlformats.org/drawingml/2006/main">
               <a:ext uri="{FF2B5EF4-FFF2-40B4-BE49-F238E27FC236}">
-                <a16:creationId xmlns:a16="http://schemas.microsoft.com/office/drawing/2014/main" id="{9B2E4770-D0EA-42F5-A9E1-8D762311CBD5}"/>
+                <a16:creationId xmlns:a16="http://schemas.microsoft.com/office/drawing/2014/main" id="{F26E49A3-7BB4-4449-9BB7-3E9607566399}"/>
               </a:ext>
             </a:extLst>
           </p:cNvPr>
@@ -4535,7 +4535,7 @@
           <p:cNvPr id="16" name="">
             <a:extLst xmlns:a="http://schemas.openxmlformats.org/drawingml/2006/main">
               <a:ext uri="{FF2B5EF4-FFF2-40B4-BE49-F238E27FC236}">
-                <a16:creationId xmlns:a16="http://schemas.microsoft.com/office/drawing/2014/main" id="{9213B2F3-EF41-4BBB-8202-75AFA698E82C}"/>
+                <a16:creationId xmlns:a16="http://schemas.microsoft.com/office/drawing/2014/main" id="{5AA72654-F562-4F5E-8C9D-CD318DABC136}"/>
               </a:ext>
             </a:extLst>
           </p:cNvPr>
@@ -4593,7 +4593,7 @@
           <p:cNvPr id="17" name="">
             <a:extLst xmlns:a="http://schemas.openxmlformats.org/drawingml/2006/main">
               <a:ext uri="{FF2B5EF4-FFF2-40B4-BE49-F238E27FC236}">
-                <a16:creationId xmlns:a16="http://schemas.microsoft.com/office/drawing/2014/main" id="{25A7EDFF-1B88-4774-BB11-8D95A73FC481}"/>
+                <a16:creationId xmlns:a16="http://schemas.microsoft.com/office/drawing/2014/main" id="{8EB50748-499B-470A-8450-E5F7285C725C}"/>
               </a:ext>
             </a:extLst>
           </p:cNvPr>
@@ -4628,7 +4628,7 @@
           <p:cNvPr id="18" name="">
             <a:extLst xmlns:a="http://schemas.openxmlformats.org/drawingml/2006/main">
               <a:ext uri="{FF2B5EF4-FFF2-40B4-BE49-F238E27FC236}">
-                <a16:creationId xmlns:a16="http://schemas.microsoft.com/office/drawing/2014/main" id="{3D528EC4-D6FF-4C3C-A1FE-CB12B8FA1718}"/>
+                <a16:creationId xmlns:a16="http://schemas.microsoft.com/office/drawing/2014/main" id="{4BF37AFA-28EC-49B8-832D-D759C1CC8C35}"/>
               </a:ext>
             </a:extLst>
           </p:cNvPr>
@@ -4663,7 +4663,7 @@
           <p:cNvPr id="19" name="">
             <a:extLst xmlns:a="http://schemas.openxmlformats.org/drawingml/2006/main">
               <a:ext uri="{FF2B5EF4-FFF2-40B4-BE49-F238E27FC236}">
-                <a16:creationId xmlns:a16="http://schemas.microsoft.com/office/drawing/2014/main" id="{D8E6FF9E-E5BE-40CC-8B11-19953F05EAF8}"/>
+                <a16:creationId xmlns:a16="http://schemas.microsoft.com/office/drawing/2014/main" id="{D793DCDC-4854-4F04-8242-4A08EC88EC5C}"/>
               </a:ext>
             </a:extLst>
           </p:cNvPr>
@@ -4721,7 +4721,7 @@
           <p:cNvPr id="20" name="">
             <a:extLst xmlns:a="http://schemas.openxmlformats.org/drawingml/2006/main">
               <a:ext uri="{FF2B5EF4-FFF2-40B4-BE49-F238E27FC236}">
-                <a16:creationId xmlns:a16="http://schemas.microsoft.com/office/drawing/2014/main" id="{133F2FAF-3CCF-435B-8E3D-86B155146FA9}"/>
+                <a16:creationId xmlns:a16="http://schemas.microsoft.com/office/drawing/2014/main" id="{FA138BD7-9CF9-47A1-8916-DFAF0D8087E7}"/>
               </a:ext>
             </a:extLst>
           </p:cNvPr>
@@ -4779,7 +4779,7 @@
           <p:cNvPr id="21" name="">
             <a:extLst xmlns:a="http://schemas.openxmlformats.org/drawingml/2006/main">
               <a:ext uri="{FF2B5EF4-FFF2-40B4-BE49-F238E27FC236}">
-                <a16:creationId xmlns:a16="http://schemas.microsoft.com/office/drawing/2014/main" id="{45CD94B3-E2BA-4B5A-B73F-FBC1C2B6AA81}"/>
+                <a16:creationId xmlns:a16="http://schemas.microsoft.com/office/drawing/2014/main" id="{0464B3CC-28E0-4B25-9846-958C2ED4F9F8}"/>
               </a:ext>
             </a:extLst>
           </p:cNvPr>
@@ -4837,7 +4837,7 @@
           <p:cNvPr id="22" name="">
             <a:extLst xmlns:a="http://schemas.openxmlformats.org/drawingml/2006/main">
               <a:ext uri="{FF2B5EF4-FFF2-40B4-BE49-F238E27FC236}">
-                <a16:creationId xmlns:a16="http://schemas.microsoft.com/office/drawing/2014/main" id="{60279F59-BCFE-4BF4-868C-5ECAF80E7212}"/>
+                <a16:creationId xmlns:a16="http://schemas.microsoft.com/office/drawing/2014/main" id="{5E992DBE-D81E-43CC-9948-F66069A82F57}"/>
               </a:ext>
             </a:extLst>
           </p:cNvPr>
@@ -4895,7 +4895,7 @@
           <p:cNvPr id="23" name="">
             <a:extLst xmlns:a="http://schemas.openxmlformats.org/drawingml/2006/main">
               <a:ext uri="{FF2B5EF4-FFF2-40B4-BE49-F238E27FC236}">
-                <a16:creationId xmlns:a16="http://schemas.microsoft.com/office/drawing/2014/main" id="{FA888E17-3B3C-4109-B7DF-CEF9214294FD}"/>
+                <a16:creationId xmlns:a16="http://schemas.microsoft.com/office/drawing/2014/main" id="{872C910D-1B42-4F0E-88C4-1ED4153C11B9}"/>
               </a:ext>
             </a:extLst>
           </p:cNvPr>
@@ -4930,7 +4930,7 @@
           <p:cNvPr id="24" name="">
             <a:extLst xmlns:a="http://schemas.openxmlformats.org/drawingml/2006/main">
               <a:ext uri="{FF2B5EF4-FFF2-40B4-BE49-F238E27FC236}">
-                <a16:creationId xmlns:a16="http://schemas.microsoft.com/office/drawing/2014/main" id="{A1D5314F-2BC6-43E2-9642-59813168330D}"/>
+                <a16:creationId xmlns:a16="http://schemas.microsoft.com/office/drawing/2014/main" id="{4772E6E0-5937-4B03-85C0-E15743EA2E99}"/>
               </a:ext>
             </a:extLst>
           </p:cNvPr>
@@ -4965,7 +4965,7 @@
           <p:cNvPr id="25" name="">
             <a:extLst xmlns:a="http://schemas.openxmlformats.org/drawingml/2006/main">
               <a:ext uri="{FF2B5EF4-FFF2-40B4-BE49-F238E27FC236}">
-                <a16:creationId xmlns:a16="http://schemas.microsoft.com/office/drawing/2014/main" id="{B229A7F3-58D4-41C2-9166-C0612DF15D0D}"/>
+                <a16:creationId xmlns:a16="http://schemas.microsoft.com/office/drawing/2014/main" id="{7AEC93B3-DDBD-4EF9-95D6-00213BB500E1}"/>
               </a:ext>
             </a:extLst>
           </p:cNvPr>
@@ -5023,7 +5023,7 @@
           <p:cNvPr id="26" name="">
             <a:extLst xmlns:a="http://schemas.openxmlformats.org/drawingml/2006/main">
               <a:ext uri="{FF2B5EF4-FFF2-40B4-BE49-F238E27FC236}">
-                <a16:creationId xmlns:a16="http://schemas.microsoft.com/office/drawing/2014/main" id="{3D31D0CF-E355-4D20-A432-4BE707BFC98C}"/>
+                <a16:creationId xmlns:a16="http://schemas.microsoft.com/office/drawing/2014/main" id="{A80B17E9-D374-414C-8A04-C4B0A68BFFFC}"/>
               </a:ext>
             </a:extLst>
           </p:cNvPr>
@@ -5081,7 +5081,7 @@
           <p:cNvPr id="27" name="">
             <a:extLst xmlns:a="http://schemas.openxmlformats.org/drawingml/2006/main">
               <a:ext uri="{FF2B5EF4-FFF2-40B4-BE49-F238E27FC236}">
-                <a16:creationId xmlns:a16="http://schemas.microsoft.com/office/drawing/2014/main" id="{E5300784-2781-48C1-83F6-5C6107E32FE9}"/>
+                <a16:creationId xmlns:a16="http://schemas.microsoft.com/office/drawing/2014/main" id="{AE086DFF-4305-4024-81B0-8FD48B74CB27}"/>
               </a:ext>
             </a:extLst>
           </p:cNvPr>
@@ -5139,7 +5139,7 @@
           <p:cNvPr id="28" name="">
             <a:extLst xmlns:a="http://schemas.openxmlformats.org/drawingml/2006/main">
               <a:ext uri="{FF2B5EF4-FFF2-40B4-BE49-F238E27FC236}">
-                <a16:creationId xmlns:a16="http://schemas.microsoft.com/office/drawing/2014/main" id="{20F1019A-6648-4396-B544-5A1E7E697018}"/>
+                <a16:creationId xmlns:a16="http://schemas.microsoft.com/office/drawing/2014/main" id="{2F885BC6-7E30-422F-8407-820B7BA85168}"/>
               </a:ext>
             </a:extLst>
           </p:cNvPr>
@@ -5197,7 +5197,7 @@
           <p:cNvPr id="29" name="">
             <a:extLst xmlns:a="http://schemas.openxmlformats.org/drawingml/2006/main">
               <a:ext uri="{FF2B5EF4-FFF2-40B4-BE49-F238E27FC236}">
-                <a16:creationId xmlns:a16="http://schemas.microsoft.com/office/drawing/2014/main" id="{6A58DD3F-2C15-4D8B-95A5-0F01BAA74099}"/>
+                <a16:creationId xmlns:a16="http://schemas.microsoft.com/office/drawing/2014/main" id="{FBC23F28-90C1-4AD0-8B6A-541CDBFE899F}"/>
               </a:ext>
             </a:extLst>
           </p:cNvPr>
@@ -5232,7 +5232,7 @@
           <p:cNvPr id="30" name="">
             <a:extLst xmlns:a="http://schemas.openxmlformats.org/drawingml/2006/main">
               <a:ext uri="{FF2B5EF4-FFF2-40B4-BE49-F238E27FC236}">
-                <a16:creationId xmlns:a16="http://schemas.microsoft.com/office/drawing/2014/main" id="{EC157395-DB6D-4E9B-BED4-2578B192919D}"/>
+                <a16:creationId xmlns:a16="http://schemas.microsoft.com/office/drawing/2014/main" id="{D4B4C873-8F2F-48C1-BF3E-17655EFE33AA}"/>
               </a:ext>
             </a:extLst>
           </p:cNvPr>
@@ -5267,7 +5267,7 @@
           <p:cNvPr id="31" name="">
             <a:extLst xmlns:a="http://schemas.openxmlformats.org/drawingml/2006/main">
               <a:ext uri="{FF2B5EF4-FFF2-40B4-BE49-F238E27FC236}">
-                <a16:creationId xmlns:a16="http://schemas.microsoft.com/office/drawing/2014/main" id="{BD02D834-C296-4383-9E84-99E329AAC9A8}"/>
+                <a16:creationId xmlns:a16="http://schemas.microsoft.com/office/drawing/2014/main" id="{104A8D82-370C-4534-87ED-5C31A87E4A86}"/>
               </a:ext>
             </a:extLst>
           </p:cNvPr>
@@ -5325,7 +5325,7 @@
           <p:cNvPr id="32" name="">
             <a:extLst xmlns:a="http://schemas.openxmlformats.org/drawingml/2006/main">
               <a:ext uri="{FF2B5EF4-FFF2-40B4-BE49-F238E27FC236}">
-                <a16:creationId xmlns:a16="http://schemas.microsoft.com/office/drawing/2014/main" id="{EC0FFB8C-EDCE-4469-A431-B50B30322D34}"/>
+                <a16:creationId xmlns:a16="http://schemas.microsoft.com/office/drawing/2014/main" id="{34C0943D-D3DB-4F05-AE0A-B0367D570B88}"/>
               </a:ext>
             </a:extLst>
           </p:cNvPr>
@@ -5383,7 +5383,7 @@
           <p:cNvPr id="33" name="">
             <a:extLst xmlns:a="http://schemas.openxmlformats.org/drawingml/2006/main">
               <a:ext uri="{FF2B5EF4-FFF2-40B4-BE49-F238E27FC236}">
-                <a16:creationId xmlns:a16="http://schemas.microsoft.com/office/drawing/2014/main" id="{F63A9DC7-F565-427F-9B6B-2075F5D9BFA3}"/>
+                <a16:creationId xmlns:a16="http://schemas.microsoft.com/office/drawing/2014/main" id="{B80A9B53-8C94-4777-BA08-93D035912AA1}"/>
               </a:ext>
             </a:extLst>
           </p:cNvPr>
@@ -5441,7 +5441,7 @@
           <p:cNvPr id="34" name="">
             <a:extLst xmlns:a="http://schemas.openxmlformats.org/drawingml/2006/main">
               <a:ext uri="{FF2B5EF4-FFF2-40B4-BE49-F238E27FC236}">
-                <a16:creationId xmlns:a16="http://schemas.microsoft.com/office/drawing/2014/main" id="{C70F1241-2781-42F9-BD7D-F9103BE414B7}"/>
+                <a16:creationId xmlns:a16="http://schemas.microsoft.com/office/drawing/2014/main" id="{6E6F4135-CBB9-40FC-8F28-22B129F41240}"/>
               </a:ext>
             </a:extLst>
           </p:cNvPr>
@@ -5499,7 +5499,7 @@
           <p:cNvPr id="35" name="">
             <a:extLst xmlns:a="http://schemas.openxmlformats.org/drawingml/2006/main">
               <a:ext uri="{FF2B5EF4-FFF2-40B4-BE49-F238E27FC236}">
-                <a16:creationId xmlns:a16="http://schemas.microsoft.com/office/drawing/2014/main" id="{E0964E61-1AC0-4FC5-9F89-45757FB19E81}"/>
+                <a16:creationId xmlns:a16="http://schemas.microsoft.com/office/drawing/2014/main" id="{597E0818-83ED-4EEB-B52C-16063C8FF8E1}"/>
               </a:ext>
             </a:extLst>
           </p:cNvPr>
@@ -5547,7 +5547,7 @@
                 <a:ea typeface="Aptos"/>
                 <a:cs typeface="Aptos"/>
               </a:rPr>
-              <a:t>WATERS NEXT GEN COMPETITIVE INTELLIGENCE · 17 AUG 2026 · waters-ci-20260817124300</a:t>
+              <a:t>WATERS NEXT GEN COMPETITIVE INTELLIGENCE · 23 AUG 2026 · waters-ci-20260820104036</a:t>
             </a:r>
           </a:p>
         </p:txBody>
@@ -5557,7 +5557,7 @@
           <p:cNvPr id="36" name="">
             <a:extLst xmlns:a="http://schemas.openxmlformats.org/drawingml/2006/main">
               <a:ext uri="{FF2B5EF4-FFF2-40B4-BE49-F238E27FC236}">
-                <a16:creationId xmlns:a16="http://schemas.microsoft.com/office/drawing/2014/main" id="{77B705F1-0095-4FED-8631-421BC4623950}"/>
+                <a16:creationId xmlns:a16="http://schemas.microsoft.com/office/drawing/2014/main" id="{31EE01B3-325A-4148-80E7-673DDB889770}"/>
               </a:ext>
             </a:extLst>
           </p:cNvPr>
@@ -5613,7 +5613,7 @@
     </p:spTree>
     <p:extLst>
       <p:ext uri="{BB962C8B-B14F-4D97-AF65-F5344CB8AC3E}">
-        <p14:creationId xmlns:p14="http://schemas.microsoft.com/office/powerpoint/2010/main" val="906120089"/>
+        <p14:creationId xmlns:p14="http://schemas.microsoft.com/office/powerpoint/2010/main" val="2038538785"/>
       </p:ext>
     </p:extLst>
   </p:cSld>
@@ -5644,7 +5644,7 @@
           <p:cNvPr id="31" name="">
             <a:extLst xmlns:a="http://schemas.openxmlformats.org/drawingml/2006/main">
               <a:ext uri="{FF2B5EF4-FFF2-40B4-BE49-F238E27FC236}">
-                <a16:creationId xmlns:a16="http://schemas.microsoft.com/office/drawing/2014/main" id="{F8C58079-E60A-42BB-963C-A7299855345A}"/>
+                <a16:creationId xmlns:a16="http://schemas.microsoft.com/office/drawing/2014/main" id="{44AEA82A-8746-48B9-A0B4-8B014FD6448B}"/>
               </a:ext>
             </a:extLst>
           </p:cNvPr>
@@ -5702,7 +5702,7 @@
           <p:cNvPr id="2" name="">
             <a:extLst xmlns:a="http://schemas.openxmlformats.org/drawingml/2006/main">
               <a:ext uri="{FF2B5EF4-FFF2-40B4-BE49-F238E27FC236}">
-                <a16:creationId xmlns:a16="http://schemas.microsoft.com/office/drawing/2014/main" id="{15CF73F5-20FE-4A79-9D02-ACFFB8A565B2}"/>
+                <a16:creationId xmlns:a16="http://schemas.microsoft.com/office/drawing/2014/main" id="{88DE207F-BABE-47AB-8C18-D00AF70690F9}"/>
               </a:ext>
             </a:extLst>
           </p:cNvPr>
@@ -5760,7 +5760,7 @@
           <p:cNvPr id="3" name="">
             <a:extLst xmlns:a="http://schemas.openxmlformats.org/drawingml/2006/main">
               <a:ext uri="{FF2B5EF4-FFF2-40B4-BE49-F238E27FC236}">
-                <a16:creationId xmlns:a16="http://schemas.microsoft.com/office/drawing/2014/main" id="{3E7CB3EB-C6FB-43B7-BDE9-5C115EC66AA1}"/>
+                <a16:creationId xmlns:a16="http://schemas.microsoft.com/office/drawing/2014/main" id="{2A163A8A-28FB-4F20-A411-33927703636E}"/>
               </a:ext>
             </a:extLst>
           </p:cNvPr>
@@ -5818,7 +5818,7 @@
           <p:cNvPr id="4" name="">
             <a:extLst xmlns:a="http://schemas.openxmlformats.org/drawingml/2006/main">
               <a:ext uri="{FF2B5EF4-FFF2-40B4-BE49-F238E27FC236}">
-                <a16:creationId xmlns:a16="http://schemas.microsoft.com/office/drawing/2014/main" id="{F4C16FE5-BAC0-4A06-8B7E-CB5F69D00FCF}"/>
+                <a16:creationId xmlns:a16="http://schemas.microsoft.com/office/drawing/2014/main" id="{33351EC9-938E-49E8-B6F0-BD182B2D88F7}"/>
               </a:ext>
             </a:extLst>
           </p:cNvPr>
@@ -5851,7 +5851,7 @@
           <p:cNvPr id="5" name="">
             <a:extLst xmlns:a="http://schemas.openxmlformats.org/drawingml/2006/main">
               <a:ext uri="{FF2B5EF4-FFF2-40B4-BE49-F238E27FC236}">
-                <a16:creationId xmlns:a16="http://schemas.microsoft.com/office/drawing/2014/main" id="{33943C41-756A-48CF-9A36-83F04871C137}"/>
+                <a16:creationId xmlns:a16="http://schemas.microsoft.com/office/drawing/2014/main" id="{B9C7A60D-F53B-4BAB-B5BC-1DD660DB259E}"/>
               </a:ext>
             </a:extLst>
           </p:cNvPr>
@@ -5886,7 +5886,7 @@
           <p:cNvPr id="6" name="">
             <a:extLst xmlns:a="http://schemas.openxmlformats.org/drawingml/2006/main">
               <a:ext uri="{FF2B5EF4-FFF2-40B4-BE49-F238E27FC236}">
-                <a16:creationId xmlns:a16="http://schemas.microsoft.com/office/drawing/2014/main" id="{D87DE794-8B4A-4637-8757-ECBDE29ACE03}"/>
+                <a16:creationId xmlns:a16="http://schemas.microsoft.com/office/drawing/2014/main" id="{B7E1D81D-2B14-491B-9D80-7D2732EBDFBD}"/>
               </a:ext>
             </a:extLst>
           </p:cNvPr>
@@ -5919,7 +5919,7 @@
           <p:cNvPr id="7" name="">
             <a:extLst xmlns:a="http://schemas.openxmlformats.org/drawingml/2006/main">
               <a:ext uri="{FF2B5EF4-FFF2-40B4-BE49-F238E27FC236}">
-                <a16:creationId xmlns:a16="http://schemas.microsoft.com/office/drawing/2014/main" id="{3DB79A4C-A07B-4364-A1F8-49ED2DE7970F}"/>
+                <a16:creationId xmlns:a16="http://schemas.microsoft.com/office/drawing/2014/main" id="{1B8FDACD-87D9-4BEC-944D-25AA3AD96FB3}"/>
               </a:ext>
             </a:extLst>
           </p:cNvPr>
@@ -5977,7 +5977,7 @@
           <p:cNvPr id="8" name="">
             <a:extLst xmlns:a="http://schemas.openxmlformats.org/drawingml/2006/main">
               <a:ext uri="{FF2B5EF4-FFF2-40B4-BE49-F238E27FC236}">
-                <a16:creationId xmlns:a16="http://schemas.microsoft.com/office/drawing/2014/main" id="{3FC25C05-E85B-44AC-B129-07B16BE8D391}"/>
+                <a16:creationId xmlns:a16="http://schemas.microsoft.com/office/drawing/2014/main" id="{8EAA95A1-A682-4ABE-9538-3428E7438539}"/>
               </a:ext>
             </a:extLst>
           </p:cNvPr>
@@ -6035,7 +6035,7 @@
           <p:cNvPr id="9" name="">
             <a:extLst xmlns:a="http://schemas.openxmlformats.org/drawingml/2006/main">
               <a:ext uri="{FF2B5EF4-FFF2-40B4-BE49-F238E27FC236}">
-                <a16:creationId xmlns:a16="http://schemas.microsoft.com/office/drawing/2014/main" id="{16647CDA-1239-47B4-89BA-FC38B04A1C85}"/>
+                <a16:creationId xmlns:a16="http://schemas.microsoft.com/office/drawing/2014/main" id="{93C42C20-124C-44CC-9E69-419451593BF4}"/>
               </a:ext>
             </a:extLst>
           </p:cNvPr>
@@ -6093,7 +6093,7 @@
           <p:cNvPr id="10" name="">
             <a:extLst xmlns:a="http://schemas.openxmlformats.org/drawingml/2006/main">
               <a:ext uri="{FF2B5EF4-FFF2-40B4-BE49-F238E27FC236}">
-                <a16:creationId xmlns:a16="http://schemas.microsoft.com/office/drawing/2014/main" id="{3486CFD1-A653-45BF-9DD3-5959B856C90A}"/>
+                <a16:creationId xmlns:a16="http://schemas.microsoft.com/office/drawing/2014/main" id="{B6D65A2D-A738-40FA-8334-853F260365CE}"/>
               </a:ext>
             </a:extLst>
           </p:cNvPr>
@@ -6151,7 +6151,7 @@
           <p:cNvPr id="11" name="">
             <a:extLst xmlns:a="http://schemas.openxmlformats.org/drawingml/2006/main">
               <a:ext uri="{FF2B5EF4-FFF2-40B4-BE49-F238E27FC236}">
-                <a16:creationId xmlns:a16="http://schemas.microsoft.com/office/drawing/2014/main" id="{46754B50-91E6-48B2-BB17-DCCCC5FB1E92}"/>
+                <a16:creationId xmlns:a16="http://schemas.microsoft.com/office/drawing/2014/main" id="{23CCA060-B0BA-430F-9AEC-FADFC714AF94}"/>
               </a:ext>
             </a:extLst>
           </p:cNvPr>
@@ -6186,7 +6186,7 @@
           <p:cNvPr id="12" name="">
             <a:extLst xmlns:a="http://schemas.openxmlformats.org/drawingml/2006/main">
               <a:ext uri="{FF2B5EF4-FFF2-40B4-BE49-F238E27FC236}">
-                <a16:creationId xmlns:a16="http://schemas.microsoft.com/office/drawing/2014/main" id="{DC364B4A-5DF0-41FC-913C-E1A740B3A58E}"/>
+                <a16:creationId xmlns:a16="http://schemas.microsoft.com/office/drawing/2014/main" id="{0D74E736-F90F-49A8-B418-0259CE58DE0E}"/>
               </a:ext>
             </a:extLst>
           </p:cNvPr>
@@ -6219,7 +6219,7 @@
           <p:cNvPr id="13" name="">
             <a:extLst xmlns:a="http://schemas.openxmlformats.org/drawingml/2006/main">
               <a:ext uri="{FF2B5EF4-FFF2-40B4-BE49-F238E27FC236}">
-                <a16:creationId xmlns:a16="http://schemas.microsoft.com/office/drawing/2014/main" id="{8B3FF07D-ADF4-467D-BBA7-88367878986B}"/>
+                <a16:creationId xmlns:a16="http://schemas.microsoft.com/office/drawing/2014/main" id="{BD7B1821-2516-4A18-ACE9-77B0391C77FF}"/>
               </a:ext>
             </a:extLst>
           </p:cNvPr>
@@ -6277,7 +6277,7 @@
           <p:cNvPr id="14" name="">
             <a:extLst xmlns:a="http://schemas.openxmlformats.org/drawingml/2006/main">
               <a:ext uri="{FF2B5EF4-FFF2-40B4-BE49-F238E27FC236}">
-                <a16:creationId xmlns:a16="http://schemas.microsoft.com/office/drawing/2014/main" id="{164012EB-678C-4F30-9270-745F9449A5F8}"/>
+                <a16:creationId xmlns:a16="http://schemas.microsoft.com/office/drawing/2014/main" id="{B87871D9-6A94-4D30-8548-BC0FACC200D1}"/>
               </a:ext>
             </a:extLst>
           </p:cNvPr>
@@ -6335,7 +6335,7 @@
           <p:cNvPr id="15" name="">
             <a:extLst xmlns:a="http://schemas.openxmlformats.org/drawingml/2006/main">
               <a:ext uri="{FF2B5EF4-FFF2-40B4-BE49-F238E27FC236}">
-                <a16:creationId xmlns:a16="http://schemas.microsoft.com/office/drawing/2014/main" id="{BC34A706-A6B4-4B65-BE77-B4396C1A49E0}"/>
+                <a16:creationId xmlns:a16="http://schemas.microsoft.com/office/drawing/2014/main" id="{5CFA351A-921D-4A2E-8713-85293B772A33}"/>
               </a:ext>
             </a:extLst>
           </p:cNvPr>
@@ -6393,7 +6393,7 @@
           <p:cNvPr id="16" name="">
             <a:extLst xmlns:a="http://schemas.openxmlformats.org/drawingml/2006/main">
               <a:ext uri="{FF2B5EF4-FFF2-40B4-BE49-F238E27FC236}">
-                <a16:creationId xmlns:a16="http://schemas.microsoft.com/office/drawing/2014/main" id="{9744671E-DAF4-499F-A269-23C3638CC0EC}"/>
+                <a16:creationId xmlns:a16="http://schemas.microsoft.com/office/drawing/2014/main" id="{D7B809C4-FEA7-4D1D-8509-27EB41DD6979}"/>
               </a:ext>
             </a:extLst>
           </p:cNvPr>
@@ -6451,7 +6451,7 @@
           <p:cNvPr id="17" name="">
             <a:extLst xmlns:a="http://schemas.openxmlformats.org/drawingml/2006/main">
               <a:ext uri="{FF2B5EF4-FFF2-40B4-BE49-F238E27FC236}">
-                <a16:creationId xmlns:a16="http://schemas.microsoft.com/office/drawing/2014/main" id="{0F15A82A-25E7-4DC5-8574-ACF40C66206E}"/>
+                <a16:creationId xmlns:a16="http://schemas.microsoft.com/office/drawing/2014/main" id="{05163DF2-9163-408B-9951-9F80F9ECB172}"/>
               </a:ext>
             </a:extLst>
           </p:cNvPr>
@@ -6486,7 +6486,7 @@
           <p:cNvPr id="18" name="">
             <a:extLst xmlns:a="http://schemas.openxmlformats.org/drawingml/2006/main">
               <a:ext uri="{FF2B5EF4-FFF2-40B4-BE49-F238E27FC236}">
-                <a16:creationId xmlns:a16="http://schemas.microsoft.com/office/drawing/2014/main" id="{91CC4ACE-F0F1-4235-819B-FACF0A67E784}"/>
+                <a16:creationId xmlns:a16="http://schemas.microsoft.com/office/drawing/2014/main" id="{ACDFB479-6A68-4E4F-8676-A41E68E64928}"/>
               </a:ext>
             </a:extLst>
           </p:cNvPr>
@@ -6519,7 +6519,7 @@
           <p:cNvPr id="19" name="">
             <a:extLst xmlns:a="http://schemas.openxmlformats.org/drawingml/2006/main">
               <a:ext uri="{FF2B5EF4-FFF2-40B4-BE49-F238E27FC236}">
-                <a16:creationId xmlns:a16="http://schemas.microsoft.com/office/drawing/2014/main" id="{8843F08B-FF4C-44CC-A429-3664DB7040D3}"/>
+                <a16:creationId xmlns:a16="http://schemas.microsoft.com/office/drawing/2014/main" id="{D6C79DC1-EA49-4B6A-984B-776F11C582F0}"/>
               </a:ext>
             </a:extLst>
           </p:cNvPr>
@@ -6577,7 +6577,7 @@
           <p:cNvPr id="20" name="">
             <a:extLst xmlns:a="http://schemas.openxmlformats.org/drawingml/2006/main">
               <a:ext uri="{FF2B5EF4-FFF2-40B4-BE49-F238E27FC236}">
-                <a16:creationId xmlns:a16="http://schemas.microsoft.com/office/drawing/2014/main" id="{6BDF565E-674B-43BE-9503-7968C28EB1F8}"/>
+                <a16:creationId xmlns:a16="http://schemas.microsoft.com/office/drawing/2014/main" id="{8A3B0328-FA30-452B-8E7D-1A44977AB599}"/>
               </a:ext>
             </a:extLst>
           </p:cNvPr>
@@ -6635,7 +6635,7 @@
           <p:cNvPr id="21" name="">
             <a:extLst xmlns:a="http://schemas.openxmlformats.org/drawingml/2006/main">
               <a:ext uri="{FF2B5EF4-FFF2-40B4-BE49-F238E27FC236}">
-                <a16:creationId xmlns:a16="http://schemas.microsoft.com/office/drawing/2014/main" id="{04EAC7E5-1AEF-4B53-B10B-1E92AFF7B90A}"/>
+                <a16:creationId xmlns:a16="http://schemas.microsoft.com/office/drawing/2014/main" id="{831D0D3D-21E7-41AF-A36E-EC25B0E31712}"/>
               </a:ext>
             </a:extLst>
           </p:cNvPr>
@@ -6693,7 +6693,7 @@
           <p:cNvPr id="22" name="">
             <a:extLst xmlns:a="http://schemas.openxmlformats.org/drawingml/2006/main">
               <a:ext uri="{FF2B5EF4-FFF2-40B4-BE49-F238E27FC236}">
-                <a16:creationId xmlns:a16="http://schemas.microsoft.com/office/drawing/2014/main" id="{C66D1C91-8F83-4648-8D96-D93E2D1CED44}"/>
+                <a16:creationId xmlns:a16="http://schemas.microsoft.com/office/drawing/2014/main" id="{CBDA7503-E3A6-4207-92F5-5F34F74BC469}"/>
               </a:ext>
             </a:extLst>
           </p:cNvPr>
@@ -6751,7 +6751,7 @@
           <p:cNvPr id="23" name="">
             <a:extLst xmlns:a="http://schemas.openxmlformats.org/drawingml/2006/main">
               <a:ext uri="{FF2B5EF4-FFF2-40B4-BE49-F238E27FC236}">
-                <a16:creationId xmlns:a16="http://schemas.microsoft.com/office/drawing/2014/main" id="{C1EB3929-CEB0-491B-A6C1-8B6173BB0550}"/>
+                <a16:creationId xmlns:a16="http://schemas.microsoft.com/office/drawing/2014/main" id="{E01DE9E7-FBB0-4ED1-8D63-C977CE2ED8AE}"/>
               </a:ext>
             </a:extLst>
           </p:cNvPr>
@@ -6786,7 +6786,7 @@
           <p:cNvPr id="24" name="">
             <a:extLst xmlns:a="http://schemas.openxmlformats.org/drawingml/2006/main">
               <a:ext uri="{FF2B5EF4-FFF2-40B4-BE49-F238E27FC236}">
-                <a16:creationId xmlns:a16="http://schemas.microsoft.com/office/drawing/2014/main" id="{33A88D4E-99F8-4403-8924-509C30D97BC3}"/>
+                <a16:creationId xmlns:a16="http://schemas.microsoft.com/office/drawing/2014/main" id="{3FB70F43-66AF-49F2-8962-2850D3F19CC4}"/>
               </a:ext>
             </a:extLst>
           </p:cNvPr>
@@ -6819,7 +6819,7 @@
           <p:cNvPr id="25" name="">
             <a:extLst xmlns:a="http://schemas.openxmlformats.org/drawingml/2006/main">
               <a:ext uri="{FF2B5EF4-FFF2-40B4-BE49-F238E27FC236}">
-                <a16:creationId xmlns:a16="http://schemas.microsoft.com/office/drawing/2014/main" id="{BE014D38-AAE4-4BE7-B177-68F514295D42}"/>
+                <a16:creationId xmlns:a16="http://schemas.microsoft.com/office/drawing/2014/main" id="{D8387D7B-D2BB-47B3-A446-12D83A3FFF61}"/>
               </a:ext>
             </a:extLst>
           </p:cNvPr>
@@ -6877,7 +6877,7 @@
           <p:cNvPr id="26" name="">
             <a:extLst xmlns:a="http://schemas.openxmlformats.org/drawingml/2006/main">
               <a:ext uri="{FF2B5EF4-FFF2-40B4-BE49-F238E27FC236}">
-                <a16:creationId xmlns:a16="http://schemas.microsoft.com/office/drawing/2014/main" id="{E87CAC8D-72FA-4B5F-9154-36AF21749A39}"/>
+                <a16:creationId xmlns:a16="http://schemas.microsoft.com/office/drawing/2014/main" id="{988A2C73-B8F3-4786-B436-4B81DB1C7E2B}"/>
               </a:ext>
             </a:extLst>
           </p:cNvPr>
@@ -6935,7 +6935,7 @@
           <p:cNvPr id="27" name="">
             <a:extLst xmlns:a="http://schemas.openxmlformats.org/drawingml/2006/main">
               <a:ext uri="{FF2B5EF4-FFF2-40B4-BE49-F238E27FC236}">
-                <a16:creationId xmlns:a16="http://schemas.microsoft.com/office/drawing/2014/main" id="{1E6F11E1-99E9-49E2-B0C0-3A8216D30D29}"/>
+                <a16:creationId xmlns:a16="http://schemas.microsoft.com/office/drawing/2014/main" id="{8BCADF0A-3CE4-48B2-B73A-AF4C2267BC63}"/>
               </a:ext>
             </a:extLst>
           </p:cNvPr>
@@ -6993,7 +6993,7 @@
           <p:cNvPr id="28" name="">
             <a:extLst xmlns:a="http://schemas.openxmlformats.org/drawingml/2006/main">
               <a:ext uri="{FF2B5EF4-FFF2-40B4-BE49-F238E27FC236}">
-                <a16:creationId xmlns:a16="http://schemas.microsoft.com/office/drawing/2014/main" id="{16C260FF-4233-44F8-B3E3-E25B6AE0A2E3}"/>
+                <a16:creationId xmlns:a16="http://schemas.microsoft.com/office/drawing/2014/main" id="{35DB14B6-753D-455A-88EE-6DA6C0278675}"/>
               </a:ext>
             </a:extLst>
           </p:cNvPr>
@@ -7051,7 +7051,7 @@
           <p:cNvPr id="29" name="">
             <a:extLst xmlns:a="http://schemas.openxmlformats.org/drawingml/2006/main">
               <a:ext uri="{FF2B5EF4-FFF2-40B4-BE49-F238E27FC236}">
-                <a16:creationId xmlns:a16="http://schemas.microsoft.com/office/drawing/2014/main" id="{E4DA6921-EB77-4230-95E9-29D50B405386}"/>
+                <a16:creationId xmlns:a16="http://schemas.microsoft.com/office/drawing/2014/main" id="{11851F2E-3DB5-4505-B302-8D9DF786007D}"/>
               </a:ext>
             </a:extLst>
           </p:cNvPr>
@@ -7099,7 +7099,7 @@
                 <a:ea typeface="Aptos"/>
                 <a:cs typeface="Aptos"/>
               </a:rPr>
-              <a:t>WATERS NEXT GEN COMPETITIVE INTELLIGENCE · 17 AUG 2026 · waters-ci-20260817124300</a:t>
+              <a:t>WATERS NEXT GEN COMPETITIVE INTELLIGENCE · 23 AUG 2026 · waters-ci-20260820104036</a:t>
             </a:r>
           </a:p>
         </p:txBody>
@@ -7109,7 +7109,7 @@
           <p:cNvPr id="30" name="">
             <a:extLst xmlns:a="http://schemas.openxmlformats.org/drawingml/2006/main">
               <a:ext uri="{FF2B5EF4-FFF2-40B4-BE49-F238E27FC236}">
-                <a16:creationId xmlns:a16="http://schemas.microsoft.com/office/drawing/2014/main" id="{C7F6AB50-8C44-461F-AA7E-23A67E4A2B8A}"/>
+                <a16:creationId xmlns:a16="http://schemas.microsoft.com/office/drawing/2014/main" id="{8378B022-67C0-40D1-9CC5-511CE0E34E64}"/>
               </a:ext>
             </a:extLst>
           </p:cNvPr>
@@ -7165,7 +7165,7 @@
     </p:spTree>
     <p:extLst>
       <p:ext uri="{BB962C8B-B14F-4D97-AF65-F5344CB8AC3E}">
-        <p14:creationId xmlns:p14="http://schemas.microsoft.com/office/powerpoint/2010/main" val="2026591930"/>
+        <p14:creationId xmlns:p14="http://schemas.microsoft.com/office/powerpoint/2010/main" val="1835208491"/>
       </p:ext>
     </p:extLst>
   </p:cSld>
@@ -7196,7 +7196,7 @@
           <p:cNvPr id="17" name="">
             <a:extLst xmlns:a="http://schemas.openxmlformats.org/drawingml/2006/main">
               <a:ext uri="{FF2B5EF4-FFF2-40B4-BE49-F238E27FC236}">
-                <a16:creationId xmlns:a16="http://schemas.microsoft.com/office/drawing/2014/main" id="{2E9C8950-9865-42A3-96F1-5F848F855909}"/>
+                <a16:creationId xmlns:a16="http://schemas.microsoft.com/office/drawing/2014/main" id="{13F76A70-9E12-4CD1-85D3-D5B6CDE40616}"/>
               </a:ext>
             </a:extLst>
           </p:cNvPr>
@@ -7254,7 +7254,7 @@
           <p:cNvPr id="2" name="">
             <a:extLst xmlns:a="http://schemas.openxmlformats.org/drawingml/2006/main">
               <a:ext uri="{FF2B5EF4-FFF2-40B4-BE49-F238E27FC236}">
-                <a16:creationId xmlns:a16="http://schemas.microsoft.com/office/drawing/2014/main" id="{59CD1398-25E5-47D6-BA6B-C45DF13866F0}"/>
+                <a16:creationId xmlns:a16="http://schemas.microsoft.com/office/drawing/2014/main" id="{AFED4C1C-55AF-48BA-867A-65A2E16C612A}"/>
               </a:ext>
             </a:extLst>
           </p:cNvPr>
@@ -7312,7 +7312,7 @@
           <p:cNvPr id="3" name="">
             <a:extLst xmlns:a="http://schemas.openxmlformats.org/drawingml/2006/main">
               <a:ext uri="{FF2B5EF4-FFF2-40B4-BE49-F238E27FC236}">
-                <a16:creationId xmlns:a16="http://schemas.microsoft.com/office/drawing/2014/main" id="{819D4FAB-6480-4678-B7C6-8FF54D56C2F5}"/>
+                <a16:creationId xmlns:a16="http://schemas.microsoft.com/office/drawing/2014/main" id="{A3AB8350-7329-4246-98C6-BBB52B9E20C1}"/>
               </a:ext>
             </a:extLst>
           </p:cNvPr>
@@ -7370,7 +7370,7 @@
           <p:cNvPr id="4" name="">
             <a:extLst xmlns:a="http://schemas.openxmlformats.org/drawingml/2006/main">
               <a:ext uri="{FF2B5EF4-FFF2-40B4-BE49-F238E27FC236}">
-                <a16:creationId xmlns:a16="http://schemas.microsoft.com/office/drawing/2014/main" id="{6FCD1BEC-5A63-498D-8179-FE69F46DFA29}"/>
+                <a16:creationId xmlns:a16="http://schemas.microsoft.com/office/drawing/2014/main" id="{FE28304C-D0C5-4EE1-AA98-082D86F2359C}"/>
               </a:ext>
             </a:extLst>
           </p:cNvPr>
@@ -7403,7 +7403,7 @@
           <p:cNvPr id="5" name="">
             <a:extLst xmlns:a="http://schemas.openxmlformats.org/drawingml/2006/main">
               <a:ext uri="{FF2B5EF4-FFF2-40B4-BE49-F238E27FC236}">
-                <a16:creationId xmlns:a16="http://schemas.microsoft.com/office/drawing/2014/main" id="{BAA2FB7E-A34E-4C22-A9CC-74AEFD119DFF}"/>
+                <a16:creationId xmlns:a16="http://schemas.microsoft.com/office/drawing/2014/main" id="{8B790196-516E-423A-BA51-85E9E00353B0}"/>
               </a:ext>
             </a:extLst>
           </p:cNvPr>
@@ -7438,7 +7438,7 @@
           <p:cNvPr id="6" name="">
             <a:extLst xmlns:a="http://schemas.openxmlformats.org/drawingml/2006/main">
               <a:ext uri="{FF2B5EF4-FFF2-40B4-BE49-F238E27FC236}">
-                <a16:creationId xmlns:a16="http://schemas.microsoft.com/office/drawing/2014/main" id="{07197101-95F6-4D6E-BA7D-AFE51AE027AE}"/>
+                <a16:creationId xmlns:a16="http://schemas.microsoft.com/office/drawing/2014/main" id="{E340163A-C5BF-4073-8DE3-206FF2EE15CB}"/>
               </a:ext>
             </a:extLst>
           </p:cNvPr>
@@ -7496,7 +7496,7 @@
           <p:cNvPr id="7" name="">
             <a:extLst xmlns:a="http://schemas.openxmlformats.org/drawingml/2006/main">
               <a:ext uri="{FF2B5EF4-FFF2-40B4-BE49-F238E27FC236}">
-                <a16:creationId xmlns:a16="http://schemas.microsoft.com/office/drawing/2014/main" id="{5315EEDC-A43E-414D-A7DF-21F16E1D931E}"/>
+                <a16:creationId xmlns:a16="http://schemas.microsoft.com/office/drawing/2014/main" id="{2CE900DC-BEC5-45BC-9E80-FEE74D7BAE70}"/>
               </a:ext>
             </a:extLst>
           </p:cNvPr>
@@ -7554,7 +7554,7 @@
           <p:cNvPr id="8" name="">
             <a:extLst xmlns:a="http://schemas.openxmlformats.org/drawingml/2006/main">
               <a:ext uri="{FF2B5EF4-FFF2-40B4-BE49-F238E27FC236}">
-                <a16:creationId xmlns:a16="http://schemas.microsoft.com/office/drawing/2014/main" id="{55B2B777-80D4-41F1-93EB-31669CEA1E7E}"/>
+                <a16:creationId xmlns:a16="http://schemas.microsoft.com/office/drawing/2014/main" id="{93AFDA85-1180-4297-AA99-6E9826076AA1}"/>
               </a:ext>
             </a:extLst>
           </p:cNvPr>
@@ -7612,7 +7612,7 @@
           <p:cNvPr id="9" name="">
             <a:extLst xmlns:a="http://schemas.openxmlformats.org/drawingml/2006/main">
               <a:ext uri="{FF2B5EF4-FFF2-40B4-BE49-F238E27FC236}">
-                <a16:creationId xmlns:a16="http://schemas.microsoft.com/office/drawing/2014/main" id="{EF06EF6E-9652-488E-A181-31D9D43F1A09}"/>
+                <a16:creationId xmlns:a16="http://schemas.microsoft.com/office/drawing/2014/main" id="{66C2D2F7-4924-4D18-8FE5-238887F28352}"/>
               </a:ext>
             </a:extLst>
           </p:cNvPr>
@@ -7693,7 +7693,7 @@
           <p:cNvPr id="10" name="">
             <a:extLst xmlns:a="http://schemas.openxmlformats.org/drawingml/2006/main">
               <a:ext uri="{FF2B5EF4-FFF2-40B4-BE49-F238E27FC236}">
-                <a16:creationId xmlns:a16="http://schemas.microsoft.com/office/drawing/2014/main" id="{603EBC39-EC57-4BA6-924B-63EB46ED2342}"/>
+                <a16:creationId xmlns:a16="http://schemas.microsoft.com/office/drawing/2014/main" id="{0D7BF52D-B542-490C-A5BE-1F0DC1823220}"/>
               </a:ext>
             </a:extLst>
           </p:cNvPr>
@@ -7728,7 +7728,7 @@
           <p:cNvPr id="11" name="">
             <a:extLst xmlns:a="http://schemas.openxmlformats.org/drawingml/2006/main">
               <a:ext uri="{FF2B5EF4-FFF2-40B4-BE49-F238E27FC236}">
-                <a16:creationId xmlns:a16="http://schemas.microsoft.com/office/drawing/2014/main" id="{DB051100-A267-4EFC-AA17-311F679A2F28}"/>
+                <a16:creationId xmlns:a16="http://schemas.microsoft.com/office/drawing/2014/main" id="{152799C3-A769-4E66-B512-40E04C2C3BC3}"/>
               </a:ext>
             </a:extLst>
           </p:cNvPr>
@@ -7786,7 +7786,7 @@
           <p:cNvPr id="12" name="">
             <a:extLst xmlns:a="http://schemas.openxmlformats.org/drawingml/2006/main">
               <a:ext uri="{FF2B5EF4-FFF2-40B4-BE49-F238E27FC236}">
-                <a16:creationId xmlns:a16="http://schemas.microsoft.com/office/drawing/2014/main" id="{4F81332D-CFA3-44BE-AAAE-03EDDD9B2293}"/>
+                <a16:creationId xmlns:a16="http://schemas.microsoft.com/office/drawing/2014/main" id="{9B281AEB-2CB9-45E4-A866-82AEEAC2C34B}"/>
               </a:ext>
             </a:extLst>
           </p:cNvPr>
@@ -7844,7 +7844,7 @@
           <p:cNvPr id="13" name="">
             <a:extLst xmlns:a="http://schemas.openxmlformats.org/drawingml/2006/main">
               <a:ext uri="{FF2B5EF4-FFF2-40B4-BE49-F238E27FC236}">
-                <a16:creationId xmlns:a16="http://schemas.microsoft.com/office/drawing/2014/main" id="{A31C9F33-8C36-4446-BCA6-CE16F80EC9F7}"/>
+                <a16:creationId xmlns:a16="http://schemas.microsoft.com/office/drawing/2014/main" id="{1F3435AF-D0B9-42C3-AE69-02DDF592070C}"/>
               </a:ext>
             </a:extLst>
           </p:cNvPr>
@@ -7902,7 +7902,7 @@
           <p:cNvPr id="14" name="">
             <a:extLst xmlns:a="http://schemas.openxmlformats.org/drawingml/2006/main">
               <a:ext uri="{FF2B5EF4-FFF2-40B4-BE49-F238E27FC236}">
-                <a16:creationId xmlns:a16="http://schemas.microsoft.com/office/drawing/2014/main" id="{47707275-1297-4657-A620-F30BCD678BF5}"/>
+                <a16:creationId xmlns:a16="http://schemas.microsoft.com/office/drawing/2014/main" id="{9F4D3C59-A541-4FEA-BC6C-6978F38E40D4}"/>
               </a:ext>
             </a:extLst>
           </p:cNvPr>
@@ -8006,7 +8006,7 @@
           <p:cNvPr id="15" name="">
             <a:extLst xmlns:a="http://schemas.openxmlformats.org/drawingml/2006/main">
               <a:ext uri="{FF2B5EF4-FFF2-40B4-BE49-F238E27FC236}">
-                <a16:creationId xmlns:a16="http://schemas.microsoft.com/office/drawing/2014/main" id="{087D4055-AE73-406B-B2E8-F7E10BF040CF}"/>
+                <a16:creationId xmlns:a16="http://schemas.microsoft.com/office/drawing/2014/main" id="{188A7A28-8D89-492B-9E59-28D038EE06D5}"/>
               </a:ext>
             </a:extLst>
           </p:cNvPr>
@@ -8054,7 +8054,7 @@
                 <a:ea typeface="Aptos"/>
                 <a:cs typeface="Aptos"/>
               </a:rPr>
-              <a:t>WATERS NEXT GEN COMPETITIVE INTELLIGENCE · 17 AUG 2026 · waters-ci-20260817124300</a:t>
+              <a:t>WATERS NEXT GEN COMPETITIVE INTELLIGENCE · 23 AUG 2026 · waters-ci-20260820104036</a:t>
             </a:r>
           </a:p>
         </p:txBody>
@@ -8064,7 +8064,7 @@
           <p:cNvPr id="16" name="">
             <a:extLst xmlns:a="http://schemas.openxmlformats.org/drawingml/2006/main">
               <a:ext uri="{FF2B5EF4-FFF2-40B4-BE49-F238E27FC236}">
-                <a16:creationId xmlns:a16="http://schemas.microsoft.com/office/drawing/2014/main" id="{6D46575A-8AD3-4279-8EEB-A95E64FFA550}"/>
+                <a16:creationId xmlns:a16="http://schemas.microsoft.com/office/drawing/2014/main" id="{56B1F886-CF5A-4B67-9E1F-A31D1AE824C7}"/>
               </a:ext>
             </a:extLst>
           </p:cNvPr>
@@ -8120,7 +8120,7 @@
     </p:spTree>
     <p:extLst>
       <p:ext uri="{BB962C8B-B14F-4D97-AF65-F5344CB8AC3E}">
-        <p14:creationId xmlns:p14="http://schemas.microsoft.com/office/powerpoint/2010/main" val="570183646"/>
+        <p14:creationId xmlns:p14="http://schemas.microsoft.com/office/powerpoint/2010/main" val="1763329019"/>
       </p:ext>
     </p:extLst>
   </p:cSld>
@@ -8151,7 +8151,7 @@
           <p:cNvPr id="37" name="">
             <a:extLst xmlns:a="http://schemas.openxmlformats.org/drawingml/2006/main">
               <a:ext uri="{FF2B5EF4-FFF2-40B4-BE49-F238E27FC236}">
-                <a16:creationId xmlns:a16="http://schemas.microsoft.com/office/drawing/2014/main" id="{CA905E1F-3F0D-4B1F-9E7A-F69479FC7FF9}"/>
+                <a16:creationId xmlns:a16="http://schemas.microsoft.com/office/drawing/2014/main" id="{F03C5B79-2721-4831-B2FF-53F3F370C3C4}"/>
               </a:ext>
             </a:extLst>
           </p:cNvPr>
@@ -8209,7 +8209,7 @@
           <p:cNvPr id="2" name="">
             <a:extLst xmlns:a="http://schemas.openxmlformats.org/drawingml/2006/main">
               <a:ext uri="{FF2B5EF4-FFF2-40B4-BE49-F238E27FC236}">
-                <a16:creationId xmlns:a16="http://schemas.microsoft.com/office/drawing/2014/main" id="{91D1DDE9-7867-4E6A-9443-0BA13BF03D05}"/>
+                <a16:creationId xmlns:a16="http://schemas.microsoft.com/office/drawing/2014/main" id="{C2DA951B-9D25-47B4-9C20-FEB6999EE5D3}"/>
               </a:ext>
             </a:extLst>
           </p:cNvPr>
@@ -8267,7 +8267,7 @@
           <p:cNvPr id="3" name="">
             <a:extLst xmlns:a="http://schemas.openxmlformats.org/drawingml/2006/main">
               <a:ext uri="{FF2B5EF4-FFF2-40B4-BE49-F238E27FC236}">
-                <a16:creationId xmlns:a16="http://schemas.microsoft.com/office/drawing/2014/main" id="{D068F465-44C4-4E15-86FC-4355986140CB}"/>
+                <a16:creationId xmlns:a16="http://schemas.microsoft.com/office/drawing/2014/main" id="{B34D7B53-E11D-458C-8269-F97BD8FDB890}"/>
               </a:ext>
             </a:extLst>
           </p:cNvPr>
@@ -8325,7 +8325,7 @@
           <p:cNvPr id="4" name="">
             <a:extLst xmlns:a="http://schemas.openxmlformats.org/drawingml/2006/main">
               <a:ext uri="{FF2B5EF4-FFF2-40B4-BE49-F238E27FC236}">
-                <a16:creationId xmlns:a16="http://schemas.microsoft.com/office/drawing/2014/main" id="{43DED25A-DC59-4AE9-B610-035B750D148F}"/>
+                <a16:creationId xmlns:a16="http://schemas.microsoft.com/office/drawing/2014/main" id="{2976DFA8-85F7-4524-9D7C-CDE9971C8A80}"/>
               </a:ext>
             </a:extLst>
           </p:cNvPr>
@@ -8358,7 +8358,7 @@
           <p:cNvPr id="5" name="">
             <a:extLst xmlns:a="http://schemas.openxmlformats.org/drawingml/2006/main">
               <a:ext uri="{FF2B5EF4-FFF2-40B4-BE49-F238E27FC236}">
-                <a16:creationId xmlns:a16="http://schemas.microsoft.com/office/drawing/2014/main" id="{AF92DC1C-A849-4879-9850-AB2E8B886D4C}"/>
+                <a16:creationId xmlns:a16="http://schemas.microsoft.com/office/drawing/2014/main" id="{7D03E38B-BB3B-492B-B5E1-757553FA0DE8}"/>
               </a:ext>
             </a:extLst>
           </p:cNvPr>
@@ -8393,7 +8393,7 @@
           <p:cNvPr id="6" name="">
             <a:extLst xmlns:a="http://schemas.openxmlformats.org/drawingml/2006/main">
               <a:ext uri="{FF2B5EF4-FFF2-40B4-BE49-F238E27FC236}">
-                <a16:creationId xmlns:a16="http://schemas.microsoft.com/office/drawing/2014/main" id="{3E708680-86CB-4B76-B71A-6497DF3EE25E}"/>
+                <a16:creationId xmlns:a16="http://schemas.microsoft.com/office/drawing/2014/main" id="{1A18C4A0-8AE5-4EA4-AED0-19DC2FF02EC7}"/>
               </a:ext>
             </a:extLst>
           </p:cNvPr>
@@ -8426,7 +8426,7 @@
           <p:cNvPr id="7" name="">
             <a:extLst xmlns:a="http://schemas.openxmlformats.org/drawingml/2006/main">
               <a:ext uri="{FF2B5EF4-FFF2-40B4-BE49-F238E27FC236}">
-                <a16:creationId xmlns:a16="http://schemas.microsoft.com/office/drawing/2014/main" id="{CABB2633-6171-429A-B671-94A379B53A2B}"/>
+                <a16:creationId xmlns:a16="http://schemas.microsoft.com/office/drawing/2014/main" id="{44C3AAF6-9C51-4ADF-A420-581D7B8D3AC0}"/>
               </a:ext>
             </a:extLst>
           </p:cNvPr>
@@ -8484,7 +8484,7 @@
           <p:cNvPr id="8" name="">
             <a:extLst xmlns:a="http://schemas.openxmlformats.org/drawingml/2006/main">
               <a:ext uri="{FF2B5EF4-FFF2-40B4-BE49-F238E27FC236}">
-                <a16:creationId xmlns:a16="http://schemas.microsoft.com/office/drawing/2014/main" id="{9A912350-AE98-4360-A45E-07C26D03BA92}"/>
+                <a16:creationId xmlns:a16="http://schemas.microsoft.com/office/drawing/2014/main" id="{FB4A736D-A992-48B1-9960-F07A6D52AE3E}"/>
               </a:ext>
             </a:extLst>
           </p:cNvPr>
@@ -8542,7 +8542,7 @@
           <p:cNvPr id="9" name="">
             <a:extLst xmlns:a="http://schemas.openxmlformats.org/drawingml/2006/main">
               <a:ext uri="{FF2B5EF4-FFF2-40B4-BE49-F238E27FC236}">
-                <a16:creationId xmlns:a16="http://schemas.microsoft.com/office/drawing/2014/main" id="{E5E43E8C-8685-4C61-9F3E-DEEA7C7C98E0}"/>
+                <a16:creationId xmlns:a16="http://schemas.microsoft.com/office/drawing/2014/main" id="{8A1FF304-1899-46C2-ADFD-8EDE500C36FE}"/>
               </a:ext>
             </a:extLst>
           </p:cNvPr>
@@ -8600,7 +8600,7 @@
           <p:cNvPr id="10" name="">
             <a:extLst xmlns:a="http://schemas.openxmlformats.org/drawingml/2006/main">
               <a:ext uri="{FF2B5EF4-FFF2-40B4-BE49-F238E27FC236}">
-                <a16:creationId xmlns:a16="http://schemas.microsoft.com/office/drawing/2014/main" id="{6016E242-CBA9-4ADA-82F6-4A60D55F8ADA}"/>
+                <a16:creationId xmlns:a16="http://schemas.microsoft.com/office/drawing/2014/main" id="{E0B0B09F-8108-4236-8914-542ECDE7DF2C}"/>
               </a:ext>
             </a:extLst>
           </p:cNvPr>
@@ -8658,7 +8658,7 @@
           <p:cNvPr id="11" name="">
             <a:extLst xmlns:a="http://schemas.openxmlformats.org/drawingml/2006/main">
               <a:ext uri="{FF2B5EF4-FFF2-40B4-BE49-F238E27FC236}">
-                <a16:creationId xmlns:a16="http://schemas.microsoft.com/office/drawing/2014/main" id="{318A5148-010A-42CE-B073-E854CA2BA262}"/>
+                <a16:creationId xmlns:a16="http://schemas.microsoft.com/office/drawing/2014/main" id="{3D801700-A21C-48BC-8A4B-CAFAC3EA05C8}"/>
               </a:ext>
             </a:extLst>
           </p:cNvPr>
@@ -8691,7 +8691,7 @@
           <p:cNvPr id="12" name="">
             <a:extLst xmlns:a="http://schemas.openxmlformats.org/drawingml/2006/main">
               <a:ext uri="{FF2B5EF4-FFF2-40B4-BE49-F238E27FC236}">
-                <a16:creationId xmlns:a16="http://schemas.microsoft.com/office/drawing/2014/main" id="{5DC5C520-B1FA-4FDB-BB39-CAF82FE6CDA0}"/>
+                <a16:creationId xmlns:a16="http://schemas.microsoft.com/office/drawing/2014/main" id="{95C91568-F045-43E4-9240-763C28CDE27D}"/>
               </a:ext>
             </a:extLst>
           </p:cNvPr>
@@ -8749,7 +8749,7 @@
           <p:cNvPr id="13" name="">
             <a:extLst xmlns:a="http://schemas.openxmlformats.org/drawingml/2006/main">
               <a:ext uri="{FF2B5EF4-FFF2-40B4-BE49-F238E27FC236}">
-                <a16:creationId xmlns:a16="http://schemas.microsoft.com/office/drawing/2014/main" id="{6A9918DF-385F-4631-A6EC-F96997DCBC50}"/>
+                <a16:creationId xmlns:a16="http://schemas.microsoft.com/office/drawing/2014/main" id="{6297C0C5-BC54-4CBA-BEF1-4BB380DCBAE4}"/>
               </a:ext>
             </a:extLst>
           </p:cNvPr>
@@ -8807,7 +8807,7 @@
           <p:cNvPr id="14" name="">
             <a:extLst xmlns:a="http://schemas.openxmlformats.org/drawingml/2006/main">
               <a:ext uri="{FF2B5EF4-FFF2-40B4-BE49-F238E27FC236}">
-                <a16:creationId xmlns:a16="http://schemas.microsoft.com/office/drawing/2014/main" id="{F1D3F4F7-C97A-43DA-B357-09C707466CDF}"/>
+                <a16:creationId xmlns:a16="http://schemas.microsoft.com/office/drawing/2014/main" id="{DA901248-ECE7-4560-B6B9-A8C10798C1F3}"/>
               </a:ext>
             </a:extLst>
           </p:cNvPr>
@@ -8865,7 +8865,7 @@
           <p:cNvPr id="15" name="">
             <a:extLst xmlns:a="http://schemas.openxmlformats.org/drawingml/2006/main">
               <a:ext uri="{FF2B5EF4-FFF2-40B4-BE49-F238E27FC236}">
-                <a16:creationId xmlns:a16="http://schemas.microsoft.com/office/drawing/2014/main" id="{DB055579-DCB3-4925-9073-6BA76C9390FD}"/>
+                <a16:creationId xmlns:a16="http://schemas.microsoft.com/office/drawing/2014/main" id="{9DD6F60D-21BF-400E-934E-25EA39F34F5D}"/>
               </a:ext>
             </a:extLst>
           </p:cNvPr>
@@ -8900,7 +8900,7 @@
           <p:cNvPr id="16" name="">
             <a:extLst xmlns:a="http://schemas.openxmlformats.org/drawingml/2006/main">
               <a:ext uri="{FF2B5EF4-FFF2-40B4-BE49-F238E27FC236}">
-                <a16:creationId xmlns:a16="http://schemas.microsoft.com/office/drawing/2014/main" id="{04DE3699-F50A-4BBE-8507-38F9241F620A}"/>
+                <a16:creationId xmlns:a16="http://schemas.microsoft.com/office/drawing/2014/main" id="{61C4A74B-CD41-46B2-833E-9CB717958DDB}"/>
               </a:ext>
             </a:extLst>
           </p:cNvPr>
@@ -8933,7 +8933,7 @@
           <p:cNvPr id="17" name="">
             <a:extLst xmlns:a="http://schemas.openxmlformats.org/drawingml/2006/main">
               <a:ext uri="{FF2B5EF4-FFF2-40B4-BE49-F238E27FC236}">
-                <a16:creationId xmlns:a16="http://schemas.microsoft.com/office/drawing/2014/main" id="{1FE1A941-A345-4FCB-9450-90370D34E6A7}"/>
+                <a16:creationId xmlns:a16="http://schemas.microsoft.com/office/drawing/2014/main" id="{7F027D94-96C6-4051-8106-E6DD48886FB4}"/>
               </a:ext>
             </a:extLst>
           </p:cNvPr>
@@ -8991,7 +8991,7 @@
           <p:cNvPr id="18" name="">
             <a:extLst xmlns:a="http://schemas.openxmlformats.org/drawingml/2006/main">
               <a:ext uri="{FF2B5EF4-FFF2-40B4-BE49-F238E27FC236}">
-                <a16:creationId xmlns:a16="http://schemas.microsoft.com/office/drawing/2014/main" id="{9128AEDB-5D65-48AC-895F-090507907F50}"/>
+                <a16:creationId xmlns:a16="http://schemas.microsoft.com/office/drawing/2014/main" id="{0DA9AFFE-059F-4E59-BF05-1930DCD79A26}"/>
               </a:ext>
             </a:extLst>
           </p:cNvPr>
@@ -9049,7 +9049,7 @@
           <p:cNvPr id="19" name="">
             <a:extLst xmlns:a="http://schemas.openxmlformats.org/drawingml/2006/main">
               <a:ext uri="{FF2B5EF4-FFF2-40B4-BE49-F238E27FC236}">
-                <a16:creationId xmlns:a16="http://schemas.microsoft.com/office/drawing/2014/main" id="{85FBFA17-036F-4C0C-868F-53C970F2DD83}"/>
+                <a16:creationId xmlns:a16="http://schemas.microsoft.com/office/drawing/2014/main" id="{20BD726C-9A43-4E1D-A349-C26D21BA7895}"/>
               </a:ext>
             </a:extLst>
           </p:cNvPr>
@@ -9107,7 +9107,7 @@
           <p:cNvPr id="20" name="">
             <a:extLst xmlns:a="http://schemas.openxmlformats.org/drawingml/2006/main">
               <a:ext uri="{FF2B5EF4-FFF2-40B4-BE49-F238E27FC236}">
-                <a16:creationId xmlns:a16="http://schemas.microsoft.com/office/drawing/2014/main" id="{D976FB24-76AC-488E-820A-5443825E084C}"/>
+                <a16:creationId xmlns:a16="http://schemas.microsoft.com/office/drawing/2014/main" id="{9B3DBB0E-FA4E-49CB-89E3-8205A2FCE9D7}"/>
               </a:ext>
             </a:extLst>
           </p:cNvPr>
@@ -9165,7 +9165,7 @@
           <p:cNvPr id="21" name="">
             <a:extLst xmlns:a="http://schemas.openxmlformats.org/drawingml/2006/main">
               <a:ext uri="{FF2B5EF4-FFF2-40B4-BE49-F238E27FC236}">
-                <a16:creationId xmlns:a16="http://schemas.microsoft.com/office/drawing/2014/main" id="{CE007361-CD55-42F1-8947-151C8A1FC48A}"/>
+                <a16:creationId xmlns:a16="http://schemas.microsoft.com/office/drawing/2014/main" id="{0FEE1F48-EEA6-442F-AD9D-99EEB9FBA47C}"/>
               </a:ext>
             </a:extLst>
           </p:cNvPr>
@@ -9198,7 +9198,7 @@
           <p:cNvPr id="22" name="">
             <a:extLst xmlns:a="http://schemas.openxmlformats.org/drawingml/2006/main">
               <a:ext uri="{FF2B5EF4-FFF2-40B4-BE49-F238E27FC236}">
-                <a16:creationId xmlns:a16="http://schemas.microsoft.com/office/drawing/2014/main" id="{C6EA0409-2A30-46F8-9DEA-714284DE12C1}"/>
+                <a16:creationId xmlns:a16="http://schemas.microsoft.com/office/drawing/2014/main" id="{B9F923EF-7CB7-4F7B-86D6-C464F19780FA}"/>
               </a:ext>
             </a:extLst>
           </p:cNvPr>
@@ -9256,7 +9256,7 @@
           <p:cNvPr id="23" name="">
             <a:extLst xmlns:a="http://schemas.openxmlformats.org/drawingml/2006/main">
               <a:ext uri="{FF2B5EF4-FFF2-40B4-BE49-F238E27FC236}">
-                <a16:creationId xmlns:a16="http://schemas.microsoft.com/office/drawing/2014/main" id="{351B0F15-440B-405B-854F-8A4076F7CEFA}"/>
+                <a16:creationId xmlns:a16="http://schemas.microsoft.com/office/drawing/2014/main" id="{EBFEE523-329E-4446-8753-30663FB3EE3B}"/>
               </a:ext>
             </a:extLst>
           </p:cNvPr>
@@ -9314,7 +9314,7 @@
           <p:cNvPr id="24" name="">
             <a:extLst xmlns:a="http://schemas.openxmlformats.org/drawingml/2006/main">
               <a:ext uri="{FF2B5EF4-FFF2-40B4-BE49-F238E27FC236}">
-                <a16:creationId xmlns:a16="http://schemas.microsoft.com/office/drawing/2014/main" id="{A848220B-D21A-4F1C-AFE3-D18183FA7BFA}"/>
+                <a16:creationId xmlns:a16="http://schemas.microsoft.com/office/drawing/2014/main" id="{6E0AB0B1-514B-4159-B12F-C966C581D10F}"/>
               </a:ext>
             </a:extLst>
           </p:cNvPr>
@@ -9372,7 +9372,7 @@
           <p:cNvPr id="25" name="">
             <a:extLst xmlns:a="http://schemas.openxmlformats.org/drawingml/2006/main">
               <a:ext uri="{FF2B5EF4-FFF2-40B4-BE49-F238E27FC236}">
-                <a16:creationId xmlns:a16="http://schemas.microsoft.com/office/drawing/2014/main" id="{69871C23-9CF4-4E55-A595-2B035A2CD6EB}"/>
+                <a16:creationId xmlns:a16="http://schemas.microsoft.com/office/drawing/2014/main" id="{8985191D-EE81-4341-8A30-06166C8F89F9}"/>
               </a:ext>
             </a:extLst>
           </p:cNvPr>
@@ -9407,7 +9407,7 @@
           <p:cNvPr id="26" name="">
             <a:extLst xmlns:a="http://schemas.openxmlformats.org/drawingml/2006/main">
               <a:ext uri="{FF2B5EF4-FFF2-40B4-BE49-F238E27FC236}">
-                <a16:creationId xmlns:a16="http://schemas.microsoft.com/office/drawing/2014/main" id="{6C7DA4B2-BBFD-49FC-94FE-E9E314C6A875}"/>
+                <a16:creationId xmlns:a16="http://schemas.microsoft.com/office/drawing/2014/main" id="{F8E048B0-8639-46AF-875A-1BA1EA77050A}"/>
               </a:ext>
             </a:extLst>
           </p:cNvPr>
@@ -9440,7 +9440,7 @@
           <p:cNvPr id="27" name="">
             <a:extLst xmlns:a="http://schemas.openxmlformats.org/drawingml/2006/main">
               <a:ext uri="{FF2B5EF4-FFF2-40B4-BE49-F238E27FC236}">
-                <a16:creationId xmlns:a16="http://schemas.microsoft.com/office/drawing/2014/main" id="{33D6D66A-72AC-4290-9F29-9AA00C36E2D1}"/>
+                <a16:creationId xmlns:a16="http://schemas.microsoft.com/office/drawing/2014/main" id="{C8CDA726-9E12-41F0-96A8-22C4FA9096A5}"/>
               </a:ext>
             </a:extLst>
           </p:cNvPr>
@@ -9498,7 +9498,7 @@
           <p:cNvPr id="28" name="">
             <a:extLst xmlns:a="http://schemas.openxmlformats.org/drawingml/2006/main">
               <a:ext uri="{FF2B5EF4-FFF2-40B4-BE49-F238E27FC236}">
-                <a16:creationId xmlns:a16="http://schemas.microsoft.com/office/drawing/2014/main" id="{85A1D521-038F-439F-8B17-41F48638242F}"/>
+                <a16:creationId xmlns:a16="http://schemas.microsoft.com/office/drawing/2014/main" id="{392D58CC-8B35-408C-ADBE-FA823A7DCEE0}"/>
               </a:ext>
             </a:extLst>
           </p:cNvPr>
@@ -9556,7 +9556,7 @@
           <p:cNvPr id="29" name="">
             <a:extLst xmlns:a="http://schemas.openxmlformats.org/drawingml/2006/main">
               <a:ext uri="{FF2B5EF4-FFF2-40B4-BE49-F238E27FC236}">
-                <a16:creationId xmlns:a16="http://schemas.microsoft.com/office/drawing/2014/main" id="{006C7554-7F58-4BD5-A851-1A2F28EF0BBB}"/>
+                <a16:creationId xmlns:a16="http://schemas.microsoft.com/office/drawing/2014/main" id="{2240FD40-EDA0-4D30-A2A5-E581338575C0}"/>
               </a:ext>
             </a:extLst>
           </p:cNvPr>
@@ -9604,7 +9604,7 @@
                 <a:ea typeface="Aptos"/>
                 <a:cs typeface="Aptos"/>
               </a:rPr>
-              <a:t>58/100</a:t>
+              <a:t>54/100</a:t>
             </a:r>
           </a:p>
         </p:txBody>
@@ -9614,7 +9614,7 @@
           <p:cNvPr id="30" name="">
             <a:extLst xmlns:a="http://schemas.openxmlformats.org/drawingml/2006/main">
               <a:ext uri="{FF2B5EF4-FFF2-40B4-BE49-F238E27FC236}">
-                <a16:creationId xmlns:a16="http://schemas.microsoft.com/office/drawing/2014/main" id="{CE3C456A-91D8-48AE-A1B5-0D5248B525A7}"/>
+                <a16:creationId xmlns:a16="http://schemas.microsoft.com/office/drawing/2014/main" id="{4A0271AA-2915-40D4-9888-284453AA324A}"/>
               </a:ext>
             </a:extLst>
           </p:cNvPr>
@@ -9672,7 +9672,7 @@
           <p:cNvPr id="31" name="">
             <a:extLst xmlns:a="http://schemas.openxmlformats.org/drawingml/2006/main">
               <a:ext uri="{FF2B5EF4-FFF2-40B4-BE49-F238E27FC236}">
-                <a16:creationId xmlns:a16="http://schemas.microsoft.com/office/drawing/2014/main" id="{A309FC5F-B64B-4092-9FC2-DEA474B7C15B}"/>
+                <a16:creationId xmlns:a16="http://schemas.microsoft.com/office/drawing/2014/main" id="{89931BA9-B054-4155-A347-6607FB415BFC}"/>
               </a:ext>
             </a:extLst>
           </p:cNvPr>
@@ -9705,7 +9705,7 @@
           <p:cNvPr id="32" name="">
             <a:extLst xmlns:a="http://schemas.openxmlformats.org/drawingml/2006/main">
               <a:ext uri="{FF2B5EF4-FFF2-40B4-BE49-F238E27FC236}">
-                <a16:creationId xmlns:a16="http://schemas.microsoft.com/office/drawing/2014/main" id="{9D835A3D-2FAB-4BED-AD2B-9F93861B1BD0}"/>
+                <a16:creationId xmlns:a16="http://schemas.microsoft.com/office/drawing/2014/main" id="{1434706D-FF73-41F3-97F0-88D41A96AAF7}"/>
               </a:ext>
             </a:extLst>
           </p:cNvPr>
@@ -9763,7 +9763,7 @@
           <p:cNvPr id="33" name="">
             <a:extLst xmlns:a="http://schemas.openxmlformats.org/drawingml/2006/main">
               <a:ext uri="{FF2B5EF4-FFF2-40B4-BE49-F238E27FC236}">
-                <a16:creationId xmlns:a16="http://schemas.microsoft.com/office/drawing/2014/main" id="{374B9436-1CD5-48BE-B656-9832E71001F1}"/>
+                <a16:creationId xmlns:a16="http://schemas.microsoft.com/office/drawing/2014/main" id="{F9AE5847-484D-4466-ADA3-8E2D35FBC6F3}"/>
               </a:ext>
             </a:extLst>
           </p:cNvPr>
@@ -9821,7 +9821,7 @@
           <p:cNvPr id="34" name="">
             <a:extLst xmlns:a="http://schemas.openxmlformats.org/drawingml/2006/main">
               <a:ext uri="{FF2B5EF4-FFF2-40B4-BE49-F238E27FC236}">
-                <a16:creationId xmlns:a16="http://schemas.microsoft.com/office/drawing/2014/main" id="{E175FAA4-0945-45B0-AA0A-36FD58A119FE}"/>
+                <a16:creationId xmlns:a16="http://schemas.microsoft.com/office/drawing/2014/main" id="{2577ACB3-CE68-48E6-8CA3-8E89C6A729D2}"/>
               </a:ext>
             </a:extLst>
           </p:cNvPr>
@@ -9879,7 +9879,7 @@
           <p:cNvPr id="35" name="">
             <a:extLst xmlns:a="http://schemas.openxmlformats.org/drawingml/2006/main">
               <a:ext uri="{FF2B5EF4-FFF2-40B4-BE49-F238E27FC236}">
-                <a16:creationId xmlns:a16="http://schemas.microsoft.com/office/drawing/2014/main" id="{F224EB8A-5291-4D3C-84E3-DAF06505BC26}"/>
+                <a16:creationId xmlns:a16="http://schemas.microsoft.com/office/drawing/2014/main" id="{B77D1AF7-9D10-4BA8-9561-2E7261D733E5}"/>
               </a:ext>
             </a:extLst>
           </p:cNvPr>
@@ -9927,7 +9927,7 @@
                 <a:ea typeface="Aptos"/>
                 <a:cs typeface="Aptos"/>
               </a:rPr>
-              <a:t>WATERS NEXT GEN COMPETITIVE INTELLIGENCE · 17 AUG 2026 · waters-ci-20260817124300</a:t>
+              <a:t>WATERS NEXT GEN COMPETITIVE INTELLIGENCE · 23 AUG 2026 · waters-ci-20260820104036</a:t>
             </a:r>
           </a:p>
         </p:txBody>
@@ -9937,7 +9937,7 @@
           <p:cNvPr id="36" name="">
             <a:extLst xmlns:a="http://schemas.openxmlformats.org/drawingml/2006/main">
               <a:ext uri="{FF2B5EF4-FFF2-40B4-BE49-F238E27FC236}">
-                <a16:creationId xmlns:a16="http://schemas.microsoft.com/office/drawing/2014/main" id="{9789469E-7B67-45D3-BF21-E6FB08C6F494}"/>
+                <a16:creationId xmlns:a16="http://schemas.microsoft.com/office/drawing/2014/main" id="{600EC9C0-6759-4C3E-B7A9-CF378CD91F1E}"/>
               </a:ext>
             </a:extLst>
           </p:cNvPr>
@@ -9993,7 +9993,7 @@
     </p:spTree>
     <p:extLst>
       <p:ext uri="{BB962C8B-B14F-4D97-AF65-F5344CB8AC3E}">
-        <p14:creationId xmlns:p14="http://schemas.microsoft.com/office/powerpoint/2010/main" val="1913361237"/>
+        <p14:creationId xmlns:p14="http://schemas.microsoft.com/office/powerpoint/2010/main" val="1645855691"/>
       </p:ext>
     </p:extLst>
   </p:cSld>
@@ -10024,7 +10024,7 @@
           <p:cNvPr id="26" name="">
             <a:extLst xmlns:a="http://schemas.openxmlformats.org/drawingml/2006/main">
               <a:ext uri="{FF2B5EF4-FFF2-40B4-BE49-F238E27FC236}">
-                <a16:creationId xmlns:a16="http://schemas.microsoft.com/office/drawing/2014/main" id="{815D1DBC-CC69-49A5-ACBE-837653733B5A}"/>
+                <a16:creationId xmlns:a16="http://schemas.microsoft.com/office/drawing/2014/main" id="{FABCC522-F2B8-47C2-B28D-F0930B398609}"/>
               </a:ext>
             </a:extLst>
           </p:cNvPr>
@@ -10082,7 +10082,7 @@
           <p:cNvPr id="2" name="">
             <a:extLst xmlns:a="http://schemas.openxmlformats.org/drawingml/2006/main">
               <a:ext uri="{FF2B5EF4-FFF2-40B4-BE49-F238E27FC236}">
-                <a16:creationId xmlns:a16="http://schemas.microsoft.com/office/drawing/2014/main" id="{D9632293-978B-4ACF-9522-23D8CF96B568}"/>
+                <a16:creationId xmlns:a16="http://schemas.microsoft.com/office/drawing/2014/main" id="{B6F77BD2-6FA4-4277-877A-D33EE72B8138}"/>
               </a:ext>
             </a:extLst>
           </p:cNvPr>
@@ -10140,7 +10140,7 @@
           <p:cNvPr id="3" name="">
             <a:extLst xmlns:a="http://schemas.openxmlformats.org/drawingml/2006/main">
               <a:ext uri="{FF2B5EF4-FFF2-40B4-BE49-F238E27FC236}">
-                <a16:creationId xmlns:a16="http://schemas.microsoft.com/office/drawing/2014/main" id="{0ABFAB36-286C-43E8-BED4-A87028753C47}"/>
+                <a16:creationId xmlns:a16="http://schemas.microsoft.com/office/drawing/2014/main" id="{5CFCC700-996C-47E7-BFAF-F74CCDA9992E}"/>
               </a:ext>
             </a:extLst>
           </p:cNvPr>
@@ -10198,7 +10198,7 @@
           <p:cNvPr id="4" name="">
             <a:extLst xmlns:a="http://schemas.openxmlformats.org/drawingml/2006/main">
               <a:ext uri="{FF2B5EF4-FFF2-40B4-BE49-F238E27FC236}">
-                <a16:creationId xmlns:a16="http://schemas.microsoft.com/office/drawing/2014/main" id="{0703FEB9-603D-4559-99A4-A45FA1144B96}"/>
+                <a16:creationId xmlns:a16="http://schemas.microsoft.com/office/drawing/2014/main" id="{9FBDFEFF-C04B-43CE-A88B-E5262DB64A82}"/>
               </a:ext>
             </a:extLst>
           </p:cNvPr>
@@ -10231,7 +10231,7 @@
           <p:cNvPr id="5" name="">
             <a:extLst xmlns:a="http://schemas.openxmlformats.org/drawingml/2006/main">
               <a:ext uri="{FF2B5EF4-FFF2-40B4-BE49-F238E27FC236}">
-                <a16:creationId xmlns:a16="http://schemas.microsoft.com/office/drawing/2014/main" id="{E7B0DD43-66F2-459C-A383-0B41E5C5E62D}"/>
+                <a16:creationId xmlns:a16="http://schemas.microsoft.com/office/drawing/2014/main" id="{A1BF2801-F605-4766-A884-3A32F6C9D36E}"/>
               </a:ext>
             </a:extLst>
           </p:cNvPr>
@@ -10264,7 +10264,7 @@
           <p:cNvPr id="6" name="">
             <a:extLst xmlns:a="http://schemas.openxmlformats.org/drawingml/2006/main">
               <a:ext uri="{FF2B5EF4-FFF2-40B4-BE49-F238E27FC236}">
-                <a16:creationId xmlns:a16="http://schemas.microsoft.com/office/drawing/2014/main" id="{D1637327-1BB6-41F8-BAC2-6B4E2B8995A0}"/>
+                <a16:creationId xmlns:a16="http://schemas.microsoft.com/office/drawing/2014/main" id="{BB351DD1-2403-41C5-83FD-F2930EB76899}"/>
               </a:ext>
             </a:extLst>
           </p:cNvPr>
@@ -10299,7 +10299,7 @@
           <p:cNvPr id="7" name="">
             <a:extLst xmlns:a="http://schemas.openxmlformats.org/drawingml/2006/main">
               <a:ext uri="{FF2B5EF4-FFF2-40B4-BE49-F238E27FC236}">
-                <a16:creationId xmlns:a16="http://schemas.microsoft.com/office/drawing/2014/main" id="{D175C65E-B624-4E6F-9FC3-E38490848BC8}"/>
+                <a16:creationId xmlns:a16="http://schemas.microsoft.com/office/drawing/2014/main" id="{1499AFDB-78FC-4427-A4D4-66F01B4B59E6}"/>
               </a:ext>
             </a:extLst>
           </p:cNvPr>
@@ -10357,7 +10357,7 @@
           <p:cNvPr id="8" name="">
             <a:extLst xmlns:a="http://schemas.openxmlformats.org/drawingml/2006/main">
               <a:ext uri="{FF2B5EF4-FFF2-40B4-BE49-F238E27FC236}">
-                <a16:creationId xmlns:a16="http://schemas.microsoft.com/office/drawing/2014/main" id="{5DF335A7-89C8-4DAE-ABF4-712C79044AE0}"/>
+                <a16:creationId xmlns:a16="http://schemas.microsoft.com/office/drawing/2014/main" id="{FA8FC00C-74AF-468E-9F77-4E624CE0F38F}"/>
               </a:ext>
             </a:extLst>
           </p:cNvPr>
@@ -10415,7 +10415,7 @@
           <p:cNvPr id="9" name="">
             <a:extLst xmlns:a="http://schemas.openxmlformats.org/drawingml/2006/main">
               <a:ext uri="{FF2B5EF4-FFF2-40B4-BE49-F238E27FC236}">
-                <a16:creationId xmlns:a16="http://schemas.microsoft.com/office/drawing/2014/main" id="{4D535FFF-B8B4-49BF-B722-68480869F33A}"/>
+                <a16:creationId xmlns:a16="http://schemas.microsoft.com/office/drawing/2014/main" id="{B9B0B67A-F634-4FE0-A72F-0668EA692111}"/>
               </a:ext>
             </a:extLst>
           </p:cNvPr>
@@ -10473,7 +10473,7 @@
           <p:cNvPr id="10" name="">
             <a:extLst xmlns:a="http://schemas.openxmlformats.org/drawingml/2006/main">
               <a:ext uri="{FF2B5EF4-FFF2-40B4-BE49-F238E27FC236}">
-                <a16:creationId xmlns:a16="http://schemas.microsoft.com/office/drawing/2014/main" id="{1E614146-C5B8-4DB3-B9E1-08104438743E}"/>
+                <a16:creationId xmlns:a16="http://schemas.microsoft.com/office/drawing/2014/main" id="{6981B745-08A8-4FE0-B732-57D0C5F9499D}"/>
               </a:ext>
             </a:extLst>
           </p:cNvPr>
@@ -10508,7 +10508,7 @@
           <p:cNvPr id="11" name="">
             <a:extLst xmlns:a="http://schemas.openxmlformats.org/drawingml/2006/main">
               <a:ext uri="{FF2B5EF4-FFF2-40B4-BE49-F238E27FC236}">
-                <a16:creationId xmlns:a16="http://schemas.microsoft.com/office/drawing/2014/main" id="{9B908A2F-1D95-448A-980B-F9E4024B8C9C}"/>
+                <a16:creationId xmlns:a16="http://schemas.microsoft.com/office/drawing/2014/main" id="{F74E7C06-E3FB-4579-838E-A827E5E24B4A}"/>
               </a:ext>
             </a:extLst>
           </p:cNvPr>
@@ -10566,7 +10566,7 @@
           <p:cNvPr id="12" name="">
             <a:extLst xmlns:a="http://schemas.openxmlformats.org/drawingml/2006/main">
               <a:ext uri="{FF2B5EF4-FFF2-40B4-BE49-F238E27FC236}">
-                <a16:creationId xmlns:a16="http://schemas.microsoft.com/office/drawing/2014/main" id="{9324ED1F-505F-4E6C-B9AB-97684E72C5EE}"/>
+                <a16:creationId xmlns:a16="http://schemas.microsoft.com/office/drawing/2014/main" id="{410ED084-A9A7-481B-801A-1981D8937700}"/>
               </a:ext>
             </a:extLst>
           </p:cNvPr>
@@ -10624,7 +10624,7 @@
           <p:cNvPr id="13" name="">
             <a:extLst xmlns:a="http://schemas.openxmlformats.org/drawingml/2006/main">
               <a:ext uri="{FF2B5EF4-FFF2-40B4-BE49-F238E27FC236}">
-                <a16:creationId xmlns:a16="http://schemas.microsoft.com/office/drawing/2014/main" id="{6B693ABC-1835-49A8-B6D1-15F7CEC4C09E}"/>
+                <a16:creationId xmlns:a16="http://schemas.microsoft.com/office/drawing/2014/main" id="{4E98C3B3-8ED5-4DF4-B570-D908BCEC5044}"/>
               </a:ext>
             </a:extLst>
           </p:cNvPr>
@@ -10682,7 +10682,7 @@
           <p:cNvPr id="14" name="">
             <a:extLst xmlns:a="http://schemas.openxmlformats.org/drawingml/2006/main">
               <a:ext uri="{FF2B5EF4-FFF2-40B4-BE49-F238E27FC236}">
-                <a16:creationId xmlns:a16="http://schemas.microsoft.com/office/drawing/2014/main" id="{247CADEB-BB32-41DA-91E8-6E9E3958FB3F}"/>
+                <a16:creationId xmlns:a16="http://schemas.microsoft.com/office/drawing/2014/main" id="{B90998AB-9981-4C66-AF06-1A9E49F1C556}"/>
               </a:ext>
             </a:extLst>
           </p:cNvPr>
@@ -10717,7 +10717,7 @@
           <p:cNvPr id="15" name="">
             <a:extLst xmlns:a="http://schemas.openxmlformats.org/drawingml/2006/main">
               <a:ext uri="{FF2B5EF4-FFF2-40B4-BE49-F238E27FC236}">
-                <a16:creationId xmlns:a16="http://schemas.microsoft.com/office/drawing/2014/main" id="{64DDBC4F-D190-41F0-BABC-D489D878B96A}"/>
+                <a16:creationId xmlns:a16="http://schemas.microsoft.com/office/drawing/2014/main" id="{BB277143-D74D-4E17-9E6B-2C67063299FB}"/>
               </a:ext>
             </a:extLst>
           </p:cNvPr>
@@ -10775,7 +10775,7 @@
           <p:cNvPr id="16" name="">
             <a:extLst xmlns:a="http://schemas.openxmlformats.org/drawingml/2006/main">
               <a:ext uri="{FF2B5EF4-FFF2-40B4-BE49-F238E27FC236}">
-                <a16:creationId xmlns:a16="http://schemas.microsoft.com/office/drawing/2014/main" id="{57F05424-FA27-4751-9AAB-7FB86C9866C7}"/>
+                <a16:creationId xmlns:a16="http://schemas.microsoft.com/office/drawing/2014/main" id="{D4A4FD1C-04D8-4837-9870-3BEEF7DA3E0A}"/>
               </a:ext>
             </a:extLst>
           </p:cNvPr>
@@ -10833,7 +10833,7 @@
           <p:cNvPr id="17" name="">
             <a:extLst xmlns:a="http://schemas.openxmlformats.org/drawingml/2006/main">
               <a:ext uri="{FF2B5EF4-FFF2-40B4-BE49-F238E27FC236}">
-                <a16:creationId xmlns:a16="http://schemas.microsoft.com/office/drawing/2014/main" id="{AE8977B3-EAF8-4648-B276-4D71A5A2E6BE}"/>
+                <a16:creationId xmlns:a16="http://schemas.microsoft.com/office/drawing/2014/main" id="{E8C0144D-2DC4-4291-807B-1F666A246297}"/>
               </a:ext>
             </a:extLst>
           </p:cNvPr>
@@ -10891,7 +10891,7 @@
           <p:cNvPr id="18" name="">
             <a:extLst xmlns:a="http://schemas.openxmlformats.org/drawingml/2006/main">
               <a:ext uri="{FF2B5EF4-FFF2-40B4-BE49-F238E27FC236}">
-                <a16:creationId xmlns:a16="http://schemas.microsoft.com/office/drawing/2014/main" id="{E014C177-40D9-478D-A636-9F88C64EE44A}"/>
+                <a16:creationId xmlns:a16="http://schemas.microsoft.com/office/drawing/2014/main" id="{D2A1948F-FC2B-418A-820C-385A269A0C35}"/>
               </a:ext>
             </a:extLst>
           </p:cNvPr>
@@ -10926,7 +10926,7 @@
           <p:cNvPr id="19" name="">
             <a:extLst xmlns:a="http://schemas.openxmlformats.org/drawingml/2006/main">
               <a:ext uri="{FF2B5EF4-FFF2-40B4-BE49-F238E27FC236}">
-                <a16:creationId xmlns:a16="http://schemas.microsoft.com/office/drawing/2014/main" id="{54AD52BD-8C5F-4110-9D55-312B7929BFFF}"/>
+                <a16:creationId xmlns:a16="http://schemas.microsoft.com/office/drawing/2014/main" id="{D9D467D0-0DBD-419D-92BF-736C8EFB9837}"/>
               </a:ext>
             </a:extLst>
           </p:cNvPr>
@@ -10984,7 +10984,7 @@
           <p:cNvPr id="20" name="">
             <a:extLst xmlns:a="http://schemas.openxmlformats.org/drawingml/2006/main">
               <a:ext uri="{FF2B5EF4-FFF2-40B4-BE49-F238E27FC236}">
-                <a16:creationId xmlns:a16="http://schemas.microsoft.com/office/drawing/2014/main" id="{EE12A31A-A36E-4EA5-ABCD-FF7967C71FD7}"/>
+                <a16:creationId xmlns:a16="http://schemas.microsoft.com/office/drawing/2014/main" id="{340428CF-012A-4EC3-B6C9-DE1E17E69142}"/>
               </a:ext>
             </a:extLst>
           </p:cNvPr>
@@ -11042,7 +11042,7 @@
           <p:cNvPr id="21" name="">
             <a:extLst xmlns:a="http://schemas.openxmlformats.org/drawingml/2006/main">
               <a:ext uri="{FF2B5EF4-FFF2-40B4-BE49-F238E27FC236}">
-                <a16:creationId xmlns:a16="http://schemas.microsoft.com/office/drawing/2014/main" id="{C6A761BC-5F5D-4F8A-89BC-F9FC5D264EAB}"/>
+                <a16:creationId xmlns:a16="http://schemas.microsoft.com/office/drawing/2014/main" id="{3381A733-E30B-4BF6-B100-F0B8B5410721}"/>
               </a:ext>
             </a:extLst>
           </p:cNvPr>
@@ -11100,7 +11100,7 @@
           <p:cNvPr id="22" name="">
             <a:extLst xmlns:a="http://schemas.openxmlformats.org/drawingml/2006/main">
               <a:ext uri="{FF2B5EF4-FFF2-40B4-BE49-F238E27FC236}">
-                <a16:creationId xmlns:a16="http://schemas.microsoft.com/office/drawing/2014/main" id="{983E9BA3-0993-4DDB-A182-04065E512122}"/>
+                <a16:creationId xmlns:a16="http://schemas.microsoft.com/office/drawing/2014/main" id="{21796CC6-3C29-4969-9D0A-A806609E3325}"/>
               </a:ext>
             </a:extLst>
           </p:cNvPr>
@@ -11135,7 +11135,7 @@
           <p:cNvPr id="23" name="">
             <a:extLst xmlns:a="http://schemas.openxmlformats.org/drawingml/2006/main">
               <a:ext uri="{FF2B5EF4-FFF2-40B4-BE49-F238E27FC236}">
-                <a16:creationId xmlns:a16="http://schemas.microsoft.com/office/drawing/2014/main" id="{401FFB8C-5645-46DB-900B-58F08F5866FC}"/>
+                <a16:creationId xmlns:a16="http://schemas.microsoft.com/office/drawing/2014/main" id="{B7B9F595-3BEB-4098-BB7F-FEEEA6186D53}"/>
               </a:ext>
             </a:extLst>
           </p:cNvPr>
@@ -11193,7 +11193,7 @@
           <p:cNvPr id="24" name="">
             <a:extLst xmlns:a="http://schemas.openxmlformats.org/drawingml/2006/main">
               <a:ext uri="{FF2B5EF4-FFF2-40B4-BE49-F238E27FC236}">
-                <a16:creationId xmlns:a16="http://schemas.microsoft.com/office/drawing/2014/main" id="{00A4AE52-BCD0-40CB-94DC-5FF0B9E92699}"/>
+                <a16:creationId xmlns:a16="http://schemas.microsoft.com/office/drawing/2014/main" id="{5622BE43-1BF1-4AAF-B12D-046524832F4F}"/>
               </a:ext>
             </a:extLst>
           </p:cNvPr>
@@ -11241,7 +11241,7 @@
                 <a:ea typeface="Aptos"/>
                 <a:cs typeface="Aptos"/>
               </a:rPr>
-              <a:t>WATERS NEXT GEN COMPETITIVE INTELLIGENCE · 17 AUG 2026 · waters-ci-20260817124300</a:t>
+              <a:t>WATERS NEXT GEN COMPETITIVE INTELLIGENCE · 23 AUG 2026 · waters-ci-20260820104036</a:t>
             </a:r>
           </a:p>
         </p:txBody>
@@ -11251,7 +11251,7 @@
           <p:cNvPr id="25" name="">
             <a:extLst xmlns:a="http://schemas.openxmlformats.org/drawingml/2006/main">
               <a:ext uri="{FF2B5EF4-FFF2-40B4-BE49-F238E27FC236}">
-                <a16:creationId xmlns:a16="http://schemas.microsoft.com/office/drawing/2014/main" id="{51B27A01-F313-41E0-B36E-5D5FE3A8D506}"/>
+                <a16:creationId xmlns:a16="http://schemas.microsoft.com/office/drawing/2014/main" id="{863D6332-71AA-44B6-B810-95D8348CCF86}"/>
               </a:ext>
             </a:extLst>
           </p:cNvPr>
@@ -11307,7 +11307,7 @@
     </p:spTree>
     <p:extLst>
       <p:ext uri="{BB962C8B-B14F-4D97-AF65-F5344CB8AC3E}">
-        <p14:creationId xmlns:p14="http://schemas.microsoft.com/office/powerpoint/2010/main" val="786264057"/>
+        <p14:creationId xmlns:p14="http://schemas.microsoft.com/office/powerpoint/2010/main" val="2136145895"/>
       </p:ext>
     </p:extLst>
   </p:cSld>
@@ -11338,7 +11338,7 @@
           <p:cNvPr id="38" name="">
             <a:extLst xmlns:a="http://schemas.openxmlformats.org/drawingml/2006/main">
               <a:ext uri="{FF2B5EF4-FFF2-40B4-BE49-F238E27FC236}">
-                <a16:creationId xmlns:a16="http://schemas.microsoft.com/office/drawing/2014/main" id="{42C858C8-8156-46AF-B1D9-F10053F18C22}"/>
+                <a16:creationId xmlns:a16="http://schemas.microsoft.com/office/drawing/2014/main" id="{32491075-96E1-4E9C-83A1-3C48CD4F6DE4}"/>
               </a:ext>
             </a:extLst>
           </p:cNvPr>
@@ -11396,7 +11396,7 @@
           <p:cNvPr id="2" name="">
             <a:extLst xmlns:a="http://schemas.openxmlformats.org/drawingml/2006/main">
               <a:ext uri="{FF2B5EF4-FFF2-40B4-BE49-F238E27FC236}">
-                <a16:creationId xmlns:a16="http://schemas.microsoft.com/office/drawing/2014/main" id="{F5F146B2-0137-4D13-A458-94AFF1992E95}"/>
+                <a16:creationId xmlns:a16="http://schemas.microsoft.com/office/drawing/2014/main" id="{A0DC2777-05ED-427F-927D-078309AF7075}"/>
               </a:ext>
             </a:extLst>
           </p:cNvPr>
@@ -11454,7 +11454,7 @@
           <p:cNvPr id="3" name="">
             <a:extLst xmlns:a="http://schemas.openxmlformats.org/drawingml/2006/main">
               <a:ext uri="{FF2B5EF4-FFF2-40B4-BE49-F238E27FC236}">
-                <a16:creationId xmlns:a16="http://schemas.microsoft.com/office/drawing/2014/main" id="{5CC53B60-EDF8-44D8-8D6E-0845D1D5F9B2}"/>
+                <a16:creationId xmlns:a16="http://schemas.microsoft.com/office/drawing/2014/main" id="{E3F7F93C-B89D-48DA-9C05-72DACCAE9841}"/>
               </a:ext>
             </a:extLst>
           </p:cNvPr>
@@ -11512,7 +11512,7 @@
           <p:cNvPr id="4" name="">
             <a:extLst xmlns:a="http://schemas.openxmlformats.org/drawingml/2006/main">
               <a:ext uri="{FF2B5EF4-FFF2-40B4-BE49-F238E27FC236}">
-                <a16:creationId xmlns:a16="http://schemas.microsoft.com/office/drawing/2014/main" id="{7D227110-A4D4-4D8B-A7FC-A62918B0DE8E}"/>
+                <a16:creationId xmlns:a16="http://schemas.microsoft.com/office/drawing/2014/main" id="{0F8CC259-5D9F-45A2-B8A0-B58EE0473F9F}"/>
               </a:ext>
             </a:extLst>
           </p:cNvPr>
@@ -11545,7 +11545,7 @@
           <p:cNvPr id="5" name="">
             <a:extLst xmlns:a="http://schemas.openxmlformats.org/drawingml/2006/main">
               <a:ext uri="{FF2B5EF4-FFF2-40B4-BE49-F238E27FC236}">
-                <a16:creationId xmlns:a16="http://schemas.microsoft.com/office/drawing/2014/main" id="{F0BC3547-C419-4EBF-AF65-512D926CC2D0}"/>
+                <a16:creationId xmlns:a16="http://schemas.microsoft.com/office/drawing/2014/main" id="{74E8428C-85FC-4278-89F0-E740F2DA887F}"/>
               </a:ext>
             </a:extLst>
           </p:cNvPr>
@@ -11603,7 +11603,7 @@
           <p:cNvPr id="6" name="">
             <a:extLst xmlns:a="http://schemas.openxmlformats.org/drawingml/2006/main">
               <a:ext uri="{FF2B5EF4-FFF2-40B4-BE49-F238E27FC236}">
-                <a16:creationId xmlns:a16="http://schemas.microsoft.com/office/drawing/2014/main" id="{30C3E8DB-B3A9-401E-A3E2-B9CEAF7E8544}"/>
+                <a16:creationId xmlns:a16="http://schemas.microsoft.com/office/drawing/2014/main" id="{0F3C4232-F48C-4BC3-A764-A8F2C6403E11}"/>
               </a:ext>
             </a:extLst>
           </p:cNvPr>
@@ -11661,7 +11661,7 @@
           <p:cNvPr id="7" name="">
             <a:extLst xmlns:a="http://schemas.openxmlformats.org/drawingml/2006/main">
               <a:ext uri="{FF2B5EF4-FFF2-40B4-BE49-F238E27FC236}">
-                <a16:creationId xmlns:a16="http://schemas.microsoft.com/office/drawing/2014/main" id="{4112535E-FD8A-48D2-A4C1-E72241BC7DC3}"/>
+                <a16:creationId xmlns:a16="http://schemas.microsoft.com/office/drawing/2014/main" id="{EE81E1D4-A92F-4F82-8245-EBD738E39A74}"/>
               </a:ext>
             </a:extLst>
           </p:cNvPr>
@@ -11717,10 +11717,10 @@
       <p:sp>
         <p:nvSpPr>
           <p:cNvPr id="8" name="">
-            <a:hlinkClick xmlns:r="http://schemas.openxmlformats.org/officeDocument/2006/relationships" xmlns:a="http://schemas.openxmlformats.org/drawingml/2006/main" r:id="R4dc2a76046144483"/>
-            <a:extLst xmlns:a="http://schemas.openxmlformats.org/drawingml/2006/main">
-              <a:ext uri="{FF2B5EF4-FFF2-40B4-BE49-F238E27FC236}">
-                <a16:creationId xmlns:a16="http://schemas.microsoft.com/office/drawing/2014/main" id="{F126D89D-DC51-409C-A32E-0C4388377FDD}"/>
+            <a:hlinkClick xmlns:r="http://schemas.openxmlformats.org/officeDocument/2006/relationships" xmlns:a="http://schemas.openxmlformats.org/drawingml/2006/main" r:id="R2346898bc55f48e4"/>
+            <a:extLst xmlns:a="http://schemas.openxmlformats.org/drawingml/2006/main">
+              <a:ext uri="{FF2B5EF4-FFF2-40B4-BE49-F238E27FC236}">
+                <a16:creationId xmlns:a16="http://schemas.microsoft.com/office/drawing/2014/main" id="{C37BDD27-CC13-4FEF-9A93-1E213C7DF097}"/>
               </a:ext>
             </a:extLst>
           </p:cNvPr>
@@ -11768,7 +11768,7 @@
                 <a:ea typeface="Aptos"/>
                 <a:cs typeface="Aptos"/>
               </a:rPr>
-              <a:t>https://pubmed.ncbi.nlm.nih.gov/?term=%28%28PFAS+OR+%22per-+and+polyfluoroalkyl%22%29+AND+%28%22LC-MS%22+OR+%22LC-MS%2FMS%22+OR+chromatography%29%29+AND+%28%222025%2F08%2F17%22%5BDate+-+Publication%5D+%3A+%222026%2F08%2F17%22%5BDate+-+Publication%5D%29</a:t>
+              <a:t>https://pubmed.ncbi.nlm.nih.gov/?term=%28%28PFAS+OR+%22per-+and+polyfluoroalkyl%22%29+AND+%28%22LC-MS%22+OR+%22LC-MS%2FMS%22+OR+chromatography%29%29+AND+%28%222025%2F08%2F20%22%5BDate+-+Publication%5D+%3A+%222026%2F08%2F20%22%5BDate+-+Publication%5D%29</a:t>
             </a:r>
           </a:p>
         </p:txBody>
@@ -11778,7 +11778,7 @@
           <p:cNvPr id="9" name="">
             <a:extLst xmlns:a="http://schemas.openxmlformats.org/drawingml/2006/main">
               <a:ext uri="{FF2B5EF4-FFF2-40B4-BE49-F238E27FC236}">
-                <a16:creationId xmlns:a16="http://schemas.microsoft.com/office/drawing/2014/main" id="{013820AF-56B6-472D-94FF-F730819FE7AC}"/>
+                <a16:creationId xmlns:a16="http://schemas.microsoft.com/office/drawing/2014/main" id="{6E465B59-718E-424C-B6E0-813ED6835AE1}"/>
               </a:ext>
             </a:extLst>
           </p:cNvPr>
@@ -11811,7 +11811,7 @@
           <p:cNvPr id="10" name="">
             <a:extLst xmlns:a="http://schemas.openxmlformats.org/drawingml/2006/main">
               <a:ext uri="{FF2B5EF4-FFF2-40B4-BE49-F238E27FC236}">
-                <a16:creationId xmlns:a16="http://schemas.microsoft.com/office/drawing/2014/main" id="{0E53F82C-3D81-46A2-90F1-6D209C2AFB7F}"/>
+                <a16:creationId xmlns:a16="http://schemas.microsoft.com/office/drawing/2014/main" id="{1F12CAD0-707C-4C22-9528-14CCA1949692}"/>
               </a:ext>
             </a:extLst>
           </p:cNvPr>
@@ -11869,7 +11869,7 @@
           <p:cNvPr id="11" name="">
             <a:extLst xmlns:a="http://schemas.openxmlformats.org/drawingml/2006/main">
               <a:ext uri="{FF2B5EF4-FFF2-40B4-BE49-F238E27FC236}">
-                <a16:creationId xmlns:a16="http://schemas.microsoft.com/office/drawing/2014/main" id="{BB719665-FE66-4499-A93B-6C48E700464C}"/>
+                <a16:creationId xmlns:a16="http://schemas.microsoft.com/office/drawing/2014/main" id="{A7EAAA8C-C0E5-4E59-95CA-D93407B067CD}"/>
               </a:ext>
             </a:extLst>
           </p:cNvPr>
@@ -11927,7 +11927,7 @@
           <p:cNvPr id="12" name="">
             <a:extLst xmlns:a="http://schemas.openxmlformats.org/drawingml/2006/main">
               <a:ext uri="{FF2B5EF4-FFF2-40B4-BE49-F238E27FC236}">
-                <a16:creationId xmlns:a16="http://schemas.microsoft.com/office/drawing/2014/main" id="{9C42DB96-4965-42B8-9CF0-967C5DEDDB6C}"/>
+                <a16:creationId xmlns:a16="http://schemas.microsoft.com/office/drawing/2014/main" id="{FAE38FBF-33BE-47E7-8FF9-979347A16E22}"/>
               </a:ext>
             </a:extLst>
           </p:cNvPr>
@@ -11983,10 +11983,10 @@
       <p:sp>
         <p:nvSpPr>
           <p:cNvPr id="13" name="">
-            <a:hlinkClick xmlns:r="http://schemas.openxmlformats.org/officeDocument/2006/relationships" xmlns:a="http://schemas.openxmlformats.org/drawingml/2006/main" r:id="R86858532b1b84cd8"/>
-            <a:extLst xmlns:a="http://schemas.openxmlformats.org/drawingml/2006/main">
-              <a:ext uri="{FF2B5EF4-FFF2-40B4-BE49-F238E27FC236}">
-                <a16:creationId xmlns:a16="http://schemas.microsoft.com/office/drawing/2014/main" id="{7CF24DAA-98ED-486A-BBBB-750E1E56F77C}"/>
+            <a:hlinkClick xmlns:r="http://schemas.openxmlformats.org/officeDocument/2006/relationships" xmlns:a="http://schemas.openxmlformats.org/drawingml/2006/main" r:id="R823171ce63a3433a"/>
+            <a:extLst xmlns:a="http://schemas.openxmlformats.org/drawingml/2006/main">
+              <a:ext uri="{FF2B5EF4-FFF2-40B4-BE49-F238E27FC236}">
+                <a16:creationId xmlns:a16="http://schemas.microsoft.com/office/drawing/2014/main" id="{ABA52872-7257-4B9A-99A0-26B001349AD8}"/>
               </a:ext>
             </a:extLst>
           </p:cNvPr>
@@ -12044,7 +12044,7 @@
           <p:cNvPr id="14" name="">
             <a:extLst xmlns:a="http://schemas.openxmlformats.org/drawingml/2006/main">
               <a:ext uri="{FF2B5EF4-FFF2-40B4-BE49-F238E27FC236}">
-                <a16:creationId xmlns:a16="http://schemas.microsoft.com/office/drawing/2014/main" id="{745E7327-7C61-488A-8D71-17BA8A9781B5}"/>
+                <a16:creationId xmlns:a16="http://schemas.microsoft.com/office/drawing/2014/main" id="{2E38276C-A5FD-44D7-BC15-571F52DE82CD}"/>
               </a:ext>
             </a:extLst>
           </p:cNvPr>
@@ -12077,7 +12077,7 @@
           <p:cNvPr id="15" name="">
             <a:extLst xmlns:a="http://schemas.openxmlformats.org/drawingml/2006/main">
               <a:ext uri="{FF2B5EF4-FFF2-40B4-BE49-F238E27FC236}">
-                <a16:creationId xmlns:a16="http://schemas.microsoft.com/office/drawing/2014/main" id="{7907DC36-A542-4392-B0EF-A4CF7189F23A}"/>
+                <a16:creationId xmlns:a16="http://schemas.microsoft.com/office/drawing/2014/main" id="{6AF7692C-5EA9-4031-8140-CA1C7F0C9E30}"/>
               </a:ext>
             </a:extLst>
           </p:cNvPr>
@@ -12135,7 +12135,7 @@
           <p:cNvPr id="16" name="">
             <a:extLst xmlns:a="http://schemas.openxmlformats.org/drawingml/2006/main">
               <a:ext uri="{FF2B5EF4-FFF2-40B4-BE49-F238E27FC236}">
-                <a16:creationId xmlns:a16="http://schemas.microsoft.com/office/drawing/2014/main" id="{D45E9C14-63AB-418E-BACB-755287AF4E73}"/>
+                <a16:creationId xmlns:a16="http://schemas.microsoft.com/office/drawing/2014/main" id="{FE989846-97D1-4497-8813-317104443FD6}"/>
               </a:ext>
             </a:extLst>
           </p:cNvPr>
@@ -12193,7 +12193,7 @@
           <p:cNvPr id="17" name="">
             <a:extLst xmlns:a="http://schemas.openxmlformats.org/drawingml/2006/main">
               <a:ext uri="{FF2B5EF4-FFF2-40B4-BE49-F238E27FC236}">
-                <a16:creationId xmlns:a16="http://schemas.microsoft.com/office/drawing/2014/main" id="{82EB48B5-8CDB-42F0-8A2E-281D387B437C}"/>
+                <a16:creationId xmlns:a16="http://schemas.microsoft.com/office/drawing/2014/main" id="{2E746D48-99CC-414D-BD0B-C1AA8E2303EB}"/>
               </a:ext>
             </a:extLst>
           </p:cNvPr>
@@ -12249,10 +12249,10 @@
       <p:sp>
         <p:nvSpPr>
           <p:cNvPr id="18" name="">
-            <a:hlinkClick xmlns:r="http://schemas.openxmlformats.org/officeDocument/2006/relationships" xmlns:a="http://schemas.openxmlformats.org/drawingml/2006/main" r:id="R2d2e81e6d61741ef"/>
-            <a:extLst xmlns:a="http://schemas.openxmlformats.org/drawingml/2006/main">
-              <a:ext uri="{FF2B5EF4-FFF2-40B4-BE49-F238E27FC236}">
-                <a16:creationId xmlns:a16="http://schemas.microsoft.com/office/drawing/2014/main" id="{683698E7-1075-466E-902D-013150684011}"/>
+            <a:hlinkClick xmlns:r="http://schemas.openxmlformats.org/officeDocument/2006/relationships" xmlns:a="http://schemas.openxmlformats.org/drawingml/2006/main" r:id="Redf15c6127f04896"/>
+            <a:extLst xmlns:a="http://schemas.openxmlformats.org/drawingml/2006/main">
+              <a:ext uri="{FF2B5EF4-FFF2-40B4-BE49-F238E27FC236}">
+                <a16:creationId xmlns:a16="http://schemas.microsoft.com/office/drawing/2014/main" id="{243FFF72-06F7-4474-BDBC-81CD7780A0C9}"/>
               </a:ext>
             </a:extLst>
           </p:cNvPr>
@@ -12310,7 +12310,7 @@
           <p:cNvPr id="19" name="">
             <a:extLst xmlns:a="http://schemas.openxmlformats.org/drawingml/2006/main">
               <a:ext uri="{FF2B5EF4-FFF2-40B4-BE49-F238E27FC236}">
-                <a16:creationId xmlns:a16="http://schemas.microsoft.com/office/drawing/2014/main" id="{B01F5203-CB11-45A1-9FCB-3B2E4CBFB5FE}"/>
+                <a16:creationId xmlns:a16="http://schemas.microsoft.com/office/drawing/2014/main" id="{AEE82383-587B-4A01-92D3-FDC602C26807}"/>
               </a:ext>
             </a:extLst>
           </p:cNvPr>
@@ -12343,7 +12343,7 @@
           <p:cNvPr id="20" name="">
             <a:extLst xmlns:a="http://schemas.openxmlformats.org/drawingml/2006/main">
               <a:ext uri="{FF2B5EF4-FFF2-40B4-BE49-F238E27FC236}">
-                <a16:creationId xmlns:a16="http://schemas.microsoft.com/office/drawing/2014/main" id="{9329C9D9-81C9-4BBA-9DFB-843BBC34B53A}"/>
+                <a16:creationId xmlns:a16="http://schemas.microsoft.com/office/drawing/2014/main" id="{FCA3D1DA-1B34-4654-9980-C5F427588649}"/>
               </a:ext>
             </a:extLst>
           </p:cNvPr>
@@ -12401,7 +12401,7 @@
           <p:cNvPr id="21" name="">
             <a:extLst xmlns:a="http://schemas.openxmlformats.org/drawingml/2006/main">
               <a:ext uri="{FF2B5EF4-FFF2-40B4-BE49-F238E27FC236}">
-                <a16:creationId xmlns:a16="http://schemas.microsoft.com/office/drawing/2014/main" id="{9CA26E1E-D621-44D0-B118-CF52A9777A75}"/>
+                <a16:creationId xmlns:a16="http://schemas.microsoft.com/office/drawing/2014/main" id="{9F3B95C4-E608-4F20-A785-73D2562B6622}"/>
               </a:ext>
             </a:extLst>
           </p:cNvPr>
@@ -12459,7 +12459,7 @@
           <p:cNvPr id="22" name="">
             <a:extLst xmlns:a="http://schemas.openxmlformats.org/drawingml/2006/main">
               <a:ext uri="{FF2B5EF4-FFF2-40B4-BE49-F238E27FC236}">
-                <a16:creationId xmlns:a16="http://schemas.microsoft.com/office/drawing/2014/main" id="{D0F932E9-665A-456E-B3D5-2DFD6B07A97A}"/>
+                <a16:creationId xmlns:a16="http://schemas.microsoft.com/office/drawing/2014/main" id="{16535C97-E7D5-49D2-8FD6-BC6B5EE0B9F9}"/>
               </a:ext>
             </a:extLst>
           </p:cNvPr>
@@ -12515,10 +12515,10 @@
       <p:sp>
         <p:nvSpPr>
           <p:cNvPr id="23" name="">
-            <a:hlinkClick xmlns:r="http://schemas.openxmlformats.org/officeDocument/2006/relationships" xmlns:a="http://schemas.openxmlformats.org/drawingml/2006/main" r:id="R30d64dfb53c84636"/>
-            <a:extLst xmlns:a="http://schemas.openxmlformats.org/drawingml/2006/main">
-              <a:ext uri="{FF2B5EF4-FFF2-40B4-BE49-F238E27FC236}">
-                <a16:creationId xmlns:a16="http://schemas.microsoft.com/office/drawing/2014/main" id="{76CDAD7B-5EC0-424B-8925-65685A71DECC}"/>
+            <a:hlinkClick xmlns:r="http://schemas.openxmlformats.org/officeDocument/2006/relationships" xmlns:a="http://schemas.openxmlformats.org/drawingml/2006/main" r:id="Ra61963531b1a40d3"/>
+            <a:extLst xmlns:a="http://schemas.openxmlformats.org/drawingml/2006/main">
+              <a:ext uri="{FF2B5EF4-FFF2-40B4-BE49-F238E27FC236}">
+                <a16:creationId xmlns:a16="http://schemas.microsoft.com/office/drawing/2014/main" id="{0D569E55-CBDE-4C9F-94EC-4B2E9AC05F93}"/>
               </a:ext>
             </a:extLst>
           </p:cNvPr>
@@ -12576,7 +12576,7 @@
           <p:cNvPr id="24" name="">
             <a:extLst xmlns:a="http://schemas.openxmlformats.org/drawingml/2006/main">
               <a:ext uri="{FF2B5EF4-FFF2-40B4-BE49-F238E27FC236}">
-                <a16:creationId xmlns:a16="http://schemas.microsoft.com/office/drawing/2014/main" id="{FF726ABD-C512-45DC-BB4A-80303E5D4A6F}"/>
+                <a16:creationId xmlns:a16="http://schemas.microsoft.com/office/drawing/2014/main" id="{0EC2ABC2-FBED-4A34-A2C2-7A754A769AF8}"/>
               </a:ext>
             </a:extLst>
           </p:cNvPr>
@@ -12609,7 +12609,7 @@
           <p:cNvPr id="25" name="">
             <a:extLst xmlns:a="http://schemas.openxmlformats.org/drawingml/2006/main">
               <a:ext uri="{FF2B5EF4-FFF2-40B4-BE49-F238E27FC236}">
-                <a16:creationId xmlns:a16="http://schemas.microsoft.com/office/drawing/2014/main" id="{29DC2B00-8641-4E28-A8FE-8400E21F4A7C}"/>
+                <a16:creationId xmlns:a16="http://schemas.microsoft.com/office/drawing/2014/main" id="{D04BEFF4-C479-4EDF-BEF8-6D5945ECFB5F}"/>
               </a:ext>
             </a:extLst>
           </p:cNvPr>
@@ -12667,7 +12667,7 @@
           <p:cNvPr id="26" name="">
             <a:extLst xmlns:a="http://schemas.openxmlformats.org/drawingml/2006/main">
               <a:ext uri="{FF2B5EF4-FFF2-40B4-BE49-F238E27FC236}">
-                <a16:creationId xmlns:a16="http://schemas.microsoft.com/office/drawing/2014/main" id="{7542D708-3CA9-411D-80C8-C5DF57292CD3}"/>
+                <a16:creationId xmlns:a16="http://schemas.microsoft.com/office/drawing/2014/main" id="{6FED93DD-3747-44CA-9EF7-325830D91F4C}"/>
               </a:ext>
             </a:extLst>
           </p:cNvPr>
@@ -12725,7 +12725,7 @@
           <p:cNvPr id="27" name="">
             <a:extLst xmlns:a="http://schemas.openxmlformats.org/drawingml/2006/main">
               <a:ext uri="{FF2B5EF4-FFF2-40B4-BE49-F238E27FC236}">
-                <a16:creationId xmlns:a16="http://schemas.microsoft.com/office/drawing/2014/main" id="{973F832C-3784-4E33-BC21-F71416DA99D1}"/>
+                <a16:creationId xmlns:a16="http://schemas.microsoft.com/office/drawing/2014/main" id="{BDD27345-9BE2-4518-904F-2C0721A04023}"/>
               </a:ext>
             </a:extLst>
           </p:cNvPr>
@@ -12781,10 +12781,10 @@
       <p:sp>
         <p:nvSpPr>
           <p:cNvPr id="28" name="">
-            <a:hlinkClick xmlns:r="http://schemas.openxmlformats.org/officeDocument/2006/relationships" xmlns:a="http://schemas.openxmlformats.org/drawingml/2006/main" r:id="Rf3cfe9ea83a2499d"/>
-            <a:extLst xmlns:a="http://schemas.openxmlformats.org/drawingml/2006/main">
-              <a:ext uri="{FF2B5EF4-FFF2-40B4-BE49-F238E27FC236}">
-                <a16:creationId xmlns:a16="http://schemas.microsoft.com/office/drawing/2014/main" id="{5848CDEA-B095-4F10-ABAF-1A5C85DFB4B5}"/>
+            <a:hlinkClick xmlns:r="http://schemas.openxmlformats.org/officeDocument/2006/relationships" xmlns:a="http://schemas.openxmlformats.org/drawingml/2006/main" r:id="R65b5227a71434014"/>
+            <a:extLst xmlns:a="http://schemas.openxmlformats.org/drawingml/2006/main">
+              <a:ext uri="{FF2B5EF4-FFF2-40B4-BE49-F238E27FC236}">
+                <a16:creationId xmlns:a16="http://schemas.microsoft.com/office/drawing/2014/main" id="{6E6AD32A-881E-4C8D-9579-C656FF3C9A99}"/>
               </a:ext>
             </a:extLst>
           </p:cNvPr>
@@ -12842,7 +12842,7 @@
           <p:cNvPr id="29" name="">
             <a:extLst xmlns:a="http://schemas.openxmlformats.org/drawingml/2006/main">
               <a:ext uri="{FF2B5EF4-FFF2-40B4-BE49-F238E27FC236}">
-                <a16:creationId xmlns:a16="http://schemas.microsoft.com/office/drawing/2014/main" id="{78930B46-6D0F-4D7C-9042-93CE74FF4A73}"/>
+                <a16:creationId xmlns:a16="http://schemas.microsoft.com/office/drawing/2014/main" id="{EC42AFDD-98BC-46EB-9568-B1C10D590218}"/>
               </a:ext>
             </a:extLst>
           </p:cNvPr>
@@ -12875,7 +12875,7 @@
           <p:cNvPr id="30" name="">
             <a:extLst xmlns:a="http://schemas.openxmlformats.org/drawingml/2006/main">
               <a:ext uri="{FF2B5EF4-FFF2-40B4-BE49-F238E27FC236}">
-                <a16:creationId xmlns:a16="http://schemas.microsoft.com/office/drawing/2014/main" id="{A3C2CB32-5A0F-45BF-8FD9-F82150DB5E6A}"/>
+                <a16:creationId xmlns:a16="http://schemas.microsoft.com/office/drawing/2014/main" id="{ACFC0F7B-6407-43FD-B7E4-C543CFCF1068}"/>
               </a:ext>
             </a:extLst>
           </p:cNvPr>
@@ -12933,7 +12933,7 @@
           <p:cNvPr id="31" name="">
             <a:extLst xmlns:a="http://schemas.openxmlformats.org/drawingml/2006/main">
               <a:ext uri="{FF2B5EF4-FFF2-40B4-BE49-F238E27FC236}">
-                <a16:creationId xmlns:a16="http://schemas.microsoft.com/office/drawing/2014/main" id="{D42B78DE-7684-40B0-8BF4-5F04316BBB17}"/>
+                <a16:creationId xmlns:a16="http://schemas.microsoft.com/office/drawing/2014/main" id="{1D57072D-7B28-4261-B9A3-0D981453BED3}"/>
               </a:ext>
             </a:extLst>
           </p:cNvPr>
@@ -12991,7 +12991,7 @@
           <p:cNvPr id="32" name="">
             <a:extLst xmlns:a="http://schemas.openxmlformats.org/drawingml/2006/main">
               <a:ext uri="{FF2B5EF4-FFF2-40B4-BE49-F238E27FC236}">
-                <a16:creationId xmlns:a16="http://schemas.microsoft.com/office/drawing/2014/main" id="{0CC45C86-BC00-4E7C-9A44-D398FEF91580}"/>
+                <a16:creationId xmlns:a16="http://schemas.microsoft.com/office/drawing/2014/main" id="{290BAB12-301E-4491-A09C-5C71C834FA24}"/>
               </a:ext>
             </a:extLst>
           </p:cNvPr>
@@ -13047,10 +13047,10 @@
       <p:sp>
         <p:nvSpPr>
           <p:cNvPr id="33" name="">
-            <a:hlinkClick xmlns:r="http://schemas.openxmlformats.org/officeDocument/2006/relationships" xmlns:a="http://schemas.openxmlformats.org/drawingml/2006/main" r:id="R4015d6f821aa4e23"/>
-            <a:extLst xmlns:a="http://schemas.openxmlformats.org/drawingml/2006/main">
-              <a:ext uri="{FF2B5EF4-FFF2-40B4-BE49-F238E27FC236}">
-                <a16:creationId xmlns:a16="http://schemas.microsoft.com/office/drawing/2014/main" id="{8E348F2B-8E70-443B-BDF4-6FDED28337BA}"/>
+            <a:hlinkClick xmlns:r="http://schemas.openxmlformats.org/officeDocument/2006/relationships" xmlns:a="http://schemas.openxmlformats.org/drawingml/2006/main" r:id="Rcfc2d21479ad49e5"/>
+            <a:extLst xmlns:a="http://schemas.openxmlformats.org/drawingml/2006/main">
+              <a:ext uri="{FF2B5EF4-FFF2-40B4-BE49-F238E27FC236}">
+                <a16:creationId xmlns:a16="http://schemas.microsoft.com/office/drawing/2014/main" id="{A1C737B3-0B23-433A-BA1E-B50128336299}"/>
               </a:ext>
             </a:extLst>
           </p:cNvPr>
@@ -13108,7 +13108,7 @@
           <p:cNvPr id="34" name="">
             <a:extLst xmlns:a="http://schemas.openxmlformats.org/drawingml/2006/main">
               <a:ext uri="{FF2B5EF4-FFF2-40B4-BE49-F238E27FC236}">
-                <a16:creationId xmlns:a16="http://schemas.microsoft.com/office/drawing/2014/main" id="{39F1C259-A794-4AAF-810C-865E4997E232}"/>
+                <a16:creationId xmlns:a16="http://schemas.microsoft.com/office/drawing/2014/main" id="{E94198B0-1900-4B9A-A2E8-CEF01C7F3DED}"/>
               </a:ext>
             </a:extLst>
           </p:cNvPr>
@@ -13143,7 +13143,7 @@
           <p:cNvPr id="35" name="">
             <a:extLst xmlns:a="http://schemas.openxmlformats.org/drawingml/2006/main">
               <a:ext uri="{FF2B5EF4-FFF2-40B4-BE49-F238E27FC236}">
-                <a16:creationId xmlns:a16="http://schemas.microsoft.com/office/drawing/2014/main" id="{2C466B1F-5A32-4DF7-943F-9C230C82C8A3}"/>
+                <a16:creationId xmlns:a16="http://schemas.microsoft.com/office/drawing/2014/main" id="{E6767625-79E4-4C9B-B2BF-A61622D2CAFA}"/>
               </a:ext>
             </a:extLst>
           </p:cNvPr>
@@ -13191,7 +13191,7 @@
                 <a:ea typeface="Aptos"/>
                 <a:cs typeface="Aptos"/>
               </a:rPr>
-              <a:t>Snapshot: waters-ci-20260817124300 · As of 2026-08-17T12:43:00 · Business magnitude requires Waters internal data.</a:t>
+              <a:t>Snapshot: waters-ci-20260820104036 · As of 2026-08-23 · Business magnitude requires Waters internal data.</a:t>
             </a:r>
           </a:p>
         </p:txBody>
@@ -13201,7 +13201,7 @@
           <p:cNvPr id="36" name="">
             <a:extLst xmlns:a="http://schemas.openxmlformats.org/drawingml/2006/main">
               <a:ext uri="{FF2B5EF4-FFF2-40B4-BE49-F238E27FC236}">
-                <a16:creationId xmlns:a16="http://schemas.microsoft.com/office/drawing/2014/main" id="{5F1FDF5F-F33D-4937-9CE5-C9EA28128AAC}"/>
+                <a16:creationId xmlns:a16="http://schemas.microsoft.com/office/drawing/2014/main" id="{5E59F4DA-6118-49F7-B412-678E1CC7E67F}"/>
               </a:ext>
             </a:extLst>
           </p:cNvPr>
@@ -13249,7 +13249,7 @@
                 <a:ea typeface="Aptos"/>
                 <a:cs typeface="Aptos"/>
               </a:rPr>
-              <a:t>WATERS NEXT GEN COMPETITIVE INTELLIGENCE · 17 AUG 2026 · waters-ci-20260817124300</a:t>
+              <a:t>WATERS NEXT GEN COMPETITIVE INTELLIGENCE · 23 AUG 2026 · waters-ci-20260820104036</a:t>
             </a:r>
           </a:p>
         </p:txBody>
@@ -13259,7 +13259,7 @@
           <p:cNvPr id="37" name="">
             <a:extLst xmlns:a="http://schemas.openxmlformats.org/drawingml/2006/main">
               <a:ext uri="{FF2B5EF4-FFF2-40B4-BE49-F238E27FC236}">
-                <a16:creationId xmlns:a16="http://schemas.microsoft.com/office/drawing/2014/main" id="{B5E83AA7-E29A-4BB1-A959-2C86AF2CA9D4}"/>
+                <a16:creationId xmlns:a16="http://schemas.microsoft.com/office/drawing/2014/main" id="{DA42734A-D3CF-465C-8CD3-5F9F2877839C}"/>
               </a:ext>
             </a:extLst>
           </p:cNvPr>
@@ -13315,7 +13315,7 @@
     </p:spTree>
     <p:extLst>
       <p:ext uri="{BB962C8B-B14F-4D97-AF65-F5344CB8AC3E}">
-        <p14:creationId xmlns:p14="http://schemas.microsoft.com/office/powerpoint/2010/main" val="1100017722"/>
+        <p14:creationId xmlns:p14="http://schemas.microsoft.com/office/powerpoint/2010/main" val="1418829203"/>
       </p:ext>
     </p:extLst>
   </p:cSld>

</xml_diff>